<commit_message>
Balance Korean line breaks across training presentation editions
</commit_message>
<xml_diff>
--- a/education/training/signature/compact/training-signature.pptx
+++ b/education/training/signature/compact/training-signature.pptx
@@ -2,32 +2,32 @@
 <file path=ppt/presentation.xml><?xml version="1.0" encoding="utf-8"?>
 <p:presentation xmlns:p="http://schemas.openxmlformats.org/presentationml/2006/main">
   <p:sldMasterIdLst>
-    <p:sldMasterId xmlns:r="http://schemas.openxmlformats.org/officeDocument/2006/relationships" id="2147483648" r:id="Rf927beba174f4bfc"/>
+    <p:sldMasterId xmlns:r="http://schemas.openxmlformats.org/officeDocument/2006/relationships" id="2147483648" r:id="R2d1bf454d6b74ede"/>
   </p:sldMasterIdLst>
   <p:notesMasterIdLst>
-    <p:notesMasterId xmlns:r="http://schemas.openxmlformats.org/officeDocument/2006/relationships" r:id="R2d7da28092e74f58"/>
+    <p:notesMasterId xmlns:r="http://schemas.openxmlformats.org/officeDocument/2006/relationships" r:id="R1891e47c5de14915"/>
   </p:notesMasterIdLst>
   <p:sldIdLst>
-    <p:sldId xmlns:r="http://schemas.openxmlformats.org/officeDocument/2006/relationships" id="256" r:id="Rd8a53714765047a5"/>
-    <p:sldId xmlns:r="http://schemas.openxmlformats.org/officeDocument/2006/relationships" id="257" r:id="Rac7bbc6c44a54b6d"/>
-    <p:sldId xmlns:r="http://schemas.openxmlformats.org/officeDocument/2006/relationships" id="258" r:id="R51f2ac37a3ef46a9"/>
-    <p:sldId xmlns:r="http://schemas.openxmlformats.org/officeDocument/2006/relationships" id="259" r:id="Ra1f5dc3a103b4bf4"/>
-    <p:sldId xmlns:r="http://schemas.openxmlformats.org/officeDocument/2006/relationships" id="260" r:id="R9850d103f9ac4db2"/>
-    <p:sldId xmlns:r="http://schemas.openxmlformats.org/officeDocument/2006/relationships" id="261" r:id="Re90d3e626f154eed"/>
-    <p:sldId xmlns:r="http://schemas.openxmlformats.org/officeDocument/2006/relationships" id="262" r:id="R91f1fecd6903492d"/>
-    <p:sldId xmlns:r="http://schemas.openxmlformats.org/officeDocument/2006/relationships" id="263" r:id="R4303353282b84524"/>
-    <p:sldId xmlns:r="http://schemas.openxmlformats.org/officeDocument/2006/relationships" id="264" r:id="R8aea72bb42554107"/>
-    <p:sldId xmlns:r="http://schemas.openxmlformats.org/officeDocument/2006/relationships" id="265" r:id="R769e377e14d744bb"/>
-    <p:sldId xmlns:r="http://schemas.openxmlformats.org/officeDocument/2006/relationships" id="266" r:id="R6003d2f9071a4f2b"/>
-    <p:sldId xmlns:r="http://schemas.openxmlformats.org/officeDocument/2006/relationships" id="267" r:id="R449541bd82ae4fe0"/>
-    <p:sldId xmlns:r="http://schemas.openxmlformats.org/officeDocument/2006/relationships" id="268" r:id="R52d7b15e692c4427"/>
-    <p:sldId xmlns:r="http://schemas.openxmlformats.org/officeDocument/2006/relationships" id="269" r:id="R0926e805e6e24a4e"/>
-    <p:sldId xmlns:r="http://schemas.openxmlformats.org/officeDocument/2006/relationships" id="270" r:id="R6cd609d4fb32404b"/>
-    <p:sldId xmlns:r="http://schemas.openxmlformats.org/officeDocument/2006/relationships" id="271" r:id="R1b89ee2221624280"/>
-    <p:sldId xmlns:r="http://schemas.openxmlformats.org/officeDocument/2006/relationships" id="272" r:id="R8111e598a4d343b1"/>
-    <p:sldId xmlns:r="http://schemas.openxmlformats.org/officeDocument/2006/relationships" id="273" r:id="Rce66f3a774c54bbf"/>
-    <p:sldId xmlns:r="http://schemas.openxmlformats.org/officeDocument/2006/relationships" id="274" r:id="R6b595bc52e464145"/>
-    <p:sldId xmlns:r="http://schemas.openxmlformats.org/officeDocument/2006/relationships" id="275" r:id="Re43e08451f854def"/>
+    <p:sldId xmlns:r="http://schemas.openxmlformats.org/officeDocument/2006/relationships" id="256" r:id="R73adb8e3133f43cc"/>
+    <p:sldId xmlns:r="http://schemas.openxmlformats.org/officeDocument/2006/relationships" id="257" r:id="R864db455d02f44dd"/>
+    <p:sldId xmlns:r="http://schemas.openxmlformats.org/officeDocument/2006/relationships" id="258" r:id="R31203715b00a4d17"/>
+    <p:sldId xmlns:r="http://schemas.openxmlformats.org/officeDocument/2006/relationships" id="259" r:id="Rc31dbc1730ca4146"/>
+    <p:sldId xmlns:r="http://schemas.openxmlformats.org/officeDocument/2006/relationships" id="260" r:id="Rd882ce381aac441f"/>
+    <p:sldId xmlns:r="http://schemas.openxmlformats.org/officeDocument/2006/relationships" id="261" r:id="Raa83ec398f5941af"/>
+    <p:sldId xmlns:r="http://schemas.openxmlformats.org/officeDocument/2006/relationships" id="262" r:id="Rf9d164c2bca44157"/>
+    <p:sldId xmlns:r="http://schemas.openxmlformats.org/officeDocument/2006/relationships" id="263" r:id="Rc1170b8044ff4930"/>
+    <p:sldId xmlns:r="http://schemas.openxmlformats.org/officeDocument/2006/relationships" id="264" r:id="R9494046b12ae4b95"/>
+    <p:sldId xmlns:r="http://schemas.openxmlformats.org/officeDocument/2006/relationships" id="265" r:id="R0e19359c1a734f82"/>
+    <p:sldId xmlns:r="http://schemas.openxmlformats.org/officeDocument/2006/relationships" id="266" r:id="R84e3927466324283"/>
+    <p:sldId xmlns:r="http://schemas.openxmlformats.org/officeDocument/2006/relationships" id="267" r:id="Ra4511195fb364644"/>
+    <p:sldId xmlns:r="http://schemas.openxmlformats.org/officeDocument/2006/relationships" id="268" r:id="Rba70c520041f4db7"/>
+    <p:sldId xmlns:r="http://schemas.openxmlformats.org/officeDocument/2006/relationships" id="269" r:id="Ra357f1d89cb74f03"/>
+    <p:sldId xmlns:r="http://schemas.openxmlformats.org/officeDocument/2006/relationships" id="270" r:id="R196e34d33a664baf"/>
+    <p:sldId xmlns:r="http://schemas.openxmlformats.org/officeDocument/2006/relationships" id="271" r:id="R9d5026a1e9444a4d"/>
+    <p:sldId xmlns:r="http://schemas.openxmlformats.org/officeDocument/2006/relationships" id="272" r:id="Rbc9adc5e8f8d4a4e"/>
+    <p:sldId xmlns:r="http://schemas.openxmlformats.org/officeDocument/2006/relationships" id="273" r:id="R80d4e5e4d1fe44a0"/>
+    <p:sldId xmlns:r="http://schemas.openxmlformats.org/officeDocument/2006/relationships" id="274" r:id="R28825bcc53c642c0"/>
+    <p:sldId xmlns:r="http://schemas.openxmlformats.org/officeDocument/2006/relationships" id="275" r:id="Raa376f99003c4daa"/>
   </p:sldIdLst>
   <p:sldSz cx="12192000" cy="6858000"/>
   <p:notesSz cx="6858000" cy="9144000"/>
@@ -6663,7 +6663,7 @@
           <p:cNvPr id="3" name="Title">
             <a:extLst xmlns:a="http://schemas.openxmlformats.org/drawingml/2006/main">
               <a:ext uri="{FF2B5EF4-FFF2-40B4-BE49-F238E27FC236}">
-                <a16:creationId xmlns:a16="http://schemas.microsoft.com/office/drawing/2014/main" id="{2E86EE58-BE56-4972-B51F-96852039EB9C}"/>
+                <a16:creationId xmlns:a16="http://schemas.microsoft.com/office/drawing/2014/main" id="{BCC65DEA-6A22-4F3E-92B2-85FABA4A69D8}"/>
               </a:ext>
             </a:extLst>
           </p:cNvPr>
@@ -6820,7 +6820,7 @@
           <p:cNvPr id="2" name="Subtitle">
             <a:extLst xmlns:a="http://schemas.openxmlformats.org/drawingml/2006/main">
               <a:ext uri="{FF2B5EF4-FFF2-40B4-BE49-F238E27FC236}">
-                <a16:creationId xmlns:a16="http://schemas.microsoft.com/office/drawing/2014/main" id="{EC850D06-48A9-4DA1-B355-3C1954F8E1D0}"/>
+                <a16:creationId xmlns:a16="http://schemas.microsoft.com/office/drawing/2014/main" id="{A0A4F419-21AB-4AB2-BD5B-37140C4209B4}"/>
               </a:ext>
             </a:extLst>
           </p:cNvPr>
@@ -6994,7 +6994,7 @@
           <p:cNvPr id="2" name="Section title">
             <a:extLst xmlns:a="http://schemas.openxmlformats.org/drawingml/2006/main">
               <a:ext uri="{FF2B5EF4-FFF2-40B4-BE49-F238E27FC236}">
-                <a16:creationId xmlns:a16="http://schemas.microsoft.com/office/drawing/2014/main" id="{5FC26A28-9DA3-4BA6-A063-2E0F18221E7F}"/>
+                <a16:creationId xmlns:a16="http://schemas.microsoft.com/office/drawing/2014/main" id="{A7349459-B5A5-46F7-9200-D3ACC5AD5238}"/>
               </a:ext>
             </a:extLst>
           </p:cNvPr>
@@ -7168,7 +7168,7 @@
           <p:cNvPr id="3" name="Title">
             <a:extLst xmlns:a="http://schemas.openxmlformats.org/drawingml/2006/main">
               <a:ext uri="{FF2B5EF4-FFF2-40B4-BE49-F238E27FC236}">
-                <a16:creationId xmlns:a16="http://schemas.microsoft.com/office/drawing/2014/main" id="{18D9F790-9BFD-45E8-9F0D-CFC00131D6DC}"/>
+                <a16:creationId xmlns:a16="http://schemas.microsoft.com/office/drawing/2014/main" id="{EC3CBD51-6A97-4AC4-B090-3D451D84F3CD}"/>
               </a:ext>
             </a:extLst>
           </p:cNvPr>
@@ -7325,7 +7325,7 @@
           <p:cNvPr id="2" name="Body">
             <a:extLst xmlns:a="http://schemas.openxmlformats.org/drawingml/2006/main">
               <a:ext uri="{FF2B5EF4-FFF2-40B4-BE49-F238E27FC236}">
-                <a16:creationId xmlns:a16="http://schemas.microsoft.com/office/drawing/2014/main" id="{7CD4AF74-A140-439A-B384-160D0686D220}"/>
+                <a16:creationId xmlns:a16="http://schemas.microsoft.com/office/drawing/2014/main" id="{16499BB1-C203-4214-9DCE-24CD51741B85}"/>
               </a:ext>
             </a:extLst>
           </p:cNvPr>
@@ -7499,7 +7499,7 @@
           <p:cNvPr id="4" name="Title">
             <a:extLst xmlns:a="http://schemas.openxmlformats.org/drawingml/2006/main">
               <a:ext uri="{FF2B5EF4-FFF2-40B4-BE49-F238E27FC236}">
-                <a16:creationId xmlns:a16="http://schemas.microsoft.com/office/drawing/2014/main" id="{3351FBBE-E4B5-4DEB-83DF-9A96D4F7B672}"/>
+                <a16:creationId xmlns:a16="http://schemas.microsoft.com/office/drawing/2014/main" id="{24C5CCDD-2EB3-41DD-813F-17F9755A9958}"/>
               </a:ext>
             </a:extLst>
           </p:cNvPr>
@@ -7656,7 +7656,7 @@
           <p:cNvPr id="2" name="Left column">
             <a:extLst xmlns:a="http://schemas.openxmlformats.org/drawingml/2006/main">
               <a:ext uri="{FF2B5EF4-FFF2-40B4-BE49-F238E27FC236}">
-                <a16:creationId xmlns:a16="http://schemas.microsoft.com/office/drawing/2014/main" id="{FB44D258-ECDA-453C-87B8-0B930E15600C}"/>
+                <a16:creationId xmlns:a16="http://schemas.microsoft.com/office/drawing/2014/main" id="{52858D80-32C5-4C07-B7BA-5FA25AB37D3A}"/>
               </a:ext>
             </a:extLst>
           </p:cNvPr>
@@ -7813,7 +7813,7 @@
           <p:cNvPr id="3" name="Right column">
             <a:extLst xmlns:a="http://schemas.openxmlformats.org/drawingml/2006/main">
               <a:ext uri="{FF2B5EF4-FFF2-40B4-BE49-F238E27FC236}">
-                <a16:creationId xmlns:a16="http://schemas.microsoft.com/office/drawing/2014/main" id="{8E5193E4-75B2-443E-BA31-9FD80586C4AE}"/>
+                <a16:creationId xmlns:a16="http://schemas.microsoft.com/office/drawing/2014/main" id="{C4905DF0-FA09-4BCA-8C53-AD22A2486B64}"/>
               </a:ext>
             </a:extLst>
           </p:cNvPr>
@@ -7987,7 +7987,7 @@
           <p:cNvPr id="3" name="Title">
             <a:extLst xmlns:a="http://schemas.openxmlformats.org/drawingml/2006/main">
               <a:ext uri="{FF2B5EF4-FFF2-40B4-BE49-F238E27FC236}">
-                <a16:creationId xmlns:a16="http://schemas.microsoft.com/office/drawing/2014/main" id="{377FD6E2-A716-4519-BBBF-DDEFA2020451}"/>
+                <a16:creationId xmlns:a16="http://schemas.microsoft.com/office/drawing/2014/main" id="{1A1A665C-5238-4E79-8115-D5013F1C0A87}"/>
               </a:ext>
             </a:extLst>
           </p:cNvPr>
@@ -8144,7 +8144,7 @@
           <p:cNvPr id="2" name="Left column">
             <a:extLst xmlns:a="http://schemas.openxmlformats.org/drawingml/2006/main">
               <a:ext uri="{FF2B5EF4-FFF2-40B4-BE49-F238E27FC236}">
-                <a16:creationId xmlns:a16="http://schemas.microsoft.com/office/drawing/2014/main" id="{50F7CFB8-A6A3-41F6-A044-6CC13788D944}"/>
+                <a16:creationId xmlns:a16="http://schemas.microsoft.com/office/drawing/2014/main" id="{477EA6F3-EBEE-47E5-ADDC-1A1357A7E862}"/>
               </a:ext>
             </a:extLst>
           </p:cNvPr>
@@ -8339,12 +8339,12 @@
   </p:cSld>
   <p:clrMap bg1="lt1" tx1="dk1" bg2="lt2" tx2="dk2" accent1="accent1" accent2="accent2" accent3="accent3" accent4="accent4" accent5="accent5" accent6="accent6" hlink="hlink" folHlink="folHlink"/>
   <p:sldLayoutIdLst>
-    <p:sldLayoutId xmlns:r="http://schemas.openxmlformats.org/officeDocument/2006/relationships" id="2147483649" r:id="R634a898b5af949cd"/>
-    <p:sldLayoutId xmlns:r="http://schemas.openxmlformats.org/officeDocument/2006/relationships" id="2147483650" r:id="Ra88b8bbd469a48e3"/>
-    <p:sldLayoutId xmlns:r="http://schemas.openxmlformats.org/officeDocument/2006/relationships" id="2147483651" r:id="R226b5a00969642b1"/>
-    <p:sldLayoutId xmlns:r="http://schemas.openxmlformats.org/officeDocument/2006/relationships" id="2147483652" r:id="R4b22df2f425740b0"/>
-    <p:sldLayoutId xmlns:r="http://schemas.openxmlformats.org/officeDocument/2006/relationships" id="2147483653" r:id="R7527a437afae4d24"/>
-    <p:sldLayoutId xmlns:r="http://schemas.openxmlformats.org/officeDocument/2006/relationships" id="2147483654" r:id="R59ec53ddc02a48a2"/>
+    <p:sldLayoutId xmlns:r="http://schemas.openxmlformats.org/officeDocument/2006/relationships" id="2147483649" r:id="R663e0e12a8d54195"/>
+    <p:sldLayoutId xmlns:r="http://schemas.openxmlformats.org/officeDocument/2006/relationships" id="2147483650" r:id="R15137cf0edec4088"/>
+    <p:sldLayoutId xmlns:r="http://schemas.openxmlformats.org/officeDocument/2006/relationships" id="2147483651" r:id="R7d2eca98900549df"/>
+    <p:sldLayoutId xmlns:r="http://schemas.openxmlformats.org/officeDocument/2006/relationships" id="2147483652" r:id="R401e0de8abca4e6c"/>
+    <p:sldLayoutId xmlns:r="http://schemas.openxmlformats.org/officeDocument/2006/relationships" id="2147483653" r:id="Rca9f9fa60cc84855"/>
+    <p:sldLayoutId xmlns:r="http://schemas.openxmlformats.org/officeDocument/2006/relationships" id="2147483654" r:id="R3c9d69787c714a01"/>
   </p:sldLayoutIdLst>
   <p:txStyles>
     <p:titleStyle>
@@ -8895,7 +8895,7 @@
           <p:cNvPr id="8" name="">
             <a:extLst xmlns:a="http://schemas.openxmlformats.org/drawingml/2006/main">
               <a:ext uri="{FF2B5EF4-FFF2-40B4-BE49-F238E27FC236}">
-                <a16:creationId xmlns:a16="http://schemas.microsoft.com/office/drawing/2014/main" id="{856C9FCE-BAFF-40B4-9005-BDCFBE6C70AA}"/>
+                <a16:creationId xmlns:a16="http://schemas.microsoft.com/office/drawing/2014/main" id="{DA21E2AF-86B8-4343-AED2-9C5E65D4465B}"/>
               </a:ext>
             </a:extLst>
           </p:cNvPr>
@@ -8905,7 +8905,7 @@
           <p:nvPr/>
         </p:nvPicPr>
         <p:blipFill>
-          <a:blip xmlns:r="http://schemas.openxmlformats.org/officeDocument/2006/relationships" xmlns:a="http://schemas.openxmlformats.org/drawingml/2006/main" r:embed="R41fe7fe6423240bb"/>
+          <a:blip xmlns:r="http://schemas.openxmlformats.org/officeDocument/2006/relationships" xmlns:a="http://schemas.openxmlformats.org/drawingml/2006/main" r:embed="R2273722bcdad4455"/>
           <a:srcRect xmlns:a="http://schemas.openxmlformats.org/drawingml/2006/main" l="0" t="0" r="0" b="0"/>
           <a:stretch xmlns:a="http://schemas.openxmlformats.org/drawingml/2006/main">
             <a:fillRect l="0" t="0" r="0" b="0"/>
@@ -8926,7 +8926,7 @@
           <p:cNvPr id="2" name="">
             <a:extLst xmlns:a="http://schemas.openxmlformats.org/drawingml/2006/main">
               <a:ext uri="{FF2B5EF4-FFF2-40B4-BE49-F238E27FC236}">
-                <a16:creationId xmlns:a16="http://schemas.microsoft.com/office/drawing/2014/main" id="{D34AC9B4-2116-4A09-ADE2-9FC513E488F5}"/>
+                <a16:creationId xmlns:a16="http://schemas.microsoft.com/office/drawing/2014/main" id="{9CD10DD6-B2CF-443C-A80D-5E35928369B7}"/>
               </a:ext>
             </a:extLst>
           </p:cNvPr>
@@ -8994,7 +8994,7 @@
           <p:cNvPr id="3" name="">
             <a:extLst xmlns:a="http://schemas.openxmlformats.org/drawingml/2006/main">
               <a:ext uri="{FF2B5EF4-FFF2-40B4-BE49-F238E27FC236}">
-                <a16:creationId xmlns:a16="http://schemas.microsoft.com/office/drawing/2014/main" id="{5B2DC784-0D41-4308-B27A-EEE0ED0ED64B}"/>
+                <a16:creationId xmlns:a16="http://schemas.microsoft.com/office/drawing/2014/main" id="{07D4AE39-EF0F-456B-80B0-C09A1F600987}"/>
               </a:ext>
             </a:extLst>
           </p:cNvPr>
@@ -9062,7 +9062,7 @@
           <p:cNvPr id="4" name="">
             <a:extLst xmlns:a="http://schemas.openxmlformats.org/drawingml/2006/main">
               <a:ext uri="{FF2B5EF4-FFF2-40B4-BE49-F238E27FC236}">
-                <a16:creationId xmlns:a16="http://schemas.microsoft.com/office/drawing/2014/main" id="{69C43468-10CD-4275-9BBE-3FFFFE680977}"/>
+                <a16:creationId xmlns:a16="http://schemas.microsoft.com/office/drawing/2014/main" id="{40287B3C-A510-41E8-8F53-40151957383F}"/>
               </a:ext>
             </a:extLst>
           </p:cNvPr>
@@ -9130,7 +9130,7 @@
           <p:cNvPr id="5" name="">
             <a:extLst xmlns:a="http://schemas.openxmlformats.org/drawingml/2006/main">
               <a:ext uri="{FF2B5EF4-FFF2-40B4-BE49-F238E27FC236}">
-                <a16:creationId xmlns:a16="http://schemas.microsoft.com/office/drawing/2014/main" id="{22F6BAD2-343D-4928-A50D-168733051040}"/>
+                <a16:creationId xmlns:a16="http://schemas.microsoft.com/office/drawing/2014/main" id="{4E0699D0-8F3E-4C0B-95DB-2D7CDF8078C5}"/>
               </a:ext>
             </a:extLst>
           </p:cNvPr>
@@ -9221,7 +9221,7 @@
           <p:cNvPr id="6" name="">
             <a:extLst xmlns:a="http://schemas.openxmlformats.org/drawingml/2006/main">
               <a:ext uri="{FF2B5EF4-FFF2-40B4-BE49-F238E27FC236}">
-                <a16:creationId xmlns:a16="http://schemas.microsoft.com/office/drawing/2014/main" id="{1C0C8E84-97BE-4371-8540-56F431753E47}"/>
+                <a16:creationId xmlns:a16="http://schemas.microsoft.com/office/drawing/2014/main" id="{0B0A6974-E18E-47A9-B9A7-A8D6BECAA169}"/>
               </a:ext>
             </a:extLst>
           </p:cNvPr>
@@ -9289,7 +9289,7 @@
           <p:cNvPr id="7" name="">
             <a:extLst xmlns:a="http://schemas.openxmlformats.org/drawingml/2006/main">
               <a:ext uri="{FF2B5EF4-FFF2-40B4-BE49-F238E27FC236}">
-                <a16:creationId xmlns:a16="http://schemas.microsoft.com/office/drawing/2014/main" id="{4128C8C8-FD22-43A7-8DE7-1995477239AF}"/>
+                <a16:creationId xmlns:a16="http://schemas.microsoft.com/office/drawing/2014/main" id="{1BD2EE4E-0C34-4E75-9672-CE9BDC11C3EE}"/>
               </a:ext>
             </a:extLst>
           </p:cNvPr>
@@ -9355,7 +9355,7 @@
     </p:spTree>
     <p:extLst>
       <p:ext uri="{BB962C8B-B14F-4D97-AF65-F5344CB8AC3E}">
-        <p14:creationId xmlns:p14="http://schemas.microsoft.com/office/powerpoint/2010/main" val="88145153"/>
+        <p14:creationId xmlns:p14="http://schemas.microsoft.com/office/powerpoint/2010/main" val="718026231"/>
       </p:ext>
     </p:extLst>
   </p:cSld>
@@ -9386,7 +9386,7 @@
           <p:cNvPr id="14" name="">
             <a:extLst xmlns:a="http://schemas.openxmlformats.org/drawingml/2006/main">
               <a:ext uri="{FF2B5EF4-FFF2-40B4-BE49-F238E27FC236}">
-                <a16:creationId xmlns:a16="http://schemas.microsoft.com/office/drawing/2014/main" id="{0A7E0ED1-5956-4CA7-84A2-A8B68EF155E7}"/>
+                <a16:creationId xmlns:a16="http://schemas.microsoft.com/office/drawing/2014/main" id="{3A2D8083-1B46-4532-9AF7-B5F3C429A555}"/>
               </a:ext>
             </a:extLst>
           </p:cNvPr>
@@ -9454,7 +9454,7 @@
           <p:cNvPr id="2" name="">
             <a:extLst xmlns:a="http://schemas.openxmlformats.org/drawingml/2006/main">
               <a:ext uri="{FF2B5EF4-FFF2-40B4-BE49-F238E27FC236}">
-                <a16:creationId xmlns:a16="http://schemas.microsoft.com/office/drawing/2014/main" id="{7CD9A868-164E-40A7-9023-70EB1C0A5E05}"/>
+                <a16:creationId xmlns:a16="http://schemas.microsoft.com/office/drawing/2014/main" id="{667687F3-9DAE-4425-B280-FC05824A30F0}"/>
               </a:ext>
             </a:extLst>
           </p:cNvPr>
@@ -9522,7 +9522,7 @@
           <p:cNvPr id="3" name="">
             <a:extLst xmlns:a="http://schemas.openxmlformats.org/drawingml/2006/main">
               <a:ext uri="{FF2B5EF4-FFF2-40B4-BE49-F238E27FC236}">
-                <a16:creationId xmlns:a16="http://schemas.microsoft.com/office/drawing/2014/main" id="{90597B51-E812-4A53-9641-201843C42883}"/>
+                <a16:creationId xmlns:a16="http://schemas.microsoft.com/office/drawing/2014/main" id="{6B17248C-D861-4178-BE33-B4D123C68C0A}"/>
               </a:ext>
             </a:extLst>
           </p:cNvPr>
@@ -9590,7 +9590,7 @@
           <p:cNvPr id="4" name="">
             <a:extLst xmlns:a="http://schemas.openxmlformats.org/drawingml/2006/main">
               <a:ext uri="{FF2B5EF4-FFF2-40B4-BE49-F238E27FC236}">
-                <a16:creationId xmlns:a16="http://schemas.microsoft.com/office/drawing/2014/main" id="{8626C59C-9044-4C2B-9DFF-273FDF6C093D}"/>
+                <a16:creationId xmlns:a16="http://schemas.microsoft.com/office/drawing/2014/main" id="{C94C2123-9F37-4193-A334-3440DB453680}"/>
               </a:ext>
             </a:extLst>
           </p:cNvPr>
@@ -9658,7 +9658,7 @@
           <p:cNvPr id="5" name="">
             <a:extLst xmlns:a="http://schemas.openxmlformats.org/drawingml/2006/main">
               <a:ext uri="{FF2B5EF4-FFF2-40B4-BE49-F238E27FC236}">
-                <a16:creationId xmlns:a16="http://schemas.microsoft.com/office/drawing/2014/main" id="{5F398EEA-36E9-4569-A0C0-E375FC8A2A5C}"/>
+                <a16:creationId xmlns:a16="http://schemas.microsoft.com/office/drawing/2014/main" id="{B368EFB8-19C2-445C-BED3-C2AD8A300C32}"/>
               </a:ext>
             </a:extLst>
           </p:cNvPr>
@@ -9726,7 +9726,7 @@
           <p:cNvPr id="6" name="">
             <a:extLst xmlns:a="http://schemas.openxmlformats.org/drawingml/2006/main">
               <a:ext uri="{FF2B5EF4-FFF2-40B4-BE49-F238E27FC236}">
-                <a16:creationId xmlns:a16="http://schemas.microsoft.com/office/drawing/2014/main" id="{AF80C6C7-7729-40E7-83A9-DD07B59EF700}"/>
+                <a16:creationId xmlns:a16="http://schemas.microsoft.com/office/drawing/2014/main" id="{2BFC5D4A-1DD4-4AC2-8A5F-3215144E2E4A}"/>
               </a:ext>
             </a:extLst>
           </p:cNvPr>
@@ -9863,7 +9863,7 @@
           <p:cNvPr id="7" name="">
             <a:extLst xmlns:a="http://schemas.openxmlformats.org/drawingml/2006/main">
               <a:ext uri="{FF2B5EF4-FFF2-40B4-BE49-F238E27FC236}">
-                <a16:creationId xmlns:a16="http://schemas.microsoft.com/office/drawing/2014/main" id="{58FE4D42-C73E-4B50-A733-368F7A047201}"/>
+                <a16:creationId xmlns:a16="http://schemas.microsoft.com/office/drawing/2014/main" id="{2F191CE4-AA6B-4DB8-A5FB-E196C9EC07A8}"/>
               </a:ext>
             </a:extLst>
           </p:cNvPr>
@@ -9931,7 +9931,7 @@
           <p:cNvPr id="8" name="">
             <a:extLst xmlns:a="http://schemas.openxmlformats.org/drawingml/2006/main">
               <a:ext uri="{FF2B5EF4-FFF2-40B4-BE49-F238E27FC236}">
-                <a16:creationId xmlns:a16="http://schemas.microsoft.com/office/drawing/2014/main" id="{62C4BADA-D815-48D3-A240-46609C194A76}"/>
+                <a16:creationId xmlns:a16="http://schemas.microsoft.com/office/drawing/2014/main" id="{CCD289EB-35CE-4438-91FB-59F40EEDF37D}"/>
               </a:ext>
             </a:extLst>
           </p:cNvPr>
@@ -9999,7 +9999,7 @@
           <p:cNvPr id="9" name="">
             <a:extLst xmlns:a="http://schemas.openxmlformats.org/drawingml/2006/main">
               <a:ext uri="{FF2B5EF4-FFF2-40B4-BE49-F238E27FC236}">
-                <a16:creationId xmlns:a16="http://schemas.microsoft.com/office/drawing/2014/main" id="{55FCB66F-352E-43A8-B265-2BD048A706DC}"/>
+                <a16:creationId xmlns:a16="http://schemas.microsoft.com/office/drawing/2014/main" id="{45D8E355-624D-41A9-B8AA-4268E51147E7}"/>
               </a:ext>
             </a:extLst>
           </p:cNvPr>
@@ -10136,7 +10136,7 @@
           <p:cNvPr id="10" name="">
             <a:extLst xmlns:a="http://schemas.openxmlformats.org/drawingml/2006/main">
               <a:ext uri="{FF2B5EF4-FFF2-40B4-BE49-F238E27FC236}">
-                <a16:creationId xmlns:a16="http://schemas.microsoft.com/office/drawing/2014/main" id="{60F69E30-334E-4CD1-B159-D3AED4096BCD}"/>
+                <a16:creationId xmlns:a16="http://schemas.microsoft.com/office/drawing/2014/main" id="{2DDDD52D-C66C-45EA-8521-450AEBD67492}"/>
               </a:ext>
             </a:extLst>
           </p:cNvPr>
@@ -10204,7 +10204,7 @@
           <p:cNvPr id="11" name="">
             <a:extLst xmlns:a="http://schemas.openxmlformats.org/drawingml/2006/main">
               <a:ext uri="{FF2B5EF4-FFF2-40B4-BE49-F238E27FC236}">
-                <a16:creationId xmlns:a16="http://schemas.microsoft.com/office/drawing/2014/main" id="{C1532560-4934-4B0C-A3F3-85A8A645AEDB}"/>
+                <a16:creationId xmlns:a16="http://schemas.microsoft.com/office/drawing/2014/main" id="{5CB32D5A-30B5-46F9-A6A9-C012C3FC8B5F}"/>
               </a:ext>
             </a:extLst>
           </p:cNvPr>
@@ -10272,7 +10272,7 @@
           <p:cNvPr id="12" name="">
             <a:extLst xmlns:a="http://schemas.openxmlformats.org/drawingml/2006/main">
               <a:ext uri="{FF2B5EF4-FFF2-40B4-BE49-F238E27FC236}">
-                <a16:creationId xmlns:a16="http://schemas.microsoft.com/office/drawing/2014/main" id="{33E348C7-C5B8-4D21-9378-326F36EB8476}"/>
+                <a16:creationId xmlns:a16="http://schemas.microsoft.com/office/drawing/2014/main" id="{8C4B7B79-0CAF-4068-8E94-9FF6AE4649EB}"/>
               </a:ext>
             </a:extLst>
           </p:cNvPr>
@@ -10409,7 +10409,7 @@
           <p:cNvPr id="13" name="">
             <a:extLst xmlns:a="http://schemas.openxmlformats.org/drawingml/2006/main">
               <a:ext uri="{FF2B5EF4-FFF2-40B4-BE49-F238E27FC236}">
-                <a16:creationId xmlns:a16="http://schemas.microsoft.com/office/drawing/2014/main" id="{E7A4A9FA-2B17-410E-BA7A-127553895956}"/>
+                <a16:creationId xmlns:a16="http://schemas.microsoft.com/office/drawing/2014/main" id="{31C9499C-2DF1-44AA-973F-E80395717499}"/>
               </a:ext>
             </a:extLst>
           </p:cNvPr>
@@ -10475,7 +10475,7 @@
     </p:spTree>
     <p:extLst>
       <p:ext uri="{BB962C8B-B14F-4D97-AF65-F5344CB8AC3E}">
-        <p14:creationId xmlns:p14="http://schemas.microsoft.com/office/powerpoint/2010/main" val="99580744"/>
+        <p14:creationId xmlns:p14="http://schemas.microsoft.com/office/powerpoint/2010/main" val="1428685861"/>
       </p:ext>
     </p:extLst>
   </p:cSld>
@@ -10506,7 +10506,7 @@
           <p:cNvPr id="21" name="">
             <a:extLst xmlns:a="http://schemas.openxmlformats.org/drawingml/2006/main">
               <a:ext uri="{FF2B5EF4-FFF2-40B4-BE49-F238E27FC236}">
-                <a16:creationId xmlns:a16="http://schemas.microsoft.com/office/drawing/2014/main" id="{4049655F-A916-4DB9-B203-8B67A39F26BC}"/>
+                <a16:creationId xmlns:a16="http://schemas.microsoft.com/office/drawing/2014/main" id="{C57E16B3-DB40-45B5-9976-95D1E0DF68F7}"/>
               </a:ext>
             </a:extLst>
           </p:cNvPr>
@@ -10574,7 +10574,7 @@
           <p:cNvPr id="2" name="">
             <a:extLst xmlns:a="http://schemas.openxmlformats.org/drawingml/2006/main">
               <a:ext uri="{FF2B5EF4-FFF2-40B4-BE49-F238E27FC236}">
-                <a16:creationId xmlns:a16="http://schemas.microsoft.com/office/drawing/2014/main" id="{104CADC5-EE1F-478E-8C9F-38E72831782F}"/>
+                <a16:creationId xmlns:a16="http://schemas.microsoft.com/office/drawing/2014/main" id="{9A4785A1-F68E-49B1-B92A-57C6E48C6D93}"/>
               </a:ext>
             </a:extLst>
           </p:cNvPr>
@@ -10642,7 +10642,7 @@
           <p:cNvPr id="3" name="">
             <a:extLst xmlns:a="http://schemas.openxmlformats.org/drawingml/2006/main">
               <a:ext uri="{FF2B5EF4-FFF2-40B4-BE49-F238E27FC236}">
-                <a16:creationId xmlns:a16="http://schemas.microsoft.com/office/drawing/2014/main" id="{F1C8E721-8829-4594-A60D-3CAC99CCAD99}"/>
+                <a16:creationId xmlns:a16="http://schemas.microsoft.com/office/drawing/2014/main" id="{EEE5B2FB-EAF9-4F4E-9CF6-7619C30F9A58}"/>
               </a:ext>
             </a:extLst>
           </p:cNvPr>
@@ -10710,7 +10710,7 @@
           <p:cNvPr id="4" name="">
             <a:extLst xmlns:a="http://schemas.openxmlformats.org/drawingml/2006/main">
               <a:ext uri="{FF2B5EF4-FFF2-40B4-BE49-F238E27FC236}">
-                <a16:creationId xmlns:a16="http://schemas.microsoft.com/office/drawing/2014/main" id="{968C2A8A-DDA3-4E6A-86A9-3818EE56C3D1}"/>
+                <a16:creationId xmlns:a16="http://schemas.microsoft.com/office/drawing/2014/main" id="{453B97DF-5C95-4977-B4EB-81D37F2B7DAF}"/>
               </a:ext>
             </a:extLst>
           </p:cNvPr>
@@ -10720,7 +10720,7 @@
           <p:nvPr/>
         </p:nvPicPr>
         <p:blipFill>
-          <a:blip xmlns:r="http://schemas.openxmlformats.org/officeDocument/2006/relationships" xmlns:a="http://schemas.openxmlformats.org/drawingml/2006/main" r:embed="R9b9f8c97128442e9"/>
+          <a:blip xmlns:r="http://schemas.openxmlformats.org/officeDocument/2006/relationships" xmlns:a="http://schemas.openxmlformats.org/drawingml/2006/main" r:embed="R00cced28af3e41f2"/>
           <a:stretch xmlns:a="http://schemas.openxmlformats.org/drawingml/2006/main"/>
         </p:blipFill>
         <p:spPr>
@@ -10738,7 +10738,7 @@
           <p:cNvPr id="5" name="">
             <a:extLst xmlns:a="http://schemas.openxmlformats.org/drawingml/2006/main">
               <a:ext uri="{FF2B5EF4-FFF2-40B4-BE49-F238E27FC236}">
-                <a16:creationId xmlns:a16="http://schemas.microsoft.com/office/drawing/2014/main" id="{7AFA8646-C5A6-4BF9-9635-EEF167BAE277}"/>
+                <a16:creationId xmlns:a16="http://schemas.microsoft.com/office/drawing/2014/main" id="{00319938-4F42-48A2-849F-7F9B468F8CA4}"/>
               </a:ext>
             </a:extLst>
           </p:cNvPr>
@@ -10806,7 +10806,7 @@
           <p:cNvPr id="6" name="">
             <a:extLst xmlns:a="http://schemas.openxmlformats.org/drawingml/2006/main">
               <a:ext uri="{FF2B5EF4-FFF2-40B4-BE49-F238E27FC236}">
-                <a16:creationId xmlns:a16="http://schemas.microsoft.com/office/drawing/2014/main" id="{4C8EBE8B-A44E-444A-8C5B-AC85A375CB94}"/>
+                <a16:creationId xmlns:a16="http://schemas.microsoft.com/office/drawing/2014/main" id="{304ADAD8-E86B-4F51-950A-D875330ABA26}"/>
               </a:ext>
             </a:extLst>
           </p:cNvPr>
@@ -10874,7 +10874,7 @@
           <p:cNvPr id="7" name="">
             <a:extLst xmlns:a="http://schemas.openxmlformats.org/drawingml/2006/main">
               <a:ext uri="{FF2B5EF4-FFF2-40B4-BE49-F238E27FC236}">
-                <a16:creationId xmlns:a16="http://schemas.microsoft.com/office/drawing/2014/main" id="{5C344009-8C4E-4C01-B28E-D5AB0A959818}"/>
+                <a16:creationId xmlns:a16="http://schemas.microsoft.com/office/drawing/2014/main" id="{87D6D4B6-15CD-49FA-9F01-6E2FDAB2CC08}"/>
               </a:ext>
             </a:extLst>
           </p:cNvPr>
@@ -10965,7 +10965,7 @@
           <p:cNvPr id="8" name="">
             <a:extLst xmlns:a="http://schemas.openxmlformats.org/drawingml/2006/main">
               <a:ext uri="{FF2B5EF4-FFF2-40B4-BE49-F238E27FC236}">
-                <a16:creationId xmlns:a16="http://schemas.microsoft.com/office/drawing/2014/main" id="{7A82D73D-AD40-4141-A374-BAA2256664FB}"/>
+                <a16:creationId xmlns:a16="http://schemas.microsoft.com/office/drawing/2014/main" id="{38A03A46-FDFA-4D39-B6EE-D986C0097AE0}"/>
               </a:ext>
             </a:extLst>
           </p:cNvPr>
@@ -10975,7 +10975,7 @@
           <p:nvPr/>
         </p:nvPicPr>
         <p:blipFill>
-          <a:blip xmlns:r="http://schemas.openxmlformats.org/officeDocument/2006/relationships" xmlns:a="http://schemas.openxmlformats.org/drawingml/2006/main" r:embed="R32cfc9425f41479f"/>
+          <a:blip xmlns:r="http://schemas.openxmlformats.org/officeDocument/2006/relationships" xmlns:a="http://schemas.openxmlformats.org/drawingml/2006/main" r:embed="R8d40a20f7d9b4a3c"/>
           <a:stretch xmlns:a="http://schemas.openxmlformats.org/drawingml/2006/main"/>
         </p:blipFill>
         <p:spPr>
@@ -10993,7 +10993,7 @@
           <p:cNvPr id="9" name="">
             <a:extLst xmlns:a="http://schemas.openxmlformats.org/drawingml/2006/main">
               <a:ext uri="{FF2B5EF4-FFF2-40B4-BE49-F238E27FC236}">
-                <a16:creationId xmlns:a16="http://schemas.microsoft.com/office/drawing/2014/main" id="{4F0C25AD-B86F-4F34-811C-51230488AE35}"/>
+                <a16:creationId xmlns:a16="http://schemas.microsoft.com/office/drawing/2014/main" id="{7646EB81-CB82-4CF0-B7AF-8FFEEC5580F3}"/>
               </a:ext>
             </a:extLst>
           </p:cNvPr>
@@ -11061,7 +11061,7 @@
           <p:cNvPr id="10" name="">
             <a:extLst xmlns:a="http://schemas.openxmlformats.org/drawingml/2006/main">
               <a:ext uri="{FF2B5EF4-FFF2-40B4-BE49-F238E27FC236}">
-                <a16:creationId xmlns:a16="http://schemas.microsoft.com/office/drawing/2014/main" id="{97D04948-01EA-4B79-A1E2-A584D98838F0}"/>
+                <a16:creationId xmlns:a16="http://schemas.microsoft.com/office/drawing/2014/main" id="{776D86EE-FD2E-49F4-9953-0B5D34A02115}"/>
               </a:ext>
             </a:extLst>
           </p:cNvPr>
@@ -11129,7 +11129,7 @@
           <p:cNvPr id="11" name="">
             <a:extLst xmlns:a="http://schemas.openxmlformats.org/drawingml/2006/main">
               <a:ext uri="{FF2B5EF4-FFF2-40B4-BE49-F238E27FC236}">
-                <a16:creationId xmlns:a16="http://schemas.microsoft.com/office/drawing/2014/main" id="{3AD776C3-7348-4446-9CF7-4761478A75FE}"/>
+                <a16:creationId xmlns:a16="http://schemas.microsoft.com/office/drawing/2014/main" id="{E9BBB591-4128-428E-BEEE-146D4011FC5E}"/>
               </a:ext>
             </a:extLst>
           </p:cNvPr>
@@ -11220,7 +11220,7 @@
           <p:cNvPr id="12" name="">
             <a:extLst xmlns:a="http://schemas.openxmlformats.org/drawingml/2006/main">
               <a:ext uri="{FF2B5EF4-FFF2-40B4-BE49-F238E27FC236}">
-                <a16:creationId xmlns:a16="http://schemas.microsoft.com/office/drawing/2014/main" id="{EE5D4931-5FCC-4555-9FE1-E199DE4391E8}"/>
+                <a16:creationId xmlns:a16="http://schemas.microsoft.com/office/drawing/2014/main" id="{D55222FE-1FA0-4FC2-9856-5874B667B53F}"/>
               </a:ext>
             </a:extLst>
           </p:cNvPr>
@@ -11230,7 +11230,7 @@
           <p:nvPr/>
         </p:nvPicPr>
         <p:blipFill>
-          <a:blip xmlns:r="http://schemas.openxmlformats.org/officeDocument/2006/relationships" xmlns:a="http://schemas.openxmlformats.org/drawingml/2006/main" r:embed="R7707b30d7f6a4f1b"/>
+          <a:blip xmlns:r="http://schemas.openxmlformats.org/officeDocument/2006/relationships" xmlns:a="http://schemas.openxmlformats.org/drawingml/2006/main" r:embed="Ra7f70b111ac241ff"/>
           <a:stretch xmlns:a="http://schemas.openxmlformats.org/drawingml/2006/main"/>
         </p:blipFill>
         <p:spPr>
@@ -11248,7 +11248,7 @@
           <p:cNvPr id="13" name="">
             <a:extLst xmlns:a="http://schemas.openxmlformats.org/drawingml/2006/main">
               <a:ext uri="{FF2B5EF4-FFF2-40B4-BE49-F238E27FC236}">
-                <a16:creationId xmlns:a16="http://schemas.microsoft.com/office/drawing/2014/main" id="{B578DA8D-88FD-4DF7-8CA9-9A849C5844E0}"/>
+                <a16:creationId xmlns:a16="http://schemas.microsoft.com/office/drawing/2014/main" id="{03C0B550-84E6-4EE3-96D0-52240CBEFA27}"/>
               </a:ext>
             </a:extLst>
           </p:cNvPr>
@@ -11316,7 +11316,7 @@
           <p:cNvPr id="14" name="">
             <a:extLst xmlns:a="http://schemas.openxmlformats.org/drawingml/2006/main">
               <a:ext uri="{FF2B5EF4-FFF2-40B4-BE49-F238E27FC236}">
-                <a16:creationId xmlns:a16="http://schemas.microsoft.com/office/drawing/2014/main" id="{5DDE4A6C-7ABD-4DD5-963B-A5B67F64D02F}"/>
+                <a16:creationId xmlns:a16="http://schemas.microsoft.com/office/drawing/2014/main" id="{6F2CAA1C-826E-4485-AA1E-3752A074D78E}"/>
               </a:ext>
             </a:extLst>
           </p:cNvPr>
@@ -11384,7 +11384,7 @@
           <p:cNvPr id="15" name="">
             <a:extLst xmlns:a="http://schemas.openxmlformats.org/drawingml/2006/main">
               <a:ext uri="{FF2B5EF4-FFF2-40B4-BE49-F238E27FC236}">
-                <a16:creationId xmlns:a16="http://schemas.microsoft.com/office/drawing/2014/main" id="{7B91B12A-9D55-4A66-894C-603E41F4DE02}"/>
+                <a16:creationId xmlns:a16="http://schemas.microsoft.com/office/drawing/2014/main" id="{9AC7AD2D-E026-40A9-AFE9-82E201459823}"/>
               </a:ext>
             </a:extLst>
           </p:cNvPr>
@@ -11475,7 +11475,7 @@
           <p:cNvPr id="16" name="">
             <a:extLst xmlns:a="http://schemas.openxmlformats.org/drawingml/2006/main">
               <a:ext uri="{FF2B5EF4-FFF2-40B4-BE49-F238E27FC236}">
-                <a16:creationId xmlns:a16="http://schemas.microsoft.com/office/drawing/2014/main" id="{35F65906-223F-468F-8DF5-6206837FB83A}"/>
+                <a16:creationId xmlns:a16="http://schemas.microsoft.com/office/drawing/2014/main" id="{4526A4E6-4B7C-4109-8934-67040BB30130}"/>
               </a:ext>
             </a:extLst>
           </p:cNvPr>
@@ -11485,7 +11485,7 @@
           <p:nvPr/>
         </p:nvPicPr>
         <p:blipFill>
-          <a:blip xmlns:r="http://schemas.openxmlformats.org/officeDocument/2006/relationships" xmlns:a="http://schemas.openxmlformats.org/drawingml/2006/main" r:embed="R25cc9bec5efc4444"/>
+          <a:blip xmlns:r="http://schemas.openxmlformats.org/officeDocument/2006/relationships" xmlns:a="http://schemas.openxmlformats.org/drawingml/2006/main" r:embed="R3ca6eb10c1c94229"/>
           <a:stretch xmlns:a="http://schemas.openxmlformats.org/drawingml/2006/main"/>
         </p:blipFill>
         <p:spPr>
@@ -11503,7 +11503,7 @@
           <p:cNvPr id="17" name="">
             <a:extLst xmlns:a="http://schemas.openxmlformats.org/drawingml/2006/main">
               <a:ext uri="{FF2B5EF4-FFF2-40B4-BE49-F238E27FC236}">
-                <a16:creationId xmlns:a16="http://schemas.microsoft.com/office/drawing/2014/main" id="{03260152-3308-4DD3-81BD-AE41ACCC8D50}"/>
+                <a16:creationId xmlns:a16="http://schemas.microsoft.com/office/drawing/2014/main" id="{07DAA06B-E703-4D9B-9E09-7476AF0BE956}"/>
               </a:ext>
             </a:extLst>
           </p:cNvPr>
@@ -11571,7 +11571,7 @@
           <p:cNvPr id="18" name="">
             <a:extLst xmlns:a="http://schemas.openxmlformats.org/drawingml/2006/main">
               <a:ext uri="{FF2B5EF4-FFF2-40B4-BE49-F238E27FC236}">
-                <a16:creationId xmlns:a16="http://schemas.microsoft.com/office/drawing/2014/main" id="{5DDC4217-73F6-4638-BAAA-2CF2266A1236}"/>
+                <a16:creationId xmlns:a16="http://schemas.microsoft.com/office/drawing/2014/main" id="{C9E21EAA-A4AB-4E1C-BD0A-12C31B6586F8}"/>
               </a:ext>
             </a:extLst>
           </p:cNvPr>
@@ -11639,7 +11639,7 @@
           <p:cNvPr id="19" name="">
             <a:extLst xmlns:a="http://schemas.openxmlformats.org/drawingml/2006/main">
               <a:ext uri="{FF2B5EF4-FFF2-40B4-BE49-F238E27FC236}">
-                <a16:creationId xmlns:a16="http://schemas.microsoft.com/office/drawing/2014/main" id="{55A0C886-56FF-443F-82FE-136799599BA9}"/>
+                <a16:creationId xmlns:a16="http://schemas.microsoft.com/office/drawing/2014/main" id="{D01D92A3-DC50-43C1-8A20-CDE612489BB5}"/>
               </a:ext>
             </a:extLst>
           </p:cNvPr>
@@ -11730,7 +11730,7 @@
           <p:cNvPr id="20" name="">
             <a:extLst xmlns:a="http://schemas.openxmlformats.org/drawingml/2006/main">
               <a:ext uri="{FF2B5EF4-FFF2-40B4-BE49-F238E27FC236}">
-                <a16:creationId xmlns:a16="http://schemas.microsoft.com/office/drawing/2014/main" id="{E352E650-E8AE-43D4-87E9-592F2F3551DE}"/>
+                <a16:creationId xmlns:a16="http://schemas.microsoft.com/office/drawing/2014/main" id="{86C5FBDA-4877-4CE5-9AFD-83528B9A7544}"/>
               </a:ext>
             </a:extLst>
           </p:cNvPr>
@@ -11796,7 +11796,7 @@
     </p:spTree>
     <p:extLst>
       <p:ext uri="{BB962C8B-B14F-4D97-AF65-F5344CB8AC3E}">
-        <p14:creationId xmlns:p14="http://schemas.microsoft.com/office/powerpoint/2010/main" val="863710621"/>
+        <p14:creationId xmlns:p14="http://schemas.microsoft.com/office/powerpoint/2010/main" val="1766809642"/>
       </p:ext>
     </p:extLst>
   </p:cSld>
@@ -11827,7 +11827,7 @@
           <p:cNvPr id="21" name="">
             <a:extLst xmlns:a="http://schemas.openxmlformats.org/drawingml/2006/main">
               <a:ext uri="{FF2B5EF4-FFF2-40B4-BE49-F238E27FC236}">
-                <a16:creationId xmlns:a16="http://schemas.microsoft.com/office/drawing/2014/main" id="{9B8F1F9A-10F8-4723-9089-A4EEF65A0AB2}"/>
+                <a16:creationId xmlns:a16="http://schemas.microsoft.com/office/drawing/2014/main" id="{9B942990-132F-47BD-87CA-FEC34BA034A2}"/>
               </a:ext>
             </a:extLst>
           </p:cNvPr>
@@ -11895,7 +11895,7 @@
           <p:cNvPr id="2" name="">
             <a:extLst xmlns:a="http://schemas.openxmlformats.org/drawingml/2006/main">
               <a:ext uri="{FF2B5EF4-FFF2-40B4-BE49-F238E27FC236}">
-                <a16:creationId xmlns:a16="http://schemas.microsoft.com/office/drawing/2014/main" id="{917B3616-C651-446D-B239-C8532A86C603}"/>
+                <a16:creationId xmlns:a16="http://schemas.microsoft.com/office/drawing/2014/main" id="{9161145A-D95B-41C8-A13C-1B9D9E23A6CE}"/>
               </a:ext>
             </a:extLst>
           </p:cNvPr>
@@ -11963,7 +11963,7 @@
           <p:cNvPr id="3" name="">
             <a:extLst xmlns:a="http://schemas.openxmlformats.org/drawingml/2006/main">
               <a:ext uri="{FF2B5EF4-FFF2-40B4-BE49-F238E27FC236}">
-                <a16:creationId xmlns:a16="http://schemas.microsoft.com/office/drawing/2014/main" id="{B85D6CE5-E481-40C9-B114-DF8EC6DEAA5F}"/>
+                <a16:creationId xmlns:a16="http://schemas.microsoft.com/office/drawing/2014/main" id="{80F35524-F18E-4B63-BCD7-CE479AB1BE48}"/>
               </a:ext>
             </a:extLst>
           </p:cNvPr>
@@ -12031,7 +12031,7 @@
           <p:cNvPr id="4" name="">
             <a:extLst xmlns:a="http://schemas.openxmlformats.org/drawingml/2006/main">
               <a:ext uri="{FF2B5EF4-FFF2-40B4-BE49-F238E27FC236}">
-                <a16:creationId xmlns:a16="http://schemas.microsoft.com/office/drawing/2014/main" id="{6F525FB1-0499-44DF-B4C4-13D5B113F107}"/>
+                <a16:creationId xmlns:a16="http://schemas.microsoft.com/office/drawing/2014/main" id="{34BC6281-3875-4F3F-B281-3C872D2416B8}"/>
               </a:ext>
             </a:extLst>
           </p:cNvPr>
@@ -12041,7 +12041,7 @@
           <p:nvPr/>
         </p:nvPicPr>
         <p:blipFill>
-          <a:blip xmlns:r="http://schemas.openxmlformats.org/officeDocument/2006/relationships" xmlns:a="http://schemas.openxmlformats.org/drawingml/2006/main" r:embed="Rc99fe3c36bc94306"/>
+          <a:blip xmlns:r="http://schemas.openxmlformats.org/officeDocument/2006/relationships" xmlns:a="http://schemas.openxmlformats.org/drawingml/2006/main" r:embed="R1d0f548c98444289"/>
           <a:stretch xmlns:a="http://schemas.openxmlformats.org/drawingml/2006/main"/>
         </p:blipFill>
         <p:spPr>
@@ -12059,7 +12059,7 @@
           <p:cNvPr id="5" name="">
             <a:extLst xmlns:a="http://schemas.openxmlformats.org/drawingml/2006/main">
               <a:ext uri="{FF2B5EF4-FFF2-40B4-BE49-F238E27FC236}">
-                <a16:creationId xmlns:a16="http://schemas.microsoft.com/office/drawing/2014/main" id="{940AAD04-1E56-401E-8764-4F398258D08D}"/>
+                <a16:creationId xmlns:a16="http://schemas.microsoft.com/office/drawing/2014/main" id="{FB0C834A-39AD-437C-BD8E-ADEFCC61F514}"/>
               </a:ext>
             </a:extLst>
           </p:cNvPr>
@@ -12127,7 +12127,7 @@
           <p:cNvPr id="6" name="">
             <a:extLst xmlns:a="http://schemas.openxmlformats.org/drawingml/2006/main">
               <a:ext uri="{FF2B5EF4-FFF2-40B4-BE49-F238E27FC236}">
-                <a16:creationId xmlns:a16="http://schemas.microsoft.com/office/drawing/2014/main" id="{8D5E4142-DF3D-44F6-8F1C-CE7A165E1D3B}"/>
+                <a16:creationId xmlns:a16="http://schemas.microsoft.com/office/drawing/2014/main" id="{28FCF11B-B3BC-455B-A2B5-8BAF3AFE48D7}"/>
               </a:ext>
             </a:extLst>
           </p:cNvPr>
@@ -12195,7 +12195,7 @@
           <p:cNvPr id="7" name="">
             <a:extLst xmlns:a="http://schemas.openxmlformats.org/drawingml/2006/main">
               <a:ext uri="{FF2B5EF4-FFF2-40B4-BE49-F238E27FC236}">
-                <a16:creationId xmlns:a16="http://schemas.microsoft.com/office/drawing/2014/main" id="{88652C0D-505B-4E14-BCFE-5728902A55D5}"/>
+                <a16:creationId xmlns:a16="http://schemas.microsoft.com/office/drawing/2014/main" id="{74E6EED5-A893-4717-B95A-33F1C6567157}"/>
               </a:ext>
             </a:extLst>
           </p:cNvPr>
@@ -12205,7 +12205,7 @@
           <p:nvPr/>
         </p:nvPicPr>
         <p:blipFill>
-          <a:blip xmlns:r="http://schemas.openxmlformats.org/officeDocument/2006/relationships" xmlns:a="http://schemas.openxmlformats.org/drawingml/2006/main" r:embed="R47056818ce0c4a82"/>
+          <a:blip xmlns:r="http://schemas.openxmlformats.org/officeDocument/2006/relationships" xmlns:a="http://schemas.openxmlformats.org/drawingml/2006/main" r:embed="R58d1d9550d654894"/>
           <a:stretch xmlns:a="http://schemas.openxmlformats.org/drawingml/2006/main"/>
         </p:blipFill>
         <p:spPr>
@@ -12223,7 +12223,7 @@
           <p:cNvPr id="8" name="">
             <a:extLst xmlns:a="http://schemas.openxmlformats.org/drawingml/2006/main">
               <a:ext uri="{FF2B5EF4-FFF2-40B4-BE49-F238E27FC236}">
-                <a16:creationId xmlns:a16="http://schemas.microsoft.com/office/drawing/2014/main" id="{9415F809-7172-4A25-9223-85F474CE0C1F}"/>
+                <a16:creationId xmlns:a16="http://schemas.microsoft.com/office/drawing/2014/main" id="{A1519B89-1C9E-4C38-B1DF-459BF2387E4B}"/>
               </a:ext>
             </a:extLst>
           </p:cNvPr>
@@ -12291,7 +12291,7 @@
           <p:cNvPr id="9" name="">
             <a:extLst xmlns:a="http://schemas.openxmlformats.org/drawingml/2006/main">
               <a:ext uri="{FF2B5EF4-FFF2-40B4-BE49-F238E27FC236}">
-                <a16:creationId xmlns:a16="http://schemas.microsoft.com/office/drawing/2014/main" id="{09EB0FE3-F5C1-48FC-BF6B-3CFEDFFC7400}"/>
+                <a16:creationId xmlns:a16="http://schemas.microsoft.com/office/drawing/2014/main" id="{2D1C7786-C087-44C6-ADDB-6BA638700216}"/>
               </a:ext>
             </a:extLst>
           </p:cNvPr>
@@ -12359,7 +12359,7 @@
           <p:cNvPr id="10" name="">
             <a:extLst xmlns:a="http://schemas.openxmlformats.org/drawingml/2006/main">
               <a:ext uri="{FF2B5EF4-FFF2-40B4-BE49-F238E27FC236}">
-                <a16:creationId xmlns:a16="http://schemas.microsoft.com/office/drawing/2014/main" id="{76008E8A-5F65-49B8-8CA5-D3213E6FD850}"/>
+                <a16:creationId xmlns:a16="http://schemas.microsoft.com/office/drawing/2014/main" id="{8FF18EEA-D1C3-46DC-8F4D-06B81C828F88}"/>
               </a:ext>
             </a:extLst>
           </p:cNvPr>
@@ -12369,7 +12369,7 @@
           <p:nvPr/>
         </p:nvPicPr>
         <p:blipFill>
-          <a:blip xmlns:r="http://schemas.openxmlformats.org/officeDocument/2006/relationships" xmlns:a="http://schemas.openxmlformats.org/drawingml/2006/main" r:embed="Rf22896fa58f74a55"/>
+          <a:blip xmlns:r="http://schemas.openxmlformats.org/officeDocument/2006/relationships" xmlns:a="http://schemas.openxmlformats.org/drawingml/2006/main" r:embed="Rf592b1ba28f3494a"/>
           <a:stretch xmlns:a="http://schemas.openxmlformats.org/drawingml/2006/main"/>
         </p:blipFill>
         <p:spPr>
@@ -12387,7 +12387,7 @@
           <p:cNvPr id="11" name="">
             <a:extLst xmlns:a="http://schemas.openxmlformats.org/drawingml/2006/main">
               <a:ext uri="{FF2B5EF4-FFF2-40B4-BE49-F238E27FC236}">
-                <a16:creationId xmlns:a16="http://schemas.microsoft.com/office/drawing/2014/main" id="{80D37F72-0F4A-40BF-8257-44C93D9475F4}"/>
+                <a16:creationId xmlns:a16="http://schemas.microsoft.com/office/drawing/2014/main" id="{6B0865F0-503C-4064-B4DC-1F7C5364D1AC}"/>
               </a:ext>
             </a:extLst>
           </p:cNvPr>
@@ -12455,7 +12455,7 @@
           <p:cNvPr id="12" name="">
             <a:extLst xmlns:a="http://schemas.openxmlformats.org/drawingml/2006/main">
               <a:ext uri="{FF2B5EF4-FFF2-40B4-BE49-F238E27FC236}">
-                <a16:creationId xmlns:a16="http://schemas.microsoft.com/office/drawing/2014/main" id="{290808D6-AFB7-4EA3-99EF-D20F4C43ED46}"/>
+                <a16:creationId xmlns:a16="http://schemas.microsoft.com/office/drawing/2014/main" id="{4CBA73DC-426B-4CBD-A113-726DD68C8251}"/>
               </a:ext>
             </a:extLst>
           </p:cNvPr>
@@ -12523,7 +12523,7 @@
           <p:cNvPr id="13" name="">
             <a:extLst xmlns:a="http://schemas.openxmlformats.org/drawingml/2006/main">
               <a:ext uri="{FF2B5EF4-FFF2-40B4-BE49-F238E27FC236}">
-                <a16:creationId xmlns:a16="http://schemas.microsoft.com/office/drawing/2014/main" id="{6C1467A6-249D-4567-88F6-F7044FE8E0AA}"/>
+                <a16:creationId xmlns:a16="http://schemas.microsoft.com/office/drawing/2014/main" id="{B04508C3-16CE-496B-B8BF-E7C1DEB0137E}"/>
               </a:ext>
             </a:extLst>
           </p:cNvPr>
@@ -12533,7 +12533,7 @@
           <p:nvPr/>
         </p:nvPicPr>
         <p:blipFill>
-          <a:blip xmlns:r="http://schemas.openxmlformats.org/officeDocument/2006/relationships" xmlns:a="http://schemas.openxmlformats.org/drawingml/2006/main" r:embed="Rb4b0023e6dc64a99"/>
+          <a:blip xmlns:r="http://schemas.openxmlformats.org/officeDocument/2006/relationships" xmlns:a="http://schemas.openxmlformats.org/drawingml/2006/main" r:embed="R36cdc882dd334a48"/>
           <a:stretch xmlns:a="http://schemas.openxmlformats.org/drawingml/2006/main"/>
         </p:blipFill>
         <p:spPr>
@@ -12551,7 +12551,7 @@
           <p:cNvPr id="14" name="">
             <a:extLst xmlns:a="http://schemas.openxmlformats.org/drawingml/2006/main">
               <a:ext uri="{FF2B5EF4-FFF2-40B4-BE49-F238E27FC236}">
-                <a16:creationId xmlns:a16="http://schemas.microsoft.com/office/drawing/2014/main" id="{51121298-21BD-4624-B5D3-CDF24C0E82EC}"/>
+                <a16:creationId xmlns:a16="http://schemas.microsoft.com/office/drawing/2014/main" id="{8C527279-C7A1-477F-85A9-E43AFDC6544B}"/>
               </a:ext>
             </a:extLst>
           </p:cNvPr>
@@ -12619,7 +12619,7 @@
           <p:cNvPr id="15" name="">
             <a:extLst xmlns:a="http://schemas.openxmlformats.org/drawingml/2006/main">
               <a:ext uri="{FF2B5EF4-FFF2-40B4-BE49-F238E27FC236}">
-                <a16:creationId xmlns:a16="http://schemas.microsoft.com/office/drawing/2014/main" id="{FB332A69-E804-4A08-A75A-C0743A22B85B}"/>
+                <a16:creationId xmlns:a16="http://schemas.microsoft.com/office/drawing/2014/main" id="{2BF8D74A-0A7C-4A3D-AF6E-632A08568644}"/>
               </a:ext>
             </a:extLst>
           </p:cNvPr>
@@ -12687,7 +12687,7 @@
           <p:cNvPr id="16" name="">
             <a:extLst xmlns:a="http://schemas.openxmlformats.org/drawingml/2006/main">
               <a:ext uri="{FF2B5EF4-FFF2-40B4-BE49-F238E27FC236}">
-                <a16:creationId xmlns:a16="http://schemas.microsoft.com/office/drawing/2014/main" id="{AB7520E1-14E8-4BCB-A541-DD25C11D8E0B}"/>
+                <a16:creationId xmlns:a16="http://schemas.microsoft.com/office/drawing/2014/main" id="{5F3C6C43-F846-4333-A374-177D8B5BE986}"/>
               </a:ext>
             </a:extLst>
           </p:cNvPr>
@@ -12697,7 +12697,7 @@
           <p:nvPr/>
         </p:nvPicPr>
         <p:blipFill>
-          <a:blip xmlns:r="http://schemas.openxmlformats.org/officeDocument/2006/relationships" xmlns:a="http://schemas.openxmlformats.org/drawingml/2006/main" r:embed="Rb2e3aedcae7f4546"/>
+          <a:blip xmlns:r="http://schemas.openxmlformats.org/officeDocument/2006/relationships" xmlns:a="http://schemas.openxmlformats.org/drawingml/2006/main" r:embed="Rfd8733059ad84c1b"/>
           <a:stretch xmlns:a="http://schemas.openxmlformats.org/drawingml/2006/main"/>
         </p:blipFill>
         <p:spPr>
@@ -12715,7 +12715,7 @@
           <p:cNvPr id="17" name="">
             <a:extLst xmlns:a="http://schemas.openxmlformats.org/drawingml/2006/main">
               <a:ext uri="{FF2B5EF4-FFF2-40B4-BE49-F238E27FC236}">
-                <a16:creationId xmlns:a16="http://schemas.microsoft.com/office/drawing/2014/main" id="{9CE19013-0130-4B43-B09A-F9FDA3F60207}"/>
+                <a16:creationId xmlns:a16="http://schemas.microsoft.com/office/drawing/2014/main" id="{63895974-8864-49C1-BA5D-2DE66F854B52}"/>
               </a:ext>
             </a:extLst>
           </p:cNvPr>
@@ -12783,7 +12783,7 @@
           <p:cNvPr id="18" name="">
             <a:extLst xmlns:a="http://schemas.openxmlformats.org/drawingml/2006/main">
               <a:ext uri="{FF2B5EF4-FFF2-40B4-BE49-F238E27FC236}">
-                <a16:creationId xmlns:a16="http://schemas.microsoft.com/office/drawing/2014/main" id="{AAD06DD6-A394-499E-A137-8ECF0EC4E318}"/>
+                <a16:creationId xmlns:a16="http://schemas.microsoft.com/office/drawing/2014/main" id="{6FBC3C53-E250-4742-91EB-6D646353E2ED}"/>
               </a:ext>
             </a:extLst>
           </p:cNvPr>
@@ -12851,7 +12851,7 @@
           <p:cNvPr id="19" name="">
             <a:extLst xmlns:a="http://schemas.openxmlformats.org/drawingml/2006/main">
               <a:ext uri="{FF2B5EF4-FFF2-40B4-BE49-F238E27FC236}">
-                <a16:creationId xmlns:a16="http://schemas.microsoft.com/office/drawing/2014/main" id="{093285A1-A2F7-40A7-AF7B-DB7484DF3C61}"/>
+                <a16:creationId xmlns:a16="http://schemas.microsoft.com/office/drawing/2014/main" id="{9196629F-91E1-4143-B27B-C09BE34605A1}"/>
               </a:ext>
             </a:extLst>
           </p:cNvPr>
@@ -12919,7 +12919,7 @@
           <p:cNvPr id="20" name="">
             <a:extLst xmlns:a="http://schemas.openxmlformats.org/drawingml/2006/main">
               <a:ext uri="{FF2B5EF4-FFF2-40B4-BE49-F238E27FC236}">
-                <a16:creationId xmlns:a16="http://schemas.microsoft.com/office/drawing/2014/main" id="{4F3FFF12-B5D9-4812-BF1A-F73EFE90BB63}"/>
+                <a16:creationId xmlns:a16="http://schemas.microsoft.com/office/drawing/2014/main" id="{5B2471DF-B99E-46C5-9197-9A9A16627737}"/>
               </a:ext>
             </a:extLst>
           </p:cNvPr>
@@ -12985,7 +12985,7 @@
     </p:spTree>
     <p:extLst>
       <p:ext uri="{BB962C8B-B14F-4D97-AF65-F5344CB8AC3E}">
-        <p14:creationId xmlns:p14="http://schemas.microsoft.com/office/powerpoint/2010/main" val="1386407367"/>
+        <p14:creationId xmlns:p14="http://schemas.microsoft.com/office/powerpoint/2010/main" val="592191550"/>
       </p:ext>
     </p:extLst>
   </p:cSld>
@@ -13016,7 +13016,7 @@
           <p:cNvPr id="13" name="">
             <a:extLst xmlns:a="http://schemas.openxmlformats.org/drawingml/2006/main">
               <a:ext uri="{FF2B5EF4-FFF2-40B4-BE49-F238E27FC236}">
-                <a16:creationId xmlns:a16="http://schemas.microsoft.com/office/drawing/2014/main" id="{B8C4DFE3-3ADB-4A8D-8162-2A9FD466FBCA}"/>
+                <a16:creationId xmlns:a16="http://schemas.microsoft.com/office/drawing/2014/main" id="{8CF9CF6D-1FD6-4C5C-8889-09EB09AB6E6E}"/>
               </a:ext>
             </a:extLst>
           </p:cNvPr>
@@ -13084,7 +13084,7 @@
           <p:cNvPr id="2" name="">
             <a:extLst xmlns:a="http://schemas.openxmlformats.org/drawingml/2006/main">
               <a:ext uri="{FF2B5EF4-FFF2-40B4-BE49-F238E27FC236}">
-                <a16:creationId xmlns:a16="http://schemas.microsoft.com/office/drawing/2014/main" id="{DA37CA92-8C5C-4E97-818E-436F51FAF1AB}"/>
+                <a16:creationId xmlns:a16="http://schemas.microsoft.com/office/drawing/2014/main" id="{1AE13B93-AAA5-4D9B-9ABB-7903573AD486}"/>
               </a:ext>
             </a:extLst>
           </p:cNvPr>
@@ -13152,7 +13152,7 @@
           <p:cNvPr id="3" name="">
             <a:extLst xmlns:a="http://schemas.openxmlformats.org/drawingml/2006/main">
               <a:ext uri="{FF2B5EF4-FFF2-40B4-BE49-F238E27FC236}">
-                <a16:creationId xmlns:a16="http://schemas.microsoft.com/office/drawing/2014/main" id="{12519459-83B8-4FAE-9083-8BB24E4B13CE}"/>
+                <a16:creationId xmlns:a16="http://schemas.microsoft.com/office/drawing/2014/main" id="{E54A854A-0013-4BD0-BEEE-5A8EC2B78D52}"/>
               </a:ext>
             </a:extLst>
           </p:cNvPr>
@@ -13220,7 +13220,7 @@
           <p:cNvPr id="4" name="">
             <a:extLst xmlns:a="http://schemas.openxmlformats.org/drawingml/2006/main">
               <a:ext uri="{FF2B5EF4-FFF2-40B4-BE49-F238E27FC236}">
-                <a16:creationId xmlns:a16="http://schemas.microsoft.com/office/drawing/2014/main" id="{DC4512C2-C329-4197-A5C8-EA75D606306E}"/>
+                <a16:creationId xmlns:a16="http://schemas.microsoft.com/office/drawing/2014/main" id="{D403CD17-2E0D-4953-AB4C-FE8538EB636C}"/>
               </a:ext>
             </a:extLst>
           </p:cNvPr>
@@ -13230,7 +13230,7 @@
           <p:nvPr/>
         </p:nvPicPr>
         <p:blipFill>
-          <a:blip xmlns:r="http://schemas.openxmlformats.org/officeDocument/2006/relationships" xmlns:a="http://schemas.openxmlformats.org/drawingml/2006/main" r:embed="Rbb6b058458824365"/>
+          <a:blip xmlns:r="http://schemas.openxmlformats.org/officeDocument/2006/relationships" xmlns:a="http://schemas.openxmlformats.org/drawingml/2006/main" r:embed="R263b3774c40a48c4"/>
           <a:stretch xmlns:a="http://schemas.openxmlformats.org/drawingml/2006/main"/>
         </p:blipFill>
         <p:spPr>
@@ -13248,7 +13248,7 @@
           <p:cNvPr id="5" name="">
             <a:extLst xmlns:a="http://schemas.openxmlformats.org/drawingml/2006/main">
               <a:ext uri="{FF2B5EF4-FFF2-40B4-BE49-F238E27FC236}">
-                <a16:creationId xmlns:a16="http://schemas.microsoft.com/office/drawing/2014/main" id="{1EA07E8B-34E1-4BD2-AC6E-1684493D3609}"/>
+                <a16:creationId xmlns:a16="http://schemas.microsoft.com/office/drawing/2014/main" id="{956D73E6-5D5C-4707-8158-E0CCC8E06C14}"/>
               </a:ext>
             </a:extLst>
           </p:cNvPr>
@@ -13316,7 +13316,7 @@
           <p:cNvPr id="6" name="">
             <a:extLst xmlns:a="http://schemas.openxmlformats.org/drawingml/2006/main">
               <a:ext uri="{FF2B5EF4-FFF2-40B4-BE49-F238E27FC236}">
-                <a16:creationId xmlns:a16="http://schemas.microsoft.com/office/drawing/2014/main" id="{39B9ADD4-7C27-4677-B915-8C57AC4C86E7}"/>
+                <a16:creationId xmlns:a16="http://schemas.microsoft.com/office/drawing/2014/main" id="{BD05AF53-51F0-4796-A9DD-9C6FE95F18F9}"/>
               </a:ext>
             </a:extLst>
           </p:cNvPr>
@@ -13384,7 +13384,7 @@
           <p:cNvPr id="7" name="">
             <a:extLst xmlns:a="http://schemas.openxmlformats.org/drawingml/2006/main">
               <a:ext uri="{FF2B5EF4-FFF2-40B4-BE49-F238E27FC236}">
-                <a16:creationId xmlns:a16="http://schemas.microsoft.com/office/drawing/2014/main" id="{0193255D-DECE-4E0B-AFAD-DE6FD30FE0CA}"/>
+                <a16:creationId xmlns:a16="http://schemas.microsoft.com/office/drawing/2014/main" id="{43D12CF0-71D0-4CF3-8DE8-1037E69E9E03}"/>
               </a:ext>
             </a:extLst>
           </p:cNvPr>
@@ -13452,7 +13452,7 @@
           <p:cNvPr id="8" name="">
             <a:extLst xmlns:a="http://schemas.openxmlformats.org/drawingml/2006/main">
               <a:ext uri="{FF2B5EF4-FFF2-40B4-BE49-F238E27FC236}">
-                <a16:creationId xmlns:a16="http://schemas.microsoft.com/office/drawing/2014/main" id="{B035C199-2D68-4795-AE38-0D9CB79E22DF}"/>
+                <a16:creationId xmlns:a16="http://schemas.microsoft.com/office/drawing/2014/main" id="{59387683-9E92-4CA3-B232-9F9323EC37D5}"/>
               </a:ext>
             </a:extLst>
           </p:cNvPr>
@@ -13520,7 +13520,7 @@
           <p:cNvPr id="9" name="">
             <a:extLst xmlns:a="http://schemas.openxmlformats.org/drawingml/2006/main">
               <a:ext uri="{FF2B5EF4-FFF2-40B4-BE49-F238E27FC236}">
-                <a16:creationId xmlns:a16="http://schemas.microsoft.com/office/drawing/2014/main" id="{AF32B7D1-1BAF-4657-9741-4ECC532C0817}"/>
+                <a16:creationId xmlns:a16="http://schemas.microsoft.com/office/drawing/2014/main" id="{1FFA4F4C-9FD6-4293-8862-BBD0D0518D11}"/>
               </a:ext>
             </a:extLst>
           </p:cNvPr>
@@ -13588,7 +13588,7 @@
           <p:cNvPr id="10" name="">
             <a:extLst xmlns:a="http://schemas.openxmlformats.org/drawingml/2006/main">
               <a:ext uri="{FF2B5EF4-FFF2-40B4-BE49-F238E27FC236}">
-                <a16:creationId xmlns:a16="http://schemas.microsoft.com/office/drawing/2014/main" id="{9FC44DD9-3669-4798-A3DA-364CB829812A}"/>
+                <a16:creationId xmlns:a16="http://schemas.microsoft.com/office/drawing/2014/main" id="{38047F67-ED3C-4128-A06C-2E47C0B7DB64}"/>
               </a:ext>
             </a:extLst>
           </p:cNvPr>
@@ -13656,7 +13656,7 @@
           <p:cNvPr id="11" name="">
             <a:extLst xmlns:a="http://schemas.openxmlformats.org/drawingml/2006/main">
               <a:ext uri="{FF2B5EF4-FFF2-40B4-BE49-F238E27FC236}">
-                <a16:creationId xmlns:a16="http://schemas.microsoft.com/office/drawing/2014/main" id="{2A76D744-87EF-467E-86A9-86C02B31D173}"/>
+                <a16:creationId xmlns:a16="http://schemas.microsoft.com/office/drawing/2014/main" id="{4605CBEB-EEE4-4052-B2A2-6511AB7A0CF8}"/>
               </a:ext>
             </a:extLst>
           </p:cNvPr>
@@ -13724,7 +13724,7 @@
           <p:cNvPr id="12" name="">
             <a:extLst xmlns:a="http://schemas.openxmlformats.org/drawingml/2006/main">
               <a:ext uri="{FF2B5EF4-FFF2-40B4-BE49-F238E27FC236}">
-                <a16:creationId xmlns:a16="http://schemas.microsoft.com/office/drawing/2014/main" id="{A7107CAC-D330-493E-A47E-7109A04EE190}"/>
+                <a16:creationId xmlns:a16="http://schemas.microsoft.com/office/drawing/2014/main" id="{30776D97-92F5-4893-B830-AE65E045F12A}"/>
               </a:ext>
             </a:extLst>
           </p:cNvPr>
@@ -13790,7 +13790,7 @@
     </p:spTree>
     <p:extLst>
       <p:ext uri="{BB962C8B-B14F-4D97-AF65-F5344CB8AC3E}">
-        <p14:creationId xmlns:p14="http://schemas.microsoft.com/office/powerpoint/2010/main" val="1716916238"/>
+        <p14:creationId xmlns:p14="http://schemas.microsoft.com/office/powerpoint/2010/main" val="887001085"/>
       </p:ext>
     </p:extLst>
   </p:cSld>
@@ -13821,7 +13821,7 @@
           <p:cNvPr id="18" name="">
             <a:extLst xmlns:a="http://schemas.openxmlformats.org/drawingml/2006/main">
               <a:ext uri="{FF2B5EF4-FFF2-40B4-BE49-F238E27FC236}">
-                <a16:creationId xmlns:a16="http://schemas.microsoft.com/office/drawing/2014/main" id="{CE31C409-F33A-497D-A889-9C4823DA9D1B}"/>
+                <a16:creationId xmlns:a16="http://schemas.microsoft.com/office/drawing/2014/main" id="{CD5FB708-DA12-42DE-ACBA-1E1467CFF105}"/>
               </a:ext>
             </a:extLst>
           </p:cNvPr>
@@ -13889,7 +13889,7 @@
           <p:cNvPr id="2" name="">
             <a:extLst xmlns:a="http://schemas.openxmlformats.org/drawingml/2006/main">
               <a:ext uri="{FF2B5EF4-FFF2-40B4-BE49-F238E27FC236}">
-                <a16:creationId xmlns:a16="http://schemas.microsoft.com/office/drawing/2014/main" id="{70A068BA-1AF3-4617-BDF9-A4A73E18E1EF}"/>
+                <a16:creationId xmlns:a16="http://schemas.microsoft.com/office/drawing/2014/main" id="{4CAD59B2-3002-41F7-8BAC-7EBF6B8CBB9E}"/>
               </a:ext>
             </a:extLst>
           </p:cNvPr>
@@ -13957,7 +13957,7 @@
           <p:cNvPr id="3" name="">
             <a:extLst xmlns:a="http://schemas.openxmlformats.org/drawingml/2006/main">
               <a:ext uri="{FF2B5EF4-FFF2-40B4-BE49-F238E27FC236}">
-                <a16:creationId xmlns:a16="http://schemas.microsoft.com/office/drawing/2014/main" id="{8907A14C-B54D-4A11-B31C-F8AF4525C635}"/>
+                <a16:creationId xmlns:a16="http://schemas.microsoft.com/office/drawing/2014/main" id="{6AF8339F-CC0D-4042-8C7B-91015EA126E6}"/>
               </a:ext>
             </a:extLst>
           </p:cNvPr>
@@ -14025,7 +14025,7 @@
           <p:cNvPr id="4" name="">
             <a:extLst xmlns:a="http://schemas.openxmlformats.org/drawingml/2006/main">
               <a:ext uri="{FF2B5EF4-FFF2-40B4-BE49-F238E27FC236}">
-                <a16:creationId xmlns:a16="http://schemas.microsoft.com/office/drawing/2014/main" id="{6698A420-187F-4DD6-93FE-8EB8293FDCA5}"/>
+                <a16:creationId xmlns:a16="http://schemas.microsoft.com/office/drawing/2014/main" id="{77350536-4C17-47A3-B89F-98AF5C4AB222}"/>
               </a:ext>
             </a:extLst>
           </p:cNvPr>
@@ -14093,7 +14093,7 @@
           <p:cNvPr id="5" name="">
             <a:extLst xmlns:a="http://schemas.openxmlformats.org/drawingml/2006/main">
               <a:ext uri="{FF2B5EF4-FFF2-40B4-BE49-F238E27FC236}">
-                <a16:creationId xmlns:a16="http://schemas.microsoft.com/office/drawing/2014/main" id="{BE7D0C30-3961-4143-B6E0-341770D316F6}"/>
+                <a16:creationId xmlns:a16="http://schemas.microsoft.com/office/drawing/2014/main" id="{9A55CCF6-94D0-4685-AE0B-11B2073D81FF}"/>
               </a:ext>
             </a:extLst>
           </p:cNvPr>
@@ -14161,7 +14161,7 @@
           <p:cNvPr id="6" name="">
             <a:extLst xmlns:a="http://schemas.openxmlformats.org/drawingml/2006/main">
               <a:ext uri="{FF2B5EF4-FFF2-40B4-BE49-F238E27FC236}">
-                <a16:creationId xmlns:a16="http://schemas.microsoft.com/office/drawing/2014/main" id="{6EF38C45-0807-4AA1-AC5B-418E6F42D39A}"/>
+                <a16:creationId xmlns:a16="http://schemas.microsoft.com/office/drawing/2014/main" id="{30D1D93D-6831-4311-A1FC-D25C73D809E4}"/>
               </a:ext>
             </a:extLst>
           </p:cNvPr>
@@ -14229,7 +14229,7 @@
           <p:cNvPr id="7" name="">
             <a:extLst xmlns:a="http://schemas.openxmlformats.org/drawingml/2006/main">
               <a:ext uri="{FF2B5EF4-FFF2-40B4-BE49-F238E27FC236}">
-                <a16:creationId xmlns:a16="http://schemas.microsoft.com/office/drawing/2014/main" id="{C3FE3ABB-0CCD-4C5D-8A2A-BA446F927CE1}"/>
+                <a16:creationId xmlns:a16="http://schemas.microsoft.com/office/drawing/2014/main" id="{2F9DA1A0-8D54-4D5F-9AB3-B8A0503C740D}"/>
               </a:ext>
             </a:extLst>
           </p:cNvPr>
@@ -14297,7 +14297,7 @@
           <p:cNvPr id="8" name="">
             <a:extLst xmlns:a="http://schemas.openxmlformats.org/drawingml/2006/main">
               <a:ext uri="{FF2B5EF4-FFF2-40B4-BE49-F238E27FC236}">
-                <a16:creationId xmlns:a16="http://schemas.microsoft.com/office/drawing/2014/main" id="{F5FF3C69-6253-4CFF-867E-E97FEA73FCE9}"/>
+                <a16:creationId xmlns:a16="http://schemas.microsoft.com/office/drawing/2014/main" id="{A5E3B957-22AA-4796-8975-7F843F0277A8}"/>
               </a:ext>
             </a:extLst>
           </p:cNvPr>
@@ -14365,7 +14365,7 @@
           <p:cNvPr id="9" name="">
             <a:extLst xmlns:a="http://schemas.openxmlformats.org/drawingml/2006/main">
               <a:ext uri="{FF2B5EF4-FFF2-40B4-BE49-F238E27FC236}">
-                <a16:creationId xmlns:a16="http://schemas.microsoft.com/office/drawing/2014/main" id="{C150C42A-0B53-4491-9BFD-C15FE2DD8021}"/>
+                <a16:creationId xmlns:a16="http://schemas.microsoft.com/office/drawing/2014/main" id="{511265B3-71AB-4D69-B106-91E8B3F49C00}"/>
               </a:ext>
             </a:extLst>
           </p:cNvPr>
@@ -14433,7 +14433,7 @@
           <p:cNvPr id="10" name="">
             <a:extLst xmlns:a="http://schemas.openxmlformats.org/drawingml/2006/main">
               <a:ext uri="{FF2B5EF4-FFF2-40B4-BE49-F238E27FC236}">
-                <a16:creationId xmlns:a16="http://schemas.microsoft.com/office/drawing/2014/main" id="{2F0F33C8-F61F-4506-A297-421D095F5811}"/>
+                <a16:creationId xmlns:a16="http://schemas.microsoft.com/office/drawing/2014/main" id="{15FC27B1-54E8-4DBF-BE6E-0CF2631C3BF5}"/>
               </a:ext>
             </a:extLst>
           </p:cNvPr>
@@ -14501,7 +14501,7 @@
           <p:cNvPr id="11" name="">
             <a:extLst xmlns:a="http://schemas.openxmlformats.org/drawingml/2006/main">
               <a:ext uri="{FF2B5EF4-FFF2-40B4-BE49-F238E27FC236}">
-                <a16:creationId xmlns:a16="http://schemas.microsoft.com/office/drawing/2014/main" id="{D054A935-8970-43D8-9264-02CAFCD9EB10}"/>
+                <a16:creationId xmlns:a16="http://schemas.microsoft.com/office/drawing/2014/main" id="{5C1FF43D-4603-4A42-9103-EB6904FB0624}"/>
               </a:ext>
             </a:extLst>
           </p:cNvPr>
@@ -14569,7 +14569,7 @@
           <p:cNvPr id="12" name="">
             <a:extLst xmlns:a="http://schemas.openxmlformats.org/drawingml/2006/main">
               <a:ext uri="{FF2B5EF4-FFF2-40B4-BE49-F238E27FC236}">
-                <a16:creationId xmlns:a16="http://schemas.microsoft.com/office/drawing/2014/main" id="{C735208C-F03C-4A9D-8E4E-A701A7D59F5E}"/>
+                <a16:creationId xmlns:a16="http://schemas.microsoft.com/office/drawing/2014/main" id="{09700A96-2F29-4576-8E57-85605C8FB16B}"/>
               </a:ext>
             </a:extLst>
           </p:cNvPr>
@@ -14637,7 +14637,7 @@
           <p:cNvPr id="13" name="">
             <a:extLst xmlns:a="http://schemas.openxmlformats.org/drawingml/2006/main">
               <a:ext uri="{FF2B5EF4-FFF2-40B4-BE49-F238E27FC236}">
-                <a16:creationId xmlns:a16="http://schemas.microsoft.com/office/drawing/2014/main" id="{58F7AB69-CBFB-48C9-B99B-025E3273B99F}"/>
+                <a16:creationId xmlns:a16="http://schemas.microsoft.com/office/drawing/2014/main" id="{EF38C50C-5794-4E34-991D-472C7D4E31DA}"/>
               </a:ext>
             </a:extLst>
           </p:cNvPr>
@@ -14705,7 +14705,7 @@
           <p:cNvPr id="14" name="">
             <a:extLst xmlns:a="http://schemas.openxmlformats.org/drawingml/2006/main">
               <a:ext uri="{FF2B5EF4-FFF2-40B4-BE49-F238E27FC236}">
-                <a16:creationId xmlns:a16="http://schemas.microsoft.com/office/drawing/2014/main" id="{8CA65078-6835-41B4-A3DF-0A5AE3F9CECF}"/>
+                <a16:creationId xmlns:a16="http://schemas.microsoft.com/office/drawing/2014/main" id="{11FA34E3-F273-457D-A9F9-1C2B51BD2193}"/>
               </a:ext>
             </a:extLst>
           </p:cNvPr>
@@ -14773,7 +14773,7 @@
           <p:cNvPr id="15" name="">
             <a:extLst xmlns:a="http://schemas.openxmlformats.org/drawingml/2006/main">
               <a:ext uri="{FF2B5EF4-FFF2-40B4-BE49-F238E27FC236}">
-                <a16:creationId xmlns:a16="http://schemas.microsoft.com/office/drawing/2014/main" id="{56328DB0-5A73-4CD0-BEBF-8F0242B0590F}"/>
+                <a16:creationId xmlns:a16="http://schemas.microsoft.com/office/drawing/2014/main" id="{98F06042-8DF8-4B07-97C7-6F9F8DEA8965}"/>
               </a:ext>
             </a:extLst>
           </p:cNvPr>
@@ -14841,7 +14841,7 @@
           <p:cNvPr id="16" name="">
             <a:extLst xmlns:a="http://schemas.openxmlformats.org/drawingml/2006/main">
               <a:ext uri="{FF2B5EF4-FFF2-40B4-BE49-F238E27FC236}">
-                <a16:creationId xmlns:a16="http://schemas.microsoft.com/office/drawing/2014/main" id="{89109A18-ECC0-4098-A4B0-F713522E40E1}"/>
+                <a16:creationId xmlns:a16="http://schemas.microsoft.com/office/drawing/2014/main" id="{29012A7E-8443-431A-991F-80710937946D}"/>
               </a:ext>
             </a:extLst>
           </p:cNvPr>
@@ -14909,7 +14909,7 @@
           <p:cNvPr id="17" name="">
             <a:extLst xmlns:a="http://schemas.openxmlformats.org/drawingml/2006/main">
               <a:ext uri="{FF2B5EF4-FFF2-40B4-BE49-F238E27FC236}">
-                <a16:creationId xmlns:a16="http://schemas.microsoft.com/office/drawing/2014/main" id="{CF4E4EFE-781F-4EAC-AB92-323A117731B1}"/>
+                <a16:creationId xmlns:a16="http://schemas.microsoft.com/office/drawing/2014/main" id="{577D67E9-5904-4B43-8C2C-A8F34E1E3988}"/>
               </a:ext>
             </a:extLst>
           </p:cNvPr>
@@ -14975,7 +14975,7 @@
     </p:spTree>
     <p:extLst>
       <p:ext uri="{BB962C8B-B14F-4D97-AF65-F5344CB8AC3E}">
-        <p14:creationId xmlns:p14="http://schemas.microsoft.com/office/powerpoint/2010/main" val="149038200"/>
+        <p14:creationId xmlns:p14="http://schemas.microsoft.com/office/powerpoint/2010/main" val="1731175648"/>
       </p:ext>
     </p:extLst>
   </p:cSld>
@@ -15006,7 +15006,7 @@
           <p:cNvPr id="16" name="">
             <a:extLst xmlns:a="http://schemas.openxmlformats.org/drawingml/2006/main">
               <a:ext uri="{FF2B5EF4-FFF2-40B4-BE49-F238E27FC236}">
-                <a16:creationId xmlns:a16="http://schemas.microsoft.com/office/drawing/2014/main" id="{FAA98535-559C-4820-B0CA-8EE515A7AA57}"/>
+                <a16:creationId xmlns:a16="http://schemas.microsoft.com/office/drawing/2014/main" id="{0278F38F-58CA-410E-88CD-95FD54442E2E}"/>
               </a:ext>
             </a:extLst>
           </p:cNvPr>
@@ -15074,7 +15074,7 @@
           <p:cNvPr id="2" name="">
             <a:extLst xmlns:a="http://schemas.openxmlformats.org/drawingml/2006/main">
               <a:ext uri="{FF2B5EF4-FFF2-40B4-BE49-F238E27FC236}">
-                <a16:creationId xmlns:a16="http://schemas.microsoft.com/office/drawing/2014/main" id="{5B755690-305A-48F0-8AC2-FE27D7ADB0C3}"/>
+                <a16:creationId xmlns:a16="http://schemas.microsoft.com/office/drawing/2014/main" id="{00EC0B38-BBD7-4BE7-ABE1-6B7BD0EEC6DF}"/>
               </a:ext>
             </a:extLst>
           </p:cNvPr>
@@ -15142,7 +15142,7 @@
           <p:cNvPr id="3" name="">
             <a:extLst xmlns:a="http://schemas.openxmlformats.org/drawingml/2006/main">
               <a:ext uri="{FF2B5EF4-FFF2-40B4-BE49-F238E27FC236}">
-                <a16:creationId xmlns:a16="http://schemas.microsoft.com/office/drawing/2014/main" id="{EEA5F9EB-166F-49AD-AC06-613AD54A3274}"/>
+                <a16:creationId xmlns:a16="http://schemas.microsoft.com/office/drawing/2014/main" id="{6AA7CB33-2B15-4495-8D18-70DC339CA4CF}"/>
               </a:ext>
             </a:extLst>
           </p:cNvPr>
@@ -15210,7 +15210,7 @@
           <p:cNvPr id="4" name="">
             <a:extLst xmlns:a="http://schemas.openxmlformats.org/drawingml/2006/main">
               <a:ext uri="{FF2B5EF4-FFF2-40B4-BE49-F238E27FC236}">
-                <a16:creationId xmlns:a16="http://schemas.microsoft.com/office/drawing/2014/main" id="{0D13BC7A-4E2A-4981-81AC-06FE9AAB00FF}"/>
+                <a16:creationId xmlns:a16="http://schemas.microsoft.com/office/drawing/2014/main" id="{1B9B2819-499B-4241-AFE3-A1364E1B7B64}"/>
               </a:ext>
             </a:extLst>
           </p:cNvPr>
@@ -15278,7 +15278,7 @@
           <p:cNvPr id="5" name="">
             <a:extLst xmlns:a="http://schemas.openxmlformats.org/drawingml/2006/main">
               <a:ext uri="{FF2B5EF4-FFF2-40B4-BE49-F238E27FC236}">
-                <a16:creationId xmlns:a16="http://schemas.microsoft.com/office/drawing/2014/main" id="{E557A11E-BFF7-4CF2-A69C-1A3EF9D3F57F}"/>
+                <a16:creationId xmlns:a16="http://schemas.microsoft.com/office/drawing/2014/main" id="{85A9A2FA-7484-45F7-8258-8057F3871B0B}"/>
               </a:ext>
             </a:extLst>
           </p:cNvPr>
@@ -15346,7 +15346,7 @@
           <p:cNvPr id="6" name="">
             <a:extLst xmlns:a="http://schemas.openxmlformats.org/drawingml/2006/main">
               <a:ext uri="{FF2B5EF4-FFF2-40B4-BE49-F238E27FC236}">
-                <a16:creationId xmlns:a16="http://schemas.microsoft.com/office/drawing/2014/main" id="{EC20C020-C109-4959-9F4D-4EC91F571B1E}"/>
+                <a16:creationId xmlns:a16="http://schemas.microsoft.com/office/drawing/2014/main" id="{1AEE44D8-43F2-49C6-83AE-52EC70BEEEF9}"/>
               </a:ext>
             </a:extLst>
           </p:cNvPr>
@@ -15414,7 +15414,7 @@
           <p:cNvPr id="7" name="">
             <a:extLst xmlns:a="http://schemas.openxmlformats.org/drawingml/2006/main">
               <a:ext uri="{FF2B5EF4-FFF2-40B4-BE49-F238E27FC236}">
-                <a16:creationId xmlns:a16="http://schemas.microsoft.com/office/drawing/2014/main" id="{04FE5801-705C-4716-B683-1984E6C6EBE3}"/>
+                <a16:creationId xmlns:a16="http://schemas.microsoft.com/office/drawing/2014/main" id="{571C1F4C-FE7B-4D8A-8B05-A454F183E270}"/>
               </a:ext>
             </a:extLst>
           </p:cNvPr>
@@ -15482,7 +15482,7 @@
           <p:cNvPr id="8" name="">
             <a:extLst xmlns:a="http://schemas.openxmlformats.org/drawingml/2006/main">
               <a:ext uri="{FF2B5EF4-FFF2-40B4-BE49-F238E27FC236}">
-                <a16:creationId xmlns:a16="http://schemas.microsoft.com/office/drawing/2014/main" id="{9C15DCE2-23C6-4A32-8D68-A6C55B4AFF30}"/>
+                <a16:creationId xmlns:a16="http://schemas.microsoft.com/office/drawing/2014/main" id="{F4F04FEC-C692-4789-A0BE-90195C66BA27}"/>
               </a:ext>
             </a:extLst>
           </p:cNvPr>
@@ -15550,7 +15550,7 @@
           <p:cNvPr id="9" name="">
             <a:extLst xmlns:a="http://schemas.openxmlformats.org/drawingml/2006/main">
               <a:ext uri="{FF2B5EF4-FFF2-40B4-BE49-F238E27FC236}">
-                <a16:creationId xmlns:a16="http://schemas.microsoft.com/office/drawing/2014/main" id="{86415AAA-E979-4872-81DD-DDEAC0DA8CE2}"/>
+                <a16:creationId xmlns:a16="http://schemas.microsoft.com/office/drawing/2014/main" id="{03C3B214-643F-46B2-9162-732257C34C40}"/>
               </a:ext>
             </a:extLst>
           </p:cNvPr>
@@ -15618,7 +15618,7 @@
           <p:cNvPr id="10" name="">
             <a:extLst xmlns:a="http://schemas.openxmlformats.org/drawingml/2006/main">
               <a:ext uri="{FF2B5EF4-FFF2-40B4-BE49-F238E27FC236}">
-                <a16:creationId xmlns:a16="http://schemas.microsoft.com/office/drawing/2014/main" id="{95B4830D-EB63-41AB-9085-5DF85C70583E}"/>
+                <a16:creationId xmlns:a16="http://schemas.microsoft.com/office/drawing/2014/main" id="{DB3D8A36-0D25-4D69-9A66-7C3093723E46}"/>
               </a:ext>
             </a:extLst>
           </p:cNvPr>
@@ -15686,7 +15686,7 @@
           <p:cNvPr id="11" name="">
             <a:extLst xmlns:a="http://schemas.openxmlformats.org/drawingml/2006/main">
               <a:ext uri="{FF2B5EF4-FFF2-40B4-BE49-F238E27FC236}">
-                <a16:creationId xmlns:a16="http://schemas.microsoft.com/office/drawing/2014/main" id="{D743B7CF-F5F9-4C90-AE77-BA928242BE50}"/>
+                <a16:creationId xmlns:a16="http://schemas.microsoft.com/office/drawing/2014/main" id="{1C6BC059-EBA1-4283-A261-5186BE63F1BE}"/>
               </a:ext>
             </a:extLst>
           </p:cNvPr>
@@ -15754,7 +15754,7 @@
           <p:cNvPr id="12" name="">
             <a:extLst xmlns:a="http://schemas.openxmlformats.org/drawingml/2006/main">
               <a:ext uri="{FF2B5EF4-FFF2-40B4-BE49-F238E27FC236}">
-                <a16:creationId xmlns:a16="http://schemas.microsoft.com/office/drawing/2014/main" id="{E3FFE7B0-ED95-471D-B0EC-07AAC49463DA}"/>
+                <a16:creationId xmlns:a16="http://schemas.microsoft.com/office/drawing/2014/main" id="{CDF702CC-27F2-4FFD-A570-CD323A76E150}"/>
               </a:ext>
             </a:extLst>
           </p:cNvPr>
@@ -15822,7 +15822,7 @@
           <p:cNvPr id="13" name="">
             <a:extLst xmlns:a="http://schemas.openxmlformats.org/drawingml/2006/main">
               <a:ext uri="{FF2B5EF4-FFF2-40B4-BE49-F238E27FC236}">
-                <a16:creationId xmlns:a16="http://schemas.microsoft.com/office/drawing/2014/main" id="{72C1BD15-BFB1-4290-B8DE-C5EDDEC55969}"/>
+                <a16:creationId xmlns:a16="http://schemas.microsoft.com/office/drawing/2014/main" id="{8B33C2AF-8E04-4A52-9076-A788B957DCB6}"/>
               </a:ext>
             </a:extLst>
           </p:cNvPr>
@@ -15890,7 +15890,7 @@
           <p:cNvPr id="14" name="">
             <a:extLst xmlns:a="http://schemas.openxmlformats.org/drawingml/2006/main">
               <a:ext uri="{FF2B5EF4-FFF2-40B4-BE49-F238E27FC236}">
-                <a16:creationId xmlns:a16="http://schemas.microsoft.com/office/drawing/2014/main" id="{22794AAD-AD0D-4E31-AC53-84047AA2BD87}"/>
+                <a16:creationId xmlns:a16="http://schemas.microsoft.com/office/drawing/2014/main" id="{06EB16CA-72DA-48BD-92B2-E1CBC5FAB233}"/>
               </a:ext>
             </a:extLst>
           </p:cNvPr>
@@ -15958,7 +15958,7 @@
           <p:cNvPr id="15" name="">
             <a:extLst xmlns:a="http://schemas.openxmlformats.org/drawingml/2006/main">
               <a:ext uri="{FF2B5EF4-FFF2-40B4-BE49-F238E27FC236}">
-                <a16:creationId xmlns:a16="http://schemas.microsoft.com/office/drawing/2014/main" id="{E25E6979-BFBA-4210-81F4-D7CDDC889A29}"/>
+                <a16:creationId xmlns:a16="http://schemas.microsoft.com/office/drawing/2014/main" id="{ABA581BF-59DE-44C6-9F0B-CC19F56143B6}"/>
               </a:ext>
             </a:extLst>
           </p:cNvPr>
@@ -16024,7 +16024,7 @@
     </p:spTree>
     <p:extLst>
       <p:ext uri="{BB962C8B-B14F-4D97-AF65-F5344CB8AC3E}">
-        <p14:creationId xmlns:p14="http://schemas.microsoft.com/office/powerpoint/2010/main" val="1624747804"/>
+        <p14:creationId xmlns:p14="http://schemas.microsoft.com/office/powerpoint/2010/main" val="1374290691"/>
       </p:ext>
     </p:extLst>
   </p:cSld>
@@ -16055,7 +16055,7 @@
           <p:cNvPr id="18" name="">
             <a:extLst xmlns:a="http://schemas.openxmlformats.org/drawingml/2006/main">
               <a:ext uri="{FF2B5EF4-FFF2-40B4-BE49-F238E27FC236}">
-                <a16:creationId xmlns:a16="http://schemas.microsoft.com/office/drawing/2014/main" id="{DD2F03D8-1C2B-4599-B967-533490CCC396}"/>
+                <a16:creationId xmlns:a16="http://schemas.microsoft.com/office/drawing/2014/main" id="{68415365-8941-4123-90DD-8113BD82E891}"/>
               </a:ext>
             </a:extLst>
           </p:cNvPr>
@@ -16123,7 +16123,7 @@
           <p:cNvPr id="2" name="">
             <a:extLst xmlns:a="http://schemas.openxmlformats.org/drawingml/2006/main">
               <a:ext uri="{FF2B5EF4-FFF2-40B4-BE49-F238E27FC236}">
-                <a16:creationId xmlns:a16="http://schemas.microsoft.com/office/drawing/2014/main" id="{8661D442-7FD1-488E-9B1C-17D3037E341C}"/>
+                <a16:creationId xmlns:a16="http://schemas.microsoft.com/office/drawing/2014/main" id="{96976D4D-1462-4152-8E80-8E4D0A0E270F}"/>
               </a:ext>
             </a:extLst>
           </p:cNvPr>
@@ -16191,7 +16191,7 @@
           <p:cNvPr id="3" name="">
             <a:extLst xmlns:a="http://schemas.openxmlformats.org/drawingml/2006/main">
               <a:ext uri="{FF2B5EF4-FFF2-40B4-BE49-F238E27FC236}">
-                <a16:creationId xmlns:a16="http://schemas.microsoft.com/office/drawing/2014/main" id="{E77E592F-FE02-4119-90FB-2B79EFEC1A80}"/>
+                <a16:creationId xmlns:a16="http://schemas.microsoft.com/office/drawing/2014/main" id="{1FD77688-BC88-4E9C-8077-F3B8700374BD}"/>
               </a:ext>
             </a:extLst>
           </p:cNvPr>
@@ -16259,7 +16259,7 @@
           <p:cNvPr id="4" name="">
             <a:extLst xmlns:a="http://schemas.openxmlformats.org/drawingml/2006/main">
               <a:ext uri="{FF2B5EF4-FFF2-40B4-BE49-F238E27FC236}">
-                <a16:creationId xmlns:a16="http://schemas.microsoft.com/office/drawing/2014/main" id="{D0E7AA50-A6ED-47C8-8B23-04010C9022C5}"/>
+                <a16:creationId xmlns:a16="http://schemas.microsoft.com/office/drawing/2014/main" id="{584A18EF-7370-42DF-9163-69A5FC8C70A4}"/>
               </a:ext>
             </a:extLst>
           </p:cNvPr>
@@ -16289,7 +16289,7 @@
           <p:cNvPr id="5" name="">
             <a:extLst xmlns:a="http://schemas.openxmlformats.org/drawingml/2006/main">
               <a:ext uri="{FF2B5EF4-FFF2-40B4-BE49-F238E27FC236}">
-                <a16:creationId xmlns:a16="http://schemas.microsoft.com/office/drawing/2014/main" id="{7633DC8B-95C7-4FF9-AD71-DBDD5927F79C}"/>
+                <a16:creationId xmlns:a16="http://schemas.microsoft.com/office/drawing/2014/main" id="{D63B32E1-BEE6-4F76-A505-633F1B1C9AD6}"/>
               </a:ext>
             </a:extLst>
           </p:cNvPr>
@@ -16357,7 +16357,7 @@
           <p:cNvPr id="6" name="">
             <a:extLst xmlns:a="http://schemas.openxmlformats.org/drawingml/2006/main">
               <a:ext uri="{FF2B5EF4-FFF2-40B4-BE49-F238E27FC236}">
-                <a16:creationId xmlns:a16="http://schemas.microsoft.com/office/drawing/2014/main" id="{5FF66A60-2317-4DBE-A756-95021A152820}"/>
+                <a16:creationId xmlns:a16="http://schemas.microsoft.com/office/drawing/2014/main" id="{3EC86474-9EE8-4091-9EBD-DD74F2E577CA}"/>
               </a:ext>
             </a:extLst>
           </p:cNvPr>
@@ -16425,7 +16425,7 @@
           <p:cNvPr id="7" name="">
             <a:extLst xmlns:a="http://schemas.openxmlformats.org/drawingml/2006/main">
               <a:ext uri="{FF2B5EF4-FFF2-40B4-BE49-F238E27FC236}">
-                <a16:creationId xmlns:a16="http://schemas.microsoft.com/office/drawing/2014/main" id="{2D41523D-0943-458E-8D0E-212D77E04DB5}"/>
+                <a16:creationId xmlns:a16="http://schemas.microsoft.com/office/drawing/2014/main" id="{49A56091-B6DA-48EE-B70D-B91F20E009E2}"/>
               </a:ext>
             </a:extLst>
           </p:cNvPr>
@@ -16516,7 +16516,7 @@
           <p:cNvPr id="8" name="">
             <a:extLst xmlns:a="http://schemas.openxmlformats.org/drawingml/2006/main">
               <a:ext uri="{FF2B5EF4-FFF2-40B4-BE49-F238E27FC236}">
-                <a16:creationId xmlns:a16="http://schemas.microsoft.com/office/drawing/2014/main" id="{C94EAA17-BFEE-4C24-B726-A2AE9F5DDC0B}"/>
+                <a16:creationId xmlns:a16="http://schemas.microsoft.com/office/drawing/2014/main" id="{9779C4EC-C34B-45F4-82B3-0786E3B865ED}"/>
               </a:ext>
             </a:extLst>
           </p:cNvPr>
@@ -16546,7 +16546,7 @@
           <p:cNvPr id="9" name="">
             <a:extLst xmlns:a="http://schemas.openxmlformats.org/drawingml/2006/main">
               <a:ext uri="{FF2B5EF4-FFF2-40B4-BE49-F238E27FC236}">
-                <a16:creationId xmlns:a16="http://schemas.microsoft.com/office/drawing/2014/main" id="{15A3DC45-C073-468B-8FB8-AA32F75C946F}"/>
+                <a16:creationId xmlns:a16="http://schemas.microsoft.com/office/drawing/2014/main" id="{1757CF9D-8EB6-4B89-9FAF-3DEF2278C74A}"/>
               </a:ext>
             </a:extLst>
           </p:cNvPr>
@@ -16614,7 +16614,7 @@
           <p:cNvPr id="10" name="">
             <a:extLst xmlns:a="http://schemas.openxmlformats.org/drawingml/2006/main">
               <a:ext uri="{FF2B5EF4-FFF2-40B4-BE49-F238E27FC236}">
-                <a16:creationId xmlns:a16="http://schemas.microsoft.com/office/drawing/2014/main" id="{77F583E9-E608-41C4-96E2-AA5035287C0D}"/>
+                <a16:creationId xmlns:a16="http://schemas.microsoft.com/office/drawing/2014/main" id="{EC20379F-7E79-4434-B1A7-9352049E9F05}"/>
               </a:ext>
             </a:extLst>
           </p:cNvPr>
@@ -16682,7 +16682,7 @@
           <p:cNvPr id="11" name="">
             <a:extLst xmlns:a="http://schemas.openxmlformats.org/drawingml/2006/main">
               <a:ext uri="{FF2B5EF4-FFF2-40B4-BE49-F238E27FC236}">
-                <a16:creationId xmlns:a16="http://schemas.microsoft.com/office/drawing/2014/main" id="{6596CAE3-F572-42C7-9898-FEBE30DE1F7E}"/>
+                <a16:creationId xmlns:a16="http://schemas.microsoft.com/office/drawing/2014/main" id="{3D01CE62-92B8-4012-8C28-6D7F45DEF5D4}"/>
               </a:ext>
             </a:extLst>
           </p:cNvPr>
@@ -16773,7 +16773,7 @@
           <p:cNvPr id="12" name="">
             <a:extLst xmlns:a="http://schemas.openxmlformats.org/drawingml/2006/main">
               <a:ext uri="{FF2B5EF4-FFF2-40B4-BE49-F238E27FC236}">
-                <a16:creationId xmlns:a16="http://schemas.microsoft.com/office/drawing/2014/main" id="{F68FDFA6-4B86-43D7-8FDB-65C999AE7BE1}"/>
+                <a16:creationId xmlns:a16="http://schemas.microsoft.com/office/drawing/2014/main" id="{54F3472A-C677-4368-82CA-2E3FFA7B18D1}"/>
               </a:ext>
             </a:extLst>
           </p:cNvPr>
@@ -16803,7 +16803,7 @@
           <p:cNvPr id="13" name="">
             <a:extLst xmlns:a="http://schemas.openxmlformats.org/drawingml/2006/main">
               <a:ext uri="{FF2B5EF4-FFF2-40B4-BE49-F238E27FC236}">
-                <a16:creationId xmlns:a16="http://schemas.microsoft.com/office/drawing/2014/main" id="{897A0FAF-F018-43AC-A889-504A7FBB26A3}"/>
+                <a16:creationId xmlns:a16="http://schemas.microsoft.com/office/drawing/2014/main" id="{CAF7143E-6DAC-471E-93BF-070FA7B209A3}"/>
               </a:ext>
             </a:extLst>
           </p:cNvPr>
@@ -16871,7 +16871,7 @@
           <p:cNvPr id="14" name="">
             <a:extLst xmlns:a="http://schemas.openxmlformats.org/drawingml/2006/main">
               <a:ext uri="{FF2B5EF4-FFF2-40B4-BE49-F238E27FC236}">
-                <a16:creationId xmlns:a16="http://schemas.microsoft.com/office/drawing/2014/main" id="{CD6F7861-903C-4FDD-B5DE-BA80EE513550}"/>
+                <a16:creationId xmlns:a16="http://schemas.microsoft.com/office/drawing/2014/main" id="{D93474AC-E4BE-40D9-90C3-7E977E88DF64}"/>
               </a:ext>
             </a:extLst>
           </p:cNvPr>
@@ -16939,7 +16939,7 @@
           <p:cNvPr id="15" name="">
             <a:extLst xmlns:a="http://schemas.openxmlformats.org/drawingml/2006/main">
               <a:ext uri="{FF2B5EF4-FFF2-40B4-BE49-F238E27FC236}">
-                <a16:creationId xmlns:a16="http://schemas.microsoft.com/office/drawing/2014/main" id="{B0CA38D6-D8E4-4E35-8975-129EA25229B9}"/>
+                <a16:creationId xmlns:a16="http://schemas.microsoft.com/office/drawing/2014/main" id="{01B138A3-1889-43A6-9392-E6497CD4931B}"/>
               </a:ext>
             </a:extLst>
           </p:cNvPr>
@@ -17030,7 +17030,7 @@
           <p:cNvPr id="16" name="">
             <a:extLst xmlns:a="http://schemas.openxmlformats.org/drawingml/2006/main">
               <a:ext uri="{FF2B5EF4-FFF2-40B4-BE49-F238E27FC236}">
-                <a16:creationId xmlns:a16="http://schemas.microsoft.com/office/drawing/2014/main" id="{107408A5-0E7F-4353-B9D2-141E511EEB4D}"/>
+                <a16:creationId xmlns:a16="http://schemas.microsoft.com/office/drawing/2014/main" id="{63C62487-FDE2-4FC2-8FF3-543AD555B0BB}"/>
               </a:ext>
             </a:extLst>
           </p:cNvPr>
@@ -17098,7 +17098,7 @@
           <p:cNvPr id="17" name="">
             <a:extLst xmlns:a="http://schemas.openxmlformats.org/drawingml/2006/main">
               <a:ext uri="{FF2B5EF4-FFF2-40B4-BE49-F238E27FC236}">
-                <a16:creationId xmlns:a16="http://schemas.microsoft.com/office/drawing/2014/main" id="{7C40C667-291C-4D33-BA65-65ED562E7379}"/>
+                <a16:creationId xmlns:a16="http://schemas.microsoft.com/office/drawing/2014/main" id="{1AEFDC44-310A-4E5B-8496-872E627ADD50}"/>
               </a:ext>
             </a:extLst>
           </p:cNvPr>
@@ -17164,7 +17164,7 @@
     </p:spTree>
     <p:extLst>
       <p:ext uri="{BB962C8B-B14F-4D97-AF65-F5344CB8AC3E}">
-        <p14:creationId xmlns:p14="http://schemas.microsoft.com/office/powerpoint/2010/main" val="604819656"/>
+        <p14:creationId xmlns:p14="http://schemas.microsoft.com/office/powerpoint/2010/main" val="972838340"/>
       </p:ext>
     </p:extLst>
   </p:cSld>
@@ -17195,7 +17195,7 @@
           <p:cNvPr id="16" name="">
             <a:extLst xmlns:a="http://schemas.openxmlformats.org/drawingml/2006/main">
               <a:ext uri="{FF2B5EF4-FFF2-40B4-BE49-F238E27FC236}">
-                <a16:creationId xmlns:a16="http://schemas.microsoft.com/office/drawing/2014/main" id="{C32CABAA-731F-4338-AF89-D70113E05D9D}"/>
+                <a16:creationId xmlns:a16="http://schemas.microsoft.com/office/drawing/2014/main" id="{088BEE17-6DE3-477C-B5B7-53359FC7EAB4}"/>
               </a:ext>
             </a:extLst>
           </p:cNvPr>
@@ -17205,7 +17205,7 @@
           <p:nvPr/>
         </p:nvPicPr>
         <p:blipFill>
-          <a:blip xmlns:r="http://schemas.openxmlformats.org/officeDocument/2006/relationships" xmlns:a="http://schemas.openxmlformats.org/drawingml/2006/main" r:embed="R291ca23784da4ef8"/>
+          <a:blip xmlns:r="http://schemas.openxmlformats.org/officeDocument/2006/relationships" xmlns:a="http://schemas.openxmlformats.org/drawingml/2006/main" r:embed="Rd1f9a5389cba4b2a"/>
           <a:srcRect xmlns:a="http://schemas.openxmlformats.org/drawingml/2006/main" l="0" t="0" r="0" b="0"/>
           <a:stretch xmlns:a="http://schemas.openxmlformats.org/drawingml/2006/main">
             <a:fillRect l="0" t="0" r="0" b="0"/>
@@ -17226,7 +17226,7 @@
           <p:cNvPr id="2" name="">
             <a:extLst xmlns:a="http://schemas.openxmlformats.org/drawingml/2006/main">
               <a:ext uri="{FF2B5EF4-FFF2-40B4-BE49-F238E27FC236}">
-                <a16:creationId xmlns:a16="http://schemas.microsoft.com/office/drawing/2014/main" id="{8B95757B-F68E-4350-BE5D-AC9B270A3461}"/>
+                <a16:creationId xmlns:a16="http://schemas.microsoft.com/office/drawing/2014/main" id="{831FA214-EDB8-40F0-89D5-71322487EEE1}"/>
               </a:ext>
             </a:extLst>
           </p:cNvPr>
@@ -17294,7 +17294,7 @@
           <p:cNvPr id="3" name="">
             <a:extLst xmlns:a="http://schemas.openxmlformats.org/drawingml/2006/main">
               <a:ext uri="{FF2B5EF4-FFF2-40B4-BE49-F238E27FC236}">
-                <a16:creationId xmlns:a16="http://schemas.microsoft.com/office/drawing/2014/main" id="{F50A283A-F75F-436E-B226-18596EAB7A5C}"/>
+                <a16:creationId xmlns:a16="http://schemas.microsoft.com/office/drawing/2014/main" id="{B9CE0B46-6544-41E9-9AB4-9BE047EEA85F}"/>
               </a:ext>
             </a:extLst>
           </p:cNvPr>
@@ -17362,7 +17362,7 @@
           <p:cNvPr id="4" name="">
             <a:extLst xmlns:a="http://schemas.openxmlformats.org/drawingml/2006/main">
               <a:ext uri="{FF2B5EF4-FFF2-40B4-BE49-F238E27FC236}">
-                <a16:creationId xmlns:a16="http://schemas.microsoft.com/office/drawing/2014/main" id="{2F5B5DC1-9B49-4B2A-97FE-7FF56F8CE598}"/>
+                <a16:creationId xmlns:a16="http://schemas.microsoft.com/office/drawing/2014/main" id="{0CC689E5-0502-4270-8CAE-26079E425126}"/>
               </a:ext>
             </a:extLst>
           </p:cNvPr>
@@ -17430,7 +17430,7 @@
           <p:cNvPr id="5" name="">
             <a:extLst xmlns:a="http://schemas.openxmlformats.org/drawingml/2006/main">
               <a:ext uri="{FF2B5EF4-FFF2-40B4-BE49-F238E27FC236}">
-                <a16:creationId xmlns:a16="http://schemas.microsoft.com/office/drawing/2014/main" id="{C1656F5E-7667-4B7C-B78B-7DE08DA88041}"/>
+                <a16:creationId xmlns:a16="http://schemas.microsoft.com/office/drawing/2014/main" id="{CB4ACD77-8E9A-45D4-8EBE-7668CA191D25}"/>
               </a:ext>
             </a:extLst>
           </p:cNvPr>
@@ -17498,7 +17498,7 @@
           <p:cNvPr id="6" name="">
             <a:extLst xmlns:a="http://schemas.openxmlformats.org/drawingml/2006/main">
               <a:ext uri="{FF2B5EF4-FFF2-40B4-BE49-F238E27FC236}">
-                <a16:creationId xmlns:a16="http://schemas.microsoft.com/office/drawing/2014/main" id="{CF5A73CC-558E-4D60-9CF0-B8910EB5C0A1}"/>
+                <a16:creationId xmlns:a16="http://schemas.microsoft.com/office/drawing/2014/main" id="{7BE5CEAE-7355-4B64-9892-EB26471D07CD}"/>
               </a:ext>
             </a:extLst>
           </p:cNvPr>
@@ -17566,7 +17566,7 @@
           <p:cNvPr id="7" name="">
             <a:extLst xmlns:a="http://schemas.openxmlformats.org/drawingml/2006/main">
               <a:ext uri="{FF2B5EF4-FFF2-40B4-BE49-F238E27FC236}">
-                <a16:creationId xmlns:a16="http://schemas.microsoft.com/office/drawing/2014/main" id="{F0895904-DF8E-469A-9D44-2F6B10AADE23}"/>
+                <a16:creationId xmlns:a16="http://schemas.microsoft.com/office/drawing/2014/main" id="{EFDB4B3E-4604-49B2-AFA6-5D2693B28B19}"/>
               </a:ext>
             </a:extLst>
           </p:cNvPr>
@@ -17657,7 +17657,7 @@
           <p:cNvPr id="8" name="">
             <a:extLst xmlns:a="http://schemas.openxmlformats.org/drawingml/2006/main">
               <a:ext uri="{FF2B5EF4-FFF2-40B4-BE49-F238E27FC236}">
-                <a16:creationId xmlns:a16="http://schemas.microsoft.com/office/drawing/2014/main" id="{1A5DC3CB-50DA-43EB-941B-E5F26FE8FD94}"/>
+                <a16:creationId xmlns:a16="http://schemas.microsoft.com/office/drawing/2014/main" id="{BF820D81-59CA-49F1-A321-EEC269843C11}"/>
               </a:ext>
             </a:extLst>
           </p:cNvPr>
@@ -17725,7 +17725,7 @@
           <p:cNvPr id="9" name="">
             <a:extLst xmlns:a="http://schemas.openxmlformats.org/drawingml/2006/main">
               <a:ext uri="{FF2B5EF4-FFF2-40B4-BE49-F238E27FC236}">
-                <a16:creationId xmlns:a16="http://schemas.microsoft.com/office/drawing/2014/main" id="{B8A3E8A2-C940-4458-8F80-80F86A6B653A}"/>
+                <a16:creationId xmlns:a16="http://schemas.microsoft.com/office/drawing/2014/main" id="{D09D3B48-8F4B-4966-952F-F0A0BB1AC25B}"/>
               </a:ext>
             </a:extLst>
           </p:cNvPr>
@@ -17793,7 +17793,7 @@
           <p:cNvPr id="10" name="">
             <a:extLst xmlns:a="http://schemas.openxmlformats.org/drawingml/2006/main">
               <a:ext uri="{FF2B5EF4-FFF2-40B4-BE49-F238E27FC236}">
-                <a16:creationId xmlns:a16="http://schemas.microsoft.com/office/drawing/2014/main" id="{AF9F0BF8-8713-42F1-8C16-4F313AD0A6B0}"/>
+                <a16:creationId xmlns:a16="http://schemas.microsoft.com/office/drawing/2014/main" id="{B9E17FAF-F661-4820-AEE5-D7CEDDD72888}"/>
               </a:ext>
             </a:extLst>
           </p:cNvPr>
@@ -17884,7 +17884,7 @@
           <p:cNvPr id="11" name="">
             <a:extLst xmlns:a="http://schemas.openxmlformats.org/drawingml/2006/main">
               <a:ext uri="{FF2B5EF4-FFF2-40B4-BE49-F238E27FC236}">
-                <a16:creationId xmlns:a16="http://schemas.microsoft.com/office/drawing/2014/main" id="{8D4F171E-6F5D-44DD-B295-4C2B55FB16D7}"/>
+                <a16:creationId xmlns:a16="http://schemas.microsoft.com/office/drawing/2014/main" id="{8A35CA05-7EA4-48BB-9645-5C3E6F02B9AF}"/>
               </a:ext>
             </a:extLst>
           </p:cNvPr>
@@ -17952,7 +17952,7 @@
           <p:cNvPr id="12" name="">
             <a:extLst xmlns:a="http://schemas.openxmlformats.org/drawingml/2006/main">
               <a:ext uri="{FF2B5EF4-FFF2-40B4-BE49-F238E27FC236}">
-                <a16:creationId xmlns:a16="http://schemas.microsoft.com/office/drawing/2014/main" id="{074AC0B4-44CF-47C0-BB51-9E4EBF74288F}"/>
+                <a16:creationId xmlns:a16="http://schemas.microsoft.com/office/drawing/2014/main" id="{121D6782-429E-4897-BB23-3CAD029B4F71}"/>
               </a:ext>
             </a:extLst>
           </p:cNvPr>
@@ -18020,7 +18020,7 @@
           <p:cNvPr id="13" name="">
             <a:extLst xmlns:a="http://schemas.openxmlformats.org/drawingml/2006/main">
               <a:ext uri="{FF2B5EF4-FFF2-40B4-BE49-F238E27FC236}">
-                <a16:creationId xmlns:a16="http://schemas.microsoft.com/office/drawing/2014/main" id="{F66CAEF1-CFC2-46FA-9D22-794953E2764E}"/>
+                <a16:creationId xmlns:a16="http://schemas.microsoft.com/office/drawing/2014/main" id="{C18BCD1E-24E1-40B6-910F-D7FF97E63B89}"/>
               </a:ext>
             </a:extLst>
           </p:cNvPr>
@@ -18111,7 +18111,7 @@
           <p:cNvPr id="14" name="">
             <a:extLst xmlns:a="http://schemas.openxmlformats.org/drawingml/2006/main">
               <a:ext uri="{FF2B5EF4-FFF2-40B4-BE49-F238E27FC236}">
-                <a16:creationId xmlns:a16="http://schemas.microsoft.com/office/drawing/2014/main" id="{36B997B9-C39F-47F3-A12A-35A195163441}"/>
+                <a16:creationId xmlns:a16="http://schemas.microsoft.com/office/drawing/2014/main" id="{1C66C689-BDA9-4ABD-9F52-23D87249611A}"/>
               </a:ext>
             </a:extLst>
           </p:cNvPr>
@@ -18179,7 +18179,7 @@
           <p:cNvPr id="15" name="">
             <a:extLst xmlns:a="http://schemas.openxmlformats.org/drawingml/2006/main">
               <a:ext uri="{FF2B5EF4-FFF2-40B4-BE49-F238E27FC236}">
-                <a16:creationId xmlns:a16="http://schemas.microsoft.com/office/drawing/2014/main" id="{EEEE66B7-E532-4C47-BF5C-B44F8CC1A3A7}"/>
+                <a16:creationId xmlns:a16="http://schemas.microsoft.com/office/drawing/2014/main" id="{3804FBEB-097E-4CF6-BC58-B89FB20BA2A0}"/>
               </a:ext>
             </a:extLst>
           </p:cNvPr>
@@ -18245,7 +18245,7 @@
     </p:spTree>
     <p:extLst>
       <p:ext uri="{BB962C8B-B14F-4D97-AF65-F5344CB8AC3E}">
-        <p14:creationId xmlns:p14="http://schemas.microsoft.com/office/powerpoint/2010/main" val="1130954612"/>
+        <p14:creationId xmlns:p14="http://schemas.microsoft.com/office/powerpoint/2010/main" val="106741718"/>
       </p:ext>
     </p:extLst>
   </p:cSld>
@@ -18276,7 +18276,7 @@
           <p:cNvPr id="18" name="">
             <a:extLst xmlns:a="http://schemas.openxmlformats.org/drawingml/2006/main">
               <a:ext uri="{FF2B5EF4-FFF2-40B4-BE49-F238E27FC236}">
-                <a16:creationId xmlns:a16="http://schemas.microsoft.com/office/drawing/2014/main" id="{7CB3948C-AEBC-426B-B3D0-495B36E01B67}"/>
+                <a16:creationId xmlns:a16="http://schemas.microsoft.com/office/drawing/2014/main" id="{6F5A0118-F212-4344-B417-192BA432F693}"/>
               </a:ext>
             </a:extLst>
           </p:cNvPr>
@@ -18344,7 +18344,7 @@
           <p:cNvPr id="2" name="">
             <a:extLst xmlns:a="http://schemas.openxmlformats.org/drawingml/2006/main">
               <a:ext uri="{FF2B5EF4-FFF2-40B4-BE49-F238E27FC236}">
-                <a16:creationId xmlns:a16="http://schemas.microsoft.com/office/drawing/2014/main" id="{EE67819B-EF94-47D8-B137-3DB70D085DE8}"/>
+                <a16:creationId xmlns:a16="http://schemas.microsoft.com/office/drawing/2014/main" id="{103A1E51-1589-49EE-922E-86E95D339DE9}"/>
               </a:ext>
             </a:extLst>
           </p:cNvPr>
@@ -18412,7 +18412,7 @@
           <p:cNvPr id="3" name="">
             <a:extLst xmlns:a="http://schemas.openxmlformats.org/drawingml/2006/main">
               <a:ext uri="{FF2B5EF4-FFF2-40B4-BE49-F238E27FC236}">
-                <a16:creationId xmlns:a16="http://schemas.microsoft.com/office/drawing/2014/main" id="{8937AB61-0274-48DE-B786-0645D35226E6}"/>
+                <a16:creationId xmlns:a16="http://schemas.microsoft.com/office/drawing/2014/main" id="{5D605F3E-AFED-47D2-A594-816AB2E831B1}"/>
               </a:ext>
             </a:extLst>
           </p:cNvPr>
@@ -18480,7 +18480,7 @@
           <p:cNvPr id="4" name="">
             <a:extLst xmlns:a="http://schemas.openxmlformats.org/drawingml/2006/main">
               <a:ext uri="{FF2B5EF4-FFF2-40B4-BE49-F238E27FC236}">
-                <a16:creationId xmlns:a16="http://schemas.microsoft.com/office/drawing/2014/main" id="{6DB3BD8D-2CC6-41EA-AD3F-E41B51D639E1}"/>
+                <a16:creationId xmlns:a16="http://schemas.microsoft.com/office/drawing/2014/main" id="{155AA277-A595-4A2B-BC91-06D987928FD0}"/>
               </a:ext>
             </a:extLst>
           </p:cNvPr>
@@ -18490,7 +18490,7 @@
           <p:nvPr/>
         </p:nvPicPr>
         <p:blipFill>
-          <a:blip xmlns:r="http://schemas.openxmlformats.org/officeDocument/2006/relationships" xmlns:a="http://schemas.openxmlformats.org/drawingml/2006/main" r:embed="R7a2ae0d6763e4831"/>
+          <a:blip xmlns:r="http://schemas.openxmlformats.org/officeDocument/2006/relationships" xmlns:a="http://schemas.openxmlformats.org/drawingml/2006/main" r:embed="Rc4f22244165c4924"/>
           <a:stretch xmlns:a="http://schemas.openxmlformats.org/drawingml/2006/main"/>
         </p:blipFill>
         <p:spPr>
@@ -18508,7 +18508,7 @@
           <p:cNvPr id="5" name="">
             <a:extLst xmlns:a="http://schemas.openxmlformats.org/drawingml/2006/main">
               <a:ext uri="{FF2B5EF4-FFF2-40B4-BE49-F238E27FC236}">
-                <a16:creationId xmlns:a16="http://schemas.microsoft.com/office/drawing/2014/main" id="{91CCC8C3-EC5D-4A74-BFC0-42B31F7F2B83}"/>
+                <a16:creationId xmlns:a16="http://schemas.microsoft.com/office/drawing/2014/main" id="{AE601CC4-1580-48C2-A2AD-7E841B2DB781}"/>
               </a:ext>
             </a:extLst>
           </p:cNvPr>
@@ -18576,7 +18576,7 @@
           <p:cNvPr id="6" name="">
             <a:extLst xmlns:a="http://schemas.openxmlformats.org/drawingml/2006/main">
               <a:ext uri="{FF2B5EF4-FFF2-40B4-BE49-F238E27FC236}">
-                <a16:creationId xmlns:a16="http://schemas.microsoft.com/office/drawing/2014/main" id="{CA6DED1A-476C-44F4-BB9E-B2D0EDD7FB51}"/>
+                <a16:creationId xmlns:a16="http://schemas.microsoft.com/office/drawing/2014/main" id="{FF6F516C-7708-42D3-B17E-D074F8D909E2}"/>
               </a:ext>
             </a:extLst>
           </p:cNvPr>
@@ -18644,7 +18644,7 @@
           <p:cNvPr id="7" name="">
             <a:extLst xmlns:a="http://schemas.openxmlformats.org/drawingml/2006/main">
               <a:ext uri="{FF2B5EF4-FFF2-40B4-BE49-F238E27FC236}">
-                <a16:creationId xmlns:a16="http://schemas.microsoft.com/office/drawing/2014/main" id="{D46F69ED-5B7C-4A91-B305-6A37BEB9D7F7}"/>
+                <a16:creationId xmlns:a16="http://schemas.microsoft.com/office/drawing/2014/main" id="{418439E3-9DF0-4CF2-878A-F24A1EA9A842}"/>
               </a:ext>
             </a:extLst>
           </p:cNvPr>
@@ -18735,7 +18735,7 @@
           <p:cNvPr id="8" name="">
             <a:extLst xmlns:a="http://schemas.openxmlformats.org/drawingml/2006/main">
               <a:ext uri="{FF2B5EF4-FFF2-40B4-BE49-F238E27FC236}">
-                <a16:creationId xmlns:a16="http://schemas.microsoft.com/office/drawing/2014/main" id="{626E7F79-8234-47DD-846C-67D5B635183D}"/>
+                <a16:creationId xmlns:a16="http://schemas.microsoft.com/office/drawing/2014/main" id="{431C962E-69F8-44E0-9653-3832B9A37469}"/>
               </a:ext>
             </a:extLst>
           </p:cNvPr>
@@ -18745,7 +18745,7 @@
           <p:nvPr/>
         </p:nvPicPr>
         <p:blipFill>
-          <a:blip xmlns:r="http://schemas.openxmlformats.org/officeDocument/2006/relationships" xmlns:a="http://schemas.openxmlformats.org/drawingml/2006/main" r:embed="R7c832616e7f94090"/>
+          <a:blip xmlns:r="http://schemas.openxmlformats.org/officeDocument/2006/relationships" xmlns:a="http://schemas.openxmlformats.org/drawingml/2006/main" r:embed="R06514c01d6a04a15"/>
           <a:stretch xmlns:a="http://schemas.openxmlformats.org/drawingml/2006/main"/>
         </p:blipFill>
         <p:spPr>
@@ -18763,7 +18763,7 @@
           <p:cNvPr id="9" name="">
             <a:extLst xmlns:a="http://schemas.openxmlformats.org/drawingml/2006/main">
               <a:ext uri="{FF2B5EF4-FFF2-40B4-BE49-F238E27FC236}">
-                <a16:creationId xmlns:a16="http://schemas.microsoft.com/office/drawing/2014/main" id="{50A4CD4B-DE30-47E6-8DBA-18F9185F5905}"/>
+                <a16:creationId xmlns:a16="http://schemas.microsoft.com/office/drawing/2014/main" id="{6CFB0A99-1A75-47BE-9631-7153C6B2C4BC}"/>
               </a:ext>
             </a:extLst>
           </p:cNvPr>
@@ -18831,7 +18831,7 @@
           <p:cNvPr id="10" name="">
             <a:extLst xmlns:a="http://schemas.openxmlformats.org/drawingml/2006/main">
               <a:ext uri="{FF2B5EF4-FFF2-40B4-BE49-F238E27FC236}">
-                <a16:creationId xmlns:a16="http://schemas.microsoft.com/office/drawing/2014/main" id="{F8907005-C379-4C3D-9249-D5345E409FAD}"/>
+                <a16:creationId xmlns:a16="http://schemas.microsoft.com/office/drawing/2014/main" id="{D5727416-8BC2-4480-999C-465E5086B1F8}"/>
               </a:ext>
             </a:extLst>
           </p:cNvPr>
@@ -18899,7 +18899,7 @@
           <p:cNvPr id="11" name="">
             <a:extLst xmlns:a="http://schemas.openxmlformats.org/drawingml/2006/main">
               <a:ext uri="{FF2B5EF4-FFF2-40B4-BE49-F238E27FC236}">
-                <a16:creationId xmlns:a16="http://schemas.microsoft.com/office/drawing/2014/main" id="{4B2AD18C-6C8D-4B31-9493-2AFFA12D4B36}"/>
+                <a16:creationId xmlns:a16="http://schemas.microsoft.com/office/drawing/2014/main" id="{3821A099-80E7-4AEE-9F70-B51B2B53E47C}"/>
               </a:ext>
             </a:extLst>
           </p:cNvPr>
@@ -18990,7 +18990,7 @@
           <p:cNvPr id="12" name="">
             <a:extLst xmlns:a="http://schemas.openxmlformats.org/drawingml/2006/main">
               <a:ext uri="{FF2B5EF4-FFF2-40B4-BE49-F238E27FC236}">
-                <a16:creationId xmlns:a16="http://schemas.microsoft.com/office/drawing/2014/main" id="{A649BBD7-A647-49FF-8169-65749350CDFC}"/>
+                <a16:creationId xmlns:a16="http://schemas.microsoft.com/office/drawing/2014/main" id="{F6C01310-70C9-42DB-A8BB-22AE1A8B7705}"/>
               </a:ext>
             </a:extLst>
           </p:cNvPr>
@@ -19000,7 +19000,7 @@
           <p:nvPr/>
         </p:nvPicPr>
         <p:blipFill>
-          <a:blip xmlns:r="http://schemas.openxmlformats.org/officeDocument/2006/relationships" xmlns:a="http://schemas.openxmlformats.org/drawingml/2006/main" r:embed="Rc7de65c0327d4d46"/>
+          <a:blip xmlns:r="http://schemas.openxmlformats.org/officeDocument/2006/relationships" xmlns:a="http://schemas.openxmlformats.org/drawingml/2006/main" r:embed="R2fd802abe9604d4c"/>
           <a:stretch xmlns:a="http://schemas.openxmlformats.org/drawingml/2006/main"/>
         </p:blipFill>
         <p:spPr>
@@ -19018,7 +19018,7 @@
           <p:cNvPr id="13" name="">
             <a:extLst xmlns:a="http://schemas.openxmlformats.org/drawingml/2006/main">
               <a:ext uri="{FF2B5EF4-FFF2-40B4-BE49-F238E27FC236}">
-                <a16:creationId xmlns:a16="http://schemas.microsoft.com/office/drawing/2014/main" id="{AABB6F8E-93A0-4714-AE74-A07EB3AE8F4A}"/>
+                <a16:creationId xmlns:a16="http://schemas.microsoft.com/office/drawing/2014/main" id="{329A1A3D-888B-456D-A477-72C0A939CA65}"/>
               </a:ext>
             </a:extLst>
           </p:cNvPr>
@@ -19086,7 +19086,7 @@
           <p:cNvPr id="14" name="">
             <a:extLst xmlns:a="http://schemas.openxmlformats.org/drawingml/2006/main">
               <a:ext uri="{FF2B5EF4-FFF2-40B4-BE49-F238E27FC236}">
-                <a16:creationId xmlns:a16="http://schemas.microsoft.com/office/drawing/2014/main" id="{6BCF1F63-75A1-4AAD-B819-DD827737A889}"/>
+                <a16:creationId xmlns:a16="http://schemas.microsoft.com/office/drawing/2014/main" id="{FF4FDB91-9248-4B10-BF5D-34C04096F17B}"/>
               </a:ext>
             </a:extLst>
           </p:cNvPr>
@@ -19154,7 +19154,7 @@
           <p:cNvPr id="15" name="">
             <a:extLst xmlns:a="http://schemas.openxmlformats.org/drawingml/2006/main">
               <a:ext uri="{FF2B5EF4-FFF2-40B4-BE49-F238E27FC236}">
-                <a16:creationId xmlns:a16="http://schemas.microsoft.com/office/drawing/2014/main" id="{86E1D33A-5599-43B8-9A81-7AEEF3A033FB}"/>
+                <a16:creationId xmlns:a16="http://schemas.microsoft.com/office/drawing/2014/main" id="{BF03EE7D-56CA-4A32-8258-4F2CA9768698}"/>
               </a:ext>
             </a:extLst>
           </p:cNvPr>
@@ -19245,7 +19245,7 @@
           <p:cNvPr id="16" name="">
             <a:extLst xmlns:a="http://schemas.openxmlformats.org/drawingml/2006/main">
               <a:ext uri="{FF2B5EF4-FFF2-40B4-BE49-F238E27FC236}">
-                <a16:creationId xmlns:a16="http://schemas.microsoft.com/office/drawing/2014/main" id="{E6B15358-49D7-4249-9CE2-DB270A402AF3}"/>
+                <a16:creationId xmlns:a16="http://schemas.microsoft.com/office/drawing/2014/main" id="{3F169D11-F447-4E41-B969-995F04638CEA}"/>
               </a:ext>
             </a:extLst>
           </p:cNvPr>
@@ -19313,7 +19313,7 @@
           <p:cNvPr id="17" name="">
             <a:extLst xmlns:a="http://schemas.openxmlformats.org/drawingml/2006/main">
               <a:ext uri="{FF2B5EF4-FFF2-40B4-BE49-F238E27FC236}">
-                <a16:creationId xmlns:a16="http://schemas.microsoft.com/office/drawing/2014/main" id="{D5461185-5E9E-4575-93B1-8EBD4F907C5B}"/>
+                <a16:creationId xmlns:a16="http://schemas.microsoft.com/office/drawing/2014/main" id="{73EEE5BB-02BC-4CC6-BD48-2024B893F64C}"/>
               </a:ext>
             </a:extLst>
           </p:cNvPr>
@@ -19379,7 +19379,7 @@
     </p:spTree>
     <p:extLst>
       <p:ext uri="{BB962C8B-B14F-4D97-AF65-F5344CB8AC3E}">
-        <p14:creationId xmlns:p14="http://schemas.microsoft.com/office/powerpoint/2010/main" val="2119650353"/>
+        <p14:creationId xmlns:p14="http://schemas.microsoft.com/office/powerpoint/2010/main" val="320586329"/>
       </p:ext>
     </p:extLst>
   </p:cSld>
@@ -19410,7 +19410,7 @@
           <p:cNvPr id="12" name="">
             <a:extLst xmlns:a="http://schemas.openxmlformats.org/drawingml/2006/main">
               <a:ext uri="{FF2B5EF4-FFF2-40B4-BE49-F238E27FC236}">
-                <a16:creationId xmlns:a16="http://schemas.microsoft.com/office/drawing/2014/main" id="{0C800C63-C0EA-437E-ABFF-61CC62814064}"/>
+                <a16:creationId xmlns:a16="http://schemas.microsoft.com/office/drawing/2014/main" id="{F3CCA0C8-2FE0-4D05-BD0F-DD97F6DCE696}"/>
               </a:ext>
             </a:extLst>
           </p:cNvPr>
@@ -19478,7 +19478,7 @@
           <p:cNvPr id="2" name="">
             <a:extLst xmlns:a="http://schemas.openxmlformats.org/drawingml/2006/main">
               <a:ext uri="{FF2B5EF4-FFF2-40B4-BE49-F238E27FC236}">
-                <a16:creationId xmlns:a16="http://schemas.microsoft.com/office/drawing/2014/main" id="{149086BA-BB9E-437B-98F0-C2A8BACAF925}"/>
+                <a16:creationId xmlns:a16="http://schemas.microsoft.com/office/drawing/2014/main" id="{4720E2BE-7698-482C-B009-48D9FBDBFD86}"/>
               </a:ext>
             </a:extLst>
           </p:cNvPr>
@@ -19546,7 +19546,7 @@
           <p:cNvPr id="3" name="">
             <a:extLst xmlns:a="http://schemas.openxmlformats.org/drawingml/2006/main">
               <a:ext uri="{FF2B5EF4-FFF2-40B4-BE49-F238E27FC236}">
-                <a16:creationId xmlns:a16="http://schemas.microsoft.com/office/drawing/2014/main" id="{E719AC12-7E52-4ED3-A60D-D761FD5551A9}"/>
+                <a16:creationId xmlns:a16="http://schemas.microsoft.com/office/drawing/2014/main" id="{E0BFD21F-8A67-432A-AE4D-3C11FC4583EC}"/>
               </a:ext>
             </a:extLst>
           </p:cNvPr>
@@ -19614,7 +19614,7 @@
           <p:cNvPr id="4" name="">
             <a:extLst xmlns:a="http://schemas.openxmlformats.org/drawingml/2006/main">
               <a:ext uri="{FF2B5EF4-FFF2-40B4-BE49-F238E27FC236}">
-                <a16:creationId xmlns:a16="http://schemas.microsoft.com/office/drawing/2014/main" id="{383D983F-F36B-4D04-B27F-D135C6EECDF0}"/>
+                <a16:creationId xmlns:a16="http://schemas.microsoft.com/office/drawing/2014/main" id="{D05BB93C-A71A-4D54-8CD6-BCA6FE4F29BD}"/>
               </a:ext>
             </a:extLst>
           </p:cNvPr>
@@ -19624,7 +19624,7 @@
           <p:nvPr/>
         </p:nvPicPr>
         <p:blipFill>
-          <a:blip xmlns:r="http://schemas.openxmlformats.org/officeDocument/2006/relationships" xmlns:a="http://schemas.openxmlformats.org/drawingml/2006/main" r:embed="R5869c6a96f064883"/>
+          <a:blip xmlns:r="http://schemas.openxmlformats.org/officeDocument/2006/relationships" xmlns:a="http://schemas.openxmlformats.org/drawingml/2006/main" r:embed="R65ef9d773cc2487e"/>
           <a:stretch xmlns:a="http://schemas.openxmlformats.org/drawingml/2006/main"/>
         </p:blipFill>
         <p:spPr>
@@ -19642,7 +19642,7 @@
           <p:cNvPr id="5" name="">
             <a:extLst xmlns:a="http://schemas.openxmlformats.org/drawingml/2006/main">
               <a:ext uri="{FF2B5EF4-FFF2-40B4-BE49-F238E27FC236}">
-                <a16:creationId xmlns:a16="http://schemas.microsoft.com/office/drawing/2014/main" id="{755A7322-490D-4159-B1EE-D5B172E51F23}"/>
+                <a16:creationId xmlns:a16="http://schemas.microsoft.com/office/drawing/2014/main" id="{A8F7BAA4-6FD1-44A9-A045-2DFEE036A11A}"/>
               </a:ext>
             </a:extLst>
           </p:cNvPr>
@@ -19710,7 +19710,7 @@
           <p:cNvPr id="6" name="">
             <a:extLst xmlns:a="http://schemas.openxmlformats.org/drawingml/2006/main">
               <a:ext uri="{FF2B5EF4-FFF2-40B4-BE49-F238E27FC236}">
-                <a16:creationId xmlns:a16="http://schemas.microsoft.com/office/drawing/2014/main" id="{F2A92864-1090-4F5A-95F9-A0EEA368439A}"/>
+                <a16:creationId xmlns:a16="http://schemas.microsoft.com/office/drawing/2014/main" id="{EF088088-305E-415F-AD0B-3F7FFB7B895A}"/>
               </a:ext>
             </a:extLst>
           </p:cNvPr>
@@ -19801,7 +19801,7 @@
           <p:cNvPr id="7" name="">
             <a:extLst xmlns:a="http://schemas.openxmlformats.org/drawingml/2006/main">
               <a:ext uri="{FF2B5EF4-FFF2-40B4-BE49-F238E27FC236}">
-                <a16:creationId xmlns:a16="http://schemas.microsoft.com/office/drawing/2014/main" id="{7AC35389-D6C5-4E4B-995C-F9BA474184E4}"/>
+                <a16:creationId xmlns:a16="http://schemas.microsoft.com/office/drawing/2014/main" id="{EEB99A12-2B24-4802-BC66-F59224C57A7B}"/>
               </a:ext>
             </a:extLst>
           </p:cNvPr>
@@ -19811,7 +19811,7 @@
           <p:nvPr/>
         </p:nvPicPr>
         <p:blipFill>
-          <a:blip xmlns:r="http://schemas.openxmlformats.org/officeDocument/2006/relationships" xmlns:a="http://schemas.openxmlformats.org/drawingml/2006/main" r:embed="R37a59d0231a24c7a"/>
+          <a:blip xmlns:r="http://schemas.openxmlformats.org/officeDocument/2006/relationships" xmlns:a="http://schemas.openxmlformats.org/drawingml/2006/main" r:embed="R27944457e5234f04"/>
           <a:stretch xmlns:a="http://schemas.openxmlformats.org/drawingml/2006/main"/>
         </p:blipFill>
         <p:spPr>
@@ -19829,7 +19829,7 @@
           <p:cNvPr id="8" name="">
             <a:extLst xmlns:a="http://schemas.openxmlformats.org/drawingml/2006/main">
               <a:ext uri="{FF2B5EF4-FFF2-40B4-BE49-F238E27FC236}">
-                <a16:creationId xmlns:a16="http://schemas.microsoft.com/office/drawing/2014/main" id="{E3471F72-91B4-4753-9075-A91DE52AAE2C}"/>
+                <a16:creationId xmlns:a16="http://schemas.microsoft.com/office/drawing/2014/main" id="{3ED60305-744C-42A2-A123-AB3FC058AE6C}"/>
               </a:ext>
             </a:extLst>
           </p:cNvPr>
@@ -19897,7 +19897,7 @@
           <p:cNvPr id="9" name="">
             <a:extLst xmlns:a="http://schemas.openxmlformats.org/drawingml/2006/main">
               <a:ext uri="{FF2B5EF4-FFF2-40B4-BE49-F238E27FC236}">
-                <a16:creationId xmlns:a16="http://schemas.microsoft.com/office/drawing/2014/main" id="{A08A85AE-DEE7-4EA1-914F-568C493DA510}"/>
+                <a16:creationId xmlns:a16="http://schemas.microsoft.com/office/drawing/2014/main" id="{B482CB76-79F1-4978-9CFF-5F44A43D335B}"/>
               </a:ext>
             </a:extLst>
           </p:cNvPr>
@@ -19988,7 +19988,7 @@
           <p:cNvPr id="10" name="">
             <a:extLst xmlns:a="http://schemas.openxmlformats.org/drawingml/2006/main">
               <a:ext uri="{FF2B5EF4-FFF2-40B4-BE49-F238E27FC236}">
-                <a16:creationId xmlns:a16="http://schemas.microsoft.com/office/drawing/2014/main" id="{2B2AE13C-57AB-4383-9844-429F9D4AE524}"/>
+                <a16:creationId xmlns:a16="http://schemas.microsoft.com/office/drawing/2014/main" id="{B2C6D096-4932-4AF3-A61F-C7E79698FBB6}"/>
               </a:ext>
             </a:extLst>
           </p:cNvPr>
@@ -20056,7 +20056,7 @@
           <p:cNvPr id="11" name="">
             <a:extLst xmlns:a="http://schemas.openxmlformats.org/drawingml/2006/main">
               <a:ext uri="{FF2B5EF4-FFF2-40B4-BE49-F238E27FC236}">
-                <a16:creationId xmlns:a16="http://schemas.microsoft.com/office/drawing/2014/main" id="{9332BB00-DC77-4363-B739-AD6D8B66B22F}"/>
+                <a16:creationId xmlns:a16="http://schemas.microsoft.com/office/drawing/2014/main" id="{A6E2E5B9-F1DD-49B9-9CAB-B34933E42C95}"/>
               </a:ext>
             </a:extLst>
           </p:cNvPr>
@@ -20122,7 +20122,7 @@
     </p:spTree>
     <p:extLst>
       <p:ext uri="{BB962C8B-B14F-4D97-AF65-F5344CB8AC3E}">
-        <p14:creationId xmlns:p14="http://schemas.microsoft.com/office/powerpoint/2010/main" val="650036022"/>
+        <p14:creationId xmlns:p14="http://schemas.microsoft.com/office/powerpoint/2010/main" val="84301088"/>
       </p:ext>
     </p:extLst>
   </p:cSld>
@@ -20153,7 +20153,7 @@
           <p:cNvPr id="12" name="">
             <a:extLst xmlns:a="http://schemas.openxmlformats.org/drawingml/2006/main">
               <a:ext uri="{FF2B5EF4-FFF2-40B4-BE49-F238E27FC236}">
-                <a16:creationId xmlns:a16="http://schemas.microsoft.com/office/drawing/2014/main" id="{32B69004-AC47-498F-8545-792FF9B22F34}"/>
+                <a16:creationId xmlns:a16="http://schemas.microsoft.com/office/drawing/2014/main" id="{DDFF5B2C-CD5D-4557-9545-DC1ACF4AC267}"/>
               </a:ext>
             </a:extLst>
           </p:cNvPr>
@@ -20163,7 +20163,7 @@
           <p:nvPr/>
         </p:nvPicPr>
         <p:blipFill>
-          <a:blip xmlns:r="http://schemas.openxmlformats.org/officeDocument/2006/relationships" xmlns:a="http://schemas.openxmlformats.org/drawingml/2006/main" r:embed="Rfc0338cfcfa544d1"/>
+          <a:blip xmlns:r="http://schemas.openxmlformats.org/officeDocument/2006/relationships" xmlns:a="http://schemas.openxmlformats.org/drawingml/2006/main" r:embed="Re34b45d1eec44f26"/>
           <a:srcRect xmlns:a="http://schemas.openxmlformats.org/drawingml/2006/main" l="0" t="0" r="0" b="0"/>
           <a:stretch xmlns:a="http://schemas.openxmlformats.org/drawingml/2006/main">
             <a:fillRect l="0" t="0" r="0" b="0"/>
@@ -20184,7 +20184,7 @@
           <p:cNvPr id="2" name="">
             <a:extLst xmlns:a="http://schemas.openxmlformats.org/drawingml/2006/main">
               <a:ext uri="{FF2B5EF4-FFF2-40B4-BE49-F238E27FC236}">
-                <a16:creationId xmlns:a16="http://schemas.microsoft.com/office/drawing/2014/main" id="{A3264D18-BCE7-4E7A-B05D-066DE1FDEC15}"/>
+                <a16:creationId xmlns:a16="http://schemas.microsoft.com/office/drawing/2014/main" id="{DAA57186-FE8E-4BC0-B2AE-337C3D75DF38}"/>
               </a:ext>
             </a:extLst>
           </p:cNvPr>
@@ -20252,7 +20252,7 @@
           <p:cNvPr id="3" name="">
             <a:extLst xmlns:a="http://schemas.openxmlformats.org/drawingml/2006/main">
               <a:ext uri="{FF2B5EF4-FFF2-40B4-BE49-F238E27FC236}">
-                <a16:creationId xmlns:a16="http://schemas.microsoft.com/office/drawing/2014/main" id="{A7919407-6294-4551-B4C8-FE0889479003}"/>
+                <a16:creationId xmlns:a16="http://schemas.microsoft.com/office/drawing/2014/main" id="{5B3B1717-6302-4450-A7E7-C0E6E1ECF801}"/>
               </a:ext>
             </a:extLst>
           </p:cNvPr>
@@ -20320,7 +20320,7 @@
           <p:cNvPr id="4" name="">
             <a:extLst xmlns:a="http://schemas.openxmlformats.org/drawingml/2006/main">
               <a:ext uri="{FF2B5EF4-FFF2-40B4-BE49-F238E27FC236}">
-                <a16:creationId xmlns:a16="http://schemas.microsoft.com/office/drawing/2014/main" id="{14D52B08-D919-4750-870C-3793C33981ED}"/>
+                <a16:creationId xmlns:a16="http://schemas.microsoft.com/office/drawing/2014/main" id="{D6DDE534-C339-4944-9F8A-19D7439B5564}"/>
               </a:ext>
             </a:extLst>
           </p:cNvPr>
@@ -20388,7 +20388,7 @@
           <p:cNvPr id="5" name="">
             <a:extLst xmlns:a="http://schemas.openxmlformats.org/drawingml/2006/main">
               <a:ext uri="{FF2B5EF4-FFF2-40B4-BE49-F238E27FC236}">
-                <a16:creationId xmlns:a16="http://schemas.microsoft.com/office/drawing/2014/main" id="{9B3DEFAD-3C2D-437B-A09F-FDF4081F06D5}"/>
+                <a16:creationId xmlns:a16="http://schemas.microsoft.com/office/drawing/2014/main" id="{5BA72FE1-EFAB-46AC-B531-BC8458BD2188}"/>
               </a:ext>
             </a:extLst>
           </p:cNvPr>
@@ -20398,7 +20398,7 @@
           <p:nvPr/>
         </p:nvPicPr>
         <p:blipFill>
-          <a:blip xmlns:r="http://schemas.openxmlformats.org/officeDocument/2006/relationships" xmlns:a="http://schemas.openxmlformats.org/drawingml/2006/main" r:embed="R553b703cd09642a7"/>
+          <a:blip xmlns:r="http://schemas.openxmlformats.org/officeDocument/2006/relationships" xmlns:a="http://schemas.openxmlformats.org/drawingml/2006/main" r:embed="R3a432491d251435c"/>
           <a:stretch xmlns:a="http://schemas.openxmlformats.org/drawingml/2006/main"/>
         </p:blipFill>
         <p:spPr>
@@ -20416,7 +20416,7 @@
           <p:cNvPr id="6" name="">
             <a:extLst xmlns:a="http://schemas.openxmlformats.org/drawingml/2006/main">
               <a:ext uri="{FF2B5EF4-FFF2-40B4-BE49-F238E27FC236}">
-                <a16:creationId xmlns:a16="http://schemas.microsoft.com/office/drawing/2014/main" id="{208C15E5-BEA6-468D-8401-98C5A4DB11D1}"/>
+                <a16:creationId xmlns:a16="http://schemas.microsoft.com/office/drawing/2014/main" id="{E827DF9D-7025-4A85-B9E7-A1EA0D499C5A}"/>
               </a:ext>
             </a:extLst>
           </p:cNvPr>
@@ -20484,7 +20484,7 @@
           <p:cNvPr id="7" name="">
             <a:extLst xmlns:a="http://schemas.openxmlformats.org/drawingml/2006/main">
               <a:ext uri="{FF2B5EF4-FFF2-40B4-BE49-F238E27FC236}">
-                <a16:creationId xmlns:a16="http://schemas.microsoft.com/office/drawing/2014/main" id="{2CA7AE29-AEB8-4DDE-B339-437BC24A45E2}"/>
+                <a16:creationId xmlns:a16="http://schemas.microsoft.com/office/drawing/2014/main" id="{FA120D7D-B64D-4CD5-9D66-46C3945B256F}"/>
               </a:ext>
             </a:extLst>
           </p:cNvPr>
@@ -20575,7 +20575,7 @@
           <p:cNvPr id="8" name="">
             <a:extLst xmlns:a="http://schemas.openxmlformats.org/drawingml/2006/main">
               <a:ext uri="{FF2B5EF4-FFF2-40B4-BE49-F238E27FC236}">
-                <a16:creationId xmlns:a16="http://schemas.microsoft.com/office/drawing/2014/main" id="{84930C62-3173-4002-9641-B30B29BB4D09}"/>
+                <a16:creationId xmlns:a16="http://schemas.microsoft.com/office/drawing/2014/main" id="{CA36C5D1-E276-4DFC-8798-F83BA63432FB}"/>
               </a:ext>
             </a:extLst>
           </p:cNvPr>
@@ -20585,7 +20585,7 @@
           <p:nvPr/>
         </p:nvPicPr>
         <p:blipFill>
-          <a:blip xmlns:r="http://schemas.openxmlformats.org/officeDocument/2006/relationships" xmlns:a="http://schemas.openxmlformats.org/drawingml/2006/main" r:embed="Rd42f4270d88b45b7"/>
+          <a:blip xmlns:r="http://schemas.openxmlformats.org/officeDocument/2006/relationships" xmlns:a="http://schemas.openxmlformats.org/drawingml/2006/main" r:embed="Rdab5b97a8b6247ad"/>
           <a:stretch xmlns:a="http://schemas.openxmlformats.org/drawingml/2006/main"/>
         </p:blipFill>
         <p:spPr>
@@ -20603,7 +20603,7 @@
           <p:cNvPr id="9" name="">
             <a:extLst xmlns:a="http://schemas.openxmlformats.org/drawingml/2006/main">
               <a:ext uri="{FF2B5EF4-FFF2-40B4-BE49-F238E27FC236}">
-                <a16:creationId xmlns:a16="http://schemas.microsoft.com/office/drawing/2014/main" id="{904A52E3-0E2A-44A8-A442-E5E5516BC089}"/>
+                <a16:creationId xmlns:a16="http://schemas.microsoft.com/office/drawing/2014/main" id="{D06271DF-D439-4524-9DDB-8C63EFDE432A}"/>
               </a:ext>
             </a:extLst>
           </p:cNvPr>
@@ -20671,7 +20671,7 @@
           <p:cNvPr id="10" name="">
             <a:extLst xmlns:a="http://schemas.openxmlformats.org/drawingml/2006/main">
               <a:ext uri="{FF2B5EF4-FFF2-40B4-BE49-F238E27FC236}">
-                <a16:creationId xmlns:a16="http://schemas.microsoft.com/office/drawing/2014/main" id="{0BE92B19-31D5-4A4F-8FA8-0F3737C4CF16}"/>
+                <a16:creationId xmlns:a16="http://schemas.microsoft.com/office/drawing/2014/main" id="{FC7128F6-82CB-4FB9-BE79-1912419BCBD0}"/>
               </a:ext>
             </a:extLst>
           </p:cNvPr>
@@ -20762,7 +20762,7 @@
           <p:cNvPr id="11" name="">
             <a:extLst xmlns:a="http://schemas.openxmlformats.org/drawingml/2006/main">
               <a:ext uri="{FF2B5EF4-FFF2-40B4-BE49-F238E27FC236}">
-                <a16:creationId xmlns:a16="http://schemas.microsoft.com/office/drawing/2014/main" id="{DF860D82-58AF-43E7-A998-CD4D3EC372C3}"/>
+                <a16:creationId xmlns:a16="http://schemas.microsoft.com/office/drawing/2014/main" id="{E96448BC-7BC5-46A6-A283-C06E0DC08CE6}"/>
               </a:ext>
             </a:extLst>
           </p:cNvPr>
@@ -20828,7 +20828,7 @@
     </p:spTree>
     <p:extLst>
       <p:ext uri="{BB962C8B-B14F-4D97-AF65-F5344CB8AC3E}">
-        <p14:creationId xmlns:p14="http://schemas.microsoft.com/office/powerpoint/2010/main" val="1222367453"/>
+        <p14:creationId xmlns:p14="http://schemas.microsoft.com/office/powerpoint/2010/main" val="277048651"/>
       </p:ext>
     </p:extLst>
   </p:cSld>
@@ -20859,7 +20859,7 @@
           <p:cNvPr id="7" name="">
             <a:extLst xmlns:a="http://schemas.openxmlformats.org/drawingml/2006/main">
               <a:ext uri="{FF2B5EF4-FFF2-40B4-BE49-F238E27FC236}">
-                <a16:creationId xmlns:a16="http://schemas.microsoft.com/office/drawing/2014/main" id="{BC0AFCDA-5350-4946-B5F8-30549623335B}"/>
+                <a16:creationId xmlns:a16="http://schemas.microsoft.com/office/drawing/2014/main" id="{E4F5DAF2-B83C-4C4D-B725-CCD85F8AB71E}"/>
               </a:ext>
             </a:extLst>
           </p:cNvPr>
@@ -20869,7 +20869,7 @@
           <p:nvPr/>
         </p:nvPicPr>
         <p:blipFill>
-          <a:blip xmlns:r="http://schemas.openxmlformats.org/officeDocument/2006/relationships" xmlns:a="http://schemas.openxmlformats.org/drawingml/2006/main" r:embed="R8205dde5cb4d4c62"/>
+          <a:blip xmlns:r="http://schemas.openxmlformats.org/officeDocument/2006/relationships" xmlns:a="http://schemas.openxmlformats.org/drawingml/2006/main" r:embed="Rab67d93ec0af43d7"/>
           <a:srcRect xmlns:a="http://schemas.openxmlformats.org/drawingml/2006/main" l="0" t="0" r="0" b="0"/>
           <a:stretch xmlns:a="http://schemas.openxmlformats.org/drawingml/2006/main">
             <a:fillRect l="0" t="0" r="0" b="0"/>
@@ -20890,7 +20890,7 @@
           <p:cNvPr id="2" name="">
             <a:extLst xmlns:a="http://schemas.openxmlformats.org/drawingml/2006/main">
               <a:ext uri="{FF2B5EF4-FFF2-40B4-BE49-F238E27FC236}">
-                <a16:creationId xmlns:a16="http://schemas.microsoft.com/office/drawing/2014/main" id="{4BD35983-DA17-4633-987D-90D517E1049A}"/>
+                <a16:creationId xmlns:a16="http://schemas.microsoft.com/office/drawing/2014/main" id="{6745B183-5879-43C0-B37D-DBC39F1D7A7A}"/>
               </a:ext>
             </a:extLst>
           </p:cNvPr>
@@ -20958,7 +20958,7 @@
           <p:cNvPr id="3" name="">
             <a:extLst xmlns:a="http://schemas.openxmlformats.org/drawingml/2006/main">
               <a:ext uri="{FF2B5EF4-FFF2-40B4-BE49-F238E27FC236}">
-                <a16:creationId xmlns:a16="http://schemas.microsoft.com/office/drawing/2014/main" id="{042CBE94-CB68-4FC0-95A6-B67AF56C56C8}"/>
+                <a16:creationId xmlns:a16="http://schemas.microsoft.com/office/drawing/2014/main" id="{E9093041-6B4D-4C77-A1E0-EF1A2FC9F0B4}"/>
               </a:ext>
             </a:extLst>
           </p:cNvPr>
@@ -21049,7 +21049,7 @@
           <p:cNvPr id="4" name="">
             <a:extLst xmlns:a="http://schemas.openxmlformats.org/drawingml/2006/main">
               <a:ext uri="{FF2B5EF4-FFF2-40B4-BE49-F238E27FC236}">
-                <a16:creationId xmlns:a16="http://schemas.microsoft.com/office/drawing/2014/main" id="{1C7A4CB5-D94D-49E2-A74F-453843637901}"/>
+                <a16:creationId xmlns:a16="http://schemas.microsoft.com/office/drawing/2014/main" id="{5BBD028E-963E-4F21-B239-F8D0B0EFE7E5}"/>
               </a:ext>
             </a:extLst>
           </p:cNvPr>
@@ -21140,7 +21140,7 @@
           <p:cNvPr id="5" name="">
             <a:extLst xmlns:a="http://schemas.openxmlformats.org/drawingml/2006/main">
               <a:ext uri="{FF2B5EF4-FFF2-40B4-BE49-F238E27FC236}">
-                <a16:creationId xmlns:a16="http://schemas.microsoft.com/office/drawing/2014/main" id="{D94C83DE-E357-433D-84B3-8CE12DD2B5A4}"/>
+                <a16:creationId xmlns:a16="http://schemas.microsoft.com/office/drawing/2014/main" id="{D004F636-D40C-421B-BDB9-5C00DC717BD3}"/>
               </a:ext>
             </a:extLst>
           </p:cNvPr>
@@ -21231,7 +21231,7 @@
           <p:cNvPr id="6" name="">
             <a:extLst xmlns:a="http://schemas.openxmlformats.org/drawingml/2006/main">
               <a:ext uri="{FF2B5EF4-FFF2-40B4-BE49-F238E27FC236}">
-                <a16:creationId xmlns:a16="http://schemas.microsoft.com/office/drawing/2014/main" id="{41A1DF56-F35E-4B17-9B1C-0E6268B8EE6A}"/>
+                <a16:creationId xmlns:a16="http://schemas.microsoft.com/office/drawing/2014/main" id="{943E3753-B2C5-493E-BB9F-9CEE7DA98750}"/>
               </a:ext>
             </a:extLst>
           </p:cNvPr>
@@ -21297,7 +21297,7 @@
     </p:spTree>
     <p:extLst>
       <p:ext uri="{BB962C8B-B14F-4D97-AF65-F5344CB8AC3E}">
-        <p14:creationId xmlns:p14="http://schemas.microsoft.com/office/powerpoint/2010/main" val="980696004"/>
+        <p14:creationId xmlns:p14="http://schemas.microsoft.com/office/powerpoint/2010/main" val="2032107229"/>
       </p:ext>
     </p:extLst>
   </p:cSld>
@@ -21328,7 +21328,7 @@
           <p:cNvPr id="12" name="">
             <a:extLst xmlns:a="http://schemas.openxmlformats.org/drawingml/2006/main">
               <a:ext uri="{FF2B5EF4-FFF2-40B4-BE49-F238E27FC236}">
-                <a16:creationId xmlns:a16="http://schemas.microsoft.com/office/drawing/2014/main" id="{4E31FB4C-99E6-41A8-AEF9-2C27E07F00EC}"/>
+                <a16:creationId xmlns:a16="http://schemas.microsoft.com/office/drawing/2014/main" id="{0D7AD33E-5849-44C4-88C2-F3D898E75A49}"/>
               </a:ext>
             </a:extLst>
           </p:cNvPr>
@@ -21338,7 +21338,7 @@
           <p:nvPr/>
         </p:nvPicPr>
         <p:blipFill>
-          <a:blip xmlns:r="http://schemas.openxmlformats.org/officeDocument/2006/relationships" xmlns:a="http://schemas.openxmlformats.org/drawingml/2006/main" r:embed="Rcb7cf4ec89fd4ef6"/>
+          <a:blip xmlns:r="http://schemas.openxmlformats.org/officeDocument/2006/relationships" xmlns:a="http://schemas.openxmlformats.org/drawingml/2006/main" r:embed="R7a45e8f2e0a94ce3"/>
           <a:srcRect xmlns:a="http://schemas.openxmlformats.org/drawingml/2006/main" l="0" t="0" r="0" b="0"/>
           <a:stretch xmlns:a="http://schemas.openxmlformats.org/drawingml/2006/main">
             <a:fillRect l="0" t="0" r="0" b="0"/>
@@ -21359,7 +21359,7 @@
           <p:cNvPr id="2" name="">
             <a:extLst xmlns:a="http://schemas.openxmlformats.org/drawingml/2006/main">
               <a:ext uri="{FF2B5EF4-FFF2-40B4-BE49-F238E27FC236}">
-                <a16:creationId xmlns:a16="http://schemas.microsoft.com/office/drawing/2014/main" id="{60812AF0-AA7C-471C-876A-221243675170}"/>
+                <a16:creationId xmlns:a16="http://schemas.microsoft.com/office/drawing/2014/main" id="{F487AA55-B411-4852-A105-F8E7AB26498A}"/>
               </a:ext>
             </a:extLst>
           </p:cNvPr>
@@ -21427,7 +21427,7 @@
           <p:cNvPr id="3" name="">
             <a:extLst xmlns:a="http://schemas.openxmlformats.org/drawingml/2006/main">
               <a:ext uri="{FF2B5EF4-FFF2-40B4-BE49-F238E27FC236}">
-                <a16:creationId xmlns:a16="http://schemas.microsoft.com/office/drawing/2014/main" id="{59029873-6297-44EC-8F83-7A1D3CEE0BE0}"/>
+                <a16:creationId xmlns:a16="http://schemas.microsoft.com/office/drawing/2014/main" id="{03C6CF9A-23B5-4732-A67C-4864DF781636}"/>
               </a:ext>
             </a:extLst>
           </p:cNvPr>
@@ -21495,7 +21495,7 @@
           <p:cNvPr id="4" name="">
             <a:extLst xmlns:a="http://schemas.openxmlformats.org/drawingml/2006/main">
               <a:ext uri="{FF2B5EF4-FFF2-40B4-BE49-F238E27FC236}">
-                <a16:creationId xmlns:a16="http://schemas.microsoft.com/office/drawing/2014/main" id="{708105F4-499E-463C-9C9D-7928BD0B1C0C}"/>
+                <a16:creationId xmlns:a16="http://schemas.microsoft.com/office/drawing/2014/main" id="{98880631-2ECF-4AF5-9FAD-29BF48F3B29F}"/>
               </a:ext>
             </a:extLst>
           </p:cNvPr>
@@ -21563,7 +21563,7 @@
           <p:cNvPr id="5" name="">
             <a:extLst xmlns:a="http://schemas.openxmlformats.org/drawingml/2006/main">
               <a:ext uri="{FF2B5EF4-FFF2-40B4-BE49-F238E27FC236}">
-                <a16:creationId xmlns:a16="http://schemas.microsoft.com/office/drawing/2014/main" id="{47B4FA1A-3C33-4FCF-887F-C7935AF877F8}"/>
+                <a16:creationId xmlns:a16="http://schemas.microsoft.com/office/drawing/2014/main" id="{A07204D7-315B-4DA2-979F-D2B150609A24}"/>
               </a:ext>
             </a:extLst>
           </p:cNvPr>
@@ -21573,7 +21573,7 @@
           <p:nvPr/>
         </p:nvPicPr>
         <p:blipFill>
-          <a:blip xmlns:r="http://schemas.openxmlformats.org/officeDocument/2006/relationships" xmlns:a="http://schemas.openxmlformats.org/drawingml/2006/main" r:embed="Ra4183f5ecb4447a9"/>
+          <a:blip xmlns:r="http://schemas.openxmlformats.org/officeDocument/2006/relationships" xmlns:a="http://schemas.openxmlformats.org/drawingml/2006/main" r:embed="R7dc8947d29b24168"/>
           <a:stretch xmlns:a="http://schemas.openxmlformats.org/drawingml/2006/main"/>
         </p:blipFill>
         <p:spPr>
@@ -21591,7 +21591,7 @@
           <p:cNvPr id="6" name="">
             <a:extLst xmlns:a="http://schemas.openxmlformats.org/drawingml/2006/main">
               <a:ext uri="{FF2B5EF4-FFF2-40B4-BE49-F238E27FC236}">
-                <a16:creationId xmlns:a16="http://schemas.microsoft.com/office/drawing/2014/main" id="{138871FC-9C4D-428E-9967-6A3250C9308A}"/>
+                <a16:creationId xmlns:a16="http://schemas.microsoft.com/office/drawing/2014/main" id="{D5AF2F5F-D7D8-4044-B3BD-9D8BCC8724DF}"/>
               </a:ext>
             </a:extLst>
           </p:cNvPr>
@@ -21659,7 +21659,7 @@
           <p:cNvPr id="7" name="">
             <a:extLst xmlns:a="http://schemas.openxmlformats.org/drawingml/2006/main">
               <a:ext uri="{FF2B5EF4-FFF2-40B4-BE49-F238E27FC236}">
-                <a16:creationId xmlns:a16="http://schemas.microsoft.com/office/drawing/2014/main" id="{4E35773C-8614-4CE7-9B97-F8D5A74CA31E}"/>
+                <a16:creationId xmlns:a16="http://schemas.microsoft.com/office/drawing/2014/main" id="{AE692E1F-29A8-4C23-9BAE-53601B08D43E}"/>
               </a:ext>
             </a:extLst>
           </p:cNvPr>
@@ -21750,7 +21750,7 @@
           <p:cNvPr id="8" name="">
             <a:extLst xmlns:a="http://schemas.openxmlformats.org/drawingml/2006/main">
               <a:ext uri="{FF2B5EF4-FFF2-40B4-BE49-F238E27FC236}">
-                <a16:creationId xmlns:a16="http://schemas.microsoft.com/office/drawing/2014/main" id="{541886EA-1ACF-4783-B2EC-68D88ECEE905}"/>
+                <a16:creationId xmlns:a16="http://schemas.microsoft.com/office/drawing/2014/main" id="{53E8C83F-CAB1-4D8B-AECF-9296BE45E2EA}"/>
               </a:ext>
             </a:extLst>
           </p:cNvPr>
@@ -21760,7 +21760,7 @@
           <p:nvPr/>
         </p:nvPicPr>
         <p:blipFill>
-          <a:blip xmlns:r="http://schemas.openxmlformats.org/officeDocument/2006/relationships" xmlns:a="http://schemas.openxmlformats.org/drawingml/2006/main" r:embed="R4cef69fefb3c4269"/>
+          <a:blip xmlns:r="http://schemas.openxmlformats.org/officeDocument/2006/relationships" xmlns:a="http://schemas.openxmlformats.org/drawingml/2006/main" r:embed="R9bbba43297354adc"/>
           <a:stretch xmlns:a="http://schemas.openxmlformats.org/drawingml/2006/main"/>
         </p:blipFill>
         <p:spPr>
@@ -21778,7 +21778,7 @@
           <p:cNvPr id="9" name="">
             <a:extLst xmlns:a="http://schemas.openxmlformats.org/drawingml/2006/main">
               <a:ext uri="{FF2B5EF4-FFF2-40B4-BE49-F238E27FC236}">
-                <a16:creationId xmlns:a16="http://schemas.microsoft.com/office/drawing/2014/main" id="{64304EFB-1345-4411-ADA1-2AA6F8F4882C}"/>
+                <a16:creationId xmlns:a16="http://schemas.microsoft.com/office/drawing/2014/main" id="{98FEB22C-C1F1-4ABE-A101-454C11FD7C4B}"/>
               </a:ext>
             </a:extLst>
           </p:cNvPr>
@@ -21846,7 +21846,7 @@
           <p:cNvPr id="10" name="">
             <a:extLst xmlns:a="http://schemas.openxmlformats.org/drawingml/2006/main">
               <a:ext uri="{FF2B5EF4-FFF2-40B4-BE49-F238E27FC236}">
-                <a16:creationId xmlns:a16="http://schemas.microsoft.com/office/drawing/2014/main" id="{81BDA55D-2215-4236-A46A-96046516B81D}"/>
+                <a16:creationId xmlns:a16="http://schemas.microsoft.com/office/drawing/2014/main" id="{9FB1EB72-9116-405A-B830-8A85DBD84EA7}"/>
               </a:ext>
             </a:extLst>
           </p:cNvPr>
@@ -21937,7 +21937,7 @@
           <p:cNvPr id="11" name="">
             <a:extLst xmlns:a="http://schemas.openxmlformats.org/drawingml/2006/main">
               <a:ext uri="{FF2B5EF4-FFF2-40B4-BE49-F238E27FC236}">
-                <a16:creationId xmlns:a16="http://schemas.microsoft.com/office/drawing/2014/main" id="{DEE6E97E-8140-4C53-8078-7F73BA15927A}"/>
+                <a16:creationId xmlns:a16="http://schemas.microsoft.com/office/drawing/2014/main" id="{A552C021-7B9D-4901-9AB0-CE425B7A87DB}"/>
               </a:ext>
             </a:extLst>
           </p:cNvPr>
@@ -22003,7 +22003,7 @@
     </p:spTree>
     <p:extLst>
       <p:ext uri="{BB962C8B-B14F-4D97-AF65-F5344CB8AC3E}">
-        <p14:creationId xmlns:p14="http://schemas.microsoft.com/office/powerpoint/2010/main" val="1155578642"/>
+        <p14:creationId xmlns:p14="http://schemas.microsoft.com/office/powerpoint/2010/main" val="683053605"/>
       </p:ext>
     </p:extLst>
   </p:cSld>
@@ -22034,7 +22034,7 @@
           <p:cNvPr id="15" name="">
             <a:extLst xmlns:a="http://schemas.openxmlformats.org/drawingml/2006/main">
               <a:ext uri="{FF2B5EF4-FFF2-40B4-BE49-F238E27FC236}">
-                <a16:creationId xmlns:a16="http://schemas.microsoft.com/office/drawing/2014/main" id="{75F1C045-B182-402D-A1C8-30050B9EEF40}"/>
+                <a16:creationId xmlns:a16="http://schemas.microsoft.com/office/drawing/2014/main" id="{059199B5-54FD-43C2-81B3-E5CB915FC794}"/>
               </a:ext>
             </a:extLst>
           </p:cNvPr>
@@ -22044,7 +22044,7 @@
           <p:nvPr/>
         </p:nvPicPr>
         <p:blipFill>
-          <a:blip xmlns:r="http://schemas.openxmlformats.org/officeDocument/2006/relationships" xmlns:a="http://schemas.openxmlformats.org/drawingml/2006/main" r:embed="R5a49fc969b4d4480"/>
+          <a:blip xmlns:r="http://schemas.openxmlformats.org/officeDocument/2006/relationships" xmlns:a="http://schemas.openxmlformats.org/drawingml/2006/main" r:embed="R202a3278b2b7426f"/>
           <a:srcRect xmlns:a="http://schemas.openxmlformats.org/drawingml/2006/main" l="0" t="0" r="0" b="0"/>
           <a:stretch xmlns:a="http://schemas.openxmlformats.org/drawingml/2006/main">
             <a:fillRect l="0" t="0" r="0" b="0"/>
@@ -22065,7 +22065,7 @@
           <p:cNvPr id="2" name="">
             <a:extLst xmlns:a="http://schemas.openxmlformats.org/drawingml/2006/main">
               <a:ext uri="{FF2B5EF4-FFF2-40B4-BE49-F238E27FC236}">
-                <a16:creationId xmlns:a16="http://schemas.microsoft.com/office/drawing/2014/main" id="{F5018A5B-FE3D-487E-B63B-20CE99E771D3}"/>
+                <a16:creationId xmlns:a16="http://schemas.microsoft.com/office/drawing/2014/main" id="{3D174D38-0FB7-4A8B-B311-71C56903E8F0}"/>
               </a:ext>
             </a:extLst>
           </p:cNvPr>
@@ -22133,7 +22133,7 @@
           <p:cNvPr id="3" name="">
             <a:extLst xmlns:a="http://schemas.openxmlformats.org/drawingml/2006/main">
               <a:ext uri="{FF2B5EF4-FFF2-40B4-BE49-F238E27FC236}">
-                <a16:creationId xmlns:a16="http://schemas.microsoft.com/office/drawing/2014/main" id="{580E9A7D-6EB8-4509-BAF9-44ACCD97C920}"/>
+                <a16:creationId xmlns:a16="http://schemas.microsoft.com/office/drawing/2014/main" id="{C159F36D-4E50-435C-921A-259E52F1E836}"/>
               </a:ext>
             </a:extLst>
           </p:cNvPr>
@@ -22201,7 +22201,7 @@
           <p:cNvPr id="4" name="">
             <a:extLst xmlns:a="http://schemas.openxmlformats.org/drawingml/2006/main">
               <a:ext uri="{FF2B5EF4-FFF2-40B4-BE49-F238E27FC236}">
-                <a16:creationId xmlns:a16="http://schemas.microsoft.com/office/drawing/2014/main" id="{0774EFBD-F793-4ACE-A681-B3CC50BB207C}"/>
+                <a16:creationId xmlns:a16="http://schemas.microsoft.com/office/drawing/2014/main" id="{360443AB-A3EA-45FD-B9D6-CA7515BDBB39}"/>
               </a:ext>
             </a:extLst>
           </p:cNvPr>
@@ -22269,7 +22269,7 @@
           <p:cNvPr id="5" name="">
             <a:extLst xmlns:a="http://schemas.openxmlformats.org/drawingml/2006/main">
               <a:ext uri="{FF2B5EF4-FFF2-40B4-BE49-F238E27FC236}">
-                <a16:creationId xmlns:a16="http://schemas.microsoft.com/office/drawing/2014/main" id="{F1581F3E-F0F5-4E27-A9B0-55ACFF89D2DD}"/>
+                <a16:creationId xmlns:a16="http://schemas.microsoft.com/office/drawing/2014/main" id="{919911C6-A743-43B8-B38E-9C1269F91D3A}"/>
               </a:ext>
             </a:extLst>
           </p:cNvPr>
@@ -22337,7 +22337,7 @@
           <p:cNvPr id="6" name="">
             <a:extLst xmlns:a="http://schemas.openxmlformats.org/drawingml/2006/main">
               <a:ext uri="{FF2B5EF4-FFF2-40B4-BE49-F238E27FC236}">
-                <a16:creationId xmlns:a16="http://schemas.microsoft.com/office/drawing/2014/main" id="{9753FD54-4882-473F-8AB0-EB0A77A37675}"/>
+                <a16:creationId xmlns:a16="http://schemas.microsoft.com/office/drawing/2014/main" id="{BF625452-963F-4346-93AB-B8632EE66CE4}"/>
               </a:ext>
             </a:extLst>
           </p:cNvPr>
@@ -22405,7 +22405,7 @@
           <p:cNvPr id="7" name="">
             <a:extLst xmlns:a="http://schemas.openxmlformats.org/drawingml/2006/main">
               <a:ext uri="{FF2B5EF4-FFF2-40B4-BE49-F238E27FC236}">
-                <a16:creationId xmlns:a16="http://schemas.microsoft.com/office/drawing/2014/main" id="{639A6F26-9B33-46CB-AAB8-BF4F57EF747F}"/>
+                <a16:creationId xmlns:a16="http://schemas.microsoft.com/office/drawing/2014/main" id="{F0A3B94D-9F8E-464A-B63B-DF44AB83B8ED}"/>
               </a:ext>
             </a:extLst>
           </p:cNvPr>
@@ -22473,7 +22473,7 @@
           <p:cNvPr id="8" name="">
             <a:extLst xmlns:a="http://schemas.openxmlformats.org/drawingml/2006/main">
               <a:ext uri="{FF2B5EF4-FFF2-40B4-BE49-F238E27FC236}">
-                <a16:creationId xmlns:a16="http://schemas.microsoft.com/office/drawing/2014/main" id="{BA6477CE-F4FF-4FF2-AB48-5435F5905716}"/>
+                <a16:creationId xmlns:a16="http://schemas.microsoft.com/office/drawing/2014/main" id="{BF32CD8B-124C-4F9A-8730-74CF26D9DD31}"/>
               </a:ext>
             </a:extLst>
           </p:cNvPr>
@@ -22541,7 +22541,7 @@
           <p:cNvPr id="9" name="">
             <a:extLst xmlns:a="http://schemas.openxmlformats.org/drawingml/2006/main">
               <a:ext uri="{FF2B5EF4-FFF2-40B4-BE49-F238E27FC236}">
-                <a16:creationId xmlns:a16="http://schemas.microsoft.com/office/drawing/2014/main" id="{F8624D52-1681-43E7-9270-CB3BE7E9BD4D}"/>
+                <a16:creationId xmlns:a16="http://schemas.microsoft.com/office/drawing/2014/main" id="{14C89A2F-7414-42A3-BD04-9908D94C44F6}"/>
               </a:ext>
             </a:extLst>
           </p:cNvPr>
@@ -22609,7 +22609,7 @@
           <p:cNvPr id="10" name="">
             <a:extLst xmlns:a="http://schemas.openxmlformats.org/drawingml/2006/main">
               <a:ext uri="{FF2B5EF4-FFF2-40B4-BE49-F238E27FC236}">
-                <a16:creationId xmlns:a16="http://schemas.microsoft.com/office/drawing/2014/main" id="{6672591C-C5A9-4FF6-931F-79F64BA3713F}"/>
+                <a16:creationId xmlns:a16="http://schemas.microsoft.com/office/drawing/2014/main" id="{A101C52B-916F-4535-AFB0-67531F550FF6}"/>
               </a:ext>
             </a:extLst>
           </p:cNvPr>
@@ -22700,7 +22700,7 @@
           <p:cNvPr id="11" name="">
             <a:extLst xmlns:a="http://schemas.openxmlformats.org/drawingml/2006/main">
               <a:ext uri="{FF2B5EF4-FFF2-40B4-BE49-F238E27FC236}">
-                <a16:creationId xmlns:a16="http://schemas.microsoft.com/office/drawing/2014/main" id="{009DA7D9-0D7B-485A-8A86-E9B5D837EC63}"/>
+                <a16:creationId xmlns:a16="http://schemas.microsoft.com/office/drawing/2014/main" id="{5971B9A9-6EE3-4571-AB32-79288D864BEC}"/>
               </a:ext>
             </a:extLst>
           </p:cNvPr>
@@ -22768,7 +22768,7 @@
           <p:cNvPr id="12" name="">
             <a:extLst xmlns:a="http://schemas.openxmlformats.org/drawingml/2006/main">
               <a:ext uri="{FF2B5EF4-FFF2-40B4-BE49-F238E27FC236}">
-                <a16:creationId xmlns:a16="http://schemas.microsoft.com/office/drawing/2014/main" id="{4992F592-DCEA-4CDA-8DC4-7261F55FBC0C}"/>
+                <a16:creationId xmlns:a16="http://schemas.microsoft.com/office/drawing/2014/main" id="{0254CC70-E21D-4B8F-9213-D1DF8F46EFC7}"/>
               </a:ext>
             </a:extLst>
           </p:cNvPr>
@@ -22836,7 +22836,7 @@
           <p:cNvPr id="13" name="">
             <a:extLst xmlns:a="http://schemas.openxmlformats.org/drawingml/2006/main">
               <a:ext uri="{FF2B5EF4-FFF2-40B4-BE49-F238E27FC236}">
-                <a16:creationId xmlns:a16="http://schemas.microsoft.com/office/drawing/2014/main" id="{5B2FAE38-6414-4162-8B45-375ED9643AA3}"/>
+                <a16:creationId xmlns:a16="http://schemas.microsoft.com/office/drawing/2014/main" id="{DEFE0EA1-D050-4ED5-B9F0-99B8BBD77F49}"/>
               </a:ext>
             </a:extLst>
           </p:cNvPr>
@@ -22927,7 +22927,7 @@
           <p:cNvPr id="14" name="">
             <a:extLst xmlns:a="http://schemas.openxmlformats.org/drawingml/2006/main">
               <a:ext uri="{FF2B5EF4-FFF2-40B4-BE49-F238E27FC236}">
-                <a16:creationId xmlns:a16="http://schemas.microsoft.com/office/drawing/2014/main" id="{D1F1E431-A7A8-4378-A2BB-F6103336FCCF}"/>
+                <a16:creationId xmlns:a16="http://schemas.microsoft.com/office/drawing/2014/main" id="{6FCEE00E-2086-49B7-9CBF-19FEAFDF7BD6}"/>
               </a:ext>
             </a:extLst>
           </p:cNvPr>
@@ -22993,7 +22993,7 @@
     </p:spTree>
     <p:extLst>
       <p:ext uri="{BB962C8B-B14F-4D97-AF65-F5344CB8AC3E}">
-        <p14:creationId xmlns:p14="http://schemas.microsoft.com/office/powerpoint/2010/main" val="172881932"/>
+        <p14:creationId xmlns:p14="http://schemas.microsoft.com/office/powerpoint/2010/main" val="1549668552"/>
       </p:ext>
     </p:extLst>
   </p:cSld>
@@ -23024,7 +23024,7 @@
           <p:cNvPr id="17" name="">
             <a:extLst xmlns:a="http://schemas.openxmlformats.org/drawingml/2006/main">
               <a:ext uri="{FF2B5EF4-FFF2-40B4-BE49-F238E27FC236}">
-                <a16:creationId xmlns:a16="http://schemas.microsoft.com/office/drawing/2014/main" id="{B45C8CE7-52F5-480F-AB87-3160C01AAB27}"/>
+                <a16:creationId xmlns:a16="http://schemas.microsoft.com/office/drawing/2014/main" id="{1B908624-DB77-4BC3-884A-870F8AEC0449}"/>
               </a:ext>
             </a:extLst>
           </p:cNvPr>
@@ -23092,7 +23092,7 @@
           <p:cNvPr id="2" name="">
             <a:extLst xmlns:a="http://schemas.openxmlformats.org/drawingml/2006/main">
               <a:ext uri="{FF2B5EF4-FFF2-40B4-BE49-F238E27FC236}">
-                <a16:creationId xmlns:a16="http://schemas.microsoft.com/office/drawing/2014/main" id="{B8A37078-2B9B-4132-ABFB-F845185B6F49}"/>
+                <a16:creationId xmlns:a16="http://schemas.microsoft.com/office/drawing/2014/main" id="{580A174C-88A2-439D-8AEB-B8CE6E538013}"/>
               </a:ext>
             </a:extLst>
           </p:cNvPr>
@@ -23160,7 +23160,7 @@
           <p:cNvPr id="3" name="">
             <a:extLst xmlns:a="http://schemas.openxmlformats.org/drawingml/2006/main">
               <a:ext uri="{FF2B5EF4-FFF2-40B4-BE49-F238E27FC236}">
-                <a16:creationId xmlns:a16="http://schemas.microsoft.com/office/drawing/2014/main" id="{DBD9F75F-D207-4742-B292-957C787C2948}"/>
+                <a16:creationId xmlns:a16="http://schemas.microsoft.com/office/drawing/2014/main" id="{0DE538EA-BD67-4A5E-B553-889F67E022AA}"/>
               </a:ext>
             </a:extLst>
           </p:cNvPr>
@@ -23228,7 +23228,7 @@
           <p:cNvPr id="4" name="">
             <a:extLst xmlns:a="http://schemas.openxmlformats.org/drawingml/2006/main">
               <a:ext uri="{FF2B5EF4-FFF2-40B4-BE49-F238E27FC236}">
-                <a16:creationId xmlns:a16="http://schemas.microsoft.com/office/drawing/2014/main" id="{8B59B69F-F8C6-4E0A-B4EB-AA331F22D802}"/>
+                <a16:creationId xmlns:a16="http://schemas.microsoft.com/office/drawing/2014/main" id="{517D5881-EE66-453D-9C75-5559C079A7B9}"/>
               </a:ext>
             </a:extLst>
           </p:cNvPr>
@@ -23238,7 +23238,7 @@
           <p:nvPr/>
         </p:nvPicPr>
         <p:blipFill>
-          <a:blip xmlns:r="http://schemas.openxmlformats.org/officeDocument/2006/relationships" xmlns:a="http://schemas.openxmlformats.org/drawingml/2006/main" r:embed="R729f814bdffb489b"/>
+          <a:blip xmlns:r="http://schemas.openxmlformats.org/officeDocument/2006/relationships" xmlns:a="http://schemas.openxmlformats.org/drawingml/2006/main" r:embed="R45b1ebc28cd3416a"/>
           <a:stretch xmlns:a="http://schemas.openxmlformats.org/drawingml/2006/main"/>
         </p:blipFill>
         <p:spPr>
@@ -23256,7 +23256,7 @@
           <p:cNvPr id="5" name="">
             <a:extLst xmlns:a="http://schemas.openxmlformats.org/drawingml/2006/main">
               <a:ext uri="{FF2B5EF4-FFF2-40B4-BE49-F238E27FC236}">
-                <a16:creationId xmlns:a16="http://schemas.microsoft.com/office/drawing/2014/main" id="{8BD26322-D2EC-44E2-B3EC-AF8376A98ECE}"/>
+                <a16:creationId xmlns:a16="http://schemas.microsoft.com/office/drawing/2014/main" id="{9AF24884-A02B-4ACC-9059-1841928ED25E}"/>
               </a:ext>
             </a:extLst>
           </p:cNvPr>
@@ -23324,7 +23324,7 @@
           <p:cNvPr id="6" name="">
             <a:extLst xmlns:a="http://schemas.openxmlformats.org/drawingml/2006/main">
               <a:ext uri="{FF2B5EF4-FFF2-40B4-BE49-F238E27FC236}">
-                <a16:creationId xmlns:a16="http://schemas.microsoft.com/office/drawing/2014/main" id="{D7E9BF9F-530D-4048-A37B-834A015CC039}"/>
+                <a16:creationId xmlns:a16="http://schemas.microsoft.com/office/drawing/2014/main" id="{6BF3F627-E10D-4B3D-A975-0F91292C838E}"/>
               </a:ext>
             </a:extLst>
           </p:cNvPr>
@@ -23392,7 +23392,7 @@
           <p:cNvPr id="7" name="">
             <a:extLst xmlns:a="http://schemas.openxmlformats.org/drawingml/2006/main">
               <a:ext uri="{FF2B5EF4-FFF2-40B4-BE49-F238E27FC236}">
-                <a16:creationId xmlns:a16="http://schemas.microsoft.com/office/drawing/2014/main" id="{F1E8BB2B-ADCC-42D0-A651-E764CEB873D8}"/>
+                <a16:creationId xmlns:a16="http://schemas.microsoft.com/office/drawing/2014/main" id="{4A825E4A-F92E-49CB-9907-C64DE8B7906A}"/>
               </a:ext>
             </a:extLst>
           </p:cNvPr>
@@ -23402,7 +23402,7 @@
           <p:nvPr/>
         </p:nvPicPr>
         <p:blipFill>
-          <a:blip xmlns:r="http://schemas.openxmlformats.org/officeDocument/2006/relationships" xmlns:a="http://schemas.openxmlformats.org/drawingml/2006/main" r:embed="Re106740960c3433f"/>
+          <a:blip xmlns:r="http://schemas.openxmlformats.org/officeDocument/2006/relationships" xmlns:a="http://schemas.openxmlformats.org/drawingml/2006/main" r:embed="R4cf2a28ba3b743a2"/>
           <a:stretch xmlns:a="http://schemas.openxmlformats.org/drawingml/2006/main"/>
         </p:blipFill>
         <p:spPr>
@@ -23420,7 +23420,7 @@
           <p:cNvPr id="8" name="">
             <a:extLst xmlns:a="http://schemas.openxmlformats.org/drawingml/2006/main">
               <a:ext uri="{FF2B5EF4-FFF2-40B4-BE49-F238E27FC236}">
-                <a16:creationId xmlns:a16="http://schemas.microsoft.com/office/drawing/2014/main" id="{A9FED82A-9828-4DAC-9E76-37A3B84307F0}"/>
+                <a16:creationId xmlns:a16="http://schemas.microsoft.com/office/drawing/2014/main" id="{0F5CD0FA-3D59-4F7C-9C76-3DB059CF6E6D}"/>
               </a:ext>
             </a:extLst>
           </p:cNvPr>
@@ -23488,7 +23488,7 @@
           <p:cNvPr id="9" name="">
             <a:extLst xmlns:a="http://schemas.openxmlformats.org/drawingml/2006/main">
               <a:ext uri="{FF2B5EF4-FFF2-40B4-BE49-F238E27FC236}">
-                <a16:creationId xmlns:a16="http://schemas.microsoft.com/office/drawing/2014/main" id="{81FAFF21-1B97-44BB-BAF7-CBD6E5E445EE}"/>
+                <a16:creationId xmlns:a16="http://schemas.microsoft.com/office/drawing/2014/main" id="{42ECDB5A-8740-4743-80F8-1D58F3082BB1}"/>
               </a:ext>
             </a:extLst>
           </p:cNvPr>
@@ -23556,7 +23556,7 @@
           <p:cNvPr id="10" name="">
             <a:extLst xmlns:a="http://schemas.openxmlformats.org/drawingml/2006/main">
               <a:ext uri="{FF2B5EF4-FFF2-40B4-BE49-F238E27FC236}">
-                <a16:creationId xmlns:a16="http://schemas.microsoft.com/office/drawing/2014/main" id="{51DEAF28-1786-4381-A3F8-6F561276B01F}"/>
+                <a16:creationId xmlns:a16="http://schemas.microsoft.com/office/drawing/2014/main" id="{93910515-75DB-43F9-86D7-62AC3A385C39}"/>
               </a:ext>
             </a:extLst>
           </p:cNvPr>
@@ -23566,7 +23566,7 @@
           <p:nvPr/>
         </p:nvPicPr>
         <p:blipFill>
-          <a:blip xmlns:r="http://schemas.openxmlformats.org/officeDocument/2006/relationships" xmlns:a="http://schemas.openxmlformats.org/drawingml/2006/main" r:embed="Rc9c92f3b1e7b4a6f"/>
+          <a:blip xmlns:r="http://schemas.openxmlformats.org/officeDocument/2006/relationships" xmlns:a="http://schemas.openxmlformats.org/drawingml/2006/main" r:embed="Ra841142237984876"/>
           <a:stretch xmlns:a="http://schemas.openxmlformats.org/drawingml/2006/main"/>
         </p:blipFill>
         <p:spPr>
@@ -23584,7 +23584,7 @@
           <p:cNvPr id="11" name="">
             <a:extLst xmlns:a="http://schemas.openxmlformats.org/drawingml/2006/main">
               <a:ext uri="{FF2B5EF4-FFF2-40B4-BE49-F238E27FC236}">
-                <a16:creationId xmlns:a16="http://schemas.microsoft.com/office/drawing/2014/main" id="{0EC8460D-9676-4C24-8358-6E96DD3EFEB3}"/>
+                <a16:creationId xmlns:a16="http://schemas.microsoft.com/office/drawing/2014/main" id="{7EAEB1CE-EF28-4AB0-AE23-9DBE76A40A78}"/>
               </a:ext>
             </a:extLst>
           </p:cNvPr>
@@ -23652,7 +23652,7 @@
           <p:cNvPr id="12" name="">
             <a:extLst xmlns:a="http://schemas.openxmlformats.org/drawingml/2006/main">
               <a:ext uri="{FF2B5EF4-FFF2-40B4-BE49-F238E27FC236}">
-                <a16:creationId xmlns:a16="http://schemas.microsoft.com/office/drawing/2014/main" id="{9C5A3FFA-3369-4F95-8940-70EDA8E3A2C4}"/>
+                <a16:creationId xmlns:a16="http://schemas.microsoft.com/office/drawing/2014/main" id="{BAAD2682-BC55-4CCB-884E-7B60BF263DDD}"/>
               </a:ext>
             </a:extLst>
           </p:cNvPr>
@@ -23720,7 +23720,7 @@
           <p:cNvPr id="13" name="">
             <a:extLst xmlns:a="http://schemas.openxmlformats.org/drawingml/2006/main">
               <a:ext uri="{FF2B5EF4-FFF2-40B4-BE49-F238E27FC236}">
-                <a16:creationId xmlns:a16="http://schemas.microsoft.com/office/drawing/2014/main" id="{1C65634C-2A17-4C91-9834-B1D929E40804}"/>
+                <a16:creationId xmlns:a16="http://schemas.microsoft.com/office/drawing/2014/main" id="{E2FDAD46-ED62-442E-A1EB-5547095D332C}"/>
               </a:ext>
             </a:extLst>
           </p:cNvPr>
@@ -23730,7 +23730,7 @@
           <p:nvPr/>
         </p:nvPicPr>
         <p:blipFill>
-          <a:blip xmlns:r="http://schemas.openxmlformats.org/officeDocument/2006/relationships" xmlns:a="http://schemas.openxmlformats.org/drawingml/2006/main" r:embed="R4489682925ac43a1"/>
+          <a:blip xmlns:r="http://schemas.openxmlformats.org/officeDocument/2006/relationships" xmlns:a="http://schemas.openxmlformats.org/drawingml/2006/main" r:embed="R30bf8441b85e4e88"/>
           <a:stretch xmlns:a="http://schemas.openxmlformats.org/drawingml/2006/main"/>
         </p:blipFill>
         <p:spPr>
@@ -23748,7 +23748,7 @@
           <p:cNvPr id="14" name="">
             <a:extLst xmlns:a="http://schemas.openxmlformats.org/drawingml/2006/main">
               <a:ext uri="{FF2B5EF4-FFF2-40B4-BE49-F238E27FC236}">
-                <a16:creationId xmlns:a16="http://schemas.microsoft.com/office/drawing/2014/main" id="{25C60758-FF51-4803-8302-31155B4FE19B}"/>
+                <a16:creationId xmlns:a16="http://schemas.microsoft.com/office/drawing/2014/main" id="{14EDD1B6-56BE-4935-A4F4-7E231391AC8D}"/>
               </a:ext>
             </a:extLst>
           </p:cNvPr>
@@ -23816,7 +23816,7 @@
           <p:cNvPr id="15" name="">
             <a:extLst xmlns:a="http://schemas.openxmlformats.org/drawingml/2006/main">
               <a:ext uri="{FF2B5EF4-FFF2-40B4-BE49-F238E27FC236}">
-                <a16:creationId xmlns:a16="http://schemas.microsoft.com/office/drawing/2014/main" id="{687CB2FA-9FF1-4916-85CC-FFC8446E89EB}"/>
+                <a16:creationId xmlns:a16="http://schemas.microsoft.com/office/drawing/2014/main" id="{47BE70F6-DBD3-4207-82A7-4945461D5971}"/>
               </a:ext>
             </a:extLst>
           </p:cNvPr>
@@ -23884,7 +23884,7 @@
           <p:cNvPr id="16" name="">
             <a:extLst xmlns:a="http://schemas.openxmlformats.org/drawingml/2006/main">
               <a:ext uri="{FF2B5EF4-FFF2-40B4-BE49-F238E27FC236}">
-                <a16:creationId xmlns:a16="http://schemas.microsoft.com/office/drawing/2014/main" id="{5A1D847D-DE84-4EF7-9A0C-5EDBB641822A}"/>
+                <a16:creationId xmlns:a16="http://schemas.microsoft.com/office/drawing/2014/main" id="{A2032A49-FC33-4E94-A801-491ECC484A29}"/>
               </a:ext>
             </a:extLst>
           </p:cNvPr>
@@ -23950,7 +23950,7 @@
     </p:spTree>
     <p:extLst>
       <p:ext uri="{BB962C8B-B14F-4D97-AF65-F5344CB8AC3E}">
-        <p14:creationId xmlns:p14="http://schemas.microsoft.com/office/powerpoint/2010/main" val="1128803355"/>
+        <p14:creationId xmlns:p14="http://schemas.microsoft.com/office/powerpoint/2010/main" val="1957838079"/>
       </p:ext>
     </p:extLst>
   </p:cSld>
@@ -23981,7 +23981,7 @@
           <p:cNvPr id="14" name="">
             <a:extLst xmlns:a="http://schemas.openxmlformats.org/drawingml/2006/main">
               <a:ext uri="{FF2B5EF4-FFF2-40B4-BE49-F238E27FC236}">
-                <a16:creationId xmlns:a16="http://schemas.microsoft.com/office/drawing/2014/main" id="{60E57A86-8BD6-4194-8803-F3FBFCDC061E}"/>
+                <a16:creationId xmlns:a16="http://schemas.microsoft.com/office/drawing/2014/main" id="{2DB93D5C-0153-4958-90B6-D3913B04E8C2}"/>
               </a:ext>
             </a:extLst>
           </p:cNvPr>
@@ -24049,7 +24049,7 @@
           <p:cNvPr id="2" name="">
             <a:extLst xmlns:a="http://schemas.openxmlformats.org/drawingml/2006/main">
               <a:ext uri="{FF2B5EF4-FFF2-40B4-BE49-F238E27FC236}">
-                <a16:creationId xmlns:a16="http://schemas.microsoft.com/office/drawing/2014/main" id="{5C286450-80C0-4A5D-A76A-FDD194C58885}"/>
+                <a16:creationId xmlns:a16="http://schemas.microsoft.com/office/drawing/2014/main" id="{50EEB386-BFA6-41DA-B656-0690292D846E}"/>
               </a:ext>
             </a:extLst>
           </p:cNvPr>
@@ -24117,7 +24117,7 @@
           <p:cNvPr id="3" name="">
             <a:extLst xmlns:a="http://schemas.openxmlformats.org/drawingml/2006/main">
               <a:ext uri="{FF2B5EF4-FFF2-40B4-BE49-F238E27FC236}">
-                <a16:creationId xmlns:a16="http://schemas.microsoft.com/office/drawing/2014/main" id="{0133604C-2068-46BD-847B-7C130B264636}"/>
+                <a16:creationId xmlns:a16="http://schemas.microsoft.com/office/drawing/2014/main" id="{F4D57F8D-F575-4ECE-986F-D7A0398F6860}"/>
               </a:ext>
             </a:extLst>
           </p:cNvPr>
@@ -24185,7 +24185,7 @@
           <p:cNvPr id="4" name="">
             <a:extLst xmlns:a="http://schemas.openxmlformats.org/drawingml/2006/main">
               <a:ext uri="{FF2B5EF4-FFF2-40B4-BE49-F238E27FC236}">
-                <a16:creationId xmlns:a16="http://schemas.microsoft.com/office/drawing/2014/main" id="{CA3F9296-7EFF-4DCC-95D3-2C831BDB4725}"/>
+                <a16:creationId xmlns:a16="http://schemas.microsoft.com/office/drawing/2014/main" id="{5DF3C91D-B751-4D2F-B97E-50D13A9BE0BD}"/>
               </a:ext>
             </a:extLst>
           </p:cNvPr>
@@ -24195,7 +24195,7 @@
           <p:nvPr/>
         </p:nvPicPr>
         <p:blipFill>
-          <a:blip xmlns:r="http://schemas.openxmlformats.org/officeDocument/2006/relationships" xmlns:a="http://schemas.openxmlformats.org/drawingml/2006/main" r:embed="R9ca5c9513e9b4f69"/>
+          <a:blip xmlns:r="http://schemas.openxmlformats.org/officeDocument/2006/relationships" xmlns:a="http://schemas.openxmlformats.org/drawingml/2006/main" r:embed="R475e05080b5d4340"/>
           <a:stretch xmlns:a="http://schemas.openxmlformats.org/drawingml/2006/main"/>
         </p:blipFill>
         <p:spPr>
@@ -24213,7 +24213,7 @@
           <p:cNvPr id="5" name="">
             <a:extLst xmlns:a="http://schemas.openxmlformats.org/drawingml/2006/main">
               <a:ext uri="{FF2B5EF4-FFF2-40B4-BE49-F238E27FC236}">
-                <a16:creationId xmlns:a16="http://schemas.microsoft.com/office/drawing/2014/main" id="{26F5F66D-5274-495D-958B-11BCED150FCE}"/>
+                <a16:creationId xmlns:a16="http://schemas.microsoft.com/office/drawing/2014/main" id="{752F4065-EFA9-42A5-8F63-05934533A547}"/>
               </a:ext>
             </a:extLst>
           </p:cNvPr>
@@ -24281,7 +24281,7 @@
           <p:cNvPr id="6" name="">
             <a:extLst xmlns:a="http://schemas.openxmlformats.org/drawingml/2006/main">
               <a:ext uri="{FF2B5EF4-FFF2-40B4-BE49-F238E27FC236}">
-                <a16:creationId xmlns:a16="http://schemas.microsoft.com/office/drawing/2014/main" id="{E92CCA63-E57D-4BB9-9E23-9E6D0BBC00E1}"/>
+                <a16:creationId xmlns:a16="http://schemas.microsoft.com/office/drawing/2014/main" id="{C81739CE-D451-4ADC-BE1A-6F5B82F4BD32}"/>
               </a:ext>
             </a:extLst>
           </p:cNvPr>
@@ -24349,7 +24349,7 @@
           <p:cNvPr id="7" name="">
             <a:extLst xmlns:a="http://schemas.openxmlformats.org/drawingml/2006/main">
               <a:ext uri="{FF2B5EF4-FFF2-40B4-BE49-F238E27FC236}">
-                <a16:creationId xmlns:a16="http://schemas.microsoft.com/office/drawing/2014/main" id="{026BE442-C954-4576-B291-556E8B98999D}"/>
+                <a16:creationId xmlns:a16="http://schemas.microsoft.com/office/drawing/2014/main" id="{37201128-1595-49FD-8228-656AD0C18177}"/>
               </a:ext>
             </a:extLst>
           </p:cNvPr>
@@ -24359,7 +24359,7 @@
           <p:nvPr/>
         </p:nvPicPr>
         <p:blipFill>
-          <a:blip xmlns:r="http://schemas.openxmlformats.org/officeDocument/2006/relationships" xmlns:a="http://schemas.openxmlformats.org/drawingml/2006/main" r:embed="R91322aa7274d4ebe"/>
+          <a:blip xmlns:r="http://schemas.openxmlformats.org/officeDocument/2006/relationships" xmlns:a="http://schemas.openxmlformats.org/drawingml/2006/main" r:embed="R07efc1c376d34dde"/>
           <a:stretch xmlns:a="http://schemas.openxmlformats.org/drawingml/2006/main"/>
         </p:blipFill>
         <p:spPr>
@@ -24377,7 +24377,7 @@
           <p:cNvPr id="8" name="">
             <a:extLst xmlns:a="http://schemas.openxmlformats.org/drawingml/2006/main">
               <a:ext uri="{FF2B5EF4-FFF2-40B4-BE49-F238E27FC236}">
-                <a16:creationId xmlns:a16="http://schemas.microsoft.com/office/drawing/2014/main" id="{3E9CCCFA-38A1-47F1-AB65-8EF847D6E4CD}"/>
+                <a16:creationId xmlns:a16="http://schemas.microsoft.com/office/drawing/2014/main" id="{1F3B2134-9B9F-4F8D-BB16-9E624F6D9235}"/>
               </a:ext>
             </a:extLst>
           </p:cNvPr>
@@ -24445,7 +24445,7 @@
           <p:cNvPr id="9" name="">
             <a:extLst xmlns:a="http://schemas.openxmlformats.org/drawingml/2006/main">
               <a:ext uri="{FF2B5EF4-FFF2-40B4-BE49-F238E27FC236}">
-                <a16:creationId xmlns:a16="http://schemas.microsoft.com/office/drawing/2014/main" id="{2C563C68-6372-44E1-BD1C-F00F9AEF9937}"/>
+                <a16:creationId xmlns:a16="http://schemas.microsoft.com/office/drawing/2014/main" id="{785A3369-6F81-4D09-A480-0849FF2921E1}"/>
               </a:ext>
             </a:extLst>
           </p:cNvPr>
@@ -24513,7 +24513,7 @@
           <p:cNvPr id="10" name="">
             <a:extLst xmlns:a="http://schemas.openxmlformats.org/drawingml/2006/main">
               <a:ext uri="{FF2B5EF4-FFF2-40B4-BE49-F238E27FC236}">
-                <a16:creationId xmlns:a16="http://schemas.microsoft.com/office/drawing/2014/main" id="{E0367485-D228-4F9B-BF7E-719D4D857BD2}"/>
+                <a16:creationId xmlns:a16="http://schemas.microsoft.com/office/drawing/2014/main" id="{4D6C9296-E6FE-47A7-8703-7B1C3BB41709}"/>
               </a:ext>
             </a:extLst>
           </p:cNvPr>
@@ -24523,7 +24523,7 @@
           <p:nvPr/>
         </p:nvPicPr>
         <p:blipFill>
-          <a:blip xmlns:r="http://schemas.openxmlformats.org/officeDocument/2006/relationships" xmlns:a="http://schemas.openxmlformats.org/drawingml/2006/main" r:embed="R713a667db5aa4ce7"/>
+          <a:blip xmlns:r="http://schemas.openxmlformats.org/officeDocument/2006/relationships" xmlns:a="http://schemas.openxmlformats.org/drawingml/2006/main" r:embed="Rc48888740cb04d19"/>
           <a:stretch xmlns:a="http://schemas.openxmlformats.org/drawingml/2006/main"/>
         </p:blipFill>
         <p:spPr>
@@ -24541,7 +24541,7 @@
           <p:cNvPr id="11" name="">
             <a:extLst xmlns:a="http://schemas.openxmlformats.org/drawingml/2006/main">
               <a:ext uri="{FF2B5EF4-FFF2-40B4-BE49-F238E27FC236}">
-                <a16:creationId xmlns:a16="http://schemas.microsoft.com/office/drawing/2014/main" id="{59852752-8DF6-4EF3-89F6-AB0AF6EE5100}"/>
+                <a16:creationId xmlns:a16="http://schemas.microsoft.com/office/drawing/2014/main" id="{21F60EC3-12BE-4137-AE3A-112592BDD31C}"/>
               </a:ext>
             </a:extLst>
           </p:cNvPr>
@@ -24609,7 +24609,7 @@
           <p:cNvPr id="12" name="">
             <a:extLst xmlns:a="http://schemas.openxmlformats.org/drawingml/2006/main">
               <a:ext uri="{FF2B5EF4-FFF2-40B4-BE49-F238E27FC236}">
-                <a16:creationId xmlns:a16="http://schemas.microsoft.com/office/drawing/2014/main" id="{676E46DD-5780-4C1A-BCFD-0E39D00E56A3}"/>
+                <a16:creationId xmlns:a16="http://schemas.microsoft.com/office/drawing/2014/main" id="{48097476-DB33-4097-893F-664E97D68D3B}"/>
               </a:ext>
             </a:extLst>
           </p:cNvPr>
@@ -24677,7 +24677,7 @@
           <p:cNvPr id="13" name="">
             <a:extLst xmlns:a="http://schemas.openxmlformats.org/drawingml/2006/main">
               <a:ext uri="{FF2B5EF4-FFF2-40B4-BE49-F238E27FC236}">
-                <a16:creationId xmlns:a16="http://schemas.microsoft.com/office/drawing/2014/main" id="{0F51F78D-F0B5-4A45-9CE4-05E5B4149FA9}"/>
+                <a16:creationId xmlns:a16="http://schemas.microsoft.com/office/drawing/2014/main" id="{D782579A-881B-46EB-BC75-7C3E452EA55B}"/>
               </a:ext>
             </a:extLst>
           </p:cNvPr>
@@ -24743,7 +24743,7 @@
     </p:spTree>
     <p:extLst>
       <p:ext uri="{BB962C8B-B14F-4D97-AF65-F5344CB8AC3E}">
-        <p14:creationId xmlns:p14="http://schemas.microsoft.com/office/powerpoint/2010/main" val="618029531"/>
+        <p14:creationId xmlns:p14="http://schemas.microsoft.com/office/powerpoint/2010/main" val="1599471854"/>
       </p:ext>
     </p:extLst>
   </p:cSld>
@@ -24774,7 +24774,7 @@
           <p:cNvPr id="15" name="">
             <a:extLst xmlns:a="http://schemas.openxmlformats.org/drawingml/2006/main">
               <a:ext uri="{FF2B5EF4-FFF2-40B4-BE49-F238E27FC236}">
-                <a16:creationId xmlns:a16="http://schemas.microsoft.com/office/drawing/2014/main" id="{4281C4FC-92BE-443D-822B-DE1CA3325F0D}"/>
+                <a16:creationId xmlns:a16="http://schemas.microsoft.com/office/drawing/2014/main" id="{E3F491D6-3A18-44AE-9795-EC7D3F1158FE}"/>
               </a:ext>
             </a:extLst>
           </p:cNvPr>
@@ -24784,7 +24784,7 @@
           <p:nvPr/>
         </p:nvPicPr>
         <p:blipFill>
-          <a:blip xmlns:r="http://schemas.openxmlformats.org/officeDocument/2006/relationships" xmlns:a="http://schemas.openxmlformats.org/drawingml/2006/main" r:embed="R802ce46b19554188"/>
+          <a:blip xmlns:r="http://schemas.openxmlformats.org/officeDocument/2006/relationships" xmlns:a="http://schemas.openxmlformats.org/drawingml/2006/main" r:embed="Rdba36033dbcf4c17"/>
           <a:srcRect xmlns:a="http://schemas.openxmlformats.org/drawingml/2006/main" l="0" t="0" r="0" b="0"/>
           <a:stretch xmlns:a="http://schemas.openxmlformats.org/drawingml/2006/main">
             <a:fillRect l="0" t="0" r="0" b="0"/>
@@ -24805,7 +24805,7 @@
           <p:cNvPr id="2" name="">
             <a:extLst xmlns:a="http://schemas.openxmlformats.org/drawingml/2006/main">
               <a:ext uri="{FF2B5EF4-FFF2-40B4-BE49-F238E27FC236}">
-                <a16:creationId xmlns:a16="http://schemas.microsoft.com/office/drawing/2014/main" id="{971F2AF7-A924-4702-9170-C01AB9E9A9F1}"/>
+                <a16:creationId xmlns:a16="http://schemas.microsoft.com/office/drawing/2014/main" id="{EEDEB4D1-8B67-42A9-8A78-E4A12B6002B8}"/>
               </a:ext>
             </a:extLst>
           </p:cNvPr>
@@ -24873,7 +24873,7 @@
           <p:cNvPr id="3" name="">
             <a:extLst xmlns:a="http://schemas.openxmlformats.org/drawingml/2006/main">
               <a:ext uri="{FF2B5EF4-FFF2-40B4-BE49-F238E27FC236}">
-                <a16:creationId xmlns:a16="http://schemas.microsoft.com/office/drawing/2014/main" id="{6D5F8A76-0A52-4D2B-88B8-94440BFB92DB}"/>
+                <a16:creationId xmlns:a16="http://schemas.microsoft.com/office/drawing/2014/main" id="{A7924B01-3194-4583-B2D6-13706588A4AE}"/>
               </a:ext>
             </a:extLst>
           </p:cNvPr>
@@ -24941,7 +24941,7 @@
           <p:cNvPr id="4" name="">
             <a:extLst xmlns:a="http://schemas.openxmlformats.org/drawingml/2006/main">
               <a:ext uri="{FF2B5EF4-FFF2-40B4-BE49-F238E27FC236}">
-                <a16:creationId xmlns:a16="http://schemas.microsoft.com/office/drawing/2014/main" id="{83027D94-75D4-418A-BD71-27088C4DB093}"/>
+                <a16:creationId xmlns:a16="http://schemas.microsoft.com/office/drawing/2014/main" id="{44EE5CF2-36E3-4BF9-BE9A-FE4544A6CCA5}"/>
               </a:ext>
             </a:extLst>
           </p:cNvPr>
@@ -25009,7 +25009,7 @@
           <p:cNvPr id="5" name="">
             <a:extLst xmlns:a="http://schemas.openxmlformats.org/drawingml/2006/main">
               <a:ext uri="{FF2B5EF4-FFF2-40B4-BE49-F238E27FC236}">
-                <a16:creationId xmlns:a16="http://schemas.microsoft.com/office/drawing/2014/main" id="{AD646311-5539-4712-A0A9-90DFA8A9439B}"/>
+                <a16:creationId xmlns:a16="http://schemas.microsoft.com/office/drawing/2014/main" id="{4E09674F-1620-424D-A1F7-DF6CD587121D}"/>
               </a:ext>
             </a:extLst>
           </p:cNvPr>
@@ -25077,7 +25077,7 @@
           <p:cNvPr id="6" name="">
             <a:extLst xmlns:a="http://schemas.openxmlformats.org/drawingml/2006/main">
               <a:ext uri="{FF2B5EF4-FFF2-40B4-BE49-F238E27FC236}">
-                <a16:creationId xmlns:a16="http://schemas.microsoft.com/office/drawing/2014/main" id="{86F5AAC8-942B-49FB-90A9-20E513D4F00B}"/>
+                <a16:creationId xmlns:a16="http://schemas.microsoft.com/office/drawing/2014/main" id="{ED9E217C-591B-47DE-98B6-424E7C629A77}"/>
               </a:ext>
             </a:extLst>
           </p:cNvPr>
@@ -25168,7 +25168,7 @@
           <p:cNvPr id="7" name="">
             <a:extLst xmlns:a="http://schemas.openxmlformats.org/drawingml/2006/main">
               <a:ext uri="{FF2B5EF4-FFF2-40B4-BE49-F238E27FC236}">
-                <a16:creationId xmlns:a16="http://schemas.microsoft.com/office/drawing/2014/main" id="{D98F0C56-2387-42F7-B771-5BA9C5B66758}"/>
+                <a16:creationId xmlns:a16="http://schemas.microsoft.com/office/drawing/2014/main" id="{D5888278-82C5-423C-B086-5D6572F67A18}"/>
               </a:ext>
             </a:extLst>
           </p:cNvPr>
@@ -25236,7 +25236,7 @@
           <p:cNvPr id="8" name="">
             <a:extLst xmlns:a="http://schemas.openxmlformats.org/drawingml/2006/main">
               <a:ext uri="{FF2B5EF4-FFF2-40B4-BE49-F238E27FC236}">
-                <a16:creationId xmlns:a16="http://schemas.microsoft.com/office/drawing/2014/main" id="{4216817C-DA68-4698-8850-6EDFCB4339F6}"/>
+                <a16:creationId xmlns:a16="http://schemas.microsoft.com/office/drawing/2014/main" id="{B72558F6-C2D4-44F3-87BF-F95EBD85F167}"/>
               </a:ext>
             </a:extLst>
           </p:cNvPr>
@@ -25304,7 +25304,7 @@
           <p:cNvPr id="9" name="">
             <a:extLst xmlns:a="http://schemas.openxmlformats.org/drawingml/2006/main">
               <a:ext uri="{FF2B5EF4-FFF2-40B4-BE49-F238E27FC236}">
-                <a16:creationId xmlns:a16="http://schemas.microsoft.com/office/drawing/2014/main" id="{C9C4AD18-F7C5-4DE1-AF79-FAAE85C84A7E}"/>
+                <a16:creationId xmlns:a16="http://schemas.microsoft.com/office/drawing/2014/main" id="{814D6C3D-70AD-4C4D-A873-BE35AD7FEEC5}"/>
               </a:ext>
             </a:extLst>
           </p:cNvPr>
@@ -25372,7 +25372,7 @@
           <p:cNvPr id="10" name="">
             <a:extLst xmlns:a="http://schemas.openxmlformats.org/drawingml/2006/main">
               <a:ext uri="{FF2B5EF4-FFF2-40B4-BE49-F238E27FC236}">
-                <a16:creationId xmlns:a16="http://schemas.microsoft.com/office/drawing/2014/main" id="{E5804C59-9889-4336-9D3E-B14A9FF5E204}"/>
+                <a16:creationId xmlns:a16="http://schemas.microsoft.com/office/drawing/2014/main" id="{85A66114-A38E-4F69-BBAA-6C320415DB5B}"/>
               </a:ext>
             </a:extLst>
           </p:cNvPr>
@@ -25440,7 +25440,7 @@
           <p:cNvPr id="11" name="">
             <a:extLst xmlns:a="http://schemas.openxmlformats.org/drawingml/2006/main">
               <a:ext uri="{FF2B5EF4-FFF2-40B4-BE49-F238E27FC236}">
-                <a16:creationId xmlns:a16="http://schemas.microsoft.com/office/drawing/2014/main" id="{56752D49-EE09-44CA-9C88-26D8EAEC83D7}"/>
+                <a16:creationId xmlns:a16="http://schemas.microsoft.com/office/drawing/2014/main" id="{936F309B-1472-411D-A1A8-FC6DE23E873E}"/>
               </a:ext>
             </a:extLst>
           </p:cNvPr>
@@ -25508,7 +25508,7 @@
           <p:cNvPr id="12" name="">
             <a:extLst xmlns:a="http://schemas.openxmlformats.org/drawingml/2006/main">
               <a:ext uri="{FF2B5EF4-FFF2-40B4-BE49-F238E27FC236}">
-                <a16:creationId xmlns:a16="http://schemas.microsoft.com/office/drawing/2014/main" id="{8DB71F88-26B2-4E39-BDAF-094EF7CD4B3C}"/>
+                <a16:creationId xmlns:a16="http://schemas.microsoft.com/office/drawing/2014/main" id="{7345D443-8825-4CBE-8273-CCF3F38217A5}"/>
               </a:ext>
             </a:extLst>
           </p:cNvPr>
@@ -25576,7 +25576,7 @@
           <p:cNvPr id="13" name="">
             <a:extLst xmlns:a="http://schemas.openxmlformats.org/drawingml/2006/main">
               <a:ext uri="{FF2B5EF4-FFF2-40B4-BE49-F238E27FC236}">
-                <a16:creationId xmlns:a16="http://schemas.microsoft.com/office/drawing/2014/main" id="{BD179D69-4F69-4D0C-A267-90C1A8EC9E84}"/>
+                <a16:creationId xmlns:a16="http://schemas.microsoft.com/office/drawing/2014/main" id="{017FBB53-3DC9-42C3-B945-1C7C5DDB7A86}"/>
               </a:ext>
             </a:extLst>
           </p:cNvPr>
@@ -25644,7 +25644,7 @@
           <p:cNvPr id="14" name="">
             <a:extLst xmlns:a="http://schemas.openxmlformats.org/drawingml/2006/main">
               <a:ext uri="{FF2B5EF4-FFF2-40B4-BE49-F238E27FC236}">
-                <a16:creationId xmlns:a16="http://schemas.microsoft.com/office/drawing/2014/main" id="{91666894-2CE0-4A42-8C68-55EAFA6EBE4F}"/>
+                <a16:creationId xmlns:a16="http://schemas.microsoft.com/office/drawing/2014/main" id="{D1214B9A-F380-4751-A4E2-7C3B0C5D3C91}"/>
               </a:ext>
             </a:extLst>
           </p:cNvPr>
@@ -25710,7 +25710,7 @@
     </p:spTree>
     <p:extLst>
       <p:ext uri="{BB962C8B-B14F-4D97-AF65-F5344CB8AC3E}">
-        <p14:creationId xmlns:p14="http://schemas.microsoft.com/office/powerpoint/2010/main" val="845089451"/>
+        <p14:creationId xmlns:p14="http://schemas.microsoft.com/office/powerpoint/2010/main" val="24294997"/>
       </p:ext>
     </p:extLst>
   </p:cSld>
@@ -25741,7 +25741,7 @@
           <p:cNvPr id="29" name="">
             <a:extLst xmlns:a="http://schemas.openxmlformats.org/drawingml/2006/main">
               <a:ext uri="{FF2B5EF4-FFF2-40B4-BE49-F238E27FC236}">
-                <a16:creationId xmlns:a16="http://schemas.microsoft.com/office/drawing/2014/main" id="{17B753F3-AA9A-4F8A-BFF0-B8CBCCFF1B91}"/>
+                <a16:creationId xmlns:a16="http://schemas.microsoft.com/office/drawing/2014/main" id="{434649C3-88DF-4CD6-BF99-72ED7FB3408C}"/>
               </a:ext>
             </a:extLst>
           </p:cNvPr>
@@ -25809,7 +25809,7 @@
           <p:cNvPr id="2" name="">
             <a:extLst xmlns:a="http://schemas.openxmlformats.org/drawingml/2006/main">
               <a:ext uri="{FF2B5EF4-FFF2-40B4-BE49-F238E27FC236}">
-                <a16:creationId xmlns:a16="http://schemas.microsoft.com/office/drawing/2014/main" id="{CF229AB8-6D45-4170-B61C-DED51DC771F4}"/>
+                <a16:creationId xmlns:a16="http://schemas.microsoft.com/office/drawing/2014/main" id="{4E3526B7-627A-47D7-B1FF-B88C309B6FCA}"/>
               </a:ext>
             </a:extLst>
           </p:cNvPr>
@@ -25877,7 +25877,7 @@
           <p:cNvPr id="3" name="">
             <a:extLst xmlns:a="http://schemas.openxmlformats.org/drawingml/2006/main">
               <a:ext uri="{FF2B5EF4-FFF2-40B4-BE49-F238E27FC236}">
-                <a16:creationId xmlns:a16="http://schemas.microsoft.com/office/drawing/2014/main" id="{E7C1E96F-FB64-429F-ABB2-38A78041155A}"/>
+                <a16:creationId xmlns:a16="http://schemas.microsoft.com/office/drawing/2014/main" id="{A022F40B-18EF-4F13-AE32-E5D9A9731618}"/>
               </a:ext>
             </a:extLst>
           </p:cNvPr>
@@ -25945,7 +25945,7 @@
           <p:cNvPr id="4" name="">
             <a:extLst xmlns:a="http://schemas.openxmlformats.org/drawingml/2006/main">
               <a:ext uri="{FF2B5EF4-FFF2-40B4-BE49-F238E27FC236}">
-                <a16:creationId xmlns:a16="http://schemas.microsoft.com/office/drawing/2014/main" id="{D746296B-B0C2-4F58-AF91-DD03B7AFAF91}"/>
+                <a16:creationId xmlns:a16="http://schemas.microsoft.com/office/drawing/2014/main" id="{56BC718A-3257-486D-8101-3A0C8AB9B9B2}"/>
               </a:ext>
             </a:extLst>
           </p:cNvPr>
@@ -25977,7 +25977,7 @@
           <p:cNvPr id="5" name="">
             <a:extLst xmlns:a="http://schemas.openxmlformats.org/drawingml/2006/main">
               <a:ext uri="{FF2B5EF4-FFF2-40B4-BE49-F238E27FC236}">
-                <a16:creationId xmlns:a16="http://schemas.microsoft.com/office/drawing/2014/main" id="{DEAB138D-BAE9-43F8-B1DE-6A0CEB144387}"/>
+                <a16:creationId xmlns:a16="http://schemas.microsoft.com/office/drawing/2014/main" id="{39A6E8C3-BF19-4EE0-8E84-C329D533F601}"/>
               </a:ext>
             </a:extLst>
           </p:cNvPr>
@@ -26045,7 +26045,7 @@
           <p:cNvPr id="6" name="">
             <a:extLst xmlns:a="http://schemas.openxmlformats.org/drawingml/2006/main">
               <a:ext uri="{FF2B5EF4-FFF2-40B4-BE49-F238E27FC236}">
-                <a16:creationId xmlns:a16="http://schemas.microsoft.com/office/drawing/2014/main" id="{D1C8460F-2C92-4E8C-836E-A5352F6C2EFC}"/>
+                <a16:creationId xmlns:a16="http://schemas.microsoft.com/office/drawing/2014/main" id="{F5BBAFD2-373C-49A6-AF12-BEBB58839564}"/>
               </a:ext>
             </a:extLst>
           </p:cNvPr>
@@ -26113,7 +26113,7 @@
           <p:cNvPr id="7" name="">
             <a:extLst xmlns:a="http://schemas.openxmlformats.org/drawingml/2006/main">
               <a:ext uri="{FF2B5EF4-FFF2-40B4-BE49-F238E27FC236}">
-                <a16:creationId xmlns:a16="http://schemas.microsoft.com/office/drawing/2014/main" id="{C84EF44D-D595-4DA7-9940-5E6C22EF5C03}"/>
+                <a16:creationId xmlns:a16="http://schemas.microsoft.com/office/drawing/2014/main" id="{0EEA514A-5722-4FC1-9889-FD2FE2A3BD0B}"/>
               </a:ext>
             </a:extLst>
           </p:cNvPr>
@@ -26181,7 +26181,7 @@
           <p:cNvPr id="8" name="">
             <a:extLst xmlns:a="http://schemas.openxmlformats.org/drawingml/2006/main">
               <a:ext uri="{FF2B5EF4-FFF2-40B4-BE49-F238E27FC236}">
-                <a16:creationId xmlns:a16="http://schemas.microsoft.com/office/drawing/2014/main" id="{AFFFDD5C-9B02-403A-8102-ACBA28BE310D}"/>
+                <a16:creationId xmlns:a16="http://schemas.microsoft.com/office/drawing/2014/main" id="{2FB49033-9649-4E39-A6E4-6364D455C94B}"/>
               </a:ext>
             </a:extLst>
           </p:cNvPr>
@@ -26211,7 +26211,7 @@
           <p:cNvPr id="9" name="">
             <a:extLst xmlns:a="http://schemas.openxmlformats.org/drawingml/2006/main">
               <a:ext uri="{FF2B5EF4-FFF2-40B4-BE49-F238E27FC236}">
-                <a16:creationId xmlns:a16="http://schemas.microsoft.com/office/drawing/2014/main" id="{207F4A25-56A2-42BE-B622-A6E62EFD7749}"/>
+                <a16:creationId xmlns:a16="http://schemas.microsoft.com/office/drawing/2014/main" id="{5ADA7ACA-8C59-4E2A-8568-FE0176A9AF93}"/>
               </a:ext>
             </a:extLst>
           </p:cNvPr>
@@ -26243,7 +26243,7 @@
           <p:cNvPr id="10" name="">
             <a:extLst xmlns:a="http://schemas.openxmlformats.org/drawingml/2006/main">
               <a:ext uri="{FF2B5EF4-FFF2-40B4-BE49-F238E27FC236}">
-                <a16:creationId xmlns:a16="http://schemas.microsoft.com/office/drawing/2014/main" id="{AD572DBE-BC2E-4D9A-B9AA-8E1254D13CC0}"/>
+                <a16:creationId xmlns:a16="http://schemas.microsoft.com/office/drawing/2014/main" id="{38B26224-61DD-4081-A8B1-93741E4A3FAC}"/>
               </a:ext>
             </a:extLst>
           </p:cNvPr>
@@ -26311,7 +26311,7 @@
           <p:cNvPr id="11" name="">
             <a:extLst xmlns:a="http://schemas.openxmlformats.org/drawingml/2006/main">
               <a:ext uri="{FF2B5EF4-FFF2-40B4-BE49-F238E27FC236}">
-                <a16:creationId xmlns:a16="http://schemas.microsoft.com/office/drawing/2014/main" id="{AC07307A-E592-407E-ABDA-8008091F7244}"/>
+                <a16:creationId xmlns:a16="http://schemas.microsoft.com/office/drawing/2014/main" id="{48A1A53F-846C-499C-8343-3E41B738FC03}"/>
               </a:ext>
             </a:extLst>
           </p:cNvPr>
@@ -26379,7 +26379,7 @@
           <p:cNvPr id="12" name="">
             <a:extLst xmlns:a="http://schemas.openxmlformats.org/drawingml/2006/main">
               <a:ext uri="{FF2B5EF4-FFF2-40B4-BE49-F238E27FC236}">
-                <a16:creationId xmlns:a16="http://schemas.microsoft.com/office/drawing/2014/main" id="{736E7B36-FB84-446C-8D17-3C9FC0895A4B}"/>
+                <a16:creationId xmlns:a16="http://schemas.microsoft.com/office/drawing/2014/main" id="{4062C643-B954-488E-840C-6D67578DD90C}"/>
               </a:ext>
             </a:extLst>
           </p:cNvPr>
@@ -26447,7 +26447,7 @@
           <p:cNvPr id="13" name="">
             <a:extLst xmlns:a="http://schemas.openxmlformats.org/drawingml/2006/main">
               <a:ext uri="{FF2B5EF4-FFF2-40B4-BE49-F238E27FC236}">
-                <a16:creationId xmlns:a16="http://schemas.microsoft.com/office/drawing/2014/main" id="{0E3ECBF4-276A-4813-96FA-F9995371F50C}"/>
+                <a16:creationId xmlns:a16="http://schemas.microsoft.com/office/drawing/2014/main" id="{BDDF0DB6-7038-41B7-B02E-EBA34338FBCB}"/>
               </a:ext>
             </a:extLst>
           </p:cNvPr>
@@ -26477,7 +26477,7 @@
           <p:cNvPr id="14" name="">
             <a:extLst xmlns:a="http://schemas.openxmlformats.org/drawingml/2006/main">
               <a:ext uri="{FF2B5EF4-FFF2-40B4-BE49-F238E27FC236}">
-                <a16:creationId xmlns:a16="http://schemas.microsoft.com/office/drawing/2014/main" id="{4214CB9F-EF1C-4864-872C-36CBE9A519D5}"/>
+                <a16:creationId xmlns:a16="http://schemas.microsoft.com/office/drawing/2014/main" id="{03946A73-E9CC-4D07-BBD4-91D701A3C4F8}"/>
               </a:ext>
             </a:extLst>
           </p:cNvPr>
@@ -26509,7 +26509,7 @@
           <p:cNvPr id="15" name="">
             <a:extLst xmlns:a="http://schemas.openxmlformats.org/drawingml/2006/main">
               <a:ext uri="{FF2B5EF4-FFF2-40B4-BE49-F238E27FC236}">
-                <a16:creationId xmlns:a16="http://schemas.microsoft.com/office/drawing/2014/main" id="{91A3D0C3-1E38-433C-90A0-B8CB59996576}"/>
+                <a16:creationId xmlns:a16="http://schemas.microsoft.com/office/drawing/2014/main" id="{ECA6182F-99CF-4472-B888-8ED8C3BD8DCF}"/>
               </a:ext>
             </a:extLst>
           </p:cNvPr>
@@ -26577,7 +26577,7 @@
           <p:cNvPr id="16" name="">
             <a:extLst xmlns:a="http://schemas.openxmlformats.org/drawingml/2006/main">
               <a:ext uri="{FF2B5EF4-FFF2-40B4-BE49-F238E27FC236}">
-                <a16:creationId xmlns:a16="http://schemas.microsoft.com/office/drawing/2014/main" id="{25526D50-D9E1-41E2-8953-4C0FBFA9162C}"/>
+                <a16:creationId xmlns:a16="http://schemas.microsoft.com/office/drawing/2014/main" id="{4C2DAABD-A11F-4598-84BA-B95984707E0E}"/>
               </a:ext>
             </a:extLst>
           </p:cNvPr>
@@ -26645,7 +26645,7 @@
           <p:cNvPr id="17" name="">
             <a:extLst xmlns:a="http://schemas.openxmlformats.org/drawingml/2006/main">
               <a:ext uri="{FF2B5EF4-FFF2-40B4-BE49-F238E27FC236}">
-                <a16:creationId xmlns:a16="http://schemas.microsoft.com/office/drawing/2014/main" id="{DAD8CB7D-CFF3-418B-93C7-71D8DBAA4155}"/>
+                <a16:creationId xmlns:a16="http://schemas.microsoft.com/office/drawing/2014/main" id="{C1C677B5-2E87-4095-85AE-DBF8943F6DF5}"/>
               </a:ext>
             </a:extLst>
           </p:cNvPr>
@@ -26713,7 +26713,7 @@
           <p:cNvPr id="18" name="">
             <a:extLst xmlns:a="http://schemas.openxmlformats.org/drawingml/2006/main">
               <a:ext uri="{FF2B5EF4-FFF2-40B4-BE49-F238E27FC236}">
-                <a16:creationId xmlns:a16="http://schemas.microsoft.com/office/drawing/2014/main" id="{3252B38B-7AAB-4C59-8550-436DEAF35224}"/>
+                <a16:creationId xmlns:a16="http://schemas.microsoft.com/office/drawing/2014/main" id="{FE862D85-DCD3-42D3-8E23-65798A85090D}"/>
               </a:ext>
             </a:extLst>
           </p:cNvPr>
@@ -26743,7 +26743,7 @@
           <p:cNvPr id="19" name="">
             <a:extLst xmlns:a="http://schemas.openxmlformats.org/drawingml/2006/main">
               <a:ext uri="{FF2B5EF4-FFF2-40B4-BE49-F238E27FC236}">
-                <a16:creationId xmlns:a16="http://schemas.microsoft.com/office/drawing/2014/main" id="{676CE391-BEDE-4E00-8E79-D05A5110C26C}"/>
+                <a16:creationId xmlns:a16="http://schemas.microsoft.com/office/drawing/2014/main" id="{A354B993-C3F5-4CF1-B946-CA9666067AAC}"/>
               </a:ext>
             </a:extLst>
           </p:cNvPr>
@@ -26775,7 +26775,7 @@
           <p:cNvPr id="20" name="">
             <a:extLst xmlns:a="http://schemas.openxmlformats.org/drawingml/2006/main">
               <a:ext uri="{FF2B5EF4-FFF2-40B4-BE49-F238E27FC236}">
-                <a16:creationId xmlns:a16="http://schemas.microsoft.com/office/drawing/2014/main" id="{4B47A6A9-1F8B-48C8-970D-38D5259DDC18}"/>
+                <a16:creationId xmlns:a16="http://schemas.microsoft.com/office/drawing/2014/main" id="{FDD3C897-FCDD-4153-A613-6F47A60ABA3D}"/>
               </a:ext>
             </a:extLst>
           </p:cNvPr>
@@ -26843,7 +26843,7 @@
           <p:cNvPr id="21" name="">
             <a:extLst xmlns:a="http://schemas.openxmlformats.org/drawingml/2006/main">
               <a:ext uri="{FF2B5EF4-FFF2-40B4-BE49-F238E27FC236}">
-                <a16:creationId xmlns:a16="http://schemas.microsoft.com/office/drawing/2014/main" id="{7DAF3712-EFC5-4C61-97FF-BF2AF6A5C1F0}"/>
+                <a16:creationId xmlns:a16="http://schemas.microsoft.com/office/drawing/2014/main" id="{72E35439-EE05-4C16-8E1C-ACCE12C4FBE1}"/>
               </a:ext>
             </a:extLst>
           </p:cNvPr>
@@ -26911,7 +26911,7 @@
           <p:cNvPr id="22" name="">
             <a:extLst xmlns:a="http://schemas.openxmlformats.org/drawingml/2006/main">
               <a:ext uri="{FF2B5EF4-FFF2-40B4-BE49-F238E27FC236}">
-                <a16:creationId xmlns:a16="http://schemas.microsoft.com/office/drawing/2014/main" id="{6AC8A3A3-CEC0-406C-8811-FB428BE495BB}"/>
+                <a16:creationId xmlns:a16="http://schemas.microsoft.com/office/drawing/2014/main" id="{4338B9FA-A335-4E61-9A14-7A2408B7806D}"/>
               </a:ext>
             </a:extLst>
           </p:cNvPr>
@@ -26979,7 +26979,7 @@
           <p:cNvPr id="23" name="">
             <a:extLst xmlns:a="http://schemas.openxmlformats.org/drawingml/2006/main">
               <a:ext uri="{FF2B5EF4-FFF2-40B4-BE49-F238E27FC236}">
-                <a16:creationId xmlns:a16="http://schemas.microsoft.com/office/drawing/2014/main" id="{2567523B-6BD7-41A1-B269-FB3D6B7D5CA1}"/>
+                <a16:creationId xmlns:a16="http://schemas.microsoft.com/office/drawing/2014/main" id="{6D85F868-10DD-4F50-8A59-365C29BD7CFF}"/>
               </a:ext>
             </a:extLst>
           </p:cNvPr>
@@ -27009,7 +27009,7 @@
           <p:cNvPr id="24" name="">
             <a:extLst xmlns:a="http://schemas.openxmlformats.org/drawingml/2006/main">
               <a:ext uri="{FF2B5EF4-FFF2-40B4-BE49-F238E27FC236}">
-                <a16:creationId xmlns:a16="http://schemas.microsoft.com/office/drawing/2014/main" id="{18880F69-7924-480E-9932-54740829619F}"/>
+                <a16:creationId xmlns:a16="http://schemas.microsoft.com/office/drawing/2014/main" id="{06079C2A-847E-4F79-9764-D7BBEC2B8CC4}"/>
               </a:ext>
             </a:extLst>
           </p:cNvPr>
@@ -27041,7 +27041,7 @@
           <p:cNvPr id="25" name="">
             <a:extLst xmlns:a="http://schemas.openxmlformats.org/drawingml/2006/main">
               <a:ext uri="{FF2B5EF4-FFF2-40B4-BE49-F238E27FC236}">
-                <a16:creationId xmlns:a16="http://schemas.microsoft.com/office/drawing/2014/main" id="{1118703A-FE12-4F53-AACB-10AD52DBE975}"/>
+                <a16:creationId xmlns:a16="http://schemas.microsoft.com/office/drawing/2014/main" id="{232DAC00-6DB0-4381-9BB5-9EE2F5E7F86D}"/>
               </a:ext>
             </a:extLst>
           </p:cNvPr>
@@ -27109,7 +27109,7 @@
           <p:cNvPr id="26" name="">
             <a:extLst xmlns:a="http://schemas.openxmlformats.org/drawingml/2006/main">
               <a:ext uri="{FF2B5EF4-FFF2-40B4-BE49-F238E27FC236}">
-                <a16:creationId xmlns:a16="http://schemas.microsoft.com/office/drawing/2014/main" id="{D0588B16-7D80-47CE-8B8B-C935F50B478B}"/>
+                <a16:creationId xmlns:a16="http://schemas.microsoft.com/office/drawing/2014/main" id="{F7423D65-41CA-441F-9652-84A815BF37AF}"/>
               </a:ext>
             </a:extLst>
           </p:cNvPr>
@@ -27177,7 +27177,7 @@
           <p:cNvPr id="27" name="">
             <a:extLst xmlns:a="http://schemas.openxmlformats.org/drawingml/2006/main">
               <a:ext uri="{FF2B5EF4-FFF2-40B4-BE49-F238E27FC236}">
-                <a16:creationId xmlns:a16="http://schemas.microsoft.com/office/drawing/2014/main" id="{3E8C45A9-6022-4448-B63F-CC00B5143E56}"/>
+                <a16:creationId xmlns:a16="http://schemas.microsoft.com/office/drawing/2014/main" id="{60839BDD-94CF-49C5-ACEB-E9F6D93C1B21}"/>
               </a:ext>
             </a:extLst>
           </p:cNvPr>
@@ -27245,7 +27245,7 @@
           <p:cNvPr id="28" name="">
             <a:extLst xmlns:a="http://schemas.openxmlformats.org/drawingml/2006/main">
               <a:ext uri="{FF2B5EF4-FFF2-40B4-BE49-F238E27FC236}">
-                <a16:creationId xmlns:a16="http://schemas.microsoft.com/office/drawing/2014/main" id="{125AA3DD-4B39-4804-B78D-10A50FB851C3}"/>
+                <a16:creationId xmlns:a16="http://schemas.microsoft.com/office/drawing/2014/main" id="{16F112FC-58F5-47B6-AA08-45302E04B12B}"/>
               </a:ext>
             </a:extLst>
           </p:cNvPr>
@@ -27311,7 +27311,7 @@
     </p:spTree>
     <p:extLst>
       <p:ext uri="{BB962C8B-B14F-4D97-AF65-F5344CB8AC3E}">
-        <p14:creationId xmlns:p14="http://schemas.microsoft.com/office/powerpoint/2010/main" val="1507158686"/>
+        <p14:creationId xmlns:p14="http://schemas.microsoft.com/office/powerpoint/2010/main" val="1878106722"/>
       </p:ext>
     </p:extLst>
   </p:cSld>
@@ -27342,7 +27342,7 @@
           <p:cNvPr id="21" name="">
             <a:extLst xmlns:a="http://schemas.openxmlformats.org/drawingml/2006/main">
               <a:ext uri="{FF2B5EF4-FFF2-40B4-BE49-F238E27FC236}">
-                <a16:creationId xmlns:a16="http://schemas.microsoft.com/office/drawing/2014/main" id="{FD4E41D0-4029-4912-A0AD-950378349245}"/>
+                <a16:creationId xmlns:a16="http://schemas.microsoft.com/office/drawing/2014/main" id="{F683F822-497C-44EE-B186-579B818582AE}"/>
               </a:ext>
             </a:extLst>
           </p:cNvPr>
@@ -27410,7 +27410,7 @@
           <p:cNvPr id="2" name="">
             <a:extLst xmlns:a="http://schemas.openxmlformats.org/drawingml/2006/main">
               <a:ext uri="{FF2B5EF4-FFF2-40B4-BE49-F238E27FC236}">
-                <a16:creationId xmlns:a16="http://schemas.microsoft.com/office/drawing/2014/main" id="{510740A8-ACD2-4638-B2D4-79F87789624C}"/>
+                <a16:creationId xmlns:a16="http://schemas.microsoft.com/office/drawing/2014/main" id="{8DBCFBB2-DD11-453F-8D0C-DD918F257068}"/>
               </a:ext>
             </a:extLst>
           </p:cNvPr>
@@ -27478,7 +27478,7 @@
           <p:cNvPr id="3" name="">
             <a:extLst xmlns:a="http://schemas.openxmlformats.org/drawingml/2006/main">
               <a:ext uri="{FF2B5EF4-FFF2-40B4-BE49-F238E27FC236}">
-                <a16:creationId xmlns:a16="http://schemas.microsoft.com/office/drawing/2014/main" id="{F0EB0B8F-9080-4827-876A-EEBADF9D4334}"/>
+                <a16:creationId xmlns:a16="http://schemas.microsoft.com/office/drawing/2014/main" id="{F98635D5-773C-4880-8E4B-E19DAE9D73D7}"/>
               </a:ext>
             </a:extLst>
           </p:cNvPr>
@@ -27546,7 +27546,7 @@
           <p:cNvPr id="4" name="">
             <a:extLst xmlns:a="http://schemas.openxmlformats.org/drawingml/2006/main">
               <a:ext uri="{FF2B5EF4-FFF2-40B4-BE49-F238E27FC236}">
-                <a16:creationId xmlns:a16="http://schemas.microsoft.com/office/drawing/2014/main" id="{0AC44FE4-020B-460E-BEE2-6F65C7D79D39}"/>
+                <a16:creationId xmlns:a16="http://schemas.microsoft.com/office/drawing/2014/main" id="{2E0A74E2-FB2F-4452-BEF8-080CF5D3ECB4}"/>
               </a:ext>
             </a:extLst>
           </p:cNvPr>
@@ -27614,7 +27614,7 @@
           <p:cNvPr id="5" name="">
             <a:extLst xmlns:a="http://schemas.openxmlformats.org/drawingml/2006/main">
               <a:ext uri="{FF2B5EF4-FFF2-40B4-BE49-F238E27FC236}">
-                <a16:creationId xmlns:a16="http://schemas.microsoft.com/office/drawing/2014/main" id="{07790C07-8E77-452C-ACA3-01521FA62788}"/>
+                <a16:creationId xmlns:a16="http://schemas.microsoft.com/office/drawing/2014/main" id="{634E567B-12B4-458E-BEA1-6F4E98884003}"/>
               </a:ext>
             </a:extLst>
           </p:cNvPr>
@@ -27682,7 +27682,7 @@
           <p:cNvPr id="6" name="">
             <a:extLst xmlns:a="http://schemas.openxmlformats.org/drawingml/2006/main">
               <a:ext uri="{FF2B5EF4-FFF2-40B4-BE49-F238E27FC236}">
-                <a16:creationId xmlns:a16="http://schemas.microsoft.com/office/drawing/2014/main" id="{2A2340B8-183F-4B0C-8404-40D13108BD64}"/>
+                <a16:creationId xmlns:a16="http://schemas.microsoft.com/office/drawing/2014/main" id="{2D052046-5DDD-4E5A-AA09-BBC4E7F885E0}"/>
               </a:ext>
             </a:extLst>
           </p:cNvPr>
@@ -27750,7 +27750,7 @@
           <p:cNvPr id="7" name="">
             <a:extLst xmlns:a="http://schemas.openxmlformats.org/drawingml/2006/main">
               <a:ext uri="{FF2B5EF4-FFF2-40B4-BE49-F238E27FC236}">
-                <a16:creationId xmlns:a16="http://schemas.microsoft.com/office/drawing/2014/main" id="{B7E57EC1-EAD5-47A5-B293-BFCFA042C9AE}"/>
+                <a16:creationId xmlns:a16="http://schemas.microsoft.com/office/drawing/2014/main" id="{B8574A8A-B859-41AC-AF14-8C7C2777BB22}"/>
               </a:ext>
             </a:extLst>
           </p:cNvPr>
@@ -27818,7 +27818,7 @@
           <p:cNvPr id="8" name="">
             <a:extLst xmlns:a="http://schemas.openxmlformats.org/drawingml/2006/main">
               <a:ext uri="{FF2B5EF4-FFF2-40B4-BE49-F238E27FC236}">
-                <a16:creationId xmlns:a16="http://schemas.microsoft.com/office/drawing/2014/main" id="{40731359-4648-46C0-A8F3-15EC05B24B54}"/>
+                <a16:creationId xmlns:a16="http://schemas.microsoft.com/office/drawing/2014/main" id="{89ED25E9-E946-4E07-AE8D-9A22564B419B}"/>
               </a:ext>
             </a:extLst>
           </p:cNvPr>
@@ -27886,7 +27886,7 @@
           <p:cNvPr id="9" name="">
             <a:extLst xmlns:a="http://schemas.openxmlformats.org/drawingml/2006/main">
               <a:ext uri="{FF2B5EF4-FFF2-40B4-BE49-F238E27FC236}">
-                <a16:creationId xmlns:a16="http://schemas.microsoft.com/office/drawing/2014/main" id="{211E1CB7-EFA4-42AB-BB3F-E219C8C82D7B}"/>
+                <a16:creationId xmlns:a16="http://schemas.microsoft.com/office/drawing/2014/main" id="{40EE01D8-D46E-4B46-B57C-316CB6E1CB82}"/>
               </a:ext>
             </a:extLst>
           </p:cNvPr>
@@ -27954,7 +27954,7 @@
           <p:cNvPr id="10" name="">
             <a:extLst xmlns:a="http://schemas.openxmlformats.org/drawingml/2006/main">
               <a:ext uri="{FF2B5EF4-FFF2-40B4-BE49-F238E27FC236}">
-                <a16:creationId xmlns:a16="http://schemas.microsoft.com/office/drawing/2014/main" id="{CA094C57-EB24-4991-9850-C1E6939C32D1}"/>
+                <a16:creationId xmlns:a16="http://schemas.microsoft.com/office/drawing/2014/main" id="{B6183815-4B1F-4668-AAA8-7E67EB7A76B9}"/>
               </a:ext>
             </a:extLst>
           </p:cNvPr>
@@ -28022,7 +28022,7 @@
           <p:cNvPr id="11" name="">
             <a:extLst xmlns:a="http://schemas.openxmlformats.org/drawingml/2006/main">
               <a:ext uri="{FF2B5EF4-FFF2-40B4-BE49-F238E27FC236}">
-                <a16:creationId xmlns:a16="http://schemas.microsoft.com/office/drawing/2014/main" id="{531F0A8F-8CD9-414B-8910-CC472B88C8AC}"/>
+                <a16:creationId xmlns:a16="http://schemas.microsoft.com/office/drawing/2014/main" id="{E4051834-14B9-4786-8690-DF112283B513}"/>
               </a:ext>
             </a:extLst>
           </p:cNvPr>
@@ -28090,7 +28090,7 @@
           <p:cNvPr id="12" name="">
             <a:extLst xmlns:a="http://schemas.openxmlformats.org/drawingml/2006/main">
               <a:ext uri="{FF2B5EF4-FFF2-40B4-BE49-F238E27FC236}">
-                <a16:creationId xmlns:a16="http://schemas.microsoft.com/office/drawing/2014/main" id="{7F19039A-10BE-452B-B61D-F1466039B3FC}"/>
+                <a16:creationId xmlns:a16="http://schemas.microsoft.com/office/drawing/2014/main" id="{FAFE0DA8-8EF6-48F2-AADE-F942D07C14DA}"/>
               </a:ext>
             </a:extLst>
           </p:cNvPr>
@@ -28158,7 +28158,7 @@
           <p:cNvPr id="13" name="">
             <a:extLst xmlns:a="http://schemas.openxmlformats.org/drawingml/2006/main">
               <a:ext uri="{FF2B5EF4-FFF2-40B4-BE49-F238E27FC236}">
-                <a16:creationId xmlns:a16="http://schemas.microsoft.com/office/drawing/2014/main" id="{F39580EE-05EC-49D9-A129-388F992861A3}"/>
+                <a16:creationId xmlns:a16="http://schemas.microsoft.com/office/drawing/2014/main" id="{7E65A7B6-1AED-4A38-AEAF-7409A908C6EE}"/>
               </a:ext>
             </a:extLst>
           </p:cNvPr>
@@ -28226,7 +28226,7 @@
           <p:cNvPr id="14" name="">
             <a:extLst xmlns:a="http://schemas.openxmlformats.org/drawingml/2006/main">
               <a:ext uri="{FF2B5EF4-FFF2-40B4-BE49-F238E27FC236}">
-                <a16:creationId xmlns:a16="http://schemas.microsoft.com/office/drawing/2014/main" id="{25390DA9-E46F-4AC8-AC38-4388B478154C}"/>
+                <a16:creationId xmlns:a16="http://schemas.microsoft.com/office/drawing/2014/main" id="{E9DCABDE-7BDB-431F-9F51-7FCB8B36A926}"/>
               </a:ext>
             </a:extLst>
           </p:cNvPr>
@@ -28294,7 +28294,7 @@
           <p:cNvPr id="15" name="">
             <a:extLst xmlns:a="http://schemas.openxmlformats.org/drawingml/2006/main">
               <a:ext uri="{FF2B5EF4-FFF2-40B4-BE49-F238E27FC236}">
-                <a16:creationId xmlns:a16="http://schemas.microsoft.com/office/drawing/2014/main" id="{0A4B5FB1-8951-480F-872E-2D43216F527E}"/>
+                <a16:creationId xmlns:a16="http://schemas.microsoft.com/office/drawing/2014/main" id="{BB47B299-7285-49AA-8849-4998120C7BEF}"/>
               </a:ext>
             </a:extLst>
           </p:cNvPr>
@@ -28362,7 +28362,7 @@
           <p:cNvPr id="16" name="">
             <a:extLst xmlns:a="http://schemas.openxmlformats.org/drawingml/2006/main">
               <a:ext uri="{FF2B5EF4-FFF2-40B4-BE49-F238E27FC236}">
-                <a16:creationId xmlns:a16="http://schemas.microsoft.com/office/drawing/2014/main" id="{B4B82D70-B177-40A7-A5DA-9E4E0DC77167}"/>
+                <a16:creationId xmlns:a16="http://schemas.microsoft.com/office/drawing/2014/main" id="{31CDF409-76B7-4635-B7F3-879F428410B8}"/>
               </a:ext>
             </a:extLst>
           </p:cNvPr>
@@ -28430,7 +28430,7 @@
           <p:cNvPr id="17" name="">
             <a:extLst xmlns:a="http://schemas.openxmlformats.org/drawingml/2006/main">
               <a:ext uri="{FF2B5EF4-FFF2-40B4-BE49-F238E27FC236}">
-                <a16:creationId xmlns:a16="http://schemas.microsoft.com/office/drawing/2014/main" id="{EBAB47A7-9BBE-470C-86A8-12A3F90D04B0}"/>
+                <a16:creationId xmlns:a16="http://schemas.microsoft.com/office/drawing/2014/main" id="{3BB9D991-7DD9-4DA7-8B5C-85C8BD6DB1B2}"/>
               </a:ext>
             </a:extLst>
           </p:cNvPr>
@@ -28498,7 +28498,7 @@
           <p:cNvPr id="18" name="">
             <a:extLst xmlns:a="http://schemas.openxmlformats.org/drawingml/2006/main">
               <a:ext uri="{FF2B5EF4-FFF2-40B4-BE49-F238E27FC236}">
-                <a16:creationId xmlns:a16="http://schemas.microsoft.com/office/drawing/2014/main" id="{8A4E538C-F664-4C38-87E6-7DF336B204C5}"/>
+                <a16:creationId xmlns:a16="http://schemas.microsoft.com/office/drawing/2014/main" id="{5E248863-49D3-4CE2-A5FD-59574C5AD7B7}"/>
               </a:ext>
             </a:extLst>
           </p:cNvPr>
@@ -28566,7 +28566,7 @@
           <p:cNvPr id="19" name="">
             <a:extLst xmlns:a="http://schemas.openxmlformats.org/drawingml/2006/main">
               <a:ext uri="{FF2B5EF4-FFF2-40B4-BE49-F238E27FC236}">
-                <a16:creationId xmlns:a16="http://schemas.microsoft.com/office/drawing/2014/main" id="{D3F7DCEC-D520-43B3-9AC4-0B59C2DF10A0}"/>
+                <a16:creationId xmlns:a16="http://schemas.microsoft.com/office/drawing/2014/main" id="{DAFE2F5A-CF1E-47E9-B6D4-9EE0FF1D2587}"/>
               </a:ext>
             </a:extLst>
           </p:cNvPr>
@@ -28634,7 +28634,7 @@
           <p:cNvPr id="20" name="">
             <a:extLst xmlns:a="http://schemas.openxmlformats.org/drawingml/2006/main">
               <a:ext uri="{FF2B5EF4-FFF2-40B4-BE49-F238E27FC236}">
-                <a16:creationId xmlns:a16="http://schemas.microsoft.com/office/drawing/2014/main" id="{53D4349F-B385-497F-851A-EA4FC8BC3BCD}"/>
+                <a16:creationId xmlns:a16="http://schemas.microsoft.com/office/drawing/2014/main" id="{86E53C55-4C94-4805-B07E-7BA8C05C9160}"/>
               </a:ext>
             </a:extLst>
           </p:cNvPr>
@@ -28700,7 +28700,7 @@
     </p:spTree>
     <p:extLst>
       <p:ext uri="{BB962C8B-B14F-4D97-AF65-F5344CB8AC3E}">
-        <p14:creationId xmlns:p14="http://schemas.microsoft.com/office/powerpoint/2010/main" val="2018918182"/>
+        <p14:creationId xmlns:p14="http://schemas.microsoft.com/office/powerpoint/2010/main" val="704194958"/>
       </p:ext>
     </p:extLst>
   </p:cSld>

</xml_diff>

<commit_message>
Build a staged sandwich feedback diagram with transparent layers
</commit_message>
<xml_diff>
--- a/education/training/signature/compact/training-signature.pptx
+++ b/education/training/signature/compact/training-signature.pptx
@@ -2,32 +2,32 @@
 <file path=ppt/presentation.xml><?xml version="1.0" encoding="utf-8"?>
 <p:presentation xmlns:p="http://schemas.openxmlformats.org/presentationml/2006/main">
   <p:sldMasterIdLst>
-    <p:sldMasterId xmlns:r="http://schemas.openxmlformats.org/officeDocument/2006/relationships" id="2147483648" r:id="R2d1bf454d6b74ede"/>
+    <p:sldMasterId xmlns:r="http://schemas.openxmlformats.org/officeDocument/2006/relationships" id="2147483648" r:id="R97e4772f2baa4b05"/>
   </p:sldMasterIdLst>
   <p:notesMasterIdLst>
-    <p:notesMasterId xmlns:r="http://schemas.openxmlformats.org/officeDocument/2006/relationships" r:id="R1891e47c5de14915"/>
+    <p:notesMasterId xmlns:r="http://schemas.openxmlformats.org/officeDocument/2006/relationships" r:id="Rc0a42559285b496c"/>
   </p:notesMasterIdLst>
   <p:sldIdLst>
-    <p:sldId xmlns:r="http://schemas.openxmlformats.org/officeDocument/2006/relationships" id="256" r:id="R73adb8e3133f43cc"/>
-    <p:sldId xmlns:r="http://schemas.openxmlformats.org/officeDocument/2006/relationships" id="257" r:id="R864db455d02f44dd"/>
-    <p:sldId xmlns:r="http://schemas.openxmlformats.org/officeDocument/2006/relationships" id="258" r:id="R31203715b00a4d17"/>
-    <p:sldId xmlns:r="http://schemas.openxmlformats.org/officeDocument/2006/relationships" id="259" r:id="Rc31dbc1730ca4146"/>
-    <p:sldId xmlns:r="http://schemas.openxmlformats.org/officeDocument/2006/relationships" id="260" r:id="Rd882ce381aac441f"/>
-    <p:sldId xmlns:r="http://schemas.openxmlformats.org/officeDocument/2006/relationships" id="261" r:id="Raa83ec398f5941af"/>
-    <p:sldId xmlns:r="http://schemas.openxmlformats.org/officeDocument/2006/relationships" id="262" r:id="Rf9d164c2bca44157"/>
-    <p:sldId xmlns:r="http://schemas.openxmlformats.org/officeDocument/2006/relationships" id="263" r:id="Rc1170b8044ff4930"/>
-    <p:sldId xmlns:r="http://schemas.openxmlformats.org/officeDocument/2006/relationships" id="264" r:id="R9494046b12ae4b95"/>
-    <p:sldId xmlns:r="http://schemas.openxmlformats.org/officeDocument/2006/relationships" id="265" r:id="R0e19359c1a734f82"/>
-    <p:sldId xmlns:r="http://schemas.openxmlformats.org/officeDocument/2006/relationships" id="266" r:id="R84e3927466324283"/>
-    <p:sldId xmlns:r="http://schemas.openxmlformats.org/officeDocument/2006/relationships" id="267" r:id="Ra4511195fb364644"/>
-    <p:sldId xmlns:r="http://schemas.openxmlformats.org/officeDocument/2006/relationships" id="268" r:id="Rba70c520041f4db7"/>
-    <p:sldId xmlns:r="http://schemas.openxmlformats.org/officeDocument/2006/relationships" id="269" r:id="Ra357f1d89cb74f03"/>
-    <p:sldId xmlns:r="http://schemas.openxmlformats.org/officeDocument/2006/relationships" id="270" r:id="R196e34d33a664baf"/>
-    <p:sldId xmlns:r="http://schemas.openxmlformats.org/officeDocument/2006/relationships" id="271" r:id="R9d5026a1e9444a4d"/>
-    <p:sldId xmlns:r="http://schemas.openxmlformats.org/officeDocument/2006/relationships" id="272" r:id="Rbc9adc5e8f8d4a4e"/>
-    <p:sldId xmlns:r="http://schemas.openxmlformats.org/officeDocument/2006/relationships" id="273" r:id="R80d4e5e4d1fe44a0"/>
-    <p:sldId xmlns:r="http://schemas.openxmlformats.org/officeDocument/2006/relationships" id="274" r:id="R28825bcc53c642c0"/>
-    <p:sldId xmlns:r="http://schemas.openxmlformats.org/officeDocument/2006/relationships" id="275" r:id="Raa376f99003c4daa"/>
+    <p:sldId xmlns:r="http://schemas.openxmlformats.org/officeDocument/2006/relationships" id="256" r:id="R5a3911193d984ef5"/>
+    <p:sldId xmlns:r="http://schemas.openxmlformats.org/officeDocument/2006/relationships" id="257" r:id="R7e9fe74424024872"/>
+    <p:sldId xmlns:r="http://schemas.openxmlformats.org/officeDocument/2006/relationships" id="258" r:id="R11cdff0603214ac9"/>
+    <p:sldId xmlns:r="http://schemas.openxmlformats.org/officeDocument/2006/relationships" id="259" r:id="Ra279ca4f4c1943d8"/>
+    <p:sldId xmlns:r="http://schemas.openxmlformats.org/officeDocument/2006/relationships" id="260" r:id="R066029f3ea644f79"/>
+    <p:sldId xmlns:r="http://schemas.openxmlformats.org/officeDocument/2006/relationships" id="261" r:id="R3fab1d48af964a3c"/>
+    <p:sldId xmlns:r="http://schemas.openxmlformats.org/officeDocument/2006/relationships" id="262" r:id="R3a3544ad0ad24b6b"/>
+    <p:sldId xmlns:r="http://schemas.openxmlformats.org/officeDocument/2006/relationships" id="263" r:id="Rd7b4cfc7894c4b42"/>
+    <p:sldId xmlns:r="http://schemas.openxmlformats.org/officeDocument/2006/relationships" id="264" r:id="R1e7060040b7643ab"/>
+    <p:sldId xmlns:r="http://schemas.openxmlformats.org/officeDocument/2006/relationships" id="265" r:id="R35300bd9c4944587"/>
+    <p:sldId xmlns:r="http://schemas.openxmlformats.org/officeDocument/2006/relationships" id="266" r:id="Ra06d872261174aec"/>
+    <p:sldId xmlns:r="http://schemas.openxmlformats.org/officeDocument/2006/relationships" id="267" r:id="R30de557749d945a1"/>
+    <p:sldId xmlns:r="http://schemas.openxmlformats.org/officeDocument/2006/relationships" id="268" r:id="R627231799ae840fd"/>
+    <p:sldId xmlns:r="http://schemas.openxmlformats.org/officeDocument/2006/relationships" id="269" r:id="R0bee8250f37449c0"/>
+    <p:sldId xmlns:r="http://schemas.openxmlformats.org/officeDocument/2006/relationships" id="270" r:id="R372160a02ef2424e"/>
+    <p:sldId xmlns:r="http://schemas.openxmlformats.org/officeDocument/2006/relationships" id="271" r:id="Rbe7b510517be442c"/>
+    <p:sldId xmlns:r="http://schemas.openxmlformats.org/officeDocument/2006/relationships" id="272" r:id="Rbdf3834caa1c4c50"/>
+    <p:sldId xmlns:r="http://schemas.openxmlformats.org/officeDocument/2006/relationships" id="273" r:id="R902744503da047e4"/>
+    <p:sldId xmlns:r="http://schemas.openxmlformats.org/officeDocument/2006/relationships" id="274" r:id="Rd2f963559ea84b16"/>
+    <p:sldId xmlns:r="http://schemas.openxmlformats.org/officeDocument/2006/relationships" id="275" r:id="Rf86f84d9b22f4800"/>
   </p:sldIdLst>
   <p:sldSz cx="12192000" cy="6858000"/>
   <p:notesSz cx="6858000" cy="9144000"/>
@@ -6663,7 +6663,7 @@
           <p:cNvPr id="3" name="Title">
             <a:extLst xmlns:a="http://schemas.openxmlformats.org/drawingml/2006/main">
               <a:ext uri="{FF2B5EF4-FFF2-40B4-BE49-F238E27FC236}">
-                <a16:creationId xmlns:a16="http://schemas.microsoft.com/office/drawing/2014/main" id="{BCC65DEA-6A22-4F3E-92B2-85FABA4A69D8}"/>
+                <a16:creationId xmlns:a16="http://schemas.microsoft.com/office/drawing/2014/main" id="{C5BE8F49-2A43-4560-99D6-DD806CE89198}"/>
               </a:ext>
             </a:extLst>
           </p:cNvPr>
@@ -6820,7 +6820,7 @@
           <p:cNvPr id="2" name="Subtitle">
             <a:extLst xmlns:a="http://schemas.openxmlformats.org/drawingml/2006/main">
               <a:ext uri="{FF2B5EF4-FFF2-40B4-BE49-F238E27FC236}">
-                <a16:creationId xmlns:a16="http://schemas.microsoft.com/office/drawing/2014/main" id="{A0A4F419-21AB-4AB2-BD5B-37140C4209B4}"/>
+                <a16:creationId xmlns:a16="http://schemas.microsoft.com/office/drawing/2014/main" id="{9ECA0144-2443-4E32-A1E2-7B1EAEF31F91}"/>
               </a:ext>
             </a:extLst>
           </p:cNvPr>
@@ -6994,7 +6994,7 @@
           <p:cNvPr id="2" name="Section title">
             <a:extLst xmlns:a="http://schemas.openxmlformats.org/drawingml/2006/main">
               <a:ext uri="{FF2B5EF4-FFF2-40B4-BE49-F238E27FC236}">
-                <a16:creationId xmlns:a16="http://schemas.microsoft.com/office/drawing/2014/main" id="{A7349459-B5A5-46F7-9200-D3ACC5AD5238}"/>
+                <a16:creationId xmlns:a16="http://schemas.microsoft.com/office/drawing/2014/main" id="{936D5F23-A867-4ACF-8CD4-1CA9A1C401DC}"/>
               </a:ext>
             </a:extLst>
           </p:cNvPr>
@@ -7168,7 +7168,7 @@
           <p:cNvPr id="3" name="Title">
             <a:extLst xmlns:a="http://schemas.openxmlformats.org/drawingml/2006/main">
               <a:ext uri="{FF2B5EF4-FFF2-40B4-BE49-F238E27FC236}">
-                <a16:creationId xmlns:a16="http://schemas.microsoft.com/office/drawing/2014/main" id="{EC3CBD51-6A97-4AC4-B090-3D451D84F3CD}"/>
+                <a16:creationId xmlns:a16="http://schemas.microsoft.com/office/drawing/2014/main" id="{837AB72F-C570-4EC2-BCD7-62329DADCDD1}"/>
               </a:ext>
             </a:extLst>
           </p:cNvPr>
@@ -7325,7 +7325,7 @@
           <p:cNvPr id="2" name="Body">
             <a:extLst xmlns:a="http://schemas.openxmlformats.org/drawingml/2006/main">
               <a:ext uri="{FF2B5EF4-FFF2-40B4-BE49-F238E27FC236}">
-                <a16:creationId xmlns:a16="http://schemas.microsoft.com/office/drawing/2014/main" id="{16499BB1-C203-4214-9DCE-24CD51741B85}"/>
+                <a16:creationId xmlns:a16="http://schemas.microsoft.com/office/drawing/2014/main" id="{57264C21-9EE8-4BCD-97D3-B36C9B598D63}"/>
               </a:ext>
             </a:extLst>
           </p:cNvPr>
@@ -7499,7 +7499,7 @@
           <p:cNvPr id="4" name="Title">
             <a:extLst xmlns:a="http://schemas.openxmlformats.org/drawingml/2006/main">
               <a:ext uri="{FF2B5EF4-FFF2-40B4-BE49-F238E27FC236}">
-                <a16:creationId xmlns:a16="http://schemas.microsoft.com/office/drawing/2014/main" id="{24C5CCDD-2EB3-41DD-813F-17F9755A9958}"/>
+                <a16:creationId xmlns:a16="http://schemas.microsoft.com/office/drawing/2014/main" id="{11617272-0CD9-48F6-874A-240092AE8F29}"/>
               </a:ext>
             </a:extLst>
           </p:cNvPr>
@@ -7656,7 +7656,7 @@
           <p:cNvPr id="2" name="Left column">
             <a:extLst xmlns:a="http://schemas.openxmlformats.org/drawingml/2006/main">
               <a:ext uri="{FF2B5EF4-FFF2-40B4-BE49-F238E27FC236}">
-                <a16:creationId xmlns:a16="http://schemas.microsoft.com/office/drawing/2014/main" id="{52858D80-32C5-4C07-B7BA-5FA25AB37D3A}"/>
+                <a16:creationId xmlns:a16="http://schemas.microsoft.com/office/drawing/2014/main" id="{5957419A-269A-406F-8425-3DB1ADABA9DC}"/>
               </a:ext>
             </a:extLst>
           </p:cNvPr>
@@ -7813,7 +7813,7 @@
           <p:cNvPr id="3" name="Right column">
             <a:extLst xmlns:a="http://schemas.openxmlformats.org/drawingml/2006/main">
               <a:ext uri="{FF2B5EF4-FFF2-40B4-BE49-F238E27FC236}">
-                <a16:creationId xmlns:a16="http://schemas.microsoft.com/office/drawing/2014/main" id="{C4905DF0-FA09-4BCA-8C53-AD22A2486B64}"/>
+                <a16:creationId xmlns:a16="http://schemas.microsoft.com/office/drawing/2014/main" id="{3DAA037B-ABAE-4E43-AC43-378E70DD5894}"/>
               </a:ext>
             </a:extLst>
           </p:cNvPr>
@@ -7987,7 +7987,7 @@
           <p:cNvPr id="3" name="Title">
             <a:extLst xmlns:a="http://schemas.openxmlformats.org/drawingml/2006/main">
               <a:ext uri="{FF2B5EF4-FFF2-40B4-BE49-F238E27FC236}">
-                <a16:creationId xmlns:a16="http://schemas.microsoft.com/office/drawing/2014/main" id="{1A1A665C-5238-4E79-8115-D5013F1C0A87}"/>
+                <a16:creationId xmlns:a16="http://schemas.microsoft.com/office/drawing/2014/main" id="{B4AB990E-B68F-47B5-934A-8A6F587848EB}"/>
               </a:ext>
             </a:extLst>
           </p:cNvPr>
@@ -8144,7 +8144,7 @@
           <p:cNvPr id="2" name="Left column">
             <a:extLst xmlns:a="http://schemas.openxmlformats.org/drawingml/2006/main">
               <a:ext uri="{FF2B5EF4-FFF2-40B4-BE49-F238E27FC236}">
-                <a16:creationId xmlns:a16="http://schemas.microsoft.com/office/drawing/2014/main" id="{477EA6F3-EBEE-47E5-ADDC-1A1357A7E862}"/>
+                <a16:creationId xmlns:a16="http://schemas.microsoft.com/office/drawing/2014/main" id="{D4B3529E-CC0C-405F-8BED-A155A5B2AB2E}"/>
               </a:ext>
             </a:extLst>
           </p:cNvPr>
@@ -8339,12 +8339,12 @@
   </p:cSld>
   <p:clrMap bg1="lt1" tx1="dk1" bg2="lt2" tx2="dk2" accent1="accent1" accent2="accent2" accent3="accent3" accent4="accent4" accent5="accent5" accent6="accent6" hlink="hlink" folHlink="folHlink"/>
   <p:sldLayoutIdLst>
-    <p:sldLayoutId xmlns:r="http://schemas.openxmlformats.org/officeDocument/2006/relationships" id="2147483649" r:id="R663e0e12a8d54195"/>
-    <p:sldLayoutId xmlns:r="http://schemas.openxmlformats.org/officeDocument/2006/relationships" id="2147483650" r:id="R15137cf0edec4088"/>
-    <p:sldLayoutId xmlns:r="http://schemas.openxmlformats.org/officeDocument/2006/relationships" id="2147483651" r:id="R7d2eca98900549df"/>
-    <p:sldLayoutId xmlns:r="http://schemas.openxmlformats.org/officeDocument/2006/relationships" id="2147483652" r:id="R401e0de8abca4e6c"/>
-    <p:sldLayoutId xmlns:r="http://schemas.openxmlformats.org/officeDocument/2006/relationships" id="2147483653" r:id="Rca9f9fa60cc84855"/>
-    <p:sldLayoutId xmlns:r="http://schemas.openxmlformats.org/officeDocument/2006/relationships" id="2147483654" r:id="R3c9d69787c714a01"/>
+    <p:sldLayoutId xmlns:r="http://schemas.openxmlformats.org/officeDocument/2006/relationships" id="2147483649" r:id="Rb504ffd95111403e"/>
+    <p:sldLayoutId xmlns:r="http://schemas.openxmlformats.org/officeDocument/2006/relationships" id="2147483650" r:id="R3d94a293435a4763"/>
+    <p:sldLayoutId xmlns:r="http://schemas.openxmlformats.org/officeDocument/2006/relationships" id="2147483651" r:id="R36a0e2f2c27944d8"/>
+    <p:sldLayoutId xmlns:r="http://schemas.openxmlformats.org/officeDocument/2006/relationships" id="2147483652" r:id="R136b66828d2e416f"/>
+    <p:sldLayoutId xmlns:r="http://schemas.openxmlformats.org/officeDocument/2006/relationships" id="2147483653" r:id="R2584e89845764534"/>
+    <p:sldLayoutId xmlns:r="http://schemas.openxmlformats.org/officeDocument/2006/relationships" id="2147483654" r:id="R10b0c13890f446ea"/>
   </p:sldLayoutIdLst>
   <p:txStyles>
     <p:titleStyle>
@@ -8895,7 +8895,7 @@
           <p:cNvPr id="8" name="">
             <a:extLst xmlns:a="http://schemas.openxmlformats.org/drawingml/2006/main">
               <a:ext uri="{FF2B5EF4-FFF2-40B4-BE49-F238E27FC236}">
-                <a16:creationId xmlns:a16="http://schemas.microsoft.com/office/drawing/2014/main" id="{DA21E2AF-86B8-4343-AED2-9C5E65D4465B}"/>
+                <a16:creationId xmlns:a16="http://schemas.microsoft.com/office/drawing/2014/main" id="{BE8DF342-AF45-43F6-B2DF-878399735EC8}"/>
               </a:ext>
             </a:extLst>
           </p:cNvPr>
@@ -8905,7 +8905,7 @@
           <p:nvPr/>
         </p:nvPicPr>
         <p:blipFill>
-          <a:blip xmlns:r="http://schemas.openxmlformats.org/officeDocument/2006/relationships" xmlns:a="http://schemas.openxmlformats.org/drawingml/2006/main" r:embed="R2273722bcdad4455"/>
+          <a:blip xmlns:r="http://schemas.openxmlformats.org/officeDocument/2006/relationships" xmlns:a="http://schemas.openxmlformats.org/drawingml/2006/main" r:embed="R656d442b2f274e2b"/>
           <a:srcRect xmlns:a="http://schemas.openxmlformats.org/drawingml/2006/main" l="0" t="0" r="0" b="0"/>
           <a:stretch xmlns:a="http://schemas.openxmlformats.org/drawingml/2006/main">
             <a:fillRect l="0" t="0" r="0" b="0"/>
@@ -8926,7 +8926,7 @@
           <p:cNvPr id="2" name="">
             <a:extLst xmlns:a="http://schemas.openxmlformats.org/drawingml/2006/main">
               <a:ext uri="{FF2B5EF4-FFF2-40B4-BE49-F238E27FC236}">
-                <a16:creationId xmlns:a16="http://schemas.microsoft.com/office/drawing/2014/main" id="{9CD10DD6-B2CF-443C-A80D-5E35928369B7}"/>
+                <a16:creationId xmlns:a16="http://schemas.microsoft.com/office/drawing/2014/main" id="{E4A3AE81-4FCF-4C07-ADC5-6BFEC205A7C1}"/>
               </a:ext>
             </a:extLst>
           </p:cNvPr>
@@ -8994,7 +8994,7 @@
           <p:cNvPr id="3" name="">
             <a:extLst xmlns:a="http://schemas.openxmlformats.org/drawingml/2006/main">
               <a:ext uri="{FF2B5EF4-FFF2-40B4-BE49-F238E27FC236}">
-                <a16:creationId xmlns:a16="http://schemas.microsoft.com/office/drawing/2014/main" id="{07D4AE39-EF0F-456B-80B0-C09A1F600987}"/>
+                <a16:creationId xmlns:a16="http://schemas.microsoft.com/office/drawing/2014/main" id="{57B6A900-9A63-48F4-A37D-E8A0AAF88EFD}"/>
               </a:ext>
             </a:extLst>
           </p:cNvPr>
@@ -9062,7 +9062,7 @@
           <p:cNvPr id="4" name="">
             <a:extLst xmlns:a="http://schemas.openxmlformats.org/drawingml/2006/main">
               <a:ext uri="{FF2B5EF4-FFF2-40B4-BE49-F238E27FC236}">
-                <a16:creationId xmlns:a16="http://schemas.microsoft.com/office/drawing/2014/main" id="{40287B3C-A510-41E8-8F53-40151957383F}"/>
+                <a16:creationId xmlns:a16="http://schemas.microsoft.com/office/drawing/2014/main" id="{6C76D26D-6D2E-4B3D-8431-19B8348E2A62}"/>
               </a:ext>
             </a:extLst>
           </p:cNvPr>
@@ -9130,7 +9130,7 @@
           <p:cNvPr id="5" name="">
             <a:extLst xmlns:a="http://schemas.openxmlformats.org/drawingml/2006/main">
               <a:ext uri="{FF2B5EF4-FFF2-40B4-BE49-F238E27FC236}">
-                <a16:creationId xmlns:a16="http://schemas.microsoft.com/office/drawing/2014/main" id="{4E0699D0-8F3E-4C0B-95DB-2D7CDF8078C5}"/>
+                <a16:creationId xmlns:a16="http://schemas.microsoft.com/office/drawing/2014/main" id="{589CAEA1-D8D2-42F5-8F7D-F0A3E89CD42E}"/>
               </a:ext>
             </a:extLst>
           </p:cNvPr>
@@ -9221,7 +9221,7 @@
           <p:cNvPr id="6" name="">
             <a:extLst xmlns:a="http://schemas.openxmlformats.org/drawingml/2006/main">
               <a:ext uri="{FF2B5EF4-FFF2-40B4-BE49-F238E27FC236}">
-                <a16:creationId xmlns:a16="http://schemas.microsoft.com/office/drawing/2014/main" id="{0B0A6974-E18E-47A9-B9A7-A8D6BECAA169}"/>
+                <a16:creationId xmlns:a16="http://schemas.microsoft.com/office/drawing/2014/main" id="{DCA17A43-5BB3-46A4-8CFF-946F48566AA2}"/>
               </a:ext>
             </a:extLst>
           </p:cNvPr>
@@ -9289,7 +9289,7 @@
           <p:cNvPr id="7" name="">
             <a:extLst xmlns:a="http://schemas.openxmlformats.org/drawingml/2006/main">
               <a:ext uri="{FF2B5EF4-FFF2-40B4-BE49-F238E27FC236}">
-                <a16:creationId xmlns:a16="http://schemas.microsoft.com/office/drawing/2014/main" id="{1BD2EE4E-0C34-4E75-9672-CE9BDC11C3EE}"/>
+                <a16:creationId xmlns:a16="http://schemas.microsoft.com/office/drawing/2014/main" id="{5FB2F8BD-B871-45B1-B364-6B4CD05BA8CD}"/>
               </a:ext>
             </a:extLst>
           </p:cNvPr>
@@ -9355,7 +9355,7 @@
     </p:spTree>
     <p:extLst>
       <p:ext uri="{BB962C8B-B14F-4D97-AF65-F5344CB8AC3E}">
-        <p14:creationId xmlns:p14="http://schemas.microsoft.com/office/powerpoint/2010/main" val="718026231"/>
+        <p14:creationId xmlns:p14="http://schemas.microsoft.com/office/powerpoint/2010/main" val="563153221"/>
       </p:ext>
     </p:extLst>
   </p:cSld>
@@ -9386,7 +9386,7 @@
           <p:cNvPr id="14" name="">
             <a:extLst xmlns:a="http://schemas.openxmlformats.org/drawingml/2006/main">
               <a:ext uri="{FF2B5EF4-FFF2-40B4-BE49-F238E27FC236}">
-                <a16:creationId xmlns:a16="http://schemas.microsoft.com/office/drawing/2014/main" id="{3A2D8083-1B46-4532-9AF7-B5F3C429A555}"/>
+                <a16:creationId xmlns:a16="http://schemas.microsoft.com/office/drawing/2014/main" id="{34A09B38-F3B4-4BE7-A1A6-B32DE03F4FFA}"/>
               </a:ext>
             </a:extLst>
           </p:cNvPr>
@@ -9454,7 +9454,7 @@
           <p:cNvPr id="2" name="">
             <a:extLst xmlns:a="http://schemas.openxmlformats.org/drawingml/2006/main">
               <a:ext uri="{FF2B5EF4-FFF2-40B4-BE49-F238E27FC236}">
-                <a16:creationId xmlns:a16="http://schemas.microsoft.com/office/drawing/2014/main" id="{667687F3-9DAE-4425-B280-FC05824A30F0}"/>
+                <a16:creationId xmlns:a16="http://schemas.microsoft.com/office/drawing/2014/main" id="{AF08F7CF-E8C4-4634-BD51-CF9E753B1036}"/>
               </a:ext>
             </a:extLst>
           </p:cNvPr>
@@ -9522,7 +9522,7 @@
           <p:cNvPr id="3" name="">
             <a:extLst xmlns:a="http://schemas.openxmlformats.org/drawingml/2006/main">
               <a:ext uri="{FF2B5EF4-FFF2-40B4-BE49-F238E27FC236}">
-                <a16:creationId xmlns:a16="http://schemas.microsoft.com/office/drawing/2014/main" id="{6B17248C-D861-4178-BE33-B4D123C68C0A}"/>
+                <a16:creationId xmlns:a16="http://schemas.microsoft.com/office/drawing/2014/main" id="{21D3E367-50C7-4920-A5E2-51A69C9C01FD}"/>
               </a:ext>
             </a:extLst>
           </p:cNvPr>
@@ -9590,7 +9590,7 @@
           <p:cNvPr id="4" name="">
             <a:extLst xmlns:a="http://schemas.openxmlformats.org/drawingml/2006/main">
               <a:ext uri="{FF2B5EF4-FFF2-40B4-BE49-F238E27FC236}">
-                <a16:creationId xmlns:a16="http://schemas.microsoft.com/office/drawing/2014/main" id="{C94C2123-9F37-4193-A334-3440DB453680}"/>
+                <a16:creationId xmlns:a16="http://schemas.microsoft.com/office/drawing/2014/main" id="{C62CC475-6E2C-4EBB-B650-DCAFFAF9BDD8}"/>
               </a:ext>
             </a:extLst>
           </p:cNvPr>
@@ -9658,7 +9658,7 @@
           <p:cNvPr id="5" name="">
             <a:extLst xmlns:a="http://schemas.openxmlformats.org/drawingml/2006/main">
               <a:ext uri="{FF2B5EF4-FFF2-40B4-BE49-F238E27FC236}">
-                <a16:creationId xmlns:a16="http://schemas.microsoft.com/office/drawing/2014/main" id="{B368EFB8-19C2-445C-BED3-C2AD8A300C32}"/>
+                <a16:creationId xmlns:a16="http://schemas.microsoft.com/office/drawing/2014/main" id="{675543EF-D5FA-4C4A-AE50-A5D0B413C816}"/>
               </a:ext>
             </a:extLst>
           </p:cNvPr>
@@ -9726,7 +9726,7 @@
           <p:cNvPr id="6" name="">
             <a:extLst xmlns:a="http://schemas.openxmlformats.org/drawingml/2006/main">
               <a:ext uri="{FF2B5EF4-FFF2-40B4-BE49-F238E27FC236}">
-                <a16:creationId xmlns:a16="http://schemas.microsoft.com/office/drawing/2014/main" id="{2BFC5D4A-1DD4-4AC2-8A5F-3215144E2E4A}"/>
+                <a16:creationId xmlns:a16="http://schemas.microsoft.com/office/drawing/2014/main" id="{B36C84AC-4F16-428C-A9CF-316695F551BD}"/>
               </a:ext>
             </a:extLst>
           </p:cNvPr>
@@ -9863,7 +9863,7 @@
           <p:cNvPr id="7" name="">
             <a:extLst xmlns:a="http://schemas.openxmlformats.org/drawingml/2006/main">
               <a:ext uri="{FF2B5EF4-FFF2-40B4-BE49-F238E27FC236}">
-                <a16:creationId xmlns:a16="http://schemas.microsoft.com/office/drawing/2014/main" id="{2F191CE4-AA6B-4DB8-A5FB-E196C9EC07A8}"/>
+                <a16:creationId xmlns:a16="http://schemas.microsoft.com/office/drawing/2014/main" id="{F102334D-104E-4696-B22D-BEAB27FD7DEE}"/>
               </a:ext>
             </a:extLst>
           </p:cNvPr>
@@ -9931,7 +9931,7 @@
           <p:cNvPr id="8" name="">
             <a:extLst xmlns:a="http://schemas.openxmlformats.org/drawingml/2006/main">
               <a:ext uri="{FF2B5EF4-FFF2-40B4-BE49-F238E27FC236}">
-                <a16:creationId xmlns:a16="http://schemas.microsoft.com/office/drawing/2014/main" id="{CCD289EB-35CE-4438-91FB-59F40EEDF37D}"/>
+                <a16:creationId xmlns:a16="http://schemas.microsoft.com/office/drawing/2014/main" id="{0373E51E-8EA2-43EB-AC51-F6D1828F6645}"/>
               </a:ext>
             </a:extLst>
           </p:cNvPr>
@@ -9999,7 +9999,7 @@
           <p:cNvPr id="9" name="">
             <a:extLst xmlns:a="http://schemas.openxmlformats.org/drawingml/2006/main">
               <a:ext uri="{FF2B5EF4-FFF2-40B4-BE49-F238E27FC236}">
-                <a16:creationId xmlns:a16="http://schemas.microsoft.com/office/drawing/2014/main" id="{45D8E355-624D-41A9-B8AA-4268E51147E7}"/>
+                <a16:creationId xmlns:a16="http://schemas.microsoft.com/office/drawing/2014/main" id="{E2DFFF90-6140-4479-99D0-04706B856E4A}"/>
               </a:ext>
             </a:extLst>
           </p:cNvPr>
@@ -10136,7 +10136,7 @@
           <p:cNvPr id="10" name="">
             <a:extLst xmlns:a="http://schemas.openxmlformats.org/drawingml/2006/main">
               <a:ext uri="{FF2B5EF4-FFF2-40B4-BE49-F238E27FC236}">
-                <a16:creationId xmlns:a16="http://schemas.microsoft.com/office/drawing/2014/main" id="{2DDDD52D-C66C-45EA-8521-450AEBD67492}"/>
+                <a16:creationId xmlns:a16="http://schemas.microsoft.com/office/drawing/2014/main" id="{E618316C-8389-4874-979C-687F666287C7}"/>
               </a:ext>
             </a:extLst>
           </p:cNvPr>
@@ -10204,7 +10204,7 @@
           <p:cNvPr id="11" name="">
             <a:extLst xmlns:a="http://schemas.openxmlformats.org/drawingml/2006/main">
               <a:ext uri="{FF2B5EF4-FFF2-40B4-BE49-F238E27FC236}">
-                <a16:creationId xmlns:a16="http://schemas.microsoft.com/office/drawing/2014/main" id="{5CB32D5A-30B5-46F9-A6A9-C012C3FC8B5F}"/>
+                <a16:creationId xmlns:a16="http://schemas.microsoft.com/office/drawing/2014/main" id="{DAE519F1-B430-4B19-AE7B-8D91144BB4F3}"/>
               </a:ext>
             </a:extLst>
           </p:cNvPr>
@@ -10272,7 +10272,7 @@
           <p:cNvPr id="12" name="">
             <a:extLst xmlns:a="http://schemas.openxmlformats.org/drawingml/2006/main">
               <a:ext uri="{FF2B5EF4-FFF2-40B4-BE49-F238E27FC236}">
-                <a16:creationId xmlns:a16="http://schemas.microsoft.com/office/drawing/2014/main" id="{8C4B7B79-0CAF-4068-8E94-9FF6AE4649EB}"/>
+                <a16:creationId xmlns:a16="http://schemas.microsoft.com/office/drawing/2014/main" id="{6594D2F3-35E3-4E0A-8706-042144BAE5C8}"/>
               </a:ext>
             </a:extLst>
           </p:cNvPr>
@@ -10409,7 +10409,7 @@
           <p:cNvPr id="13" name="">
             <a:extLst xmlns:a="http://schemas.openxmlformats.org/drawingml/2006/main">
               <a:ext uri="{FF2B5EF4-FFF2-40B4-BE49-F238E27FC236}">
-                <a16:creationId xmlns:a16="http://schemas.microsoft.com/office/drawing/2014/main" id="{31C9499C-2DF1-44AA-973F-E80395717499}"/>
+                <a16:creationId xmlns:a16="http://schemas.microsoft.com/office/drawing/2014/main" id="{DA57456C-C190-445B-B952-B2E8EB88FB07}"/>
               </a:ext>
             </a:extLst>
           </p:cNvPr>
@@ -10475,7 +10475,7 @@
     </p:spTree>
     <p:extLst>
       <p:ext uri="{BB962C8B-B14F-4D97-AF65-F5344CB8AC3E}">
-        <p14:creationId xmlns:p14="http://schemas.microsoft.com/office/powerpoint/2010/main" val="1428685861"/>
+        <p14:creationId xmlns:p14="http://schemas.microsoft.com/office/powerpoint/2010/main" val="2034951199"/>
       </p:ext>
     </p:extLst>
   </p:cSld>
@@ -10506,7 +10506,7 @@
           <p:cNvPr id="21" name="">
             <a:extLst xmlns:a="http://schemas.openxmlformats.org/drawingml/2006/main">
               <a:ext uri="{FF2B5EF4-FFF2-40B4-BE49-F238E27FC236}">
-                <a16:creationId xmlns:a16="http://schemas.microsoft.com/office/drawing/2014/main" id="{C57E16B3-DB40-45B5-9976-95D1E0DF68F7}"/>
+                <a16:creationId xmlns:a16="http://schemas.microsoft.com/office/drawing/2014/main" id="{372A0231-D5DA-4DC7-A480-A1EEBC08BF0C}"/>
               </a:ext>
             </a:extLst>
           </p:cNvPr>
@@ -10574,7 +10574,7 @@
           <p:cNvPr id="2" name="">
             <a:extLst xmlns:a="http://schemas.openxmlformats.org/drawingml/2006/main">
               <a:ext uri="{FF2B5EF4-FFF2-40B4-BE49-F238E27FC236}">
-                <a16:creationId xmlns:a16="http://schemas.microsoft.com/office/drawing/2014/main" id="{9A4785A1-F68E-49B1-B92A-57C6E48C6D93}"/>
+                <a16:creationId xmlns:a16="http://schemas.microsoft.com/office/drawing/2014/main" id="{3A1B7A2C-77C4-49E4-87D7-054F87AED798}"/>
               </a:ext>
             </a:extLst>
           </p:cNvPr>
@@ -10642,7 +10642,7 @@
           <p:cNvPr id="3" name="">
             <a:extLst xmlns:a="http://schemas.openxmlformats.org/drawingml/2006/main">
               <a:ext uri="{FF2B5EF4-FFF2-40B4-BE49-F238E27FC236}">
-                <a16:creationId xmlns:a16="http://schemas.microsoft.com/office/drawing/2014/main" id="{EEE5B2FB-EAF9-4F4E-9CF6-7619C30F9A58}"/>
+                <a16:creationId xmlns:a16="http://schemas.microsoft.com/office/drawing/2014/main" id="{FF95AD0D-20CB-4377-B5F9-A9B1FE6A2840}"/>
               </a:ext>
             </a:extLst>
           </p:cNvPr>
@@ -10710,7 +10710,7 @@
           <p:cNvPr id="4" name="">
             <a:extLst xmlns:a="http://schemas.openxmlformats.org/drawingml/2006/main">
               <a:ext uri="{FF2B5EF4-FFF2-40B4-BE49-F238E27FC236}">
-                <a16:creationId xmlns:a16="http://schemas.microsoft.com/office/drawing/2014/main" id="{453B97DF-5C95-4977-B4EB-81D37F2B7DAF}"/>
+                <a16:creationId xmlns:a16="http://schemas.microsoft.com/office/drawing/2014/main" id="{B15C3CE8-20BC-4339-81A0-84A6F46AB2AA}"/>
               </a:ext>
             </a:extLst>
           </p:cNvPr>
@@ -10720,7 +10720,7 @@
           <p:nvPr/>
         </p:nvPicPr>
         <p:blipFill>
-          <a:blip xmlns:r="http://schemas.openxmlformats.org/officeDocument/2006/relationships" xmlns:a="http://schemas.openxmlformats.org/drawingml/2006/main" r:embed="R00cced28af3e41f2"/>
+          <a:blip xmlns:r="http://schemas.openxmlformats.org/officeDocument/2006/relationships" xmlns:a="http://schemas.openxmlformats.org/drawingml/2006/main" r:embed="Rcba65484ed124924"/>
           <a:stretch xmlns:a="http://schemas.openxmlformats.org/drawingml/2006/main"/>
         </p:blipFill>
         <p:spPr>
@@ -10738,7 +10738,7 @@
           <p:cNvPr id="5" name="">
             <a:extLst xmlns:a="http://schemas.openxmlformats.org/drawingml/2006/main">
               <a:ext uri="{FF2B5EF4-FFF2-40B4-BE49-F238E27FC236}">
-                <a16:creationId xmlns:a16="http://schemas.microsoft.com/office/drawing/2014/main" id="{00319938-4F42-48A2-849F-7F9B468F8CA4}"/>
+                <a16:creationId xmlns:a16="http://schemas.microsoft.com/office/drawing/2014/main" id="{C6882321-5115-4A27-AAB6-C4E35F12BF25}"/>
               </a:ext>
             </a:extLst>
           </p:cNvPr>
@@ -10806,7 +10806,7 @@
           <p:cNvPr id="6" name="">
             <a:extLst xmlns:a="http://schemas.openxmlformats.org/drawingml/2006/main">
               <a:ext uri="{FF2B5EF4-FFF2-40B4-BE49-F238E27FC236}">
-                <a16:creationId xmlns:a16="http://schemas.microsoft.com/office/drawing/2014/main" id="{304ADAD8-E86B-4F51-950A-D875330ABA26}"/>
+                <a16:creationId xmlns:a16="http://schemas.microsoft.com/office/drawing/2014/main" id="{B143AC2D-B683-473B-9C23-3591BDE1C2EA}"/>
               </a:ext>
             </a:extLst>
           </p:cNvPr>
@@ -10874,7 +10874,7 @@
           <p:cNvPr id="7" name="">
             <a:extLst xmlns:a="http://schemas.openxmlformats.org/drawingml/2006/main">
               <a:ext uri="{FF2B5EF4-FFF2-40B4-BE49-F238E27FC236}">
-                <a16:creationId xmlns:a16="http://schemas.microsoft.com/office/drawing/2014/main" id="{87D6D4B6-15CD-49FA-9F01-6E2FDAB2CC08}"/>
+                <a16:creationId xmlns:a16="http://schemas.microsoft.com/office/drawing/2014/main" id="{9EEC03E9-D51D-46F0-AFB4-BDD8532A6016}"/>
               </a:ext>
             </a:extLst>
           </p:cNvPr>
@@ -10965,7 +10965,7 @@
           <p:cNvPr id="8" name="">
             <a:extLst xmlns:a="http://schemas.openxmlformats.org/drawingml/2006/main">
               <a:ext uri="{FF2B5EF4-FFF2-40B4-BE49-F238E27FC236}">
-                <a16:creationId xmlns:a16="http://schemas.microsoft.com/office/drawing/2014/main" id="{38A03A46-FDFA-4D39-B6EE-D986C0097AE0}"/>
+                <a16:creationId xmlns:a16="http://schemas.microsoft.com/office/drawing/2014/main" id="{B2E0D38D-E9F5-4B28-AAA8-9C0040BF2095}"/>
               </a:ext>
             </a:extLst>
           </p:cNvPr>
@@ -10975,7 +10975,7 @@
           <p:nvPr/>
         </p:nvPicPr>
         <p:blipFill>
-          <a:blip xmlns:r="http://schemas.openxmlformats.org/officeDocument/2006/relationships" xmlns:a="http://schemas.openxmlformats.org/drawingml/2006/main" r:embed="R8d40a20f7d9b4a3c"/>
+          <a:blip xmlns:r="http://schemas.openxmlformats.org/officeDocument/2006/relationships" xmlns:a="http://schemas.openxmlformats.org/drawingml/2006/main" r:embed="R768d16be09be4804"/>
           <a:stretch xmlns:a="http://schemas.openxmlformats.org/drawingml/2006/main"/>
         </p:blipFill>
         <p:spPr>
@@ -10993,7 +10993,7 @@
           <p:cNvPr id="9" name="">
             <a:extLst xmlns:a="http://schemas.openxmlformats.org/drawingml/2006/main">
               <a:ext uri="{FF2B5EF4-FFF2-40B4-BE49-F238E27FC236}">
-                <a16:creationId xmlns:a16="http://schemas.microsoft.com/office/drawing/2014/main" id="{7646EB81-CB82-4CF0-B7AF-8FFEEC5580F3}"/>
+                <a16:creationId xmlns:a16="http://schemas.microsoft.com/office/drawing/2014/main" id="{D4AED50E-8614-4EB1-9E75-DA7FE0B18A28}"/>
               </a:ext>
             </a:extLst>
           </p:cNvPr>
@@ -11061,7 +11061,7 @@
           <p:cNvPr id="10" name="">
             <a:extLst xmlns:a="http://schemas.openxmlformats.org/drawingml/2006/main">
               <a:ext uri="{FF2B5EF4-FFF2-40B4-BE49-F238E27FC236}">
-                <a16:creationId xmlns:a16="http://schemas.microsoft.com/office/drawing/2014/main" id="{776D86EE-FD2E-49F4-9953-0B5D34A02115}"/>
+                <a16:creationId xmlns:a16="http://schemas.microsoft.com/office/drawing/2014/main" id="{605101E3-8F73-4DF0-A3AA-C22896397B83}"/>
               </a:ext>
             </a:extLst>
           </p:cNvPr>
@@ -11129,7 +11129,7 @@
           <p:cNvPr id="11" name="">
             <a:extLst xmlns:a="http://schemas.openxmlformats.org/drawingml/2006/main">
               <a:ext uri="{FF2B5EF4-FFF2-40B4-BE49-F238E27FC236}">
-                <a16:creationId xmlns:a16="http://schemas.microsoft.com/office/drawing/2014/main" id="{E9BBB591-4128-428E-BEEE-146D4011FC5E}"/>
+                <a16:creationId xmlns:a16="http://schemas.microsoft.com/office/drawing/2014/main" id="{87DD97E5-2841-41D4-82F6-402CB90003E8}"/>
               </a:ext>
             </a:extLst>
           </p:cNvPr>
@@ -11220,7 +11220,7 @@
           <p:cNvPr id="12" name="">
             <a:extLst xmlns:a="http://schemas.openxmlformats.org/drawingml/2006/main">
               <a:ext uri="{FF2B5EF4-FFF2-40B4-BE49-F238E27FC236}">
-                <a16:creationId xmlns:a16="http://schemas.microsoft.com/office/drawing/2014/main" id="{D55222FE-1FA0-4FC2-9856-5874B667B53F}"/>
+                <a16:creationId xmlns:a16="http://schemas.microsoft.com/office/drawing/2014/main" id="{61560999-EEEC-4465-BFDC-824BEF24B816}"/>
               </a:ext>
             </a:extLst>
           </p:cNvPr>
@@ -11230,7 +11230,7 @@
           <p:nvPr/>
         </p:nvPicPr>
         <p:blipFill>
-          <a:blip xmlns:r="http://schemas.openxmlformats.org/officeDocument/2006/relationships" xmlns:a="http://schemas.openxmlformats.org/drawingml/2006/main" r:embed="Ra7f70b111ac241ff"/>
+          <a:blip xmlns:r="http://schemas.openxmlformats.org/officeDocument/2006/relationships" xmlns:a="http://schemas.openxmlformats.org/drawingml/2006/main" r:embed="Rda5b5d7b3dee4a13"/>
           <a:stretch xmlns:a="http://schemas.openxmlformats.org/drawingml/2006/main"/>
         </p:blipFill>
         <p:spPr>
@@ -11248,7 +11248,7 @@
           <p:cNvPr id="13" name="">
             <a:extLst xmlns:a="http://schemas.openxmlformats.org/drawingml/2006/main">
               <a:ext uri="{FF2B5EF4-FFF2-40B4-BE49-F238E27FC236}">
-                <a16:creationId xmlns:a16="http://schemas.microsoft.com/office/drawing/2014/main" id="{03C0B550-84E6-4EE3-96D0-52240CBEFA27}"/>
+                <a16:creationId xmlns:a16="http://schemas.microsoft.com/office/drawing/2014/main" id="{24D6B3A7-792E-43FF-AAA6-9FC7537EE642}"/>
               </a:ext>
             </a:extLst>
           </p:cNvPr>
@@ -11316,7 +11316,7 @@
           <p:cNvPr id="14" name="">
             <a:extLst xmlns:a="http://schemas.openxmlformats.org/drawingml/2006/main">
               <a:ext uri="{FF2B5EF4-FFF2-40B4-BE49-F238E27FC236}">
-                <a16:creationId xmlns:a16="http://schemas.microsoft.com/office/drawing/2014/main" id="{6F2CAA1C-826E-4485-AA1E-3752A074D78E}"/>
+                <a16:creationId xmlns:a16="http://schemas.microsoft.com/office/drawing/2014/main" id="{42D2320E-E6DB-4E71-909D-225CCD2C177E}"/>
               </a:ext>
             </a:extLst>
           </p:cNvPr>
@@ -11384,7 +11384,7 @@
           <p:cNvPr id="15" name="">
             <a:extLst xmlns:a="http://schemas.openxmlformats.org/drawingml/2006/main">
               <a:ext uri="{FF2B5EF4-FFF2-40B4-BE49-F238E27FC236}">
-                <a16:creationId xmlns:a16="http://schemas.microsoft.com/office/drawing/2014/main" id="{9AC7AD2D-E026-40A9-AFE9-82E201459823}"/>
+                <a16:creationId xmlns:a16="http://schemas.microsoft.com/office/drawing/2014/main" id="{EEF6C065-2BE5-4372-A588-DDE4ECB32FAF}"/>
               </a:ext>
             </a:extLst>
           </p:cNvPr>
@@ -11475,7 +11475,7 @@
           <p:cNvPr id="16" name="">
             <a:extLst xmlns:a="http://schemas.openxmlformats.org/drawingml/2006/main">
               <a:ext uri="{FF2B5EF4-FFF2-40B4-BE49-F238E27FC236}">
-                <a16:creationId xmlns:a16="http://schemas.microsoft.com/office/drawing/2014/main" id="{4526A4E6-4B7C-4109-8934-67040BB30130}"/>
+                <a16:creationId xmlns:a16="http://schemas.microsoft.com/office/drawing/2014/main" id="{9647C589-7AAB-480D-BA4E-373CCBEF98EE}"/>
               </a:ext>
             </a:extLst>
           </p:cNvPr>
@@ -11485,7 +11485,7 @@
           <p:nvPr/>
         </p:nvPicPr>
         <p:blipFill>
-          <a:blip xmlns:r="http://schemas.openxmlformats.org/officeDocument/2006/relationships" xmlns:a="http://schemas.openxmlformats.org/drawingml/2006/main" r:embed="R3ca6eb10c1c94229"/>
+          <a:blip xmlns:r="http://schemas.openxmlformats.org/officeDocument/2006/relationships" xmlns:a="http://schemas.openxmlformats.org/drawingml/2006/main" r:embed="R986d7efe394e4673"/>
           <a:stretch xmlns:a="http://schemas.openxmlformats.org/drawingml/2006/main"/>
         </p:blipFill>
         <p:spPr>
@@ -11503,7 +11503,7 @@
           <p:cNvPr id="17" name="">
             <a:extLst xmlns:a="http://schemas.openxmlformats.org/drawingml/2006/main">
               <a:ext uri="{FF2B5EF4-FFF2-40B4-BE49-F238E27FC236}">
-                <a16:creationId xmlns:a16="http://schemas.microsoft.com/office/drawing/2014/main" id="{07DAA06B-E703-4D9B-9E09-7476AF0BE956}"/>
+                <a16:creationId xmlns:a16="http://schemas.microsoft.com/office/drawing/2014/main" id="{0FEE8DDB-E904-4B7B-B7F8-A3B2964EFA4B}"/>
               </a:ext>
             </a:extLst>
           </p:cNvPr>
@@ -11571,7 +11571,7 @@
           <p:cNvPr id="18" name="">
             <a:extLst xmlns:a="http://schemas.openxmlformats.org/drawingml/2006/main">
               <a:ext uri="{FF2B5EF4-FFF2-40B4-BE49-F238E27FC236}">
-                <a16:creationId xmlns:a16="http://schemas.microsoft.com/office/drawing/2014/main" id="{C9E21EAA-A4AB-4E1C-BD0A-12C31B6586F8}"/>
+                <a16:creationId xmlns:a16="http://schemas.microsoft.com/office/drawing/2014/main" id="{99085A82-C3DE-48A7-A746-0D077EFB0FDE}"/>
               </a:ext>
             </a:extLst>
           </p:cNvPr>
@@ -11639,7 +11639,7 @@
           <p:cNvPr id="19" name="">
             <a:extLst xmlns:a="http://schemas.openxmlformats.org/drawingml/2006/main">
               <a:ext uri="{FF2B5EF4-FFF2-40B4-BE49-F238E27FC236}">
-                <a16:creationId xmlns:a16="http://schemas.microsoft.com/office/drawing/2014/main" id="{D01D92A3-DC50-43C1-8A20-CDE612489BB5}"/>
+                <a16:creationId xmlns:a16="http://schemas.microsoft.com/office/drawing/2014/main" id="{EA484F82-8257-46BC-B246-AE90D6F118C4}"/>
               </a:ext>
             </a:extLst>
           </p:cNvPr>
@@ -11730,7 +11730,7 @@
           <p:cNvPr id="20" name="">
             <a:extLst xmlns:a="http://schemas.openxmlformats.org/drawingml/2006/main">
               <a:ext uri="{FF2B5EF4-FFF2-40B4-BE49-F238E27FC236}">
-                <a16:creationId xmlns:a16="http://schemas.microsoft.com/office/drawing/2014/main" id="{86C5FBDA-4877-4CE5-9AFD-83528B9A7544}"/>
+                <a16:creationId xmlns:a16="http://schemas.microsoft.com/office/drawing/2014/main" id="{3F39C2C0-3E75-4D61-B3F5-FE3A8CE4C7B9}"/>
               </a:ext>
             </a:extLst>
           </p:cNvPr>
@@ -11796,7 +11796,7 @@
     </p:spTree>
     <p:extLst>
       <p:ext uri="{BB962C8B-B14F-4D97-AF65-F5344CB8AC3E}">
-        <p14:creationId xmlns:p14="http://schemas.microsoft.com/office/powerpoint/2010/main" val="1766809642"/>
+        <p14:creationId xmlns:p14="http://schemas.microsoft.com/office/powerpoint/2010/main" val="1776764749"/>
       </p:ext>
     </p:extLst>
   </p:cSld>
@@ -11827,7 +11827,7 @@
           <p:cNvPr id="21" name="">
             <a:extLst xmlns:a="http://schemas.openxmlformats.org/drawingml/2006/main">
               <a:ext uri="{FF2B5EF4-FFF2-40B4-BE49-F238E27FC236}">
-                <a16:creationId xmlns:a16="http://schemas.microsoft.com/office/drawing/2014/main" id="{9B942990-132F-47BD-87CA-FEC34BA034A2}"/>
+                <a16:creationId xmlns:a16="http://schemas.microsoft.com/office/drawing/2014/main" id="{92641241-5AB8-447A-BAEA-BAFABC6200C4}"/>
               </a:ext>
             </a:extLst>
           </p:cNvPr>
@@ -11895,7 +11895,7 @@
           <p:cNvPr id="2" name="">
             <a:extLst xmlns:a="http://schemas.openxmlformats.org/drawingml/2006/main">
               <a:ext uri="{FF2B5EF4-FFF2-40B4-BE49-F238E27FC236}">
-                <a16:creationId xmlns:a16="http://schemas.microsoft.com/office/drawing/2014/main" id="{9161145A-D95B-41C8-A13C-1B9D9E23A6CE}"/>
+                <a16:creationId xmlns:a16="http://schemas.microsoft.com/office/drawing/2014/main" id="{D71B6FB4-D87C-49CB-BF28-ECFA69C8552C}"/>
               </a:ext>
             </a:extLst>
           </p:cNvPr>
@@ -11963,7 +11963,7 @@
           <p:cNvPr id="3" name="">
             <a:extLst xmlns:a="http://schemas.openxmlformats.org/drawingml/2006/main">
               <a:ext uri="{FF2B5EF4-FFF2-40B4-BE49-F238E27FC236}">
-                <a16:creationId xmlns:a16="http://schemas.microsoft.com/office/drawing/2014/main" id="{80F35524-F18E-4B63-BCD7-CE479AB1BE48}"/>
+                <a16:creationId xmlns:a16="http://schemas.microsoft.com/office/drawing/2014/main" id="{E3254A35-1465-45E9-94D8-BE3B1BAD8C8F}"/>
               </a:ext>
             </a:extLst>
           </p:cNvPr>
@@ -12031,7 +12031,7 @@
           <p:cNvPr id="4" name="">
             <a:extLst xmlns:a="http://schemas.openxmlformats.org/drawingml/2006/main">
               <a:ext uri="{FF2B5EF4-FFF2-40B4-BE49-F238E27FC236}">
-                <a16:creationId xmlns:a16="http://schemas.microsoft.com/office/drawing/2014/main" id="{34BC6281-3875-4F3F-B281-3C872D2416B8}"/>
+                <a16:creationId xmlns:a16="http://schemas.microsoft.com/office/drawing/2014/main" id="{4C59EBFD-9D7E-4E25-A0D4-2FF169A7DD89}"/>
               </a:ext>
             </a:extLst>
           </p:cNvPr>
@@ -12041,7 +12041,7 @@
           <p:nvPr/>
         </p:nvPicPr>
         <p:blipFill>
-          <a:blip xmlns:r="http://schemas.openxmlformats.org/officeDocument/2006/relationships" xmlns:a="http://schemas.openxmlformats.org/drawingml/2006/main" r:embed="R1d0f548c98444289"/>
+          <a:blip xmlns:r="http://schemas.openxmlformats.org/officeDocument/2006/relationships" xmlns:a="http://schemas.openxmlformats.org/drawingml/2006/main" r:embed="Rc828acdade514b51"/>
           <a:stretch xmlns:a="http://schemas.openxmlformats.org/drawingml/2006/main"/>
         </p:blipFill>
         <p:spPr>
@@ -12059,7 +12059,7 @@
           <p:cNvPr id="5" name="">
             <a:extLst xmlns:a="http://schemas.openxmlformats.org/drawingml/2006/main">
               <a:ext uri="{FF2B5EF4-FFF2-40B4-BE49-F238E27FC236}">
-                <a16:creationId xmlns:a16="http://schemas.microsoft.com/office/drawing/2014/main" id="{FB0C834A-39AD-437C-BD8E-ADEFCC61F514}"/>
+                <a16:creationId xmlns:a16="http://schemas.microsoft.com/office/drawing/2014/main" id="{DA9E376B-42CF-4F48-97A2-EE1098C92B94}"/>
               </a:ext>
             </a:extLst>
           </p:cNvPr>
@@ -12127,7 +12127,7 @@
           <p:cNvPr id="6" name="">
             <a:extLst xmlns:a="http://schemas.openxmlformats.org/drawingml/2006/main">
               <a:ext uri="{FF2B5EF4-FFF2-40B4-BE49-F238E27FC236}">
-                <a16:creationId xmlns:a16="http://schemas.microsoft.com/office/drawing/2014/main" id="{28FCF11B-B3BC-455B-A2B5-8BAF3AFE48D7}"/>
+                <a16:creationId xmlns:a16="http://schemas.microsoft.com/office/drawing/2014/main" id="{A4E54C19-86F8-4844-BAD1-EEE7931EE27A}"/>
               </a:ext>
             </a:extLst>
           </p:cNvPr>
@@ -12195,7 +12195,7 @@
           <p:cNvPr id="7" name="">
             <a:extLst xmlns:a="http://schemas.openxmlformats.org/drawingml/2006/main">
               <a:ext uri="{FF2B5EF4-FFF2-40B4-BE49-F238E27FC236}">
-                <a16:creationId xmlns:a16="http://schemas.microsoft.com/office/drawing/2014/main" id="{74E6EED5-A893-4717-B95A-33F1C6567157}"/>
+                <a16:creationId xmlns:a16="http://schemas.microsoft.com/office/drawing/2014/main" id="{D3B57186-121E-4225-B607-26D62D861A9E}"/>
               </a:ext>
             </a:extLst>
           </p:cNvPr>
@@ -12205,7 +12205,7 @@
           <p:nvPr/>
         </p:nvPicPr>
         <p:blipFill>
-          <a:blip xmlns:r="http://schemas.openxmlformats.org/officeDocument/2006/relationships" xmlns:a="http://schemas.openxmlformats.org/drawingml/2006/main" r:embed="R58d1d9550d654894"/>
+          <a:blip xmlns:r="http://schemas.openxmlformats.org/officeDocument/2006/relationships" xmlns:a="http://schemas.openxmlformats.org/drawingml/2006/main" r:embed="R7c3b3e27666b4e93"/>
           <a:stretch xmlns:a="http://schemas.openxmlformats.org/drawingml/2006/main"/>
         </p:blipFill>
         <p:spPr>
@@ -12223,7 +12223,7 @@
           <p:cNvPr id="8" name="">
             <a:extLst xmlns:a="http://schemas.openxmlformats.org/drawingml/2006/main">
               <a:ext uri="{FF2B5EF4-FFF2-40B4-BE49-F238E27FC236}">
-                <a16:creationId xmlns:a16="http://schemas.microsoft.com/office/drawing/2014/main" id="{A1519B89-1C9E-4C38-B1DF-459BF2387E4B}"/>
+                <a16:creationId xmlns:a16="http://schemas.microsoft.com/office/drawing/2014/main" id="{0DF607C7-1678-4652-B82C-6A893A924A27}"/>
               </a:ext>
             </a:extLst>
           </p:cNvPr>
@@ -12291,7 +12291,7 @@
           <p:cNvPr id="9" name="">
             <a:extLst xmlns:a="http://schemas.openxmlformats.org/drawingml/2006/main">
               <a:ext uri="{FF2B5EF4-FFF2-40B4-BE49-F238E27FC236}">
-                <a16:creationId xmlns:a16="http://schemas.microsoft.com/office/drawing/2014/main" id="{2D1C7786-C087-44C6-ADDB-6BA638700216}"/>
+                <a16:creationId xmlns:a16="http://schemas.microsoft.com/office/drawing/2014/main" id="{08C2ED2F-CA94-4DE3-9029-0E28B3B9CB28}"/>
               </a:ext>
             </a:extLst>
           </p:cNvPr>
@@ -12359,7 +12359,7 @@
           <p:cNvPr id="10" name="">
             <a:extLst xmlns:a="http://schemas.openxmlformats.org/drawingml/2006/main">
               <a:ext uri="{FF2B5EF4-FFF2-40B4-BE49-F238E27FC236}">
-                <a16:creationId xmlns:a16="http://schemas.microsoft.com/office/drawing/2014/main" id="{8FF18EEA-D1C3-46DC-8F4D-06B81C828F88}"/>
+                <a16:creationId xmlns:a16="http://schemas.microsoft.com/office/drawing/2014/main" id="{AF26EE6E-FB5C-45EE-8978-EA589C162ED0}"/>
               </a:ext>
             </a:extLst>
           </p:cNvPr>
@@ -12369,7 +12369,7 @@
           <p:nvPr/>
         </p:nvPicPr>
         <p:blipFill>
-          <a:blip xmlns:r="http://schemas.openxmlformats.org/officeDocument/2006/relationships" xmlns:a="http://schemas.openxmlformats.org/drawingml/2006/main" r:embed="Rf592b1ba28f3494a"/>
+          <a:blip xmlns:r="http://schemas.openxmlformats.org/officeDocument/2006/relationships" xmlns:a="http://schemas.openxmlformats.org/drawingml/2006/main" r:embed="Rc45790349b574264"/>
           <a:stretch xmlns:a="http://schemas.openxmlformats.org/drawingml/2006/main"/>
         </p:blipFill>
         <p:spPr>
@@ -12387,7 +12387,7 @@
           <p:cNvPr id="11" name="">
             <a:extLst xmlns:a="http://schemas.openxmlformats.org/drawingml/2006/main">
               <a:ext uri="{FF2B5EF4-FFF2-40B4-BE49-F238E27FC236}">
-                <a16:creationId xmlns:a16="http://schemas.microsoft.com/office/drawing/2014/main" id="{6B0865F0-503C-4064-B4DC-1F7C5364D1AC}"/>
+                <a16:creationId xmlns:a16="http://schemas.microsoft.com/office/drawing/2014/main" id="{82CCA82D-FDE3-4E92-A07F-73600300F890}"/>
               </a:ext>
             </a:extLst>
           </p:cNvPr>
@@ -12455,7 +12455,7 @@
           <p:cNvPr id="12" name="">
             <a:extLst xmlns:a="http://schemas.openxmlformats.org/drawingml/2006/main">
               <a:ext uri="{FF2B5EF4-FFF2-40B4-BE49-F238E27FC236}">
-                <a16:creationId xmlns:a16="http://schemas.microsoft.com/office/drawing/2014/main" id="{4CBA73DC-426B-4CBD-A113-726DD68C8251}"/>
+                <a16:creationId xmlns:a16="http://schemas.microsoft.com/office/drawing/2014/main" id="{82EE30BE-7A9F-4CC0-B4EB-E47234FCA632}"/>
               </a:ext>
             </a:extLst>
           </p:cNvPr>
@@ -12523,7 +12523,7 @@
           <p:cNvPr id="13" name="">
             <a:extLst xmlns:a="http://schemas.openxmlformats.org/drawingml/2006/main">
               <a:ext uri="{FF2B5EF4-FFF2-40B4-BE49-F238E27FC236}">
-                <a16:creationId xmlns:a16="http://schemas.microsoft.com/office/drawing/2014/main" id="{B04508C3-16CE-496B-B8BF-E7C1DEB0137E}"/>
+                <a16:creationId xmlns:a16="http://schemas.microsoft.com/office/drawing/2014/main" id="{639A45F4-7DF6-49FF-9CB3-3CE58F05925C}"/>
               </a:ext>
             </a:extLst>
           </p:cNvPr>
@@ -12533,7 +12533,7 @@
           <p:nvPr/>
         </p:nvPicPr>
         <p:blipFill>
-          <a:blip xmlns:r="http://schemas.openxmlformats.org/officeDocument/2006/relationships" xmlns:a="http://schemas.openxmlformats.org/drawingml/2006/main" r:embed="R36cdc882dd334a48"/>
+          <a:blip xmlns:r="http://schemas.openxmlformats.org/officeDocument/2006/relationships" xmlns:a="http://schemas.openxmlformats.org/drawingml/2006/main" r:embed="R94f3007961ea4d76"/>
           <a:stretch xmlns:a="http://schemas.openxmlformats.org/drawingml/2006/main"/>
         </p:blipFill>
         <p:spPr>
@@ -12551,7 +12551,7 @@
           <p:cNvPr id="14" name="">
             <a:extLst xmlns:a="http://schemas.openxmlformats.org/drawingml/2006/main">
               <a:ext uri="{FF2B5EF4-FFF2-40B4-BE49-F238E27FC236}">
-                <a16:creationId xmlns:a16="http://schemas.microsoft.com/office/drawing/2014/main" id="{8C527279-C7A1-477F-85A9-E43AFDC6544B}"/>
+                <a16:creationId xmlns:a16="http://schemas.microsoft.com/office/drawing/2014/main" id="{BA54C7B2-7760-4765-AE73-D4FCE0982011}"/>
               </a:ext>
             </a:extLst>
           </p:cNvPr>
@@ -12619,7 +12619,7 @@
           <p:cNvPr id="15" name="">
             <a:extLst xmlns:a="http://schemas.openxmlformats.org/drawingml/2006/main">
               <a:ext uri="{FF2B5EF4-FFF2-40B4-BE49-F238E27FC236}">
-                <a16:creationId xmlns:a16="http://schemas.microsoft.com/office/drawing/2014/main" id="{2BF8D74A-0A7C-4A3D-AF6E-632A08568644}"/>
+                <a16:creationId xmlns:a16="http://schemas.microsoft.com/office/drawing/2014/main" id="{B5F11684-F118-4FB5-A90D-7521B28A4A88}"/>
               </a:ext>
             </a:extLst>
           </p:cNvPr>
@@ -12687,7 +12687,7 @@
           <p:cNvPr id="16" name="">
             <a:extLst xmlns:a="http://schemas.openxmlformats.org/drawingml/2006/main">
               <a:ext uri="{FF2B5EF4-FFF2-40B4-BE49-F238E27FC236}">
-                <a16:creationId xmlns:a16="http://schemas.microsoft.com/office/drawing/2014/main" id="{5F3C6C43-F846-4333-A374-177D8B5BE986}"/>
+                <a16:creationId xmlns:a16="http://schemas.microsoft.com/office/drawing/2014/main" id="{2B349693-EB23-4D63-A8E0-1C32EAD5D517}"/>
               </a:ext>
             </a:extLst>
           </p:cNvPr>
@@ -12697,7 +12697,7 @@
           <p:nvPr/>
         </p:nvPicPr>
         <p:blipFill>
-          <a:blip xmlns:r="http://schemas.openxmlformats.org/officeDocument/2006/relationships" xmlns:a="http://schemas.openxmlformats.org/drawingml/2006/main" r:embed="Rfd8733059ad84c1b"/>
+          <a:blip xmlns:r="http://schemas.openxmlformats.org/officeDocument/2006/relationships" xmlns:a="http://schemas.openxmlformats.org/drawingml/2006/main" r:embed="R35366cf61cd9463e"/>
           <a:stretch xmlns:a="http://schemas.openxmlformats.org/drawingml/2006/main"/>
         </p:blipFill>
         <p:spPr>
@@ -12715,7 +12715,7 @@
           <p:cNvPr id="17" name="">
             <a:extLst xmlns:a="http://schemas.openxmlformats.org/drawingml/2006/main">
               <a:ext uri="{FF2B5EF4-FFF2-40B4-BE49-F238E27FC236}">
-                <a16:creationId xmlns:a16="http://schemas.microsoft.com/office/drawing/2014/main" id="{63895974-8864-49C1-BA5D-2DE66F854B52}"/>
+                <a16:creationId xmlns:a16="http://schemas.microsoft.com/office/drawing/2014/main" id="{FED31705-42FB-4AF3-A1CA-017AA81F64AE}"/>
               </a:ext>
             </a:extLst>
           </p:cNvPr>
@@ -12783,7 +12783,7 @@
           <p:cNvPr id="18" name="">
             <a:extLst xmlns:a="http://schemas.openxmlformats.org/drawingml/2006/main">
               <a:ext uri="{FF2B5EF4-FFF2-40B4-BE49-F238E27FC236}">
-                <a16:creationId xmlns:a16="http://schemas.microsoft.com/office/drawing/2014/main" id="{6FBC3C53-E250-4742-91EB-6D646353E2ED}"/>
+                <a16:creationId xmlns:a16="http://schemas.microsoft.com/office/drawing/2014/main" id="{F5C83DF2-B29B-4311-9CC7-603906A4A11B}"/>
               </a:ext>
             </a:extLst>
           </p:cNvPr>
@@ -12851,7 +12851,7 @@
           <p:cNvPr id="19" name="">
             <a:extLst xmlns:a="http://schemas.openxmlformats.org/drawingml/2006/main">
               <a:ext uri="{FF2B5EF4-FFF2-40B4-BE49-F238E27FC236}">
-                <a16:creationId xmlns:a16="http://schemas.microsoft.com/office/drawing/2014/main" id="{9196629F-91E1-4143-B27B-C09BE34605A1}"/>
+                <a16:creationId xmlns:a16="http://schemas.microsoft.com/office/drawing/2014/main" id="{1FF0CE5F-AD0B-42D9-8B75-D571CF64E2E7}"/>
               </a:ext>
             </a:extLst>
           </p:cNvPr>
@@ -12919,7 +12919,7 @@
           <p:cNvPr id="20" name="">
             <a:extLst xmlns:a="http://schemas.openxmlformats.org/drawingml/2006/main">
               <a:ext uri="{FF2B5EF4-FFF2-40B4-BE49-F238E27FC236}">
-                <a16:creationId xmlns:a16="http://schemas.microsoft.com/office/drawing/2014/main" id="{5B2471DF-B99E-46C5-9197-9A9A16627737}"/>
+                <a16:creationId xmlns:a16="http://schemas.microsoft.com/office/drawing/2014/main" id="{1D991699-792D-4853-B673-BD865DBB8A70}"/>
               </a:ext>
             </a:extLst>
           </p:cNvPr>
@@ -12985,7 +12985,7 @@
     </p:spTree>
     <p:extLst>
       <p:ext uri="{BB962C8B-B14F-4D97-AF65-F5344CB8AC3E}">
-        <p14:creationId xmlns:p14="http://schemas.microsoft.com/office/powerpoint/2010/main" val="592191550"/>
+        <p14:creationId xmlns:p14="http://schemas.microsoft.com/office/powerpoint/2010/main" val="1031961689"/>
       </p:ext>
     </p:extLst>
   </p:cSld>
@@ -13013,10 +13013,10 @@
       </p:grpSpPr>
       <p:sp>
         <p:nvSpPr>
-          <p:cNvPr id="13" name="">
-            <a:extLst xmlns:a="http://schemas.openxmlformats.org/drawingml/2006/main">
-              <a:ext uri="{FF2B5EF4-FFF2-40B4-BE49-F238E27FC236}">
-                <a16:creationId xmlns:a16="http://schemas.microsoft.com/office/drawing/2014/main" id="{8CF9CF6D-1FD6-4C5C-8889-09EB09AB6E6E}"/>
+          <p:cNvPr id="18" name="">
+            <a:extLst xmlns:a="http://schemas.openxmlformats.org/drawingml/2006/main">
+              <a:ext uri="{FF2B5EF4-FFF2-40B4-BE49-F238E27FC236}">
+                <a16:creationId xmlns:a16="http://schemas.microsoft.com/office/drawing/2014/main" id="{A344C7B0-34A7-4682-9F47-F8D636277B44}"/>
               </a:ext>
             </a:extLst>
           </p:cNvPr>
@@ -13084,7 +13084,7 @@
           <p:cNvPr id="2" name="">
             <a:extLst xmlns:a="http://schemas.openxmlformats.org/drawingml/2006/main">
               <a:ext uri="{FF2B5EF4-FFF2-40B4-BE49-F238E27FC236}">
-                <a16:creationId xmlns:a16="http://schemas.microsoft.com/office/drawing/2014/main" id="{1AE13B93-AAA5-4D9B-9ABB-7903573AD486}"/>
+                <a16:creationId xmlns:a16="http://schemas.microsoft.com/office/drawing/2014/main" id="{2331A884-CBCE-405D-A125-86632C2E1F25}"/>
               </a:ext>
             </a:extLst>
           </p:cNvPr>
@@ -13152,7 +13152,7 @@
           <p:cNvPr id="3" name="">
             <a:extLst xmlns:a="http://schemas.openxmlformats.org/drawingml/2006/main">
               <a:ext uri="{FF2B5EF4-FFF2-40B4-BE49-F238E27FC236}">
-                <a16:creationId xmlns:a16="http://schemas.microsoft.com/office/drawing/2014/main" id="{E54A854A-0013-4BD0-BEEE-5A8EC2B78D52}"/>
+                <a16:creationId xmlns:a16="http://schemas.microsoft.com/office/drawing/2014/main" id="{A2A00F13-9DFB-4F2D-B827-A20B0DA8C664}"/>
               </a:ext>
             </a:extLst>
           </p:cNvPr>
@@ -13220,7 +13220,7 @@
           <p:cNvPr id="4" name="">
             <a:extLst xmlns:a="http://schemas.openxmlformats.org/drawingml/2006/main">
               <a:ext uri="{FF2B5EF4-FFF2-40B4-BE49-F238E27FC236}">
-                <a16:creationId xmlns:a16="http://schemas.microsoft.com/office/drawing/2014/main" id="{D403CD17-2E0D-4953-AB4C-FE8538EB636C}"/>
+                <a16:creationId xmlns:a16="http://schemas.microsoft.com/office/drawing/2014/main" id="{3A3C2EAE-A5A6-4917-B2EA-FB261A3B4567}"/>
               </a:ext>
             </a:extLst>
           </p:cNvPr>
@@ -13230,13 +13230,13 @@
           <p:nvPr/>
         </p:nvPicPr>
         <p:blipFill>
-          <a:blip xmlns:r="http://schemas.openxmlformats.org/officeDocument/2006/relationships" xmlns:a="http://schemas.openxmlformats.org/drawingml/2006/main" r:embed="R263b3774c40a48c4"/>
+          <a:blip xmlns:r="http://schemas.openxmlformats.org/officeDocument/2006/relationships" xmlns:a="http://schemas.openxmlformats.org/drawingml/2006/main" r:embed="Rc0414607968545b1"/>
           <a:stretch xmlns:a="http://schemas.openxmlformats.org/drawingml/2006/main"/>
         </p:blipFill>
         <p:spPr>
           <a:xfrm xmlns:a="http://schemas.openxmlformats.org/drawingml/2006/main">
-            <a:off x="7715250" y="2905125"/>
-            <a:ext cx="2857500" cy="2857500"/>
+            <a:off x="7239635" y="2476500"/>
+            <a:ext cx="4094480" cy="1181100"/>
           </a:xfrm>
           <a:prstGeom xmlns:a="http://schemas.openxmlformats.org/drawingml/2006/main" prst="rect">
             <a:avLst/>
@@ -13248,7 +13248,153 @@
           <p:cNvPr id="5" name="">
             <a:extLst xmlns:a="http://schemas.openxmlformats.org/drawingml/2006/main">
               <a:ext uri="{FF2B5EF4-FFF2-40B4-BE49-F238E27FC236}">
-                <a16:creationId xmlns:a16="http://schemas.microsoft.com/office/drawing/2014/main" id="{956D73E6-5D5C-4707-8158-E0CCC8E06C14}"/>
+                <a16:creationId xmlns:a16="http://schemas.microsoft.com/office/drawing/2014/main" id="{4D09986F-9CFA-453E-8CBD-245B733DDF84}"/>
+              </a:ext>
+            </a:extLst>
+          </p:cNvPr>
+          <p:cNvSpPr>
+            <a:spLocks xmlns:a="http://schemas.openxmlformats.org/drawingml/2006/main" noGrp="1"/>
+          </p:cNvSpPr>
+          <p:nvPr/>
+        </p:nvSpPr>
+        <p:spPr>
+          <a:xfrm xmlns:a="http://schemas.openxmlformats.org/drawingml/2006/main">
+            <a:off x="6286500" y="3048000"/>
+            <a:ext cx="723900" cy="14288"/>
+          </a:xfrm>
+          <a:prstGeom xmlns:a="http://schemas.openxmlformats.org/drawingml/2006/main" prst="rect">
+            <a:avLst/>
+          </a:prstGeom>
+          <a:solidFill xmlns:a="http://schemas.openxmlformats.org/drawingml/2006/main">
+            <a:srgbClr val="756044"/>
+          </a:solidFill>
+          <a:ln xmlns:a="http://schemas.openxmlformats.org/drawingml/2006/main" w="0">
+            <a:noFill/>
+          </a:ln>
+        </p:spPr>
+      </p:sp>
+      <p:pic>
+        <p:nvPicPr>
+          <p:cNvPr id="6" name="">
+            <a:extLst xmlns:a="http://schemas.openxmlformats.org/drawingml/2006/main">
+              <a:ext uri="{FF2B5EF4-FFF2-40B4-BE49-F238E27FC236}">
+                <a16:creationId xmlns:a16="http://schemas.microsoft.com/office/drawing/2014/main" id="{AB0ACB8D-987E-421A-8AA2-5BE8E5A2CE61}"/>
+              </a:ext>
+            </a:extLst>
+          </p:cNvPr>
+          <p:cNvPicPr>
+            <a:picLocks xmlns:a="http://schemas.openxmlformats.org/drawingml/2006/main" noChangeAspect="1"/>
+          </p:cNvPicPr>
+          <p:nvPr/>
+        </p:nvPicPr>
+        <p:blipFill>
+          <a:blip xmlns:r="http://schemas.openxmlformats.org/officeDocument/2006/relationships" xmlns:a="http://schemas.openxmlformats.org/drawingml/2006/main" r:embed="R37ddfcd9e6b9412a"/>
+          <a:stretch xmlns:a="http://schemas.openxmlformats.org/drawingml/2006/main"/>
+        </p:blipFill>
+        <p:spPr>
+          <a:xfrm xmlns:a="http://schemas.openxmlformats.org/drawingml/2006/main">
+            <a:off x="7239635" y="3543300"/>
+            <a:ext cx="4094480" cy="1181100"/>
+          </a:xfrm>
+          <a:prstGeom xmlns:a="http://schemas.openxmlformats.org/drawingml/2006/main" prst="rect">
+            <a:avLst/>
+          </a:prstGeom>
+        </p:spPr>
+      </p:pic>
+      <p:sp>
+        <p:nvSpPr>
+          <p:cNvPr id="7" name="">
+            <a:extLst xmlns:a="http://schemas.openxmlformats.org/drawingml/2006/main">
+              <a:ext uri="{FF2B5EF4-FFF2-40B4-BE49-F238E27FC236}">
+                <a16:creationId xmlns:a16="http://schemas.microsoft.com/office/drawing/2014/main" id="{024CD3D5-5D08-4B49-8BEE-89137A96DFA3}"/>
+              </a:ext>
+            </a:extLst>
+          </p:cNvPr>
+          <p:cNvSpPr>
+            <a:spLocks xmlns:a="http://schemas.openxmlformats.org/drawingml/2006/main" noGrp="1"/>
+          </p:cNvSpPr>
+          <p:nvPr/>
+        </p:nvSpPr>
+        <p:spPr>
+          <a:xfrm xmlns:a="http://schemas.openxmlformats.org/drawingml/2006/main">
+            <a:off x="6286500" y="4114800"/>
+            <a:ext cx="723900" cy="14288"/>
+          </a:xfrm>
+          <a:prstGeom xmlns:a="http://schemas.openxmlformats.org/drawingml/2006/main" prst="rect">
+            <a:avLst/>
+          </a:prstGeom>
+          <a:solidFill xmlns:a="http://schemas.openxmlformats.org/drawingml/2006/main">
+            <a:srgbClr val="756044"/>
+          </a:solidFill>
+          <a:ln xmlns:a="http://schemas.openxmlformats.org/drawingml/2006/main" w="0">
+            <a:noFill/>
+          </a:ln>
+        </p:spPr>
+      </p:sp>
+      <p:pic>
+        <p:nvPicPr>
+          <p:cNvPr id="8" name="">
+            <a:extLst xmlns:a="http://schemas.openxmlformats.org/drawingml/2006/main">
+              <a:ext uri="{FF2B5EF4-FFF2-40B4-BE49-F238E27FC236}">
+                <a16:creationId xmlns:a16="http://schemas.microsoft.com/office/drawing/2014/main" id="{FAE6D244-A815-46BF-94B5-4567B6E94ADB}"/>
+              </a:ext>
+            </a:extLst>
+          </p:cNvPr>
+          <p:cNvPicPr>
+            <a:picLocks xmlns:a="http://schemas.openxmlformats.org/drawingml/2006/main" noChangeAspect="1"/>
+          </p:cNvPicPr>
+          <p:nvPr/>
+        </p:nvPicPr>
+        <p:blipFill>
+          <a:blip xmlns:r="http://schemas.openxmlformats.org/officeDocument/2006/relationships" xmlns:a="http://schemas.openxmlformats.org/drawingml/2006/main" r:embed="Rfddc3dcf4dd841c0"/>
+          <a:stretch xmlns:a="http://schemas.openxmlformats.org/drawingml/2006/main"/>
+        </p:blipFill>
+        <p:spPr>
+          <a:xfrm xmlns:a="http://schemas.openxmlformats.org/drawingml/2006/main">
+            <a:off x="7239635" y="4610100"/>
+            <a:ext cx="4094480" cy="1181100"/>
+          </a:xfrm>
+          <a:prstGeom xmlns:a="http://schemas.openxmlformats.org/drawingml/2006/main" prst="rect">
+            <a:avLst/>
+          </a:prstGeom>
+        </p:spPr>
+      </p:pic>
+      <p:sp>
+        <p:nvSpPr>
+          <p:cNvPr id="9" name="">
+            <a:extLst xmlns:a="http://schemas.openxmlformats.org/drawingml/2006/main">
+              <a:ext uri="{FF2B5EF4-FFF2-40B4-BE49-F238E27FC236}">
+                <a16:creationId xmlns:a16="http://schemas.microsoft.com/office/drawing/2014/main" id="{8F162A46-2BB0-4606-8EB3-057CD12B13AD}"/>
+              </a:ext>
+            </a:extLst>
+          </p:cNvPr>
+          <p:cNvSpPr>
+            <a:spLocks xmlns:a="http://schemas.openxmlformats.org/drawingml/2006/main" noGrp="1"/>
+          </p:cNvSpPr>
+          <p:nvPr/>
+        </p:nvSpPr>
+        <p:spPr>
+          <a:xfrm xmlns:a="http://schemas.openxmlformats.org/drawingml/2006/main">
+            <a:off x="6286500" y="5181600"/>
+            <a:ext cx="723900" cy="14288"/>
+          </a:xfrm>
+          <a:prstGeom xmlns:a="http://schemas.openxmlformats.org/drawingml/2006/main" prst="rect">
+            <a:avLst/>
+          </a:prstGeom>
+          <a:solidFill xmlns:a="http://schemas.openxmlformats.org/drawingml/2006/main">
+            <a:srgbClr val="756044"/>
+          </a:solidFill>
+          <a:ln xmlns:a="http://schemas.openxmlformats.org/drawingml/2006/main" w="0">
+            <a:noFill/>
+          </a:ln>
+        </p:spPr>
+      </p:sp>
+      <p:sp>
+        <p:nvSpPr>
+          <p:cNvPr id="10" name="">
+            <a:extLst xmlns:a="http://schemas.openxmlformats.org/drawingml/2006/main">
+              <a:ext uri="{FF2B5EF4-FFF2-40B4-BE49-F238E27FC236}">
+                <a16:creationId xmlns:a16="http://schemas.microsoft.com/office/drawing/2014/main" id="{DB7B5960-7C69-4E39-888B-1DA36C7778BA}"/>
               </a:ext>
             </a:extLst>
           </p:cNvPr>
@@ -13313,10 +13459,10 @@
       </p:sp>
       <p:sp>
         <p:nvSpPr>
-          <p:cNvPr id="6" name="">
-            <a:extLst xmlns:a="http://schemas.openxmlformats.org/drawingml/2006/main">
-              <a:ext uri="{FF2B5EF4-FFF2-40B4-BE49-F238E27FC236}">
-                <a16:creationId xmlns:a16="http://schemas.microsoft.com/office/drawing/2014/main" id="{BD05AF53-51F0-4796-A9DD-9C6FE95F18F9}"/>
+          <p:cNvPr id="11" name="">
+            <a:extLst xmlns:a="http://schemas.openxmlformats.org/drawingml/2006/main">
+              <a:ext uri="{FF2B5EF4-FFF2-40B4-BE49-F238E27FC236}">
+                <a16:creationId xmlns:a16="http://schemas.microsoft.com/office/drawing/2014/main" id="{B1EAF6BA-B90E-4782-8F31-5B975B4F9919}"/>
               </a:ext>
             </a:extLst>
           </p:cNvPr>
@@ -13381,10 +13527,10 @@
       </p:sp>
       <p:sp>
         <p:nvSpPr>
-          <p:cNvPr id="7" name="">
-            <a:extLst xmlns:a="http://schemas.openxmlformats.org/drawingml/2006/main">
-              <a:ext uri="{FF2B5EF4-FFF2-40B4-BE49-F238E27FC236}">
-                <a16:creationId xmlns:a16="http://schemas.microsoft.com/office/drawing/2014/main" id="{43D12CF0-71D0-4CF3-8DE8-1037E69E9E03}"/>
+          <p:cNvPr id="12" name="">
+            <a:extLst xmlns:a="http://schemas.openxmlformats.org/drawingml/2006/main">
+              <a:ext uri="{FF2B5EF4-FFF2-40B4-BE49-F238E27FC236}">
+                <a16:creationId xmlns:a16="http://schemas.microsoft.com/office/drawing/2014/main" id="{D3CBDCD8-0251-4138-9EB4-EA0FDE4312C4}"/>
               </a:ext>
             </a:extLst>
           </p:cNvPr>
@@ -13449,10 +13595,10 @@
       </p:sp>
       <p:sp>
         <p:nvSpPr>
-          <p:cNvPr id="8" name="">
-            <a:extLst xmlns:a="http://schemas.openxmlformats.org/drawingml/2006/main">
-              <a:ext uri="{FF2B5EF4-FFF2-40B4-BE49-F238E27FC236}">
-                <a16:creationId xmlns:a16="http://schemas.microsoft.com/office/drawing/2014/main" id="{59387683-9E92-4CA3-B232-9F9323EC37D5}"/>
+          <p:cNvPr id="13" name="">
+            <a:extLst xmlns:a="http://schemas.openxmlformats.org/drawingml/2006/main">
+              <a:ext uri="{FF2B5EF4-FFF2-40B4-BE49-F238E27FC236}">
+                <a16:creationId xmlns:a16="http://schemas.microsoft.com/office/drawing/2014/main" id="{23B1E50C-A5C5-44C2-9429-F2D3701DF73D}"/>
               </a:ext>
             </a:extLst>
           </p:cNvPr>
@@ -13517,10 +13663,10 @@
       </p:sp>
       <p:sp>
         <p:nvSpPr>
-          <p:cNvPr id="9" name="">
-            <a:extLst xmlns:a="http://schemas.openxmlformats.org/drawingml/2006/main">
-              <a:ext uri="{FF2B5EF4-FFF2-40B4-BE49-F238E27FC236}">
-                <a16:creationId xmlns:a16="http://schemas.microsoft.com/office/drawing/2014/main" id="{1FFA4F4C-9FD6-4293-8862-BBD0D0518D11}"/>
+          <p:cNvPr id="14" name="">
+            <a:extLst xmlns:a="http://schemas.openxmlformats.org/drawingml/2006/main">
+              <a:ext uri="{FF2B5EF4-FFF2-40B4-BE49-F238E27FC236}">
+                <a16:creationId xmlns:a16="http://schemas.microsoft.com/office/drawing/2014/main" id="{2CBCA6D7-5AF6-450B-9FCC-80783434F986}"/>
               </a:ext>
             </a:extLst>
           </p:cNvPr>
@@ -13585,10 +13731,10 @@
       </p:sp>
       <p:sp>
         <p:nvSpPr>
-          <p:cNvPr id="10" name="">
-            <a:extLst xmlns:a="http://schemas.openxmlformats.org/drawingml/2006/main">
-              <a:ext uri="{FF2B5EF4-FFF2-40B4-BE49-F238E27FC236}">
-                <a16:creationId xmlns:a16="http://schemas.microsoft.com/office/drawing/2014/main" id="{38047F67-ED3C-4128-A06C-2E47C0B7DB64}"/>
+          <p:cNvPr id="15" name="">
+            <a:extLst xmlns:a="http://schemas.openxmlformats.org/drawingml/2006/main">
+              <a:ext uri="{FF2B5EF4-FFF2-40B4-BE49-F238E27FC236}">
+                <a16:creationId xmlns:a16="http://schemas.microsoft.com/office/drawing/2014/main" id="{F0E30C0F-18C7-408E-959D-F8EF58F1BB3B}"/>
               </a:ext>
             </a:extLst>
           </p:cNvPr>
@@ -13653,10 +13799,10 @@
       </p:sp>
       <p:sp>
         <p:nvSpPr>
-          <p:cNvPr id="11" name="">
-            <a:extLst xmlns:a="http://schemas.openxmlformats.org/drawingml/2006/main">
-              <a:ext uri="{FF2B5EF4-FFF2-40B4-BE49-F238E27FC236}">
-                <a16:creationId xmlns:a16="http://schemas.microsoft.com/office/drawing/2014/main" id="{4605CBEB-EEE4-4052-B2A2-6511AB7A0CF8}"/>
+          <p:cNvPr id="16" name="">
+            <a:extLst xmlns:a="http://schemas.openxmlformats.org/drawingml/2006/main">
+              <a:ext uri="{FF2B5EF4-FFF2-40B4-BE49-F238E27FC236}">
+                <a16:creationId xmlns:a16="http://schemas.microsoft.com/office/drawing/2014/main" id="{13E5B1F0-D17A-495F-9894-3D2FDA5B33CA}"/>
               </a:ext>
             </a:extLst>
           </p:cNvPr>
@@ -13721,10 +13867,10 @@
       </p:sp>
       <p:sp>
         <p:nvSpPr>
-          <p:cNvPr id="12" name="">
-            <a:extLst xmlns:a="http://schemas.openxmlformats.org/drawingml/2006/main">
-              <a:ext uri="{FF2B5EF4-FFF2-40B4-BE49-F238E27FC236}">
-                <a16:creationId xmlns:a16="http://schemas.microsoft.com/office/drawing/2014/main" id="{30776D97-92F5-4893-B830-AE65E045F12A}"/>
+          <p:cNvPr id="17" name="">
+            <a:extLst xmlns:a="http://schemas.openxmlformats.org/drawingml/2006/main">
+              <a:ext uri="{FF2B5EF4-FFF2-40B4-BE49-F238E27FC236}">
+                <a16:creationId xmlns:a16="http://schemas.microsoft.com/office/drawing/2014/main" id="{5F041495-FB6C-409E-A510-C9183F3CACA8}"/>
               </a:ext>
             </a:extLst>
           </p:cNvPr>
@@ -13790,7 +13936,7 @@
     </p:spTree>
     <p:extLst>
       <p:ext uri="{BB962C8B-B14F-4D97-AF65-F5344CB8AC3E}">
-        <p14:creationId xmlns:p14="http://schemas.microsoft.com/office/powerpoint/2010/main" val="887001085"/>
+        <p14:creationId xmlns:p14="http://schemas.microsoft.com/office/powerpoint/2010/main" val="705770492"/>
       </p:ext>
     </p:extLst>
   </p:cSld>
@@ -13821,7 +13967,7 @@
           <p:cNvPr id="18" name="">
             <a:extLst xmlns:a="http://schemas.openxmlformats.org/drawingml/2006/main">
               <a:ext uri="{FF2B5EF4-FFF2-40B4-BE49-F238E27FC236}">
-                <a16:creationId xmlns:a16="http://schemas.microsoft.com/office/drawing/2014/main" id="{CD5FB708-DA12-42DE-ACBA-1E1467CFF105}"/>
+                <a16:creationId xmlns:a16="http://schemas.microsoft.com/office/drawing/2014/main" id="{EC24EF0A-5C9E-4AD1-B587-9AEAEF720239}"/>
               </a:ext>
             </a:extLst>
           </p:cNvPr>
@@ -13889,7 +14035,7 @@
           <p:cNvPr id="2" name="">
             <a:extLst xmlns:a="http://schemas.openxmlformats.org/drawingml/2006/main">
               <a:ext uri="{FF2B5EF4-FFF2-40B4-BE49-F238E27FC236}">
-                <a16:creationId xmlns:a16="http://schemas.microsoft.com/office/drawing/2014/main" id="{4CAD59B2-3002-41F7-8BAC-7EBF6B8CBB9E}"/>
+                <a16:creationId xmlns:a16="http://schemas.microsoft.com/office/drawing/2014/main" id="{D23E2C0B-0CFB-4D01-879F-2E777D1B693E}"/>
               </a:ext>
             </a:extLst>
           </p:cNvPr>
@@ -13957,7 +14103,7 @@
           <p:cNvPr id="3" name="">
             <a:extLst xmlns:a="http://schemas.openxmlformats.org/drawingml/2006/main">
               <a:ext uri="{FF2B5EF4-FFF2-40B4-BE49-F238E27FC236}">
-                <a16:creationId xmlns:a16="http://schemas.microsoft.com/office/drawing/2014/main" id="{6AF8339F-CC0D-4042-8C7B-91015EA126E6}"/>
+                <a16:creationId xmlns:a16="http://schemas.microsoft.com/office/drawing/2014/main" id="{DCFFB908-9A8A-431F-B454-035B1E950454}"/>
               </a:ext>
             </a:extLst>
           </p:cNvPr>
@@ -14025,7 +14171,7 @@
           <p:cNvPr id="4" name="">
             <a:extLst xmlns:a="http://schemas.openxmlformats.org/drawingml/2006/main">
               <a:ext uri="{FF2B5EF4-FFF2-40B4-BE49-F238E27FC236}">
-                <a16:creationId xmlns:a16="http://schemas.microsoft.com/office/drawing/2014/main" id="{77350536-4C17-47A3-B89F-98AF5C4AB222}"/>
+                <a16:creationId xmlns:a16="http://schemas.microsoft.com/office/drawing/2014/main" id="{8ECC2B73-4035-44D1-A0F9-D83005138F67}"/>
               </a:ext>
             </a:extLst>
           </p:cNvPr>
@@ -14093,7 +14239,7 @@
           <p:cNvPr id="5" name="">
             <a:extLst xmlns:a="http://schemas.openxmlformats.org/drawingml/2006/main">
               <a:ext uri="{FF2B5EF4-FFF2-40B4-BE49-F238E27FC236}">
-                <a16:creationId xmlns:a16="http://schemas.microsoft.com/office/drawing/2014/main" id="{9A55CCF6-94D0-4685-AE0B-11B2073D81FF}"/>
+                <a16:creationId xmlns:a16="http://schemas.microsoft.com/office/drawing/2014/main" id="{708C9DA5-AD8E-4E88-853A-F43EB46449DE}"/>
               </a:ext>
             </a:extLst>
           </p:cNvPr>
@@ -14161,7 +14307,7 @@
           <p:cNvPr id="6" name="">
             <a:extLst xmlns:a="http://schemas.openxmlformats.org/drawingml/2006/main">
               <a:ext uri="{FF2B5EF4-FFF2-40B4-BE49-F238E27FC236}">
-                <a16:creationId xmlns:a16="http://schemas.microsoft.com/office/drawing/2014/main" id="{30D1D93D-6831-4311-A1FC-D25C73D809E4}"/>
+                <a16:creationId xmlns:a16="http://schemas.microsoft.com/office/drawing/2014/main" id="{3C183104-2130-4AFE-AB16-CE62777F4619}"/>
               </a:ext>
             </a:extLst>
           </p:cNvPr>
@@ -14229,7 +14375,7 @@
           <p:cNvPr id="7" name="">
             <a:extLst xmlns:a="http://schemas.openxmlformats.org/drawingml/2006/main">
               <a:ext uri="{FF2B5EF4-FFF2-40B4-BE49-F238E27FC236}">
-                <a16:creationId xmlns:a16="http://schemas.microsoft.com/office/drawing/2014/main" id="{2F9DA1A0-8D54-4D5F-9AB3-B8A0503C740D}"/>
+                <a16:creationId xmlns:a16="http://schemas.microsoft.com/office/drawing/2014/main" id="{1A4DABC3-4809-4735-8080-BFEEBC11719B}"/>
               </a:ext>
             </a:extLst>
           </p:cNvPr>
@@ -14297,7 +14443,7 @@
           <p:cNvPr id="8" name="">
             <a:extLst xmlns:a="http://schemas.openxmlformats.org/drawingml/2006/main">
               <a:ext uri="{FF2B5EF4-FFF2-40B4-BE49-F238E27FC236}">
-                <a16:creationId xmlns:a16="http://schemas.microsoft.com/office/drawing/2014/main" id="{A5E3B957-22AA-4796-8975-7F843F0277A8}"/>
+                <a16:creationId xmlns:a16="http://schemas.microsoft.com/office/drawing/2014/main" id="{1B8CD272-0B3C-4B88-92CE-E0DCCE0F557F}"/>
               </a:ext>
             </a:extLst>
           </p:cNvPr>
@@ -14365,7 +14511,7 @@
           <p:cNvPr id="9" name="">
             <a:extLst xmlns:a="http://schemas.openxmlformats.org/drawingml/2006/main">
               <a:ext uri="{FF2B5EF4-FFF2-40B4-BE49-F238E27FC236}">
-                <a16:creationId xmlns:a16="http://schemas.microsoft.com/office/drawing/2014/main" id="{511265B3-71AB-4D69-B106-91E8B3F49C00}"/>
+                <a16:creationId xmlns:a16="http://schemas.microsoft.com/office/drawing/2014/main" id="{1C30295A-DDBF-45D4-9D91-3B00DD9D8332}"/>
               </a:ext>
             </a:extLst>
           </p:cNvPr>
@@ -14433,7 +14579,7 @@
           <p:cNvPr id="10" name="">
             <a:extLst xmlns:a="http://schemas.openxmlformats.org/drawingml/2006/main">
               <a:ext uri="{FF2B5EF4-FFF2-40B4-BE49-F238E27FC236}">
-                <a16:creationId xmlns:a16="http://schemas.microsoft.com/office/drawing/2014/main" id="{15FC27B1-54E8-4DBF-BE6E-0CF2631C3BF5}"/>
+                <a16:creationId xmlns:a16="http://schemas.microsoft.com/office/drawing/2014/main" id="{9469DD04-0C2C-41B0-BEC9-6441638F13A7}"/>
               </a:ext>
             </a:extLst>
           </p:cNvPr>
@@ -14501,7 +14647,7 @@
           <p:cNvPr id="11" name="">
             <a:extLst xmlns:a="http://schemas.openxmlformats.org/drawingml/2006/main">
               <a:ext uri="{FF2B5EF4-FFF2-40B4-BE49-F238E27FC236}">
-                <a16:creationId xmlns:a16="http://schemas.microsoft.com/office/drawing/2014/main" id="{5C1FF43D-4603-4A42-9103-EB6904FB0624}"/>
+                <a16:creationId xmlns:a16="http://schemas.microsoft.com/office/drawing/2014/main" id="{182D384B-F136-46D6-9ECE-A3C6624579E7}"/>
               </a:ext>
             </a:extLst>
           </p:cNvPr>
@@ -14569,7 +14715,7 @@
           <p:cNvPr id="12" name="">
             <a:extLst xmlns:a="http://schemas.openxmlformats.org/drawingml/2006/main">
               <a:ext uri="{FF2B5EF4-FFF2-40B4-BE49-F238E27FC236}">
-                <a16:creationId xmlns:a16="http://schemas.microsoft.com/office/drawing/2014/main" id="{09700A96-2F29-4576-8E57-85605C8FB16B}"/>
+                <a16:creationId xmlns:a16="http://schemas.microsoft.com/office/drawing/2014/main" id="{42E94D85-50B2-40DB-A0CA-28E3BFCFD3AC}"/>
               </a:ext>
             </a:extLst>
           </p:cNvPr>
@@ -14637,7 +14783,7 @@
           <p:cNvPr id="13" name="">
             <a:extLst xmlns:a="http://schemas.openxmlformats.org/drawingml/2006/main">
               <a:ext uri="{FF2B5EF4-FFF2-40B4-BE49-F238E27FC236}">
-                <a16:creationId xmlns:a16="http://schemas.microsoft.com/office/drawing/2014/main" id="{EF38C50C-5794-4E34-991D-472C7D4E31DA}"/>
+                <a16:creationId xmlns:a16="http://schemas.microsoft.com/office/drawing/2014/main" id="{D8E37DC4-4309-4CE8-A58F-CAF4D41D2C0A}"/>
               </a:ext>
             </a:extLst>
           </p:cNvPr>
@@ -14705,7 +14851,7 @@
           <p:cNvPr id="14" name="">
             <a:extLst xmlns:a="http://schemas.openxmlformats.org/drawingml/2006/main">
               <a:ext uri="{FF2B5EF4-FFF2-40B4-BE49-F238E27FC236}">
-                <a16:creationId xmlns:a16="http://schemas.microsoft.com/office/drawing/2014/main" id="{11FA34E3-F273-457D-A9F9-1C2B51BD2193}"/>
+                <a16:creationId xmlns:a16="http://schemas.microsoft.com/office/drawing/2014/main" id="{A6EDE9F8-4449-46B2-8728-21B394C9F498}"/>
               </a:ext>
             </a:extLst>
           </p:cNvPr>
@@ -14773,7 +14919,7 @@
           <p:cNvPr id="15" name="">
             <a:extLst xmlns:a="http://schemas.openxmlformats.org/drawingml/2006/main">
               <a:ext uri="{FF2B5EF4-FFF2-40B4-BE49-F238E27FC236}">
-                <a16:creationId xmlns:a16="http://schemas.microsoft.com/office/drawing/2014/main" id="{98F06042-8DF8-4B07-97C7-6F9F8DEA8965}"/>
+                <a16:creationId xmlns:a16="http://schemas.microsoft.com/office/drawing/2014/main" id="{11634886-7E15-41AB-A97F-B1B31EB88BF0}"/>
               </a:ext>
             </a:extLst>
           </p:cNvPr>
@@ -14841,7 +14987,7 @@
           <p:cNvPr id="16" name="">
             <a:extLst xmlns:a="http://schemas.openxmlformats.org/drawingml/2006/main">
               <a:ext uri="{FF2B5EF4-FFF2-40B4-BE49-F238E27FC236}">
-                <a16:creationId xmlns:a16="http://schemas.microsoft.com/office/drawing/2014/main" id="{29012A7E-8443-431A-991F-80710937946D}"/>
+                <a16:creationId xmlns:a16="http://schemas.microsoft.com/office/drawing/2014/main" id="{C7372B44-896E-48C6-B28F-9CB49EB379FB}"/>
               </a:ext>
             </a:extLst>
           </p:cNvPr>
@@ -14909,7 +15055,7 @@
           <p:cNvPr id="17" name="">
             <a:extLst xmlns:a="http://schemas.openxmlformats.org/drawingml/2006/main">
               <a:ext uri="{FF2B5EF4-FFF2-40B4-BE49-F238E27FC236}">
-                <a16:creationId xmlns:a16="http://schemas.microsoft.com/office/drawing/2014/main" id="{577D67E9-5904-4B43-8C2C-A8F34E1E3988}"/>
+                <a16:creationId xmlns:a16="http://schemas.microsoft.com/office/drawing/2014/main" id="{665D4EBB-81C4-4983-BE18-46F4F1707F1E}"/>
               </a:ext>
             </a:extLst>
           </p:cNvPr>
@@ -14975,7 +15121,7 @@
     </p:spTree>
     <p:extLst>
       <p:ext uri="{BB962C8B-B14F-4D97-AF65-F5344CB8AC3E}">
-        <p14:creationId xmlns:p14="http://schemas.microsoft.com/office/powerpoint/2010/main" val="1731175648"/>
+        <p14:creationId xmlns:p14="http://schemas.microsoft.com/office/powerpoint/2010/main" val="2116570834"/>
       </p:ext>
     </p:extLst>
   </p:cSld>
@@ -15006,7 +15152,7 @@
           <p:cNvPr id="16" name="">
             <a:extLst xmlns:a="http://schemas.openxmlformats.org/drawingml/2006/main">
               <a:ext uri="{FF2B5EF4-FFF2-40B4-BE49-F238E27FC236}">
-                <a16:creationId xmlns:a16="http://schemas.microsoft.com/office/drawing/2014/main" id="{0278F38F-58CA-410E-88CD-95FD54442E2E}"/>
+                <a16:creationId xmlns:a16="http://schemas.microsoft.com/office/drawing/2014/main" id="{E4867B40-5E06-487A-8F0B-95C70D8E243B}"/>
               </a:ext>
             </a:extLst>
           </p:cNvPr>
@@ -15074,7 +15220,7 @@
           <p:cNvPr id="2" name="">
             <a:extLst xmlns:a="http://schemas.openxmlformats.org/drawingml/2006/main">
               <a:ext uri="{FF2B5EF4-FFF2-40B4-BE49-F238E27FC236}">
-                <a16:creationId xmlns:a16="http://schemas.microsoft.com/office/drawing/2014/main" id="{00EC0B38-BBD7-4BE7-ABE1-6B7BD0EEC6DF}"/>
+                <a16:creationId xmlns:a16="http://schemas.microsoft.com/office/drawing/2014/main" id="{3D91D663-C1EB-4887-B659-01C3A87364E2}"/>
               </a:ext>
             </a:extLst>
           </p:cNvPr>
@@ -15142,7 +15288,7 @@
           <p:cNvPr id="3" name="">
             <a:extLst xmlns:a="http://schemas.openxmlformats.org/drawingml/2006/main">
               <a:ext uri="{FF2B5EF4-FFF2-40B4-BE49-F238E27FC236}">
-                <a16:creationId xmlns:a16="http://schemas.microsoft.com/office/drawing/2014/main" id="{6AA7CB33-2B15-4495-8D18-70DC339CA4CF}"/>
+                <a16:creationId xmlns:a16="http://schemas.microsoft.com/office/drawing/2014/main" id="{C0948B10-87F5-4D63-B71E-94F0DF515F5A}"/>
               </a:ext>
             </a:extLst>
           </p:cNvPr>
@@ -15210,7 +15356,7 @@
           <p:cNvPr id="4" name="">
             <a:extLst xmlns:a="http://schemas.openxmlformats.org/drawingml/2006/main">
               <a:ext uri="{FF2B5EF4-FFF2-40B4-BE49-F238E27FC236}">
-                <a16:creationId xmlns:a16="http://schemas.microsoft.com/office/drawing/2014/main" id="{1B9B2819-499B-4241-AFE3-A1364E1B7B64}"/>
+                <a16:creationId xmlns:a16="http://schemas.microsoft.com/office/drawing/2014/main" id="{70EB8B92-33E6-4802-88BC-BE709A42D363}"/>
               </a:ext>
             </a:extLst>
           </p:cNvPr>
@@ -15278,7 +15424,7 @@
           <p:cNvPr id="5" name="">
             <a:extLst xmlns:a="http://schemas.openxmlformats.org/drawingml/2006/main">
               <a:ext uri="{FF2B5EF4-FFF2-40B4-BE49-F238E27FC236}">
-                <a16:creationId xmlns:a16="http://schemas.microsoft.com/office/drawing/2014/main" id="{85A9A2FA-7484-45F7-8258-8057F3871B0B}"/>
+                <a16:creationId xmlns:a16="http://schemas.microsoft.com/office/drawing/2014/main" id="{1F1C3852-86E0-4BDD-8341-07BEAD8B8377}"/>
               </a:ext>
             </a:extLst>
           </p:cNvPr>
@@ -15346,7 +15492,7 @@
           <p:cNvPr id="6" name="">
             <a:extLst xmlns:a="http://schemas.openxmlformats.org/drawingml/2006/main">
               <a:ext uri="{FF2B5EF4-FFF2-40B4-BE49-F238E27FC236}">
-                <a16:creationId xmlns:a16="http://schemas.microsoft.com/office/drawing/2014/main" id="{1AEE44D8-43F2-49C6-83AE-52EC70BEEEF9}"/>
+                <a16:creationId xmlns:a16="http://schemas.microsoft.com/office/drawing/2014/main" id="{4B1F20C8-CB8F-4080-BF73-74095D477402}"/>
               </a:ext>
             </a:extLst>
           </p:cNvPr>
@@ -15414,7 +15560,7 @@
           <p:cNvPr id="7" name="">
             <a:extLst xmlns:a="http://schemas.openxmlformats.org/drawingml/2006/main">
               <a:ext uri="{FF2B5EF4-FFF2-40B4-BE49-F238E27FC236}">
-                <a16:creationId xmlns:a16="http://schemas.microsoft.com/office/drawing/2014/main" id="{571C1F4C-FE7B-4D8A-8B05-A454F183E270}"/>
+                <a16:creationId xmlns:a16="http://schemas.microsoft.com/office/drawing/2014/main" id="{9695585F-E7F8-4E19-9891-D6D1A90F847D}"/>
               </a:ext>
             </a:extLst>
           </p:cNvPr>
@@ -15482,7 +15628,7 @@
           <p:cNvPr id="8" name="">
             <a:extLst xmlns:a="http://schemas.openxmlformats.org/drawingml/2006/main">
               <a:ext uri="{FF2B5EF4-FFF2-40B4-BE49-F238E27FC236}">
-                <a16:creationId xmlns:a16="http://schemas.microsoft.com/office/drawing/2014/main" id="{F4F04FEC-C692-4789-A0BE-90195C66BA27}"/>
+                <a16:creationId xmlns:a16="http://schemas.microsoft.com/office/drawing/2014/main" id="{98DF6B0A-0911-4501-BD31-DAF40B1FE38C}"/>
               </a:ext>
             </a:extLst>
           </p:cNvPr>
@@ -15550,7 +15696,7 @@
           <p:cNvPr id="9" name="">
             <a:extLst xmlns:a="http://schemas.openxmlformats.org/drawingml/2006/main">
               <a:ext uri="{FF2B5EF4-FFF2-40B4-BE49-F238E27FC236}">
-                <a16:creationId xmlns:a16="http://schemas.microsoft.com/office/drawing/2014/main" id="{03C3B214-643F-46B2-9162-732257C34C40}"/>
+                <a16:creationId xmlns:a16="http://schemas.microsoft.com/office/drawing/2014/main" id="{EF602E10-4B62-4F64-8BD7-E9EBFEA4621D}"/>
               </a:ext>
             </a:extLst>
           </p:cNvPr>
@@ -15618,7 +15764,7 @@
           <p:cNvPr id="10" name="">
             <a:extLst xmlns:a="http://schemas.openxmlformats.org/drawingml/2006/main">
               <a:ext uri="{FF2B5EF4-FFF2-40B4-BE49-F238E27FC236}">
-                <a16:creationId xmlns:a16="http://schemas.microsoft.com/office/drawing/2014/main" id="{DB3D8A36-0D25-4D69-9A66-7C3093723E46}"/>
+                <a16:creationId xmlns:a16="http://schemas.microsoft.com/office/drawing/2014/main" id="{07594581-0EF3-4F0C-B467-976C4C8679EC}"/>
               </a:ext>
             </a:extLst>
           </p:cNvPr>
@@ -15686,7 +15832,7 @@
           <p:cNvPr id="11" name="">
             <a:extLst xmlns:a="http://schemas.openxmlformats.org/drawingml/2006/main">
               <a:ext uri="{FF2B5EF4-FFF2-40B4-BE49-F238E27FC236}">
-                <a16:creationId xmlns:a16="http://schemas.microsoft.com/office/drawing/2014/main" id="{1C6BC059-EBA1-4283-A261-5186BE63F1BE}"/>
+                <a16:creationId xmlns:a16="http://schemas.microsoft.com/office/drawing/2014/main" id="{48E3F636-73C2-40BB-9136-529A178D03AF}"/>
               </a:ext>
             </a:extLst>
           </p:cNvPr>
@@ -15754,7 +15900,7 @@
           <p:cNvPr id="12" name="">
             <a:extLst xmlns:a="http://schemas.openxmlformats.org/drawingml/2006/main">
               <a:ext uri="{FF2B5EF4-FFF2-40B4-BE49-F238E27FC236}">
-                <a16:creationId xmlns:a16="http://schemas.microsoft.com/office/drawing/2014/main" id="{CDF702CC-27F2-4FFD-A570-CD323A76E150}"/>
+                <a16:creationId xmlns:a16="http://schemas.microsoft.com/office/drawing/2014/main" id="{BACF4211-5F80-44A4-A72F-B4D33C08316A}"/>
               </a:ext>
             </a:extLst>
           </p:cNvPr>
@@ -15822,7 +15968,7 @@
           <p:cNvPr id="13" name="">
             <a:extLst xmlns:a="http://schemas.openxmlformats.org/drawingml/2006/main">
               <a:ext uri="{FF2B5EF4-FFF2-40B4-BE49-F238E27FC236}">
-                <a16:creationId xmlns:a16="http://schemas.microsoft.com/office/drawing/2014/main" id="{8B33C2AF-8E04-4A52-9076-A788B957DCB6}"/>
+                <a16:creationId xmlns:a16="http://schemas.microsoft.com/office/drawing/2014/main" id="{2752DE63-0BF3-446E-9FE5-21A82B0F5521}"/>
               </a:ext>
             </a:extLst>
           </p:cNvPr>
@@ -15890,7 +16036,7 @@
           <p:cNvPr id="14" name="">
             <a:extLst xmlns:a="http://schemas.openxmlformats.org/drawingml/2006/main">
               <a:ext uri="{FF2B5EF4-FFF2-40B4-BE49-F238E27FC236}">
-                <a16:creationId xmlns:a16="http://schemas.microsoft.com/office/drawing/2014/main" id="{06EB16CA-72DA-48BD-92B2-E1CBC5FAB233}"/>
+                <a16:creationId xmlns:a16="http://schemas.microsoft.com/office/drawing/2014/main" id="{B157BCCC-2D7A-4CD4-AE4C-C7E1F1908893}"/>
               </a:ext>
             </a:extLst>
           </p:cNvPr>
@@ -15958,7 +16104,7 @@
           <p:cNvPr id="15" name="">
             <a:extLst xmlns:a="http://schemas.openxmlformats.org/drawingml/2006/main">
               <a:ext uri="{FF2B5EF4-FFF2-40B4-BE49-F238E27FC236}">
-                <a16:creationId xmlns:a16="http://schemas.microsoft.com/office/drawing/2014/main" id="{ABA581BF-59DE-44C6-9F0B-CC19F56143B6}"/>
+                <a16:creationId xmlns:a16="http://schemas.microsoft.com/office/drawing/2014/main" id="{9F93A989-1288-4AD9-B6AC-A8E07962CD18}"/>
               </a:ext>
             </a:extLst>
           </p:cNvPr>
@@ -16024,7 +16170,7 @@
     </p:spTree>
     <p:extLst>
       <p:ext uri="{BB962C8B-B14F-4D97-AF65-F5344CB8AC3E}">
-        <p14:creationId xmlns:p14="http://schemas.microsoft.com/office/powerpoint/2010/main" val="1374290691"/>
+        <p14:creationId xmlns:p14="http://schemas.microsoft.com/office/powerpoint/2010/main" val="154041786"/>
       </p:ext>
     </p:extLst>
   </p:cSld>
@@ -16055,7 +16201,7 @@
           <p:cNvPr id="18" name="">
             <a:extLst xmlns:a="http://schemas.openxmlformats.org/drawingml/2006/main">
               <a:ext uri="{FF2B5EF4-FFF2-40B4-BE49-F238E27FC236}">
-                <a16:creationId xmlns:a16="http://schemas.microsoft.com/office/drawing/2014/main" id="{68415365-8941-4123-90DD-8113BD82E891}"/>
+                <a16:creationId xmlns:a16="http://schemas.microsoft.com/office/drawing/2014/main" id="{26E39644-5D59-4191-8CCC-130D9551B854}"/>
               </a:ext>
             </a:extLst>
           </p:cNvPr>
@@ -16123,7 +16269,7 @@
           <p:cNvPr id="2" name="">
             <a:extLst xmlns:a="http://schemas.openxmlformats.org/drawingml/2006/main">
               <a:ext uri="{FF2B5EF4-FFF2-40B4-BE49-F238E27FC236}">
-                <a16:creationId xmlns:a16="http://schemas.microsoft.com/office/drawing/2014/main" id="{96976D4D-1462-4152-8E80-8E4D0A0E270F}"/>
+                <a16:creationId xmlns:a16="http://schemas.microsoft.com/office/drawing/2014/main" id="{A9816FE3-49B9-41D4-8635-23ACACBBC8BD}"/>
               </a:ext>
             </a:extLst>
           </p:cNvPr>
@@ -16191,7 +16337,7 @@
           <p:cNvPr id="3" name="">
             <a:extLst xmlns:a="http://schemas.openxmlformats.org/drawingml/2006/main">
               <a:ext uri="{FF2B5EF4-FFF2-40B4-BE49-F238E27FC236}">
-                <a16:creationId xmlns:a16="http://schemas.microsoft.com/office/drawing/2014/main" id="{1FD77688-BC88-4E9C-8077-F3B8700374BD}"/>
+                <a16:creationId xmlns:a16="http://schemas.microsoft.com/office/drawing/2014/main" id="{55EDBD21-A696-481A-908E-0847A002A133}"/>
               </a:ext>
             </a:extLst>
           </p:cNvPr>
@@ -16259,7 +16405,7 @@
           <p:cNvPr id="4" name="">
             <a:extLst xmlns:a="http://schemas.openxmlformats.org/drawingml/2006/main">
               <a:ext uri="{FF2B5EF4-FFF2-40B4-BE49-F238E27FC236}">
-                <a16:creationId xmlns:a16="http://schemas.microsoft.com/office/drawing/2014/main" id="{584A18EF-7370-42DF-9163-69A5FC8C70A4}"/>
+                <a16:creationId xmlns:a16="http://schemas.microsoft.com/office/drawing/2014/main" id="{93AB7FAA-FA17-4762-8F3B-7E15A1661384}"/>
               </a:ext>
             </a:extLst>
           </p:cNvPr>
@@ -16289,7 +16435,7 @@
           <p:cNvPr id="5" name="">
             <a:extLst xmlns:a="http://schemas.openxmlformats.org/drawingml/2006/main">
               <a:ext uri="{FF2B5EF4-FFF2-40B4-BE49-F238E27FC236}">
-                <a16:creationId xmlns:a16="http://schemas.microsoft.com/office/drawing/2014/main" id="{D63B32E1-BEE6-4F76-A505-633F1B1C9AD6}"/>
+                <a16:creationId xmlns:a16="http://schemas.microsoft.com/office/drawing/2014/main" id="{15DF39C6-F3A4-47ED-ACB0-BD33C4749766}"/>
               </a:ext>
             </a:extLst>
           </p:cNvPr>
@@ -16357,7 +16503,7 @@
           <p:cNvPr id="6" name="">
             <a:extLst xmlns:a="http://schemas.openxmlformats.org/drawingml/2006/main">
               <a:ext uri="{FF2B5EF4-FFF2-40B4-BE49-F238E27FC236}">
-                <a16:creationId xmlns:a16="http://schemas.microsoft.com/office/drawing/2014/main" id="{3EC86474-9EE8-4091-9EBD-DD74F2E577CA}"/>
+                <a16:creationId xmlns:a16="http://schemas.microsoft.com/office/drawing/2014/main" id="{52154977-F34A-4010-9491-6AE1223D27A7}"/>
               </a:ext>
             </a:extLst>
           </p:cNvPr>
@@ -16425,7 +16571,7 @@
           <p:cNvPr id="7" name="">
             <a:extLst xmlns:a="http://schemas.openxmlformats.org/drawingml/2006/main">
               <a:ext uri="{FF2B5EF4-FFF2-40B4-BE49-F238E27FC236}">
-                <a16:creationId xmlns:a16="http://schemas.microsoft.com/office/drawing/2014/main" id="{49A56091-B6DA-48EE-B70D-B91F20E009E2}"/>
+                <a16:creationId xmlns:a16="http://schemas.microsoft.com/office/drawing/2014/main" id="{5EA71610-2857-4017-A6DA-833A7B868555}"/>
               </a:ext>
             </a:extLst>
           </p:cNvPr>
@@ -16516,7 +16662,7 @@
           <p:cNvPr id="8" name="">
             <a:extLst xmlns:a="http://schemas.openxmlformats.org/drawingml/2006/main">
               <a:ext uri="{FF2B5EF4-FFF2-40B4-BE49-F238E27FC236}">
-                <a16:creationId xmlns:a16="http://schemas.microsoft.com/office/drawing/2014/main" id="{9779C4EC-C34B-45F4-82B3-0786E3B865ED}"/>
+                <a16:creationId xmlns:a16="http://schemas.microsoft.com/office/drawing/2014/main" id="{7AC0AAFB-C2A8-4136-A5FA-7915558C72BA}"/>
               </a:ext>
             </a:extLst>
           </p:cNvPr>
@@ -16546,7 +16692,7 @@
           <p:cNvPr id="9" name="">
             <a:extLst xmlns:a="http://schemas.openxmlformats.org/drawingml/2006/main">
               <a:ext uri="{FF2B5EF4-FFF2-40B4-BE49-F238E27FC236}">
-                <a16:creationId xmlns:a16="http://schemas.microsoft.com/office/drawing/2014/main" id="{1757CF9D-8EB6-4B89-9FAF-3DEF2278C74A}"/>
+                <a16:creationId xmlns:a16="http://schemas.microsoft.com/office/drawing/2014/main" id="{028731BE-AA27-42BC-B8B3-59E25667386C}"/>
               </a:ext>
             </a:extLst>
           </p:cNvPr>
@@ -16614,7 +16760,7 @@
           <p:cNvPr id="10" name="">
             <a:extLst xmlns:a="http://schemas.openxmlformats.org/drawingml/2006/main">
               <a:ext uri="{FF2B5EF4-FFF2-40B4-BE49-F238E27FC236}">
-                <a16:creationId xmlns:a16="http://schemas.microsoft.com/office/drawing/2014/main" id="{EC20379F-7E79-4434-B1A7-9352049E9F05}"/>
+                <a16:creationId xmlns:a16="http://schemas.microsoft.com/office/drawing/2014/main" id="{6B35A69E-2954-4126-9122-C7CA2342A3FF}"/>
               </a:ext>
             </a:extLst>
           </p:cNvPr>
@@ -16682,7 +16828,7 @@
           <p:cNvPr id="11" name="">
             <a:extLst xmlns:a="http://schemas.openxmlformats.org/drawingml/2006/main">
               <a:ext uri="{FF2B5EF4-FFF2-40B4-BE49-F238E27FC236}">
-                <a16:creationId xmlns:a16="http://schemas.microsoft.com/office/drawing/2014/main" id="{3D01CE62-92B8-4012-8C28-6D7F45DEF5D4}"/>
+                <a16:creationId xmlns:a16="http://schemas.microsoft.com/office/drawing/2014/main" id="{178C1D97-CFE8-4BE3-A091-FD71A660AA1E}"/>
               </a:ext>
             </a:extLst>
           </p:cNvPr>
@@ -16773,7 +16919,7 @@
           <p:cNvPr id="12" name="">
             <a:extLst xmlns:a="http://schemas.openxmlformats.org/drawingml/2006/main">
               <a:ext uri="{FF2B5EF4-FFF2-40B4-BE49-F238E27FC236}">
-                <a16:creationId xmlns:a16="http://schemas.microsoft.com/office/drawing/2014/main" id="{54F3472A-C677-4368-82CA-2E3FFA7B18D1}"/>
+                <a16:creationId xmlns:a16="http://schemas.microsoft.com/office/drawing/2014/main" id="{27E017E8-836D-418C-A7EC-D8452266B672}"/>
               </a:ext>
             </a:extLst>
           </p:cNvPr>
@@ -16803,7 +16949,7 @@
           <p:cNvPr id="13" name="">
             <a:extLst xmlns:a="http://schemas.openxmlformats.org/drawingml/2006/main">
               <a:ext uri="{FF2B5EF4-FFF2-40B4-BE49-F238E27FC236}">
-                <a16:creationId xmlns:a16="http://schemas.microsoft.com/office/drawing/2014/main" id="{CAF7143E-6DAC-471E-93BF-070FA7B209A3}"/>
+                <a16:creationId xmlns:a16="http://schemas.microsoft.com/office/drawing/2014/main" id="{9DA73015-4591-4373-A206-A9D9D749482C}"/>
               </a:ext>
             </a:extLst>
           </p:cNvPr>
@@ -16871,7 +17017,7 @@
           <p:cNvPr id="14" name="">
             <a:extLst xmlns:a="http://schemas.openxmlformats.org/drawingml/2006/main">
               <a:ext uri="{FF2B5EF4-FFF2-40B4-BE49-F238E27FC236}">
-                <a16:creationId xmlns:a16="http://schemas.microsoft.com/office/drawing/2014/main" id="{D93474AC-E4BE-40D9-90C3-7E977E88DF64}"/>
+                <a16:creationId xmlns:a16="http://schemas.microsoft.com/office/drawing/2014/main" id="{D1F63CFA-F346-401E-8A1B-751DD1AB49F1}"/>
               </a:ext>
             </a:extLst>
           </p:cNvPr>
@@ -16939,7 +17085,7 @@
           <p:cNvPr id="15" name="">
             <a:extLst xmlns:a="http://schemas.openxmlformats.org/drawingml/2006/main">
               <a:ext uri="{FF2B5EF4-FFF2-40B4-BE49-F238E27FC236}">
-                <a16:creationId xmlns:a16="http://schemas.microsoft.com/office/drawing/2014/main" id="{01B138A3-1889-43A6-9392-E6497CD4931B}"/>
+                <a16:creationId xmlns:a16="http://schemas.microsoft.com/office/drawing/2014/main" id="{5EC35639-A90D-4D6A-BD39-2C5197AA9E78}"/>
               </a:ext>
             </a:extLst>
           </p:cNvPr>
@@ -17030,7 +17176,7 @@
           <p:cNvPr id="16" name="">
             <a:extLst xmlns:a="http://schemas.openxmlformats.org/drawingml/2006/main">
               <a:ext uri="{FF2B5EF4-FFF2-40B4-BE49-F238E27FC236}">
-                <a16:creationId xmlns:a16="http://schemas.microsoft.com/office/drawing/2014/main" id="{63C62487-FDE2-4FC2-8FF3-543AD555B0BB}"/>
+                <a16:creationId xmlns:a16="http://schemas.microsoft.com/office/drawing/2014/main" id="{BC87A9AA-2AFA-452F-B602-EA77D97C9F44}"/>
               </a:ext>
             </a:extLst>
           </p:cNvPr>
@@ -17098,7 +17244,7 @@
           <p:cNvPr id="17" name="">
             <a:extLst xmlns:a="http://schemas.openxmlformats.org/drawingml/2006/main">
               <a:ext uri="{FF2B5EF4-FFF2-40B4-BE49-F238E27FC236}">
-                <a16:creationId xmlns:a16="http://schemas.microsoft.com/office/drawing/2014/main" id="{1AEFDC44-310A-4E5B-8496-872E627ADD50}"/>
+                <a16:creationId xmlns:a16="http://schemas.microsoft.com/office/drawing/2014/main" id="{45B70054-6543-4B1B-AA66-DA54DA45614E}"/>
               </a:ext>
             </a:extLst>
           </p:cNvPr>
@@ -17164,7 +17310,7 @@
     </p:spTree>
     <p:extLst>
       <p:ext uri="{BB962C8B-B14F-4D97-AF65-F5344CB8AC3E}">
-        <p14:creationId xmlns:p14="http://schemas.microsoft.com/office/powerpoint/2010/main" val="972838340"/>
+        <p14:creationId xmlns:p14="http://schemas.microsoft.com/office/powerpoint/2010/main" val="1366420311"/>
       </p:ext>
     </p:extLst>
   </p:cSld>
@@ -17195,7 +17341,7 @@
           <p:cNvPr id="16" name="">
             <a:extLst xmlns:a="http://schemas.openxmlformats.org/drawingml/2006/main">
               <a:ext uri="{FF2B5EF4-FFF2-40B4-BE49-F238E27FC236}">
-                <a16:creationId xmlns:a16="http://schemas.microsoft.com/office/drawing/2014/main" id="{088BEE17-6DE3-477C-B5B7-53359FC7EAB4}"/>
+                <a16:creationId xmlns:a16="http://schemas.microsoft.com/office/drawing/2014/main" id="{0D3DEF94-ABB8-49A4-AF98-CAAAFDE76AEE}"/>
               </a:ext>
             </a:extLst>
           </p:cNvPr>
@@ -17205,7 +17351,7 @@
           <p:nvPr/>
         </p:nvPicPr>
         <p:blipFill>
-          <a:blip xmlns:r="http://schemas.openxmlformats.org/officeDocument/2006/relationships" xmlns:a="http://schemas.openxmlformats.org/drawingml/2006/main" r:embed="Rd1f9a5389cba4b2a"/>
+          <a:blip xmlns:r="http://schemas.openxmlformats.org/officeDocument/2006/relationships" xmlns:a="http://schemas.openxmlformats.org/drawingml/2006/main" r:embed="Rf584fe7507d4473d"/>
           <a:srcRect xmlns:a="http://schemas.openxmlformats.org/drawingml/2006/main" l="0" t="0" r="0" b="0"/>
           <a:stretch xmlns:a="http://schemas.openxmlformats.org/drawingml/2006/main">
             <a:fillRect l="0" t="0" r="0" b="0"/>
@@ -17226,7 +17372,7 @@
           <p:cNvPr id="2" name="">
             <a:extLst xmlns:a="http://schemas.openxmlformats.org/drawingml/2006/main">
               <a:ext uri="{FF2B5EF4-FFF2-40B4-BE49-F238E27FC236}">
-                <a16:creationId xmlns:a16="http://schemas.microsoft.com/office/drawing/2014/main" id="{831FA214-EDB8-40F0-89D5-71322487EEE1}"/>
+                <a16:creationId xmlns:a16="http://schemas.microsoft.com/office/drawing/2014/main" id="{5379CF55-50B2-4A48-A5A4-0EE2BDBAEB73}"/>
               </a:ext>
             </a:extLst>
           </p:cNvPr>
@@ -17294,7 +17440,7 @@
           <p:cNvPr id="3" name="">
             <a:extLst xmlns:a="http://schemas.openxmlformats.org/drawingml/2006/main">
               <a:ext uri="{FF2B5EF4-FFF2-40B4-BE49-F238E27FC236}">
-                <a16:creationId xmlns:a16="http://schemas.microsoft.com/office/drawing/2014/main" id="{B9CE0B46-6544-41E9-9AB4-9BE047EEA85F}"/>
+                <a16:creationId xmlns:a16="http://schemas.microsoft.com/office/drawing/2014/main" id="{CECA6625-1287-4519-B8CF-1601BB6C2EFF}"/>
               </a:ext>
             </a:extLst>
           </p:cNvPr>
@@ -17362,7 +17508,7 @@
           <p:cNvPr id="4" name="">
             <a:extLst xmlns:a="http://schemas.openxmlformats.org/drawingml/2006/main">
               <a:ext uri="{FF2B5EF4-FFF2-40B4-BE49-F238E27FC236}">
-                <a16:creationId xmlns:a16="http://schemas.microsoft.com/office/drawing/2014/main" id="{0CC689E5-0502-4270-8CAE-26079E425126}"/>
+                <a16:creationId xmlns:a16="http://schemas.microsoft.com/office/drawing/2014/main" id="{76848F49-DD12-4612-8FD9-62EE0DA94A32}"/>
               </a:ext>
             </a:extLst>
           </p:cNvPr>
@@ -17430,7 +17576,7 @@
           <p:cNvPr id="5" name="">
             <a:extLst xmlns:a="http://schemas.openxmlformats.org/drawingml/2006/main">
               <a:ext uri="{FF2B5EF4-FFF2-40B4-BE49-F238E27FC236}">
-                <a16:creationId xmlns:a16="http://schemas.microsoft.com/office/drawing/2014/main" id="{CB4ACD77-8E9A-45D4-8EBE-7668CA191D25}"/>
+                <a16:creationId xmlns:a16="http://schemas.microsoft.com/office/drawing/2014/main" id="{16E7DF26-2A3B-4536-A134-0C219A266A9A}"/>
               </a:ext>
             </a:extLst>
           </p:cNvPr>
@@ -17498,7 +17644,7 @@
           <p:cNvPr id="6" name="">
             <a:extLst xmlns:a="http://schemas.openxmlformats.org/drawingml/2006/main">
               <a:ext uri="{FF2B5EF4-FFF2-40B4-BE49-F238E27FC236}">
-                <a16:creationId xmlns:a16="http://schemas.microsoft.com/office/drawing/2014/main" id="{7BE5CEAE-7355-4B64-9892-EB26471D07CD}"/>
+                <a16:creationId xmlns:a16="http://schemas.microsoft.com/office/drawing/2014/main" id="{A32B0434-A605-4052-A522-3B1A43DAE1B4}"/>
               </a:ext>
             </a:extLst>
           </p:cNvPr>
@@ -17566,7 +17712,7 @@
           <p:cNvPr id="7" name="">
             <a:extLst xmlns:a="http://schemas.openxmlformats.org/drawingml/2006/main">
               <a:ext uri="{FF2B5EF4-FFF2-40B4-BE49-F238E27FC236}">
-                <a16:creationId xmlns:a16="http://schemas.microsoft.com/office/drawing/2014/main" id="{EFDB4B3E-4604-49B2-AFA6-5D2693B28B19}"/>
+                <a16:creationId xmlns:a16="http://schemas.microsoft.com/office/drawing/2014/main" id="{E8B48A51-9A1D-41E2-A79F-3DE87BE94638}"/>
               </a:ext>
             </a:extLst>
           </p:cNvPr>
@@ -17657,7 +17803,7 @@
           <p:cNvPr id="8" name="">
             <a:extLst xmlns:a="http://schemas.openxmlformats.org/drawingml/2006/main">
               <a:ext uri="{FF2B5EF4-FFF2-40B4-BE49-F238E27FC236}">
-                <a16:creationId xmlns:a16="http://schemas.microsoft.com/office/drawing/2014/main" id="{BF820D81-59CA-49F1-A321-EEC269843C11}"/>
+                <a16:creationId xmlns:a16="http://schemas.microsoft.com/office/drawing/2014/main" id="{84BFE51F-0315-462A-99AA-21EB174DEF25}"/>
               </a:ext>
             </a:extLst>
           </p:cNvPr>
@@ -17725,7 +17871,7 @@
           <p:cNvPr id="9" name="">
             <a:extLst xmlns:a="http://schemas.openxmlformats.org/drawingml/2006/main">
               <a:ext uri="{FF2B5EF4-FFF2-40B4-BE49-F238E27FC236}">
-                <a16:creationId xmlns:a16="http://schemas.microsoft.com/office/drawing/2014/main" id="{D09D3B48-8F4B-4966-952F-F0A0BB1AC25B}"/>
+                <a16:creationId xmlns:a16="http://schemas.microsoft.com/office/drawing/2014/main" id="{B75B87F9-F431-435C-90D7-6480D3FA1875}"/>
               </a:ext>
             </a:extLst>
           </p:cNvPr>
@@ -17793,7 +17939,7 @@
           <p:cNvPr id="10" name="">
             <a:extLst xmlns:a="http://schemas.openxmlformats.org/drawingml/2006/main">
               <a:ext uri="{FF2B5EF4-FFF2-40B4-BE49-F238E27FC236}">
-                <a16:creationId xmlns:a16="http://schemas.microsoft.com/office/drawing/2014/main" id="{B9E17FAF-F661-4820-AEE5-D7CEDDD72888}"/>
+                <a16:creationId xmlns:a16="http://schemas.microsoft.com/office/drawing/2014/main" id="{AAB15611-224F-4850-9783-0592E5F26AAB}"/>
               </a:ext>
             </a:extLst>
           </p:cNvPr>
@@ -17884,7 +18030,7 @@
           <p:cNvPr id="11" name="">
             <a:extLst xmlns:a="http://schemas.openxmlformats.org/drawingml/2006/main">
               <a:ext uri="{FF2B5EF4-FFF2-40B4-BE49-F238E27FC236}">
-                <a16:creationId xmlns:a16="http://schemas.microsoft.com/office/drawing/2014/main" id="{8A35CA05-7EA4-48BB-9645-5C3E6F02B9AF}"/>
+                <a16:creationId xmlns:a16="http://schemas.microsoft.com/office/drawing/2014/main" id="{61834C42-138D-41C3-8C08-2E524A71B4C2}"/>
               </a:ext>
             </a:extLst>
           </p:cNvPr>
@@ -17952,7 +18098,7 @@
           <p:cNvPr id="12" name="">
             <a:extLst xmlns:a="http://schemas.openxmlformats.org/drawingml/2006/main">
               <a:ext uri="{FF2B5EF4-FFF2-40B4-BE49-F238E27FC236}">
-                <a16:creationId xmlns:a16="http://schemas.microsoft.com/office/drawing/2014/main" id="{121D6782-429E-4897-BB23-3CAD029B4F71}"/>
+                <a16:creationId xmlns:a16="http://schemas.microsoft.com/office/drawing/2014/main" id="{52576BBC-2E4B-4434-8D26-DEA9F0B58B20}"/>
               </a:ext>
             </a:extLst>
           </p:cNvPr>
@@ -18020,7 +18166,7 @@
           <p:cNvPr id="13" name="">
             <a:extLst xmlns:a="http://schemas.openxmlformats.org/drawingml/2006/main">
               <a:ext uri="{FF2B5EF4-FFF2-40B4-BE49-F238E27FC236}">
-                <a16:creationId xmlns:a16="http://schemas.microsoft.com/office/drawing/2014/main" id="{C18BCD1E-24E1-40B6-910F-D7FF97E63B89}"/>
+                <a16:creationId xmlns:a16="http://schemas.microsoft.com/office/drawing/2014/main" id="{42797150-A3FB-4025-8034-B68BF66F75FD}"/>
               </a:ext>
             </a:extLst>
           </p:cNvPr>
@@ -18111,7 +18257,7 @@
           <p:cNvPr id="14" name="">
             <a:extLst xmlns:a="http://schemas.openxmlformats.org/drawingml/2006/main">
               <a:ext uri="{FF2B5EF4-FFF2-40B4-BE49-F238E27FC236}">
-                <a16:creationId xmlns:a16="http://schemas.microsoft.com/office/drawing/2014/main" id="{1C66C689-BDA9-4ABD-9F52-23D87249611A}"/>
+                <a16:creationId xmlns:a16="http://schemas.microsoft.com/office/drawing/2014/main" id="{485DF632-7724-40AB-B863-B24031E3E70F}"/>
               </a:ext>
             </a:extLst>
           </p:cNvPr>
@@ -18179,7 +18325,7 @@
           <p:cNvPr id="15" name="">
             <a:extLst xmlns:a="http://schemas.openxmlformats.org/drawingml/2006/main">
               <a:ext uri="{FF2B5EF4-FFF2-40B4-BE49-F238E27FC236}">
-                <a16:creationId xmlns:a16="http://schemas.microsoft.com/office/drawing/2014/main" id="{3804FBEB-097E-4CF6-BC58-B89FB20BA2A0}"/>
+                <a16:creationId xmlns:a16="http://schemas.microsoft.com/office/drawing/2014/main" id="{748BECAA-C648-40BC-BB94-386C5D3448C9}"/>
               </a:ext>
             </a:extLst>
           </p:cNvPr>
@@ -18245,7 +18391,7 @@
     </p:spTree>
     <p:extLst>
       <p:ext uri="{BB962C8B-B14F-4D97-AF65-F5344CB8AC3E}">
-        <p14:creationId xmlns:p14="http://schemas.microsoft.com/office/powerpoint/2010/main" val="106741718"/>
+        <p14:creationId xmlns:p14="http://schemas.microsoft.com/office/powerpoint/2010/main" val="1950736466"/>
       </p:ext>
     </p:extLst>
   </p:cSld>
@@ -18276,7 +18422,7 @@
           <p:cNvPr id="18" name="">
             <a:extLst xmlns:a="http://schemas.openxmlformats.org/drawingml/2006/main">
               <a:ext uri="{FF2B5EF4-FFF2-40B4-BE49-F238E27FC236}">
-                <a16:creationId xmlns:a16="http://schemas.microsoft.com/office/drawing/2014/main" id="{6F5A0118-F212-4344-B417-192BA432F693}"/>
+                <a16:creationId xmlns:a16="http://schemas.microsoft.com/office/drawing/2014/main" id="{6A70AFE4-BCCA-4066-9793-1D0CDB2205AF}"/>
               </a:ext>
             </a:extLst>
           </p:cNvPr>
@@ -18344,7 +18490,7 @@
           <p:cNvPr id="2" name="">
             <a:extLst xmlns:a="http://schemas.openxmlformats.org/drawingml/2006/main">
               <a:ext uri="{FF2B5EF4-FFF2-40B4-BE49-F238E27FC236}">
-                <a16:creationId xmlns:a16="http://schemas.microsoft.com/office/drawing/2014/main" id="{103A1E51-1589-49EE-922E-86E95D339DE9}"/>
+                <a16:creationId xmlns:a16="http://schemas.microsoft.com/office/drawing/2014/main" id="{DC613B03-E138-4681-BB4E-E64033ADC7E2}"/>
               </a:ext>
             </a:extLst>
           </p:cNvPr>
@@ -18412,7 +18558,7 @@
           <p:cNvPr id="3" name="">
             <a:extLst xmlns:a="http://schemas.openxmlformats.org/drawingml/2006/main">
               <a:ext uri="{FF2B5EF4-FFF2-40B4-BE49-F238E27FC236}">
-                <a16:creationId xmlns:a16="http://schemas.microsoft.com/office/drawing/2014/main" id="{5D605F3E-AFED-47D2-A594-816AB2E831B1}"/>
+                <a16:creationId xmlns:a16="http://schemas.microsoft.com/office/drawing/2014/main" id="{15329A90-28A0-4492-922B-A00FFDBE3DDB}"/>
               </a:ext>
             </a:extLst>
           </p:cNvPr>
@@ -18480,7 +18626,7 @@
           <p:cNvPr id="4" name="">
             <a:extLst xmlns:a="http://schemas.openxmlformats.org/drawingml/2006/main">
               <a:ext uri="{FF2B5EF4-FFF2-40B4-BE49-F238E27FC236}">
-                <a16:creationId xmlns:a16="http://schemas.microsoft.com/office/drawing/2014/main" id="{155AA277-A595-4A2B-BC91-06D987928FD0}"/>
+                <a16:creationId xmlns:a16="http://schemas.microsoft.com/office/drawing/2014/main" id="{2DFFB244-73C1-495E-AD48-4B2C3C49E180}"/>
               </a:ext>
             </a:extLst>
           </p:cNvPr>
@@ -18490,7 +18636,7 @@
           <p:nvPr/>
         </p:nvPicPr>
         <p:blipFill>
-          <a:blip xmlns:r="http://schemas.openxmlformats.org/officeDocument/2006/relationships" xmlns:a="http://schemas.openxmlformats.org/drawingml/2006/main" r:embed="Rc4f22244165c4924"/>
+          <a:blip xmlns:r="http://schemas.openxmlformats.org/officeDocument/2006/relationships" xmlns:a="http://schemas.openxmlformats.org/drawingml/2006/main" r:embed="R0f3a01af16404cba"/>
           <a:stretch xmlns:a="http://schemas.openxmlformats.org/drawingml/2006/main"/>
         </p:blipFill>
         <p:spPr>
@@ -18508,7 +18654,7 @@
           <p:cNvPr id="5" name="">
             <a:extLst xmlns:a="http://schemas.openxmlformats.org/drawingml/2006/main">
               <a:ext uri="{FF2B5EF4-FFF2-40B4-BE49-F238E27FC236}">
-                <a16:creationId xmlns:a16="http://schemas.microsoft.com/office/drawing/2014/main" id="{AE601CC4-1580-48C2-A2AD-7E841B2DB781}"/>
+                <a16:creationId xmlns:a16="http://schemas.microsoft.com/office/drawing/2014/main" id="{B72D30CC-13FB-499F-847D-5B9AE8582E40}"/>
               </a:ext>
             </a:extLst>
           </p:cNvPr>
@@ -18576,7 +18722,7 @@
           <p:cNvPr id="6" name="">
             <a:extLst xmlns:a="http://schemas.openxmlformats.org/drawingml/2006/main">
               <a:ext uri="{FF2B5EF4-FFF2-40B4-BE49-F238E27FC236}">
-                <a16:creationId xmlns:a16="http://schemas.microsoft.com/office/drawing/2014/main" id="{FF6F516C-7708-42D3-B17E-D074F8D909E2}"/>
+                <a16:creationId xmlns:a16="http://schemas.microsoft.com/office/drawing/2014/main" id="{20D84DEB-D09F-4B1B-8321-235472FE5B73}"/>
               </a:ext>
             </a:extLst>
           </p:cNvPr>
@@ -18644,7 +18790,7 @@
           <p:cNvPr id="7" name="">
             <a:extLst xmlns:a="http://schemas.openxmlformats.org/drawingml/2006/main">
               <a:ext uri="{FF2B5EF4-FFF2-40B4-BE49-F238E27FC236}">
-                <a16:creationId xmlns:a16="http://schemas.microsoft.com/office/drawing/2014/main" id="{418439E3-9DF0-4CF2-878A-F24A1EA9A842}"/>
+                <a16:creationId xmlns:a16="http://schemas.microsoft.com/office/drawing/2014/main" id="{A5BC2389-D6A7-439B-921C-DA1577FEE6F0}"/>
               </a:ext>
             </a:extLst>
           </p:cNvPr>
@@ -18735,7 +18881,7 @@
           <p:cNvPr id="8" name="">
             <a:extLst xmlns:a="http://schemas.openxmlformats.org/drawingml/2006/main">
               <a:ext uri="{FF2B5EF4-FFF2-40B4-BE49-F238E27FC236}">
-                <a16:creationId xmlns:a16="http://schemas.microsoft.com/office/drawing/2014/main" id="{431C962E-69F8-44E0-9653-3832B9A37469}"/>
+                <a16:creationId xmlns:a16="http://schemas.microsoft.com/office/drawing/2014/main" id="{DE438019-533F-4AF1-85DA-906B19ABC259}"/>
               </a:ext>
             </a:extLst>
           </p:cNvPr>
@@ -18745,7 +18891,7 @@
           <p:nvPr/>
         </p:nvPicPr>
         <p:blipFill>
-          <a:blip xmlns:r="http://schemas.openxmlformats.org/officeDocument/2006/relationships" xmlns:a="http://schemas.openxmlformats.org/drawingml/2006/main" r:embed="R06514c01d6a04a15"/>
+          <a:blip xmlns:r="http://schemas.openxmlformats.org/officeDocument/2006/relationships" xmlns:a="http://schemas.openxmlformats.org/drawingml/2006/main" r:embed="R3a09deb9326e43b1"/>
           <a:stretch xmlns:a="http://schemas.openxmlformats.org/drawingml/2006/main"/>
         </p:blipFill>
         <p:spPr>
@@ -18763,7 +18909,7 @@
           <p:cNvPr id="9" name="">
             <a:extLst xmlns:a="http://schemas.openxmlformats.org/drawingml/2006/main">
               <a:ext uri="{FF2B5EF4-FFF2-40B4-BE49-F238E27FC236}">
-                <a16:creationId xmlns:a16="http://schemas.microsoft.com/office/drawing/2014/main" id="{6CFB0A99-1A75-47BE-9631-7153C6B2C4BC}"/>
+                <a16:creationId xmlns:a16="http://schemas.microsoft.com/office/drawing/2014/main" id="{28A8B024-F212-4E4F-B0DF-920DDD37A27D}"/>
               </a:ext>
             </a:extLst>
           </p:cNvPr>
@@ -18831,7 +18977,7 @@
           <p:cNvPr id="10" name="">
             <a:extLst xmlns:a="http://schemas.openxmlformats.org/drawingml/2006/main">
               <a:ext uri="{FF2B5EF4-FFF2-40B4-BE49-F238E27FC236}">
-                <a16:creationId xmlns:a16="http://schemas.microsoft.com/office/drawing/2014/main" id="{D5727416-8BC2-4480-999C-465E5086B1F8}"/>
+                <a16:creationId xmlns:a16="http://schemas.microsoft.com/office/drawing/2014/main" id="{09154500-DC5E-4AF8-B940-8AFBDE51D6FB}"/>
               </a:ext>
             </a:extLst>
           </p:cNvPr>
@@ -18899,7 +19045,7 @@
           <p:cNvPr id="11" name="">
             <a:extLst xmlns:a="http://schemas.openxmlformats.org/drawingml/2006/main">
               <a:ext uri="{FF2B5EF4-FFF2-40B4-BE49-F238E27FC236}">
-                <a16:creationId xmlns:a16="http://schemas.microsoft.com/office/drawing/2014/main" id="{3821A099-80E7-4AEE-9F70-B51B2B53E47C}"/>
+                <a16:creationId xmlns:a16="http://schemas.microsoft.com/office/drawing/2014/main" id="{6CA6B585-473F-4958-979F-07A663D0E75A}"/>
               </a:ext>
             </a:extLst>
           </p:cNvPr>
@@ -18990,7 +19136,7 @@
           <p:cNvPr id="12" name="">
             <a:extLst xmlns:a="http://schemas.openxmlformats.org/drawingml/2006/main">
               <a:ext uri="{FF2B5EF4-FFF2-40B4-BE49-F238E27FC236}">
-                <a16:creationId xmlns:a16="http://schemas.microsoft.com/office/drawing/2014/main" id="{F6C01310-70C9-42DB-A8BB-22AE1A8B7705}"/>
+                <a16:creationId xmlns:a16="http://schemas.microsoft.com/office/drawing/2014/main" id="{B71640D0-E69A-48B7-8D25-E1CF7B4D8E25}"/>
               </a:ext>
             </a:extLst>
           </p:cNvPr>
@@ -19000,7 +19146,7 @@
           <p:nvPr/>
         </p:nvPicPr>
         <p:blipFill>
-          <a:blip xmlns:r="http://schemas.openxmlformats.org/officeDocument/2006/relationships" xmlns:a="http://schemas.openxmlformats.org/drawingml/2006/main" r:embed="R2fd802abe9604d4c"/>
+          <a:blip xmlns:r="http://schemas.openxmlformats.org/officeDocument/2006/relationships" xmlns:a="http://schemas.openxmlformats.org/drawingml/2006/main" r:embed="R96170949a53a4201"/>
           <a:stretch xmlns:a="http://schemas.openxmlformats.org/drawingml/2006/main"/>
         </p:blipFill>
         <p:spPr>
@@ -19018,7 +19164,7 @@
           <p:cNvPr id="13" name="">
             <a:extLst xmlns:a="http://schemas.openxmlformats.org/drawingml/2006/main">
               <a:ext uri="{FF2B5EF4-FFF2-40B4-BE49-F238E27FC236}">
-                <a16:creationId xmlns:a16="http://schemas.microsoft.com/office/drawing/2014/main" id="{329A1A3D-888B-456D-A477-72C0A939CA65}"/>
+                <a16:creationId xmlns:a16="http://schemas.microsoft.com/office/drawing/2014/main" id="{14F1807B-4DDF-40E9-A4C7-2FB3AB7AE1B9}"/>
               </a:ext>
             </a:extLst>
           </p:cNvPr>
@@ -19086,7 +19232,7 @@
           <p:cNvPr id="14" name="">
             <a:extLst xmlns:a="http://schemas.openxmlformats.org/drawingml/2006/main">
               <a:ext uri="{FF2B5EF4-FFF2-40B4-BE49-F238E27FC236}">
-                <a16:creationId xmlns:a16="http://schemas.microsoft.com/office/drawing/2014/main" id="{FF4FDB91-9248-4B10-BF5D-34C04096F17B}"/>
+                <a16:creationId xmlns:a16="http://schemas.microsoft.com/office/drawing/2014/main" id="{7C8CBFD0-E576-475F-B653-2040AEF93AAD}"/>
               </a:ext>
             </a:extLst>
           </p:cNvPr>
@@ -19154,7 +19300,7 @@
           <p:cNvPr id="15" name="">
             <a:extLst xmlns:a="http://schemas.openxmlformats.org/drawingml/2006/main">
               <a:ext uri="{FF2B5EF4-FFF2-40B4-BE49-F238E27FC236}">
-                <a16:creationId xmlns:a16="http://schemas.microsoft.com/office/drawing/2014/main" id="{BF03EE7D-56CA-4A32-8258-4F2CA9768698}"/>
+                <a16:creationId xmlns:a16="http://schemas.microsoft.com/office/drawing/2014/main" id="{932B3D10-6D9C-46A6-98C8-9CFDECA3E70E}"/>
               </a:ext>
             </a:extLst>
           </p:cNvPr>
@@ -19245,7 +19391,7 @@
           <p:cNvPr id="16" name="">
             <a:extLst xmlns:a="http://schemas.openxmlformats.org/drawingml/2006/main">
               <a:ext uri="{FF2B5EF4-FFF2-40B4-BE49-F238E27FC236}">
-                <a16:creationId xmlns:a16="http://schemas.microsoft.com/office/drawing/2014/main" id="{3F169D11-F447-4E41-B969-995F04638CEA}"/>
+                <a16:creationId xmlns:a16="http://schemas.microsoft.com/office/drawing/2014/main" id="{1286B73D-71A2-47A3-8BC3-B3CF72CB8C07}"/>
               </a:ext>
             </a:extLst>
           </p:cNvPr>
@@ -19313,7 +19459,7 @@
           <p:cNvPr id="17" name="">
             <a:extLst xmlns:a="http://schemas.openxmlformats.org/drawingml/2006/main">
               <a:ext uri="{FF2B5EF4-FFF2-40B4-BE49-F238E27FC236}">
-                <a16:creationId xmlns:a16="http://schemas.microsoft.com/office/drawing/2014/main" id="{73EEE5BB-02BC-4CC6-BD48-2024B893F64C}"/>
+                <a16:creationId xmlns:a16="http://schemas.microsoft.com/office/drawing/2014/main" id="{9C4430F3-6D7F-4CBC-B331-DEA2E71948E0}"/>
               </a:ext>
             </a:extLst>
           </p:cNvPr>
@@ -19379,7 +19525,7 @@
     </p:spTree>
     <p:extLst>
       <p:ext uri="{BB962C8B-B14F-4D97-AF65-F5344CB8AC3E}">
-        <p14:creationId xmlns:p14="http://schemas.microsoft.com/office/powerpoint/2010/main" val="320586329"/>
+        <p14:creationId xmlns:p14="http://schemas.microsoft.com/office/powerpoint/2010/main" val="784796439"/>
       </p:ext>
     </p:extLst>
   </p:cSld>
@@ -19410,7 +19556,7 @@
           <p:cNvPr id="12" name="">
             <a:extLst xmlns:a="http://schemas.openxmlformats.org/drawingml/2006/main">
               <a:ext uri="{FF2B5EF4-FFF2-40B4-BE49-F238E27FC236}">
-                <a16:creationId xmlns:a16="http://schemas.microsoft.com/office/drawing/2014/main" id="{F3CCA0C8-2FE0-4D05-BD0F-DD97F6DCE696}"/>
+                <a16:creationId xmlns:a16="http://schemas.microsoft.com/office/drawing/2014/main" id="{7BFA6000-64AE-4E1F-9C8A-B9CFE79DF59D}"/>
               </a:ext>
             </a:extLst>
           </p:cNvPr>
@@ -19478,7 +19624,7 @@
           <p:cNvPr id="2" name="">
             <a:extLst xmlns:a="http://schemas.openxmlformats.org/drawingml/2006/main">
               <a:ext uri="{FF2B5EF4-FFF2-40B4-BE49-F238E27FC236}">
-                <a16:creationId xmlns:a16="http://schemas.microsoft.com/office/drawing/2014/main" id="{4720E2BE-7698-482C-B009-48D9FBDBFD86}"/>
+                <a16:creationId xmlns:a16="http://schemas.microsoft.com/office/drawing/2014/main" id="{CD23BDFA-858B-4416-8EDC-22A1A1E0747A}"/>
               </a:ext>
             </a:extLst>
           </p:cNvPr>
@@ -19546,7 +19692,7 @@
           <p:cNvPr id="3" name="">
             <a:extLst xmlns:a="http://schemas.openxmlformats.org/drawingml/2006/main">
               <a:ext uri="{FF2B5EF4-FFF2-40B4-BE49-F238E27FC236}">
-                <a16:creationId xmlns:a16="http://schemas.microsoft.com/office/drawing/2014/main" id="{E0BFD21F-8A67-432A-AE4D-3C11FC4583EC}"/>
+                <a16:creationId xmlns:a16="http://schemas.microsoft.com/office/drawing/2014/main" id="{710C47A3-3031-498C-8257-92E88539B315}"/>
               </a:ext>
             </a:extLst>
           </p:cNvPr>
@@ -19614,7 +19760,7 @@
           <p:cNvPr id="4" name="">
             <a:extLst xmlns:a="http://schemas.openxmlformats.org/drawingml/2006/main">
               <a:ext uri="{FF2B5EF4-FFF2-40B4-BE49-F238E27FC236}">
-                <a16:creationId xmlns:a16="http://schemas.microsoft.com/office/drawing/2014/main" id="{D05BB93C-A71A-4D54-8CD6-BCA6FE4F29BD}"/>
+                <a16:creationId xmlns:a16="http://schemas.microsoft.com/office/drawing/2014/main" id="{D3C6E888-379A-4EFA-96C7-499D26C4E14F}"/>
               </a:ext>
             </a:extLst>
           </p:cNvPr>
@@ -19624,7 +19770,7 @@
           <p:nvPr/>
         </p:nvPicPr>
         <p:blipFill>
-          <a:blip xmlns:r="http://schemas.openxmlformats.org/officeDocument/2006/relationships" xmlns:a="http://schemas.openxmlformats.org/drawingml/2006/main" r:embed="R65ef9d773cc2487e"/>
+          <a:blip xmlns:r="http://schemas.openxmlformats.org/officeDocument/2006/relationships" xmlns:a="http://schemas.openxmlformats.org/drawingml/2006/main" r:embed="Rcdf78bb1783e420f"/>
           <a:stretch xmlns:a="http://schemas.openxmlformats.org/drawingml/2006/main"/>
         </p:blipFill>
         <p:spPr>
@@ -19642,7 +19788,7 @@
           <p:cNvPr id="5" name="">
             <a:extLst xmlns:a="http://schemas.openxmlformats.org/drawingml/2006/main">
               <a:ext uri="{FF2B5EF4-FFF2-40B4-BE49-F238E27FC236}">
-                <a16:creationId xmlns:a16="http://schemas.microsoft.com/office/drawing/2014/main" id="{A8F7BAA4-6FD1-44A9-A045-2DFEE036A11A}"/>
+                <a16:creationId xmlns:a16="http://schemas.microsoft.com/office/drawing/2014/main" id="{ED6D6AC4-8D1D-4C04-B2C9-1DB871FF3B3B}"/>
               </a:ext>
             </a:extLst>
           </p:cNvPr>
@@ -19710,7 +19856,7 @@
           <p:cNvPr id="6" name="">
             <a:extLst xmlns:a="http://schemas.openxmlformats.org/drawingml/2006/main">
               <a:ext uri="{FF2B5EF4-FFF2-40B4-BE49-F238E27FC236}">
-                <a16:creationId xmlns:a16="http://schemas.microsoft.com/office/drawing/2014/main" id="{EF088088-305E-415F-AD0B-3F7FFB7B895A}"/>
+                <a16:creationId xmlns:a16="http://schemas.microsoft.com/office/drawing/2014/main" id="{D11E5109-2DA5-49BE-B10F-B527007ACBE3}"/>
               </a:ext>
             </a:extLst>
           </p:cNvPr>
@@ -19801,7 +19947,7 @@
           <p:cNvPr id="7" name="">
             <a:extLst xmlns:a="http://schemas.openxmlformats.org/drawingml/2006/main">
               <a:ext uri="{FF2B5EF4-FFF2-40B4-BE49-F238E27FC236}">
-                <a16:creationId xmlns:a16="http://schemas.microsoft.com/office/drawing/2014/main" id="{EEB99A12-2B24-4802-BC66-F59224C57A7B}"/>
+                <a16:creationId xmlns:a16="http://schemas.microsoft.com/office/drawing/2014/main" id="{FB5866E4-42B2-4F5B-B4E3-D1EFF9D50CFA}"/>
               </a:ext>
             </a:extLst>
           </p:cNvPr>
@@ -19811,7 +19957,7 @@
           <p:nvPr/>
         </p:nvPicPr>
         <p:blipFill>
-          <a:blip xmlns:r="http://schemas.openxmlformats.org/officeDocument/2006/relationships" xmlns:a="http://schemas.openxmlformats.org/drawingml/2006/main" r:embed="R27944457e5234f04"/>
+          <a:blip xmlns:r="http://schemas.openxmlformats.org/officeDocument/2006/relationships" xmlns:a="http://schemas.openxmlformats.org/drawingml/2006/main" r:embed="R70578a52dcb14651"/>
           <a:stretch xmlns:a="http://schemas.openxmlformats.org/drawingml/2006/main"/>
         </p:blipFill>
         <p:spPr>
@@ -19829,7 +19975,7 @@
           <p:cNvPr id="8" name="">
             <a:extLst xmlns:a="http://schemas.openxmlformats.org/drawingml/2006/main">
               <a:ext uri="{FF2B5EF4-FFF2-40B4-BE49-F238E27FC236}">
-                <a16:creationId xmlns:a16="http://schemas.microsoft.com/office/drawing/2014/main" id="{3ED60305-744C-42A2-A123-AB3FC058AE6C}"/>
+                <a16:creationId xmlns:a16="http://schemas.microsoft.com/office/drawing/2014/main" id="{DE65EEBA-684F-41BE-9CDE-5EB11E8C1375}"/>
               </a:ext>
             </a:extLst>
           </p:cNvPr>
@@ -19897,7 +20043,7 @@
           <p:cNvPr id="9" name="">
             <a:extLst xmlns:a="http://schemas.openxmlformats.org/drawingml/2006/main">
               <a:ext uri="{FF2B5EF4-FFF2-40B4-BE49-F238E27FC236}">
-                <a16:creationId xmlns:a16="http://schemas.microsoft.com/office/drawing/2014/main" id="{B482CB76-79F1-4978-9CFF-5F44A43D335B}"/>
+                <a16:creationId xmlns:a16="http://schemas.microsoft.com/office/drawing/2014/main" id="{8FD82271-23B4-466D-83B0-AA0F2D4F818D}"/>
               </a:ext>
             </a:extLst>
           </p:cNvPr>
@@ -19988,7 +20134,7 @@
           <p:cNvPr id="10" name="">
             <a:extLst xmlns:a="http://schemas.openxmlformats.org/drawingml/2006/main">
               <a:ext uri="{FF2B5EF4-FFF2-40B4-BE49-F238E27FC236}">
-                <a16:creationId xmlns:a16="http://schemas.microsoft.com/office/drawing/2014/main" id="{B2C6D096-4932-4AF3-A61F-C7E79698FBB6}"/>
+                <a16:creationId xmlns:a16="http://schemas.microsoft.com/office/drawing/2014/main" id="{DAE742CD-20C7-43CF-9D79-E97E461FB4A3}"/>
               </a:ext>
             </a:extLst>
           </p:cNvPr>
@@ -20056,7 +20202,7 @@
           <p:cNvPr id="11" name="">
             <a:extLst xmlns:a="http://schemas.openxmlformats.org/drawingml/2006/main">
               <a:ext uri="{FF2B5EF4-FFF2-40B4-BE49-F238E27FC236}">
-                <a16:creationId xmlns:a16="http://schemas.microsoft.com/office/drawing/2014/main" id="{A6E2E5B9-F1DD-49B9-9CAB-B34933E42C95}"/>
+                <a16:creationId xmlns:a16="http://schemas.microsoft.com/office/drawing/2014/main" id="{322FEF56-961E-4DC5-AA52-7F325B258162}"/>
               </a:ext>
             </a:extLst>
           </p:cNvPr>
@@ -20122,7 +20268,7 @@
     </p:spTree>
     <p:extLst>
       <p:ext uri="{BB962C8B-B14F-4D97-AF65-F5344CB8AC3E}">
-        <p14:creationId xmlns:p14="http://schemas.microsoft.com/office/powerpoint/2010/main" val="84301088"/>
+        <p14:creationId xmlns:p14="http://schemas.microsoft.com/office/powerpoint/2010/main" val="1388836367"/>
       </p:ext>
     </p:extLst>
   </p:cSld>
@@ -20153,7 +20299,7 @@
           <p:cNvPr id="12" name="">
             <a:extLst xmlns:a="http://schemas.openxmlformats.org/drawingml/2006/main">
               <a:ext uri="{FF2B5EF4-FFF2-40B4-BE49-F238E27FC236}">
-                <a16:creationId xmlns:a16="http://schemas.microsoft.com/office/drawing/2014/main" id="{DDFF5B2C-CD5D-4557-9545-DC1ACF4AC267}"/>
+                <a16:creationId xmlns:a16="http://schemas.microsoft.com/office/drawing/2014/main" id="{0E0512CD-3111-4AC8-9D98-6F36D4E925B2}"/>
               </a:ext>
             </a:extLst>
           </p:cNvPr>
@@ -20163,7 +20309,7 @@
           <p:nvPr/>
         </p:nvPicPr>
         <p:blipFill>
-          <a:blip xmlns:r="http://schemas.openxmlformats.org/officeDocument/2006/relationships" xmlns:a="http://schemas.openxmlformats.org/drawingml/2006/main" r:embed="Re34b45d1eec44f26"/>
+          <a:blip xmlns:r="http://schemas.openxmlformats.org/officeDocument/2006/relationships" xmlns:a="http://schemas.openxmlformats.org/drawingml/2006/main" r:embed="R52c52f783ae84d7c"/>
           <a:srcRect xmlns:a="http://schemas.openxmlformats.org/drawingml/2006/main" l="0" t="0" r="0" b="0"/>
           <a:stretch xmlns:a="http://schemas.openxmlformats.org/drawingml/2006/main">
             <a:fillRect l="0" t="0" r="0" b="0"/>
@@ -20184,7 +20330,7 @@
           <p:cNvPr id="2" name="">
             <a:extLst xmlns:a="http://schemas.openxmlformats.org/drawingml/2006/main">
               <a:ext uri="{FF2B5EF4-FFF2-40B4-BE49-F238E27FC236}">
-                <a16:creationId xmlns:a16="http://schemas.microsoft.com/office/drawing/2014/main" id="{DAA57186-FE8E-4BC0-B2AE-337C3D75DF38}"/>
+                <a16:creationId xmlns:a16="http://schemas.microsoft.com/office/drawing/2014/main" id="{02E7B043-4988-458C-B7A8-CE306C18D2B7}"/>
               </a:ext>
             </a:extLst>
           </p:cNvPr>
@@ -20252,7 +20398,7 @@
           <p:cNvPr id="3" name="">
             <a:extLst xmlns:a="http://schemas.openxmlformats.org/drawingml/2006/main">
               <a:ext uri="{FF2B5EF4-FFF2-40B4-BE49-F238E27FC236}">
-                <a16:creationId xmlns:a16="http://schemas.microsoft.com/office/drawing/2014/main" id="{5B3B1717-6302-4450-A7E7-C0E6E1ECF801}"/>
+                <a16:creationId xmlns:a16="http://schemas.microsoft.com/office/drawing/2014/main" id="{A4933CC1-A437-4404-9C8E-3C46EF3496BC}"/>
               </a:ext>
             </a:extLst>
           </p:cNvPr>
@@ -20320,7 +20466,7 @@
           <p:cNvPr id="4" name="">
             <a:extLst xmlns:a="http://schemas.openxmlformats.org/drawingml/2006/main">
               <a:ext uri="{FF2B5EF4-FFF2-40B4-BE49-F238E27FC236}">
-                <a16:creationId xmlns:a16="http://schemas.microsoft.com/office/drawing/2014/main" id="{D6DDE534-C339-4944-9F8A-19D7439B5564}"/>
+                <a16:creationId xmlns:a16="http://schemas.microsoft.com/office/drawing/2014/main" id="{D43876B4-479C-44F4-9859-844CD5D385CE}"/>
               </a:ext>
             </a:extLst>
           </p:cNvPr>
@@ -20388,7 +20534,7 @@
           <p:cNvPr id="5" name="">
             <a:extLst xmlns:a="http://schemas.openxmlformats.org/drawingml/2006/main">
               <a:ext uri="{FF2B5EF4-FFF2-40B4-BE49-F238E27FC236}">
-                <a16:creationId xmlns:a16="http://schemas.microsoft.com/office/drawing/2014/main" id="{5BA72FE1-EFAB-46AC-B531-BC8458BD2188}"/>
+                <a16:creationId xmlns:a16="http://schemas.microsoft.com/office/drawing/2014/main" id="{36A94155-4A08-4D64-860E-04144EDD6C22}"/>
               </a:ext>
             </a:extLst>
           </p:cNvPr>
@@ -20398,7 +20544,7 @@
           <p:nvPr/>
         </p:nvPicPr>
         <p:blipFill>
-          <a:blip xmlns:r="http://schemas.openxmlformats.org/officeDocument/2006/relationships" xmlns:a="http://schemas.openxmlformats.org/drawingml/2006/main" r:embed="R3a432491d251435c"/>
+          <a:blip xmlns:r="http://schemas.openxmlformats.org/officeDocument/2006/relationships" xmlns:a="http://schemas.openxmlformats.org/drawingml/2006/main" r:embed="R97da8d52309e4deb"/>
           <a:stretch xmlns:a="http://schemas.openxmlformats.org/drawingml/2006/main"/>
         </p:blipFill>
         <p:spPr>
@@ -20416,7 +20562,7 @@
           <p:cNvPr id="6" name="">
             <a:extLst xmlns:a="http://schemas.openxmlformats.org/drawingml/2006/main">
               <a:ext uri="{FF2B5EF4-FFF2-40B4-BE49-F238E27FC236}">
-                <a16:creationId xmlns:a16="http://schemas.microsoft.com/office/drawing/2014/main" id="{E827DF9D-7025-4A85-B9E7-A1EA0D499C5A}"/>
+                <a16:creationId xmlns:a16="http://schemas.microsoft.com/office/drawing/2014/main" id="{28F2698B-8022-4F92-9392-21C512DDFAA3}"/>
               </a:ext>
             </a:extLst>
           </p:cNvPr>
@@ -20484,7 +20630,7 @@
           <p:cNvPr id="7" name="">
             <a:extLst xmlns:a="http://schemas.openxmlformats.org/drawingml/2006/main">
               <a:ext uri="{FF2B5EF4-FFF2-40B4-BE49-F238E27FC236}">
-                <a16:creationId xmlns:a16="http://schemas.microsoft.com/office/drawing/2014/main" id="{FA120D7D-B64D-4CD5-9D66-46C3945B256F}"/>
+                <a16:creationId xmlns:a16="http://schemas.microsoft.com/office/drawing/2014/main" id="{1FE1BE4E-BBA8-439C-974C-EA3CA6DDEB77}"/>
               </a:ext>
             </a:extLst>
           </p:cNvPr>
@@ -20575,7 +20721,7 @@
           <p:cNvPr id="8" name="">
             <a:extLst xmlns:a="http://schemas.openxmlformats.org/drawingml/2006/main">
               <a:ext uri="{FF2B5EF4-FFF2-40B4-BE49-F238E27FC236}">
-                <a16:creationId xmlns:a16="http://schemas.microsoft.com/office/drawing/2014/main" id="{CA36C5D1-E276-4DFC-8798-F83BA63432FB}"/>
+                <a16:creationId xmlns:a16="http://schemas.microsoft.com/office/drawing/2014/main" id="{1D01ED2C-9785-4CC7-80C4-1B0BAAECD11A}"/>
               </a:ext>
             </a:extLst>
           </p:cNvPr>
@@ -20585,7 +20731,7 @@
           <p:nvPr/>
         </p:nvPicPr>
         <p:blipFill>
-          <a:blip xmlns:r="http://schemas.openxmlformats.org/officeDocument/2006/relationships" xmlns:a="http://schemas.openxmlformats.org/drawingml/2006/main" r:embed="Rdab5b97a8b6247ad"/>
+          <a:blip xmlns:r="http://schemas.openxmlformats.org/officeDocument/2006/relationships" xmlns:a="http://schemas.openxmlformats.org/drawingml/2006/main" r:embed="Re94dbc87d63840ff"/>
           <a:stretch xmlns:a="http://schemas.openxmlformats.org/drawingml/2006/main"/>
         </p:blipFill>
         <p:spPr>
@@ -20603,7 +20749,7 @@
           <p:cNvPr id="9" name="">
             <a:extLst xmlns:a="http://schemas.openxmlformats.org/drawingml/2006/main">
               <a:ext uri="{FF2B5EF4-FFF2-40B4-BE49-F238E27FC236}">
-                <a16:creationId xmlns:a16="http://schemas.microsoft.com/office/drawing/2014/main" id="{D06271DF-D439-4524-9DDB-8C63EFDE432A}"/>
+                <a16:creationId xmlns:a16="http://schemas.microsoft.com/office/drawing/2014/main" id="{391F4266-763A-4C59-AC0D-8CBD6263D1A3}"/>
               </a:ext>
             </a:extLst>
           </p:cNvPr>
@@ -20671,7 +20817,7 @@
           <p:cNvPr id="10" name="">
             <a:extLst xmlns:a="http://schemas.openxmlformats.org/drawingml/2006/main">
               <a:ext uri="{FF2B5EF4-FFF2-40B4-BE49-F238E27FC236}">
-                <a16:creationId xmlns:a16="http://schemas.microsoft.com/office/drawing/2014/main" id="{FC7128F6-82CB-4FB9-BE79-1912419BCBD0}"/>
+                <a16:creationId xmlns:a16="http://schemas.microsoft.com/office/drawing/2014/main" id="{5B72CC2F-D360-4BAE-AB75-B0922A2288FD}"/>
               </a:ext>
             </a:extLst>
           </p:cNvPr>
@@ -20762,7 +20908,7 @@
           <p:cNvPr id="11" name="">
             <a:extLst xmlns:a="http://schemas.openxmlformats.org/drawingml/2006/main">
               <a:ext uri="{FF2B5EF4-FFF2-40B4-BE49-F238E27FC236}">
-                <a16:creationId xmlns:a16="http://schemas.microsoft.com/office/drawing/2014/main" id="{E96448BC-7BC5-46A6-A283-C06E0DC08CE6}"/>
+                <a16:creationId xmlns:a16="http://schemas.microsoft.com/office/drawing/2014/main" id="{B216597B-4CCA-4DCD-ACD2-0B07F1D9F5BF}"/>
               </a:ext>
             </a:extLst>
           </p:cNvPr>
@@ -20828,7 +20974,7 @@
     </p:spTree>
     <p:extLst>
       <p:ext uri="{BB962C8B-B14F-4D97-AF65-F5344CB8AC3E}">
-        <p14:creationId xmlns:p14="http://schemas.microsoft.com/office/powerpoint/2010/main" val="277048651"/>
+        <p14:creationId xmlns:p14="http://schemas.microsoft.com/office/powerpoint/2010/main" val="1023302509"/>
       </p:ext>
     </p:extLst>
   </p:cSld>
@@ -20859,7 +21005,7 @@
           <p:cNvPr id="7" name="">
             <a:extLst xmlns:a="http://schemas.openxmlformats.org/drawingml/2006/main">
               <a:ext uri="{FF2B5EF4-FFF2-40B4-BE49-F238E27FC236}">
-                <a16:creationId xmlns:a16="http://schemas.microsoft.com/office/drawing/2014/main" id="{E4F5DAF2-B83C-4C4D-B725-CCD85F8AB71E}"/>
+                <a16:creationId xmlns:a16="http://schemas.microsoft.com/office/drawing/2014/main" id="{486C184C-9E58-420D-82F5-1E438C46DC9B}"/>
               </a:ext>
             </a:extLst>
           </p:cNvPr>
@@ -20869,7 +21015,7 @@
           <p:nvPr/>
         </p:nvPicPr>
         <p:blipFill>
-          <a:blip xmlns:r="http://schemas.openxmlformats.org/officeDocument/2006/relationships" xmlns:a="http://schemas.openxmlformats.org/drawingml/2006/main" r:embed="Rab67d93ec0af43d7"/>
+          <a:blip xmlns:r="http://schemas.openxmlformats.org/officeDocument/2006/relationships" xmlns:a="http://schemas.openxmlformats.org/drawingml/2006/main" r:embed="R67ea943eb6bd45ba"/>
           <a:srcRect xmlns:a="http://schemas.openxmlformats.org/drawingml/2006/main" l="0" t="0" r="0" b="0"/>
           <a:stretch xmlns:a="http://schemas.openxmlformats.org/drawingml/2006/main">
             <a:fillRect l="0" t="0" r="0" b="0"/>
@@ -20890,7 +21036,7 @@
           <p:cNvPr id="2" name="">
             <a:extLst xmlns:a="http://schemas.openxmlformats.org/drawingml/2006/main">
               <a:ext uri="{FF2B5EF4-FFF2-40B4-BE49-F238E27FC236}">
-                <a16:creationId xmlns:a16="http://schemas.microsoft.com/office/drawing/2014/main" id="{6745B183-5879-43C0-B37D-DBC39F1D7A7A}"/>
+                <a16:creationId xmlns:a16="http://schemas.microsoft.com/office/drawing/2014/main" id="{6A76169C-66DC-4947-889F-B24E55BE6C1D}"/>
               </a:ext>
             </a:extLst>
           </p:cNvPr>
@@ -20958,7 +21104,7 @@
           <p:cNvPr id="3" name="">
             <a:extLst xmlns:a="http://schemas.openxmlformats.org/drawingml/2006/main">
               <a:ext uri="{FF2B5EF4-FFF2-40B4-BE49-F238E27FC236}">
-                <a16:creationId xmlns:a16="http://schemas.microsoft.com/office/drawing/2014/main" id="{E9093041-6B4D-4C77-A1E0-EF1A2FC9F0B4}"/>
+                <a16:creationId xmlns:a16="http://schemas.microsoft.com/office/drawing/2014/main" id="{B37F327A-7BE4-4935-930C-9B8D095415C1}"/>
               </a:ext>
             </a:extLst>
           </p:cNvPr>
@@ -21049,7 +21195,7 @@
           <p:cNvPr id="4" name="">
             <a:extLst xmlns:a="http://schemas.openxmlformats.org/drawingml/2006/main">
               <a:ext uri="{FF2B5EF4-FFF2-40B4-BE49-F238E27FC236}">
-                <a16:creationId xmlns:a16="http://schemas.microsoft.com/office/drawing/2014/main" id="{5BBD028E-963E-4F21-B239-F8D0B0EFE7E5}"/>
+                <a16:creationId xmlns:a16="http://schemas.microsoft.com/office/drawing/2014/main" id="{B2E7733A-55F5-486E-ACD0-2CFBACE8D651}"/>
               </a:ext>
             </a:extLst>
           </p:cNvPr>
@@ -21140,7 +21286,7 @@
           <p:cNvPr id="5" name="">
             <a:extLst xmlns:a="http://schemas.openxmlformats.org/drawingml/2006/main">
               <a:ext uri="{FF2B5EF4-FFF2-40B4-BE49-F238E27FC236}">
-                <a16:creationId xmlns:a16="http://schemas.microsoft.com/office/drawing/2014/main" id="{D004F636-D40C-421B-BDB9-5C00DC717BD3}"/>
+                <a16:creationId xmlns:a16="http://schemas.microsoft.com/office/drawing/2014/main" id="{F26AD833-74AC-4FA8-8A0F-1E67916CCFF0}"/>
               </a:ext>
             </a:extLst>
           </p:cNvPr>
@@ -21231,7 +21377,7 @@
           <p:cNvPr id="6" name="">
             <a:extLst xmlns:a="http://schemas.openxmlformats.org/drawingml/2006/main">
               <a:ext uri="{FF2B5EF4-FFF2-40B4-BE49-F238E27FC236}">
-                <a16:creationId xmlns:a16="http://schemas.microsoft.com/office/drawing/2014/main" id="{943E3753-B2C5-493E-BB9F-9CEE7DA98750}"/>
+                <a16:creationId xmlns:a16="http://schemas.microsoft.com/office/drawing/2014/main" id="{E5ED4A5B-D66C-45FD-8225-E39A294558EE}"/>
               </a:ext>
             </a:extLst>
           </p:cNvPr>
@@ -21297,7 +21443,7 @@
     </p:spTree>
     <p:extLst>
       <p:ext uri="{BB962C8B-B14F-4D97-AF65-F5344CB8AC3E}">
-        <p14:creationId xmlns:p14="http://schemas.microsoft.com/office/powerpoint/2010/main" val="2032107229"/>
+        <p14:creationId xmlns:p14="http://schemas.microsoft.com/office/powerpoint/2010/main" val="569441211"/>
       </p:ext>
     </p:extLst>
   </p:cSld>
@@ -21328,7 +21474,7 @@
           <p:cNvPr id="12" name="">
             <a:extLst xmlns:a="http://schemas.openxmlformats.org/drawingml/2006/main">
               <a:ext uri="{FF2B5EF4-FFF2-40B4-BE49-F238E27FC236}">
-                <a16:creationId xmlns:a16="http://schemas.microsoft.com/office/drawing/2014/main" id="{0D7AD33E-5849-44C4-88C2-F3D898E75A49}"/>
+                <a16:creationId xmlns:a16="http://schemas.microsoft.com/office/drawing/2014/main" id="{524FD594-9B09-4BD6-8033-5501EDEFE799}"/>
               </a:ext>
             </a:extLst>
           </p:cNvPr>
@@ -21338,7 +21484,7 @@
           <p:nvPr/>
         </p:nvPicPr>
         <p:blipFill>
-          <a:blip xmlns:r="http://schemas.openxmlformats.org/officeDocument/2006/relationships" xmlns:a="http://schemas.openxmlformats.org/drawingml/2006/main" r:embed="R7a45e8f2e0a94ce3"/>
+          <a:blip xmlns:r="http://schemas.openxmlformats.org/officeDocument/2006/relationships" xmlns:a="http://schemas.openxmlformats.org/drawingml/2006/main" r:embed="R465fabb2ae8b4ddf"/>
           <a:srcRect xmlns:a="http://schemas.openxmlformats.org/drawingml/2006/main" l="0" t="0" r="0" b="0"/>
           <a:stretch xmlns:a="http://schemas.openxmlformats.org/drawingml/2006/main">
             <a:fillRect l="0" t="0" r="0" b="0"/>
@@ -21359,7 +21505,7 @@
           <p:cNvPr id="2" name="">
             <a:extLst xmlns:a="http://schemas.openxmlformats.org/drawingml/2006/main">
               <a:ext uri="{FF2B5EF4-FFF2-40B4-BE49-F238E27FC236}">
-                <a16:creationId xmlns:a16="http://schemas.microsoft.com/office/drawing/2014/main" id="{F487AA55-B411-4852-A105-F8E7AB26498A}"/>
+                <a16:creationId xmlns:a16="http://schemas.microsoft.com/office/drawing/2014/main" id="{B6DFE2DC-C174-45FC-A2CE-AE8F5E3791A3}"/>
               </a:ext>
             </a:extLst>
           </p:cNvPr>
@@ -21427,7 +21573,7 @@
           <p:cNvPr id="3" name="">
             <a:extLst xmlns:a="http://schemas.openxmlformats.org/drawingml/2006/main">
               <a:ext uri="{FF2B5EF4-FFF2-40B4-BE49-F238E27FC236}">
-                <a16:creationId xmlns:a16="http://schemas.microsoft.com/office/drawing/2014/main" id="{03C6CF9A-23B5-4732-A67C-4864DF781636}"/>
+                <a16:creationId xmlns:a16="http://schemas.microsoft.com/office/drawing/2014/main" id="{0315A6F8-5AA6-4272-805D-438EBDF74233}"/>
               </a:ext>
             </a:extLst>
           </p:cNvPr>
@@ -21495,7 +21641,7 @@
           <p:cNvPr id="4" name="">
             <a:extLst xmlns:a="http://schemas.openxmlformats.org/drawingml/2006/main">
               <a:ext uri="{FF2B5EF4-FFF2-40B4-BE49-F238E27FC236}">
-                <a16:creationId xmlns:a16="http://schemas.microsoft.com/office/drawing/2014/main" id="{98880631-2ECF-4AF5-9FAD-29BF48F3B29F}"/>
+                <a16:creationId xmlns:a16="http://schemas.microsoft.com/office/drawing/2014/main" id="{59A9C8AA-9C2C-44BD-AE0B-FCF93F9AE781}"/>
               </a:ext>
             </a:extLst>
           </p:cNvPr>
@@ -21563,7 +21709,7 @@
           <p:cNvPr id="5" name="">
             <a:extLst xmlns:a="http://schemas.openxmlformats.org/drawingml/2006/main">
               <a:ext uri="{FF2B5EF4-FFF2-40B4-BE49-F238E27FC236}">
-                <a16:creationId xmlns:a16="http://schemas.microsoft.com/office/drawing/2014/main" id="{A07204D7-315B-4DA2-979F-D2B150609A24}"/>
+                <a16:creationId xmlns:a16="http://schemas.microsoft.com/office/drawing/2014/main" id="{EB1A2CA9-9E4F-47EB-9175-E47F5F5A8905}"/>
               </a:ext>
             </a:extLst>
           </p:cNvPr>
@@ -21573,7 +21719,7 @@
           <p:nvPr/>
         </p:nvPicPr>
         <p:blipFill>
-          <a:blip xmlns:r="http://schemas.openxmlformats.org/officeDocument/2006/relationships" xmlns:a="http://schemas.openxmlformats.org/drawingml/2006/main" r:embed="R7dc8947d29b24168"/>
+          <a:blip xmlns:r="http://schemas.openxmlformats.org/officeDocument/2006/relationships" xmlns:a="http://schemas.openxmlformats.org/drawingml/2006/main" r:embed="R73f645de36ea487e"/>
           <a:stretch xmlns:a="http://schemas.openxmlformats.org/drawingml/2006/main"/>
         </p:blipFill>
         <p:spPr>
@@ -21591,7 +21737,7 @@
           <p:cNvPr id="6" name="">
             <a:extLst xmlns:a="http://schemas.openxmlformats.org/drawingml/2006/main">
               <a:ext uri="{FF2B5EF4-FFF2-40B4-BE49-F238E27FC236}">
-                <a16:creationId xmlns:a16="http://schemas.microsoft.com/office/drawing/2014/main" id="{D5AF2F5F-D7D8-4044-B3BD-9D8BCC8724DF}"/>
+                <a16:creationId xmlns:a16="http://schemas.microsoft.com/office/drawing/2014/main" id="{DCA786A9-1FDD-4D90-8E5D-F6AB6772F349}"/>
               </a:ext>
             </a:extLst>
           </p:cNvPr>
@@ -21659,7 +21805,7 @@
           <p:cNvPr id="7" name="">
             <a:extLst xmlns:a="http://schemas.openxmlformats.org/drawingml/2006/main">
               <a:ext uri="{FF2B5EF4-FFF2-40B4-BE49-F238E27FC236}">
-                <a16:creationId xmlns:a16="http://schemas.microsoft.com/office/drawing/2014/main" id="{AE692E1F-29A8-4C23-9BAE-53601B08D43E}"/>
+                <a16:creationId xmlns:a16="http://schemas.microsoft.com/office/drawing/2014/main" id="{82218D36-B990-4188-8932-EB33858980BA}"/>
               </a:ext>
             </a:extLst>
           </p:cNvPr>
@@ -21750,7 +21896,7 @@
           <p:cNvPr id="8" name="">
             <a:extLst xmlns:a="http://schemas.openxmlformats.org/drawingml/2006/main">
               <a:ext uri="{FF2B5EF4-FFF2-40B4-BE49-F238E27FC236}">
-                <a16:creationId xmlns:a16="http://schemas.microsoft.com/office/drawing/2014/main" id="{53E8C83F-CAB1-4D8B-AECF-9296BE45E2EA}"/>
+                <a16:creationId xmlns:a16="http://schemas.microsoft.com/office/drawing/2014/main" id="{3A804D26-DEC5-4B25-AF49-B81E78558EAE}"/>
               </a:ext>
             </a:extLst>
           </p:cNvPr>
@@ -21760,7 +21906,7 @@
           <p:nvPr/>
         </p:nvPicPr>
         <p:blipFill>
-          <a:blip xmlns:r="http://schemas.openxmlformats.org/officeDocument/2006/relationships" xmlns:a="http://schemas.openxmlformats.org/drawingml/2006/main" r:embed="R9bbba43297354adc"/>
+          <a:blip xmlns:r="http://schemas.openxmlformats.org/officeDocument/2006/relationships" xmlns:a="http://schemas.openxmlformats.org/drawingml/2006/main" r:embed="Re9f6de7958444821"/>
           <a:stretch xmlns:a="http://schemas.openxmlformats.org/drawingml/2006/main"/>
         </p:blipFill>
         <p:spPr>
@@ -21778,7 +21924,7 @@
           <p:cNvPr id="9" name="">
             <a:extLst xmlns:a="http://schemas.openxmlformats.org/drawingml/2006/main">
               <a:ext uri="{FF2B5EF4-FFF2-40B4-BE49-F238E27FC236}">
-                <a16:creationId xmlns:a16="http://schemas.microsoft.com/office/drawing/2014/main" id="{98FEB22C-C1F1-4ABE-A101-454C11FD7C4B}"/>
+                <a16:creationId xmlns:a16="http://schemas.microsoft.com/office/drawing/2014/main" id="{3C3E8736-74DB-4618-AD39-387F5FF4C3A4}"/>
               </a:ext>
             </a:extLst>
           </p:cNvPr>
@@ -21846,7 +21992,7 @@
           <p:cNvPr id="10" name="">
             <a:extLst xmlns:a="http://schemas.openxmlformats.org/drawingml/2006/main">
               <a:ext uri="{FF2B5EF4-FFF2-40B4-BE49-F238E27FC236}">
-                <a16:creationId xmlns:a16="http://schemas.microsoft.com/office/drawing/2014/main" id="{9FB1EB72-9116-405A-B830-8A85DBD84EA7}"/>
+                <a16:creationId xmlns:a16="http://schemas.microsoft.com/office/drawing/2014/main" id="{C4CE5C17-21C9-4690-9A24-737EEEECF956}"/>
               </a:ext>
             </a:extLst>
           </p:cNvPr>
@@ -21937,7 +22083,7 @@
           <p:cNvPr id="11" name="">
             <a:extLst xmlns:a="http://schemas.openxmlformats.org/drawingml/2006/main">
               <a:ext uri="{FF2B5EF4-FFF2-40B4-BE49-F238E27FC236}">
-                <a16:creationId xmlns:a16="http://schemas.microsoft.com/office/drawing/2014/main" id="{A552C021-7B9D-4901-9AB0-CE425B7A87DB}"/>
+                <a16:creationId xmlns:a16="http://schemas.microsoft.com/office/drawing/2014/main" id="{8FF836D0-4BA4-4ABB-8E64-45A168F5A454}"/>
               </a:ext>
             </a:extLst>
           </p:cNvPr>
@@ -22003,7 +22149,7 @@
     </p:spTree>
     <p:extLst>
       <p:ext uri="{BB962C8B-B14F-4D97-AF65-F5344CB8AC3E}">
-        <p14:creationId xmlns:p14="http://schemas.microsoft.com/office/powerpoint/2010/main" val="683053605"/>
+        <p14:creationId xmlns:p14="http://schemas.microsoft.com/office/powerpoint/2010/main" val="1678179826"/>
       </p:ext>
     </p:extLst>
   </p:cSld>
@@ -22034,7 +22180,7 @@
           <p:cNvPr id="15" name="">
             <a:extLst xmlns:a="http://schemas.openxmlformats.org/drawingml/2006/main">
               <a:ext uri="{FF2B5EF4-FFF2-40B4-BE49-F238E27FC236}">
-                <a16:creationId xmlns:a16="http://schemas.microsoft.com/office/drawing/2014/main" id="{059199B5-54FD-43C2-81B3-E5CB915FC794}"/>
+                <a16:creationId xmlns:a16="http://schemas.microsoft.com/office/drawing/2014/main" id="{E50D9338-2684-46BE-813D-78A15FE91284}"/>
               </a:ext>
             </a:extLst>
           </p:cNvPr>
@@ -22044,7 +22190,7 @@
           <p:nvPr/>
         </p:nvPicPr>
         <p:blipFill>
-          <a:blip xmlns:r="http://schemas.openxmlformats.org/officeDocument/2006/relationships" xmlns:a="http://schemas.openxmlformats.org/drawingml/2006/main" r:embed="R202a3278b2b7426f"/>
+          <a:blip xmlns:r="http://schemas.openxmlformats.org/officeDocument/2006/relationships" xmlns:a="http://schemas.openxmlformats.org/drawingml/2006/main" r:embed="R90aad067bd884ab1"/>
           <a:srcRect xmlns:a="http://schemas.openxmlformats.org/drawingml/2006/main" l="0" t="0" r="0" b="0"/>
           <a:stretch xmlns:a="http://schemas.openxmlformats.org/drawingml/2006/main">
             <a:fillRect l="0" t="0" r="0" b="0"/>
@@ -22065,7 +22211,7 @@
           <p:cNvPr id="2" name="">
             <a:extLst xmlns:a="http://schemas.openxmlformats.org/drawingml/2006/main">
               <a:ext uri="{FF2B5EF4-FFF2-40B4-BE49-F238E27FC236}">
-                <a16:creationId xmlns:a16="http://schemas.microsoft.com/office/drawing/2014/main" id="{3D174D38-0FB7-4A8B-B311-71C56903E8F0}"/>
+                <a16:creationId xmlns:a16="http://schemas.microsoft.com/office/drawing/2014/main" id="{6B193FE6-093D-4872-9D99-9486A213725D}"/>
               </a:ext>
             </a:extLst>
           </p:cNvPr>
@@ -22133,7 +22279,7 @@
           <p:cNvPr id="3" name="">
             <a:extLst xmlns:a="http://schemas.openxmlformats.org/drawingml/2006/main">
               <a:ext uri="{FF2B5EF4-FFF2-40B4-BE49-F238E27FC236}">
-                <a16:creationId xmlns:a16="http://schemas.microsoft.com/office/drawing/2014/main" id="{C159F36D-4E50-435C-921A-259E52F1E836}"/>
+                <a16:creationId xmlns:a16="http://schemas.microsoft.com/office/drawing/2014/main" id="{FDD9055B-AE2B-4950-983B-0821233A1CB1}"/>
               </a:ext>
             </a:extLst>
           </p:cNvPr>
@@ -22201,7 +22347,7 @@
           <p:cNvPr id="4" name="">
             <a:extLst xmlns:a="http://schemas.openxmlformats.org/drawingml/2006/main">
               <a:ext uri="{FF2B5EF4-FFF2-40B4-BE49-F238E27FC236}">
-                <a16:creationId xmlns:a16="http://schemas.microsoft.com/office/drawing/2014/main" id="{360443AB-A3EA-45FD-B9D6-CA7515BDBB39}"/>
+                <a16:creationId xmlns:a16="http://schemas.microsoft.com/office/drawing/2014/main" id="{76D2B4CE-ECCC-4F61-90FE-383CA4E6CB02}"/>
               </a:ext>
             </a:extLst>
           </p:cNvPr>
@@ -22269,7 +22415,7 @@
           <p:cNvPr id="5" name="">
             <a:extLst xmlns:a="http://schemas.openxmlformats.org/drawingml/2006/main">
               <a:ext uri="{FF2B5EF4-FFF2-40B4-BE49-F238E27FC236}">
-                <a16:creationId xmlns:a16="http://schemas.microsoft.com/office/drawing/2014/main" id="{919911C6-A743-43B8-B38E-9C1269F91D3A}"/>
+                <a16:creationId xmlns:a16="http://schemas.microsoft.com/office/drawing/2014/main" id="{6F3A6A34-FE2D-4005-89FC-6111CA031F72}"/>
               </a:ext>
             </a:extLst>
           </p:cNvPr>
@@ -22337,7 +22483,7 @@
           <p:cNvPr id="6" name="">
             <a:extLst xmlns:a="http://schemas.openxmlformats.org/drawingml/2006/main">
               <a:ext uri="{FF2B5EF4-FFF2-40B4-BE49-F238E27FC236}">
-                <a16:creationId xmlns:a16="http://schemas.microsoft.com/office/drawing/2014/main" id="{BF625452-963F-4346-93AB-B8632EE66CE4}"/>
+                <a16:creationId xmlns:a16="http://schemas.microsoft.com/office/drawing/2014/main" id="{678571DB-84D3-4260-9263-ADD63BF02AF4}"/>
               </a:ext>
             </a:extLst>
           </p:cNvPr>
@@ -22405,7 +22551,7 @@
           <p:cNvPr id="7" name="">
             <a:extLst xmlns:a="http://schemas.openxmlformats.org/drawingml/2006/main">
               <a:ext uri="{FF2B5EF4-FFF2-40B4-BE49-F238E27FC236}">
-                <a16:creationId xmlns:a16="http://schemas.microsoft.com/office/drawing/2014/main" id="{F0A3B94D-9F8E-464A-B63B-DF44AB83B8ED}"/>
+                <a16:creationId xmlns:a16="http://schemas.microsoft.com/office/drawing/2014/main" id="{A21B9604-62EB-48D4-B02C-FD17BB12D5F4}"/>
               </a:ext>
             </a:extLst>
           </p:cNvPr>
@@ -22473,7 +22619,7 @@
           <p:cNvPr id="8" name="">
             <a:extLst xmlns:a="http://schemas.openxmlformats.org/drawingml/2006/main">
               <a:ext uri="{FF2B5EF4-FFF2-40B4-BE49-F238E27FC236}">
-                <a16:creationId xmlns:a16="http://schemas.microsoft.com/office/drawing/2014/main" id="{BF32CD8B-124C-4F9A-8730-74CF26D9DD31}"/>
+                <a16:creationId xmlns:a16="http://schemas.microsoft.com/office/drawing/2014/main" id="{0957001F-B0E8-40F2-B52C-9E254BA23FFD}"/>
               </a:ext>
             </a:extLst>
           </p:cNvPr>
@@ -22541,7 +22687,7 @@
           <p:cNvPr id="9" name="">
             <a:extLst xmlns:a="http://schemas.openxmlformats.org/drawingml/2006/main">
               <a:ext uri="{FF2B5EF4-FFF2-40B4-BE49-F238E27FC236}">
-                <a16:creationId xmlns:a16="http://schemas.microsoft.com/office/drawing/2014/main" id="{14C89A2F-7414-42A3-BD04-9908D94C44F6}"/>
+                <a16:creationId xmlns:a16="http://schemas.microsoft.com/office/drawing/2014/main" id="{0C47B29D-B72D-4140-9E41-869231C565ED}"/>
               </a:ext>
             </a:extLst>
           </p:cNvPr>
@@ -22609,7 +22755,7 @@
           <p:cNvPr id="10" name="">
             <a:extLst xmlns:a="http://schemas.openxmlformats.org/drawingml/2006/main">
               <a:ext uri="{FF2B5EF4-FFF2-40B4-BE49-F238E27FC236}">
-                <a16:creationId xmlns:a16="http://schemas.microsoft.com/office/drawing/2014/main" id="{A101C52B-916F-4535-AFB0-67531F550FF6}"/>
+                <a16:creationId xmlns:a16="http://schemas.microsoft.com/office/drawing/2014/main" id="{F2967C51-22CA-4E00-AEFC-916681C2C6CB}"/>
               </a:ext>
             </a:extLst>
           </p:cNvPr>
@@ -22700,7 +22846,7 @@
           <p:cNvPr id="11" name="">
             <a:extLst xmlns:a="http://schemas.openxmlformats.org/drawingml/2006/main">
               <a:ext uri="{FF2B5EF4-FFF2-40B4-BE49-F238E27FC236}">
-                <a16:creationId xmlns:a16="http://schemas.microsoft.com/office/drawing/2014/main" id="{5971B9A9-6EE3-4571-AB32-79288D864BEC}"/>
+                <a16:creationId xmlns:a16="http://schemas.microsoft.com/office/drawing/2014/main" id="{3CEB565E-E71C-48DB-A727-BB7E20C33F58}"/>
               </a:ext>
             </a:extLst>
           </p:cNvPr>
@@ -22768,7 +22914,7 @@
           <p:cNvPr id="12" name="">
             <a:extLst xmlns:a="http://schemas.openxmlformats.org/drawingml/2006/main">
               <a:ext uri="{FF2B5EF4-FFF2-40B4-BE49-F238E27FC236}">
-                <a16:creationId xmlns:a16="http://schemas.microsoft.com/office/drawing/2014/main" id="{0254CC70-E21D-4B8F-9213-D1DF8F46EFC7}"/>
+                <a16:creationId xmlns:a16="http://schemas.microsoft.com/office/drawing/2014/main" id="{3B515548-DF77-47E1-83E8-1E80CDCDE5D3}"/>
               </a:ext>
             </a:extLst>
           </p:cNvPr>
@@ -22836,7 +22982,7 @@
           <p:cNvPr id="13" name="">
             <a:extLst xmlns:a="http://schemas.openxmlformats.org/drawingml/2006/main">
               <a:ext uri="{FF2B5EF4-FFF2-40B4-BE49-F238E27FC236}">
-                <a16:creationId xmlns:a16="http://schemas.microsoft.com/office/drawing/2014/main" id="{DEFE0EA1-D050-4ED5-B9F0-99B8BBD77F49}"/>
+                <a16:creationId xmlns:a16="http://schemas.microsoft.com/office/drawing/2014/main" id="{7B114E86-108D-4A05-AC90-5AB4C14629FA}"/>
               </a:ext>
             </a:extLst>
           </p:cNvPr>
@@ -22927,7 +23073,7 @@
           <p:cNvPr id="14" name="">
             <a:extLst xmlns:a="http://schemas.openxmlformats.org/drawingml/2006/main">
               <a:ext uri="{FF2B5EF4-FFF2-40B4-BE49-F238E27FC236}">
-                <a16:creationId xmlns:a16="http://schemas.microsoft.com/office/drawing/2014/main" id="{6FCEE00E-2086-49B7-9CBF-19FEAFDF7BD6}"/>
+                <a16:creationId xmlns:a16="http://schemas.microsoft.com/office/drawing/2014/main" id="{BC37449D-0D5D-4CB1-B003-0388BB295E58}"/>
               </a:ext>
             </a:extLst>
           </p:cNvPr>
@@ -22993,7 +23139,7 @@
     </p:spTree>
     <p:extLst>
       <p:ext uri="{BB962C8B-B14F-4D97-AF65-F5344CB8AC3E}">
-        <p14:creationId xmlns:p14="http://schemas.microsoft.com/office/powerpoint/2010/main" val="1549668552"/>
+        <p14:creationId xmlns:p14="http://schemas.microsoft.com/office/powerpoint/2010/main" val="610062328"/>
       </p:ext>
     </p:extLst>
   </p:cSld>
@@ -23024,7 +23170,7 @@
           <p:cNvPr id="17" name="">
             <a:extLst xmlns:a="http://schemas.openxmlformats.org/drawingml/2006/main">
               <a:ext uri="{FF2B5EF4-FFF2-40B4-BE49-F238E27FC236}">
-                <a16:creationId xmlns:a16="http://schemas.microsoft.com/office/drawing/2014/main" id="{1B908624-DB77-4BC3-884A-870F8AEC0449}"/>
+                <a16:creationId xmlns:a16="http://schemas.microsoft.com/office/drawing/2014/main" id="{97BFF876-9B2D-4F8F-8F5F-3127F47B8F66}"/>
               </a:ext>
             </a:extLst>
           </p:cNvPr>
@@ -23092,7 +23238,7 @@
           <p:cNvPr id="2" name="">
             <a:extLst xmlns:a="http://schemas.openxmlformats.org/drawingml/2006/main">
               <a:ext uri="{FF2B5EF4-FFF2-40B4-BE49-F238E27FC236}">
-                <a16:creationId xmlns:a16="http://schemas.microsoft.com/office/drawing/2014/main" id="{580A174C-88A2-439D-8AEB-B8CE6E538013}"/>
+                <a16:creationId xmlns:a16="http://schemas.microsoft.com/office/drawing/2014/main" id="{BA41239A-370A-429A-BC39-83843989AD3D}"/>
               </a:ext>
             </a:extLst>
           </p:cNvPr>
@@ -23160,7 +23306,7 @@
           <p:cNvPr id="3" name="">
             <a:extLst xmlns:a="http://schemas.openxmlformats.org/drawingml/2006/main">
               <a:ext uri="{FF2B5EF4-FFF2-40B4-BE49-F238E27FC236}">
-                <a16:creationId xmlns:a16="http://schemas.microsoft.com/office/drawing/2014/main" id="{0DE538EA-BD67-4A5E-B553-889F67E022AA}"/>
+                <a16:creationId xmlns:a16="http://schemas.microsoft.com/office/drawing/2014/main" id="{0FE54AF7-D163-4E4E-AA18-BF4B57F8C866}"/>
               </a:ext>
             </a:extLst>
           </p:cNvPr>
@@ -23228,7 +23374,7 @@
           <p:cNvPr id="4" name="">
             <a:extLst xmlns:a="http://schemas.openxmlformats.org/drawingml/2006/main">
               <a:ext uri="{FF2B5EF4-FFF2-40B4-BE49-F238E27FC236}">
-                <a16:creationId xmlns:a16="http://schemas.microsoft.com/office/drawing/2014/main" id="{517D5881-EE66-453D-9C75-5559C079A7B9}"/>
+                <a16:creationId xmlns:a16="http://schemas.microsoft.com/office/drawing/2014/main" id="{D01C8CEB-EA45-4DD3-9833-3595559913BC}"/>
               </a:ext>
             </a:extLst>
           </p:cNvPr>
@@ -23238,7 +23384,7 @@
           <p:nvPr/>
         </p:nvPicPr>
         <p:blipFill>
-          <a:blip xmlns:r="http://schemas.openxmlformats.org/officeDocument/2006/relationships" xmlns:a="http://schemas.openxmlformats.org/drawingml/2006/main" r:embed="R45b1ebc28cd3416a"/>
+          <a:blip xmlns:r="http://schemas.openxmlformats.org/officeDocument/2006/relationships" xmlns:a="http://schemas.openxmlformats.org/drawingml/2006/main" r:embed="R990c11bb78624feb"/>
           <a:stretch xmlns:a="http://schemas.openxmlformats.org/drawingml/2006/main"/>
         </p:blipFill>
         <p:spPr>
@@ -23256,7 +23402,7 @@
           <p:cNvPr id="5" name="">
             <a:extLst xmlns:a="http://schemas.openxmlformats.org/drawingml/2006/main">
               <a:ext uri="{FF2B5EF4-FFF2-40B4-BE49-F238E27FC236}">
-                <a16:creationId xmlns:a16="http://schemas.microsoft.com/office/drawing/2014/main" id="{9AF24884-A02B-4ACC-9059-1841928ED25E}"/>
+                <a16:creationId xmlns:a16="http://schemas.microsoft.com/office/drawing/2014/main" id="{8365D75A-BD6F-4B9A-9250-F71ED83224D1}"/>
               </a:ext>
             </a:extLst>
           </p:cNvPr>
@@ -23324,7 +23470,7 @@
           <p:cNvPr id="6" name="">
             <a:extLst xmlns:a="http://schemas.openxmlformats.org/drawingml/2006/main">
               <a:ext uri="{FF2B5EF4-FFF2-40B4-BE49-F238E27FC236}">
-                <a16:creationId xmlns:a16="http://schemas.microsoft.com/office/drawing/2014/main" id="{6BF3F627-E10D-4B3D-A975-0F91292C838E}"/>
+                <a16:creationId xmlns:a16="http://schemas.microsoft.com/office/drawing/2014/main" id="{17DA0168-44A3-4F6A-A78A-C8C58ED042E8}"/>
               </a:ext>
             </a:extLst>
           </p:cNvPr>
@@ -23392,7 +23538,7 @@
           <p:cNvPr id="7" name="">
             <a:extLst xmlns:a="http://schemas.openxmlformats.org/drawingml/2006/main">
               <a:ext uri="{FF2B5EF4-FFF2-40B4-BE49-F238E27FC236}">
-                <a16:creationId xmlns:a16="http://schemas.microsoft.com/office/drawing/2014/main" id="{4A825E4A-F92E-49CB-9907-C64DE8B7906A}"/>
+                <a16:creationId xmlns:a16="http://schemas.microsoft.com/office/drawing/2014/main" id="{E14E5F90-8560-40B3-ACE5-86D1A5D8689E}"/>
               </a:ext>
             </a:extLst>
           </p:cNvPr>
@@ -23402,7 +23548,7 @@
           <p:nvPr/>
         </p:nvPicPr>
         <p:blipFill>
-          <a:blip xmlns:r="http://schemas.openxmlformats.org/officeDocument/2006/relationships" xmlns:a="http://schemas.openxmlformats.org/drawingml/2006/main" r:embed="R4cf2a28ba3b743a2"/>
+          <a:blip xmlns:r="http://schemas.openxmlformats.org/officeDocument/2006/relationships" xmlns:a="http://schemas.openxmlformats.org/drawingml/2006/main" r:embed="R77237a4fe7b64503"/>
           <a:stretch xmlns:a="http://schemas.openxmlformats.org/drawingml/2006/main"/>
         </p:blipFill>
         <p:spPr>
@@ -23420,7 +23566,7 @@
           <p:cNvPr id="8" name="">
             <a:extLst xmlns:a="http://schemas.openxmlformats.org/drawingml/2006/main">
               <a:ext uri="{FF2B5EF4-FFF2-40B4-BE49-F238E27FC236}">
-                <a16:creationId xmlns:a16="http://schemas.microsoft.com/office/drawing/2014/main" id="{0F5CD0FA-3D59-4F7C-9C76-3DB059CF6E6D}"/>
+                <a16:creationId xmlns:a16="http://schemas.microsoft.com/office/drawing/2014/main" id="{64E0A567-864F-4807-8649-411ED4B85065}"/>
               </a:ext>
             </a:extLst>
           </p:cNvPr>
@@ -23488,7 +23634,7 @@
           <p:cNvPr id="9" name="">
             <a:extLst xmlns:a="http://schemas.openxmlformats.org/drawingml/2006/main">
               <a:ext uri="{FF2B5EF4-FFF2-40B4-BE49-F238E27FC236}">
-                <a16:creationId xmlns:a16="http://schemas.microsoft.com/office/drawing/2014/main" id="{42ECDB5A-8740-4743-80F8-1D58F3082BB1}"/>
+                <a16:creationId xmlns:a16="http://schemas.microsoft.com/office/drawing/2014/main" id="{DEC6B58F-E2D4-4CB1-84D9-B4D8F8B156DA}"/>
               </a:ext>
             </a:extLst>
           </p:cNvPr>
@@ -23556,7 +23702,7 @@
           <p:cNvPr id="10" name="">
             <a:extLst xmlns:a="http://schemas.openxmlformats.org/drawingml/2006/main">
               <a:ext uri="{FF2B5EF4-FFF2-40B4-BE49-F238E27FC236}">
-                <a16:creationId xmlns:a16="http://schemas.microsoft.com/office/drawing/2014/main" id="{93910515-75DB-43F9-86D7-62AC3A385C39}"/>
+                <a16:creationId xmlns:a16="http://schemas.microsoft.com/office/drawing/2014/main" id="{547A90C8-C700-4229-BAA8-63A7A94E09B8}"/>
               </a:ext>
             </a:extLst>
           </p:cNvPr>
@@ -23566,7 +23712,7 @@
           <p:nvPr/>
         </p:nvPicPr>
         <p:blipFill>
-          <a:blip xmlns:r="http://schemas.openxmlformats.org/officeDocument/2006/relationships" xmlns:a="http://schemas.openxmlformats.org/drawingml/2006/main" r:embed="Ra841142237984876"/>
+          <a:blip xmlns:r="http://schemas.openxmlformats.org/officeDocument/2006/relationships" xmlns:a="http://schemas.openxmlformats.org/drawingml/2006/main" r:embed="Re8bb15efd4a84fac"/>
           <a:stretch xmlns:a="http://schemas.openxmlformats.org/drawingml/2006/main"/>
         </p:blipFill>
         <p:spPr>
@@ -23584,7 +23730,7 @@
           <p:cNvPr id="11" name="">
             <a:extLst xmlns:a="http://schemas.openxmlformats.org/drawingml/2006/main">
               <a:ext uri="{FF2B5EF4-FFF2-40B4-BE49-F238E27FC236}">
-                <a16:creationId xmlns:a16="http://schemas.microsoft.com/office/drawing/2014/main" id="{7EAEB1CE-EF28-4AB0-AE23-9DBE76A40A78}"/>
+                <a16:creationId xmlns:a16="http://schemas.microsoft.com/office/drawing/2014/main" id="{89CEA9AD-4D9B-4CEB-B749-0A84AFD85813}"/>
               </a:ext>
             </a:extLst>
           </p:cNvPr>
@@ -23652,7 +23798,7 @@
           <p:cNvPr id="12" name="">
             <a:extLst xmlns:a="http://schemas.openxmlformats.org/drawingml/2006/main">
               <a:ext uri="{FF2B5EF4-FFF2-40B4-BE49-F238E27FC236}">
-                <a16:creationId xmlns:a16="http://schemas.microsoft.com/office/drawing/2014/main" id="{BAAD2682-BC55-4CCB-884E-7B60BF263DDD}"/>
+                <a16:creationId xmlns:a16="http://schemas.microsoft.com/office/drawing/2014/main" id="{DDCD19E2-7222-4D33-9681-C8C0215FBA34}"/>
               </a:ext>
             </a:extLst>
           </p:cNvPr>
@@ -23720,7 +23866,7 @@
           <p:cNvPr id="13" name="">
             <a:extLst xmlns:a="http://schemas.openxmlformats.org/drawingml/2006/main">
               <a:ext uri="{FF2B5EF4-FFF2-40B4-BE49-F238E27FC236}">
-                <a16:creationId xmlns:a16="http://schemas.microsoft.com/office/drawing/2014/main" id="{E2FDAD46-ED62-442E-A1EB-5547095D332C}"/>
+                <a16:creationId xmlns:a16="http://schemas.microsoft.com/office/drawing/2014/main" id="{D1087D4C-2F7A-49A6-B30B-9EC8F2D810A9}"/>
               </a:ext>
             </a:extLst>
           </p:cNvPr>
@@ -23730,7 +23876,7 @@
           <p:nvPr/>
         </p:nvPicPr>
         <p:blipFill>
-          <a:blip xmlns:r="http://schemas.openxmlformats.org/officeDocument/2006/relationships" xmlns:a="http://schemas.openxmlformats.org/drawingml/2006/main" r:embed="R30bf8441b85e4e88"/>
+          <a:blip xmlns:r="http://schemas.openxmlformats.org/officeDocument/2006/relationships" xmlns:a="http://schemas.openxmlformats.org/drawingml/2006/main" r:embed="R0d229df73e644e04"/>
           <a:stretch xmlns:a="http://schemas.openxmlformats.org/drawingml/2006/main"/>
         </p:blipFill>
         <p:spPr>
@@ -23748,7 +23894,7 @@
           <p:cNvPr id="14" name="">
             <a:extLst xmlns:a="http://schemas.openxmlformats.org/drawingml/2006/main">
               <a:ext uri="{FF2B5EF4-FFF2-40B4-BE49-F238E27FC236}">
-                <a16:creationId xmlns:a16="http://schemas.microsoft.com/office/drawing/2014/main" id="{14EDD1B6-56BE-4935-A4F4-7E231391AC8D}"/>
+                <a16:creationId xmlns:a16="http://schemas.microsoft.com/office/drawing/2014/main" id="{A5FB1F4A-C2FB-4631-8095-E81C73C92788}"/>
               </a:ext>
             </a:extLst>
           </p:cNvPr>
@@ -23816,7 +23962,7 @@
           <p:cNvPr id="15" name="">
             <a:extLst xmlns:a="http://schemas.openxmlformats.org/drawingml/2006/main">
               <a:ext uri="{FF2B5EF4-FFF2-40B4-BE49-F238E27FC236}">
-                <a16:creationId xmlns:a16="http://schemas.microsoft.com/office/drawing/2014/main" id="{47BE70F6-DBD3-4207-82A7-4945461D5971}"/>
+                <a16:creationId xmlns:a16="http://schemas.microsoft.com/office/drawing/2014/main" id="{FE0005E6-276B-494C-841C-67C4DAC13984}"/>
               </a:ext>
             </a:extLst>
           </p:cNvPr>
@@ -23884,7 +24030,7 @@
           <p:cNvPr id="16" name="">
             <a:extLst xmlns:a="http://schemas.openxmlformats.org/drawingml/2006/main">
               <a:ext uri="{FF2B5EF4-FFF2-40B4-BE49-F238E27FC236}">
-                <a16:creationId xmlns:a16="http://schemas.microsoft.com/office/drawing/2014/main" id="{A2032A49-FC33-4E94-A801-491ECC484A29}"/>
+                <a16:creationId xmlns:a16="http://schemas.microsoft.com/office/drawing/2014/main" id="{EE72B085-EA79-4F63-9243-C153849F9EF4}"/>
               </a:ext>
             </a:extLst>
           </p:cNvPr>
@@ -23950,7 +24096,7 @@
     </p:spTree>
     <p:extLst>
       <p:ext uri="{BB962C8B-B14F-4D97-AF65-F5344CB8AC3E}">
-        <p14:creationId xmlns:p14="http://schemas.microsoft.com/office/powerpoint/2010/main" val="1957838079"/>
+        <p14:creationId xmlns:p14="http://schemas.microsoft.com/office/powerpoint/2010/main" val="1749550159"/>
       </p:ext>
     </p:extLst>
   </p:cSld>
@@ -23981,7 +24127,7 @@
           <p:cNvPr id="14" name="">
             <a:extLst xmlns:a="http://schemas.openxmlformats.org/drawingml/2006/main">
               <a:ext uri="{FF2B5EF4-FFF2-40B4-BE49-F238E27FC236}">
-                <a16:creationId xmlns:a16="http://schemas.microsoft.com/office/drawing/2014/main" id="{2DB93D5C-0153-4958-90B6-D3913B04E8C2}"/>
+                <a16:creationId xmlns:a16="http://schemas.microsoft.com/office/drawing/2014/main" id="{28BF6A88-DE2D-41BC-A0D1-8AF522229660}"/>
               </a:ext>
             </a:extLst>
           </p:cNvPr>
@@ -24049,7 +24195,7 @@
           <p:cNvPr id="2" name="">
             <a:extLst xmlns:a="http://schemas.openxmlformats.org/drawingml/2006/main">
               <a:ext uri="{FF2B5EF4-FFF2-40B4-BE49-F238E27FC236}">
-                <a16:creationId xmlns:a16="http://schemas.microsoft.com/office/drawing/2014/main" id="{50EEB386-BFA6-41DA-B656-0690292D846E}"/>
+                <a16:creationId xmlns:a16="http://schemas.microsoft.com/office/drawing/2014/main" id="{FAE7EBFD-4FAB-487E-88EB-61464D599915}"/>
               </a:ext>
             </a:extLst>
           </p:cNvPr>
@@ -24117,7 +24263,7 @@
           <p:cNvPr id="3" name="">
             <a:extLst xmlns:a="http://schemas.openxmlformats.org/drawingml/2006/main">
               <a:ext uri="{FF2B5EF4-FFF2-40B4-BE49-F238E27FC236}">
-                <a16:creationId xmlns:a16="http://schemas.microsoft.com/office/drawing/2014/main" id="{F4D57F8D-F575-4ECE-986F-D7A0398F6860}"/>
+                <a16:creationId xmlns:a16="http://schemas.microsoft.com/office/drawing/2014/main" id="{8BE2AFF3-942F-46F2-90CD-E4088C3E1AEB}"/>
               </a:ext>
             </a:extLst>
           </p:cNvPr>
@@ -24185,7 +24331,7 @@
           <p:cNvPr id="4" name="">
             <a:extLst xmlns:a="http://schemas.openxmlformats.org/drawingml/2006/main">
               <a:ext uri="{FF2B5EF4-FFF2-40B4-BE49-F238E27FC236}">
-                <a16:creationId xmlns:a16="http://schemas.microsoft.com/office/drawing/2014/main" id="{5DF3C91D-B751-4D2F-B97E-50D13A9BE0BD}"/>
+                <a16:creationId xmlns:a16="http://schemas.microsoft.com/office/drawing/2014/main" id="{E376CAC8-F713-46E7-8589-2F409A121FE9}"/>
               </a:ext>
             </a:extLst>
           </p:cNvPr>
@@ -24195,7 +24341,7 @@
           <p:nvPr/>
         </p:nvPicPr>
         <p:blipFill>
-          <a:blip xmlns:r="http://schemas.openxmlformats.org/officeDocument/2006/relationships" xmlns:a="http://schemas.openxmlformats.org/drawingml/2006/main" r:embed="R475e05080b5d4340"/>
+          <a:blip xmlns:r="http://schemas.openxmlformats.org/officeDocument/2006/relationships" xmlns:a="http://schemas.openxmlformats.org/drawingml/2006/main" r:embed="Rb22166ed60e34262"/>
           <a:stretch xmlns:a="http://schemas.openxmlformats.org/drawingml/2006/main"/>
         </p:blipFill>
         <p:spPr>
@@ -24213,7 +24359,7 @@
           <p:cNvPr id="5" name="">
             <a:extLst xmlns:a="http://schemas.openxmlformats.org/drawingml/2006/main">
               <a:ext uri="{FF2B5EF4-FFF2-40B4-BE49-F238E27FC236}">
-                <a16:creationId xmlns:a16="http://schemas.microsoft.com/office/drawing/2014/main" id="{752F4065-EFA9-42A5-8F63-05934533A547}"/>
+                <a16:creationId xmlns:a16="http://schemas.microsoft.com/office/drawing/2014/main" id="{C562235A-E69C-460B-8440-A0757AF00268}"/>
               </a:ext>
             </a:extLst>
           </p:cNvPr>
@@ -24281,7 +24427,7 @@
           <p:cNvPr id="6" name="">
             <a:extLst xmlns:a="http://schemas.openxmlformats.org/drawingml/2006/main">
               <a:ext uri="{FF2B5EF4-FFF2-40B4-BE49-F238E27FC236}">
-                <a16:creationId xmlns:a16="http://schemas.microsoft.com/office/drawing/2014/main" id="{C81739CE-D451-4ADC-BE1A-6F5B82F4BD32}"/>
+                <a16:creationId xmlns:a16="http://schemas.microsoft.com/office/drawing/2014/main" id="{CFC0E01C-CFAA-427C-AB48-18AC8272E5DF}"/>
               </a:ext>
             </a:extLst>
           </p:cNvPr>
@@ -24349,7 +24495,7 @@
           <p:cNvPr id="7" name="">
             <a:extLst xmlns:a="http://schemas.openxmlformats.org/drawingml/2006/main">
               <a:ext uri="{FF2B5EF4-FFF2-40B4-BE49-F238E27FC236}">
-                <a16:creationId xmlns:a16="http://schemas.microsoft.com/office/drawing/2014/main" id="{37201128-1595-49FD-8228-656AD0C18177}"/>
+                <a16:creationId xmlns:a16="http://schemas.microsoft.com/office/drawing/2014/main" id="{6D8FC3A0-223E-4FD4-8390-B4472F2BB91E}"/>
               </a:ext>
             </a:extLst>
           </p:cNvPr>
@@ -24359,7 +24505,7 @@
           <p:nvPr/>
         </p:nvPicPr>
         <p:blipFill>
-          <a:blip xmlns:r="http://schemas.openxmlformats.org/officeDocument/2006/relationships" xmlns:a="http://schemas.openxmlformats.org/drawingml/2006/main" r:embed="R07efc1c376d34dde"/>
+          <a:blip xmlns:r="http://schemas.openxmlformats.org/officeDocument/2006/relationships" xmlns:a="http://schemas.openxmlformats.org/drawingml/2006/main" r:embed="R88e7a117ad564664"/>
           <a:stretch xmlns:a="http://schemas.openxmlformats.org/drawingml/2006/main"/>
         </p:blipFill>
         <p:spPr>
@@ -24377,7 +24523,7 @@
           <p:cNvPr id="8" name="">
             <a:extLst xmlns:a="http://schemas.openxmlformats.org/drawingml/2006/main">
               <a:ext uri="{FF2B5EF4-FFF2-40B4-BE49-F238E27FC236}">
-                <a16:creationId xmlns:a16="http://schemas.microsoft.com/office/drawing/2014/main" id="{1F3B2134-9B9F-4F8D-BB16-9E624F6D9235}"/>
+                <a16:creationId xmlns:a16="http://schemas.microsoft.com/office/drawing/2014/main" id="{F0A7B879-2DEC-44BD-91B5-1385571350F6}"/>
               </a:ext>
             </a:extLst>
           </p:cNvPr>
@@ -24445,7 +24591,7 @@
           <p:cNvPr id="9" name="">
             <a:extLst xmlns:a="http://schemas.openxmlformats.org/drawingml/2006/main">
               <a:ext uri="{FF2B5EF4-FFF2-40B4-BE49-F238E27FC236}">
-                <a16:creationId xmlns:a16="http://schemas.microsoft.com/office/drawing/2014/main" id="{785A3369-6F81-4D09-A480-0849FF2921E1}"/>
+                <a16:creationId xmlns:a16="http://schemas.microsoft.com/office/drawing/2014/main" id="{0980A3C8-BFA2-4311-831F-7E5A45343D99}"/>
               </a:ext>
             </a:extLst>
           </p:cNvPr>
@@ -24513,7 +24659,7 @@
           <p:cNvPr id="10" name="">
             <a:extLst xmlns:a="http://schemas.openxmlformats.org/drawingml/2006/main">
               <a:ext uri="{FF2B5EF4-FFF2-40B4-BE49-F238E27FC236}">
-                <a16:creationId xmlns:a16="http://schemas.microsoft.com/office/drawing/2014/main" id="{4D6C9296-E6FE-47A7-8703-7B1C3BB41709}"/>
+                <a16:creationId xmlns:a16="http://schemas.microsoft.com/office/drawing/2014/main" id="{0700CCB3-E4DE-41E8-9136-32302C4EFA31}"/>
               </a:ext>
             </a:extLst>
           </p:cNvPr>
@@ -24523,7 +24669,7 @@
           <p:nvPr/>
         </p:nvPicPr>
         <p:blipFill>
-          <a:blip xmlns:r="http://schemas.openxmlformats.org/officeDocument/2006/relationships" xmlns:a="http://schemas.openxmlformats.org/drawingml/2006/main" r:embed="Rc48888740cb04d19"/>
+          <a:blip xmlns:r="http://schemas.openxmlformats.org/officeDocument/2006/relationships" xmlns:a="http://schemas.openxmlformats.org/drawingml/2006/main" r:embed="R916e26acc47e4900"/>
           <a:stretch xmlns:a="http://schemas.openxmlformats.org/drawingml/2006/main"/>
         </p:blipFill>
         <p:spPr>
@@ -24541,7 +24687,7 @@
           <p:cNvPr id="11" name="">
             <a:extLst xmlns:a="http://schemas.openxmlformats.org/drawingml/2006/main">
               <a:ext uri="{FF2B5EF4-FFF2-40B4-BE49-F238E27FC236}">
-                <a16:creationId xmlns:a16="http://schemas.microsoft.com/office/drawing/2014/main" id="{21F60EC3-12BE-4137-AE3A-112592BDD31C}"/>
+                <a16:creationId xmlns:a16="http://schemas.microsoft.com/office/drawing/2014/main" id="{978ADB64-2BD6-45BE-9987-E596E989E4EC}"/>
               </a:ext>
             </a:extLst>
           </p:cNvPr>
@@ -24609,7 +24755,7 @@
           <p:cNvPr id="12" name="">
             <a:extLst xmlns:a="http://schemas.openxmlformats.org/drawingml/2006/main">
               <a:ext uri="{FF2B5EF4-FFF2-40B4-BE49-F238E27FC236}">
-                <a16:creationId xmlns:a16="http://schemas.microsoft.com/office/drawing/2014/main" id="{48097476-DB33-4097-893F-664E97D68D3B}"/>
+                <a16:creationId xmlns:a16="http://schemas.microsoft.com/office/drawing/2014/main" id="{2FF59D58-F02B-4FAE-B8A6-CF3A3FA84B32}"/>
               </a:ext>
             </a:extLst>
           </p:cNvPr>
@@ -24677,7 +24823,7 @@
           <p:cNvPr id="13" name="">
             <a:extLst xmlns:a="http://schemas.openxmlformats.org/drawingml/2006/main">
               <a:ext uri="{FF2B5EF4-FFF2-40B4-BE49-F238E27FC236}">
-                <a16:creationId xmlns:a16="http://schemas.microsoft.com/office/drawing/2014/main" id="{D782579A-881B-46EB-BC75-7C3E452EA55B}"/>
+                <a16:creationId xmlns:a16="http://schemas.microsoft.com/office/drawing/2014/main" id="{F38984B8-0472-4F3F-822C-CAE1D15CBC7A}"/>
               </a:ext>
             </a:extLst>
           </p:cNvPr>
@@ -24743,7 +24889,7 @@
     </p:spTree>
     <p:extLst>
       <p:ext uri="{BB962C8B-B14F-4D97-AF65-F5344CB8AC3E}">
-        <p14:creationId xmlns:p14="http://schemas.microsoft.com/office/powerpoint/2010/main" val="1599471854"/>
+        <p14:creationId xmlns:p14="http://schemas.microsoft.com/office/powerpoint/2010/main" val="1261334541"/>
       </p:ext>
     </p:extLst>
   </p:cSld>
@@ -24774,7 +24920,7 @@
           <p:cNvPr id="15" name="">
             <a:extLst xmlns:a="http://schemas.openxmlformats.org/drawingml/2006/main">
               <a:ext uri="{FF2B5EF4-FFF2-40B4-BE49-F238E27FC236}">
-                <a16:creationId xmlns:a16="http://schemas.microsoft.com/office/drawing/2014/main" id="{E3F491D6-3A18-44AE-9795-EC7D3F1158FE}"/>
+                <a16:creationId xmlns:a16="http://schemas.microsoft.com/office/drawing/2014/main" id="{07D0798E-8063-406C-91CC-3389EA95362D}"/>
               </a:ext>
             </a:extLst>
           </p:cNvPr>
@@ -24784,7 +24930,7 @@
           <p:nvPr/>
         </p:nvPicPr>
         <p:blipFill>
-          <a:blip xmlns:r="http://schemas.openxmlformats.org/officeDocument/2006/relationships" xmlns:a="http://schemas.openxmlformats.org/drawingml/2006/main" r:embed="Rdba36033dbcf4c17"/>
+          <a:blip xmlns:r="http://schemas.openxmlformats.org/officeDocument/2006/relationships" xmlns:a="http://schemas.openxmlformats.org/drawingml/2006/main" r:embed="Rf33122aae7414c68"/>
           <a:srcRect xmlns:a="http://schemas.openxmlformats.org/drawingml/2006/main" l="0" t="0" r="0" b="0"/>
           <a:stretch xmlns:a="http://schemas.openxmlformats.org/drawingml/2006/main">
             <a:fillRect l="0" t="0" r="0" b="0"/>
@@ -24805,7 +24951,7 @@
           <p:cNvPr id="2" name="">
             <a:extLst xmlns:a="http://schemas.openxmlformats.org/drawingml/2006/main">
               <a:ext uri="{FF2B5EF4-FFF2-40B4-BE49-F238E27FC236}">
-                <a16:creationId xmlns:a16="http://schemas.microsoft.com/office/drawing/2014/main" id="{EEDEB4D1-8B67-42A9-8A78-E4A12B6002B8}"/>
+                <a16:creationId xmlns:a16="http://schemas.microsoft.com/office/drawing/2014/main" id="{AB71BFAA-BA0A-45EE-9C11-0CC9563AF851}"/>
               </a:ext>
             </a:extLst>
           </p:cNvPr>
@@ -24873,7 +25019,7 @@
           <p:cNvPr id="3" name="">
             <a:extLst xmlns:a="http://schemas.openxmlformats.org/drawingml/2006/main">
               <a:ext uri="{FF2B5EF4-FFF2-40B4-BE49-F238E27FC236}">
-                <a16:creationId xmlns:a16="http://schemas.microsoft.com/office/drawing/2014/main" id="{A7924B01-3194-4583-B2D6-13706588A4AE}"/>
+                <a16:creationId xmlns:a16="http://schemas.microsoft.com/office/drawing/2014/main" id="{8778FDBF-F0A8-4AD3-8FFF-2ED46E322281}"/>
               </a:ext>
             </a:extLst>
           </p:cNvPr>
@@ -24941,7 +25087,7 @@
           <p:cNvPr id="4" name="">
             <a:extLst xmlns:a="http://schemas.openxmlformats.org/drawingml/2006/main">
               <a:ext uri="{FF2B5EF4-FFF2-40B4-BE49-F238E27FC236}">
-                <a16:creationId xmlns:a16="http://schemas.microsoft.com/office/drawing/2014/main" id="{44EE5CF2-36E3-4BF9-BE9A-FE4544A6CCA5}"/>
+                <a16:creationId xmlns:a16="http://schemas.microsoft.com/office/drawing/2014/main" id="{73224F06-CD3C-4850-B1C0-121019F33323}"/>
               </a:ext>
             </a:extLst>
           </p:cNvPr>
@@ -25009,7 +25155,7 @@
           <p:cNvPr id="5" name="">
             <a:extLst xmlns:a="http://schemas.openxmlformats.org/drawingml/2006/main">
               <a:ext uri="{FF2B5EF4-FFF2-40B4-BE49-F238E27FC236}">
-                <a16:creationId xmlns:a16="http://schemas.microsoft.com/office/drawing/2014/main" id="{4E09674F-1620-424D-A1F7-DF6CD587121D}"/>
+                <a16:creationId xmlns:a16="http://schemas.microsoft.com/office/drawing/2014/main" id="{97985AA8-887B-4C0B-A775-7329C33D1545}"/>
               </a:ext>
             </a:extLst>
           </p:cNvPr>
@@ -25077,7 +25223,7 @@
           <p:cNvPr id="6" name="">
             <a:extLst xmlns:a="http://schemas.openxmlformats.org/drawingml/2006/main">
               <a:ext uri="{FF2B5EF4-FFF2-40B4-BE49-F238E27FC236}">
-                <a16:creationId xmlns:a16="http://schemas.microsoft.com/office/drawing/2014/main" id="{ED9E217C-591B-47DE-98B6-424E7C629A77}"/>
+                <a16:creationId xmlns:a16="http://schemas.microsoft.com/office/drawing/2014/main" id="{1FDB4F29-E44A-4960-A43F-2630BC495C02}"/>
               </a:ext>
             </a:extLst>
           </p:cNvPr>
@@ -25168,7 +25314,7 @@
           <p:cNvPr id="7" name="">
             <a:extLst xmlns:a="http://schemas.openxmlformats.org/drawingml/2006/main">
               <a:ext uri="{FF2B5EF4-FFF2-40B4-BE49-F238E27FC236}">
-                <a16:creationId xmlns:a16="http://schemas.microsoft.com/office/drawing/2014/main" id="{D5888278-82C5-423C-B086-5D6572F67A18}"/>
+                <a16:creationId xmlns:a16="http://schemas.microsoft.com/office/drawing/2014/main" id="{1F70CBBE-F8C6-4675-B292-8DFBF2980C8F}"/>
               </a:ext>
             </a:extLst>
           </p:cNvPr>
@@ -25236,7 +25382,7 @@
           <p:cNvPr id="8" name="">
             <a:extLst xmlns:a="http://schemas.openxmlformats.org/drawingml/2006/main">
               <a:ext uri="{FF2B5EF4-FFF2-40B4-BE49-F238E27FC236}">
-                <a16:creationId xmlns:a16="http://schemas.microsoft.com/office/drawing/2014/main" id="{B72558F6-C2D4-44F3-87BF-F95EBD85F167}"/>
+                <a16:creationId xmlns:a16="http://schemas.microsoft.com/office/drawing/2014/main" id="{F51A91E5-B830-4ADB-B4EA-9A5F3DF919D4}"/>
               </a:ext>
             </a:extLst>
           </p:cNvPr>
@@ -25304,7 +25450,7 @@
           <p:cNvPr id="9" name="">
             <a:extLst xmlns:a="http://schemas.openxmlformats.org/drawingml/2006/main">
               <a:ext uri="{FF2B5EF4-FFF2-40B4-BE49-F238E27FC236}">
-                <a16:creationId xmlns:a16="http://schemas.microsoft.com/office/drawing/2014/main" id="{814D6C3D-70AD-4C4D-A873-BE35AD7FEEC5}"/>
+                <a16:creationId xmlns:a16="http://schemas.microsoft.com/office/drawing/2014/main" id="{85D45CD4-682F-4CDB-9FED-31E7C1C904CD}"/>
               </a:ext>
             </a:extLst>
           </p:cNvPr>
@@ -25372,7 +25518,7 @@
           <p:cNvPr id="10" name="">
             <a:extLst xmlns:a="http://schemas.openxmlformats.org/drawingml/2006/main">
               <a:ext uri="{FF2B5EF4-FFF2-40B4-BE49-F238E27FC236}">
-                <a16:creationId xmlns:a16="http://schemas.microsoft.com/office/drawing/2014/main" id="{85A66114-A38E-4F69-BBAA-6C320415DB5B}"/>
+                <a16:creationId xmlns:a16="http://schemas.microsoft.com/office/drawing/2014/main" id="{48D29382-7F6D-486E-8D6C-0FCC67E13FCA}"/>
               </a:ext>
             </a:extLst>
           </p:cNvPr>
@@ -25440,7 +25586,7 @@
           <p:cNvPr id="11" name="">
             <a:extLst xmlns:a="http://schemas.openxmlformats.org/drawingml/2006/main">
               <a:ext uri="{FF2B5EF4-FFF2-40B4-BE49-F238E27FC236}">
-                <a16:creationId xmlns:a16="http://schemas.microsoft.com/office/drawing/2014/main" id="{936F309B-1472-411D-A1A8-FC6DE23E873E}"/>
+                <a16:creationId xmlns:a16="http://schemas.microsoft.com/office/drawing/2014/main" id="{2A394EB6-891A-4C9D-811F-79DE44BB940A}"/>
               </a:ext>
             </a:extLst>
           </p:cNvPr>
@@ -25508,7 +25654,7 @@
           <p:cNvPr id="12" name="">
             <a:extLst xmlns:a="http://schemas.openxmlformats.org/drawingml/2006/main">
               <a:ext uri="{FF2B5EF4-FFF2-40B4-BE49-F238E27FC236}">
-                <a16:creationId xmlns:a16="http://schemas.microsoft.com/office/drawing/2014/main" id="{7345D443-8825-4CBE-8273-CCF3F38217A5}"/>
+                <a16:creationId xmlns:a16="http://schemas.microsoft.com/office/drawing/2014/main" id="{348440FB-8ED7-443B-B051-0E617CEB2960}"/>
               </a:ext>
             </a:extLst>
           </p:cNvPr>
@@ -25576,7 +25722,7 @@
           <p:cNvPr id="13" name="">
             <a:extLst xmlns:a="http://schemas.openxmlformats.org/drawingml/2006/main">
               <a:ext uri="{FF2B5EF4-FFF2-40B4-BE49-F238E27FC236}">
-                <a16:creationId xmlns:a16="http://schemas.microsoft.com/office/drawing/2014/main" id="{017FBB53-3DC9-42C3-B945-1C7C5DDB7A86}"/>
+                <a16:creationId xmlns:a16="http://schemas.microsoft.com/office/drawing/2014/main" id="{D3334E6E-18B6-4E1A-9D7C-55CD80CC2F83}"/>
               </a:ext>
             </a:extLst>
           </p:cNvPr>
@@ -25644,7 +25790,7 @@
           <p:cNvPr id="14" name="">
             <a:extLst xmlns:a="http://schemas.openxmlformats.org/drawingml/2006/main">
               <a:ext uri="{FF2B5EF4-FFF2-40B4-BE49-F238E27FC236}">
-                <a16:creationId xmlns:a16="http://schemas.microsoft.com/office/drawing/2014/main" id="{D1214B9A-F380-4751-A4E2-7C3B0C5D3C91}"/>
+                <a16:creationId xmlns:a16="http://schemas.microsoft.com/office/drawing/2014/main" id="{7524755D-2028-4E61-B807-CCA4A622296E}"/>
               </a:ext>
             </a:extLst>
           </p:cNvPr>
@@ -25710,7 +25856,7 @@
     </p:spTree>
     <p:extLst>
       <p:ext uri="{BB962C8B-B14F-4D97-AF65-F5344CB8AC3E}">
-        <p14:creationId xmlns:p14="http://schemas.microsoft.com/office/powerpoint/2010/main" val="24294997"/>
+        <p14:creationId xmlns:p14="http://schemas.microsoft.com/office/powerpoint/2010/main" val="1295376348"/>
       </p:ext>
     </p:extLst>
   </p:cSld>
@@ -25741,7 +25887,7 @@
           <p:cNvPr id="29" name="">
             <a:extLst xmlns:a="http://schemas.openxmlformats.org/drawingml/2006/main">
               <a:ext uri="{FF2B5EF4-FFF2-40B4-BE49-F238E27FC236}">
-                <a16:creationId xmlns:a16="http://schemas.microsoft.com/office/drawing/2014/main" id="{434649C3-88DF-4CD6-BF99-72ED7FB3408C}"/>
+                <a16:creationId xmlns:a16="http://schemas.microsoft.com/office/drawing/2014/main" id="{EFBB3F23-F183-4668-BD27-79211C829233}"/>
               </a:ext>
             </a:extLst>
           </p:cNvPr>
@@ -25809,7 +25955,7 @@
           <p:cNvPr id="2" name="">
             <a:extLst xmlns:a="http://schemas.openxmlformats.org/drawingml/2006/main">
               <a:ext uri="{FF2B5EF4-FFF2-40B4-BE49-F238E27FC236}">
-                <a16:creationId xmlns:a16="http://schemas.microsoft.com/office/drawing/2014/main" id="{4E3526B7-627A-47D7-B1FF-B88C309B6FCA}"/>
+                <a16:creationId xmlns:a16="http://schemas.microsoft.com/office/drawing/2014/main" id="{7BD68548-74C6-4163-B3AC-DDC334C12EE8}"/>
               </a:ext>
             </a:extLst>
           </p:cNvPr>
@@ -25877,7 +26023,7 @@
           <p:cNvPr id="3" name="">
             <a:extLst xmlns:a="http://schemas.openxmlformats.org/drawingml/2006/main">
               <a:ext uri="{FF2B5EF4-FFF2-40B4-BE49-F238E27FC236}">
-                <a16:creationId xmlns:a16="http://schemas.microsoft.com/office/drawing/2014/main" id="{A022F40B-18EF-4F13-AE32-E5D9A9731618}"/>
+                <a16:creationId xmlns:a16="http://schemas.microsoft.com/office/drawing/2014/main" id="{7057CB21-BA81-4EB2-88F1-59DBC03E925A}"/>
               </a:ext>
             </a:extLst>
           </p:cNvPr>
@@ -25945,7 +26091,7 @@
           <p:cNvPr id="4" name="">
             <a:extLst xmlns:a="http://schemas.openxmlformats.org/drawingml/2006/main">
               <a:ext uri="{FF2B5EF4-FFF2-40B4-BE49-F238E27FC236}">
-                <a16:creationId xmlns:a16="http://schemas.microsoft.com/office/drawing/2014/main" id="{56BC718A-3257-486D-8101-3A0C8AB9B9B2}"/>
+                <a16:creationId xmlns:a16="http://schemas.microsoft.com/office/drawing/2014/main" id="{9C16BB99-3D9E-42A1-9BE4-CA07A8CCF12A}"/>
               </a:ext>
             </a:extLst>
           </p:cNvPr>
@@ -25977,7 +26123,7 @@
           <p:cNvPr id="5" name="">
             <a:extLst xmlns:a="http://schemas.openxmlformats.org/drawingml/2006/main">
               <a:ext uri="{FF2B5EF4-FFF2-40B4-BE49-F238E27FC236}">
-                <a16:creationId xmlns:a16="http://schemas.microsoft.com/office/drawing/2014/main" id="{39A6E8C3-BF19-4EE0-8E84-C329D533F601}"/>
+                <a16:creationId xmlns:a16="http://schemas.microsoft.com/office/drawing/2014/main" id="{BDD5D3DA-A86D-456C-81F6-1BD07CE05475}"/>
               </a:ext>
             </a:extLst>
           </p:cNvPr>
@@ -26045,7 +26191,7 @@
           <p:cNvPr id="6" name="">
             <a:extLst xmlns:a="http://schemas.openxmlformats.org/drawingml/2006/main">
               <a:ext uri="{FF2B5EF4-FFF2-40B4-BE49-F238E27FC236}">
-                <a16:creationId xmlns:a16="http://schemas.microsoft.com/office/drawing/2014/main" id="{F5BBAFD2-373C-49A6-AF12-BEBB58839564}"/>
+                <a16:creationId xmlns:a16="http://schemas.microsoft.com/office/drawing/2014/main" id="{D082BD1A-9E0D-40D8-9165-501B854682F8}"/>
               </a:ext>
             </a:extLst>
           </p:cNvPr>
@@ -26113,7 +26259,7 @@
           <p:cNvPr id="7" name="">
             <a:extLst xmlns:a="http://schemas.openxmlformats.org/drawingml/2006/main">
               <a:ext uri="{FF2B5EF4-FFF2-40B4-BE49-F238E27FC236}">
-                <a16:creationId xmlns:a16="http://schemas.microsoft.com/office/drawing/2014/main" id="{0EEA514A-5722-4FC1-9889-FD2FE2A3BD0B}"/>
+                <a16:creationId xmlns:a16="http://schemas.microsoft.com/office/drawing/2014/main" id="{D5AEB1B1-2B6D-4BCE-BBF8-E13763E5C575}"/>
               </a:ext>
             </a:extLst>
           </p:cNvPr>
@@ -26181,7 +26327,7 @@
           <p:cNvPr id="8" name="">
             <a:extLst xmlns:a="http://schemas.openxmlformats.org/drawingml/2006/main">
               <a:ext uri="{FF2B5EF4-FFF2-40B4-BE49-F238E27FC236}">
-                <a16:creationId xmlns:a16="http://schemas.microsoft.com/office/drawing/2014/main" id="{2FB49033-9649-4E39-A6E4-6364D455C94B}"/>
+                <a16:creationId xmlns:a16="http://schemas.microsoft.com/office/drawing/2014/main" id="{BA48CA48-D090-487C-A2B0-A034965A0078}"/>
               </a:ext>
             </a:extLst>
           </p:cNvPr>
@@ -26211,7 +26357,7 @@
           <p:cNvPr id="9" name="">
             <a:extLst xmlns:a="http://schemas.openxmlformats.org/drawingml/2006/main">
               <a:ext uri="{FF2B5EF4-FFF2-40B4-BE49-F238E27FC236}">
-                <a16:creationId xmlns:a16="http://schemas.microsoft.com/office/drawing/2014/main" id="{5ADA7ACA-8C59-4E2A-8568-FE0176A9AF93}"/>
+                <a16:creationId xmlns:a16="http://schemas.microsoft.com/office/drawing/2014/main" id="{FFC3019D-0EF6-405B-8FC3-9B4D7AF7B517}"/>
               </a:ext>
             </a:extLst>
           </p:cNvPr>
@@ -26243,7 +26389,7 @@
           <p:cNvPr id="10" name="">
             <a:extLst xmlns:a="http://schemas.openxmlformats.org/drawingml/2006/main">
               <a:ext uri="{FF2B5EF4-FFF2-40B4-BE49-F238E27FC236}">
-                <a16:creationId xmlns:a16="http://schemas.microsoft.com/office/drawing/2014/main" id="{38B26224-61DD-4081-A8B1-93741E4A3FAC}"/>
+                <a16:creationId xmlns:a16="http://schemas.microsoft.com/office/drawing/2014/main" id="{DD64CD9E-5D37-44C7-849E-F61E42C2481A}"/>
               </a:ext>
             </a:extLst>
           </p:cNvPr>
@@ -26311,7 +26457,7 @@
           <p:cNvPr id="11" name="">
             <a:extLst xmlns:a="http://schemas.openxmlformats.org/drawingml/2006/main">
               <a:ext uri="{FF2B5EF4-FFF2-40B4-BE49-F238E27FC236}">
-                <a16:creationId xmlns:a16="http://schemas.microsoft.com/office/drawing/2014/main" id="{48A1A53F-846C-499C-8343-3E41B738FC03}"/>
+                <a16:creationId xmlns:a16="http://schemas.microsoft.com/office/drawing/2014/main" id="{E448A365-2DF8-46F4-AB90-BD650D263D3C}"/>
               </a:ext>
             </a:extLst>
           </p:cNvPr>
@@ -26379,7 +26525,7 @@
           <p:cNvPr id="12" name="">
             <a:extLst xmlns:a="http://schemas.openxmlformats.org/drawingml/2006/main">
               <a:ext uri="{FF2B5EF4-FFF2-40B4-BE49-F238E27FC236}">
-                <a16:creationId xmlns:a16="http://schemas.microsoft.com/office/drawing/2014/main" id="{4062C643-B954-488E-840C-6D67578DD90C}"/>
+                <a16:creationId xmlns:a16="http://schemas.microsoft.com/office/drawing/2014/main" id="{19053871-1DC0-408D-832A-1E9C2CEB5D79}"/>
               </a:ext>
             </a:extLst>
           </p:cNvPr>
@@ -26447,7 +26593,7 @@
           <p:cNvPr id="13" name="">
             <a:extLst xmlns:a="http://schemas.openxmlformats.org/drawingml/2006/main">
               <a:ext uri="{FF2B5EF4-FFF2-40B4-BE49-F238E27FC236}">
-                <a16:creationId xmlns:a16="http://schemas.microsoft.com/office/drawing/2014/main" id="{BDDF0DB6-7038-41B7-B02E-EBA34338FBCB}"/>
+                <a16:creationId xmlns:a16="http://schemas.microsoft.com/office/drawing/2014/main" id="{12F341E8-43CE-4317-9828-012FCC43BEA3}"/>
               </a:ext>
             </a:extLst>
           </p:cNvPr>
@@ -26477,7 +26623,7 @@
           <p:cNvPr id="14" name="">
             <a:extLst xmlns:a="http://schemas.openxmlformats.org/drawingml/2006/main">
               <a:ext uri="{FF2B5EF4-FFF2-40B4-BE49-F238E27FC236}">
-                <a16:creationId xmlns:a16="http://schemas.microsoft.com/office/drawing/2014/main" id="{03946A73-E9CC-4D07-BBD4-91D701A3C4F8}"/>
+                <a16:creationId xmlns:a16="http://schemas.microsoft.com/office/drawing/2014/main" id="{720DBF63-2519-4CC8-B2E6-5C2D1A6286ED}"/>
               </a:ext>
             </a:extLst>
           </p:cNvPr>
@@ -26509,7 +26655,7 @@
           <p:cNvPr id="15" name="">
             <a:extLst xmlns:a="http://schemas.openxmlformats.org/drawingml/2006/main">
               <a:ext uri="{FF2B5EF4-FFF2-40B4-BE49-F238E27FC236}">
-                <a16:creationId xmlns:a16="http://schemas.microsoft.com/office/drawing/2014/main" id="{ECA6182F-99CF-4472-B888-8ED8C3BD8DCF}"/>
+                <a16:creationId xmlns:a16="http://schemas.microsoft.com/office/drawing/2014/main" id="{DF12796A-4F3C-41D7-B82A-A56E4FC9B3B2}"/>
               </a:ext>
             </a:extLst>
           </p:cNvPr>
@@ -26577,7 +26723,7 @@
           <p:cNvPr id="16" name="">
             <a:extLst xmlns:a="http://schemas.openxmlformats.org/drawingml/2006/main">
               <a:ext uri="{FF2B5EF4-FFF2-40B4-BE49-F238E27FC236}">
-                <a16:creationId xmlns:a16="http://schemas.microsoft.com/office/drawing/2014/main" id="{4C2DAABD-A11F-4598-84BA-B95984707E0E}"/>
+                <a16:creationId xmlns:a16="http://schemas.microsoft.com/office/drawing/2014/main" id="{64DA134D-F067-45E7-9094-3925A3975345}"/>
               </a:ext>
             </a:extLst>
           </p:cNvPr>
@@ -26645,7 +26791,7 @@
           <p:cNvPr id="17" name="">
             <a:extLst xmlns:a="http://schemas.openxmlformats.org/drawingml/2006/main">
               <a:ext uri="{FF2B5EF4-FFF2-40B4-BE49-F238E27FC236}">
-                <a16:creationId xmlns:a16="http://schemas.microsoft.com/office/drawing/2014/main" id="{C1C677B5-2E87-4095-85AE-DBF8943F6DF5}"/>
+                <a16:creationId xmlns:a16="http://schemas.microsoft.com/office/drawing/2014/main" id="{1686D8B1-3E88-457F-9855-ABCC00E6006A}"/>
               </a:ext>
             </a:extLst>
           </p:cNvPr>
@@ -26713,7 +26859,7 @@
           <p:cNvPr id="18" name="">
             <a:extLst xmlns:a="http://schemas.openxmlformats.org/drawingml/2006/main">
               <a:ext uri="{FF2B5EF4-FFF2-40B4-BE49-F238E27FC236}">
-                <a16:creationId xmlns:a16="http://schemas.microsoft.com/office/drawing/2014/main" id="{FE862D85-DCD3-42D3-8E23-65798A85090D}"/>
+                <a16:creationId xmlns:a16="http://schemas.microsoft.com/office/drawing/2014/main" id="{83B856F3-BD83-43A0-BD8D-F1B63A3259CD}"/>
               </a:ext>
             </a:extLst>
           </p:cNvPr>
@@ -26743,7 +26889,7 @@
           <p:cNvPr id="19" name="">
             <a:extLst xmlns:a="http://schemas.openxmlformats.org/drawingml/2006/main">
               <a:ext uri="{FF2B5EF4-FFF2-40B4-BE49-F238E27FC236}">
-                <a16:creationId xmlns:a16="http://schemas.microsoft.com/office/drawing/2014/main" id="{A354B993-C3F5-4CF1-B946-CA9666067AAC}"/>
+                <a16:creationId xmlns:a16="http://schemas.microsoft.com/office/drawing/2014/main" id="{321779C3-3C17-4AF1-8815-4C6CAC5A4EA3}"/>
               </a:ext>
             </a:extLst>
           </p:cNvPr>
@@ -26775,7 +26921,7 @@
           <p:cNvPr id="20" name="">
             <a:extLst xmlns:a="http://schemas.openxmlformats.org/drawingml/2006/main">
               <a:ext uri="{FF2B5EF4-FFF2-40B4-BE49-F238E27FC236}">
-                <a16:creationId xmlns:a16="http://schemas.microsoft.com/office/drawing/2014/main" id="{FDD3C897-FCDD-4153-A613-6F47A60ABA3D}"/>
+                <a16:creationId xmlns:a16="http://schemas.microsoft.com/office/drawing/2014/main" id="{D7D1C67D-2719-436A-9048-FABF27194B95}"/>
               </a:ext>
             </a:extLst>
           </p:cNvPr>
@@ -26843,7 +26989,7 @@
           <p:cNvPr id="21" name="">
             <a:extLst xmlns:a="http://schemas.openxmlformats.org/drawingml/2006/main">
               <a:ext uri="{FF2B5EF4-FFF2-40B4-BE49-F238E27FC236}">
-                <a16:creationId xmlns:a16="http://schemas.microsoft.com/office/drawing/2014/main" id="{72E35439-EE05-4C16-8E1C-ACCE12C4FBE1}"/>
+                <a16:creationId xmlns:a16="http://schemas.microsoft.com/office/drawing/2014/main" id="{115674B8-1D7B-4F93-9121-81C8809893CE}"/>
               </a:ext>
             </a:extLst>
           </p:cNvPr>
@@ -26911,7 +27057,7 @@
           <p:cNvPr id="22" name="">
             <a:extLst xmlns:a="http://schemas.openxmlformats.org/drawingml/2006/main">
               <a:ext uri="{FF2B5EF4-FFF2-40B4-BE49-F238E27FC236}">
-                <a16:creationId xmlns:a16="http://schemas.microsoft.com/office/drawing/2014/main" id="{4338B9FA-A335-4E61-9A14-7A2408B7806D}"/>
+                <a16:creationId xmlns:a16="http://schemas.microsoft.com/office/drawing/2014/main" id="{5AD8ACCD-E9F8-455D-9B0B-57F229FB64EF}"/>
               </a:ext>
             </a:extLst>
           </p:cNvPr>
@@ -26979,7 +27125,7 @@
           <p:cNvPr id="23" name="">
             <a:extLst xmlns:a="http://schemas.openxmlformats.org/drawingml/2006/main">
               <a:ext uri="{FF2B5EF4-FFF2-40B4-BE49-F238E27FC236}">
-                <a16:creationId xmlns:a16="http://schemas.microsoft.com/office/drawing/2014/main" id="{6D85F868-10DD-4F50-8A59-365C29BD7CFF}"/>
+                <a16:creationId xmlns:a16="http://schemas.microsoft.com/office/drawing/2014/main" id="{FBD2113B-D6E2-4C9E-8A3D-8C1CCCEC90C6}"/>
               </a:ext>
             </a:extLst>
           </p:cNvPr>
@@ -27009,7 +27155,7 @@
           <p:cNvPr id="24" name="">
             <a:extLst xmlns:a="http://schemas.openxmlformats.org/drawingml/2006/main">
               <a:ext uri="{FF2B5EF4-FFF2-40B4-BE49-F238E27FC236}">
-                <a16:creationId xmlns:a16="http://schemas.microsoft.com/office/drawing/2014/main" id="{06079C2A-847E-4F79-9764-D7BBEC2B8CC4}"/>
+                <a16:creationId xmlns:a16="http://schemas.microsoft.com/office/drawing/2014/main" id="{BA969DDC-2BC1-40E7-8635-D5BD44BE0FD7}"/>
               </a:ext>
             </a:extLst>
           </p:cNvPr>
@@ -27041,7 +27187,7 @@
           <p:cNvPr id="25" name="">
             <a:extLst xmlns:a="http://schemas.openxmlformats.org/drawingml/2006/main">
               <a:ext uri="{FF2B5EF4-FFF2-40B4-BE49-F238E27FC236}">
-                <a16:creationId xmlns:a16="http://schemas.microsoft.com/office/drawing/2014/main" id="{232DAC00-6DB0-4381-9BB5-9EE2F5E7F86D}"/>
+                <a16:creationId xmlns:a16="http://schemas.microsoft.com/office/drawing/2014/main" id="{216E31FE-057A-4EE8-95EF-D5C099E63FE5}"/>
               </a:ext>
             </a:extLst>
           </p:cNvPr>
@@ -27109,7 +27255,7 @@
           <p:cNvPr id="26" name="">
             <a:extLst xmlns:a="http://schemas.openxmlformats.org/drawingml/2006/main">
               <a:ext uri="{FF2B5EF4-FFF2-40B4-BE49-F238E27FC236}">
-                <a16:creationId xmlns:a16="http://schemas.microsoft.com/office/drawing/2014/main" id="{F7423D65-41CA-441F-9652-84A815BF37AF}"/>
+                <a16:creationId xmlns:a16="http://schemas.microsoft.com/office/drawing/2014/main" id="{74187858-26E6-42E8-8187-E4DC8BC9C5BD}"/>
               </a:ext>
             </a:extLst>
           </p:cNvPr>
@@ -27177,7 +27323,7 @@
           <p:cNvPr id="27" name="">
             <a:extLst xmlns:a="http://schemas.openxmlformats.org/drawingml/2006/main">
               <a:ext uri="{FF2B5EF4-FFF2-40B4-BE49-F238E27FC236}">
-                <a16:creationId xmlns:a16="http://schemas.microsoft.com/office/drawing/2014/main" id="{60839BDD-94CF-49C5-ACEB-E9F6D93C1B21}"/>
+                <a16:creationId xmlns:a16="http://schemas.microsoft.com/office/drawing/2014/main" id="{48A21637-466A-47B1-AAD6-EB1ABE1C3F59}"/>
               </a:ext>
             </a:extLst>
           </p:cNvPr>
@@ -27245,7 +27391,7 @@
           <p:cNvPr id="28" name="">
             <a:extLst xmlns:a="http://schemas.openxmlformats.org/drawingml/2006/main">
               <a:ext uri="{FF2B5EF4-FFF2-40B4-BE49-F238E27FC236}">
-                <a16:creationId xmlns:a16="http://schemas.microsoft.com/office/drawing/2014/main" id="{16F112FC-58F5-47B6-AA08-45302E04B12B}"/>
+                <a16:creationId xmlns:a16="http://schemas.microsoft.com/office/drawing/2014/main" id="{433C783B-16EE-4D6A-A19C-54D796B822D9}"/>
               </a:ext>
             </a:extLst>
           </p:cNvPr>
@@ -27311,7 +27457,7 @@
     </p:spTree>
     <p:extLst>
       <p:ext uri="{BB962C8B-B14F-4D97-AF65-F5344CB8AC3E}">
-        <p14:creationId xmlns:p14="http://schemas.microsoft.com/office/powerpoint/2010/main" val="1878106722"/>
+        <p14:creationId xmlns:p14="http://schemas.microsoft.com/office/powerpoint/2010/main" val="1592230833"/>
       </p:ext>
     </p:extLst>
   </p:cSld>
@@ -27342,7 +27488,7 @@
           <p:cNvPr id="21" name="">
             <a:extLst xmlns:a="http://schemas.openxmlformats.org/drawingml/2006/main">
               <a:ext uri="{FF2B5EF4-FFF2-40B4-BE49-F238E27FC236}">
-                <a16:creationId xmlns:a16="http://schemas.microsoft.com/office/drawing/2014/main" id="{F683F822-497C-44EE-B186-579B818582AE}"/>
+                <a16:creationId xmlns:a16="http://schemas.microsoft.com/office/drawing/2014/main" id="{6459B5A1-5DD2-4E9B-B791-E2A2ABD35BF5}"/>
               </a:ext>
             </a:extLst>
           </p:cNvPr>
@@ -27410,7 +27556,7 @@
           <p:cNvPr id="2" name="">
             <a:extLst xmlns:a="http://schemas.openxmlformats.org/drawingml/2006/main">
               <a:ext uri="{FF2B5EF4-FFF2-40B4-BE49-F238E27FC236}">
-                <a16:creationId xmlns:a16="http://schemas.microsoft.com/office/drawing/2014/main" id="{8DBCFBB2-DD11-453F-8D0C-DD918F257068}"/>
+                <a16:creationId xmlns:a16="http://schemas.microsoft.com/office/drawing/2014/main" id="{CD7C68EB-4D20-415E-B3C4-58DE09B3C63D}"/>
               </a:ext>
             </a:extLst>
           </p:cNvPr>
@@ -27478,7 +27624,7 @@
           <p:cNvPr id="3" name="">
             <a:extLst xmlns:a="http://schemas.openxmlformats.org/drawingml/2006/main">
               <a:ext uri="{FF2B5EF4-FFF2-40B4-BE49-F238E27FC236}">
-                <a16:creationId xmlns:a16="http://schemas.microsoft.com/office/drawing/2014/main" id="{F98635D5-773C-4880-8E4B-E19DAE9D73D7}"/>
+                <a16:creationId xmlns:a16="http://schemas.microsoft.com/office/drawing/2014/main" id="{E9AA4CF5-A44B-4418-BADD-7F48BAED8483}"/>
               </a:ext>
             </a:extLst>
           </p:cNvPr>
@@ -27546,7 +27692,7 @@
           <p:cNvPr id="4" name="">
             <a:extLst xmlns:a="http://schemas.openxmlformats.org/drawingml/2006/main">
               <a:ext uri="{FF2B5EF4-FFF2-40B4-BE49-F238E27FC236}">
-                <a16:creationId xmlns:a16="http://schemas.microsoft.com/office/drawing/2014/main" id="{2E0A74E2-FB2F-4452-BEF8-080CF5D3ECB4}"/>
+                <a16:creationId xmlns:a16="http://schemas.microsoft.com/office/drawing/2014/main" id="{6BEEE5FE-528F-4246-86F8-4949188994A8}"/>
               </a:ext>
             </a:extLst>
           </p:cNvPr>
@@ -27614,7 +27760,7 @@
           <p:cNvPr id="5" name="">
             <a:extLst xmlns:a="http://schemas.openxmlformats.org/drawingml/2006/main">
               <a:ext uri="{FF2B5EF4-FFF2-40B4-BE49-F238E27FC236}">
-                <a16:creationId xmlns:a16="http://schemas.microsoft.com/office/drawing/2014/main" id="{634E567B-12B4-458E-BEA1-6F4E98884003}"/>
+                <a16:creationId xmlns:a16="http://schemas.microsoft.com/office/drawing/2014/main" id="{680C653A-6C3F-4BB1-A8D2-D5406CD21391}"/>
               </a:ext>
             </a:extLst>
           </p:cNvPr>
@@ -27682,7 +27828,7 @@
           <p:cNvPr id="6" name="">
             <a:extLst xmlns:a="http://schemas.openxmlformats.org/drawingml/2006/main">
               <a:ext uri="{FF2B5EF4-FFF2-40B4-BE49-F238E27FC236}">
-                <a16:creationId xmlns:a16="http://schemas.microsoft.com/office/drawing/2014/main" id="{2D052046-5DDD-4E5A-AA09-BBC4E7F885E0}"/>
+                <a16:creationId xmlns:a16="http://schemas.microsoft.com/office/drawing/2014/main" id="{5A31B3E4-E161-40E9-ACE6-1E8C4F3A5E7B}"/>
               </a:ext>
             </a:extLst>
           </p:cNvPr>
@@ -27750,7 +27896,7 @@
           <p:cNvPr id="7" name="">
             <a:extLst xmlns:a="http://schemas.openxmlformats.org/drawingml/2006/main">
               <a:ext uri="{FF2B5EF4-FFF2-40B4-BE49-F238E27FC236}">
-                <a16:creationId xmlns:a16="http://schemas.microsoft.com/office/drawing/2014/main" id="{B8574A8A-B859-41AC-AF14-8C7C2777BB22}"/>
+                <a16:creationId xmlns:a16="http://schemas.microsoft.com/office/drawing/2014/main" id="{DA8BE42A-4E4E-4E0E-BCDF-06F62AD0E0C0}"/>
               </a:ext>
             </a:extLst>
           </p:cNvPr>
@@ -27818,7 +27964,7 @@
           <p:cNvPr id="8" name="">
             <a:extLst xmlns:a="http://schemas.openxmlformats.org/drawingml/2006/main">
               <a:ext uri="{FF2B5EF4-FFF2-40B4-BE49-F238E27FC236}">
-                <a16:creationId xmlns:a16="http://schemas.microsoft.com/office/drawing/2014/main" id="{89ED25E9-E946-4E07-AE8D-9A22564B419B}"/>
+                <a16:creationId xmlns:a16="http://schemas.microsoft.com/office/drawing/2014/main" id="{2F534C9A-079A-4A17-8B50-60BB149E220E}"/>
               </a:ext>
             </a:extLst>
           </p:cNvPr>
@@ -27886,7 +28032,7 @@
           <p:cNvPr id="9" name="">
             <a:extLst xmlns:a="http://schemas.openxmlformats.org/drawingml/2006/main">
               <a:ext uri="{FF2B5EF4-FFF2-40B4-BE49-F238E27FC236}">
-                <a16:creationId xmlns:a16="http://schemas.microsoft.com/office/drawing/2014/main" id="{40EE01D8-D46E-4B46-B57C-316CB6E1CB82}"/>
+                <a16:creationId xmlns:a16="http://schemas.microsoft.com/office/drawing/2014/main" id="{75906C49-3749-4CDE-8C3E-E89A62F286A6}"/>
               </a:ext>
             </a:extLst>
           </p:cNvPr>
@@ -27954,7 +28100,7 @@
           <p:cNvPr id="10" name="">
             <a:extLst xmlns:a="http://schemas.openxmlformats.org/drawingml/2006/main">
               <a:ext uri="{FF2B5EF4-FFF2-40B4-BE49-F238E27FC236}">
-                <a16:creationId xmlns:a16="http://schemas.microsoft.com/office/drawing/2014/main" id="{B6183815-4B1F-4668-AAA8-7E67EB7A76B9}"/>
+                <a16:creationId xmlns:a16="http://schemas.microsoft.com/office/drawing/2014/main" id="{9C5E2E13-C219-469D-BBE4-08A56BE7D6F9}"/>
               </a:ext>
             </a:extLst>
           </p:cNvPr>
@@ -28022,7 +28168,7 @@
           <p:cNvPr id="11" name="">
             <a:extLst xmlns:a="http://schemas.openxmlformats.org/drawingml/2006/main">
               <a:ext uri="{FF2B5EF4-FFF2-40B4-BE49-F238E27FC236}">
-                <a16:creationId xmlns:a16="http://schemas.microsoft.com/office/drawing/2014/main" id="{E4051834-14B9-4786-8690-DF112283B513}"/>
+                <a16:creationId xmlns:a16="http://schemas.microsoft.com/office/drawing/2014/main" id="{FF13B843-195D-4874-8B4B-2876E6D33A90}"/>
               </a:ext>
             </a:extLst>
           </p:cNvPr>
@@ -28090,7 +28236,7 @@
           <p:cNvPr id="12" name="">
             <a:extLst xmlns:a="http://schemas.openxmlformats.org/drawingml/2006/main">
               <a:ext uri="{FF2B5EF4-FFF2-40B4-BE49-F238E27FC236}">
-                <a16:creationId xmlns:a16="http://schemas.microsoft.com/office/drawing/2014/main" id="{FAFE0DA8-8EF6-48F2-AADE-F942D07C14DA}"/>
+                <a16:creationId xmlns:a16="http://schemas.microsoft.com/office/drawing/2014/main" id="{F0717D9E-8151-4E7F-8AFD-48D989FD1178}"/>
               </a:ext>
             </a:extLst>
           </p:cNvPr>
@@ -28158,7 +28304,7 @@
           <p:cNvPr id="13" name="">
             <a:extLst xmlns:a="http://schemas.openxmlformats.org/drawingml/2006/main">
               <a:ext uri="{FF2B5EF4-FFF2-40B4-BE49-F238E27FC236}">
-                <a16:creationId xmlns:a16="http://schemas.microsoft.com/office/drawing/2014/main" id="{7E65A7B6-1AED-4A38-AEAF-7409A908C6EE}"/>
+                <a16:creationId xmlns:a16="http://schemas.microsoft.com/office/drawing/2014/main" id="{78D42D5F-EA28-4F3F-90D3-8A2D268E43B5}"/>
               </a:ext>
             </a:extLst>
           </p:cNvPr>
@@ -28226,7 +28372,7 @@
           <p:cNvPr id="14" name="">
             <a:extLst xmlns:a="http://schemas.openxmlformats.org/drawingml/2006/main">
               <a:ext uri="{FF2B5EF4-FFF2-40B4-BE49-F238E27FC236}">
-                <a16:creationId xmlns:a16="http://schemas.microsoft.com/office/drawing/2014/main" id="{E9DCABDE-7BDB-431F-9F51-7FCB8B36A926}"/>
+                <a16:creationId xmlns:a16="http://schemas.microsoft.com/office/drawing/2014/main" id="{FB4F0DCD-A122-4825-8A09-2C02A45ED271}"/>
               </a:ext>
             </a:extLst>
           </p:cNvPr>
@@ -28294,7 +28440,7 @@
           <p:cNvPr id="15" name="">
             <a:extLst xmlns:a="http://schemas.openxmlformats.org/drawingml/2006/main">
               <a:ext uri="{FF2B5EF4-FFF2-40B4-BE49-F238E27FC236}">
-                <a16:creationId xmlns:a16="http://schemas.microsoft.com/office/drawing/2014/main" id="{BB47B299-7285-49AA-8849-4998120C7BEF}"/>
+                <a16:creationId xmlns:a16="http://schemas.microsoft.com/office/drawing/2014/main" id="{EEBC0D09-BFC5-4C51-B0AA-7CC920C43547}"/>
               </a:ext>
             </a:extLst>
           </p:cNvPr>
@@ -28362,7 +28508,7 @@
           <p:cNvPr id="16" name="">
             <a:extLst xmlns:a="http://schemas.openxmlformats.org/drawingml/2006/main">
               <a:ext uri="{FF2B5EF4-FFF2-40B4-BE49-F238E27FC236}">
-                <a16:creationId xmlns:a16="http://schemas.microsoft.com/office/drawing/2014/main" id="{31CDF409-76B7-4635-B7F3-879F428410B8}"/>
+                <a16:creationId xmlns:a16="http://schemas.microsoft.com/office/drawing/2014/main" id="{B16AF516-38C0-4B04-A1B6-8D3432571CAC}"/>
               </a:ext>
             </a:extLst>
           </p:cNvPr>
@@ -28430,7 +28576,7 @@
           <p:cNvPr id="17" name="">
             <a:extLst xmlns:a="http://schemas.openxmlformats.org/drawingml/2006/main">
               <a:ext uri="{FF2B5EF4-FFF2-40B4-BE49-F238E27FC236}">
-                <a16:creationId xmlns:a16="http://schemas.microsoft.com/office/drawing/2014/main" id="{3BB9D991-7DD9-4DA7-8B5C-85C8BD6DB1B2}"/>
+                <a16:creationId xmlns:a16="http://schemas.microsoft.com/office/drawing/2014/main" id="{D9D9C2DB-1929-433F-8B85-A2C39686C7C4}"/>
               </a:ext>
             </a:extLst>
           </p:cNvPr>
@@ -28498,7 +28644,7 @@
           <p:cNvPr id="18" name="">
             <a:extLst xmlns:a="http://schemas.openxmlformats.org/drawingml/2006/main">
               <a:ext uri="{FF2B5EF4-FFF2-40B4-BE49-F238E27FC236}">
-                <a16:creationId xmlns:a16="http://schemas.microsoft.com/office/drawing/2014/main" id="{5E248863-49D3-4CE2-A5FD-59574C5AD7B7}"/>
+                <a16:creationId xmlns:a16="http://schemas.microsoft.com/office/drawing/2014/main" id="{E8E03C4B-C1AC-424D-9A20-917B1DFE061D}"/>
               </a:ext>
             </a:extLst>
           </p:cNvPr>
@@ -28566,7 +28712,7 @@
           <p:cNvPr id="19" name="">
             <a:extLst xmlns:a="http://schemas.openxmlformats.org/drawingml/2006/main">
               <a:ext uri="{FF2B5EF4-FFF2-40B4-BE49-F238E27FC236}">
-                <a16:creationId xmlns:a16="http://schemas.microsoft.com/office/drawing/2014/main" id="{DAFE2F5A-CF1E-47E9-B6D4-9EE0FF1D2587}"/>
+                <a16:creationId xmlns:a16="http://schemas.microsoft.com/office/drawing/2014/main" id="{A462CEC8-F4FE-4909-B8B8-3D2C2A783A82}"/>
               </a:ext>
             </a:extLst>
           </p:cNvPr>
@@ -28634,7 +28780,7 @@
           <p:cNvPr id="20" name="">
             <a:extLst xmlns:a="http://schemas.openxmlformats.org/drawingml/2006/main">
               <a:ext uri="{FF2B5EF4-FFF2-40B4-BE49-F238E27FC236}">
-                <a16:creationId xmlns:a16="http://schemas.microsoft.com/office/drawing/2014/main" id="{86E53C55-4C94-4805-B07E-7BA8C05C9160}"/>
+                <a16:creationId xmlns:a16="http://schemas.microsoft.com/office/drawing/2014/main" id="{78E517EB-C3CE-4B4E-AF0F-0E235A5E6A6F}"/>
               </a:ext>
             </a:extLst>
           </p:cNvPr>
@@ -28700,7 +28846,7 @@
     </p:spTree>
     <p:extLst>
       <p:ext uri="{BB962C8B-B14F-4D97-AF65-F5344CB8AC3E}">
-        <p14:creationId xmlns:p14="http://schemas.microsoft.com/office/powerpoint/2010/main" val="704194958"/>
+        <p14:creationId xmlns:p14="http://schemas.microsoft.com/office/powerpoint/2010/main" val="938783815"/>
       </p:ext>
     </p:extLst>
   </p:cSld>

</xml_diff>

<commit_message>
Restore visible R initials above the five coaching stages
</commit_message>
<xml_diff>
--- a/education/training/signature/compact/training-signature.pptx
+++ b/education/training/signature/compact/training-signature.pptx
@@ -2,32 +2,32 @@
 <file path=ppt/presentation.xml><?xml version="1.0" encoding="utf-8"?>
 <p:presentation xmlns:p="http://schemas.openxmlformats.org/presentationml/2006/main">
   <p:sldMasterIdLst>
-    <p:sldMasterId xmlns:r="http://schemas.openxmlformats.org/officeDocument/2006/relationships" id="2147483648" r:id="R97e4772f2baa4b05"/>
+    <p:sldMasterId xmlns:r="http://schemas.openxmlformats.org/officeDocument/2006/relationships" id="2147483648" r:id="Re9bf8fe12d264585"/>
   </p:sldMasterIdLst>
   <p:notesMasterIdLst>
-    <p:notesMasterId xmlns:r="http://schemas.openxmlformats.org/officeDocument/2006/relationships" r:id="Rc0a42559285b496c"/>
+    <p:notesMasterId xmlns:r="http://schemas.openxmlformats.org/officeDocument/2006/relationships" r:id="Rb47272c60c8d4f02"/>
   </p:notesMasterIdLst>
   <p:sldIdLst>
-    <p:sldId xmlns:r="http://schemas.openxmlformats.org/officeDocument/2006/relationships" id="256" r:id="R5a3911193d984ef5"/>
-    <p:sldId xmlns:r="http://schemas.openxmlformats.org/officeDocument/2006/relationships" id="257" r:id="R7e9fe74424024872"/>
-    <p:sldId xmlns:r="http://schemas.openxmlformats.org/officeDocument/2006/relationships" id="258" r:id="R11cdff0603214ac9"/>
-    <p:sldId xmlns:r="http://schemas.openxmlformats.org/officeDocument/2006/relationships" id="259" r:id="Ra279ca4f4c1943d8"/>
-    <p:sldId xmlns:r="http://schemas.openxmlformats.org/officeDocument/2006/relationships" id="260" r:id="R066029f3ea644f79"/>
-    <p:sldId xmlns:r="http://schemas.openxmlformats.org/officeDocument/2006/relationships" id="261" r:id="R3fab1d48af964a3c"/>
-    <p:sldId xmlns:r="http://schemas.openxmlformats.org/officeDocument/2006/relationships" id="262" r:id="R3a3544ad0ad24b6b"/>
-    <p:sldId xmlns:r="http://schemas.openxmlformats.org/officeDocument/2006/relationships" id="263" r:id="Rd7b4cfc7894c4b42"/>
-    <p:sldId xmlns:r="http://schemas.openxmlformats.org/officeDocument/2006/relationships" id="264" r:id="R1e7060040b7643ab"/>
-    <p:sldId xmlns:r="http://schemas.openxmlformats.org/officeDocument/2006/relationships" id="265" r:id="R35300bd9c4944587"/>
-    <p:sldId xmlns:r="http://schemas.openxmlformats.org/officeDocument/2006/relationships" id="266" r:id="Ra06d872261174aec"/>
-    <p:sldId xmlns:r="http://schemas.openxmlformats.org/officeDocument/2006/relationships" id="267" r:id="R30de557749d945a1"/>
-    <p:sldId xmlns:r="http://schemas.openxmlformats.org/officeDocument/2006/relationships" id="268" r:id="R627231799ae840fd"/>
-    <p:sldId xmlns:r="http://schemas.openxmlformats.org/officeDocument/2006/relationships" id="269" r:id="R0bee8250f37449c0"/>
-    <p:sldId xmlns:r="http://schemas.openxmlformats.org/officeDocument/2006/relationships" id="270" r:id="R372160a02ef2424e"/>
-    <p:sldId xmlns:r="http://schemas.openxmlformats.org/officeDocument/2006/relationships" id="271" r:id="Rbe7b510517be442c"/>
-    <p:sldId xmlns:r="http://schemas.openxmlformats.org/officeDocument/2006/relationships" id="272" r:id="Rbdf3834caa1c4c50"/>
-    <p:sldId xmlns:r="http://schemas.openxmlformats.org/officeDocument/2006/relationships" id="273" r:id="R902744503da047e4"/>
-    <p:sldId xmlns:r="http://schemas.openxmlformats.org/officeDocument/2006/relationships" id="274" r:id="Rd2f963559ea84b16"/>
-    <p:sldId xmlns:r="http://schemas.openxmlformats.org/officeDocument/2006/relationships" id="275" r:id="Rf86f84d9b22f4800"/>
+    <p:sldId xmlns:r="http://schemas.openxmlformats.org/officeDocument/2006/relationships" id="256" r:id="Rfd0dca81ea934a9a"/>
+    <p:sldId xmlns:r="http://schemas.openxmlformats.org/officeDocument/2006/relationships" id="257" r:id="Re1d812f7def1481a"/>
+    <p:sldId xmlns:r="http://schemas.openxmlformats.org/officeDocument/2006/relationships" id="258" r:id="Ra3608235c0de490c"/>
+    <p:sldId xmlns:r="http://schemas.openxmlformats.org/officeDocument/2006/relationships" id="259" r:id="R7be8d15bd6e844d9"/>
+    <p:sldId xmlns:r="http://schemas.openxmlformats.org/officeDocument/2006/relationships" id="260" r:id="Rddbc565be8e74d1a"/>
+    <p:sldId xmlns:r="http://schemas.openxmlformats.org/officeDocument/2006/relationships" id="261" r:id="R29f4189859304e77"/>
+    <p:sldId xmlns:r="http://schemas.openxmlformats.org/officeDocument/2006/relationships" id="262" r:id="R5aaf8801b9d34e08"/>
+    <p:sldId xmlns:r="http://schemas.openxmlformats.org/officeDocument/2006/relationships" id="263" r:id="R7d547741caea4c13"/>
+    <p:sldId xmlns:r="http://schemas.openxmlformats.org/officeDocument/2006/relationships" id="264" r:id="R65463995f09949cd"/>
+    <p:sldId xmlns:r="http://schemas.openxmlformats.org/officeDocument/2006/relationships" id="265" r:id="R0e1102cfeb11471d"/>
+    <p:sldId xmlns:r="http://schemas.openxmlformats.org/officeDocument/2006/relationships" id="266" r:id="Re9d0d56cc842460a"/>
+    <p:sldId xmlns:r="http://schemas.openxmlformats.org/officeDocument/2006/relationships" id="267" r:id="R5e0717be74d64b2e"/>
+    <p:sldId xmlns:r="http://schemas.openxmlformats.org/officeDocument/2006/relationships" id="268" r:id="Rf8a8f242601f4dd6"/>
+    <p:sldId xmlns:r="http://schemas.openxmlformats.org/officeDocument/2006/relationships" id="269" r:id="Re1561ef1f48e4de9"/>
+    <p:sldId xmlns:r="http://schemas.openxmlformats.org/officeDocument/2006/relationships" id="270" r:id="R3e44314cc7d34e1c"/>
+    <p:sldId xmlns:r="http://schemas.openxmlformats.org/officeDocument/2006/relationships" id="271" r:id="R974a15974a3c497e"/>
+    <p:sldId xmlns:r="http://schemas.openxmlformats.org/officeDocument/2006/relationships" id="272" r:id="Rce8c062e79ad44f1"/>
+    <p:sldId xmlns:r="http://schemas.openxmlformats.org/officeDocument/2006/relationships" id="273" r:id="R217af01c5e204073"/>
+    <p:sldId xmlns:r="http://schemas.openxmlformats.org/officeDocument/2006/relationships" id="274" r:id="R075119554852438b"/>
+    <p:sldId xmlns:r="http://schemas.openxmlformats.org/officeDocument/2006/relationships" id="275" r:id="R586f80f9a41a408d"/>
   </p:sldIdLst>
   <p:sldSz cx="12192000" cy="6858000"/>
   <p:notesSz cx="6858000" cy="9144000"/>
@@ -6663,7 +6663,7 @@
           <p:cNvPr id="3" name="Title">
             <a:extLst xmlns:a="http://schemas.openxmlformats.org/drawingml/2006/main">
               <a:ext uri="{FF2B5EF4-FFF2-40B4-BE49-F238E27FC236}">
-                <a16:creationId xmlns:a16="http://schemas.microsoft.com/office/drawing/2014/main" id="{C5BE8F49-2A43-4560-99D6-DD806CE89198}"/>
+                <a16:creationId xmlns:a16="http://schemas.microsoft.com/office/drawing/2014/main" id="{DE4AF481-5207-447C-9F53-43EC8FEB78C3}"/>
               </a:ext>
             </a:extLst>
           </p:cNvPr>
@@ -6820,7 +6820,7 @@
           <p:cNvPr id="2" name="Subtitle">
             <a:extLst xmlns:a="http://schemas.openxmlformats.org/drawingml/2006/main">
               <a:ext uri="{FF2B5EF4-FFF2-40B4-BE49-F238E27FC236}">
-                <a16:creationId xmlns:a16="http://schemas.microsoft.com/office/drawing/2014/main" id="{9ECA0144-2443-4E32-A1E2-7B1EAEF31F91}"/>
+                <a16:creationId xmlns:a16="http://schemas.microsoft.com/office/drawing/2014/main" id="{23D33AB9-513A-4C68-980E-1E6B4C0B0648}"/>
               </a:ext>
             </a:extLst>
           </p:cNvPr>
@@ -6994,7 +6994,7 @@
           <p:cNvPr id="2" name="Section title">
             <a:extLst xmlns:a="http://schemas.openxmlformats.org/drawingml/2006/main">
               <a:ext uri="{FF2B5EF4-FFF2-40B4-BE49-F238E27FC236}">
-                <a16:creationId xmlns:a16="http://schemas.microsoft.com/office/drawing/2014/main" id="{936D5F23-A867-4ACF-8CD4-1CA9A1C401DC}"/>
+                <a16:creationId xmlns:a16="http://schemas.microsoft.com/office/drawing/2014/main" id="{53CDF189-DD60-4D79-96C4-53FD64B05115}"/>
               </a:ext>
             </a:extLst>
           </p:cNvPr>
@@ -7168,7 +7168,7 @@
           <p:cNvPr id="3" name="Title">
             <a:extLst xmlns:a="http://schemas.openxmlformats.org/drawingml/2006/main">
               <a:ext uri="{FF2B5EF4-FFF2-40B4-BE49-F238E27FC236}">
-                <a16:creationId xmlns:a16="http://schemas.microsoft.com/office/drawing/2014/main" id="{837AB72F-C570-4EC2-BCD7-62329DADCDD1}"/>
+                <a16:creationId xmlns:a16="http://schemas.microsoft.com/office/drawing/2014/main" id="{EF28394F-B513-4190-92DB-A7D09170BF80}"/>
               </a:ext>
             </a:extLst>
           </p:cNvPr>
@@ -7325,7 +7325,7 @@
           <p:cNvPr id="2" name="Body">
             <a:extLst xmlns:a="http://schemas.openxmlformats.org/drawingml/2006/main">
               <a:ext uri="{FF2B5EF4-FFF2-40B4-BE49-F238E27FC236}">
-                <a16:creationId xmlns:a16="http://schemas.microsoft.com/office/drawing/2014/main" id="{57264C21-9EE8-4BCD-97D3-B36C9B598D63}"/>
+                <a16:creationId xmlns:a16="http://schemas.microsoft.com/office/drawing/2014/main" id="{EA9C413C-06C2-4983-BA43-DB961EB8F8CF}"/>
               </a:ext>
             </a:extLst>
           </p:cNvPr>
@@ -7499,7 +7499,7 @@
           <p:cNvPr id="4" name="Title">
             <a:extLst xmlns:a="http://schemas.openxmlformats.org/drawingml/2006/main">
               <a:ext uri="{FF2B5EF4-FFF2-40B4-BE49-F238E27FC236}">
-                <a16:creationId xmlns:a16="http://schemas.microsoft.com/office/drawing/2014/main" id="{11617272-0CD9-48F6-874A-240092AE8F29}"/>
+                <a16:creationId xmlns:a16="http://schemas.microsoft.com/office/drawing/2014/main" id="{2B7F09E9-334D-43CD-A787-0A22BE2A822A}"/>
               </a:ext>
             </a:extLst>
           </p:cNvPr>
@@ -7656,7 +7656,7 @@
           <p:cNvPr id="2" name="Left column">
             <a:extLst xmlns:a="http://schemas.openxmlformats.org/drawingml/2006/main">
               <a:ext uri="{FF2B5EF4-FFF2-40B4-BE49-F238E27FC236}">
-                <a16:creationId xmlns:a16="http://schemas.microsoft.com/office/drawing/2014/main" id="{5957419A-269A-406F-8425-3DB1ADABA9DC}"/>
+                <a16:creationId xmlns:a16="http://schemas.microsoft.com/office/drawing/2014/main" id="{40BBCD70-41BD-4261-BDE9-F1872583105C}"/>
               </a:ext>
             </a:extLst>
           </p:cNvPr>
@@ -7813,7 +7813,7 @@
           <p:cNvPr id="3" name="Right column">
             <a:extLst xmlns:a="http://schemas.openxmlformats.org/drawingml/2006/main">
               <a:ext uri="{FF2B5EF4-FFF2-40B4-BE49-F238E27FC236}">
-                <a16:creationId xmlns:a16="http://schemas.microsoft.com/office/drawing/2014/main" id="{3DAA037B-ABAE-4E43-AC43-378E70DD5894}"/>
+                <a16:creationId xmlns:a16="http://schemas.microsoft.com/office/drawing/2014/main" id="{F53FECDA-F086-4225-B272-DEF190E2BCEB}"/>
               </a:ext>
             </a:extLst>
           </p:cNvPr>
@@ -7987,7 +7987,7 @@
           <p:cNvPr id="3" name="Title">
             <a:extLst xmlns:a="http://schemas.openxmlformats.org/drawingml/2006/main">
               <a:ext uri="{FF2B5EF4-FFF2-40B4-BE49-F238E27FC236}">
-                <a16:creationId xmlns:a16="http://schemas.microsoft.com/office/drawing/2014/main" id="{B4AB990E-B68F-47B5-934A-8A6F587848EB}"/>
+                <a16:creationId xmlns:a16="http://schemas.microsoft.com/office/drawing/2014/main" id="{ED8294E7-4E7F-455C-8163-FC198A67D52B}"/>
               </a:ext>
             </a:extLst>
           </p:cNvPr>
@@ -8144,7 +8144,7 @@
           <p:cNvPr id="2" name="Left column">
             <a:extLst xmlns:a="http://schemas.openxmlformats.org/drawingml/2006/main">
               <a:ext uri="{FF2B5EF4-FFF2-40B4-BE49-F238E27FC236}">
-                <a16:creationId xmlns:a16="http://schemas.microsoft.com/office/drawing/2014/main" id="{D4B3529E-CC0C-405F-8BED-A155A5B2AB2E}"/>
+                <a16:creationId xmlns:a16="http://schemas.microsoft.com/office/drawing/2014/main" id="{947F92F0-A998-449F-95DE-9799B8E3AFB6}"/>
               </a:ext>
             </a:extLst>
           </p:cNvPr>
@@ -8339,12 +8339,12 @@
   </p:cSld>
   <p:clrMap bg1="lt1" tx1="dk1" bg2="lt2" tx2="dk2" accent1="accent1" accent2="accent2" accent3="accent3" accent4="accent4" accent5="accent5" accent6="accent6" hlink="hlink" folHlink="folHlink"/>
   <p:sldLayoutIdLst>
-    <p:sldLayoutId xmlns:r="http://schemas.openxmlformats.org/officeDocument/2006/relationships" id="2147483649" r:id="Rb504ffd95111403e"/>
-    <p:sldLayoutId xmlns:r="http://schemas.openxmlformats.org/officeDocument/2006/relationships" id="2147483650" r:id="R3d94a293435a4763"/>
-    <p:sldLayoutId xmlns:r="http://schemas.openxmlformats.org/officeDocument/2006/relationships" id="2147483651" r:id="R36a0e2f2c27944d8"/>
-    <p:sldLayoutId xmlns:r="http://schemas.openxmlformats.org/officeDocument/2006/relationships" id="2147483652" r:id="R136b66828d2e416f"/>
-    <p:sldLayoutId xmlns:r="http://schemas.openxmlformats.org/officeDocument/2006/relationships" id="2147483653" r:id="R2584e89845764534"/>
-    <p:sldLayoutId xmlns:r="http://schemas.openxmlformats.org/officeDocument/2006/relationships" id="2147483654" r:id="R10b0c13890f446ea"/>
+    <p:sldLayoutId xmlns:r="http://schemas.openxmlformats.org/officeDocument/2006/relationships" id="2147483649" r:id="Raf0fc40e6b46411a"/>
+    <p:sldLayoutId xmlns:r="http://schemas.openxmlformats.org/officeDocument/2006/relationships" id="2147483650" r:id="Rce182f4186284973"/>
+    <p:sldLayoutId xmlns:r="http://schemas.openxmlformats.org/officeDocument/2006/relationships" id="2147483651" r:id="R8adf38a58aa64c4d"/>
+    <p:sldLayoutId xmlns:r="http://schemas.openxmlformats.org/officeDocument/2006/relationships" id="2147483652" r:id="R3c28790464054ffc"/>
+    <p:sldLayoutId xmlns:r="http://schemas.openxmlformats.org/officeDocument/2006/relationships" id="2147483653" r:id="R92d3e35a65b14793"/>
+    <p:sldLayoutId xmlns:r="http://schemas.openxmlformats.org/officeDocument/2006/relationships" id="2147483654" r:id="Rb5e75739c66c4756"/>
   </p:sldLayoutIdLst>
   <p:txStyles>
     <p:titleStyle>
@@ -8895,7 +8895,7 @@
           <p:cNvPr id="8" name="">
             <a:extLst xmlns:a="http://schemas.openxmlformats.org/drawingml/2006/main">
               <a:ext uri="{FF2B5EF4-FFF2-40B4-BE49-F238E27FC236}">
-                <a16:creationId xmlns:a16="http://schemas.microsoft.com/office/drawing/2014/main" id="{BE8DF342-AF45-43F6-B2DF-878399735EC8}"/>
+                <a16:creationId xmlns:a16="http://schemas.microsoft.com/office/drawing/2014/main" id="{EB176EF7-CE4E-4E59-BE35-98DE330D7360}"/>
               </a:ext>
             </a:extLst>
           </p:cNvPr>
@@ -8905,7 +8905,7 @@
           <p:nvPr/>
         </p:nvPicPr>
         <p:blipFill>
-          <a:blip xmlns:r="http://schemas.openxmlformats.org/officeDocument/2006/relationships" xmlns:a="http://schemas.openxmlformats.org/drawingml/2006/main" r:embed="R656d442b2f274e2b"/>
+          <a:blip xmlns:r="http://schemas.openxmlformats.org/officeDocument/2006/relationships" xmlns:a="http://schemas.openxmlformats.org/drawingml/2006/main" r:embed="R1388a1f0a97d44c9"/>
           <a:srcRect xmlns:a="http://schemas.openxmlformats.org/drawingml/2006/main" l="0" t="0" r="0" b="0"/>
           <a:stretch xmlns:a="http://schemas.openxmlformats.org/drawingml/2006/main">
             <a:fillRect l="0" t="0" r="0" b="0"/>
@@ -8926,7 +8926,7 @@
           <p:cNvPr id="2" name="">
             <a:extLst xmlns:a="http://schemas.openxmlformats.org/drawingml/2006/main">
               <a:ext uri="{FF2B5EF4-FFF2-40B4-BE49-F238E27FC236}">
-                <a16:creationId xmlns:a16="http://schemas.microsoft.com/office/drawing/2014/main" id="{E4A3AE81-4FCF-4C07-ADC5-6BFEC205A7C1}"/>
+                <a16:creationId xmlns:a16="http://schemas.microsoft.com/office/drawing/2014/main" id="{26EF417F-C987-455C-95D2-DA0ACFE00463}"/>
               </a:ext>
             </a:extLst>
           </p:cNvPr>
@@ -8994,7 +8994,7 @@
           <p:cNvPr id="3" name="">
             <a:extLst xmlns:a="http://schemas.openxmlformats.org/drawingml/2006/main">
               <a:ext uri="{FF2B5EF4-FFF2-40B4-BE49-F238E27FC236}">
-                <a16:creationId xmlns:a16="http://schemas.microsoft.com/office/drawing/2014/main" id="{57B6A900-9A63-48F4-A37D-E8A0AAF88EFD}"/>
+                <a16:creationId xmlns:a16="http://schemas.microsoft.com/office/drawing/2014/main" id="{3BFF96C9-F1BF-4C9E-810A-90FC42D68F0F}"/>
               </a:ext>
             </a:extLst>
           </p:cNvPr>
@@ -9062,7 +9062,7 @@
           <p:cNvPr id="4" name="">
             <a:extLst xmlns:a="http://schemas.openxmlformats.org/drawingml/2006/main">
               <a:ext uri="{FF2B5EF4-FFF2-40B4-BE49-F238E27FC236}">
-                <a16:creationId xmlns:a16="http://schemas.microsoft.com/office/drawing/2014/main" id="{6C76D26D-6D2E-4B3D-8431-19B8348E2A62}"/>
+                <a16:creationId xmlns:a16="http://schemas.microsoft.com/office/drawing/2014/main" id="{A1C959A9-53BB-491F-ACE1-C446B0B6318A}"/>
               </a:ext>
             </a:extLst>
           </p:cNvPr>
@@ -9130,7 +9130,7 @@
           <p:cNvPr id="5" name="">
             <a:extLst xmlns:a="http://schemas.openxmlformats.org/drawingml/2006/main">
               <a:ext uri="{FF2B5EF4-FFF2-40B4-BE49-F238E27FC236}">
-                <a16:creationId xmlns:a16="http://schemas.microsoft.com/office/drawing/2014/main" id="{589CAEA1-D8D2-42F5-8F7D-F0A3E89CD42E}"/>
+                <a16:creationId xmlns:a16="http://schemas.microsoft.com/office/drawing/2014/main" id="{34E9B38D-8221-4536-ADD7-214ED98C21FE}"/>
               </a:ext>
             </a:extLst>
           </p:cNvPr>
@@ -9221,7 +9221,7 @@
           <p:cNvPr id="6" name="">
             <a:extLst xmlns:a="http://schemas.openxmlformats.org/drawingml/2006/main">
               <a:ext uri="{FF2B5EF4-FFF2-40B4-BE49-F238E27FC236}">
-                <a16:creationId xmlns:a16="http://schemas.microsoft.com/office/drawing/2014/main" id="{DCA17A43-5BB3-46A4-8CFF-946F48566AA2}"/>
+                <a16:creationId xmlns:a16="http://schemas.microsoft.com/office/drawing/2014/main" id="{66621708-439F-4EBD-B606-AA80C69BAB96}"/>
               </a:ext>
             </a:extLst>
           </p:cNvPr>
@@ -9289,7 +9289,7 @@
           <p:cNvPr id="7" name="">
             <a:extLst xmlns:a="http://schemas.openxmlformats.org/drawingml/2006/main">
               <a:ext uri="{FF2B5EF4-FFF2-40B4-BE49-F238E27FC236}">
-                <a16:creationId xmlns:a16="http://schemas.microsoft.com/office/drawing/2014/main" id="{5FB2F8BD-B871-45B1-B364-6B4CD05BA8CD}"/>
+                <a16:creationId xmlns:a16="http://schemas.microsoft.com/office/drawing/2014/main" id="{3646E4EF-2C7B-4C66-A0A7-BC5F7DA7E67B}"/>
               </a:ext>
             </a:extLst>
           </p:cNvPr>
@@ -9355,7 +9355,7 @@
     </p:spTree>
     <p:extLst>
       <p:ext uri="{BB962C8B-B14F-4D97-AF65-F5344CB8AC3E}">
-        <p14:creationId xmlns:p14="http://schemas.microsoft.com/office/powerpoint/2010/main" val="563153221"/>
+        <p14:creationId xmlns:p14="http://schemas.microsoft.com/office/powerpoint/2010/main" val="1333803595"/>
       </p:ext>
     </p:extLst>
   </p:cSld>
@@ -9386,7 +9386,7 @@
           <p:cNvPr id="14" name="">
             <a:extLst xmlns:a="http://schemas.openxmlformats.org/drawingml/2006/main">
               <a:ext uri="{FF2B5EF4-FFF2-40B4-BE49-F238E27FC236}">
-                <a16:creationId xmlns:a16="http://schemas.microsoft.com/office/drawing/2014/main" id="{34A09B38-F3B4-4BE7-A1A6-B32DE03F4FFA}"/>
+                <a16:creationId xmlns:a16="http://schemas.microsoft.com/office/drawing/2014/main" id="{C0BE2D4E-6AEB-4202-A11E-0FF6134CD9EC}"/>
               </a:ext>
             </a:extLst>
           </p:cNvPr>
@@ -9454,7 +9454,7 @@
           <p:cNvPr id="2" name="">
             <a:extLst xmlns:a="http://schemas.openxmlformats.org/drawingml/2006/main">
               <a:ext uri="{FF2B5EF4-FFF2-40B4-BE49-F238E27FC236}">
-                <a16:creationId xmlns:a16="http://schemas.microsoft.com/office/drawing/2014/main" id="{AF08F7CF-E8C4-4634-BD51-CF9E753B1036}"/>
+                <a16:creationId xmlns:a16="http://schemas.microsoft.com/office/drawing/2014/main" id="{51AD3C7C-1E2B-4345-AD48-7BF7BBD769F2}"/>
               </a:ext>
             </a:extLst>
           </p:cNvPr>
@@ -9522,7 +9522,7 @@
           <p:cNvPr id="3" name="">
             <a:extLst xmlns:a="http://schemas.openxmlformats.org/drawingml/2006/main">
               <a:ext uri="{FF2B5EF4-FFF2-40B4-BE49-F238E27FC236}">
-                <a16:creationId xmlns:a16="http://schemas.microsoft.com/office/drawing/2014/main" id="{21D3E367-50C7-4920-A5E2-51A69C9C01FD}"/>
+                <a16:creationId xmlns:a16="http://schemas.microsoft.com/office/drawing/2014/main" id="{3E17F0B4-736A-486B-A859-AB58B4E34F41}"/>
               </a:ext>
             </a:extLst>
           </p:cNvPr>
@@ -9590,7 +9590,7 @@
           <p:cNvPr id="4" name="">
             <a:extLst xmlns:a="http://schemas.openxmlformats.org/drawingml/2006/main">
               <a:ext uri="{FF2B5EF4-FFF2-40B4-BE49-F238E27FC236}">
-                <a16:creationId xmlns:a16="http://schemas.microsoft.com/office/drawing/2014/main" id="{C62CC475-6E2C-4EBB-B650-DCAFFAF9BDD8}"/>
+                <a16:creationId xmlns:a16="http://schemas.microsoft.com/office/drawing/2014/main" id="{0280A195-7C23-47F5-9C62-6769E61EA6E0}"/>
               </a:ext>
             </a:extLst>
           </p:cNvPr>
@@ -9658,7 +9658,7 @@
           <p:cNvPr id="5" name="">
             <a:extLst xmlns:a="http://schemas.openxmlformats.org/drawingml/2006/main">
               <a:ext uri="{FF2B5EF4-FFF2-40B4-BE49-F238E27FC236}">
-                <a16:creationId xmlns:a16="http://schemas.microsoft.com/office/drawing/2014/main" id="{675543EF-D5FA-4C4A-AE50-A5D0B413C816}"/>
+                <a16:creationId xmlns:a16="http://schemas.microsoft.com/office/drawing/2014/main" id="{F2A70D45-5C2C-4C8C-B333-8DCC250E57FD}"/>
               </a:ext>
             </a:extLst>
           </p:cNvPr>
@@ -9726,7 +9726,7 @@
           <p:cNvPr id="6" name="">
             <a:extLst xmlns:a="http://schemas.openxmlformats.org/drawingml/2006/main">
               <a:ext uri="{FF2B5EF4-FFF2-40B4-BE49-F238E27FC236}">
-                <a16:creationId xmlns:a16="http://schemas.microsoft.com/office/drawing/2014/main" id="{B36C84AC-4F16-428C-A9CF-316695F551BD}"/>
+                <a16:creationId xmlns:a16="http://schemas.microsoft.com/office/drawing/2014/main" id="{36E2BCE4-230E-442B-A0BD-6F7D8632B9B1}"/>
               </a:ext>
             </a:extLst>
           </p:cNvPr>
@@ -9863,7 +9863,7 @@
           <p:cNvPr id="7" name="">
             <a:extLst xmlns:a="http://schemas.openxmlformats.org/drawingml/2006/main">
               <a:ext uri="{FF2B5EF4-FFF2-40B4-BE49-F238E27FC236}">
-                <a16:creationId xmlns:a16="http://schemas.microsoft.com/office/drawing/2014/main" id="{F102334D-104E-4696-B22D-BEAB27FD7DEE}"/>
+                <a16:creationId xmlns:a16="http://schemas.microsoft.com/office/drawing/2014/main" id="{CFA5BF76-562F-4D9E-95A4-3BB199C69956}"/>
               </a:ext>
             </a:extLst>
           </p:cNvPr>
@@ -9931,7 +9931,7 @@
           <p:cNvPr id="8" name="">
             <a:extLst xmlns:a="http://schemas.openxmlformats.org/drawingml/2006/main">
               <a:ext uri="{FF2B5EF4-FFF2-40B4-BE49-F238E27FC236}">
-                <a16:creationId xmlns:a16="http://schemas.microsoft.com/office/drawing/2014/main" id="{0373E51E-8EA2-43EB-AC51-F6D1828F6645}"/>
+                <a16:creationId xmlns:a16="http://schemas.microsoft.com/office/drawing/2014/main" id="{36055A6B-2CAD-43BF-82F2-5AF585BD4CF6}"/>
               </a:ext>
             </a:extLst>
           </p:cNvPr>
@@ -9999,7 +9999,7 @@
           <p:cNvPr id="9" name="">
             <a:extLst xmlns:a="http://schemas.openxmlformats.org/drawingml/2006/main">
               <a:ext uri="{FF2B5EF4-FFF2-40B4-BE49-F238E27FC236}">
-                <a16:creationId xmlns:a16="http://schemas.microsoft.com/office/drawing/2014/main" id="{E2DFFF90-6140-4479-99D0-04706B856E4A}"/>
+                <a16:creationId xmlns:a16="http://schemas.microsoft.com/office/drawing/2014/main" id="{F46F95B4-AACC-424F-893C-C85B45BF50F3}"/>
               </a:ext>
             </a:extLst>
           </p:cNvPr>
@@ -10136,7 +10136,7 @@
           <p:cNvPr id="10" name="">
             <a:extLst xmlns:a="http://schemas.openxmlformats.org/drawingml/2006/main">
               <a:ext uri="{FF2B5EF4-FFF2-40B4-BE49-F238E27FC236}">
-                <a16:creationId xmlns:a16="http://schemas.microsoft.com/office/drawing/2014/main" id="{E618316C-8389-4874-979C-687F666287C7}"/>
+                <a16:creationId xmlns:a16="http://schemas.microsoft.com/office/drawing/2014/main" id="{757D9A8D-B18C-4B70-9461-557E75C485AE}"/>
               </a:ext>
             </a:extLst>
           </p:cNvPr>
@@ -10204,7 +10204,7 @@
           <p:cNvPr id="11" name="">
             <a:extLst xmlns:a="http://schemas.openxmlformats.org/drawingml/2006/main">
               <a:ext uri="{FF2B5EF4-FFF2-40B4-BE49-F238E27FC236}">
-                <a16:creationId xmlns:a16="http://schemas.microsoft.com/office/drawing/2014/main" id="{DAE519F1-B430-4B19-AE7B-8D91144BB4F3}"/>
+                <a16:creationId xmlns:a16="http://schemas.microsoft.com/office/drawing/2014/main" id="{3BA9506C-8A67-4A4B-9FD4-A5101F3BA0DF}"/>
               </a:ext>
             </a:extLst>
           </p:cNvPr>
@@ -10272,7 +10272,7 @@
           <p:cNvPr id="12" name="">
             <a:extLst xmlns:a="http://schemas.openxmlformats.org/drawingml/2006/main">
               <a:ext uri="{FF2B5EF4-FFF2-40B4-BE49-F238E27FC236}">
-                <a16:creationId xmlns:a16="http://schemas.microsoft.com/office/drawing/2014/main" id="{6594D2F3-35E3-4E0A-8706-042144BAE5C8}"/>
+                <a16:creationId xmlns:a16="http://schemas.microsoft.com/office/drawing/2014/main" id="{FA5D2E50-7DD5-4251-A88C-58F990ADCA41}"/>
               </a:ext>
             </a:extLst>
           </p:cNvPr>
@@ -10409,7 +10409,7 @@
           <p:cNvPr id="13" name="">
             <a:extLst xmlns:a="http://schemas.openxmlformats.org/drawingml/2006/main">
               <a:ext uri="{FF2B5EF4-FFF2-40B4-BE49-F238E27FC236}">
-                <a16:creationId xmlns:a16="http://schemas.microsoft.com/office/drawing/2014/main" id="{DA57456C-C190-445B-B952-B2E8EB88FB07}"/>
+                <a16:creationId xmlns:a16="http://schemas.microsoft.com/office/drawing/2014/main" id="{9A0A2212-DABF-4C28-8D33-09F8368B2817}"/>
               </a:ext>
             </a:extLst>
           </p:cNvPr>
@@ -10475,7 +10475,7 @@
     </p:spTree>
     <p:extLst>
       <p:ext uri="{BB962C8B-B14F-4D97-AF65-F5344CB8AC3E}">
-        <p14:creationId xmlns:p14="http://schemas.microsoft.com/office/powerpoint/2010/main" val="2034951199"/>
+        <p14:creationId xmlns:p14="http://schemas.microsoft.com/office/powerpoint/2010/main" val="768923183"/>
       </p:ext>
     </p:extLst>
   </p:cSld>
@@ -10506,7 +10506,7 @@
           <p:cNvPr id="21" name="">
             <a:extLst xmlns:a="http://schemas.openxmlformats.org/drawingml/2006/main">
               <a:ext uri="{FF2B5EF4-FFF2-40B4-BE49-F238E27FC236}">
-                <a16:creationId xmlns:a16="http://schemas.microsoft.com/office/drawing/2014/main" id="{372A0231-D5DA-4DC7-A480-A1EEBC08BF0C}"/>
+                <a16:creationId xmlns:a16="http://schemas.microsoft.com/office/drawing/2014/main" id="{1200AD82-8537-48D5-9E25-4BFC5A76FE43}"/>
               </a:ext>
             </a:extLst>
           </p:cNvPr>
@@ -10574,7 +10574,7 @@
           <p:cNvPr id="2" name="">
             <a:extLst xmlns:a="http://schemas.openxmlformats.org/drawingml/2006/main">
               <a:ext uri="{FF2B5EF4-FFF2-40B4-BE49-F238E27FC236}">
-                <a16:creationId xmlns:a16="http://schemas.microsoft.com/office/drawing/2014/main" id="{3A1B7A2C-77C4-49E4-87D7-054F87AED798}"/>
+                <a16:creationId xmlns:a16="http://schemas.microsoft.com/office/drawing/2014/main" id="{3EF2D0B8-3D11-4D5B-B56C-87E9CC180450}"/>
               </a:ext>
             </a:extLst>
           </p:cNvPr>
@@ -10642,7 +10642,7 @@
           <p:cNvPr id="3" name="">
             <a:extLst xmlns:a="http://schemas.openxmlformats.org/drawingml/2006/main">
               <a:ext uri="{FF2B5EF4-FFF2-40B4-BE49-F238E27FC236}">
-                <a16:creationId xmlns:a16="http://schemas.microsoft.com/office/drawing/2014/main" id="{FF95AD0D-20CB-4377-B5F9-A9B1FE6A2840}"/>
+                <a16:creationId xmlns:a16="http://schemas.microsoft.com/office/drawing/2014/main" id="{BC380BDE-B4B6-4EF0-963E-5AF4DA19F5AB}"/>
               </a:ext>
             </a:extLst>
           </p:cNvPr>
@@ -10710,7 +10710,7 @@
           <p:cNvPr id="4" name="">
             <a:extLst xmlns:a="http://schemas.openxmlformats.org/drawingml/2006/main">
               <a:ext uri="{FF2B5EF4-FFF2-40B4-BE49-F238E27FC236}">
-                <a16:creationId xmlns:a16="http://schemas.microsoft.com/office/drawing/2014/main" id="{B15C3CE8-20BC-4339-81A0-84A6F46AB2AA}"/>
+                <a16:creationId xmlns:a16="http://schemas.microsoft.com/office/drawing/2014/main" id="{C2E0E996-CF4E-40EF-845B-F76F142CCE3A}"/>
               </a:ext>
             </a:extLst>
           </p:cNvPr>
@@ -10720,7 +10720,7 @@
           <p:nvPr/>
         </p:nvPicPr>
         <p:blipFill>
-          <a:blip xmlns:r="http://schemas.openxmlformats.org/officeDocument/2006/relationships" xmlns:a="http://schemas.openxmlformats.org/drawingml/2006/main" r:embed="Rcba65484ed124924"/>
+          <a:blip xmlns:r="http://schemas.openxmlformats.org/officeDocument/2006/relationships" xmlns:a="http://schemas.openxmlformats.org/drawingml/2006/main" r:embed="R9bfa09573763478f"/>
           <a:stretch xmlns:a="http://schemas.openxmlformats.org/drawingml/2006/main"/>
         </p:blipFill>
         <p:spPr>
@@ -10738,7 +10738,7 @@
           <p:cNvPr id="5" name="">
             <a:extLst xmlns:a="http://schemas.openxmlformats.org/drawingml/2006/main">
               <a:ext uri="{FF2B5EF4-FFF2-40B4-BE49-F238E27FC236}">
-                <a16:creationId xmlns:a16="http://schemas.microsoft.com/office/drawing/2014/main" id="{C6882321-5115-4A27-AAB6-C4E35F12BF25}"/>
+                <a16:creationId xmlns:a16="http://schemas.microsoft.com/office/drawing/2014/main" id="{36E57DF7-9900-46C8-8EF2-5BA2548A14D2}"/>
               </a:ext>
             </a:extLst>
           </p:cNvPr>
@@ -10806,7 +10806,7 @@
           <p:cNvPr id="6" name="">
             <a:extLst xmlns:a="http://schemas.openxmlformats.org/drawingml/2006/main">
               <a:ext uri="{FF2B5EF4-FFF2-40B4-BE49-F238E27FC236}">
-                <a16:creationId xmlns:a16="http://schemas.microsoft.com/office/drawing/2014/main" id="{B143AC2D-B683-473B-9C23-3591BDE1C2EA}"/>
+                <a16:creationId xmlns:a16="http://schemas.microsoft.com/office/drawing/2014/main" id="{678FCF2C-24E6-465E-B1BC-E8F2C6A93880}"/>
               </a:ext>
             </a:extLst>
           </p:cNvPr>
@@ -10874,7 +10874,7 @@
           <p:cNvPr id="7" name="">
             <a:extLst xmlns:a="http://schemas.openxmlformats.org/drawingml/2006/main">
               <a:ext uri="{FF2B5EF4-FFF2-40B4-BE49-F238E27FC236}">
-                <a16:creationId xmlns:a16="http://schemas.microsoft.com/office/drawing/2014/main" id="{9EEC03E9-D51D-46F0-AFB4-BDD8532A6016}"/>
+                <a16:creationId xmlns:a16="http://schemas.microsoft.com/office/drawing/2014/main" id="{75662199-4EBD-48A4-BB51-580DE2AE39B8}"/>
               </a:ext>
             </a:extLst>
           </p:cNvPr>
@@ -10965,7 +10965,7 @@
           <p:cNvPr id="8" name="">
             <a:extLst xmlns:a="http://schemas.openxmlformats.org/drawingml/2006/main">
               <a:ext uri="{FF2B5EF4-FFF2-40B4-BE49-F238E27FC236}">
-                <a16:creationId xmlns:a16="http://schemas.microsoft.com/office/drawing/2014/main" id="{B2E0D38D-E9F5-4B28-AAA8-9C0040BF2095}"/>
+                <a16:creationId xmlns:a16="http://schemas.microsoft.com/office/drawing/2014/main" id="{9FAD0D56-B8B9-4705-9C7C-0A7BC0C3C688}"/>
               </a:ext>
             </a:extLst>
           </p:cNvPr>
@@ -10975,7 +10975,7 @@
           <p:nvPr/>
         </p:nvPicPr>
         <p:blipFill>
-          <a:blip xmlns:r="http://schemas.openxmlformats.org/officeDocument/2006/relationships" xmlns:a="http://schemas.openxmlformats.org/drawingml/2006/main" r:embed="R768d16be09be4804"/>
+          <a:blip xmlns:r="http://schemas.openxmlformats.org/officeDocument/2006/relationships" xmlns:a="http://schemas.openxmlformats.org/drawingml/2006/main" r:embed="Rbe6e1dfdc22f42e5"/>
           <a:stretch xmlns:a="http://schemas.openxmlformats.org/drawingml/2006/main"/>
         </p:blipFill>
         <p:spPr>
@@ -10993,7 +10993,7 @@
           <p:cNvPr id="9" name="">
             <a:extLst xmlns:a="http://schemas.openxmlformats.org/drawingml/2006/main">
               <a:ext uri="{FF2B5EF4-FFF2-40B4-BE49-F238E27FC236}">
-                <a16:creationId xmlns:a16="http://schemas.microsoft.com/office/drawing/2014/main" id="{D4AED50E-8614-4EB1-9E75-DA7FE0B18A28}"/>
+                <a16:creationId xmlns:a16="http://schemas.microsoft.com/office/drawing/2014/main" id="{D4DB72B1-B060-45FF-9983-6350411161E3}"/>
               </a:ext>
             </a:extLst>
           </p:cNvPr>
@@ -11061,7 +11061,7 @@
           <p:cNvPr id="10" name="">
             <a:extLst xmlns:a="http://schemas.openxmlformats.org/drawingml/2006/main">
               <a:ext uri="{FF2B5EF4-FFF2-40B4-BE49-F238E27FC236}">
-                <a16:creationId xmlns:a16="http://schemas.microsoft.com/office/drawing/2014/main" id="{605101E3-8F73-4DF0-A3AA-C22896397B83}"/>
+                <a16:creationId xmlns:a16="http://schemas.microsoft.com/office/drawing/2014/main" id="{9C4C367C-981F-4273-A584-E8B749F102EF}"/>
               </a:ext>
             </a:extLst>
           </p:cNvPr>
@@ -11129,7 +11129,7 @@
           <p:cNvPr id="11" name="">
             <a:extLst xmlns:a="http://schemas.openxmlformats.org/drawingml/2006/main">
               <a:ext uri="{FF2B5EF4-FFF2-40B4-BE49-F238E27FC236}">
-                <a16:creationId xmlns:a16="http://schemas.microsoft.com/office/drawing/2014/main" id="{87DD97E5-2841-41D4-82F6-402CB90003E8}"/>
+                <a16:creationId xmlns:a16="http://schemas.microsoft.com/office/drawing/2014/main" id="{5A282943-7BEA-4F16-86FD-C770D1B2DB57}"/>
               </a:ext>
             </a:extLst>
           </p:cNvPr>
@@ -11220,7 +11220,7 @@
           <p:cNvPr id="12" name="">
             <a:extLst xmlns:a="http://schemas.openxmlformats.org/drawingml/2006/main">
               <a:ext uri="{FF2B5EF4-FFF2-40B4-BE49-F238E27FC236}">
-                <a16:creationId xmlns:a16="http://schemas.microsoft.com/office/drawing/2014/main" id="{61560999-EEEC-4465-BFDC-824BEF24B816}"/>
+                <a16:creationId xmlns:a16="http://schemas.microsoft.com/office/drawing/2014/main" id="{27DA4848-254B-408E-8A97-993926D779A4}"/>
               </a:ext>
             </a:extLst>
           </p:cNvPr>
@@ -11230,7 +11230,7 @@
           <p:nvPr/>
         </p:nvPicPr>
         <p:blipFill>
-          <a:blip xmlns:r="http://schemas.openxmlformats.org/officeDocument/2006/relationships" xmlns:a="http://schemas.openxmlformats.org/drawingml/2006/main" r:embed="Rda5b5d7b3dee4a13"/>
+          <a:blip xmlns:r="http://schemas.openxmlformats.org/officeDocument/2006/relationships" xmlns:a="http://schemas.openxmlformats.org/drawingml/2006/main" r:embed="Rbc0cb16641db4289"/>
           <a:stretch xmlns:a="http://schemas.openxmlformats.org/drawingml/2006/main"/>
         </p:blipFill>
         <p:spPr>
@@ -11248,7 +11248,7 @@
           <p:cNvPr id="13" name="">
             <a:extLst xmlns:a="http://schemas.openxmlformats.org/drawingml/2006/main">
               <a:ext uri="{FF2B5EF4-FFF2-40B4-BE49-F238E27FC236}">
-                <a16:creationId xmlns:a16="http://schemas.microsoft.com/office/drawing/2014/main" id="{24D6B3A7-792E-43FF-AAA6-9FC7537EE642}"/>
+                <a16:creationId xmlns:a16="http://schemas.microsoft.com/office/drawing/2014/main" id="{84FBA777-0531-47EE-8AA0-88DDAD221B9E}"/>
               </a:ext>
             </a:extLst>
           </p:cNvPr>
@@ -11316,7 +11316,7 @@
           <p:cNvPr id="14" name="">
             <a:extLst xmlns:a="http://schemas.openxmlformats.org/drawingml/2006/main">
               <a:ext uri="{FF2B5EF4-FFF2-40B4-BE49-F238E27FC236}">
-                <a16:creationId xmlns:a16="http://schemas.microsoft.com/office/drawing/2014/main" id="{42D2320E-E6DB-4E71-909D-225CCD2C177E}"/>
+                <a16:creationId xmlns:a16="http://schemas.microsoft.com/office/drawing/2014/main" id="{92D12D43-B82B-4BCC-A997-7354419B1A3E}"/>
               </a:ext>
             </a:extLst>
           </p:cNvPr>
@@ -11384,7 +11384,7 @@
           <p:cNvPr id="15" name="">
             <a:extLst xmlns:a="http://schemas.openxmlformats.org/drawingml/2006/main">
               <a:ext uri="{FF2B5EF4-FFF2-40B4-BE49-F238E27FC236}">
-                <a16:creationId xmlns:a16="http://schemas.microsoft.com/office/drawing/2014/main" id="{EEF6C065-2BE5-4372-A588-DDE4ECB32FAF}"/>
+                <a16:creationId xmlns:a16="http://schemas.microsoft.com/office/drawing/2014/main" id="{03E3DEE3-60D5-4CD3-A397-AC1692D7DBA8}"/>
               </a:ext>
             </a:extLst>
           </p:cNvPr>
@@ -11475,7 +11475,7 @@
           <p:cNvPr id="16" name="">
             <a:extLst xmlns:a="http://schemas.openxmlformats.org/drawingml/2006/main">
               <a:ext uri="{FF2B5EF4-FFF2-40B4-BE49-F238E27FC236}">
-                <a16:creationId xmlns:a16="http://schemas.microsoft.com/office/drawing/2014/main" id="{9647C589-7AAB-480D-BA4E-373CCBEF98EE}"/>
+                <a16:creationId xmlns:a16="http://schemas.microsoft.com/office/drawing/2014/main" id="{04DAF5B5-C895-4659-A230-2E0A7BCE5A45}"/>
               </a:ext>
             </a:extLst>
           </p:cNvPr>
@@ -11485,7 +11485,7 @@
           <p:nvPr/>
         </p:nvPicPr>
         <p:blipFill>
-          <a:blip xmlns:r="http://schemas.openxmlformats.org/officeDocument/2006/relationships" xmlns:a="http://schemas.openxmlformats.org/drawingml/2006/main" r:embed="R986d7efe394e4673"/>
+          <a:blip xmlns:r="http://schemas.openxmlformats.org/officeDocument/2006/relationships" xmlns:a="http://schemas.openxmlformats.org/drawingml/2006/main" r:embed="R4a6ecef3813e4d10"/>
           <a:stretch xmlns:a="http://schemas.openxmlformats.org/drawingml/2006/main"/>
         </p:blipFill>
         <p:spPr>
@@ -11503,7 +11503,7 @@
           <p:cNvPr id="17" name="">
             <a:extLst xmlns:a="http://schemas.openxmlformats.org/drawingml/2006/main">
               <a:ext uri="{FF2B5EF4-FFF2-40B4-BE49-F238E27FC236}">
-                <a16:creationId xmlns:a16="http://schemas.microsoft.com/office/drawing/2014/main" id="{0FEE8DDB-E904-4B7B-B7F8-A3B2964EFA4B}"/>
+                <a16:creationId xmlns:a16="http://schemas.microsoft.com/office/drawing/2014/main" id="{71A23159-8BCA-4D0B-A37C-56DA1E6A47D6}"/>
               </a:ext>
             </a:extLst>
           </p:cNvPr>
@@ -11571,7 +11571,7 @@
           <p:cNvPr id="18" name="">
             <a:extLst xmlns:a="http://schemas.openxmlformats.org/drawingml/2006/main">
               <a:ext uri="{FF2B5EF4-FFF2-40B4-BE49-F238E27FC236}">
-                <a16:creationId xmlns:a16="http://schemas.microsoft.com/office/drawing/2014/main" id="{99085A82-C3DE-48A7-A746-0D077EFB0FDE}"/>
+                <a16:creationId xmlns:a16="http://schemas.microsoft.com/office/drawing/2014/main" id="{FC8FAB01-E4D2-4A29-A680-58E8B7B2F6C3}"/>
               </a:ext>
             </a:extLst>
           </p:cNvPr>
@@ -11639,7 +11639,7 @@
           <p:cNvPr id="19" name="">
             <a:extLst xmlns:a="http://schemas.openxmlformats.org/drawingml/2006/main">
               <a:ext uri="{FF2B5EF4-FFF2-40B4-BE49-F238E27FC236}">
-                <a16:creationId xmlns:a16="http://schemas.microsoft.com/office/drawing/2014/main" id="{EA484F82-8257-46BC-B246-AE90D6F118C4}"/>
+                <a16:creationId xmlns:a16="http://schemas.microsoft.com/office/drawing/2014/main" id="{6F61D43E-D2CD-4434-9649-4FC9A10CE95F}"/>
               </a:ext>
             </a:extLst>
           </p:cNvPr>
@@ -11730,7 +11730,7 @@
           <p:cNvPr id="20" name="">
             <a:extLst xmlns:a="http://schemas.openxmlformats.org/drawingml/2006/main">
               <a:ext uri="{FF2B5EF4-FFF2-40B4-BE49-F238E27FC236}">
-                <a16:creationId xmlns:a16="http://schemas.microsoft.com/office/drawing/2014/main" id="{3F39C2C0-3E75-4D61-B3F5-FE3A8CE4C7B9}"/>
+                <a16:creationId xmlns:a16="http://schemas.microsoft.com/office/drawing/2014/main" id="{79D83120-F402-4F37-B173-7008E36E2112}"/>
               </a:ext>
             </a:extLst>
           </p:cNvPr>
@@ -11796,7 +11796,7 @@
     </p:spTree>
     <p:extLst>
       <p:ext uri="{BB962C8B-B14F-4D97-AF65-F5344CB8AC3E}">
-        <p14:creationId xmlns:p14="http://schemas.microsoft.com/office/powerpoint/2010/main" val="1776764749"/>
+        <p14:creationId xmlns:p14="http://schemas.microsoft.com/office/powerpoint/2010/main" val="1832225081"/>
       </p:ext>
     </p:extLst>
   </p:cSld>
@@ -11827,7 +11827,7 @@
           <p:cNvPr id="21" name="">
             <a:extLst xmlns:a="http://schemas.openxmlformats.org/drawingml/2006/main">
               <a:ext uri="{FF2B5EF4-FFF2-40B4-BE49-F238E27FC236}">
-                <a16:creationId xmlns:a16="http://schemas.microsoft.com/office/drawing/2014/main" id="{92641241-5AB8-447A-BAEA-BAFABC6200C4}"/>
+                <a16:creationId xmlns:a16="http://schemas.microsoft.com/office/drawing/2014/main" id="{3AC857B0-FC5B-4871-8665-E884BF5A6557}"/>
               </a:ext>
             </a:extLst>
           </p:cNvPr>
@@ -11895,7 +11895,7 @@
           <p:cNvPr id="2" name="">
             <a:extLst xmlns:a="http://schemas.openxmlformats.org/drawingml/2006/main">
               <a:ext uri="{FF2B5EF4-FFF2-40B4-BE49-F238E27FC236}">
-                <a16:creationId xmlns:a16="http://schemas.microsoft.com/office/drawing/2014/main" id="{D71B6FB4-D87C-49CB-BF28-ECFA69C8552C}"/>
+                <a16:creationId xmlns:a16="http://schemas.microsoft.com/office/drawing/2014/main" id="{D82EE344-C981-4EEE-8C2C-FC4252ED529F}"/>
               </a:ext>
             </a:extLst>
           </p:cNvPr>
@@ -11963,7 +11963,7 @@
           <p:cNvPr id="3" name="">
             <a:extLst xmlns:a="http://schemas.openxmlformats.org/drawingml/2006/main">
               <a:ext uri="{FF2B5EF4-FFF2-40B4-BE49-F238E27FC236}">
-                <a16:creationId xmlns:a16="http://schemas.microsoft.com/office/drawing/2014/main" id="{E3254A35-1465-45E9-94D8-BE3B1BAD8C8F}"/>
+                <a16:creationId xmlns:a16="http://schemas.microsoft.com/office/drawing/2014/main" id="{52DFD872-D0CA-4E6F-8C4B-558399AE71B5}"/>
               </a:ext>
             </a:extLst>
           </p:cNvPr>
@@ -12031,7 +12031,7 @@
           <p:cNvPr id="4" name="">
             <a:extLst xmlns:a="http://schemas.openxmlformats.org/drawingml/2006/main">
               <a:ext uri="{FF2B5EF4-FFF2-40B4-BE49-F238E27FC236}">
-                <a16:creationId xmlns:a16="http://schemas.microsoft.com/office/drawing/2014/main" id="{4C59EBFD-9D7E-4E25-A0D4-2FF169A7DD89}"/>
+                <a16:creationId xmlns:a16="http://schemas.microsoft.com/office/drawing/2014/main" id="{353CB8E9-3D5E-46A5-8ED5-A8523CEC77A2}"/>
               </a:ext>
             </a:extLst>
           </p:cNvPr>
@@ -12041,7 +12041,7 @@
           <p:nvPr/>
         </p:nvPicPr>
         <p:blipFill>
-          <a:blip xmlns:r="http://schemas.openxmlformats.org/officeDocument/2006/relationships" xmlns:a="http://schemas.openxmlformats.org/drawingml/2006/main" r:embed="Rc828acdade514b51"/>
+          <a:blip xmlns:r="http://schemas.openxmlformats.org/officeDocument/2006/relationships" xmlns:a="http://schemas.openxmlformats.org/drawingml/2006/main" r:embed="R654f193db92b4459"/>
           <a:stretch xmlns:a="http://schemas.openxmlformats.org/drawingml/2006/main"/>
         </p:blipFill>
         <p:spPr>
@@ -12059,7 +12059,7 @@
           <p:cNvPr id="5" name="">
             <a:extLst xmlns:a="http://schemas.openxmlformats.org/drawingml/2006/main">
               <a:ext uri="{FF2B5EF4-FFF2-40B4-BE49-F238E27FC236}">
-                <a16:creationId xmlns:a16="http://schemas.microsoft.com/office/drawing/2014/main" id="{DA9E376B-42CF-4F48-97A2-EE1098C92B94}"/>
+                <a16:creationId xmlns:a16="http://schemas.microsoft.com/office/drawing/2014/main" id="{392AB35C-5BA9-462C-A4E6-EA439A8BD445}"/>
               </a:ext>
             </a:extLst>
           </p:cNvPr>
@@ -12127,7 +12127,7 @@
           <p:cNvPr id="6" name="">
             <a:extLst xmlns:a="http://schemas.openxmlformats.org/drawingml/2006/main">
               <a:ext uri="{FF2B5EF4-FFF2-40B4-BE49-F238E27FC236}">
-                <a16:creationId xmlns:a16="http://schemas.microsoft.com/office/drawing/2014/main" id="{A4E54C19-86F8-4844-BAD1-EEE7931EE27A}"/>
+                <a16:creationId xmlns:a16="http://schemas.microsoft.com/office/drawing/2014/main" id="{A3A8F26B-4F9F-4225-8877-1A7F9CCDFFE9}"/>
               </a:ext>
             </a:extLst>
           </p:cNvPr>
@@ -12195,7 +12195,7 @@
           <p:cNvPr id="7" name="">
             <a:extLst xmlns:a="http://schemas.openxmlformats.org/drawingml/2006/main">
               <a:ext uri="{FF2B5EF4-FFF2-40B4-BE49-F238E27FC236}">
-                <a16:creationId xmlns:a16="http://schemas.microsoft.com/office/drawing/2014/main" id="{D3B57186-121E-4225-B607-26D62D861A9E}"/>
+                <a16:creationId xmlns:a16="http://schemas.microsoft.com/office/drawing/2014/main" id="{6138FA2A-10B3-428E-928F-A0D6075578DB}"/>
               </a:ext>
             </a:extLst>
           </p:cNvPr>
@@ -12205,7 +12205,7 @@
           <p:nvPr/>
         </p:nvPicPr>
         <p:blipFill>
-          <a:blip xmlns:r="http://schemas.openxmlformats.org/officeDocument/2006/relationships" xmlns:a="http://schemas.openxmlformats.org/drawingml/2006/main" r:embed="R7c3b3e27666b4e93"/>
+          <a:blip xmlns:r="http://schemas.openxmlformats.org/officeDocument/2006/relationships" xmlns:a="http://schemas.openxmlformats.org/drawingml/2006/main" r:embed="R333f06c572c74635"/>
           <a:stretch xmlns:a="http://schemas.openxmlformats.org/drawingml/2006/main"/>
         </p:blipFill>
         <p:spPr>
@@ -12223,7 +12223,7 @@
           <p:cNvPr id="8" name="">
             <a:extLst xmlns:a="http://schemas.openxmlformats.org/drawingml/2006/main">
               <a:ext uri="{FF2B5EF4-FFF2-40B4-BE49-F238E27FC236}">
-                <a16:creationId xmlns:a16="http://schemas.microsoft.com/office/drawing/2014/main" id="{0DF607C7-1678-4652-B82C-6A893A924A27}"/>
+                <a16:creationId xmlns:a16="http://schemas.microsoft.com/office/drawing/2014/main" id="{99CDA7F3-5A8F-4190-98A3-655F5F60F20A}"/>
               </a:ext>
             </a:extLst>
           </p:cNvPr>
@@ -12291,7 +12291,7 @@
           <p:cNvPr id="9" name="">
             <a:extLst xmlns:a="http://schemas.openxmlformats.org/drawingml/2006/main">
               <a:ext uri="{FF2B5EF4-FFF2-40B4-BE49-F238E27FC236}">
-                <a16:creationId xmlns:a16="http://schemas.microsoft.com/office/drawing/2014/main" id="{08C2ED2F-CA94-4DE3-9029-0E28B3B9CB28}"/>
+                <a16:creationId xmlns:a16="http://schemas.microsoft.com/office/drawing/2014/main" id="{85F4452E-8D5F-45E6-9897-AA4CA2ACECB7}"/>
               </a:ext>
             </a:extLst>
           </p:cNvPr>
@@ -12359,7 +12359,7 @@
           <p:cNvPr id="10" name="">
             <a:extLst xmlns:a="http://schemas.openxmlformats.org/drawingml/2006/main">
               <a:ext uri="{FF2B5EF4-FFF2-40B4-BE49-F238E27FC236}">
-                <a16:creationId xmlns:a16="http://schemas.microsoft.com/office/drawing/2014/main" id="{AF26EE6E-FB5C-45EE-8978-EA589C162ED0}"/>
+                <a16:creationId xmlns:a16="http://schemas.microsoft.com/office/drawing/2014/main" id="{251BCFB3-3C8E-449A-A9A3-ABB17A007FC2}"/>
               </a:ext>
             </a:extLst>
           </p:cNvPr>
@@ -12369,7 +12369,7 @@
           <p:nvPr/>
         </p:nvPicPr>
         <p:blipFill>
-          <a:blip xmlns:r="http://schemas.openxmlformats.org/officeDocument/2006/relationships" xmlns:a="http://schemas.openxmlformats.org/drawingml/2006/main" r:embed="Rc45790349b574264"/>
+          <a:blip xmlns:r="http://schemas.openxmlformats.org/officeDocument/2006/relationships" xmlns:a="http://schemas.openxmlformats.org/drawingml/2006/main" r:embed="R759d92b384234887"/>
           <a:stretch xmlns:a="http://schemas.openxmlformats.org/drawingml/2006/main"/>
         </p:blipFill>
         <p:spPr>
@@ -12387,7 +12387,7 @@
           <p:cNvPr id="11" name="">
             <a:extLst xmlns:a="http://schemas.openxmlformats.org/drawingml/2006/main">
               <a:ext uri="{FF2B5EF4-FFF2-40B4-BE49-F238E27FC236}">
-                <a16:creationId xmlns:a16="http://schemas.microsoft.com/office/drawing/2014/main" id="{82CCA82D-FDE3-4E92-A07F-73600300F890}"/>
+                <a16:creationId xmlns:a16="http://schemas.microsoft.com/office/drawing/2014/main" id="{562D71AB-5020-4EFB-9FAF-5ECB5DF4CF81}"/>
               </a:ext>
             </a:extLst>
           </p:cNvPr>
@@ -12455,7 +12455,7 @@
           <p:cNvPr id="12" name="">
             <a:extLst xmlns:a="http://schemas.openxmlformats.org/drawingml/2006/main">
               <a:ext uri="{FF2B5EF4-FFF2-40B4-BE49-F238E27FC236}">
-                <a16:creationId xmlns:a16="http://schemas.microsoft.com/office/drawing/2014/main" id="{82EE30BE-7A9F-4CC0-B4EB-E47234FCA632}"/>
+                <a16:creationId xmlns:a16="http://schemas.microsoft.com/office/drawing/2014/main" id="{30E33A59-6854-4846-9B66-41A91109B483}"/>
               </a:ext>
             </a:extLst>
           </p:cNvPr>
@@ -12523,7 +12523,7 @@
           <p:cNvPr id="13" name="">
             <a:extLst xmlns:a="http://schemas.openxmlformats.org/drawingml/2006/main">
               <a:ext uri="{FF2B5EF4-FFF2-40B4-BE49-F238E27FC236}">
-                <a16:creationId xmlns:a16="http://schemas.microsoft.com/office/drawing/2014/main" id="{639A45F4-7DF6-49FF-9CB3-3CE58F05925C}"/>
+                <a16:creationId xmlns:a16="http://schemas.microsoft.com/office/drawing/2014/main" id="{748A3ECE-B298-4279-8B81-B55B81A84208}"/>
               </a:ext>
             </a:extLst>
           </p:cNvPr>
@@ -12533,7 +12533,7 @@
           <p:nvPr/>
         </p:nvPicPr>
         <p:blipFill>
-          <a:blip xmlns:r="http://schemas.openxmlformats.org/officeDocument/2006/relationships" xmlns:a="http://schemas.openxmlformats.org/drawingml/2006/main" r:embed="R94f3007961ea4d76"/>
+          <a:blip xmlns:r="http://schemas.openxmlformats.org/officeDocument/2006/relationships" xmlns:a="http://schemas.openxmlformats.org/drawingml/2006/main" r:embed="Rd150e41a29864ff0"/>
           <a:stretch xmlns:a="http://schemas.openxmlformats.org/drawingml/2006/main"/>
         </p:blipFill>
         <p:spPr>
@@ -12551,7 +12551,7 @@
           <p:cNvPr id="14" name="">
             <a:extLst xmlns:a="http://schemas.openxmlformats.org/drawingml/2006/main">
               <a:ext uri="{FF2B5EF4-FFF2-40B4-BE49-F238E27FC236}">
-                <a16:creationId xmlns:a16="http://schemas.microsoft.com/office/drawing/2014/main" id="{BA54C7B2-7760-4765-AE73-D4FCE0982011}"/>
+                <a16:creationId xmlns:a16="http://schemas.microsoft.com/office/drawing/2014/main" id="{DD78143F-A411-491C-A96B-2B580020D8A4}"/>
               </a:ext>
             </a:extLst>
           </p:cNvPr>
@@ -12619,7 +12619,7 @@
           <p:cNvPr id="15" name="">
             <a:extLst xmlns:a="http://schemas.openxmlformats.org/drawingml/2006/main">
               <a:ext uri="{FF2B5EF4-FFF2-40B4-BE49-F238E27FC236}">
-                <a16:creationId xmlns:a16="http://schemas.microsoft.com/office/drawing/2014/main" id="{B5F11684-F118-4FB5-A90D-7521B28A4A88}"/>
+                <a16:creationId xmlns:a16="http://schemas.microsoft.com/office/drawing/2014/main" id="{E4336A41-6B77-4E88-994B-B4AD37639D9C}"/>
               </a:ext>
             </a:extLst>
           </p:cNvPr>
@@ -12687,7 +12687,7 @@
           <p:cNvPr id="16" name="">
             <a:extLst xmlns:a="http://schemas.openxmlformats.org/drawingml/2006/main">
               <a:ext uri="{FF2B5EF4-FFF2-40B4-BE49-F238E27FC236}">
-                <a16:creationId xmlns:a16="http://schemas.microsoft.com/office/drawing/2014/main" id="{2B349693-EB23-4D63-A8E0-1C32EAD5D517}"/>
+                <a16:creationId xmlns:a16="http://schemas.microsoft.com/office/drawing/2014/main" id="{89A83A47-097B-4510-AEEA-61F933970C84}"/>
               </a:ext>
             </a:extLst>
           </p:cNvPr>
@@ -12697,7 +12697,7 @@
           <p:nvPr/>
         </p:nvPicPr>
         <p:blipFill>
-          <a:blip xmlns:r="http://schemas.openxmlformats.org/officeDocument/2006/relationships" xmlns:a="http://schemas.openxmlformats.org/drawingml/2006/main" r:embed="R35366cf61cd9463e"/>
+          <a:blip xmlns:r="http://schemas.openxmlformats.org/officeDocument/2006/relationships" xmlns:a="http://schemas.openxmlformats.org/drawingml/2006/main" r:embed="Recaf54eece3c4b6d"/>
           <a:stretch xmlns:a="http://schemas.openxmlformats.org/drawingml/2006/main"/>
         </p:blipFill>
         <p:spPr>
@@ -12715,7 +12715,7 @@
           <p:cNvPr id="17" name="">
             <a:extLst xmlns:a="http://schemas.openxmlformats.org/drawingml/2006/main">
               <a:ext uri="{FF2B5EF4-FFF2-40B4-BE49-F238E27FC236}">
-                <a16:creationId xmlns:a16="http://schemas.microsoft.com/office/drawing/2014/main" id="{FED31705-42FB-4AF3-A1CA-017AA81F64AE}"/>
+                <a16:creationId xmlns:a16="http://schemas.microsoft.com/office/drawing/2014/main" id="{F060B4E0-CE19-4F7D-81EE-57DF3EDD7F26}"/>
               </a:ext>
             </a:extLst>
           </p:cNvPr>
@@ -12783,7 +12783,7 @@
           <p:cNvPr id="18" name="">
             <a:extLst xmlns:a="http://schemas.openxmlformats.org/drawingml/2006/main">
               <a:ext uri="{FF2B5EF4-FFF2-40B4-BE49-F238E27FC236}">
-                <a16:creationId xmlns:a16="http://schemas.microsoft.com/office/drawing/2014/main" id="{F5C83DF2-B29B-4311-9CC7-603906A4A11B}"/>
+                <a16:creationId xmlns:a16="http://schemas.microsoft.com/office/drawing/2014/main" id="{576BF525-C9B3-47B2-A2CF-97621BC9CBB1}"/>
               </a:ext>
             </a:extLst>
           </p:cNvPr>
@@ -12851,7 +12851,7 @@
           <p:cNvPr id="19" name="">
             <a:extLst xmlns:a="http://schemas.openxmlformats.org/drawingml/2006/main">
               <a:ext uri="{FF2B5EF4-FFF2-40B4-BE49-F238E27FC236}">
-                <a16:creationId xmlns:a16="http://schemas.microsoft.com/office/drawing/2014/main" id="{1FF0CE5F-AD0B-42D9-8B75-D571CF64E2E7}"/>
+                <a16:creationId xmlns:a16="http://schemas.microsoft.com/office/drawing/2014/main" id="{0481E0D6-B80D-4852-9A02-54125B3594B3}"/>
               </a:ext>
             </a:extLst>
           </p:cNvPr>
@@ -12919,7 +12919,7 @@
           <p:cNvPr id="20" name="">
             <a:extLst xmlns:a="http://schemas.openxmlformats.org/drawingml/2006/main">
               <a:ext uri="{FF2B5EF4-FFF2-40B4-BE49-F238E27FC236}">
-                <a16:creationId xmlns:a16="http://schemas.microsoft.com/office/drawing/2014/main" id="{1D991699-792D-4853-B673-BD865DBB8A70}"/>
+                <a16:creationId xmlns:a16="http://schemas.microsoft.com/office/drawing/2014/main" id="{188B3FAD-0F33-4842-BFE3-45CB1979EE4E}"/>
               </a:ext>
             </a:extLst>
           </p:cNvPr>
@@ -12985,7 +12985,7 @@
     </p:spTree>
     <p:extLst>
       <p:ext uri="{BB962C8B-B14F-4D97-AF65-F5344CB8AC3E}">
-        <p14:creationId xmlns:p14="http://schemas.microsoft.com/office/powerpoint/2010/main" val="1031961689"/>
+        <p14:creationId xmlns:p14="http://schemas.microsoft.com/office/powerpoint/2010/main" val="638222797"/>
       </p:ext>
     </p:extLst>
   </p:cSld>
@@ -13016,7 +13016,7 @@
           <p:cNvPr id="18" name="">
             <a:extLst xmlns:a="http://schemas.openxmlformats.org/drawingml/2006/main">
               <a:ext uri="{FF2B5EF4-FFF2-40B4-BE49-F238E27FC236}">
-                <a16:creationId xmlns:a16="http://schemas.microsoft.com/office/drawing/2014/main" id="{A344C7B0-34A7-4682-9F47-F8D636277B44}"/>
+                <a16:creationId xmlns:a16="http://schemas.microsoft.com/office/drawing/2014/main" id="{85034B6C-7098-4D3A-AC43-B77134ABEF3E}"/>
               </a:ext>
             </a:extLst>
           </p:cNvPr>
@@ -13084,7 +13084,7 @@
           <p:cNvPr id="2" name="">
             <a:extLst xmlns:a="http://schemas.openxmlformats.org/drawingml/2006/main">
               <a:ext uri="{FF2B5EF4-FFF2-40B4-BE49-F238E27FC236}">
-                <a16:creationId xmlns:a16="http://schemas.microsoft.com/office/drawing/2014/main" id="{2331A884-CBCE-405D-A125-86632C2E1F25}"/>
+                <a16:creationId xmlns:a16="http://schemas.microsoft.com/office/drawing/2014/main" id="{BBAA4C81-3C7F-42DD-957D-C478685E8B86}"/>
               </a:ext>
             </a:extLst>
           </p:cNvPr>
@@ -13152,7 +13152,7 @@
           <p:cNvPr id="3" name="">
             <a:extLst xmlns:a="http://schemas.openxmlformats.org/drawingml/2006/main">
               <a:ext uri="{FF2B5EF4-FFF2-40B4-BE49-F238E27FC236}">
-                <a16:creationId xmlns:a16="http://schemas.microsoft.com/office/drawing/2014/main" id="{A2A00F13-9DFB-4F2D-B827-A20B0DA8C664}"/>
+                <a16:creationId xmlns:a16="http://schemas.microsoft.com/office/drawing/2014/main" id="{07A1CF96-1D1C-4E1B-AD15-F4F57CA1F716}"/>
               </a:ext>
             </a:extLst>
           </p:cNvPr>
@@ -13220,7 +13220,7 @@
           <p:cNvPr id="4" name="">
             <a:extLst xmlns:a="http://schemas.openxmlformats.org/drawingml/2006/main">
               <a:ext uri="{FF2B5EF4-FFF2-40B4-BE49-F238E27FC236}">
-                <a16:creationId xmlns:a16="http://schemas.microsoft.com/office/drawing/2014/main" id="{3A3C2EAE-A5A6-4917-B2EA-FB261A3B4567}"/>
+                <a16:creationId xmlns:a16="http://schemas.microsoft.com/office/drawing/2014/main" id="{7F2FE0FC-532F-4341-8D98-587B134973B0}"/>
               </a:ext>
             </a:extLst>
           </p:cNvPr>
@@ -13230,7 +13230,7 @@
           <p:nvPr/>
         </p:nvPicPr>
         <p:blipFill>
-          <a:blip xmlns:r="http://schemas.openxmlformats.org/officeDocument/2006/relationships" xmlns:a="http://schemas.openxmlformats.org/drawingml/2006/main" r:embed="Rc0414607968545b1"/>
+          <a:blip xmlns:r="http://schemas.openxmlformats.org/officeDocument/2006/relationships" xmlns:a="http://schemas.openxmlformats.org/drawingml/2006/main" r:embed="R86c6fbf92bb14831"/>
           <a:stretch xmlns:a="http://schemas.openxmlformats.org/drawingml/2006/main"/>
         </p:blipFill>
         <p:spPr>
@@ -13248,7 +13248,7 @@
           <p:cNvPr id="5" name="">
             <a:extLst xmlns:a="http://schemas.openxmlformats.org/drawingml/2006/main">
               <a:ext uri="{FF2B5EF4-FFF2-40B4-BE49-F238E27FC236}">
-                <a16:creationId xmlns:a16="http://schemas.microsoft.com/office/drawing/2014/main" id="{4D09986F-9CFA-453E-8CBD-245B733DDF84}"/>
+                <a16:creationId xmlns:a16="http://schemas.microsoft.com/office/drawing/2014/main" id="{0871F1D0-935D-4319-9914-90C831E59238}"/>
               </a:ext>
             </a:extLst>
           </p:cNvPr>
@@ -13278,7 +13278,7 @@
           <p:cNvPr id="6" name="">
             <a:extLst xmlns:a="http://schemas.openxmlformats.org/drawingml/2006/main">
               <a:ext uri="{FF2B5EF4-FFF2-40B4-BE49-F238E27FC236}">
-                <a16:creationId xmlns:a16="http://schemas.microsoft.com/office/drawing/2014/main" id="{AB0ACB8D-987E-421A-8AA2-5BE8E5A2CE61}"/>
+                <a16:creationId xmlns:a16="http://schemas.microsoft.com/office/drawing/2014/main" id="{0E6A32A1-2C92-471C-9D42-CB7C341ABFF4}"/>
               </a:ext>
             </a:extLst>
           </p:cNvPr>
@@ -13288,7 +13288,7 @@
           <p:nvPr/>
         </p:nvPicPr>
         <p:blipFill>
-          <a:blip xmlns:r="http://schemas.openxmlformats.org/officeDocument/2006/relationships" xmlns:a="http://schemas.openxmlformats.org/drawingml/2006/main" r:embed="R37ddfcd9e6b9412a"/>
+          <a:blip xmlns:r="http://schemas.openxmlformats.org/officeDocument/2006/relationships" xmlns:a="http://schemas.openxmlformats.org/drawingml/2006/main" r:embed="Re3937ad941d044e7"/>
           <a:stretch xmlns:a="http://schemas.openxmlformats.org/drawingml/2006/main"/>
         </p:blipFill>
         <p:spPr>
@@ -13306,7 +13306,7 @@
           <p:cNvPr id="7" name="">
             <a:extLst xmlns:a="http://schemas.openxmlformats.org/drawingml/2006/main">
               <a:ext uri="{FF2B5EF4-FFF2-40B4-BE49-F238E27FC236}">
-                <a16:creationId xmlns:a16="http://schemas.microsoft.com/office/drawing/2014/main" id="{024CD3D5-5D08-4B49-8BEE-89137A96DFA3}"/>
+                <a16:creationId xmlns:a16="http://schemas.microsoft.com/office/drawing/2014/main" id="{04D28431-2438-426A-92F7-0F700CDF79DF}"/>
               </a:ext>
             </a:extLst>
           </p:cNvPr>
@@ -13336,7 +13336,7 @@
           <p:cNvPr id="8" name="">
             <a:extLst xmlns:a="http://schemas.openxmlformats.org/drawingml/2006/main">
               <a:ext uri="{FF2B5EF4-FFF2-40B4-BE49-F238E27FC236}">
-                <a16:creationId xmlns:a16="http://schemas.microsoft.com/office/drawing/2014/main" id="{FAE6D244-A815-46BF-94B5-4567B6E94ADB}"/>
+                <a16:creationId xmlns:a16="http://schemas.microsoft.com/office/drawing/2014/main" id="{39B75ECA-7693-4F58-BD7E-11A4B999ECF4}"/>
               </a:ext>
             </a:extLst>
           </p:cNvPr>
@@ -13346,7 +13346,7 @@
           <p:nvPr/>
         </p:nvPicPr>
         <p:blipFill>
-          <a:blip xmlns:r="http://schemas.openxmlformats.org/officeDocument/2006/relationships" xmlns:a="http://schemas.openxmlformats.org/drawingml/2006/main" r:embed="Rfddc3dcf4dd841c0"/>
+          <a:blip xmlns:r="http://schemas.openxmlformats.org/officeDocument/2006/relationships" xmlns:a="http://schemas.openxmlformats.org/drawingml/2006/main" r:embed="R042f3bf2afcb4419"/>
           <a:stretch xmlns:a="http://schemas.openxmlformats.org/drawingml/2006/main"/>
         </p:blipFill>
         <p:spPr>
@@ -13364,7 +13364,7 @@
           <p:cNvPr id="9" name="">
             <a:extLst xmlns:a="http://schemas.openxmlformats.org/drawingml/2006/main">
               <a:ext uri="{FF2B5EF4-FFF2-40B4-BE49-F238E27FC236}">
-                <a16:creationId xmlns:a16="http://schemas.microsoft.com/office/drawing/2014/main" id="{8F162A46-2BB0-4606-8EB3-057CD12B13AD}"/>
+                <a16:creationId xmlns:a16="http://schemas.microsoft.com/office/drawing/2014/main" id="{780F9942-99D6-491C-86AB-F11540DEFE57}"/>
               </a:ext>
             </a:extLst>
           </p:cNvPr>
@@ -13394,7 +13394,7 @@
           <p:cNvPr id="10" name="">
             <a:extLst xmlns:a="http://schemas.openxmlformats.org/drawingml/2006/main">
               <a:ext uri="{FF2B5EF4-FFF2-40B4-BE49-F238E27FC236}">
-                <a16:creationId xmlns:a16="http://schemas.microsoft.com/office/drawing/2014/main" id="{DB7B5960-7C69-4E39-888B-1DA36C7778BA}"/>
+                <a16:creationId xmlns:a16="http://schemas.microsoft.com/office/drawing/2014/main" id="{CFEAF5E6-E989-4096-9CBA-2FDFC918056D}"/>
               </a:ext>
             </a:extLst>
           </p:cNvPr>
@@ -13462,7 +13462,7 @@
           <p:cNvPr id="11" name="">
             <a:extLst xmlns:a="http://schemas.openxmlformats.org/drawingml/2006/main">
               <a:ext uri="{FF2B5EF4-FFF2-40B4-BE49-F238E27FC236}">
-                <a16:creationId xmlns:a16="http://schemas.microsoft.com/office/drawing/2014/main" id="{B1EAF6BA-B90E-4782-8F31-5B975B4F9919}"/>
+                <a16:creationId xmlns:a16="http://schemas.microsoft.com/office/drawing/2014/main" id="{E6406D84-5D19-4C16-B8FF-B06B90CF9E2C}"/>
               </a:ext>
             </a:extLst>
           </p:cNvPr>
@@ -13530,7 +13530,7 @@
           <p:cNvPr id="12" name="">
             <a:extLst xmlns:a="http://schemas.openxmlformats.org/drawingml/2006/main">
               <a:ext uri="{FF2B5EF4-FFF2-40B4-BE49-F238E27FC236}">
-                <a16:creationId xmlns:a16="http://schemas.microsoft.com/office/drawing/2014/main" id="{D3CBDCD8-0251-4138-9EB4-EA0FDE4312C4}"/>
+                <a16:creationId xmlns:a16="http://schemas.microsoft.com/office/drawing/2014/main" id="{390BF263-B65B-4BD1-A55B-A3AC9987AA6C}"/>
               </a:ext>
             </a:extLst>
           </p:cNvPr>
@@ -13598,7 +13598,7 @@
           <p:cNvPr id="13" name="">
             <a:extLst xmlns:a="http://schemas.openxmlformats.org/drawingml/2006/main">
               <a:ext uri="{FF2B5EF4-FFF2-40B4-BE49-F238E27FC236}">
-                <a16:creationId xmlns:a16="http://schemas.microsoft.com/office/drawing/2014/main" id="{23B1E50C-A5C5-44C2-9429-F2D3701DF73D}"/>
+                <a16:creationId xmlns:a16="http://schemas.microsoft.com/office/drawing/2014/main" id="{D157583C-6149-419E-95AC-B6DC6AE160A7}"/>
               </a:ext>
             </a:extLst>
           </p:cNvPr>
@@ -13666,7 +13666,7 @@
           <p:cNvPr id="14" name="">
             <a:extLst xmlns:a="http://schemas.openxmlformats.org/drawingml/2006/main">
               <a:ext uri="{FF2B5EF4-FFF2-40B4-BE49-F238E27FC236}">
-                <a16:creationId xmlns:a16="http://schemas.microsoft.com/office/drawing/2014/main" id="{2CBCA6D7-5AF6-450B-9FCC-80783434F986}"/>
+                <a16:creationId xmlns:a16="http://schemas.microsoft.com/office/drawing/2014/main" id="{B934F7FA-1AB2-43F9-9E22-BA4CF0697F74}"/>
               </a:ext>
             </a:extLst>
           </p:cNvPr>
@@ -13734,7 +13734,7 @@
           <p:cNvPr id="15" name="">
             <a:extLst xmlns:a="http://schemas.openxmlformats.org/drawingml/2006/main">
               <a:ext uri="{FF2B5EF4-FFF2-40B4-BE49-F238E27FC236}">
-                <a16:creationId xmlns:a16="http://schemas.microsoft.com/office/drawing/2014/main" id="{F0E30C0F-18C7-408E-959D-F8EF58F1BB3B}"/>
+                <a16:creationId xmlns:a16="http://schemas.microsoft.com/office/drawing/2014/main" id="{B73B4F59-E527-4069-8377-36C9E4E76418}"/>
               </a:ext>
             </a:extLst>
           </p:cNvPr>
@@ -13802,7 +13802,7 @@
           <p:cNvPr id="16" name="">
             <a:extLst xmlns:a="http://schemas.openxmlformats.org/drawingml/2006/main">
               <a:ext uri="{FF2B5EF4-FFF2-40B4-BE49-F238E27FC236}">
-                <a16:creationId xmlns:a16="http://schemas.microsoft.com/office/drawing/2014/main" id="{13E5B1F0-D17A-495F-9894-3D2FDA5B33CA}"/>
+                <a16:creationId xmlns:a16="http://schemas.microsoft.com/office/drawing/2014/main" id="{59B8EE94-F676-4E62-B500-8708A797DE4A}"/>
               </a:ext>
             </a:extLst>
           </p:cNvPr>
@@ -13870,7 +13870,7 @@
           <p:cNvPr id="17" name="">
             <a:extLst xmlns:a="http://schemas.openxmlformats.org/drawingml/2006/main">
               <a:ext uri="{FF2B5EF4-FFF2-40B4-BE49-F238E27FC236}">
-                <a16:creationId xmlns:a16="http://schemas.microsoft.com/office/drawing/2014/main" id="{5F041495-FB6C-409E-A510-C9183F3CACA8}"/>
+                <a16:creationId xmlns:a16="http://schemas.microsoft.com/office/drawing/2014/main" id="{5530607F-E7B7-46A7-86DF-7D33A88A6331}"/>
               </a:ext>
             </a:extLst>
           </p:cNvPr>
@@ -13936,7 +13936,7 @@
     </p:spTree>
     <p:extLst>
       <p:ext uri="{BB962C8B-B14F-4D97-AF65-F5344CB8AC3E}">
-        <p14:creationId xmlns:p14="http://schemas.microsoft.com/office/powerpoint/2010/main" val="705770492"/>
+        <p14:creationId xmlns:p14="http://schemas.microsoft.com/office/powerpoint/2010/main" val="157078916"/>
       </p:ext>
     </p:extLst>
   </p:cSld>
@@ -13967,7 +13967,7 @@
           <p:cNvPr id="18" name="">
             <a:extLst xmlns:a="http://schemas.openxmlformats.org/drawingml/2006/main">
               <a:ext uri="{FF2B5EF4-FFF2-40B4-BE49-F238E27FC236}">
-                <a16:creationId xmlns:a16="http://schemas.microsoft.com/office/drawing/2014/main" id="{EC24EF0A-5C9E-4AD1-B587-9AEAEF720239}"/>
+                <a16:creationId xmlns:a16="http://schemas.microsoft.com/office/drawing/2014/main" id="{6B206E2C-4A50-4FE5-967B-47A7BF4442B9}"/>
               </a:ext>
             </a:extLst>
           </p:cNvPr>
@@ -14035,7 +14035,7 @@
           <p:cNvPr id="2" name="">
             <a:extLst xmlns:a="http://schemas.openxmlformats.org/drawingml/2006/main">
               <a:ext uri="{FF2B5EF4-FFF2-40B4-BE49-F238E27FC236}">
-                <a16:creationId xmlns:a16="http://schemas.microsoft.com/office/drawing/2014/main" id="{D23E2C0B-0CFB-4D01-879F-2E777D1B693E}"/>
+                <a16:creationId xmlns:a16="http://schemas.microsoft.com/office/drawing/2014/main" id="{FD3699D5-050B-4961-8458-605367A677D2}"/>
               </a:ext>
             </a:extLst>
           </p:cNvPr>
@@ -14103,7 +14103,7 @@
           <p:cNvPr id="3" name="">
             <a:extLst xmlns:a="http://schemas.openxmlformats.org/drawingml/2006/main">
               <a:ext uri="{FF2B5EF4-FFF2-40B4-BE49-F238E27FC236}">
-                <a16:creationId xmlns:a16="http://schemas.microsoft.com/office/drawing/2014/main" id="{DCFFB908-9A8A-431F-B454-035B1E950454}"/>
+                <a16:creationId xmlns:a16="http://schemas.microsoft.com/office/drawing/2014/main" id="{C6648854-7289-46BE-814C-C38397B51B74}"/>
               </a:ext>
             </a:extLst>
           </p:cNvPr>
@@ -14171,7 +14171,7 @@
           <p:cNvPr id="4" name="">
             <a:extLst xmlns:a="http://schemas.openxmlformats.org/drawingml/2006/main">
               <a:ext uri="{FF2B5EF4-FFF2-40B4-BE49-F238E27FC236}">
-                <a16:creationId xmlns:a16="http://schemas.microsoft.com/office/drawing/2014/main" id="{8ECC2B73-4035-44D1-A0F9-D83005138F67}"/>
+                <a16:creationId xmlns:a16="http://schemas.microsoft.com/office/drawing/2014/main" id="{739AA4DC-2F8E-496D-9241-C6F0D2310D53}"/>
               </a:ext>
             </a:extLst>
           </p:cNvPr>
@@ -14239,7 +14239,7 @@
           <p:cNvPr id="5" name="">
             <a:extLst xmlns:a="http://schemas.openxmlformats.org/drawingml/2006/main">
               <a:ext uri="{FF2B5EF4-FFF2-40B4-BE49-F238E27FC236}">
-                <a16:creationId xmlns:a16="http://schemas.microsoft.com/office/drawing/2014/main" id="{708C9DA5-AD8E-4E88-853A-F43EB46449DE}"/>
+                <a16:creationId xmlns:a16="http://schemas.microsoft.com/office/drawing/2014/main" id="{BE5F3801-0685-42FF-97C1-4336D5B164C8}"/>
               </a:ext>
             </a:extLst>
           </p:cNvPr>
@@ -14307,7 +14307,7 @@
           <p:cNvPr id="6" name="">
             <a:extLst xmlns:a="http://schemas.openxmlformats.org/drawingml/2006/main">
               <a:ext uri="{FF2B5EF4-FFF2-40B4-BE49-F238E27FC236}">
-                <a16:creationId xmlns:a16="http://schemas.microsoft.com/office/drawing/2014/main" id="{3C183104-2130-4AFE-AB16-CE62777F4619}"/>
+                <a16:creationId xmlns:a16="http://schemas.microsoft.com/office/drawing/2014/main" id="{D47E1F57-3FEF-4DB9-98D7-6E88F3BEA7B4}"/>
               </a:ext>
             </a:extLst>
           </p:cNvPr>
@@ -14375,7 +14375,7 @@
           <p:cNvPr id="7" name="">
             <a:extLst xmlns:a="http://schemas.openxmlformats.org/drawingml/2006/main">
               <a:ext uri="{FF2B5EF4-FFF2-40B4-BE49-F238E27FC236}">
-                <a16:creationId xmlns:a16="http://schemas.microsoft.com/office/drawing/2014/main" id="{1A4DABC3-4809-4735-8080-BFEEBC11719B}"/>
+                <a16:creationId xmlns:a16="http://schemas.microsoft.com/office/drawing/2014/main" id="{934527F0-9216-4246-B0E8-7DC98F3647AF}"/>
               </a:ext>
             </a:extLst>
           </p:cNvPr>
@@ -14443,7 +14443,7 @@
           <p:cNvPr id="8" name="">
             <a:extLst xmlns:a="http://schemas.openxmlformats.org/drawingml/2006/main">
               <a:ext uri="{FF2B5EF4-FFF2-40B4-BE49-F238E27FC236}">
-                <a16:creationId xmlns:a16="http://schemas.microsoft.com/office/drawing/2014/main" id="{1B8CD272-0B3C-4B88-92CE-E0DCCE0F557F}"/>
+                <a16:creationId xmlns:a16="http://schemas.microsoft.com/office/drawing/2014/main" id="{1FB135BE-D826-46DF-9347-3014B0CF067F}"/>
               </a:ext>
             </a:extLst>
           </p:cNvPr>
@@ -14511,7 +14511,7 @@
           <p:cNvPr id="9" name="">
             <a:extLst xmlns:a="http://schemas.openxmlformats.org/drawingml/2006/main">
               <a:ext uri="{FF2B5EF4-FFF2-40B4-BE49-F238E27FC236}">
-                <a16:creationId xmlns:a16="http://schemas.microsoft.com/office/drawing/2014/main" id="{1C30295A-DDBF-45D4-9D91-3B00DD9D8332}"/>
+                <a16:creationId xmlns:a16="http://schemas.microsoft.com/office/drawing/2014/main" id="{BBC28E79-129F-4587-90FB-8F930314E587}"/>
               </a:ext>
             </a:extLst>
           </p:cNvPr>
@@ -14579,7 +14579,7 @@
           <p:cNvPr id="10" name="">
             <a:extLst xmlns:a="http://schemas.openxmlformats.org/drawingml/2006/main">
               <a:ext uri="{FF2B5EF4-FFF2-40B4-BE49-F238E27FC236}">
-                <a16:creationId xmlns:a16="http://schemas.microsoft.com/office/drawing/2014/main" id="{9469DD04-0C2C-41B0-BEC9-6441638F13A7}"/>
+                <a16:creationId xmlns:a16="http://schemas.microsoft.com/office/drawing/2014/main" id="{BBD5764E-885C-426C-9F95-D4FE23964F92}"/>
               </a:ext>
             </a:extLst>
           </p:cNvPr>
@@ -14647,7 +14647,7 @@
           <p:cNvPr id="11" name="">
             <a:extLst xmlns:a="http://schemas.openxmlformats.org/drawingml/2006/main">
               <a:ext uri="{FF2B5EF4-FFF2-40B4-BE49-F238E27FC236}">
-                <a16:creationId xmlns:a16="http://schemas.microsoft.com/office/drawing/2014/main" id="{182D384B-F136-46D6-9ECE-A3C6624579E7}"/>
+                <a16:creationId xmlns:a16="http://schemas.microsoft.com/office/drawing/2014/main" id="{98327EA2-FF27-4B14-919F-7817B67CC45E}"/>
               </a:ext>
             </a:extLst>
           </p:cNvPr>
@@ -14715,7 +14715,7 @@
           <p:cNvPr id="12" name="">
             <a:extLst xmlns:a="http://schemas.openxmlformats.org/drawingml/2006/main">
               <a:ext uri="{FF2B5EF4-FFF2-40B4-BE49-F238E27FC236}">
-                <a16:creationId xmlns:a16="http://schemas.microsoft.com/office/drawing/2014/main" id="{42E94D85-50B2-40DB-A0CA-28E3BFCFD3AC}"/>
+                <a16:creationId xmlns:a16="http://schemas.microsoft.com/office/drawing/2014/main" id="{3DF4BDE5-E2A0-4668-8B98-C3851A31718E}"/>
               </a:ext>
             </a:extLst>
           </p:cNvPr>
@@ -14783,7 +14783,7 @@
           <p:cNvPr id="13" name="">
             <a:extLst xmlns:a="http://schemas.openxmlformats.org/drawingml/2006/main">
               <a:ext uri="{FF2B5EF4-FFF2-40B4-BE49-F238E27FC236}">
-                <a16:creationId xmlns:a16="http://schemas.microsoft.com/office/drawing/2014/main" id="{D8E37DC4-4309-4CE8-A58F-CAF4D41D2C0A}"/>
+                <a16:creationId xmlns:a16="http://schemas.microsoft.com/office/drawing/2014/main" id="{A1C558E3-F6D9-49E8-B058-9B2F04B926A7}"/>
               </a:ext>
             </a:extLst>
           </p:cNvPr>
@@ -14851,7 +14851,7 @@
           <p:cNvPr id="14" name="">
             <a:extLst xmlns:a="http://schemas.openxmlformats.org/drawingml/2006/main">
               <a:ext uri="{FF2B5EF4-FFF2-40B4-BE49-F238E27FC236}">
-                <a16:creationId xmlns:a16="http://schemas.microsoft.com/office/drawing/2014/main" id="{A6EDE9F8-4449-46B2-8728-21B394C9F498}"/>
+                <a16:creationId xmlns:a16="http://schemas.microsoft.com/office/drawing/2014/main" id="{D40E6650-2CA3-436C-AAF6-29A57E8EEEAF}"/>
               </a:ext>
             </a:extLst>
           </p:cNvPr>
@@ -14919,7 +14919,7 @@
           <p:cNvPr id="15" name="">
             <a:extLst xmlns:a="http://schemas.openxmlformats.org/drawingml/2006/main">
               <a:ext uri="{FF2B5EF4-FFF2-40B4-BE49-F238E27FC236}">
-                <a16:creationId xmlns:a16="http://schemas.microsoft.com/office/drawing/2014/main" id="{11634886-7E15-41AB-A97F-B1B31EB88BF0}"/>
+                <a16:creationId xmlns:a16="http://schemas.microsoft.com/office/drawing/2014/main" id="{DE871831-DA3A-4476-94C7-DA4F420C7038}"/>
               </a:ext>
             </a:extLst>
           </p:cNvPr>
@@ -14987,7 +14987,7 @@
           <p:cNvPr id="16" name="">
             <a:extLst xmlns:a="http://schemas.openxmlformats.org/drawingml/2006/main">
               <a:ext uri="{FF2B5EF4-FFF2-40B4-BE49-F238E27FC236}">
-                <a16:creationId xmlns:a16="http://schemas.microsoft.com/office/drawing/2014/main" id="{C7372B44-896E-48C6-B28F-9CB49EB379FB}"/>
+                <a16:creationId xmlns:a16="http://schemas.microsoft.com/office/drawing/2014/main" id="{53CCFBE3-93CE-4241-8F48-13EB8F3F87FB}"/>
               </a:ext>
             </a:extLst>
           </p:cNvPr>
@@ -15055,7 +15055,7 @@
           <p:cNvPr id="17" name="">
             <a:extLst xmlns:a="http://schemas.openxmlformats.org/drawingml/2006/main">
               <a:ext uri="{FF2B5EF4-FFF2-40B4-BE49-F238E27FC236}">
-                <a16:creationId xmlns:a16="http://schemas.microsoft.com/office/drawing/2014/main" id="{665D4EBB-81C4-4983-BE18-46F4F1707F1E}"/>
+                <a16:creationId xmlns:a16="http://schemas.microsoft.com/office/drawing/2014/main" id="{FB9E4302-A463-42B9-AAE5-7EA160005E05}"/>
               </a:ext>
             </a:extLst>
           </p:cNvPr>
@@ -15121,7 +15121,7 @@
     </p:spTree>
     <p:extLst>
       <p:ext uri="{BB962C8B-B14F-4D97-AF65-F5344CB8AC3E}">
-        <p14:creationId xmlns:p14="http://schemas.microsoft.com/office/powerpoint/2010/main" val="2116570834"/>
+        <p14:creationId xmlns:p14="http://schemas.microsoft.com/office/powerpoint/2010/main" val="545376031"/>
       </p:ext>
     </p:extLst>
   </p:cSld>
@@ -15149,10 +15149,10 @@
       </p:grpSpPr>
       <p:sp>
         <p:nvSpPr>
-          <p:cNvPr id="16" name="">
-            <a:extLst xmlns:a="http://schemas.openxmlformats.org/drawingml/2006/main">
-              <a:ext uri="{FF2B5EF4-FFF2-40B4-BE49-F238E27FC236}">
-                <a16:creationId xmlns:a16="http://schemas.microsoft.com/office/drawing/2014/main" id="{E4867B40-5E06-487A-8F0B-95C70D8E243B}"/>
+          <p:cNvPr id="21" name="">
+            <a:extLst xmlns:a="http://schemas.openxmlformats.org/drawingml/2006/main">
+              <a:ext uri="{FF2B5EF4-FFF2-40B4-BE49-F238E27FC236}">
+                <a16:creationId xmlns:a16="http://schemas.microsoft.com/office/drawing/2014/main" id="{373F5B70-B20A-41B5-B6EC-9B655C4F689E}"/>
               </a:ext>
             </a:extLst>
           </p:cNvPr>
@@ -15220,7 +15220,7 @@
           <p:cNvPr id="2" name="">
             <a:extLst xmlns:a="http://schemas.openxmlformats.org/drawingml/2006/main">
               <a:ext uri="{FF2B5EF4-FFF2-40B4-BE49-F238E27FC236}">
-                <a16:creationId xmlns:a16="http://schemas.microsoft.com/office/drawing/2014/main" id="{3D91D663-C1EB-4887-B659-01C3A87364E2}"/>
+                <a16:creationId xmlns:a16="http://schemas.microsoft.com/office/drawing/2014/main" id="{B171696D-6E38-4137-B706-37ADB71690C7}"/>
               </a:ext>
             </a:extLst>
           </p:cNvPr>
@@ -15288,7 +15288,7 @@
           <p:cNvPr id="3" name="">
             <a:extLst xmlns:a="http://schemas.openxmlformats.org/drawingml/2006/main">
               <a:ext uri="{FF2B5EF4-FFF2-40B4-BE49-F238E27FC236}">
-                <a16:creationId xmlns:a16="http://schemas.microsoft.com/office/drawing/2014/main" id="{C0948B10-87F5-4D63-B71E-94F0DF515F5A}"/>
+                <a16:creationId xmlns:a16="http://schemas.microsoft.com/office/drawing/2014/main" id="{715384B6-505B-47A6-A2C2-A8616EA698F9}"/>
               </a:ext>
             </a:extLst>
           </p:cNvPr>
@@ -15356,19 +15356,87 @@
           <p:cNvPr id="4" name="">
             <a:extLst xmlns:a="http://schemas.openxmlformats.org/drawingml/2006/main">
               <a:ext uri="{FF2B5EF4-FFF2-40B4-BE49-F238E27FC236}">
-                <a16:creationId xmlns:a16="http://schemas.microsoft.com/office/drawing/2014/main" id="{70EB8B92-33E6-4802-88BC-BE709A42D363}"/>
-              </a:ext>
-            </a:extLst>
-          </p:cNvPr>
-          <p:cNvSpPr>
-            <a:spLocks xmlns:a="http://schemas.openxmlformats.org/drawingml/2006/main" noGrp="1"/>
-          </p:cNvSpPr>
-          <p:nvPr/>
-        </p:nvSpPr>
-        <p:spPr>
-          <a:xfrm xmlns:a="http://schemas.openxmlformats.org/drawingml/2006/main">
-            <a:off x="723900" y="2857500"/>
-            <a:ext cx="1889760" cy="1047750"/>
+                <a16:creationId xmlns:a16="http://schemas.microsoft.com/office/drawing/2014/main" id="{174D20C6-BB6D-4A74-B5AA-A370D3AB29ED}"/>
+              </a:ext>
+            </a:extLst>
+          </p:cNvPr>
+          <p:cNvSpPr>
+            <a:spLocks xmlns:a="http://schemas.openxmlformats.org/drawingml/2006/main" noGrp="1"/>
+          </p:cNvSpPr>
+          <p:nvPr/>
+        </p:nvSpPr>
+        <p:spPr>
+          <a:xfrm xmlns:a="http://schemas.openxmlformats.org/drawingml/2006/main">
+            <a:off x="723900" y="2667000"/>
+            <a:ext cx="1889760" cy="952500"/>
+          </a:xfrm>
+          <a:prstGeom xmlns:a="http://schemas.openxmlformats.org/drawingml/2006/main" prst="rect">
+            <a:avLst/>
+          </a:prstGeom>
+          <a:noFill xmlns:a="http://schemas.openxmlformats.org/drawingml/2006/main"/>
+          <a:ln xmlns:a="http://schemas.openxmlformats.org/drawingml/2006/main" w="0">
+            <a:noFill/>
+          </a:ln>
+        </p:spPr>
+        <p:txBody>
+          <a:bodyPr xmlns:a="http://schemas.openxmlformats.org/drawingml/2006/main" wrap="square" lIns="0" tIns="0" rIns="0" bIns="0" anchor="t">
+            <a:noAutofit/>
+          </a:bodyPr>
+          <a:lstStyle xmlns:a="http://schemas.openxmlformats.org/drawingml/2006/main">
+            <a:defPPr algn="l">
+              <a:defRPr sz="5850" b="1">
+                <a:solidFill>
+                  <a:srgbClr val="B48E5B"/>
+                </a:solidFill>
+                <a:latin typeface="Apple SD Gothic Neo"/>
+                <a:ea typeface="Apple SD Gothic Neo"/>
+                <a:cs typeface="Apple SD Gothic Neo"/>
+              </a:defRPr>
+            </a:defPPr>
+          </a:lstStyle>
+          <a:p xmlns:a="http://schemas.openxmlformats.org/drawingml/2006/main">
+            <a:pPr algn="l">
+              <a:defRPr sz="5850" b="1">
+                <a:solidFill>
+                  <a:srgbClr val="B48E5B"/>
+                </a:solidFill>
+                <a:latin typeface="Apple SD Gothic Neo"/>
+                <a:ea typeface="Apple SD Gothic Neo"/>
+                <a:cs typeface="Apple SD Gothic Neo"/>
+              </a:defRPr>
+            </a:pPr>
+            <a:r>
+              <a:rPr sz="5850" b="1">
+                <a:solidFill>
+                  <a:srgbClr val="B48E5B"/>
+                </a:solidFill>
+                <a:latin typeface="Apple SD Gothic Neo"/>
+                <a:ea typeface="Apple SD Gothic Neo"/>
+                <a:cs typeface="Apple SD Gothic Neo"/>
+              </a:rPr>
+              <a:t>R</a:t>
+            </a:r>
+          </a:p>
+        </p:txBody>
+      </p:sp>
+      <p:sp>
+        <p:nvSpPr>
+          <p:cNvPr id="5" name="">
+            <a:extLst xmlns:a="http://schemas.openxmlformats.org/drawingml/2006/main">
+              <a:ext uri="{FF2B5EF4-FFF2-40B4-BE49-F238E27FC236}">
+                <a16:creationId xmlns:a16="http://schemas.microsoft.com/office/drawing/2014/main" id="{4DE2CC03-63E0-4C1B-B997-310B9A04C083}"/>
+              </a:ext>
+            </a:extLst>
+          </p:cNvPr>
+          <p:cNvSpPr>
+            <a:spLocks xmlns:a="http://schemas.openxmlformats.org/drawingml/2006/main" noGrp="1"/>
+          </p:cNvSpPr>
+          <p:nvPr/>
+        </p:nvSpPr>
+        <p:spPr>
+          <a:xfrm xmlns:a="http://schemas.openxmlformats.org/drawingml/2006/main">
+            <a:off x="723900" y="3724275"/>
+            <a:ext cx="1889760" cy="438150"/>
           </a:xfrm>
           <a:prstGeom xmlns:a="http://schemas.openxmlformats.org/drawingml/2006/main" prst="rect">
             <a:avLst/>
@@ -15421,22 +15489,906 @@
       </p:sp>
       <p:sp>
         <p:nvSpPr>
-          <p:cNvPr id="5" name="">
-            <a:extLst xmlns:a="http://schemas.openxmlformats.org/drawingml/2006/main">
-              <a:ext uri="{FF2B5EF4-FFF2-40B4-BE49-F238E27FC236}">
-                <a16:creationId xmlns:a16="http://schemas.microsoft.com/office/drawing/2014/main" id="{1F1C3852-86E0-4BDD-8341-07BEAD8B8377}"/>
-              </a:ext>
-            </a:extLst>
-          </p:cNvPr>
-          <p:cNvSpPr>
-            <a:spLocks xmlns:a="http://schemas.openxmlformats.org/drawingml/2006/main" noGrp="1"/>
-          </p:cNvSpPr>
-          <p:nvPr/>
-        </p:nvSpPr>
-        <p:spPr>
-          <a:xfrm xmlns:a="http://schemas.openxmlformats.org/drawingml/2006/main">
-            <a:off x="723900" y="3905250"/>
-            <a:ext cx="1889760" cy="2000250"/>
+          <p:cNvPr id="6" name="">
+            <a:extLst xmlns:a="http://schemas.openxmlformats.org/drawingml/2006/main">
+              <a:ext uri="{FF2B5EF4-FFF2-40B4-BE49-F238E27FC236}">
+                <a16:creationId xmlns:a16="http://schemas.microsoft.com/office/drawing/2014/main" id="{E525B044-CE25-4B22-BB0F-D44749A86862}"/>
+              </a:ext>
+            </a:extLst>
+          </p:cNvPr>
+          <p:cNvSpPr>
+            <a:spLocks xmlns:a="http://schemas.openxmlformats.org/drawingml/2006/main" noGrp="1"/>
+          </p:cNvSpPr>
+          <p:nvPr/>
+        </p:nvSpPr>
+        <p:spPr>
+          <a:xfrm xmlns:a="http://schemas.openxmlformats.org/drawingml/2006/main">
+            <a:off x="723900" y="4362450"/>
+            <a:ext cx="1889760" cy="762000"/>
+          </a:xfrm>
+          <a:prstGeom xmlns:a="http://schemas.openxmlformats.org/drawingml/2006/main" prst="rect">
+            <a:avLst/>
+          </a:prstGeom>
+          <a:noFill xmlns:a="http://schemas.openxmlformats.org/drawingml/2006/main"/>
+          <a:ln xmlns:a="http://schemas.openxmlformats.org/drawingml/2006/main" w="0">
+            <a:noFill/>
+          </a:ln>
+        </p:spPr>
+        <p:txBody>
+          <a:bodyPr xmlns:a="http://schemas.openxmlformats.org/drawingml/2006/main" wrap="square" lIns="0" tIns="0" rIns="0" bIns="0" anchor="t">
+            <a:noAutofit/>
+          </a:bodyPr>
+          <a:lstStyle xmlns:a="http://schemas.openxmlformats.org/drawingml/2006/main">
+            <a:defPPr algn="l">
+              <a:defRPr sz="1950" b="0">
+                <a:solidFill>
+                  <a:srgbClr val="AFB6BC"/>
+                </a:solidFill>
+                <a:latin typeface="Apple SD Gothic Neo"/>
+                <a:ea typeface="Apple SD Gothic Neo"/>
+                <a:cs typeface="Apple SD Gothic Neo"/>
+              </a:defRPr>
+            </a:defPPr>
+          </a:lstStyle>
+          <a:p xmlns:a="http://schemas.openxmlformats.org/drawingml/2006/main">
+            <a:pPr algn="l">
+              <a:defRPr sz="1950" b="0">
+                <a:solidFill>
+                  <a:srgbClr val="AFB6BC"/>
+                </a:solidFill>
+                <a:latin typeface="Apple SD Gothic Neo"/>
+                <a:ea typeface="Apple SD Gothic Neo"/>
+                <a:cs typeface="Apple SD Gothic Neo"/>
+              </a:defRPr>
+            </a:pPr>
+            <a:r>
+              <a:rPr sz="1950" b="0">
+                <a:solidFill>
+                  <a:srgbClr val="AFB6BC"/>
+                </a:solidFill>
+                <a:latin typeface="Apple SD Gothic Neo"/>
+                <a:ea typeface="Apple SD Gothic Neo"/>
+                <a:cs typeface="Apple SD Gothic Neo"/>
+              </a:rPr>
+              <a:t>관계형성</a:t>
+            </a:r>
+          </a:p>
+        </p:txBody>
+      </p:sp>
+      <p:sp>
+        <p:nvSpPr>
+          <p:cNvPr id="7" name="">
+            <a:extLst xmlns:a="http://schemas.openxmlformats.org/drawingml/2006/main">
+              <a:ext uri="{FF2B5EF4-FFF2-40B4-BE49-F238E27FC236}">
+                <a16:creationId xmlns:a16="http://schemas.microsoft.com/office/drawing/2014/main" id="{026965BB-75C4-4FCC-89D0-182564A03028}"/>
+              </a:ext>
+            </a:extLst>
+          </p:cNvPr>
+          <p:cNvSpPr>
+            <a:spLocks xmlns:a="http://schemas.openxmlformats.org/drawingml/2006/main" noGrp="1"/>
+          </p:cNvSpPr>
+          <p:nvPr/>
+        </p:nvSpPr>
+        <p:spPr>
+          <a:xfrm xmlns:a="http://schemas.openxmlformats.org/drawingml/2006/main">
+            <a:off x="2937510" y="2667000"/>
+            <a:ext cx="1889760" cy="952500"/>
+          </a:xfrm>
+          <a:prstGeom xmlns:a="http://schemas.openxmlformats.org/drawingml/2006/main" prst="rect">
+            <a:avLst/>
+          </a:prstGeom>
+          <a:noFill xmlns:a="http://schemas.openxmlformats.org/drawingml/2006/main"/>
+          <a:ln xmlns:a="http://schemas.openxmlformats.org/drawingml/2006/main" w="0">
+            <a:noFill/>
+          </a:ln>
+        </p:spPr>
+        <p:txBody>
+          <a:bodyPr xmlns:a="http://schemas.openxmlformats.org/drawingml/2006/main" wrap="square" lIns="0" tIns="0" rIns="0" bIns="0" anchor="t">
+            <a:noAutofit/>
+          </a:bodyPr>
+          <a:lstStyle xmlns:a="http://schemas.openxmlformats.org/drawingml/2006/main">
+            <a:defPPr algn="l">
+              <a:defRPr sz="5850" b="1">
+                <a:solidFill>
+                  <a:srgbClr val="B48E5B"/>
+                </a:solidFill>
+                <a:latin typeface="Apple SD Gothic Neo"/>
+                <a:ea typeface="Apple SD Gothic Neo"/>
+                <a:cs typeface="Apple SD Gothic Neo"/>
+              </a:defRPr>
+            </a:defPPr>
+          </a:lstStyle>
+          <a:p xmlns:a="http://schemas.openxmlformats.org/drawingml/2006/main">
+            <a:pPr algn="l">
+              <a:defRPr sz="5850" b="1">
+                <a:solidFill>
+                  <a:srgbClr val="B48E5B"/>
+                </a:solidFill>
+                <a:latin typeface="Apple SD Gothic Neo"/>
+                <a:ea typeface="Apple SD Gothic Neo"/>
+                <a:cs typeface="Apple SD Gothic Neo"/>
+              </a:defRPr>
+            </a:pPr>
+            <a:r>
+              <a:rPr sz="5850" b="1">
+                <a:solidFill>
+                  <a:srgbClr val="B48E5B"/>
+                </a:solidFill>
+                <a:latin typeface="Apple SD Gothic Neo"/>
+                <a:ea typeface="Apple SD Gothic Neo"/>
+                <a:cs typeface="Apple SD Gothic Neo"/>
+              </a:rPr>
+              <a:t>R</a:t>
+            </a:r>
+          </a:p>
+        </p:txBody>
+      </p:sp>
+      <p:sp>
+        <p:nvSpPr>
+          <p:cNvPr id="8" name="">
+            <a:extLst xmlns:a="http://schemas.openxmlformats.org/drawingml/2006/main">
+              <a:ext uri="{FF2B5EF4-FFF2-40B4-BE49-F238E27FC236}">
+                <a16:creationId xmlns:a16="http://schemas.microsoft.com/office/drawing/2014/main" id="{67EB21D3-9AE1-4AEC-BCFB-ADB2BE9A4B66}"/>
+              </a:ext>
+            </a:extLst>
+          </p:cNvPr>
+          <p:cNvSpPr>
+            <a:spLocks xmlns:a="http://schemas.openxmlformats.org/drawingml/2006/main" noGrp="1"/>
+          </p:cNvSpPr>
+          <p:nvPr/>
+        </p:nvSpPr>
+        <p:spPr>
+          <a:xfrm xmlns:a="http://schemas.openxmlformats.org/drawingml/2006/main">
+            <a:off x="2937510" y="3724275"/>
+            <a:ext cx="1889760" cy="438150"/>
+          </a:xfrm>
+          <a:prstGeom xmlns:a="http://schemas.openxmlformats.org/drawingml/2006/main" prst="rect">
+            <a:avLst/>
+          </a:prstGeom>
+          <a:noFill xmlns:a="http://schemas.openxmlformats.org/drawingml/2006/main"/>
+          <a:ln xmlns:a="http://schemas.openxmlformats.org/drawingml/2006/main" w="0">
+            <a:noFill/>
+          </a:ln>
+        </p:spPr>
+        <p:txBody>
+          <a:bodyPr xmlns:a="http://schemas.openxmlformats.org/drawingml/2006/main" wrap="square" lIns="0" tIns="0" rIns="0" bIns="0" anchor="t">
+            <a:noAutofit/>
+          </a:bodyPr>
+          <a:lstStyle xmlns:a="http://schemas.openxmlformats.org/drawingml/2006/main">
+            <a:defPPr algn="l">
+              <a:defRPr sz="1650" b="1">
+                <a:solidFill>
+                  <a:srgbClr val="EFBB73"/>
+                </a:solidFill>
+                <a:latin typeface="Apple SD Gothic Neo"/>
+                <a:ea typeface="Apple SD Gothic Neo"/>
+                <a:cs typeface="Apple SD Gothic Neo"/>
+              </a:defRPr>
+            </a:defPPr>
+          </a:lstStyle>
+          <a:p xmlns:a="http://schemas.openxmlformats.org/drawingml/2006/main">
+            <a:pPr algn="l">
+              <a:defRPr sz="1650" b="1">
+                <a:solidFill>
+                  <a:srgbClr val="EFBB73"/>
+                </a:solidFill>
+                <a:latin typeface="Apple SD Gothic Neo"/>
+                <a:ea typeface="Apple SD Gothic Neo"/>
+                <a:cs typeface="Apple SD Gothic Neo"/>
+              </a:defRPr>
+            </a:pPr>
+            <a:r>
+              <a:rPr sz="1650" b="1">
+                <a:solidFill>
+                  <a:srgbClr val="EFBB73"/>
+                </a:solidFill>
+                <a:latin typeface="Apple SD Gothic Neo"/>
+                <a:ea typeface="Apple SD Gothic Neo"/>
+                <a:cs typeface="Apple SD Gothic Neo"/>
+              </a:rPr>
+              <a:t>Refocus</a:t>
+            </a:r>
+          </a:p>
+        </p:txBody>
+      </p:sp>
+      <p:sp>
+        <p:nvSpPr>
+          <p:cNvPr id="9" name="">
+            <a:extLst xmlns:a="http://schemas.openxmlformats.org/drawingml/2006/main">
+              <a:ext uri="{FF2B5EF4-FFF2-40B4-BE49-F238E27FC236}">
+                <a16:creationId xmlns:a16="http://schemas.microsoft.com/office/drawing/2014/main" id="{F7FD648A-2101-46EB-8DC3-0C4B6E87F501}"/>
+              </a:ext>
+            </a:extLst>
+          </p:cNvPr>
+          <p:cNvSpPr>
+            <a:spLocks xmlns:a="http://schemas.openxmlformats.org/drawingml/2006/main" noGrp="1"/>
+          </p:cNvSpPr>
+          <p:nvPr/>
+        </p:nvSpPr>
+        <p:spPr>
+          <a:xfrm xmlns:a="http://schemas.openxmlformats.org/drawingml/2006/main">
+            <a:off x="2937510" y="4362450"/>
+            <a:ext cx="1889760" cy="762000"/>
+          </a:xfrm>
+          <a:prstGeom xmlns:a="http://schemas.openxmlformats.org/drawingml/2006/main" prst="rect">
+            <a:avLst/>
+          </a:prstGeom>
+          <a:noFill xmlns:a="http://schemas.openxmlformats.org/drawingml/2006/main"/>
+          <a:ln xmlns:a="http://schemas.openxmlformats.org/drawingml/2006/main" w="0">
+            <a:noFill/>
+          </a:ln>
+        </p:spPr>
+        <p:txBody>
+          <a:bodyPr xmlns:a="http://schemas.openxmlformats.org/drawingml/2006/main" wrap="square" lIns="0" tIns="0" rIns="0" bIns="0" anchor="t">
+            <a:noAutofit/>
+          </a:bodyPr>
+          <a:lstStyle xmlns:a="http://schemas.openxmlformats.org/drawingml/2006/main">
+            <a:defPPr algn="l">
+              <a:defRPr sz="1950" b="0">
+                <a:solidFill>
+                  <a:srgbClr val="AFB6BC"/>
+                </a:solidFill>
+                <a:latin typeface="Apple SD Gothic Neo"/>
+                <a:ea typeface="Apple SD Gothic Neo"/>
+                <a:cs typeface="Apple SD Gothic Neo"/>
+              </a:defRPr>
+            </a:defPPr>
+          </a:lstStyle>
+          <a:p xmlns:a="http://schemas.openxmlformats.org/drawingml/2006/main">
+            <a:pPr algn="l">
+              <a:defRPr sz="1950" b="0">
+                <a:solidFill>
+                  <a:srgbClr val="AFB6BC"/>
+                </a:solidFill>
+                <a:latin typeface="Apple SD Gothic Neo"/>
+                <a:ea typeface="Apple SD Gothic Neo"/>
+                <a:cs typeface="Apple SD Gothic Neo"/>
+              </a:defRPr>
+            </a:pPr>
+            <a:r>
+              <a:rPr sz="1950" b="0">
+                <a:solidFill>
+                  <a:srgbClr val="AFB6BC"/>
+                </a:solidFill>
+                <a:latin typeface="Apple SD Gothic Neo"/>
+                <a:ea typeface="Apple SD Gothic Neo"/>
+                <a:cs typeface="Apple SD Gothic Neo"/>
+              </a:rPr>
+              <a:t>목표설정</a:t>
+            </a:r>
+          </a:p>
+        </p:txBody>
+      </p:sp>
+      <p:sp>
+        <p:nvSpPr>
+          <p:cNvPr id="10" name="">
+            <a:extLst xmlns:a="http://schemas.openxmlformats.org/drawingml/2006/main">
+              <a:ext uri="{FF2B5EF4-FFF2-40B4-BE49-F238E27FC236}">
+                <a16:creationId xmlns:a16="http://schemas.microsoft.com/office/drawing/2014/main" id="{083108A1-00F6-4B08-871C-B15E2E6C577E}"/>
+              </a:ext>
+            </a:extLst>
+          </p:cNvPr>
+          <p:cNvSpPr>
+            <a:spLocks xmlns:a="http://schemas.openxmlformats.org/drawingml/2006/main" noGrp="1"/>
+          </p:cNvSpPr>
+          <p:nvPr/>
+        </p:nvSpPr>
+        <p:spPr>
+          <a:xfrm xmlns:a="http://schemas.openxmlformats.org/drawingml/2006/main">
+            <a:off x="5151120" y="2667000"/>
+            <a:ext cx="1889760" cy="952500"/>
+          </a:xfrm>
+          <a:prstGeom xmlns:a="http://schemas.openxmlformats.org/drawingml/2006/main" prst="rect">
+            <a:avLst/>
+          </a:prstGeom>
+          <a:noFill xmlns:a="http://schemas.openxmlformats.org/drawingml/2006/main"/>
+          <a:ln xmlns:a="http://schemas.openxmlformats.org/drawingml/2006/main" w="0">
+            <a:noFill/>
+          </a:ln>
+        </p:spPr>
+        <p:txBody>
+          <a:bodyPr xmlns:a="http://schemas.openxmlformats.org/drawingml/2006/main" wrap="square" lIns="0" tIns="0" rIns="0" bIns="0" anchor="t">
+            <a:noAutofit/>
+          </a:bodyPr>
+          <a:lstStyle xmlns:a="http://schemas.openxmlformats.org/drawingml/2006/main">
+            <a:defPPr algn="l">
+              <a:defRPr sz="5850" b="1">
+                <a:solidFill>
+                  <a:srgbClr val="B48E5B"/>
+                </a:solidFill>
+                <a:latin typeface="Apple SD Gothic Neo"/>
+                <a:ea typeface="Apple SD Gothic Neo"/>
+                <a:cs typeface="Apple SD Gothic Neo"/>
+              </a:defRPr>
+            </a:defPPr>
+          </a:lstStyle>
+          <a:p xmlns:a="http://schemas.openxmlformats.org/drawingml/2006/main">
+            <a:pPr algn="l">
+              <a:defRPr sz="5850" b="1">
+                <a:solidFill>
+                  <a:srgbClr val="B48E5B"/>
+                </a:solidFill>
+                <a:latin typeface="Apple SD Gothic Neo"/>
+                <a:ea typeface="Apple SD Gothic Neo"/>
+                <a:cs typeface="Apple SD Gothic Neo"/>
+              </a:defRPr>
+            </a:pPr>
+            <a:r>
+              <a:rPr sz="5850" b="1">
+                <a:solidFill>
+                  <a:srgbClr val="B48E5B"/>
+                </a:solidFill>
+                <a:latin typeface="Apple SD Gothic Neo"/>
+                <a:ea typeface="Apple SD Gothic Neo"/>
+                <a:cs typeface="Apple SD Gothic Neo"/>
+              </a:rPr>
+              <a:t>R</a:t>
+            </a:r>
+          </a:p>
+        </p:txBody>
+      </p:sp>
+      <p:sp>
+        <p:nvSpPr>
+          <p:cNvPr id="11" name="">
+            <a:extLst xmlns:a="http://schemas.openxmlformats.org/drawingml/2006/main">
+              <a:ext uri="{FF2B5EF4-FFF2-40B4-BE49-F238E27FC236}">
+                <a16:creationId xmlns:a16="http://schemas.microsoft.com/office/drawing/2014/main" id="{F1284263-522A-4AC2-8064-91D99CCA1F60}"/>
+              </a:ext>
+            </a:extLst>
+          </p:cNvPr>
+          <p:cNvSpPr>
+            <a:spLocks xmlns:a="http://schemas.openxmlformats.org/drawingml/2006/main" noGrp="1"/>
+          </p:cNvSpPr>
+          <p:nvPr/>
+        </p:nvSpPr>
+        <p:spPr>
+          <a:xfrm xmlns:a="http://schemas.openxmlformats.org/drawingml/2006/main">
+            <a:off x="5151120" y="3724275"/>
+            <a:ext cx="1889760" cy="438150"/>
+          </a:xfrm>
+          <a:prstGeom xmlns:a="http://schemas.openxmlformats.org/drawingml/2006/main" prst="rect">
+            <a:avLst/>
+          </a:prstGeom>
+          <a:noFill xmlns:a="http://schemas.openxmlformats.org/drawingml/2006/main"/>
+          <a:ln xmlns:a="http://schemas.openxmlformats.org/drawingml/2006/main" w="0">
+            <a:noFill/>
+          </a:ln>
+        </p:spPr>
+        <p:txBody>
+          <a:bodyPr xmlns:a="http://schemas.openxmlformats.org/drawingml/2006/main" wrap="square" lIns="0" tIns="0" rIns="0" bIns="0" anchor="t">
+            <a:noAutofit/>
+          </a:bodyPr>
+          <a:lstStyle xmlns:a="http://schemas.openxmlformats.org/drawingml/2006/main">
+            <a:defPPr algn="l">
+              <a:defRPr sz="1650" b="1">
+                <a:solidFill>
+                  <a:srgbClr val="EFBB73"/>
+                </a:solidFill>
+                <a:latin typeface="Apple SD Gothic Neo"/>
+                <a:ea typeface="Apple SD Gothic Neo"/>
+                <a:cs typeface="Apple SD Gothic Neo"/>
+              </a:defRPr>
+            </a:defPPr>
+          </a:lstStyle>
+          <a:p xmlns:a="http://schemas.openxmlformats.org/drawingml/2006/main">
+            <a:pPr algn="l">
+              <a:defRPr sz="1650" b="1">
+                <a:solidFill>
+                  <a:srgbClr val="EFBB73"/>
+                </a:solidFill>
+                <a:latin typeface="Apple SD Gothic Neo"/>
+                <a:ea typeface="Apple SD Gothic Neo"/>
+                <a:cs typeface="Apple SD Gothic Neo"/>
+              </a:defRPr>
+            </a:pPr>
+            <a:r>
+              <a:rPr sz="1650" b="1">
+                <a:solidFill>
+                  <a:srgbClr val="EFBB73"/>
+                </a:solidFill>
+                <a:latin typeface="Apple SD Gothic Neo"/>
+                <a:ea typeface="Apple SD Gothic Neo"/>
+                <a:cs typeface="Apple SD Gothic Neo"/>
+              </a:rPr>
+              <a:t>Reality</a:t>
+            </a:r>
+          </a:p>
+        </p:txBody>
+      </p:sp>
+      <p:sp>
+        <p:nvSpPr>
+          <p:cNvPr id="12" name="">
+            <a:extLst xmlns:a="http://schemas.openxmlformats.org/drawingml/2006/main">
+              <a:ext uri="{FF2B5EF4-FFF2-40B4-BE49-F238E27FC236}">
+                <a16:creationId xmlns:a16="http://schemas.microsoft.com/office/drawing/2014/main" id="{95AAB270-8ACC-4765-AEC9-6848F99C1875}"/>
+              </a:ext>
+            </a:extLst>
+          </p:cNvPr>
+          <p:cNvSpPr>
+            <a:spLocks xmlns:a="http://schemas.openxmlformats.org/drawingml/2006/main" noGrp="1"/>
+          </p:cNvSpPr>
+          <p:nvPr/>
+        </p:nvSpPr>
+        <p:spPr>
+          <a:xfrm xmlns:a="http://schemas.openxmlformats.org/drawingml/2006/main">
+            <a:off x="5151120" y="4362450"/>
+            <a:ext cx="1889760" cy="762000"/>
+          </a:xfrm>
+          <a:prstGeom xmlns:a="http://schemas.openxmlformats.org/drawingml/2006/main" prst="rect">
+            <a:avLst/>
+          </a:prstGeom>
+          <a:noFill xmlns:a="http://schemas.openxmlformats.org/drawingml/2006/main"/>
+          <a:ln xmlns:a="http://schemas.openxmlformats.org/drawingml/2006/main" w="0">
+            <a:noFill/>
+          </a:ln>
+        </p:spPr>
+        <p:txBody>
+          <a:bodyPr xmlns:a="http://schemas.openxmlformats.org/drawingml/2006/main" wrap="square" lIns="0" tIns="0" rIns="0" bIns="0" anchor="t">
+            <a:noAutofit/>
+          </a:bodyPr>
+          <a:lstStyle xmlns:a="http://schemas.openxmlformats.org/drawingml/2006/main">
+            <a:defPPr algn="l">
+              <a:defRPr sz="1950" b="0">
+                <a:solidFill>
+                  <a:srgbClr val="AFB6BC"/>
+                </a:solidFill>
+                <a:latin typeface="Apple SD Gothic Neo"/>
+                <a:ea typeface="Apple SD Gothic Neo"/>
+                <a:cs typeface="Apple SD Gothic Neo"/>
+              </a:defRPr>
+            </a:defPPr>
+          </a:lstStyle>
+          <a:p xmlns:a="http://schemas.openxmlformats.org/drawingml/2006/main">
+            <a:pPr algn="l">
+              <a:defRPr sz="1950" b="0">
+                <a:solidFill>
+                  <a:srgbClr val="AFB6BC"/>
+                </a:solidFill>
+                <a:latin typeface="Apple SD Gothic Neo"/>
+                <a:ea typeface="Apple SD Gothic Neo"/>
+                <a:cs typeface="Apple SD Gothic Neo"/>
+              </a:defRPr>
+            </a:pPr>
+            <a:r>
+              <a:rPr sz="1950" b="0">
+                <a:solidFill>
+                  <a:srgbClr val="AFB6BC"/>
+                </a:solidFill>
+                <a:latin typeface="Apple SD Gothic Neo"/>
+                <a:ea typeface="Apple SD Gothic Neo"/>
+                <a:cs typeface="Apple SD Gothic Neo"/>
+              </a:rPr>
+              <a:t>현실 장애물</a:t>
+            </a:r>
+          </a:p>
+        </p:txBody>
+      </p:sp>
+      <p:sp>
+        <p:nvSpPr>
+          <p:cNvPr id="13" name="">
+            <a:extLst xmlns:a="http://schemas.openxmlformats.org/drawingml/2006/main">
+              <a:ext uri="{FF2B5EF4-FFF2-40B4-BE49-F238E27FC236}">
+                <a16:creationId xmlns:a16="http://schemas.microsoft.com/office/drawing/2014/main" id="{B10BDE44-C143-426E-9F61-DD0A942B4578}"/>
+              </a:ext>
+            </a:extLst>
+          </p:cNvPr>
+          <p:cNvSpPr>
+            <a:spLocks xmlns:a="http://schemas.openxmlformats.org/drawingml/2006/main" noGrp="1"/>
+          </p:cNvSpPr>
+          <p:nvPr/>
+        </p:nvSpPr>
+        <p:spPr>
+          <a:xfrm xmlns:a="http://schemas.openxmlformats.org/drawingml/2006/main">
+            <a:off x="7364730" y="2667000"/>
+            <a:ext cx="1889760" cy="952500"/>
+          </a:xfrm>
+          <a:prstGeom xmlns:a="http://schemas.openxmlformats.org/drawingml/2006/main" prst="rect">
+            <a:avLst/>
+          </a:prstGeom>
+          <a:noFill xmlns:a="http://schemas.openxmlformats.org/drawingml/2006/main"/>
+          <a:ln xmlns:a="http://schemas.openxmlformats.org/drawingml/2006/main" w="0">
+            <a:noFill/>
+          </a:ln>
+        </p:spPr>
+        <p:txBody>
+          <a:bodyPr xmlns:a="http://schemas.openxmlformats.org/drawingml/2006/main" wrap="square" lIns="0" tIns="0" rIns="0" bIns="0" anchor="t">
+            <a:noAutofit/>
+          </a:bodyPr>
+          <a:lstStyle xmlns:a="http://schemas.openxmlformats.org/drawingml/2006/main">
+            <a:defPPr algn="l">
+              <a:defRPr sz="5850" b="1">
+                <a:solidFill>
+                  <a:srgbClr val="B48E5B"/>
+                </a:solidFill>
+                <a:latin typeface="Apple SD Gothic Neo"/>
+                <a:ea typeface="Apple SD Gothic Neo"/>
+                <a:cs typeface="Apple SD Gothic Neo"/>
+              </a:defRPr>
+            </a:defPPr>
+          </a:lstStyle>
+          <a:p xmlns:a="http://schemas.openxmlformats.org/drawingml/2006/main">
+            <a:pPr algn="l">
+              <a:defRPr sz="5850" b="1">
+                <a:solidFill>
+                  <a:srgbClr val="B48E5B"/>
+                </a:solidFill>
+                <a:latin typeface="Apple SD Gothic Neo"/>
+                <a:ea typeface="Apple SD Gothic Neo"/>
+                <a:cs typeface="Apple SD Gothic Neo"/>
+              </a:defRPr>
+            </a:pPr>
+            <a:r>
+              <a:rPr sz="5850" b="1">
+                <a:solidFill>
+                  <a:srgbClr val="B48E5B"/>
+                </a:solidFill>
+                <a:latin typeface="Apple SD Gothic Neo"/>
+                <a:ea typeface="Apple SD Gothic Neo"/>
+                <a:cs typeface="Apple SD Gothic Neo"/>
+              </a:rPr>
+              <a:t>R</a:t>
+            </a:r>
+          </a:p>
+        </p:txBody>
+      </p:sp>
+      <p:sp>
+        <p:nvSpPr>
+          <p:cNvPr id="14" name="">
+            <a:extLst xmlns:a="http://schemas.openxmlformats.org/drawingml/2006/main">
+              <a:ext uri="{FF2B5EF4-FFF2-40B4-BE49-F238E27FC236}">
+                <a16:creationId xmlns:a16="http://schemas.microsoft.com/office/drawing/2014/main" id="{0788F02B-5827-4BA2-8E17-A7080AF16AFB}"/>
+              </a:ext>
+            </a:extLst>
+          </p:cNvPr>
+          <p:cNvSpPr>
+            <a:spLocks xmlns:a="http://schemas.openxmlformats.org/drawingml/2006/main" noGrp="1"/>
+          </p:cNvSpPr>
+          <p:nvPr/>
+        </p:nvSpPr>
+        <p:spPr>
+          <a:xfrm xmlns:a="http://schemas.openxmlformats.org/drawingml/2006/main">
+            <a:off x="7364730" y="3724275"/>
+            <a:ext cx="1889760" cy="438150"/>
+          </a:xfrm>
+          <a:prstGeom xmlns:a="http://schemas.openxmlformats.org/drawingml/2006/main" prst="rect">
+            <a:avLst/>
+          </a:prstGeom>
+          <a:noFill xmlns:a="http://schemas.openxmlformats.org/drawingml/2006/main"/>
+          <a:ln xmlns:a="http://schemas.openxmlformats.org/drawingml/2006/main" w="0">
+            <a:noFill/>
+          </a:ln>
+        </p:spPr>
+        <p:txBody>
+          <a:bodyPr xmlns:a="http://schemas.openxmlformats.org/drawingml/2006/main" wrap="square" lIns="0" tIns="0" rIns="0" bIns="0" anchor="t">
+            <a:noAutofit/>
+          </a:bodyPr>
+          <a:lstStyle xmlns:a="http://schemas.openxmlformats.org/drawingml/2006/main">
+            <a:defPPr algn="l">
+              <a:defRPr sz="1650" b="1">
+                <a:solidFill>
+                  <a:srgbClr val="EFBB73"/>
+                </a:solidFill>
+                <a:latin typeface="Apple SD Gothic Neo"/>
+                <a:ea typeface="Apple SD Gothic Neo"/>
+                <a:cs typeface="Apple SD Gothic Neo"/>
+              </a:defRPr>
+            </a:defPPr>
+          </a:lstStyle>
+          <a:p xmlns:a="http://schemas.openxmlformats.org/drawingml/2006/main">
+            <a:pPr algn="l">
+              <a:defRPr sz="1650" b="1">
+                <a:solidFill>
+                  <a:srgbClr val="EFBB73"/>
+                </a:solidFill>
+                <a:latin typeface="Apple SD Gothic Neo"/>
+                <a:ea typeface="Apple SD Gothic Neo"/>
+                <a:cs typeface="Apple SD Gothic Neo"/>
+              </a:defRPr>
+            </a:pPr>
+            <a:r>
+              <a:rPr sz="1650" b="1">
+                <a:solidFill>
+                  <a:srgbClr val="EFBB73"/>
+                </a:solidFill>
+                <a:latin typeface="Apple SD Gothic Neo"/>
+                <a:ea typeface="Apple SD Gothic Neo"/>
+                <a:cs typeface="Apple SD Gothic Neo"/>
+              </a:rPr>
+              <a:t>Resources</a:t>
+            </a:r>
+          </a:p>
+        </p:txBody>
+      </p:sp>
+      <p:sp>
+        <p:nvSpPr>
+          <p:cNvPr id="15" name="">
+            <a:extLst xmlns:a="http://schemas.openxmlformats.org/drawingml/2006/main">
+              <a:ext uri="{FF2B5EF4-FFF2-40B4-BE49-F238E27FC236}">
+                <a16:creationId xmlns:a16="http://schemas.microsoft.com/office/drawing/2014/main" id="{979F8433-FD42-4676-8A7D-ACCFB8FB588C}"/>
+              </a:ext>
+            </a:extLst>
+          </p:cNvPr>
+          <p:cNvSpPr>
+            <a:spLocks xmlns:a="http://schemas.openxmlformats.org/drawingml/2006/main" noGrp="1"/>
+          </p:cNvSpPr>
+          <p:nvPr/>
+        </p:nvSpPr>
+        <p:spPr>
+          <a:xfrm xmlns:a="http://schemas.openxmlformats.org/drawingml/2006/main">
+            <a:off x="7364730" y="4362450"/>
+            <a:ext cx="1889760" cy="762000"/>
+          </a:xfrm>
+          <a:prstGeom xmlns:a="http://schemas.openxmlformats.org/drawingml/2006/main" prst="rect">
+            <a:avLst/>
+          </a:prstGeom>
+          <a:noFill xmlns:a="http://schemas.openxmlformats.org/drawingml/2006/main"/>
+          <a:ln xmlns:a="http://schemas.openxmlformats.org/drawingml/2006/main" w="0">
+            <a:noFill/>
+          </a:ln>
+        </p:spPr>
+        <p:txBody>
+          <a:bodyPr xmlns:a="http://schemas.openxmlformats.org/drawingml/2006/main" wrap="square" lIns="0" tIns="0" rIns="0" bIns="0" anchor="t">
+            <a:noAutofit/>
+          </a:bodyPr>
+          <a:lstStyle xmlns:a="http://schemas.openxmlformats.org/drawingml/2006/main">
+            <a:defPPr algn="l">
+              <a:defRPr sz="1950" b="0">
+                <a:solidFill>
+                  <a:srgbClr val="AFB6BC"/>
+                </a:solidFill>
+                <a:latin typeface="Apple SD Gothic Neo"/>
+                <a:ea typeface="Apple SD Gothic Neo"/>
+                <a:cs typeface="Apple SD Gothic Neo"/>
+              </a:defRPr>
+            </a:defPPr>
+          </a:lstStyle>
+          <a:p xmlns:a="http://schemas.openxmlformats.org/drawingml/2006/main">
+            <a:pPr algn="l">
+              <a:defRPr sz="1950" b="0">
+                <a:solidFill>
+                  <a:srgbClr val="AFB6BC"/>
+                </a:solidFill>
+                <a:latin typeface="Apple SD Gothic Neo"/>
+                <a:ea typeface="Apple SD Gothic Neo"/>
+                <a:cs typeface="Apple SD Gothic Neo"/>
+              </a:defRPr>
+            </a:pPr>
+            <a:r>
+              <a:rPr sz="1950" b="0">
+                <a:solidFill>
+                  <a:srgbClr val="AFB6BC"/>
+                </a:solidFill>
+                <a:latin typeface="Apple SD Gothic Neo"/>
+                <a:ea typeface="Apple SD Gothic Neo"/>
+                <a:cs typeface="Apple SD Gothic Neo"/>
+              </a:rPr>
+              <a:t>해결자원</a:t>
+            </a:r>
+          </a:p>
+        </p:txBody>
+      </p:sp>
+      <p:sp>
+        <p:nvSpPr>
+          <p:cNvPr id="16" name="">
+            <a:extLst xmlns:a="http://schemas.openxmlformats.org/drawingml/2006/main">
+              <a:ext uri="{FF2B5EF4-FFF2-40B4-BE49-F238E27FC236}">
+                <a16:creationId xmlns:a16="http://schemas.microsoft.com/office/drawing/2014/main" id="{6B53679A-DF29-4BC4-A047-CEF8B66B6657}"/>
+              </a:ext>
+            </a:extLst>
+          </p:cNvPr>
+          <p:cNvSpPr>
+            <a:spLocks xmlns:a="http://schemas.openxmlformats.org/drawingml/2006/main" noGrp="1"/>
+          </p:cNvSpPr>
+          <p:nvPr/>
+        </p:nvSpPr>
+        <p:spPr>
+          <a:xfrm xmlns:a="http://schemas.openxmlformats.org/drawingml/2006/main">
+            <a:off x="9578340" y="2667000"/>
+            <a:ext cx="1889760" cy="952500"/>
+          </a:xfrm>
+          <a:prstGeom xmlns:a="http://schemas.openxmlformats.org/drawingml/2006/main" prst="rect">
+            <a:avLst/>
+          </a:prstGeom>
+          <a:noFill xmlns:a="http://schemas.openxmlformats.org/drawingml/2006/main"/>
+          <a:ln xmlns:a="http://schemas.openxmlformats.org/drawingml/2006/main" w="0">
+            <a:noFill/>
+          </a:ln>
+        </p:spPr>
+        <p:txBody>
+          <a:bodyPr xmlns:a="http://schemas.openxmlformats.org/drawingml/2006/main" wrap="square" lIns="0" tIns="0" rIns="0" bIns="0" anchor="t">
+            <a:noAutofit/>
+          </a:bodyPr>
+          <a:lstStyle xmlns:a="http://schemas.openxmlformats.org/drawingml/2006/main">
+            <a:defPPr algn="l">
+              <a:defRPr sz="5850" b="1">
+                <a:solidFill>
+                  <a:srgbClr val="B48E5B"/>
+                </a:solidFill>
+                <a:latin typeface="Apple SD Gothic Neo"/>
+                <a:ea typeface="Apple SD Gothic Neo"/>
+                <a:cs typeface="Apple SD Gothic Neo"/>
+              </a:defRPr>
+            </a:defPPr>
+          </a:lstStyle>
+          <a:p xmlns:a="http://schemas.openxmlformats.org/drawingml/2006/main">
+            <a:pPr algn="l">
+              <a:defRPr sz="5850" b="1">
+                <a:solidFill>
+                  <a:srgbClr val="B48E5B"/>
+                </a:solidFill>
+                <a:latin typeface="Apple SD Gothic Neo"/>
+                <a:ea typeface="Apple SD Gothic Neo"/>
+                <a:cs typeface="Apple SD Gothic Neo"/>
+              </a:defRPr>
+            </a:pPr>
+            <a:r>
+              <a:rPr sz="5850" b="1">
+                <a:solidFill>
+                  <a:srgbClr val="B48E5B"/>
+                </a:solidFill>
+                <a:latin typeface="Apple SD Gothic Neo"/>
+                <a:ea typeface="Apple SD Gothic Neo"/>
+                <a:cs typeface="Apple SD Gothic Neo"/>
+              </a:rPr>
+              <a:t>R</a:t>
+            </a:r>
+          </a:p>
+        </p:txBody>
+      </p:sp>
+      <p:sp>
+        <p:nvSpPr>
+          <p:cNvPr id="17" name="">
+            <a:extLst xmlns:a="http://schemas.openxmlformats.org/drawingml/2006/main">
+              <a:ext uri="{FF2B5EF4-FFF2-40B4-BE49-F238E27FC236}">
+                <a16:creationId xmlns:a16="http://schemas.microsoft.com/office/drawing/2014/main" id="{09BFCC04-CEB2-41AB-B18D-4EB0508B05F5}"/>
+              </a:ext>
+            </a:extLst>
+          </p:cNvPr>
+          <p:cNvSpPr>
+            <a:spLocks xmlns:a="http://schemas.openxmlformats.org/drawingml/2006/main" noGrp="1"/>
+          </p:cNvSpPr>
+          <p:nvPr/>
+        </p:nvSpPr>
+        <p:spPr>
+          <a:xfrm xmlns:a="http://schemas.openxmlformats.org/drawingml/2006/main">
+            <a:off x="9578340" y="3724275"/>
+            <a:ext cx="1889760" cy="438150"/>
+          </a:xfrm>
+          <a:prstGeom xmlns:a="http://schemas.openxmlformats.org/drawingml/2006/main" prst="rect">
+            <a:avLst/>
+          </a:prstGeom>
+          <a:noFill xmlns:a="http://schemas.openxmlformats.org/drawingml/2006/main"/>
+          <a:ln xmlns:a="http://schemas.openxmlformats.org/drawingml/2006/main" w="0">
+            <a:noFill/>
+          </a:ln>
+        </p:spPr>
+        <p:txBody>
+          <a:bodyPr xmlns:a="http://schemas.openxmlformats.org/drawingml/2006/main" wrap="square" lIns="0" tIns="0" rIns="0" bIns="0" anchor="t">
+            <a:noAutofit/>
+          </a:bodyPr>
+          <a:lstStyle xmlns:a="http://schemas.openxmlformats.org/drawingml/2006/main">
+            <a:defPPr algn="l">
+              <a:defRPr sz="1650" b="1">
+                <a:solidFill>
+                  <a:srgbClr val="EFBB73"/>
+                </a:solidFill>
+                <a:latin typeface="Apple SD Gothic Neo"/>
+                <a:ea typeface="Apple SD Gothic Neo"/>
+                <a:cs typeface="Apple SD Gothic Neo"/>
+              </a:defRPr>
+            </a:defPPr>
+          </a:lstStyle>
+          <a:p xmlns:a="http://schemas.openxmlformats.org/drawingml/2006/main">
+            <a:pPr algn="l">
+              <a:defRPr sz="1650" b="1">
+                <a:solidFill>
+                  <a:srgbClr val="EFBB73"/>
+                </a:solidFill>
+                <a:latin typeface="Apple SD Gothic Neo"/>
+                <a:ea typeface="Apple SD Gothic Neo"/>
+                <a:cs typeface="Apple SD Gothic Neo"/>
+              </a:defRPr>
+            </a:pPr>
+            <a:r>
+              <a:rPr sz="1650" b="1">
+                <a:solidFill>
+                  <a:srgbClr val="EFBB73"/>
+                </a:solidFill>
+                <a:latin typeface="Apple SD Gothic Neo"/>
+                <a:ea typeface="Apple SD Gothic Neo"/>
+                <a:cs typeface="Apple SD Gothic Neo"/>
+              </a:rPr>
+              <a:t>Responsibility</a:t>
+            </a:r>
+          </a:p>
+        </p:txBody>
+      </p:sp>
+      <p:sp>
+        <p:nvSpPr>
+          <p:cNvPr id="18" name="">
+            <a:extLst xmlns:a="http://schemas.openxmlformats.org/drawingml/2006/main">
+              <a:ext uri="{FF2B5EF4-FFF2-40B4-BE49-F238E27FC236}">
+                <a16:creationId xmlns:a16="http://schemas.microsoft.com/office/drawing/2014/main" id="{C5FFEB45-12BC-49C4-9F1C-16AE75866F51}"/>
+              </a:ext>
+            </a:extLst>
+          </p:cNvPr>
+          <p:cNvSpPr>
+            <a:spLocks xmlns:a="http://schemas.openxmlformats.org/drawingml/2006/main" noGrp="1"/>
+          </p:cNvSpPr>
+          <p:nvPr/>
+        </p:nvSpPr>
+        <p:spPr>
+          <a:xfrm xmlns:a="http://schemas.openxmlformats.org/drawingml/2006/main">
+            <a:off x="9578340" y="4362450"/>
+            <a:ext cx="1889760" cy="762000"/>
+          </a:xfrm>
+          <a:prstGeom xmlns:a="http://schemas.openxmlformats.org/drawingml/2006/main" prst="rect">
+            <a:avLst/>
+          </a:prstGeom>
+          <a:noFill xmlns:a="http://schemas.openxmlformats.org/drawingml/2006/main"/>
+          <a:ln xmlns:a="http://schemas.openxmlformats.org/drawingml/2006/main" w="0">
+            <a:noFill/>
+          </a:ln>
+        </p:spPr>
+        <p:txBody>
+          <a:bodyPr xmlns:a="http://schemas.openxmlformats.org/drawingml/2006/main" wrap="square" lIns="0" tIns="0" rIns="0" bIns="0" anchor="t">
+            <a:noAutofit/>
+          </a:bodyPr>
+          <a:lstStyle xmlns:a="http://schemas.openxmlformats.org/drawingml/2006/main">
+            <a:defPPr algn="l">
+              <a:defRPr sz="1950" b="0">
+                <a:solidFill>
+                  <a:srgbClr val="AFB6BC"/>
+                </a:solidFill>
+                <a:latin typeface="Apple SD Gothic Neo"/>
+                <a:ea typeface="Apple SD Gothic Neo"/>
+                <a:cs typeface="Apple SD Gothic Neo"/>
+              </a:defRPr>
+            </a:defPPr>
+          </a:lstStyle>
+          <a:p xmlns:a="http://schemas.openxmlformats.org/drawingml/2006/main">
+            <a:pPr algn="l">
+              <a:defRPr sz="1950" b="0">
+                <a:solidFill>
+                  <a:srgbClr val="AFB6BC"/>
+                </a:solidFill>
+                <a:latin typeface="Apple SD Gothic Neo"/>
+                <a:ea typeface="Apple SD Gothic Neo"/>
+                <a:cs typeface="Apple SD Gothic Neo"/>
+              </a:defRPr>
+            </a:pPr>
+            <a:r>
+              <a:rPr sz="1950" b="0">
+                <a:solidFill>
+                  <a:srgbClr val="AFB6BC"/>
+                </a:solidFill>
+                <a:latin typeface="Apple SD Gothic Neo"/>
+                <a:ea typeface="Apple SD Gothic Neo"/>
+                <a:cs typeface="Apple SD Gothic Neo"/>
+              </a:rPr>
+              <a:t>책임지기</a:t>
+            </a:r>
+          </a:p>
+        </p:txBody>
+      </p:sp>
+      <p:sp>
+        <p:nvSpPr>
+          <p:cNvPr id="19" name="">
+            <a:extLst xmlns:a="http://schemas.openxmlformats.org/drawingml/2006/main">
+              <a:ext uri="{FF2B5EF4-FFF2-40B4-BE49-F238E27FC236}">
+                <a16:creationId xmlns:a16="http://schemas.microsoft.com/office/drawing/2014/main" id="{B653A8ED-38A0-48F3-9CC7-825819A7921B}"/>
+              </a:ext>
+            </a:extLst>
+          </p:cNvPr>
+          <p:cNvSpPr>
+            <a:spLocks xmlns:a="http://schemas.openxmlformats.org/drawingml/2006/main" noGrp="1"/>
+          </p:cNvSpPr>
+          <p:nvPr/>
+        </p:nvSpPr>
+        <p:spPr>
+          <a:xfrm xmlns:a="http://schemas.openxmlformats.org/drawingml/2006/main">
+            <a:off x="723900" y="5495925"/>
+            <a:ext cx="10572750" cy="762000"/>
           </a:xfrm>
           <a:prstGeom xmlns:a="http://schemas.openxmlformats.org/drawingml/2006/main" prst="rect">
             <a:avLst/>
@@ -15482,618 +16434,6 @@
                 <a:ea typeface="Apple SD Gothic Neo"/>
                 <a:cs typeface="Apple SD Gothic Neo"/>
               </a:rPr>
-              <a:t>관계형성</a:t>
-            </a:r>
-          </a:p>
-        </p:txBody>
-      </p:sp>
-      <p:sp>
-        <p:nvSpPr>
-          <p:cNvPr id="6" name="">
-            <a:extLst xmlns:a="http://schemas.openxmlformats.org/drawingml/2006/main">
-              <a:ext uri="{FF2B5EF4-FFF2-40B4-BE49-F238E27FC236}">
-                <a16:creationId xmlns:a16="http://schemas.microsoft.com/office/drawing/2014/main" id="{4B1F20C8-CB8F-4080-BF73-74095D477402}"/>
-              </a:ext>
-            </a:extLst>
-          </p:cNvPr>
-          <p:cNvSpPr>
-            <a:spLocks xmlns:a="http://schemas.openxmlformats.org/drawingml/2006/main" noGrp="1"/>
-          </p:cNvSpPr>
-          <p:nvPr/>
-        </p:nvSpPr>
-        <p:spPr>
-          <a:xfrm xmlns:a="http://schemas.openxmlformats.org/drawingml/2006/main">
-            <a:off x="2937510" y="2857500"/>
-            <a:ext cx="1889760" cy="1047750"/>
-          </a:xfrm>
-          <a:prstGeom xmlns:a="http://schemas.openxmlformats.org/drawingml/2006/main" prst="rect">
-            <a:avLst/>
-          </a:prstGeom>
-          <a:noFill xmlns:a="http://schemas.openxmlformats.org/drawingml/2006/main"/>
-          <a:ln xmlns:a="http://schemas.openxmlformats.org/drawingml/2006/main" w="0">
-            <a:noFill/>
-          </a:ln>
-        </p:spPr>
-        <p:txBody>
-          <a:bodyPr xmlns:a="http://schemas.openxmlformats.org/drawingml/2006/main" wrap="square" lIns="0" tIns="0" rIns="0" bIns="0" anchor="t">
-            <a:noAutofit/>
-          </a:bodyPr>
-          <a:lstStyle xmlns:a="http://schemas.openxmlformats.org/drawingml/2006/main">
-            <a:defPPr algn="l">
-              <a:defRPr sz="1650" b="1">
-                <a:solidFill>
-                  <a:srgbClr val="EFBB73"/>
-                </a:solidFill>
-                <a:latin typeface="Apple SD Gothic Neo"/>
-                <a:ea typeface="Apple SD Gothic Neo"/>
-                <a:cs typeface="Apple SD Gothic Neo"/>
-              </a:defRPr>
-            </a:defPPr>
-          </a:lstStyle>
-          <a:p xmlns:a="http://schemas.openxmlformats.org/drawingml/2006/main">
-            <a:pPr algn="l">
-              <a:defRPr sz="1650" b="1">
-                <a:solidFill>
-                  <a:srgbClr val="EFBB73"/>
-                </a:solidFill>
-                <a:latin typeface="Apple SD Gothic Neo"/>
-                <a:ea typeface="Apple SD Gothic Neo"/>
-                <a:cs typeface="Apple SD Gothic Neo"/>
-              </a:defRPr>
-            </a:pPr>
-            <a:r>
-              <a:rPr sz="1650" b="1">
-                <a:solidFill>
-                  <a:srgbClr val="EFBB73"/>
-                </a:solidFill>
-                <a:latin typeface="Apple SD Gothic Neo"/>
-                <a:ea typeface="Apple SD Gothic Neo"/>
-                <a:cs typeface="Apple SD Gothic Neo"/>
-              </a:rPr>
-              <a:t>Refocus</a:t>
-            </a:r>
-          </a:p>
-        </p:txBody>
-      </p:sp>
-      <p:sp>
-        <p:nvSpPr>
-          <p:cNvPr id="7" name="">
-            <a:extLst xmlns:a="http://schemas.openxmlformats.org/drawingml/2006/main">
-              <a:ext uri="{FF2B5EF4-FFF2-40B4-BE49-F238E27FC236}">
-                <a16:creationId xmlns:a16="http://schemas.microsoft.com/office/drawing/2014/main" id="{9695585F-E7F8-4E19-9891-D6D1A90F847D}"/>
-              </a:ext>
-            </a:extLst>
-          </p:cNvPr>
-          <p:cNvSpPr>
-            <a:spLocks xmlns:a="http://schemas.openxmlformats.org/drawingml/2006/main" noGrp="1"/>
-          </p:cNvSpPr>
-          <p:nvPr/>
-        </p:nvSpPr>
-        <p:spPr>
-          <a:xfrm xmlns:a="http://schemas.openxmlformats.org/drawingml/2006/main">
-            <a:off x="2937510" y="3905250"/>
-            <a:ext cx="1889760" cy="2000250"/>
-          </a:xfrm>
-          <a:prstGeom xmlns:a="http://schemas.openxmlformats.org/drawingml/2006/main" prst="rect">
-            <a:avLst/>
-          </a:prstGeom>
-          <a:noFill xmlns:a="http://schemas.openxmlformats.org/drawingml/2006/main"/>
-          <a:ln xmlns:a="http://schemas.openxmlformats.org/drawingml/2006/main" w="0">
-            <a:noFill/>
-          </a:ln>
-        </p:spPr>
-        <p:txBody>
-          <a:bodyPr xmlns:a="http://schemas.openxmlformats.org/drawingml/2006/main" wrap="square" lIns="0" tIns="0" rIns="0" bIns="0" anchor="t">
-            <a:noAutofit/>
-          </a:bodyPr>
-          <a:lstStyle xmlns:a="http://schemas.openxmlformats.org/drawingml/2006/main">
-            <a:defPPr algn="l">
-              <a:defRPr sz="1800" b="0">
-                <a:solidFill>
-                  <a:srgbClr val="AFB6BC"/>
-                </a:solidFill>
-                <a:latin typeface="Apple SD Gothic Neo"/>
-                <a:ea typeface="Apple SD Gothic Neo"/>
-                <a:cs typeface="Apple SD Gothic Neo"/>
-              </a:defRPr>
-            </a:defPPr>
-          </a:lstStyle>
-          <a:p xmlns:a="http://schemas.openxmlformats.org/drawingml/2006/main">
-            <a:pPr algn="l">
-              <a:defRPr sz="1800" b="0">
-                <a:solidFill>
-                  <a:srgbClr val="AFB6BC"/>
-                </a:solidFill>
-                <a:latin typeface="Apple SD Gothic Neo"/>
-                <a:ea typeface="Apple SD Gothic Neo"/>
-                <a:cs typeface="Apple SD Gothic Neo"/>
-              </a:defRPr>
-            </a:pPr>
-            <a:r>
-              <a:rPr sz="1800" b="0">
-                <a:solidFill>
-                  <a:srgbClr val="AFB6BC"/>
-                </a:solidFill>
-                <a:latin typeface="Apple SD Gothic Neo"/>
-                <a:ea typeface="Apple SD Gothic Neo"/>
-                <a:cs typeface="Apple SD Gothic Neo"/>
-              </a:rPr>
-              <a:t>목표설정</a:t>
-            </a:r>
-          </a:p>
-        </p:txBody>
-      </p:sp>
-      <p:sp>
-        <p:nvSpPr>
-          <p:cNvPr id="8" name="">
-            <a:extLst xmlns:a="http://schemas.openxmlformats.org/drawingml/2006/main">
-              <a:ext uri="{FF2B5EF4-FFF2-40B4-BE49-F238E27FC236}">
-                <a16:creationId xmlns:a16="http://schemas.microsoft.com/office/drawing/2014/main" id="{98DF6B0A-0911-4501-BD31-DAF40B1FE38C}"/>
-              </a:ext>
-            </a:extLst>
-          </p:cNvPr>
-          <p:cNvSpPr>
-            <a:spLocks xmlns:a="http://schemas.openxmlformats.org/drawingml/2006/main" noGrp="1"/>
-          </p:cNvSpPr>
-          <p:nvPr/>
-        </p:nvSpPr>
-        <p:spPr>
-          <a:xfrm xmlns:a="http://schemas.openxmlformats.org/drawingml/2006/main">
-            <a:off x="5151120" y="2857500"/>
-            <a:ext cx="1889760" cy="1047750"/>
-          </a:xfrm>
-          <a:prstGeom xmlns:a="http://schemas.openxmlformats.org/drawingml/2006/main" prst="rect">
-            <a:avLst/>
-          </a:prstGeom>
-          <a:noFill xmlns:a="http://schemas.openxmlformats.org/drawingml/2006/main"/>
-          <a:ln xmlns:a="http://schemas.openxmlformats.org/drawingml/2006/main" w="0">
-            <a:noFill/>
-          </a:ln>
-        </p:spPr>
-        <p:txBody>
-          <a:bodyPr xmlns:a="http://schemas.openxmlformats.org/drawingml/2006/main" wrap="square" lIns="0" tIns="0" rIns="0" bIns="0" anchor="t">
-            <a:noAutofit/>
-          </a:bodyPr>
-          <a:lstStyle xmlns:a="http://schemas.openxmlformats.org/drawingml/2006/main">
-            <a:defPPr algn="l">
-              <a:defRPr sz="1650" b="1">
-                <a:solidFill>
-                  <a:srgbClr val="EFBB73"/>
-                </a:solidFill>
-                <a:latin typeface="Apple SD Gothic Neo"/>
-                <a:ea typeface="Apple SD Gothic Neo"/>
-                <a:cs typeface="Apple SD Gothic Neo"/>
-              </a:defRPr>
-            </a:defPPr>
-          </a:lstStyle>
-          <a:p xmlns:a="http://schemas.openxmlformats.org/drawingml/2006/main">
-            <a:pPr algn="l">
-              <a:defRPr sz="1650" b="1">
-                <a:solidFill>
-                  <a:srgbClr val="EFBB73"/>
-                </a:solidFill>
-                <a:latin typeface="Apple SD Gothic Neo"/>
-                <a:ea typeface="Apple SD Gothic Neo"/>
-                <a:cs typeface="Apple SD Gothic Neo"/>
-              </a:defRPr>
-            </a:pPr>
-            <a:r>
-              <a:rPr sz="1650" b="1">
-                <a:solidFill>
-                  <a:srgbClr val="EFBB73"/>
-                </a:solidFill>
-                <a:latin typeface="Apple SD Gothic Neo"/>
-                <a:ea typeface="Apple SD Gothic Neo"/>
-                <a:cs typeface="Apple SD Gothic Neo"/>
-              </a:rPr>
-              <a:t>Reality</a:t>
-            </a:r>
-          </a:p>
-        </p:txBody>
-      </p:sp>
-      <p:sp>
-        <p:nvSpPr>
-          <p:cNvPr id="9" name="">
-            <a:extLst xmlns:a="http://schemas.openxmlformats.org/drawingml/2006/main">
-              <a:ext uri="{FF2B5EF4-FFF2-40B4-BE49-F238E27FC236}">
-                <a16:creationId xmlns:a16="http://schemas.microsoft.com/office/drawing/2014/main" id="{EF602E10-4B62-4F64-8BD7-E9EBFEA4621D}"/>
-              </a:ext>
-            </a:extLst>
-          </p:cNvPr>
-          <p:cNvSpPr>
-            <a:spLocks xmlns:a="http://schemas.openxmlformats.org/drawingml/2006/main" noGrp="1"/>
-          </p:cNvSpPr>
-          <p:nvPr/>
-        </p:nvSpPr>
-        <p:spPr>
-          <a:xfrm xmlns:a="http://schemas.openxmlformats.org/drawingml/2006/main">
-            <a:off x="5151120" y="3905250"/>
-            <a:ext cx="1889760" cy="2000250"/>
-          </a:xfrm>
-          <a:prstGeom xmlns:a="http://schemas.openxmlformats.org/drawingml/2006/main" prst="rect">
-            <a:avLst/>
-          </a:prstGeom>
-          <a:noFill xmlns:a="http://schemas.openxmlformats.org/drawingml/2006/main"/>
-          <a:ln xmlns:a="http://schemas.openxmlformats.org/drawingml/2006/main" w="0">
-            <a:noFill/>
-          </a:ln>
-        </p:spPr>
-        <p:txBody>
-          <a:bodyPr xmlns:a="http://schemas.openxmlformats.org/drawingml/2006/main" wrap="square" lIns="0" tIns="0" rIns="0" bIns="0" anchor="t">
-            <a:noAutofit/>
-          </a:bodyPr>
-          <a:lstStyle xmlns:a="http://schemas.openxmlformats.org/drawingml/2006/main">
-            <a:defPPr algn="l">
-              <a:defRPr sz="1800" b="0">
-                <a:solidFill>
-                  <a:srgbClr val="AFB6BC"/>
-                </a:solidFill>
-                <a:latin typeface="Apple SD Gothic Neo"/>
-                <a:ea typeface="Apple SD Gothic Neo"/>
-                <a:cs typeface="Apple SD Gothic Neo"/>
-              </a:defRPr>
-            </a:defPPr>
-          </a:lstStyle>
-          <a:p xmlns:a="http://schemas.openxmlformats.org/drawingml/2006/main">
-            <a:pPr algn="l">
-              <a:defRPr sz="1800" b="0">
-                <a:solidFill>
-                  <a:srgbClr val="AFB6BC"/>
-                </a:solidFill>
-                <a:latin typeface="Apple SD Gothic Neo"/>
-                <a:ea typeface="Apple SD Gothic Neo"/>
-                <a:cs typeface="Apple SD Gothic Neo"/>
-              </a:defRPr>
-            </a:pPr>
-            <a:r>
-              <a:rPr sz="1800" b="0">
-                <a:solidFill>
-                  <a:srgbClr val="AFB6BC"/>
-                </a:solidFill>
-                <a:latin typeface="Apple SD Gothic Neo"/>
-                <a:ea typeface="Apple SD Gothic Neo"/>
-                <a:cs typeface="Apple SD Gothic Neo"/>
-              </a:rPr>
-              <a:t>현실 장애물</a:t>
-            </a:r>
-          </a:p>
-        </p:txBody>
-      </p:sp>
-      <p:sp>
-        <p:nvSpPr>
-          <p:cNvPr id="10" name="">
-            <a:extLst xmlns:a="http://schemas.openxmlformats.org/drawingml/2006/main">
-              <a:ext uri="{FF2B5EF4-FFF2-40B4-BE49-F238E27FC236}">
-                <a16:creationId xmlns:a16="http://schemas.microsoft.com/office/drawing/2014/main" id="{07594581-0EF3-4F0C-B467-976C4C8679EC}"/>
-              </a:ext>
-            </a:extLst>
-          </p:cNvPr>
-          <p:cNvSpPr>
-            <a:spLocks xmlns:a="http://schemas.openxmlformats.org/drawingml/2006/main" noGrp="1"/>
-          </p:cNvSpPr>
-          <p:nvPr/>
-        </p:nvSpPr>
-        <p:spPr>
-          <a:xfrm xmlns:a="http://schemas.openxmlformats.org/drawingml/2006/main">
-            <a:off x="7364730" y="2857500"/>
-            <a:ext cx="1889760" cy="1047750"/>
-          </a:xfrm>
-          <a:prstGeom xmlns:a="http://schemas.openxmlformats.org/drawingml/2006/main" prst="rect">
-            <a:avLst/>
-          </a:prstGeom>
-          <a:noFill xmlns:a="http://schemas.openxmlformats.org/drawingml/2006/main"/>
-          <a:ln xmlns:a="http://schemas.openxmlformats.org/drawingml/2006/main" w="0">
-            <a:noFill/>
-          </a:ln>
-        </p:spPr>
-        <p:txBody>
-          <a:bodyPr xmlns:a="http://schemas.openxmlformats.org/drawingml/2006/main" wrap="square" lIns="0" tIns="0" rIns="0" bIns="0" anchor="t">
-            <a:noAutofit/>
-          </a:bodyPr>
-          <a:lstStyle xmlns:a="http://schemas.openxmlformats.org/drawingml/2006/main">
-            <a:defPPr algn="l">
-              <a:defRPr sz="1650" b="1">
-                <a:solidFill>
-                  <a:srgbClr val="EFBB73"/>
-                </a:solidFill>
-                <a:latin typeface="Apple SD Gothic Neo"/>
-                <a:ea typeface="Apple SD Gothic Neo"/>
-                <a:cs typeface="Apple SD Gothic Neo"/>
-              </a:defRPr>
-            </a:defPPr>
-          </a:lstStyle>
-          <a:p xmlns:a="http://schemas.openxmlformats.org/drawingml/2006/main">
-            <a:pPr algn="l">
-              <a:defRPr sz="1650" b="1">
-                <a:solidFill>
-                  <a:srgbClr val="EFBB73"/>
-                </a:solidFill>
-                <a:latin typeface="Apple SD Gothic Neo"/>
-                <a:ea typeface="Apple SD Gothic Neo"/>
-                <a:cs typeface="Apple SD Gothic Neo"/>
-              </a:defRPr>
-            </a:pPr>
-            <a:r>
-              <a:rPr sz="1650" b="1">
-                <a:solidFill>
-                  <a:srgbClr val="EFBB73"/>
-                </a:solidFill>
-                <a:latin typeface="Apple SD Gothic Neo"/>
-                <a:ea typeface="Apple SD Gothic Neo"/>
-                <a:cs typeface="Apple SD Gothic Neo"/>
-              </a:rPr>
-              <a:t>Resources</a:t>
-            </a:r>
-          </a:p>
-        </p:txBody>
-      </p:sp>
-      <p:sp>
-        <p:nvSpPr>
-          <p:cNvPr id="11" name="">
-            <a:extLst xmlns:a="http://schemas.openxmlformats.org/drawingml/2006/main">
-              <a:ext uri="{FF2B5EF4-FFF2-40B4-BE49-F238E27FC236}">
-                <a16:creationId xmlns:a16="http://schemas.microsoft.com/office/drawing/2014/main" id="{48E3F636-73C2-40BB-9136-529A178D03AF}"/>
-              </a:ext>
-            </a:extLst>
-          </p:cNvPr>
-          <p:cNvSpPr>
-            <a:spLocks xmlns:a="http://schemas.openxmlformats.org/drawingml/2006/main" noGrp="1"/>
-          </p:cNvSpPr>
-          <p:nvPr/>
-        </p:nvSpPr>
-        <p:spPr>
-          <a:xfrm xmlns:a="http://schemas.openxmlformats.org/drawingml/2006/main">
-            <a:off x="7364730" y="3905250"/>
-            <a:ext cx="1889760" cy="2000250"/>
-          </a:xfrm>
-          <a:prstGeom xmlns:a="http://schemas.openxmlformats.org/drawingml/2006/main" prst="rect">
-            <a:avLst/>
-          </a:prstGeom>
-          <a:noFill xmlns:a="http://schemas.openxmlformats.org/drawingml/2006/main"/>
-          <a:ln xmlns:a="http://schemas.openxmlformats.org/drawingml/2006/main" w="0">
-            <a:noFill/>
-          </a:ln>
-        </p:spPr>
-        <p:txBody>
-          <a:bodyPr xmlns:a="http://schemas.openxmlformats.org/drawingml/2006/main" wrap="square" lIns="0" tIns="0" rIns="0" bIns="0" anchor="t">
-            <a:noAutofit/>
-          </a:bodyPr>
-          <a:lstStyle xmlns:a="http://schemas.openxmlformats.org/drawingml/2006/main">
-            <a:defPPr algn="l">
-              <a:defRPr sz="1800" b="0">
-                <a:solidFill>
-                  <a:srgbClr val="AFB6BC"/>
-                </a:solidFill>
-                <a:latin typeface="Apple SD Gothic Neo"/>
-                <a:ea typeface="Apple SD Gothic Neo"/>
-                <a:cs typeface="Apple SD Gothic Neo"/>
-              </a:defRPr>
-            </a:defPPr>
-          </a:lstStyle>
-          <a:p xmlns:a="http://schemas.openxmlformats.org/drawingml/2006/main">
-            <a:pPr algn="l">
-              <a:defRPr sz="1800" b="0">
-                <a:solidFill>
-                  <a:srgbClr val="AFB6BC"/>
-                </a:solidFill>
-                <a:latin typeface="Apple SD Gothic Neo"/>
-                <a:ea typeface="Apple SD Gothic Neo"/>
-                <a:cs typeface="Apple SD Gothic Neo"/>
-              </a:defRPr>
-            </a:pPr>
-            <a:r>
-              <a:rPr sz="1800" b="0">
-                <a:solidFill>
-                  <a:srgbClr val="AFB6BC"/>
-                </a:solidFill>
-                <a:latin typeface="Apple SD Gothic Neo"/>
-                <a:ea typeface="Apple SD Gothic Neo"/>
-                <a:cs typeface="Apple SD Gothic Neo"/>
-              </a:rPr>
-              <a:t>해결자원</a:t>
-            </a:r>
-          </a:p>
-        </p:txBody>
-      </p:sp>
-      <p:sp>
-        <p:nvSpPr>
-          <p:cNvPr id="12" name="">
-            <a:extLst xmlns:a="http://schemas.openxmlformats.org/drawingml/2006/main">
-              <a:ext uri="{FF2B5EF4-FFF2-40B4-BE49-F238E27FC236}">
-                <a16:creationId xmlns:a16="http://schemas.microsoft.com/office/drawing/2014/main" id="{BACF4211-5F80-44A4-A72F-B4D33C08316A}"/>
-              </a:ext>
-            </a:extLst>
-          </p:cNvPr>
-          <p:cNvSpPr>
-            <a:spLocks xmlns:a="http://schemas.openxmlformats.org/drawingml/2006/main" noGrp="1"/>
-          </p:cNvSpPr>
-          <p:nvPr/>
-        </p:nvSpPr>
-        <p:spPr>
-          <a:xfrm xmlns:a="http://schemas.openxmlformats.org/drawingml/2006/main">
-            <a:off x="9578340" y="2857500"/>
-            <a:ext cx="1889760" cy="1047750"/>
-          </a:xfrm>
-          <a:prstGeom xmlns:a="http://schemas.openxmlformats.org/drawingml/2006/main" prst="rect">
-            <a:avLst/>
-          </a:prstGeom>
-          <a:noFill xmlns:a="http://schemas.openxmlformats.org/drawingml/2006/main"/>
-          <a:ln xmlns:a="http://schemas.openxmlformats.org/drawingml/2006/main" w="0">
-            <a:noFill/>
-          </a:ln>
-        </p:spPr>
-        <p:txBody>
-          <a:bodyPr xmlns:a="http://schemas.openxmlformats.org/drawingml/2006/main" wrap="square" lIns="0" tIns="0" rIns="0" bIns="0" anchor="t">
-            <a:noAutofit/>
-          </a:bodyPr>
-          <a:lstStyle xmlns:a="http://schemas.openxmlformats.org/drawingml/2006/main">
-            <a:defPPr algn="l">
-              <a:defRPr sz="1650" b="1">
-                <a:solidFill>
-                  <a:srgbClr val="EFBB73"/>
-                </a:solidFill>
-                <a:latin typeface="Apple SD Gothic Neo"/>
-                <a:ea typeface="Apple SD Gothic Neo"/>
-                <a:cs typeface="Apple SD Gothic Neo"/>
-              </a:defRPr>
-            </a:defPPr>
-          </a:lstStyle>
-          <a:p xmlns:a="http://schemas.openxmlformats.org/drawingml/2006/main">
-            <a:pPr algn="l">
-              <a:defRPr sz="1650" b="1">
-                <a:solidFill>
-                  <a:srgbClr val="EFBB73"/>
-                </a:solidFill>
-                <a:latin typeface="Apple SD Gothic Neo"/>
-                <a:ea typeface="Apple SD Gothic Neo"/>
-                <a:cs typeface="Apple SD Gothic Neo"/>
-              </a:defRPr>
-            </a:pPr>
-            <a:r>
-              <a:rPr sz="1650" b="1">
-                <a:solidFill>
-                  <a:srgbClr val="EFBB73"/>
-                </a:solidFill>
-                <a:latin typeface="Apple SD Gothic Neo"/>
-                <a:ea typeface="Apple SD Gothic Neo"/>
-                <a:cs typeface="Apple SD Gothic Neo"/>
-              </a:rPr>
-              <a:t>Responsibility</a:t>
-            </a:r>
-          </a:p>
-        </p:txBody>
-      </p:sp>
-      <p:sp>
-        <p:nvSpPr>
-          <p:cNvPr id="13" name="">
-            <a:extLst xmlns:a="http://schemas.openxmlformats.org/drawingml/2006/main">
-              <a:ext uri="{FF2B5EF4-FFF2-40B4-BE49-F238E27FC236}">
-                <a16:creationId xmlns:a16="http://schemas.microsoft.com/office/drawing/2014/main" id="{2752DE63-0BF3-446E-9FE5-21A82B0F5521}"/>
-              </a:ext>
-            </a:extLst>
-          </p:cNvPr>
-          <p:cNvSpPr>
-            <a:spLocks xmlns:a="http://schemas.openxmlformats.org/drawingml/2006/main" noGrp="1"/>
-          </p:cNvSpPr>
-          <p:nvPr/>
-        </p:nvSpPr>
-        <p:spPr>
-          <a:xfrm xmlns:a="http://schemas.openxmlformats.org/drawingml/2006/main">
-            <a:off x="9578340" y="3905250"/>
-            <a:ext cx="1889760" cy="2000250"/>
-          </a:xfrm>
-          <a:prstGeom xmlns:a="http://schemas.openxmlformats.org/drawingml/2006/main" prst="rect">
-            <a:avLst/>
-          </a:prstGeom>
-          <a:noFill xmlns:a="http://schemas.openxmlformats.org/drawingml/2006/main"/>
-          <a:ln xmlns:a="http://schemas.openxmlformats.org/drawingml/2006/main" w="0">
-            <a:noFill/>
-          </a:ln>
-        </p:spPr>
-        <p:txBody>
-          <a:bodyPr xmlns:a="http://schemas.openxmlformats.org/drawingml/2006/main" wrap="square" lIns="0" tIns="0" rIns="0" bIns="0" anchor="t">
-            <a:noAutofit/>
-          </a:bodyPr>
-          <a:lstStyle xmlns:a="http://schemas.openxmlformats.org/drawingml/2006/main">
-            <a:defPPr algn="l">
-              <a:defRPr sz="1800" b="0">
-                <a:solidFill>
-                  <a:srgbClr val="AFB6BC"/>
-                </a:solidFill>
-                <a:latin typeface="Apple SD Gothic Neo"/>
-                <a:ea typeface="Apple SD Gothic Neo"/>
-                <a:cs typeface="Apple SD Gothic Neo"/>
-              </a:defRPr>
-            </a:defPPr>
-          </a:lstStyle>
-          <a:p xmlns:a="http://schemas.openxmlformats.org/drawingml/2006/main">
-            <a:pPr algn="l">
-              <a:defRPr sz="1800" b="0">
-                <a:solidFill>
-                  <a:srgbClr val="AFB6BC"/>
-                </a:solidFill>
-                <a:latin typeface="Apple SD Gothic Neo"/>
-                <a:ea typeface="Apple SD Gothic Neo"/>
-                <a:cs typeface="Apple SD Gothic Neo"/>
-              </a:defRPr>
-            </a:pPr>
-            <a:r>
-              <a:rPr sz="1800" b="0">
-                <a:solidFill>
-                  <a:srgbClr val="AFB6BC"/>
-                </a:solidFill>
-                <a:latin typeface="Apple SD Gothic Neo"/>
-                <a:ea typeface="Apple SD Gothic Neo"/>
-                <a:cs typeface="Apple SD Gothic Neo"/>
-              </a:rPr>
-              <a:t>책임지기</a:t>
-            </a:r>
-          </a:p>
-        </p:txBody>
-      </p:sp>
-      <p:sp>
-        <p:nvSpPr>
-          <p:cNvPr id="14" name="">
-            <a:extLst xmlns:a="http://schemas.openxmlformats.org/drawingml/2006/main">
-              <a:ext uri="{FF2B5EF4-FFF2-40B4-BE49-F238E27FC236}">
-                <a16:creationId xmlns:a16="http://schemas.microsoft.com/office/drawing/2014/main" id="{B157BCCC-2D7A-4CD4-AE4C-C7E1F1908893}"/>
-              </a:ext>
-            </a:extLst>
-          </p:cNvPr>
-          <p:cNvSpPr>
-            <a:spLocks xmlns:a="http://schemas.openxmlformats.org/drawingml/2006/main" noGrp="1"/>
-          </p:cNvSpPr>
-          <p:nvPr/>
-        </p:nvSpPr>
-        <p:spPr>
-          <a:xfrm xmlns:a="http://schemas.openxmlformats.org/drawingml/2006/main">
-            <a:off x="723900" y="5495925"/>
-            <a:ext cx="10572750" cy="762000"/>
-          </a:xfrm>
-          <a:prstGeom xmlns:a="http://schemas.openxmlformats.org/drawingml/2006/main" prst="rect">
-            <a:avLst/>
-          </a:prstGeom>
-          <a:noFill xmlns:a="http://schemas.openxmlformats.org/drawingml/2006/main"/>
-          <a:ln xmlns:a="http://schemas.openxmlformats.org/drawingml/2006/main" w="0">
-            <a:noFill/>
-          </a:ln>
-        </p:spPr>
-        <p:txBody>
-          <a:bodyPr xmlns:a="http://schemas.openxmlformats.org/drawingml/2006/main" wrap="square" lIns="0" tIns="0" rIns="0" bIns="0" anchor="t">
-            <a:noAutofit/>
-          </a:bodyPr>
-          <a:lstStyle xmlns:a="http://schemas.openxmlformats.org/drawingml/2006/main">
-            <a:defPPr algn="l">
-              <a:defRPr sz="1800" b="0">
-                <a:solidFill>
-                  <a:srgbClr val="AFB6BC"/>
-                </a:solidFill>
-                <a:latin typeface="Apple SD Gothic Neo"/>
-                <a:ea typeface="Apple SD Gothic Neo"/>
-                <a:cs typeface="Apple SD Gothic Neo"/>
-              </a:defRPr>
-            </a:defPPr>
-          </a:lstStyle>
-          <a:p xmlns:a="http://schemas.openxmlformats.org/drawingml/2006/main">
-            <a:pPr algn="l">
-              <a:defRPr sz="1800" b="0">
-                <a:solidFill>
-                  <a:srgbClr val="AFB6BC"/>
-                </a:solidFill>
-                <a:latin typeface="Apple SD Gothic Neo"/>
-                <a:ea typeface="Apple SD Gothic Neo"/>
-                <a:cs typeface="Apple SD Gothic Neo"/>
-              </a:defRPr>
-            </a:pPr>
-            <a:r>
-              <a:rPr sz="1800" b="0">
-                <a:solidFill>
-                  <a:srgbClr val="AFB6BC"/>
-                </a:solidFill>
-                <a:latin typeface="Apple SD Gothic Neo"/>
-                <a:ea typeface="Apple SD Gothic Neo"/>
-                <a:cs typeface="Apple SD Gothic Neo"/>
-              </a:rPr>
               <a:t>목표는? 장애물은? 그럼에도 해결할 방법은? 언제까지 무엇을 할지 약속하고 지킨다.</a:t>
             </a:r>
           </a:p>
@@ -16101,10 +16441,10 @@
       </p:sp>
       <p:sp>
         <p:nvSpPr>
-          <p:cNvPr id="15" name="">
-            <a:extLst xmlns:a="http://schemas.openxmlformats.org/drawingml/2006/main">
-              <a:ext uri="{FF2B5EF4-FFF2-40B4-BE49-F238E27FC236}">
-                <a16:creationId xmlns:a16="http://schemas.microsoft.com/office/drawing/2014/main" id="{9F93A989-1288-4AD9-B6AC-A8E07962CD18}"/>
+          <p:cNvPr id="20" name="">
+            <a:extLst xmlns:a="http://schemas.openxmlformats.org/drawingml/2006/main">
+              <a:ext uri="{FF2B5EF4-FFF2-40B4-BE49-F238E27FC236}">
+                <a16:creationId xmlns:a16="http://schemas.microsoft.com/office/drawing/2014/main" id="{A1AF369E-67D5-427B-B68E-5DD5E9D9491A}"/>
               </a:ext>
             </a:extLst>
           </p:cNvPr>
@@ -16170,7 +16510,7 @@
     </p:spTree>
     <p:extLst>
       <p:ext uri="{BB962C8B-B14F-4D97-AF65-F5344CB8AC3E}">
-        <p14:creationId xmlns:p14="http://schemas.microsoft.com/office/powerpoint/2010/main" val="154041786"/>
+        <p14:creationId xmlns:p14="http://schemas.microsoft.com/office/powerpoint/2010/main" val="1385201141"/>
       </p:ext>
     </p:extLst>
   </p:cSld>
@@ -16201,7 +16541,7 @@
           <p:cNvPr id="18" name="">
             <a:extLst xmlns:a="http://schemas.openxmlformats.org/drawingml/2006/main">
               <a:ext uri="{FF2B5EF4-FFF2-40B4-BE49-F238E27FC236}">
-                <a16:creationId xmlns:a16="http://schemas.microsoft.com/office/drawing/2014/main" id="{26E39644-5D59-4191-8CCC-130D9551B854}"/>
+                <a16:creationId xmlns:a16="http://schemas.microsoft.com/office/drawing/2014/main" id="{2FE0F4B9-62F5-4563-AE8E-27C3DE53516E}"/>
               </a:ext>
             </a:extLst>
           </p:cNvPr>
@@ -16269,7 +16609,7 @@
           <p:cNvPr id="2" name="">
             <a:extLst xmlns:a="http://schemas.openxmlformats.org/drawingml/2006/main">
               <a:ext uri="{FF2B5EF4-FFF2-40B4-BE49-F238E27FC236}">
-                <a16:creationId xmlns:a16="http://schemas.microsoft.com/office/drawing/2014/main" id="{A9816FE3-49B9-41D4-8635-23ACACBBC8BD}"/>
+                <a16:creationId xmlns:a16="http://schemas.microsoft.com/office/drawing/2014/main" id="{F4460611-89D4-4E3B-9242-3D549E4055A5}"/>
               </a:ext>
             </a:extLst>
           </p:cNvPr>
@@ -16337,7 +16677,7 @@
           <p:cNvPr id="3" name="">
             <a:extLst xmlns:a="http://schemas.openxmlformats.org/drawingml/2006/main">
               <a:ext uri="{FF2B5EF4-FFF2-40B4-BE49-F238E27FC236}">
-                <a16:creationId xmlns:a16="http://schemas.microsoft.com/office/drawing/2014/main" id="{55EDBD21-A696-481A-908E-0847A002A133}"/>
+                <a16:creationId xmlns:a16="http://schemas.microsoft.com/office/drawing/2014/main" id="{1785F148-CA03-4E19-A6D0-BCE2C74381C1}"/>
               </a:ext>
             </a:extLst>
           </p:cNvPr>
@@ -16405,7 +16745,7 @@
           <p:cNvPr id="4" name="">
             <a:extLst xmlns:a="http://schemas.openxmlformats.org/drawingml/2006/main">
               <a:ext uri="{FF2B5EF4-FFF2-40B4-BE49-F238E27FC236}">
-                <a16:creationId xmlns:a16="http://schemas.microsoft.com/office/drawing/2014/main" id="{93AB7FAA-FA17-4762-8F3B-7E15A1661384}"/>
+                <a16:creationId xmlns:a16="http://schemas.microsoft.com/office/drawing/2014/main" id="{DC87CA01-46FA-4197-9B19-0C8A1991894E}"/>
               </a:ext>
             </a:extLst>
           </p:cNvPr>
@@ -16435,7 +16775,7 @@
           <p:cNvPr id="5" name="">
             <a:extLst xmlns:a="http://schemas.openxmlformats.org/drawingml/2006/main">
               <a:ext uri="{FF2B5EF4-FFF2-40B4-BE49-F238E27FC236}">
-                <a16:creationId xmlns:a16="http://schemas.microsoft.com/office/drawing/2014/main" id="{15DF39C6-F3A4-47ED-ACB0-BD33C4749766}"/>
+                <a16:creationId xmlns:a16="http://schemas.microsoft.com/office/drawing/2014/main" id="{02F804B6-5988-4BBE-8079-5037E1450064}"/>
               </a:ext>
             </a:extLst>
           </p:cNvPr>
@@ -16503,7 +16843,7 @@
           <p:cNvPr id="6" name="">
             <a:extLst xmlns:a="http://schemas.openxmlformats.org/drawingml/2006/main">
               <a:ext uri="{FF2B5EF4-FFF2-40B4-BE49-F238E27FC236}">
-                <a16:creationId xmlns:a16="http://schemas.microsoft.com/office/drawing/2014/main" id="{52154977-F34A-4010-9491-6AE1223D27A7}"/>
+                <a16:creationId xmlns:a16="http://schemas.microsoft.com/office/drawing/2014/main" id="{16E3C9BC-A18A-45C2-BD81-7282CE7DE9BC}"/>
               </a:ext>
             </a:extLst>
           </p:cNvPr>
@@ -16571,7 +16911,7 @@
           <p:cNvPr id="7" name="">
             <a:extLst xmlns:a="http://schemas.openxmlformats.org/drawingml/2006/main">
               <a:ext uri="{FF2B5EF4-FFF2-40B4-BE49-F238E27FC236}">
-                <a16:creationId xmlns:a16="http://schemas.microsoft.com/office/drawing/2014/main" id="{5EA71610-2857-4017-A6DA-833A7B868555}"/>
+                <a16:creationId xmlns:a16="http://schemas.microsoft.com/office/drawing/2014/main" id="{3B06325C-2F18-402B-8D3A-DFAC07B0BED9}"/>
               </a:ext>
             </a:extLst>
           </p:cNvPr>
@@ -16662,7 +17002,7 @@
           <p:cNvPr id="8" name="">
             <a:extLst xmlns:a="http://schemas.openxmlformats.org/drawingml/2006/main">
               <a:ext uri="{FF2B5EF4-FFF2-40B4-BE49-F238E27FC236}">
-                <a16:creationId xmlns:a16="http://schemas.microsoft.com/office/drawing/2014/main" id="{7AC0AAFB-C2A8-4136-A5FA-7915558C72BA}"/>
+                <a16:creationId xmlns:a16="http://schemas.microsoft.com/office/drawing/2014/main" id="{0ACC4EE7-970F-406A-A815-09D6A72BAB8A}"/>
               </a:ext>
             </a:extLst>
           </p:cNvPr>
@@ -16692,7 +17032,7 @@
           <p:cNvPr id="9" name="">
             <a:extLst xmlns:a="http://schemas.openxmlformats.org/drawingml/2006/main">
               <a:ext uri="{FF2B5EF4-FFF2-40B4-BE49-F238E27FC236}">
-                <a16:creationId xmlns:a16="http://schemas.microsoft.com/office/drawing/2014/main" id="{028731BE-AA27-42BC-B8B3-59E25667386C}"/>
+                <a16:creationId xmlns:a16="http://schemas.microsoft.com/office/drawing/2014/main" id="{EDB39543-204A-499F-B118-C3696CA970CB}"/>
               </a:ext>
             </a:extLst>
           </p:cNvPr>
@@ -16760,7 +17100,7 @@
           <p:cNvPr id="10" name="">
             <a:extLst xmlns:a="http://schemas.openxmlformats.org/drawingml/2006/main">
               <a:ext uri="{FF2B5EF4-FFF2-40B4-BE49-F238E27FC236}">
-                <a16:creationId xmlns:a16="http://schemas.microsoft.com/office/drawing/2014/main" id="{6B35A69E-2954-4126-9122-C7CA2342A3FF}"/>
+                <a16:creationId xmlns:a16="http://schemas.microsoft.com/office/drawing/2014/main" id="{C5DB35B7-A8DA-41C1-87FF-85858D4E803E}"/>
               </a:ext>
             </a:extLst>
           </p:cNvPr>
@@ -16828,7 +17168,7 @@
           <p:cNvPr id="11" name="">
             <a:extLst xmlns:a="http://schemas.openxmlformats.org/drawingml/2006/main">
               <a:ext uri="{FF2B5EF4-FFF2-40B4-BE49-F238E27FC236}">
-                <a16:creationId xmlns:a16="http://schemas.microsoft.com/office/drawing/2014/main" id="{178C1D97-CFE8-4BE3-A091-FD71A660AA1E}"/>
+                <a16:creationId xmlns:a16="http://schemas.microsoft.com/office/drawing/2014/main" id="{0BB13AFA-5C29-45E1-BDE7-C17470A974D5}"/>
               </a:ext>
             </a:extLst>
           </p:cNvPr>
@@ -16919,7 +17259,7 @@
           <p:cNvPr id="12" name="">
             <a:extLst xmlns:a="http://schemas.openxmlformats.org/drawingml/2006/main">
               <a:ext uri="{FF2B5EF4-FFF2-40B4-BE49-F238E27FC236}">
-                <a16:creationId xmlns:a16="http://schemas.microsoft.com/office/drawing/2014/main" id="{27E017E8-836D-418C-A7EC-D8452266B672}"/>
+                <a16:creationId xmlns:a16="http://schemas.microsoft.com/office/drawing/2014/main" id="{CAF2360A-4980-4124-9D92-194BC43AA8E3}"/>
               </a:ext>
             </a:extLst>
           </p:cNvPr>
@@ -16949,7 +17289,7 @@
           <p:cNvPr id="13" name="">
             <a:extLst xmlns:a="http://schemas.openxmlformats.org/drawingml/2006/main">
               <a:ext uri="{FF2B5EF4-FFF2-40B4-BE49-F238E27FC236}">
-                <a16:creationId xmlns:a16="http://schemas.microsoft.com/office/drawing/2014/main" id="{9DA73015-4591-4373-A206-A9D9D749482C}"/>
+                <a16:creationId xmlns:a16="http://schemas.microsoft.com/office/drawing/2014/main" id="{456D2900-0CD8-47A7-9E2E-271EC195A22B}"/>
               </a:ext>
             </a:extLst>
           </p:cNvPr>
@@ -17017,7 +17357,7 @@
           <p:cNvPr id="14" name="">
             <a:extLst xmlns:a="http://schemas.openxmlformats.org/drawingml/2006/main">
               <a:ext uri="{FF2B5EF4-FFF2-40B4-BE49-F238E27FC236}">
-                <a16:creationId xmlns:a16="http://schemas.microsoft.com/office/drawing/2014/main" id="{D1F63CFA-F346-401E-8A1B-751DD1AB49F1}"/>
+                <a16:creationId xmlns:a16="http://schemas.microsoft.com/office/drawing/2014/main" id="{EC7FBD57-C476-4E49-8A64-4B2BDC3933F9}"/>
               </a:ext>
             </a:extLst>
           </p:cNvPr>
@@ -17085,7 +17425,7 @@
           <p:cNvPr id="15" name="">
             <a:extLst xmlns:a="http://schemas.openxmlformats.org/drawingml/2006/main">
               <a:ext uri="{FF2B5EF4-FFF2-40B4-BE49-F238E27FC236}">
-                <a16:creationId xmlns:a16="http://schemas.microsoft.com/office/drawing/2014/main" id="{5EC35639-A90D-4D6A-BD39-2C5197AA9E78}"/>
+                <a16:creationId xmlns:a16="http://schemas.microsoft.com/office/drawing/2014/main" id="{816D918F-41CC-466F-BC69-7AE05159F639}"/>
               </a:ext>
             </a:extLst>
           </p:cNvPr>
@@ -17176,7 +17516,7 @@
           <p:cNvPr id="16" name="">
             <a:extLst xmlns:a="http://schemas.openxmlformats.org/drawingml/2006/main">
               <a:ext uri="{FF2B5EF4-FFF2-40B4-BE49-F238E27FC236}">
-                <a16:creationId xmlns:a16="http://schemas.microsoft.com/office/drawing/2014/main" id="{BC87A9AA-2AFA-452F-B602-EA77D97C9F44}"/>
+                <a16:creationId xmlns:a16="http://schemas.microsoft.com/office/drawing/2014/main" id="{99A56B74-4CB1-4D8C-9CB7-FDBFBE4CADC4}"/>
               </a:ext>
             </a:extLst>
           </p:cNvPr>
@@ -17244,7 +17584,7 @@
           <p:cNvPr id="17" name="">
             <a:extLst xmlns:a="http://schemas.openxmlformats.org/drawingml/2006/main">
               <a:ext uri="{FF2B5EF4-FFF2-40B4-BE49-F238E27FC236}">
-                <a16:creationId xmlns:a16="http://schemas.microsoft.com/office/drawing/2014/main" id="{45B70054-6543-4B1B-AA66-DA54DA45614E}"/>
+                <a16:creationId xmlns:a16="http://schemas.microsoft.com/office/drawing/2014/main" id="{8C55BB19-F194-4DCF-88BF-137AE7B5AC73}"/>
               </a:ext>
             </a:extLst>
           </p:cNvPr>
@@ -17310,7 +17650,7 @@
     </p:spTree>
     <p:extLst>
       <p:ext uri="{BB962C8B-B14F-4D97-AF65-F5344CB8AC3E}">
-        <p14:creationId xmlns:p14="http://schemas.microsoft.com/office/powerpoint/2010/main" val="1366420311"/>
+        <p14:creationId xmlns:p14="http://schemas.microsoft.com/office/powerpoint/2010/main" val="1034289818"/>
       </p:ext>
     </p:extLst>
   </p:cSld>
@@ -17341,7 +17681,7 @@
           <p:cNvPr id="16" name="">
             <a:extLst xmlns:a="http://schemas.openxmlformats.org/drawingml/2006/main">
               <a:ext uri="{FF2B5EF4-FFF2-40B4-BE49-F238E27FC236}">
-                <a16:creationId xmlns:a16="http://schemas.microsoft.com/office/drawing/2014/main" id="{0D3DEF94-ABB8-49A4-AF98-CAAAFDE76AEE}"/>
+                <a16:creationId xmlns:a16="http://schemas.microsoft.com/office/drawing/2014/main" id="{286B345A-E9A4-4EE3-832E-11982C2ABF08}"/>
               </a:ext>
             </a:extLst>
           </p:cNvPr>
@@ -17351,7 +17691,7 @@
           <p:nvPr/>
         </p:nvPicPr>
         <p:blipFill>
-          <a:blip xmlns:r="http://schemas.openxmlformats.org/officeDocument/2006/relationships" xmlns:a="http://schemas.openxmlformats.org/drawingml/2006/main" r:embed="Rf584fe7507d4473d"/>
+          <a:blip xmlns:r="http://schemas.openxmlformats.org/officeDocument/2006/relationships" xmlns:a="http://schemas.openxmlformats.org/drawingml/2006/main" r:embed="R7bb01c174d6d43f8"/>
           <a:srcRect xmlns:a="http://schemas.openxmlformats.org/drawingml/2006/main" l="0" t="0" r="0" b="0"/>
           <a:stretch xmlns:a="http://schemas.openxmlformats.org/drawingml/2006/main">
             <a:fillRect l="0" t="0" r="0" b="0"/>
@@ -17372,7 +17712,7 @@
           <p:cNvPr id="2" name="">
             <a:extLst xmlns:a="http://schemas.openxmlformats.org/drawingml/2006/main">
               <a:ext uri="{FF2B5EF4-FFF2-40B4-BE49-F238E27FC236}">
-                <a16:creationId xmlns:a16="http://schemas.microsoft.com/office/drawing/2014/main" id="{5379CF55-50B2-4A48-A5A4-0EE2BDBAEB73}"/>
+                <a16:creationId xmlns:a16="http://schemas.microsoft.com/office/drawing/2014/main" id="{2E3D264A-26E5-46C7-8D8C-CAD9C6859A36}"/>
               </a:ext>
             </a:extLst>
           </p:cNvPr>
@@ -17440,7 +17780,7 @@
           <p:cNvPr id="3" name="">
             <a:extLst xmlns:a="http://schemas.openxmlformats.org/drawingml/2006/main">
               <a:ext uri="{FF2B5EF4-FFF2-40B4-BE49-F238E27FC236}">
-                <a16:creationId xmlns:a16="http://schemas.microsoft.com/office/drawing/2014/main" id="{CECA6625-1287-4519-B8CF-1601BB6C2EFF}"/>
+                <a16:creationId xmlns:a16="http://schemas.microsoft.com/office/drawing/2014/main" id="{72D8FB2D-4100-4225-9CA5-E30768A4F09A}"/>
               </a:ext>
             </a:extLst>
           </p:cNvPr>
@@ -17508,7 +17848,7 @@
           <p:cNvPr id="4" name="">
             <a:extLst xmlns:a="http://schemas.openxmlformats.org/drawingml/2006/main">
               <a:ext uri="{FF2B5EF4-FFF2-40B4-BE49-F238E27FC236}">
-                <a16:creationId xmlns:a16="http://schemas.microsoft.com/office/drawing/2014/main" id="{76848F49-DD12-4612-8FD9-62EE0DA94A32}"/>
+                <a16:creationId xmlns:a16="http://schemas.microsoft.com/office/drawing/2014/main" id="{6B272FB6-7CED-4B31-B6C1-1878EEE63320}"/>
               </a:ext>
             </a:extLst>
           </p:cNvPr>
@@ -17576,7 +17916,7 @@
           <p:cNvPr id="5" name="">
             <a:extLst xmlns:a="http://schemas.openxmlformats.org/drawingml/2006/main">
               <a:ext uri="{FF2B5EF4-FFF2-40B4-BE49-F238E27FC236}">
-                <a16:creationId xmlns:a16="http://schemas.microsoft.com/office/drawing/2014/main" id="{16E7DF26-2A3B-4536-A134-0C219A266A9A}"/>
+                <a16:creationId xmlns:a16="http://schemas.microsoft.com/office/drawing/2014/main" id="{38EB4074-2E1A-4DCC-B820-2857759CB015}"/>
               </a:ext>
             </a:extLst>
           </p:cNvPr>
@@ -17644,7 +17984,7 @@
           <p:cNvPr id="6" name="">
             <a:extLst xmlns:a="http://schemas.openxmlformats.org/drawingml/2006/main">
               <a:ext uri="{FF2B5EF4-FFF2-40B4-BE49-F238E27FC236}">
-                <a16:creationId xmlns:a16="http://schemas.microsoft.com/office/drawing/2014/main" id="{A32B0434-A605-4052-A522-3B1A43DAE1B4}"/>
+                <a16:creationId xmlns:a16="http://schemas.microsoft.com/office/drawing/2014/main" id="{1EC0A006-58BC-4A04-82CC-7FC20EE92DDE}"/>
               </a:ext>
             </a:extLst>
           </p:cNvPr>
@@ -17712,7 +18052,7 @@
           <p:cNvPr id="7" name="">
             <a:extLst xmlns:a="http://schemas.openxmlformats.org/drawingml/2006/main">
               <a:ext uri="{FF2B5EF4-FFF2-40B4-BE49-F238E27FC236}">
-                <a16:creationId xmlns:a16="http://schemas.microsoft.com/office/drawing/2014/main" id="{E8B48A51-9A1D-41E2-A79F-3DE87BE94638}"/>
+                <a16:creationId xmlns:a16="http://schemas.microsoft.com/office/drawing/2014/main" id="{19A62F12-C2C2-44C7-BC41-ABE6955C4E8E}"/>
               </a:ext>
             </a:extLst>
           </p:cNvPr>
@@ -17803,7 +18143,7 @@
           <p:cNvPr id="8" name="">
             <a:extLst xmlns:a="http://schemas.openxmlformats.org/drawingml/2006/main">
               <a:ext uri="{FF2B5EF4-FFF2-40B4-BE49-F238E27FC236}">
-                <a16:creationId xmlns:a16="http://schemas.microsoft.com/office/drawing/2014/main" id="{84BFE51F-0315-462A-99AA-21EB174DEF25}"/>
+                <a16:creationId xmlns:a16="http://schemas.microsoft.com/office/drawing/2014/main" id="{A41C70AF-BF83-48CA-941C-F7C074DA3664}"/>
               </a:ext>
             </a:extLst>
           </p:cNvPr>
@@ -17871,7 +18211,7 @@
           <p:cNvPr id="9" name="">
             <a:extLst xmlns:a="http://schemas.openxmlformats.org/drawingml/2006/main">
               <a:ext uri="{FF2B5EF4-FFF2-40B4-BE49-F238E27FC236}">
-                <a16:creationId xmlns:a16="http://schemas.microsoft.com/office/drawing/2014/main" id="{B75B87F9-F431-435C-90D7-6480D3FA1875}"/>
+                <a16:creationId xmlns:a16="http://schemas.microsoft.com/office/drawing/2014/main" id="{B5D6544A-03D2-4543-B359-E464FB9DE1F9}"/>
               </a:ext>
             </a:extLst>
           </p:cNvPr>
@@ -17939,7 +18279,7 @@
           <p:cNvPr id="10" name="">
             <a:extLst xmlns:a="http://schemas.openxmlformats.org/drawingml/2006/main">
               <a:ext uri="{FF2B5EF4-FFF2-40B4-BE49-F238E27FC236}">
-                <a16:creationId xmlns:a16="http://schemas.microsoft.com/office/drawing/2014/main" id="{AAB15611-224F-4850-9783-0592E5F26AAB}"/>
+                <a16:creationId xmlns:a16="http://schemas.microsoft.com/office/drawing/2014/main" id="{6D78A039-6921-4E5D-AC2F-045860DA6672}"/>
               </a:ext>
             </a:extLst>
           </p:cNvPr>
@@ -18030,7 +18370,7 @@
           <p:cNvPr id="11" name="">
             <a:extLst xmlns:a="http://schemas.openxmlformats.org/drawingml/2006/main">
               <a:ext uri="{FF2B5EF4-FFF2-40B4-BE49-F238E27FC236}">
-                <a16:creationId xmlns:a16="http://schemas.microsoft.com/office/drawing/2014/main" id="{61834C42-138D-41C3-8C08-2E524A71B4C2}"/>
+                <a16:creationId xmlns:a16="http://schemas.microsoft.com/office/drawing/2014/main" id="{82A895A3-9C6E-4339-BCE6-7EC340E700C9}"/>
               </a:ext>
             </a:extLst>
           </p:cNvPr>
@@ -18098,7 +18438,7 @@
           <p:cNvPr id="12" name="">
             <a:extLst xmlns:a="http://schemas.openxmlformats.org/drawingml/2006/main">
               <a:ext uri="{FF2B5EF4-FFF2-40B4-BE49-F238E27FC236}">
-                <a16:creationId xmlns:a16="http://schemas.microsoft.com/office/drawing/2014/main" id="{52576BBC-2E4B-4434-8D26-DEA9F0B58B20}"/>
+                <a16:creationId xmlns:a16="http://schemas.microsoft.com/office/drawing/2014/main" id="{23CF5BB1-A670-4CCB-93F1-8B5ADB51BE95}"/>
               </a:ext>
             </a:extLst>
           </p:cNvPr>
@@ -18166,7 +18506,7 @@
           <p:cNvPr id="13" name="">
             <a:extLst xmlns:a="http://schemas.openxmlformats.org/drawingml/2006/main">
               <a:ext uri="{FF2B5EF4-FFF2-40B4-BE49-F238E27FC236}">
-                <a16:creationId xmlns:a16="http://schemas.microsoft.com/office/drawing/2014/main" id="{42797150-A3FB-4025-8034-B68BF66F75FD}"/>
+                <a16:creationId xmlns:a16="http://schemas.microsoft.com/office/drawing/2014/main" id="{DE469602-1C3E-4C5C-8CD2-07DB2693F1AB}"/>
               </a:ext>
             </a:extLst>
           </p:cNvPr>
@@ -18257,7 +18597,7 @@
           <p:cNvPr id="14" name="">
             <a:extLst xmlns:a="http://schemas.openxmlformats.org/drawingml/2006/main">
               <a:ext uri="{FF2B5EF4-FFF2-40B4-BE49-F238E27FC236}">
-                <a16:creationId xmlns:a16="http://schemas.microsoft.com/office/drawing/2014/main" id="{485DF632-7724-40AB-B863-B24031E3E70F}"/>
+                <a16:creationId xmlns:a16="http://schemas.microsoft.com/office/drawing/2014/main" id="{0649E337-E36D-4D47-A0DD-F0851D9F06DB}"/>
               </a:ext>
             </a:extLst>
           </p:cNvPr>
@@ -18325,7 +18665,7 @@
           <p:cNvPr id="15" name="">
             <a:extLst xmlns:a="http://schemas.openxmlformats.org/drawingml/2006/main">
               <a:ext uri="{FF2B5EF4-FFF2-40B4-BE49-F238E27FC236}">
-                <a16:creationId xmlns:a16="http://schemas.microsoft.com/office/drawing/2014/main" id="{748BECAA-C648-40BC-BB94-386C5D3448C9}"/>
+                <a16:creationId xmlns:a16="http://schemas.microsoft.com/office/drawing/2014/main" id="{FB7BC5AF-19B7-4215-84AB-A32B9E09DB03}"/>
               </a:ext>
             </a:extLst>
           </p:cNvPr>
@@ -18391,7 +18731,7 @@
     </p:spTree>
     <p:extLst>
       <p:ext uri="{BB962C8B-B14F-4D97-AF65-F5344CB8AC3E}">
-        <p14:creationId xmlns:p14="http://schemas.microsoft.com/office/powerpoint/2010/main" val="1950736466"/>
+        <p14:creationId xmlns:p14="http://schemas.microsoft.com/office/powerpoint/2010/main" val="613379764"/>
       </p:ext>
     </p:extLst>
   </p:cSld>
@@ -18422,7 +18762,7 @@
           <p:cNvPr id="18" name="">
             <a:extLst xmlns:a="http://schemas.openxmlformats.org/drawingml/2006/main">
               <a:ext uri="{FF2B5EF4-FFF2-40B4-BE49-F238E27FC236}">
-                <a16:creationId xmlns:a16="http://schemas.microsoft.com/office/drawing/2014/main" id="{6A70AFE4-BCCA-4066-9793-1D0CDB2205AF}"/>
+                <a16:creationId xmlns:a16="http://schemas.microsoft.com/office/drawing/2014/main" id="{D05DB647-1B57-4D08-80DD-40E455C7E9A9}"/>
               </a:ext>
             </a:extLst>
           </p:cNvPr>
@@ -18490,7 +18830,7 @@
           <p:cNvPr id="2" name="">
             <a:extLst xmlns:a="http://schemas.openxmlformats.org/drawingml/2006/main">
               <a:ext uri="{FF2B5EF4-FFF2-40B4-BE49-F238E27FC236}">
-                <a16:creationId xmlns:a16="http://schemas.microsoft.com/office/drawing/2014/main" id="{DC613B03-E138-4681-BB4E-E64033ADC7E2}"/>
+                <a16:creationId xmlns:a16="http://schemas.microsoft.com/office/drawing/2014/main" id="{C90851D2-CEEB-4A3F-B799-DAE8301B3C13}"/>
               </a:ext>
             </a:extLst>
           </p:cNvPr>
@@ -18558,7 +18898,7 @@
           <p:cNvPr id="3" name="">
             <a:extLst xmlns:a="http://schemas.openxmlformats.org/drawingml/2006/main">
               <a:ext uri="{FF2B5EF4-FFF2-40B4-BE49-F238E27FC236}">
-                <a16:creationId xmlns:a16="http://schemas.microsoft.com/office/drawing/2014/main" id="{15329A90-28A0-4492-922B-A00FFDBE3DDB}"/>
+                <a16:creationId xmlns:a16="http://schemas.microsoft.com/office/drawing/2014/main" id="{2CF51346-E636-497F-8379-494244BC6007}"/>
               </a:ext>
             </a:extLst>
           </p:cNvPr>
@@ -18626,7 +18966,7 @@
           <p:cNvPr id="4" name="">
             <a:extLst xmlns:a="http://schemas.openxmlformats.org/drawingml/2006/main">
               <a:ext uri="{FF2B5EF4-FFF2-40B4-BE49-F238E27FC236}">
-                <a16:creationId xmlns:a16="http://schemas.microsoft.com/office/drawing/2014/main" id="{2DFFB244-73C1-495E-AD48-4B2C3C49E180}"/>
+                <a16:creationId xmlns:a16="http://schemas.microsoft.com/office/drawing/2014/main" id="{BEAFDD8B-6BA2-447E-B511-B99EE60E687D}"/>
               </a:ext>
             </a:extLst>
           </p:cNvPr>
@@ -18636,7 +18976,7 @@
           <p:nvPr/>
         </p:nvPicPr>
         <p:blipFill>
-          <a:blip xmlns:r="http://schemas.openxmlformats.org/officeDocument/2006/relationships" xmlns:a="http://schemas.openxmlformats.org/drawingml/2006/main" r:embed="R0f3a01af16404cba"/>
+          <a:blip xmlns:r="http://schemas.openxmlformats.org/officeDocument/2006/relationships" xmlns:a="http://schemas.openxmlformats.org/drawingml/2006/main" r:embed="R8f89bbcd0474421f"/>
           <a:stretch xmlns:a="http://schemas.openxmlformats.org/drawingml/2006/main"/>
         </p:blipFill>
         <p:spPr>
@@ -18654,7 +18994,7 @@
           <p:cNvPr id="5" name="">
             <a:extLst xmlns:a="http://schemas.openxmlformats.org/drawingml/2006/main">
               <a:ext uri="{FF2B5EF4-FFF2-40B4-BE49-F238E27FC236}">
-                <a16:creationId xmlns:a16="http://schemas.microsoft.com/office/drawing/2014/main" id="{B72D30CC-13FB-499F-847D-5B9AE8582E40}"/>
+                <a16:creationId xmlns:a16="http://schemas.microsoft.com/office/drawing/2014/main" id="{4C5327CC-F110-4325-AF67-FF89CF8C3CF0}"/>
               </a:ext>
             </a:extLst>
           </p:cNvPr>
@@ -18722,7 +19062,7 @@
           <p:cNvPr id="6" name="">
             <a:extLst xmlns:a="http://schemas.openxmlformats.org/drawingml/2006/main">
               <a:ext uri="{FF2B5EF4-FFF2-40B4-BE49-F238E27FC236}">
-                <a16:creationId xmlns:a16="http://schemas.microsoft.com/office/drawing/2014/main" id="{20D84DEB-D09F-4B1B-8321-235472FE5B73}"/>
+                <a16:creationId xmlns:a16="http://schemas.microsoft.com/office/drawing/2014/main" id="{411C1EEE-1BB7-4CCC-A574-DFF5DF7D3D1D}"/>
               </a:ext>
             </a:extLst>
           </p:cNvPr>
@@ -18790,7 +19130,7 @@
           <p:cNvPr id="7" name="">
             <a:extLst xmlns:a="http://schemas.openxmlformats.org/drawingml/2006/main">
               <a:ext uri="{FF2B5EF4-FFF2-40B4-BE49-F238E27FC236}">
-                <a16:creationId xmlns:a16="http://schemas.microsoft.com/office/drawing/2014/main" id="{A5BC2389-D6A7-439B-921C-DA1577FEE6F0}"/>
+                <a16:creationId xmlns:a16="http://schemas.microsoft.com/office/drawing/2014/main" id="{A00E3489-4326-48CF-AA67-3D1BD14B5745}"/>
               </a:ext>
             </a:extLst>
           </p:cNvPr>
@@ -18881,7 +19221,7 @@
           <p:cNvPr id="8" name="">
             <a:extLst xmlns:a="http://schemas.openxmlformats.org/drawingml/2006/main">
               <a:ext uri="{FF2B5EF4-FFF2-40B4-BE49-F238E27FC236}">
-                <a16:creationId xmlns:a16="http://schemas.microsoft.com/office/drawing/2014/main" id="{DE438019-533F-4AF1-85DA-906B19ABC259}"/>
+                <a16:creationId xmlns:a16="http://schemas.microsoft.com/office/drawing/2014/main" id="{1CC5A00B-5E9F-403D-A894-9FD5EDA2BBAF}"/>
               </a:ext>
             </a:extLst>
           </p:cNvPr>
@@ -18891,7 +19231,7 @@
           <p:nvPr/>
         </p:nvPicPr>
         <p:blipFill>
-          <a:blip xmlns:r="http://schemas.openxmlformats.org/officeDocument/2006/relationships" xmlns:a="http://schemas.openxmlformats.org/drawingml/2006/main" r:embed="R3a09deb9326e43b1"/>
+          <a:blip xmlns:r="http://schemas.openxmlformats.org/officeDocument/2006/relationships" xmlns:a="http://schemas.openxmlformats.org/drawingml/2006/main" r:embed="Rf345c1320a7a46a8"/>
           <a:stretch xmlns:a="http://schemas.openxmlformats.org/drawingml/2006/main"/>
         </p:blipFill>
         <p:spPr>
@@ -18909,7 +19249,7 @@
           <p:cNvPr id="9" name="">
             <a:extLst xmlns:a="http://schemas.openxmlformats.org/drawingml/2006/main">
               <a:ext uri="{FF2B5EF4-FFF2-40B4-BE49-F238E27FC236}">
-                <a16:creationId xmlns:a16="http://schemas.microsoft.com/office/drawing/2014/main" id="{28A8B024-F212-4E4F-B0DF-920DDD37A27D}"/>
+                <a16:creationId xmlns:a16="http://schemas.microsoft.com/office/drawing/2014/main" id="{6A359EB9-CD43-4870-9571-B3FED44DD92A}"/>
               </a:ext>
             </a:extLst>
           </p:cNvPr>
@@ -18977,7 +19317,7 @@
           <p:cNvPr id="10" name="">
             <a:extLst xmlns:a="http://schemas.openxmlformats.org/drawingml/2006/main">
               <a:ext uri="{FF2B5EF4-FFF2-40B4-BE49-F238E27FC236}">
-                <a16:creationId xmlns:a16="http://schemas.microsoft.com/office/drawing/2014/main" id="{09154500-DC5E-4AF8-B940-8AFBDE51D6FB}"/>
+                <a16:creationId xmlns:a16="http://schemas.microsoft.com/office/drawing/2014/main" id="{CB5AAA39-2388-4C5E-8B5D-5FB7B7D402C9}"/>
               </a:ext>
             </a:extLst>
           </p:cNvPr>
@@ -19045,7 +19385,7 @@
           <p:cNvPr id="11" name="">
             <a:extLst xmlns:a="http://schemas.openxmlformats.org/drawingml/2006/main">
               <a:ext uri="{FF2B5EF4-FFF2-40B4-BE49-F238E27FC236}">
-                <a16:creationId xmlns:a16="http://schemas.microsoft.com/office/drawing/2014/main" id="{6CA6B585-473F-4958-979F-07A663D0E75A}"/>
+                <a16:creationId xmlns:a16="http://schemas.microsoft.com/office/drawing/2014/main" id="{F5BDA9E5-BCD1-4093-8C96-643AA8AEFAC5}"/>
               </a:ext>
             </a:extLst>
           </p:cNvPr>
@@ -19136,7 +19476,7 @@
           <p:cNvPr id="12" name="">
             <a:extLst xmlns:a="http://schemas.openxmlformats.org/drawingml/2006/main">
               <a:ext uri="{FF2B5EF4-FFF2-40B4-BE49-F238E27FC236}">
-                <a16:creationId xmlns:a16="http://schemas.microsoft.com/office/drawing/2014/main" id="{B71640D0-E69A-48B7-8D25-E1CF7B4D8E25}"/>
+                <a16:creationId xmlns:a16="http://schemas.microsoft.com/office/drawing/2014/main" id="{8E35FF18-9BCF-4D11-BEAC-9EBE6FBA040B}"/>
               </a:ext>
             </a:extLst>
           </p:cNvPr>
@@ -19146,7 +19486,7 @@
           <p:nvPr/>
         </p:nvPicPr>
         <p:blipFill>
-          <a:blip xmlns:r="http://schemas.openxmlformats.org/officeDocument/2006/relationships" xmlns:a="http://schemas.openxmlformats.org/drawingml/2006/main" r:embed="R96170949a53a4201"/>
+          <a:blip xmlns:r="http://schemas.openxmlformats.org/officeDocument/2006/relationships" xmlns:a="http://schemas.openxmlformats.org/drawingml/2006/main" r:embed="R9133deda26cc4c4d"/>
           <a:stretch xmlns:a="http://schemas.openxmlformats.org/drawingml/2006/main"/>
         </p:blipFill>
         <p:spPr>
@@ -19164,7 +19504,7 @@
           <p:cNvPr id="13" name="">
             <a:extLst xmlns:a="http://schemas.openxmlformats.org/drawingml/2006/main">
               <a:ext uri="{FF2B5EF4-FFF2-40B4-BE49-F238E27FC236}">
-                <a16:creationId xmlns:a16="http://schemas.microsoft.com/office/drawing/2014/main" id="{14F1807B-4DDF-40E9-A4C7-2FB3AB7AE1B9}"/>
+                <a16:creationId xmlns:a16="http://schemas.microsoft.com/office/drawing/2014/main" id="{B08AB554-3D23-49C9-AE13-4B381204C491}"/>
               </a:ext>
             </a:extLst>
           </p:cNvPr>
@@ -19232,7 +19572,7 @@
           <p:cNvPr id="14" name="">
             <a:extLst xmlns:a="http://schemas.openxmlformats.org/drawingml/2006/main">
               <a:ext uri="{FF2B5EF4-FFF2-40B4-BE49-F238E27FC236}">
-                <a16:creationId xmlns:a16="http://schemas.microsoft.com/office/drawing/2014/main" id="{7C8CBFD0-E576-475F-B653-2040AEF93AAD}"/>
+                <a16:creationId xmlns:a16="http://schemas.microsoft.com/office/drawing/2014/main" id="{E58EE205-EB1D-410C-9A61-02A4CDBF9BB7}"/>
               </a:ext>
             </a:extLst>
           </p:cNvPr>
@@ -19300,7 +19640,7 @@
           <p:cNvPr id="15" name="">
             <a:extLst xmlns:a="http://schemas.openxmlformats.org/drawingml/2006/main">
               <a:ext uri="{FF2B5EF4-FFF2-40B4-BE49-F238E27FC236}">
-                <a16:creationId xmlns:a16="http://schemas.microsoft.com/office/drawing/2014/main" id="{932B3D10-6D9C-46A6-98C8-9CFDECA3E70E}"/>
+                <a16:creationId xmlns:a16="http://schemas.microsoft.com/office/drawing/2014/main" id="{8A48FA60-0E2A-4871-9DBD-705E1ADCB007}"/>
               </a:ext>
             </a:extLst>
           </p:cNvPr>
@@ -19391,7 +19731,7 @@
           <p:cNvPr id="16" name="">
             <a:extLst xmlns:a="http://schemas.openxmlformats.org/drawingml/2006/main">
               <a:ext uri="{FF2B5EF4-FFF2-40B4-BE49-F238E27FC236}">
-                <a16:creationId xmlns:a16="http://schemas.microsoft.com/office/drawing/2014/main" id="{1286B73D-71A2-47A3-8BC3-B3CF72CB8C07}"/>
+                <a16:creationId xmlns:a16="http://schemas.microsoft.com/office/drawing/2014/main" id="{4B0C7747-1231-4DD8-97A9-C6370BD3440C}"/>
               </a:ext>
             </a:extLst>
           </p:cNvPr>
@@ -19459,7 +19799,7 @@
           <p:cNvPr id="17" name="">
             <a:extLst xmlns:a="http://schemas.openxmlformats.org/drawingml/2006/main">
               <a:ext uri="{FF2B5EF4-FFF2-40B4-BE49-F238E27FC236}">
-                <a16:creationId xmlns:a16="http://schemas.microsoft.com/office/drawing/2014/main" id="{9C4430F3-6D7F-4CBC-B331-DEA2E71948E0}"/>
+                <a16:creationId xmlns:a16="http://schemas.microsoft.com/office/drawing/2014/main" id="{75782195-333F-42AA-968D-87E955BE694F}"/>
               </a:ext>
             </a:extLst>
           </p:cNvPr>
@@ -19525,7 +19865,7 @@
     </p:spTree>
     <p:extLst>
       <p:ext uri="{BB962C8B-B14F-4D97-AF65-F5344CB8AC3E}">
-        <p14:creationId xmlns:p14="http://schemas.microsoft.com/office/powerpoint/2010/main" val="784796439"/>
+        <p14:creationId xmlns:p14="http://schemas.microsoft.com/office/powerpoint/2010/main" val="491849480"/>
       </p:ext>
     </p:extLst>
   </p:cSld>
@@ -19556,7 +19896,7 @@
           <p:cNvPr id="12" name="">
             <a:extLst xmlns:a="http://schemas.openxmlformats.org/drawingml/2006/main">
               <a:ext uri="{FF2B5EF4-FFF2-40B4-BE49-F238E27FC236}">
-                <a16:creationId xmlns:a16="http://schemas.microsoft.com/office/drawing/2014/main" id="{7BFA6000-64AE-4E1F-9C8A-B9CFE79DF59D}"/>
+                <a16:creationId xmlns:a16="http://schemas.microsoft.com/office/drawing/2014/main" id="{F4B822DC-D3AA-40FF-95F8-B86F64D4D88C}"/>
               </a:ext>
             </a:extLst>
           </p:cNvPr>
@@ -19624,7 +19964,7 @@
           <p:cNvPr id="2" name="">
             <a:extLst xmlns:a="http://schemas.openxmlformats.org/drawingml/2006/main">
               <a:ext uri="{FF2B5EF4-FFF2-40B4-BE49-F238E27FC236}">
-                <a16:creationId xmlns:a16="http://schemas.microsoft.com/office/drawing/2014/main" id="{CD23BDFA-858B-4416-8EDC-22A1A1E0747A}"/>
+                <a16:creationId xmlns:a16="http://schemas.microsoft.com/office/drawing/2014/main" id="{C962B136-B994-4759-89F3-F229A3B59ADC}"/>
               </a:ext>
             </a:extLst>
           </p:cNvPr>
@@ -19692,7 +20032,7 @@
           <p:cNvPr id="3" name="">
             <a:extLst xmlns:a="http://schemas.openxmlformats.org/drawingml/2006/main">
               <a:ext uri="{FF2B5EF4-FFF2-40B4-BE49-F238E27FC236}">
-                <a16:creationId xmlns:a16="http://schemas.microsoft.com/office/drawing/2014/main" id="{710C47A3-3031-498C-8257-92E88539B315}"/>
+                <a16:creationId xmlns:a16="http://schemas.microsoft.com/office/drawing/2014/main" id="{9ECD8252-0868-4F53-9007-198ADFEC5797}"/>
               </a:ext>
             </a:extLst>
           </p:cNvPr>
@@ -19760,7 +20100,7 @@
           <p:cNvPr id="4" name="">
             <a:extLst xmlns:a="http://schemas.openxmlformats.org/drawingml/2006/main">
               <a:ext uri="{FF2B5EF4-FFF2-40B4-BE49-F238E27FC236}">
-                <a16:creationId xmlns:a16="http://schemas.microsoft.com/office/drawing/2014/main" id="{D3C6E888-379A-4EFA-96C7-499D26C4E14F}"/>
+                <a16:creationId xmlns:a16="http://schemas.microsoft.com/office/drawing/2014/main" id="{2E2B59BF-2807-4EFF-AAF3-3052C04E325A}"/>
               </a:ext>
             </a:extLst>
           </p:cNvPr>
@@ -19770,7 +20110,7 @@
           <p:nvPr/>
         </p:nvPicPr>
         <p:blipFill>
-          <a:blip xmlns:r="http://schemas.openxmlformats.org/officeDocument/2006/relationships" xmlns:a="http://schemas.openxmlformats.org/drawingml/2006/main" r:embed="Rcdf78bb1783e420f"/>
+          <a:blip xmlns:r="http://schemas.openxmlformats.org/officeDocument/2006/relationships" xmlns:a="http://schemas.openxmlformats.org/drawingml/2006/main" r:embed="Re326f45cd92b4be9"/>
           <a:stretch xmlns:a="http://schemas.openxmlformats.org/drawingml/2006/main"/>
         </p:blipFill>
         <p:spPr>
@@ -19788,7 +20128,7 @@
           <p:cNvPr id="5" name="">
             <a:extLst xmlns:a="http://schemas.openxmlformats.org/drawingml/2006/main">
               <a:ext uri="{FF2B5EF4-FFF2-40B4-BE49-F238E27FC236}">
-                <a16:creationId xmlns:a16="http://schemas.microsoft.com/office/drawing/2014/main" id="{ED6D6AC4-8D1D-4C04-B2C9-1DB871FF3B3B}"/>
+                <a16:creationId xmlns:a16="http://schemas.microsoft.com/office/drawing/2014/main" id="{58EB4196-1F5E-46DE-95D8-DC88A0FBD44E}"/>
               </a:ext>
             </a:extLst>
           </p:cNvPr>
@@ -19856,7 +20196,7 @@
           <p:cNvPr id="6" name="">
             <a:extLst xmlns:a="http://schemas.openxmlformats.org/drawingml/2006/main">
               <a:ext uri="{FF2B5EF4-FFF2-40B4-BE49-F238E27FC236}">
-                <a16:creationId xmlns:a16="http://schemas.microsoft.com/office/drawing/2014/main" id="{D11E5109-2DA5-49BE-B10F-B527007ACBE3}"/>
+                <a16:creationId xmlns:a16="http://schemas.microsoft.com/office/drawing/2014/main" id="{E7FEEB5E-80D1-454D-BA71-DB5F506DE00E}"/>
               </a:ext>
             </a:extLst>
           </p:cNvPr>
@@ -19947,7 +20287,7 @@
           <p:cNvPr id="7" name="">
             <a:extLst xmlns:a="http://schemas.openxmlformats.org/drawingml/2006/main">
               <a:ext uri="{FF2B5EF4-FFF2-40B4-BE49-F238E27FC236}">
-                <a16:creationId xmlns:a16="http://schemas.microsoft.com/office/drawing/2014/main" id="{FB5866E4-42B2-4F5B-B4E3-D1EFF9D50CFA}"/>
+                <a16:creationId xmlns:a16="http://schemas.microsoft.com/office/drawing/2014/main" id="{F32A3A38-A1E7-4254-831F-35339B4AE1E1}"/>
               </a:ext>
             </a:extLst>
           </p:cNvPr>
@@ -19957,7 +20297,7 @@
           <p:nvPr/>
         </p:nvPicPr>
         <p:blipFill>
-          <a:blip xmlns:r="http://schemas.openxmlformats.org/officeDocument/2006/relationships" xmlns:a="http://schemas.openxmlformats.org/drawingml/2006/main" r:embed="R70578a52dcb14651"/>
+          <a:blip xmlns:r="http://schemas.openxmlformats.org/officeDocument/2006/relationships" xmlns:a="http://schemas.openxmlformats.org/drawingml/2006/main" r:embed="R0907274362fe48a4"/>
           <a:stretch xmlns:a="http://schemas.openxmlformats.org/drawingml/2006/main"/>
         </p:blipFill>
         <p:spPr>
@@ -19975,7 +20315,7 @@
           <p:cNvPr id="8" name="">
             <a:extLst xmlns:a="http://schemas.openxmlformats.org/drawingml/2006/main">
               <a:ext uri="{FF2B5EF4-FFF2-40B4-BE49-F238E27FC236}">
-                <a16:creationId xmlns:a16="http://schemas.microsoft.com/office/drawing/2014/main" id="{DE65EEBA-684F-41BE-9CDE-5EB11E8C1375}"/>
+                <a16:creationId xmlns:a16="http://schemas.microsoft.com/office/drawing/2014/main" id="{2A17B95A-5D3B-4AEF-A662-5E4EE09C9D09}"/>
               </a:ext>
             </a:extLst>
           </p:cNvPr>
@@ -20043,7 +20383,7 @@
           <p:cNvPr id="9" name="">
             <a:extLst xmlns:a="http://schemas.openxmlformats.org/drawingml/2006/main">
               <a:ext uri="{FF2B5EF4-FFF2-40B4-BE49-F238E27FC236}">
-                <a16:creationId xmlns:a16="http://schemas.microsoft.com/office/drawing/2014/main" id="{8FD82271-23B4-466D-83B0-AA0F2D4F818D}"/>
+                <a16:creationId xmlns:a16="http://schemas.microsoft.com/office/drawing/2014/main" id="{E619766F-6B57-486E-A210-AA0601C995BD}"/>
               </a:ext>
             </a:extLst>
           </p:cNvPr>
@@ -20134,7 +20474,7 @@
           <p:cNvPr id="10" name="">
             <a:extLst xmlns:a="http://schemas.openxmlformats.org/drawingml/2006/main">
               <a:ext uri="{FF2B5EF4-FFF2-40B4-BE49-F238E27FC236}">
-                <a16:creationId xmlns:a16="http://schemas.microsoft.com/office/drawing/2014/main" id="{DAE742CD-20C7-43CF-9D79-E97E461FB4A3}"/>
+                <a16:creationId xmlns:a16="http://schemas.microsoft.com/office/drawing/2014/main" id="{4EEDC580-786C-451C-97DB-614070AE1789}"/>
               </a:ext>
             </a:extLst>
           </p:cNvPr>
@@ -20202,7 +20542,7 @@
           <p:cNvPr id="11" name="">
             <a:extLst xmlns:a="http://schemas.openxmlformats.org/drawingml/2006/main">
               <a:ext uri="{FF2B5EF4-FFF2-40B4-BE49-F238E27FC236}">
-                <a16:creationId xmlns:a16="http://schemas.microsoft.com/office/drawing/2014/main" id="{322FEF56-961E-4DC5-AA52-7F325B258162}"/>
+                <a16:creationId xmlns:a16="http://schemas.microsoft.com/office/drawing/2014/main" id="{2B8C7A6A-938B-4B3E-93FC-7802D858C641}"/>
               </a:ext>
             </a:extLst>
           </p:cNvPr>
@@ -20268,7 +20608,7 @@
     </p:spTree>
     <p:extLst>
       <p:ext uri="{BB962C8B-B14F-4D97-AF65-F5344CB8AC3E}">
-        <p14:creationId xmlns:p14="http://schemas.microsoft.com/office/powerpoint/2010/main" val="1388836367"/>
+        <p14:creationId xmlns:p14="http://schemas.microsoft.com/office/powerpoint/2010/main" val="824553233"/>
       </p:ext>
     </p:extLst>
   </p:cSld>
@@ -20299,7 +20639,7 @@
           <p:cNvPr id="12" name="">
             <a:extLst xmlns:a="http://schemas.openxmlformats.org/drawingml/2006/main">
               <a:ext uri="{FF2B5EF4-FFF2-40B4-BE49-F238E27FC236}">
-                <a16:creationId xmlns:a16="http://schemas.microsoft.com/office/drawing/2014/main" id="{0E0512CD-3111-4AC8-9D98-6F36D4E925B2}"/>
+                <a16:creationId xmlns:a16="http://schemas.microsoft.com/office/drawing/2014/main" id="{0CD0AA6B-A80F-4BBA-8539-369C37B58974}"/>
               </a:ext>
             </a:extLst>
           </p:cNvPr>
@@ -20309,7 +20649,7 @@
           <p:nvPr/>
         </p:nvPicPr>
         <p:blipFill>
-          <a:blip xmlns:r="http://schemas.openxmlformats.org/officeDocument/2006/relationships" xmlns:a="http://schemas.openxmlformats.org/drawingml/2006/main" r:embed="R52c52f783ae84d7c"/>
+          <a:blip xmlns:r="http://schemas.openxmlformats.org/officeDocument/2006/relationships" xmlns:a="http://schemas.openxmlformats.org/drawingml/2006/main" r:embed="R6eb54e08a49c4e2f"/>
           <a:srcRect xmlns:a="http://schemas.openxmlformats.org/drawingml/2006/main" l="0" t="0" r="0" b="0"/>
           <a:stretch xmlns:a="http://schemas.openxmlformats.org/drawingml/2006/main">
             <a:fillRect l="0" t="0" r="0" b="0"/>
@@ -20330,7 +20670,7 @@
           <p:cNvPr id="2" name="">
             <a:extLst xmlns:a="http://schemas.openxmlformats.org/drawingml/2006/main">
               <a:ext uri="{FF2B5EF4-FFF2-40B4-BE49-F238E27FC236}">
-                <a16:creationId xmlns:a16="http://schemas.microsoft.com/office/drawing/2014/main" id="{02E7B043-4988-458C-B7A8-CE306C18D2B7}"/>
+                <a16:creationId xmlns:a16="http://schemas.microsoft.com/office/drawing/2014/main" id="{FA2477BB-3474-4ACC-A065-40903646A03B}"/>
               </a:ext>
             </a:extLst>
           </p:cNvPr>
@@ -20398,7 +20738,7 @@
           <p:cNvPr id="3" name="">
             <a:extLst xmlns:a="http://schemas.openxmlformats.org/drawingml/2006/main">
               <a:ext uri="{FF2B5EF4-FFF2-40B4-BE49-F238E27FC236}">
-                <a16:creationId xmlns:a16="http://schemas.microsoft.com/office/drawing/2014/main" id="{A4933CC1-A437-4404-9C8E-3C46EF3496BC}"/>
+                <a16:creationId xmlns:a16="http://schemas.microsoft.com/office/drawing/2014/main" id="{C5BF6632-897C-4DDB-80EA-F2F2FBBBEE56}"/>
               </a:ext>
             </a:extLst>
           </p:cNvPr>
@@ -20466,7 +20806,7 @@
           <p:cNvPr id="4" name="">
             <a:extLst xmlns:a="http://schemas.openxmlformats.org/drawingml/2006/main">
               <a:ext uri="{FF2B5EF4-FFF2-40B4-BE49-F238E27FC236}">
-                <a16:creationId xmlns:a16="http://schemas.microsoft.com/office/drawing/2014/main" id="{D43876B4-479C-44F4-9859-844CD5D385CE}"/>
+                <a16:creationId xmlns:a16="http://schemas.microsoft.com/office/drawing/2014/main" id="{97A154A0-804F-472E-A08A-DE1F096923DC}"/>
               </a:ext>
             </a:extLst>
           </p:cNvPr>
@@ -20534,7 +20874,7 @@
           <p:cNvPr id="5" name="">
             <a:extLst xmlns:a="http://schemas.openxmlformats.org/drawingml/2006/main">
               <a:ext uri="{FF2B5EF4-FFF2-40B4-BE49-F238E27FC236}">
-                <a16:creationId xmlns:a16="http://schemas.microsoft.com/office/drawing/2014/main" id="{36A94155-4A08-4D64-860E-04144EDD6C22}"/>
+                <a16:creationId xmlns:a16="http://schemas.microsoft.com/office/drawing/2014/main" id="{B652641F-F493-429A-A117-91C9EC17BC69}"/>
               </a:ext>
             </a:extLst>
           </p:cNvPr>
@@ -20544,7 +20884,7 @@
           <p:nvPr/>
         </p:nvPicPr>
         <p:blipFill>
-          <a:blip xmlns:r="http://schemas.openxmlformats.org/officeDocument/2006/relationships" xmlns:a="http://schemas.openxmlformats.org/drawingml/2006/main" r:embed="R97da8d52309e4deb"/>
+          <a:blip xmlns:r="http://schemas.openxmlformats.org/officeDocument/2006/relationships" xmlns:a="http://schemas.openxmlformats.org/drawingml/2006/main" r:embed="R318a89bbbfaf4b65"/>
           <a:stretch xmlns:a="http://schemas.openxmlformats.org/drawingml/2006/main"/>
         </p:blipFill>
         <p:spPr>
@@ -20562,7 +20902,7 @@
           <p:cNvPr id="6" name="">
             <a:extLst xmlns:a="http://schemas.openxmlformats.org/drawingml/2006/main">
               <a:ext uri="{FF2B5EF4-FFF2-40B4-BE49-F238E27FC236}">
-                <a16:creationId xmlns:a16="http://schemas.microsoft.com/office/drawing/2014/main" id="{28F2698B-8022-4F92-9392-21C512DDFAA3}"/>
+                <a16:creationId xmlns:a16="http://schemas.microsoft.com/office/drawing/2014/main" id="{641062D9-3031-4638-87D7-460406FB2BD2}"/>
               </a:ext>
             </a:extLst>
           </p:cNvPr>
@@ -20630,7 +20970,7 @@
           <p:cNvPr id="7" name="">
             <a:extLst xmlns:a="http://schemas.openxmlformats.org/drawingml/2006/main">
               <a:ext uri="{FF2B5EF4-FFF2-40B4-BE49-F238E27FC236}">
-                <a16:creationId xmlns:a16="http://schemas.microsoft.com/office/drawing/2014/main" id="{1FE1BE4E-BBA8-439C-974C-EA3CA6DDEB77}"/>
+                <a16:creationId xmlns:a16="http://schemas.microsoft.com/office/drawing/2014/main" id="{5475908C-5893-478D-A8D2-4C0F3402CF32}"/>
               </a:ext>
             </a:extLst>
           </p:cNvPr>
@@ -20721,7 +21061,7 @@
           <p:cNvPr id="8" name="">
             <a:extLst xmlns:a="http://schemas.openxmlformats.org/drawingml/2006/main">
               <a:ext uri="{FF2B5EF4-FFF2-40B4-BE49-F238E27FC236}">
-                <a16:creationId xmlns:a16="http://schemas.microsoft.com/office/drawing/2014/main" id="{1D01ED2C-9785-4CC7-80C4-1B0BAAECD11A}"/>
+                <a16:creationId xmlns:a16="http://schemas.microsoft.com/office/drawing/2014/main" id="{326F8503-4254-472A-A3BA-A06AD8768B5E}"/>
               </a:ext>
             </a:extLst>
           </p:cNvPr>
@@ -20731,7 +21071,7 @@
           <p:nvPr/>
         </p:nvPicPr>
         <p:blipFill>
-          <a:blip xmlns:r="http://schemas.openxmlformats.org/officeDocument/2006/relationships" xmlns:a="http://schemas.openxmlformats.org/drawingml/2006/main" r:embed="Re94dbc87d63840ff"/>
+          <a:blip xmlns:r="http://schemas.openxmlformats.org/officeDocument/2006/relationships" xmlns:a="http://schemas.openxmlformats.org/drawingml/2006/main" r:embed="R4abcd01a1dec47d0"/>
           <a:stretch xmlns:a="http://schemas.openxmlformats.org/drawingml/2006/main"/>
         </p:blipFill>
         <p:spPr>
@@ -20749,7 +21089,7 @@
           <p:cNvPr id="9" name="">
             <a:extLst xmlns:a="http://schemas.openxmlformats.org/drawingml/2006/main">
               <a:ext uri="{FF2B5EF4-FFF2-40B4-BE49-F238E27FC236}">
-                <a16:creationId xmlns:a16="http://schemas.microsoft.com/office/drawing/2014/main" id="{391F4266-763A-4C59-AC0D-8CBD6263D1A3}"/>
+                <a16:creationId xmlns:a16="http://schemas.microsoft.com/office/drawing/2014/main" id="{244D9AF1-164A-4A4C-8205-7FA8B029B509}"/>
               </a:ext>
             </a:extLst>
           </p:cNvPr>
@@ -20817,7 +21157,7 @@
           <p:cNvPr id="10" name="">
             <a:extLst xmlns:a="http://schemas.openxmlformats.org/drawingml/2006/main">
               <a:ext uri="{FF2B5EF4-FFF2-40B4-BE49-F238E27FC236}">
-                <a16:creationId xmlns:a16="http://schemas.microsoft.com/office/drawing/2014/main" id="{5B72CC2F-D360-4BAE-AB75-B0922A2288FD}"/>
+                <a16:creationId xmlns:a16="http://schemas.microsoft.com/office/drawing/2014/main" id="{B588B193-F674-4479-8CD5-BB406D98AF0B}"/>
               </a:ext>
             </a:extLst>
           </p:cNvPr>
@@ -20908,7 +21248,7 @@
           <p:cNvPr id="11" name="">
             <a:extLst xmlns:a="http://schemas.openxmlformats.org/drawingml/2006/main">
               <a:ext uri="{FF2B5EF4-FFF2-40B4-BE49-F238E27FC236}">
-                <a16:creationId xmlns:a16="http://schemas.microsoft.com/office/drawing/2014/main" id="{B216597B-4CCA-4DCD-ACD2-0B07F1D9F5BF}"/>
+                <a16:creationId xmlns:a16="http://schemas.microsoft.com/office/drawing/2014/main" id="{0A04CC76-5664-4CEA-9FC5-1FACAD1EC067}"/>
               </a:ext>
             </a:extLst>
           </p:cNvPr>
@@ -20974,7 +21314,7 @@
     </p:spTree>
     <p:extLst>
       <p:ext uri="{BB962C8B-B14F-4D97-AF65-F5344CB8AC3E}">
-        <p14:creationId xmlns:p14="http://schemas.microsoft.com/office/powerpoint/2010/main" val="1023302509"/>
+        <p14:creationId xmlns:p14="http://schemas.microsoft.com/office/powerpoint/2010/main" val="85087031"/>
       </p:ext>
     </p:extLst>
   </p:cSld>
@@ -21005,7 +21345,7 @@
           <p:cNvPr id="7" name="">
             <a:extLst xmlns:a="http://schemas.openxmlformats.org/drawingml/2006/main">
               <a:ext uri="{FF2B5EF4-FFF2-40B4-BE49-F238E27FC236}">
-                <a16:creationId xmlns:a16="http://schemas.microsoft.com/office/drawing/2014/main" id="{486C184C-9E58-420D-82F5-1E438C46DC9B}"/>
+                <a16:creationId xmlns:a16="http://schemas.microsoft.com/office/drawing/2014/main" id="{1414285B-B32F-47A7-8D1A-7EBA5CD3B79F}"/>
               </a:ext>
             </a:extLst>
           </p:cNvPr>
@@ -21015,7 +21355,7 @@
           <p:nvPr/>
         </p:nvPicPr>
         <p:blipFill>
-          <a:blip xmlns:r="http://schemas.openxmlformats.org/officeDocument/2006/relationships" xmlns:a="http://schemas.openxmlformats.org/drawingml/2006/main" r:embed="R67ea943eb6bd45ba"/>
+          <a:blip xmlns:r="http://schemas.openxmlformats.org/officeDocument/2006/relationships" xmlns:a="http://schemas.openxmlformats.org/drawingml/2006/main" r:embed="R2e3553209ce6453a"/>
           <a:srcRect xmlns:a="http://schemas.openxmlformats.org/drawingml/2006/main" l="0" t="0" r="0" b="0"/>
           <a:stretch xmlns:a="http://schemas.openxmlformats.org/drawingml/2006/main">
             <a:fillRect l="0" t="0" r="0" b="0"/>
@@ -21036,7 +21376,7 @@
           <p:cNvPr id="2" name="">
             <a:extLst xmlns:a="http://schemas.openxmlformats.org/drawingml/2006/main">
               <a:ext uri="{FF2B5EF4-FFF2-40B4-BE49-F238E27FC236}">
-                <a16:creationId xmlns:a16="http://schemas.microsoft.com/office/drawing/2014/main" id="{6A76169C-66DC-4947-889F-B24E55BE6C1D}"/>
+                <a16:creationId xmlns:a16="http://schemas.microsoft.com/office/drawing/2014/main" id="{4C3A093E-C072-4791-8512-BC03E462A158}"/>
               </a:ext>
             </a:extLst>
           </p:cNvPr>
@@ -21104,7 +21444,7 @@
           <p:cNvPr id="3" name="">
             <a:extLst xmlns:a="http://schemas.openxmlformats.org/drawingml/2006/main">
               <a:ext uri="{FF2B5EF4-FFF2-40B4-BE49-F238E27FC236}">
-                <a16:creationId xmlns:a16="http://schemas.microsoft.com/office/drawing/2014/main" id="{B37F327A-7BE4-4935-930C-9B8D095415C1}"/>
+                <a16:creationId xmlns:a16="http://schemas.microsoft.com/office/drawing/2014/main" id="{46941518-9558-4703-AC40-D976BC61A945}"/>
               </a:ext>
             </a:extLst>
           </p:cNvPr>
@@ -21195,7 +21535,7 @@
           <p:cNvPr id="4" name="">
             <a:extLst xmlns:a="http://schemas.openxmlformats.org/drawingml/2006/main">
               <a:ext uri="{FF2B5EF4-FFF2-40B4-BE49-F238E27FC236}">
-                <a16:creationId xmlns:a16="http://schemas.microsoft.com/office/drawing/2014/main" id="{B2E7733A-55F5-486E-ACD0-2CFBACE8D651}"/>
+                <a16:creationId xmlns:a16="http://schemas.microsoft.com/office/drawing/2014/main" id="{8C994E36-CF85-479A-92AA-726BD7ECE7D8}"/>
               </a:ext>
             </a:extLst>
           </p:cNvPr>
@@ -21286,7 +21626,7 @@
           <p:cNvPr id="5" name="">
             <a:extLst xmlns:a="http://schemas.openxmlformats.org/drawingml/2006/main">
               <a:ext uri="{FF2B5EF4-FFF2-40B4-BE49-F238E27FC236}">
-                <a16:creationId xmlns:a16="http://schemas.microsoft.com/office/drawing/2014/main" id="{F26AD833-74AC-4FA8-8A0F-1E67916CCFF0}"/>
+                <a16:creationId xmlns:a16="http://schemas.microsoft.com/office/drawing/2014/main" id="{F8A7F6E5-AC95-48E2-A83C-A4653DCB103A}"/>
               </a:ext>
             </a:extLst>
           </p:cNvPr>
@@ -21377,7 +21717,7 @@
           <p:cNvPr id="6" name="">
             <a:extLst xmlns:a="http://schemas.openxmlformats.org/drawingml/2006/main">
               <a:ext uri="{FF2B5EF4-FFF2-40B4-BE49-F238E27FC236}">
-                <a16:creationId xmlns:a16="http://schemas.microsoft.com/office/drawing/2014/main" id="{E5ED4A5B-D66C-45FD-8225-E39A294558EE}"/>
+                <a16:creationId xmlns:a16="http://schemas.microsoft.com/office/drawing/2014/main" id="{608C6107-7216-4E36-B392-BCE8EE57FC93}"/>
               </a:ext>
             </a:extLst>
           </p:cNvPr>
@@ -21443,7 +21783,7 @@
     </p:spTree>
     <p:extLst>
       <p:ext uri="{BB962C8B-B14F-4D97-AF65-F5344CB8AC3E}">
-        <p14:creationId xmlns:p14="http://schemas.microsoft.com/office/powerpoint/2010/main" val="569441211"/>
+        <p14:creationId xmlns:p14="http://schemas.microsoft.com/office/powerpoint/2010/main" val="1470651895"/>
       </p:ext>
     </p:extLst>
   </p:cSld>
@@ -21474,7 +21814,7 @@
           <p:cNvPr id="12" name="">
             <a:extLst xmlns:a="http://schemas.openxmlformats.org/drawingml/2006/main">
               <a:ext uri="{FF2B5EF4-FFF2-40B4-BE49-F238E27FC236}">
-                <a16:creationId xmlns:a16="http://schemas.microsoft.com/office/drawing/2014/main" id="{524FD594-9B09-4BD6-8033-5501EDEFE799}"/>
+                <a16:creationId xmlns:a16="http://schemas.microsoft.com/office/drawing/2014/main" id="{1CC8FDDB-D4C4-49FD-9FFA-E3C72BC8A248}"/>
               </a:ext>
             </a:extLst>
           </p:cNvPr>
@@ -21484,7 +21824,7 @@
           <p:nvPr/>
         </p:nvPicPr>
         <p:blipFill>
-          <a:blip xmlns:r="http://schemas.openxmlformats.org/officeDocument/2006/relationships" xmlns:a="http://schemas.openxmlformats.org/drawingml/2006/main" r:embed="R465fabb2ae8b4ddf"/>
+          <a:blip xmlns:r="http://schemas.openxmlformats.org/officeDocument/2006/relationships" xmlns:a="http://schemas.openxmlformats.org/drawingml/2006/main" r:embed="R2dc74ec734404f5c"/>
           <a:srcRect xmlns:a="http://schemas.openxmlformats.org/drawingml/2006/main" l="0" t="0" r="0" b="0"/>
           <a:stretch xmlns:a="http://schemas.openxmlformats.org/drawingml/2006/main">
             <a:fillRect l="0" t="0" r="0" b="0"/>
@@ -21505,7 +21845,7 @@
           <p:cNvPr id="2" name="">
             <a:extLst xmlns:a="http://schemas.openxmlformats.org/drawingml/2006/main">
               <a:ext uri="{FF2B5EF4-FFF2-40B4-BE49-F238E27FC236}">
-                <a16:creationId xmlns:a16="http://schemas.microsoft.com/office/drawing/2014/main" id="{B6DFE2DC-C174-45FC-A2CE-AE8F5E3791A3}"/>
+                <a16:creationId xmlns:a16="http://schemas.microsoft.com/office/drawing/2014/main" id="{36260F87-C177-492B-BD36-EF414D30DBBC}"/>
               </a:ext>
             </a:extLst>
           </p:cNvPr>
@@ -21573,7 +21913,7 @@
           <p:cNvPr id="3" name="">
             <a:extLst xmlns:a="http://schemas.openxmlformats.org/drawingml/2006/main">
               <a:ext uri="{FF2B5EF4-FFF2-40B4-BE49-F238E27FC236}">
-                <a16:creationId xmlns:a16="http://schemas.microsoft.com/office/drawing/2014/main" id="{0315A6F8-5AA6-4272-805D-438EBDF74233}"/>
+                <a16:creationId xmlns:a16="http://schemas.microsoft.com/office/drawing/2014/main" id="{DF26E5D6-736D-44B3-8334-3B2134B08DF1}"/>
               </a:ext>
             </a:extLst>
           </p:cNvPr>
@@ -21641,7 +21981,7 @@
           <p:cNvPr id="4" name="">
             <a:extLst xmlns:a="http://schemas.openxmlformats.org/drawingml/2006/main">
               <a:ext uri="{FF2B5EF4-FFF2-40B4-BE49-F238E27FC236}">
-                <a16:creationId xmlns:a16="http://schemas.microsoft.com/office/drawing/2014/main" id="{59A9C8AA-9C2C-44BD-AE0B-FCF93F9AE781}"/>
+                <a16:creationId xmlns:a16="http://schemas.microsoft.com/office/drawing/2014/main" id="{3EE06662-7F50-4DAB-8287-6D04709BD9C8}"/>
               </a:ext>
             </a:extLst>
           </p:cNvPr>
@@ -21709,7 +22049,7 @@
           <p:cNvPr id="5" name="">
             <a:extLst xmlns:a="http://schemas.openxmlformats.org/drawingml/2006/main">
               <a:ext uri="{FF2B5EF4-FFF2-40B4-BE49-F238E27FC236}">
-                <a16:creationId xmlns:a16="http://schemas.microsoft.com/office/drawing/2014/main" id="{EB1A2CA9-9E4F-47EB-9175-E47F5F5A8905}"/>
+                <a16:creationId xmlns:a16="http://schemas.microsoft.com/office/drawing/2014/main" id="{6F06D6AD-E6F7-4742-B3DB-59AB182E1110}"/>
               </a:ext>
             </a:extLst>
           </p:cNvPr>
@@ -21719,7 +22059,7 @@
           <p:nvPr/>
         </p:nvPicPr>
         <p:blipFill>
-          <a:blip xmlns:r="http://schemas.openxmlformats.org/officeDocument/2006/relationships" xmlns:a="http://schemas.openxmlformats.org/drawingml/2006/main" r:embed="R73f645de36ea487e"/>
+          <a:blip xmlns:r="http://schemas.openxmlformats.org/officeDocument/2006/relationships" xmlns:a="http://schemas.openxmlformats.org/drawingml/2006/main" r:embed="R0c757944360c46bf"/>
           <a:stretch xmlns:a="http://schemas.openxmlformats.org/drawingml/2006/main"/>
         </p:blipFill>
         <p:spPr>
@@ -21737,7 +22077,7 @@
           <p:cNvPr id="6" name="">
             <a:extLst xmlns:a="http://schemas.openxmlformats.org/drawingml/2006/main">
               <a:ext uri="{FF2B5EF4-FFF2-40B4-BE49-F238E27FC236}">
-                <a16:creationId xmlns:a16="http://schemas.microsoft.com/office/drawing/2014/main" id="{DCA786A9-1FDD-4D90-8E5D-F6AB6772F349}"/>
+                <a16:creationId xmlns:a16="http://schemas.microsoft.com/office/drawing/2014/main" id="{18BD1FE8-2445-4DB9-8B9C-2B0460A6AAB6}"/>
               </a:ext>
             </a:extLst>
           </p:cNvPr>
@@ -21805,7 +22145,7 @@
           <p:cNvPr id="7" name="">
             <a:extLst xmlns:a="http://schemas.openxmlformats.org/drawingml/2006/main">
               <a:ext uri="{FF2B5EF4-FFF2-40B4-BE49-F238E27FC236}">
-                <a16:creationId xmlns:a16="http://schemas.microsoft.com/office/drawing/2014/main" id="{82218D36-B990-4188-8932-EB33858980BA}"/>
+                <a16:creationId xmlns:a16="http://schemas.microsoft.com/office/drawing/2014/main" id="{C8C92B0F-C5AA-4B6C-85F8-F52911EA861C}"/>
               </a:ext>
             </a:extLst>
           </p:cNvPr>
@@ -21896,7 +22236,7 @@
           <p:cNvPr id="8" name="">
             <a:extLst xmlns:a="http://schemas.openxmlformats.org/drawingml/2006/main">
               <a:ext uri="{FF2B5EF4-FFF2-40B4-BE49-F238E27FC236}">
-                <a16:creationId xmlns:a16="http://schemas.microsoft.com/office/drawing/2014/main" id="{3A804D26-DEC5-4B25-AF49-B81E78558EAE}"/>
+                <a16:creationId xmlns:a16="http://schemas.microsoft.com/office/drawing/2014/main" id="{2964A6D4-C4BE-4EA7-B0F3-92A7DF33879E}"/>
               </a:ext>
             </a:extLst>
           </p:cNvPr>
@@ -21906,7 +22246,7 @@
           <p:nvPr/>
         </p:nvPicPr>
         <p:blipFill>
-          <a:blip xmlns:r="http://schemas.openxmlformats.org/officeDocument/2006/relationships" xmlns:a="http://schemas.openxmlformats.org/drawingml/2006/main" r:embed="Re9f6de7958444821"/>
+          <a:blip xmlns:r="http://schemas.openxmlformats.org/officeDocument/2006/relationships" xmlns:a="http://schemas.openxmlformats.org/drawingml/2006/main" r:embed="Rd58e541687a74ea3"/>
           <a:stretch xmlns:a="http://schemas.openxmlformats.org/drawingml/2006/main"/>
         </p:blipFill>
         <p:spPr>
@@ -21924,7 +22264,7 @@
           <p:cNvPr id="9" name="">
             <a:extLst xmlns:a="http://schemas.openxmlformats.org/drawingml/2006/main">
               <a:ext uri="{FF2B5EF4-FFF2-40B4-BE49-F238E27FC236}">
-                <a16:creationId xmlns:a16="http://schemas.microsoft.com/office/drawing/2014/main" id="{3C3E8736-74DB-4618-AD39-387F5FF4C3A4}"/>
+                <a16:creationId xmlns:a16="http://schemas.microsoft.com/office/drawing/2014/main" id="{B171E6DB-0C8E-4461-9890-E9CB645CEBF6}"/>
               </a:ext>
             </a:extLst>
           </p:cNvPr>
@@ -21992,7 +22332,7 @@
           <p:cNvPr id="10" name="">
             <a:extLst xmlns:a="http://schemas.openxmlformats.org/drawingml/2006/main">
               <a:ext uri="{FF2B5EF4-FFF2-40B4-BE49-F238E27FC236}">
-                <a16:creationId xmlns:a16="http://schemas.microsoft.com/office/drawing/2014/main" id="{C4CE5C17-21C9-4690-9A24-737EEEECF956}"/>
+                <a16:creationId xmlns:a16="http://schemas.microsoft.com/office/drawing/2014/main" id="{45150969-C4D8-4B4F-A8C6-6F72F946E654}"/>
               </a:ext>
             </a:extLst>
           </p:cNvPr>
@@ -22083,7 +22423,7 @@
           <p:cNvPr id="11" name="">
             <a:extLst xmlns:a="http://schemas.openxmlformats.org/drawingml/2006/main">
               <a:ext uri="{FF2B5EF4-FFF2-40B4-BE49-F238E27FC236}">
-                <a16:creationId xmlns:a16="http://schemas.microsoft.com/office/drawing/2014/main" id="{8FF836D0-4BA4-4ABB-8E64-45A168F5A454}"/>
+                <a16:creationId xmlns:a16="http://schemas.microsoft.com/office/drawing/2014/main" id="{383FDD48-6B68-4A12-BFC4-BCB9BAC6DBA4}"/>
               </a:ext>
             </a:extLst>
           </p:cNvPr>
@@ -22149,7 +22489,7 @@
     </p:spTree>
     <p:extLst>
       <p:ext uri="{BB962C8B-B14F-4D97-AF65-F5344CB8AC3E}">
-        <p14:creationId xmlns:p14="http://schemas.microsoft.com/office/powerpoint/2010/main" val="1678179826"/>
+        <p14:creationId xmlns:p14="http://schemas.microsoft.com/office/powerpoint/2010/main" val="1769755975"/>
       </p:ext>
     </p:extLst>
   </p:cSld>
@@ -22180,7 +22520,7 @@
           <p:cNvPr id="15" name="">
             <a:extLst xmlns:a="http://schemas.openxmlformats.org/drawingml/2006/main">
               <a:ext uri="{FF2B5EF4-FFF2-40B4-BE49-F238E27FC236}">
-                <a16:creationId xmlns:a16="http://schemas.microsoft.com/office/drawing/2014/main" id="{E50D9338-2684-46BE-813D-78A15FE91284}"/>
+                <a16:creationId xmlns:a16="http://schemas.microsoft.com/office/drawing/2014/main" id="{E72BF283-0C2B-4B7C-B32E-25636C3003B8}"/>
               </a:ext>
             </a:extLst>
           </p:cNvPr>
@@ -22190,7 +22530,7 @@
           <p:nvPr/>
         </p:nvPicPr>
         <p:blipFill>
-          <a:blip xmlns:r="http://schemas.openxmlformats.org/officeDocument/2006/relationships" xmlns:a="http://schemas.openxmlformats.org/drawingml/2006/main" r:embed="R90aad067bd884ab1"/>
+          <a:blip xmlns:r="http://schemas.openxmlformats.org/officeDocument/2006/relationships" xmlns:a="http://schemas.openxmlformats.org/drawingml/2006/main" r:embed="R4acac3ee43ba43c0"/>
           <a:srcRect xmlns:a="http://schemas.openxmlformats.org/drawingml/2006/main" l="0" t="0" r="0" b="0"/>
           <a:stretch xmlns:a="http://schemas.openxmlformats.org/drawingml/2006/main">
             <a:fillRect l="0" t="0" r="0" b="0"/>
@@ -22211,7 +22551,7 @@
           <p:cNvPr id="2" name="">
             <a:extLst xmlns:a="http://schemas.openxmlformats.org/drawingml/2006/main">
               <a:ext uri="{FF2B5EF4-FFF2-40B4-BE49-F238E27FC236}">
-                <a16:creationId xmlns:a16="http://schemas.microsoft.com/office/drawing/2014/main" id="{6B193FE6-093D-4872-9D99-9486A213725D}"/>
+                <a16:creationId xmlns:a16="http://schemas.microsoft.com/office/drawing/2014/main" id="{95503071-565E-41E0-903A-698F5FFBB96D}"/>
               </a:ext>
             </a:extLst>
           </p:cNvPr>
@@ -22279,7 +22619,7 @@
           <p:cNvPr id="3" name="">
             <a:extLst xmlns:a="http://schemas.openxmlformats.org/drawingml/2006/main">
               <a:ext uri="{FF2B5EF4-FFF2-40B4-BE49-F238E27FC236}">
-                <a16:creationId xmlns:a16="http://schemas.microsoft.com/office/drawing/2014/main" id="{FDD9055B-AE2B-4950-983B-0821233A1CB1}"/>
+                <a16:creationId xmlns:a16="http://schemas.microsoft.com/office/drawing/2014/main" id="{449E089B-F9DE-4A34-A38B-001674AE982D}"/>
               </a:ext>
             </a:extLst>
           </p:cNvPr>
@@ -22347,7 +22687,7 @@
           <p:cNvPr id="4" name="">
             <a:extLst xmlns:a="http://schemas.openxmlformats.org/drawingml/2006/main">
               <a:ext uri="{FF2B5EF4-FFF2-40B4-BE49-F238E27FC236}">
-                <a16:creationId xmlns:a16="http://schemas.microsoft.com/office/drawing/2014/main" id="{76D2B4CE-ECCC-4F61-90FE-383CA4E6CB02}"/>
+                <a16:creationId xmlns:a16="http://schemas.microsoft.com/office/drawing/2014/main" id="{A0F8C76D-94E8-4160-A7EA-D4896D830500}"/>
               </a:ext>
             </a:extLst>
           </p:cNvPr>
@@ -22415,7 +22755,7 @@
           <p:cNvPr id="5" name="">
             <a:extLst xmlns:a="http://schemas.openxmlformats.org/drawingml/2006/main">
               <a:ext uri="{FF2B5EF4-FFF2-40B4-BE49-F238E27FC236}">
-                <a16:creationId xmlns:a16="http://schemas.microsoft.com/office/drawing/2014/main" id="{6F3A6A34-FE2D-4005-89FC-6111CA031F72}"/>
+                <a16:creationId xmlns:a16="http://schemas.microsoft.com/office/drawing/2014/main" id="{9ADB85CD-EA56-4EA2-9179-EF8FCD7A41C6}"/>
               </a:ext>
             </a:extLst>
           </p:cNvPr>
@@ -22483,7 +22823,7 @@
           <p:cNvPr id="6" name="">
             <a:extLst xmlns:a="http://schemas.openxmlformats.org/drawingml/2006/main">
               <a:ext uri="{FF2B5EF4-FFF2-40B4-BE49-F238E27FC236}">
-                <a16:creationId xmlns:a16="http://schemas.microsoft.com/office/drawing/2014/main" id="{678571DB-84D3-4260-9263-ADD63BF02AF4}"/>
+                <a16:creationId xmlns:a16="http://schemas.microsoft.com/office/drawing/2014/main" id="{3F5D40D3-9360-42A6-81EA-D0BDDDAAD441}"/>
               </a:ext>
             </a:extLst>
           </p:cNvPr>
@@ -22551,7 +22891,7 @@
           <p:cNvPr id="7" name="">
             <a:extLst xmlns:a="http://schemas.openxmlformats.org/drawingml/2006/main">
               <a:ext uri="{FF2B5EF4-FFF2-40B4-BE49-F238E27FC236}">
-                <a16:creationId xmlns:a16="http://schemas.microsoft.com/office/drawing/2014/main" id="{A21B9604-62EB-48D4-B02C-FD17BB12D5F4}"/>
+                <a16:creationId xmlns:a16="http://schemas.microsoft.com/office/drawing/2014/main" id="{594851FC-6AEA-4D1C-BA06-DEEB004CBC4E}"/>
               </a:ext>
             </a:extLst>
           </p:cNvPr>
@@ -22619,7 +22959,7 @@
           <p:cNvPr id="8" name="">
             <a:extLst xmlns:a="http://schemas.openxmlformats.org/drawingml/2006/main">
               <a:ext uri="{FF2B5EF4-FFF2-40B4-BE49-F238E27FC236}">
-                <a16:creationId xmlns:a16="http://schemas.microsoft.com/office/drawing/2014/main" id="{0957001F-B0E8-40F2-B52C-9E254BA23FFD}"/>
+                <a16:creationId xmlns:a16="http://schemas.microsoft.com/office/drawing/2014/main" id="{0E3982D4-6239-415F-B6BD-D9C195CAE849}"/>
               </a:ext>
             </a:extLst>
           </p:cNvPr>
@@ -22687,7 +23027,7 @@
           <p:cNvPr id="9" name="">
             <a:extLst xmlns:a="http://schemas.openxmlformats.org/drawingml/2006/main">
               <a:ext uri="{FF2B5EF4-FFF2-40B4-BE49-F238E27FC236}">
-                <a16:creationId xmlns:a16="http://schemas.microsoft.com/office/drawing/2014/main" id="{0C47B29D-B72D-4140-9E41-869231C565ED}"/>
+                <a16:creationId xmlns:a16="http://schemas.microsoft.com/office/drawing/2014/main" id="{F62A6580-CC95-43BE-AF23-6777CC056187}"/>
               </a:ext>
             </a:extLst>
           </p:cNvPr>
@@ -22755,7 +23095,7 @@
           <p:cNvPr id="10" name="">
             <a:extLst xmlns:a="http://schemas.openxmlformats.org/drawingml/2006/main">
               <a:ext uri="{FF2B5EF4-FFF2-40B4-BE49-F238E27FC236}">
-                <a16:creationId xmlns:a16="http://schemas.microsoft.com/office/drawing/2014/main" id="{F2967C51-22CA-4E00-AEFC-916681C2C6CB}"/>
+                <a16:creationId xmlns:a16="http://schemas.microsoft.com/office/drawing/2014/main" id="{8A13F8A3-7B78-4A87-9FEE-DDE8CA676E84}"/>
               </a:ext>
             </a:extLst>
           </p:cNvPr>
@@ -22846,7 +23186,7 @@
           <p:cNvPr id="11" name="">
             <a:extLst xmlns:a="http://schemas.openxmlformats.org/drawingml/2006/main">
               <a:ext uri="{FF2B5EF4-FFF2-40B4-BE49-F238E27FC236}">
-                <a16:creationId xmlns:a16="http://schemas.microsoft.com/office/drawing/2014/main" id="{3CEB565E-E71C-48DB-A727-BB7E20C33F58}"/>
+                <a16:creationId xmlns:a16="http://schemas.microsoft.com/office/drawing/2014/main" id="{9B02256F-84CD-41CF-8000-4785F5B651C5}"/>
               </a:ext>
             </a:extLst>
           </p:cNvPr>
@@ -22914,7 +23254,7 @@
           <p:cNvPr id="12" name="">
             <a:extLst xmlns:a="http://schemas.openxmlformats.org/drawingml/2006/main">
               <a:ext uri="{FF2B5EF4-FFF2-40B4-BE49-F238E27FC236}">
-                <a16:creationId xmlns:a16="http://schemas.microsoft.com/office/drawing/2014/main" id="{3B515548-DF77-47E1-83E8-1E80CDCDE5D3}"/>
+                <a16:creationId xmlns:a16="http://schemas.microsoft.com/office/drawing/2014/main" id="{D9A889C7-93C8-4D3B-A449-CCB3B6784CB0}"/>
               </a:ext>
             </a:extLst>
           </p:cNvPr>
@@ -22982,7 +23322,7 @@
           <p:cNvPr id="13" name="">
             <a:extLst xmlns:a="http://schemas.openxmlformats.org/drawingml/2006/main">
               <a:ext uri="{FF2B5EF4-FFF2-40B4-BE49-F238E27FC236}">
-                <a16:creationId xmlns:a16="http://schemas.microsoft.com/office/drawing/2014/main" id="{7B114E86-108D-4A05-AC90-5AB4C14629FA}"/>
+                <a16:creationId xmlns:a16="http://schemas.microsoft.com/office/drawing/2014/main" id="{93E721D3-CB45-4C95-95F0-7E90E6F70FAC}"/>
               </a:ext>
             </a:extLst>
           </p:cNvPr>
@@ -23073,7 +23413,7 @@
           <p:cNvPr id="14" name="">
             <a:extLst xmlns:a="http://schemas.openxmlformats.org/drawingml/2006/main">
               <a:ext uri="{FF2B5EF4-FFF2-40B4-BE49-F238E27FC236}">
-                <a16:creationId xmlns:a16="http://schemas.microsoft.com/office/drawing/2014/main" id="{BC37449D-0D5D-4CB1-B003-0388BB295E58}"/>
+                <a16:creationId xmlns:a16="http://schemas.microsoft.com/office/drawing/2014/main" id="{BF8D6C63-B230-4C23-8E1E-5CC77D97D0B6}"/>
               </a:ext>
             </a:extLst>
           </p:cNvPr>
@@ -23139,7 +23479,7 @@
     </p:spTree>
     <p:extLst>
       <p:ext uri="{BB962C8B-B14F-4D97-AF65-F5344CB8AC3E}">
-        <p14:creationId xmlns:p14="http://schemas.microsoft.com/office/powerpoint/2010/main" val="610062328"/>
+        <p14:creationId xmlns:p14="http://schemas.microsoft.com/office/powerpoint/2010/main" val="2123081764"/>
       </p:ext>
     </p:extLst>
   </p:cSld>
@@ -23170,7 +23510,7 @@
           <p:cNvPr id="17" name="">
             <a:extLst xmlns:a="http://schemas.openxmlformats.org/drawingml/2006/main">
               <a:ext uri="{FF2B5EF4-FFF2-40B4-BE49-F238E27FC236}">
-                <a16:creationId xmlns:a16="http://schemas.microsoft.com/office/drawing/2014/main" id="{97BFF876-9B2D-4F8F-8F5F-3127F47B8F66}"/>
+                <a16:creationId xmlns:a16="http://schemas.microsoft.com/office/drawing/2014/main" id="{360BAA4B-48E9-4B2B-8BAE-AC5FC47934DC}"/>
               </a:ext>
             </a:extLst>
           </p:cNvPr>
@@ -23238,7 +23578,7 @@
           <p:cNvPr id="2" name="">
             <a:extLst xmlns:a="http://schemas.openxmlformats.org/drawingml/2006/main">
               <a:ext uri="{FF2B5EF4-FFF2-40B4-BE49-F238E27FC236}">
-                <a16:creationId xmlns:a16="http://schemas.microsoft.com/office/drawing/2014/main" id="{BA41239A-370A-429A-BC39-83843989AD3D}"/>
+                <a16:creationId xmlns:a16="http://schemas.microsoft.com/office/drawing/2014/main" id="{A2B57DED-FFCE-4606-B9F1-2F1317B1414F}"/>
               </a:ext>
             </a:extLst>
           </p:cNvPr>
@@ -23306,7 +23646,7 @@
           <p:cNvPr id="3" name="">
             <a:extLst xmlns:a="http://schemas.openxmlformats.org/drawingml/2006/main">
               <a:ext uri="{FF2B5EF4-FFF2-40B4-BE49-F238E27FC236}">
-                <a16:creationId xmlns:a16="http://schemas.microsoft.com/office/drawing/2014/main" id="{0FE54AF7-D163-4E4E-AA18-BF4B57F8C866}"/>
+                <a16:creationId xmlns:a16="http://schemas.microsoft.com/office/drawing/2014/main" id="{350CF41B-980E-410C-BCB3-2CCA48504B51}"/>
               </a:ext>
             </a:extLst>
           </p:cNvPr>
@@ -23374,7 +23714,7 @@
           <p:cNvPr id="4" name="">
             <a:extLst xmlns:a="http://schemas.openxmlformats.org/drawingml/2006/main">
               <a:ext uri="{FF2B5EF4-FFF2-40B4-BE49-F238E27FC236}">
-                <a16:creationId xmlns:a16="http://schemas.microsoft.com/office/drawing/2014/main" id="{D01C8CEB-EA45-4DD3-9833-3595559913BC}"/>
+                <a16:creationId xmlns:a16="http://schemas.microsoft.com/office/drawing/2014/main" id="{62E57D26-69D5-4482-849F-3F9CC07DB634}"/>
               </a:ext>
             </a:extLst>
           </p:cNvPr>
@@ -23384,7 +23724,7 @@
           <p:nvPr/>
         </p:nvPicPr>
         <p:blipFill>
-          <a:blip xmlns:r="http://schemas.openxmlformats.org/officeDocument/2006/relationships" xmlns:a="http://schemas.openxmlformats.org/drawingml/2006/main" r:embed="R990c11bb78624feb"/>
+          <a:blip xmlns:r="http://schemas.openxmlformats.org/officeDocument/2006/relationships" xmlns:a="http://schemas.openxmlformats.org/drawingml/2006/main" r:embed="Rd2dcb14dbb724d7a"/>
           <a:stretch xmlns:a="http://schemas.openxmlformats.org/drawingml/2006/main"/>
         </p:blipFill>
         <p:spPr>
@@ -23402,7 +23742,7 @@
           <p:cNvPr id="5" name="">
             <a:extLst xmlns:a="http://schemas.openxmlformats.org/drawingml/2006/main">
               <a:ext uri="{FF2B5EF4-FFF2-40B4-BE49-F238E27FC236}">
-                <a16:creationId xmlns:a16="http://schemas.microsoft.com/office/drawing/2014/main" id="{8365D75A-BD6F-4B9A-9250-F71ED83224D1}"/>
+                <a16:creationId xmlns:a16="http://schemas.microsoft.com/office/drawing/2014/main" id="{816EB4F5-2165-4AA5-AB64-6BB4CAF7B915}"/>
               </a:ext>
             </a:extLst>
           </p:cNvPr>
@@ -23470,7 +23810,7 @@
           <p:cNvPr id="6" name="">
             <a:extLst xmlns:a="http://schemas.openxmlformats.org/drawingml/2006/main">
               <a:ext uri="{FF2B5EF4-FFF2-40B4-BE49-F238E27FC236}">
-                <a16:creationId xmlns:a16="http://schemas.microsoft.com/office/drawing/2014/main" id="{17DA0168-44A3-4F6A-A78A-C8C58ED042E8}"/>
+                <a16:creationId xmlns:a16="http://schemas.microsoft.com/office/drawing/2014/main" id="{4F754091-F7B5-45AF-9DBE-5579049FCE04}"/>
               </a:ext>
             </a:extLst>
           </p:cNvPr>
@@ -23538,7 +23878,7 @@
           <p:cNvPr id="7" name="">
             <a:extLst xmlns:a="http://schemas.openxmlformats.org/drawingml/2006/main">
               <a:ext uri="{FF2B5EF4-FFF2-40B4-BE49-F238E27FC236}">
-                <a16:creationId xmlns:a16="http://schemas.microsoft.com/office/drawing/2014/main" id="{E14E5F90-8560-40B3-ACE5-86D1A5D8689E}"/>
+                <a16:creationId xmlns:a16="http://schemas.microsoft.com/office/drawing/2014/main" id="{03DEC583-0FE2-4C00-B18C-EED052A02742}"/>
               </a:ext>
             </a:extLst>
           </p:cNvPr>
@@ -23548,7 +23888,7 @@
           <p:nvPr/>
         </p:nvPicPr>
         <p:blipFill>
-          <a:blip xmlns:r="http://schemas.openxmlformats.org/officeDocument/2006/relationships" xmlns:a="http://schemas.openxmlformats.org/drawingml/2006/main" r:embed="R77237a4fe7b64503"/>
+          <a:blip xmlns:r="http://schemas.openxmlformats.org/officeDocument/2006/relationships" xmlns:a="http://schemas.openxmlformats.org/drawingml/2006/main" r:embed="R1cdcc8494c7847d7"/>
           <a:stretch xmlns:a="http://schemas.openxmlformats.org/drawingml/2006/main"/>
         </p:blipFill>
         <p:spPr>
@@ -23566,7 +23906,7 @@
           <p:cNvPr id="8" name="">
             <a:extLst xmlns:a="http://schemas.openxmlformats.org/drawingml/2006/main">
               <a:ext uri="{FF2B5EF4-FFF2-40B4-BE49-F238E27FC236}">
-                <a16:creationId xmlns:a16="http://schemas.microsoft.com/office/drawing/2014/main" id="{64E0A567-864F-4807-8649-411ED4B85065}"/>
+                <a16:creationId xmlns:a16="http://schemas.microsoft.com/office/drawing/2014/main" id="{A9D228C0-B69C-42FF-B1AF-93A774DA0BB2}"/>
               </a:ext>
             </a:extLst>
           </p:cNvPr>
@@ -23634,7 +23974,7 @@
           <p:cNvPr id="9" name="">
             <a:extLst xmlns:a="http://schemas.openxmlformats.org/drawingml/2006/main">
               <a:ext uri="{FF2B5EF4-FFF2-40B4-BE49-F238E27FC236}">
-                <a16:creationId xmlns:a16="http://schemas.microsoft.com/office/drawing/2014/main" id="{DEC6B58F-E2D4-4CB1-84D9-B4D8F8B156DA}"/>
+                <a16:creationId xmlns:a16="http://schemas.microsoft.com/office/drawing/2014/main" id="{59FC4666-8C4E-4518-BC38-E29BF7CF4080}"/>
               </a:ext>
             </a:extLst>
           </p:cNvPr>
@@ -23702,7 +24042,7 @@
           <p:cNvPr id="10" name="">
             <a:extLst xmlns:a="http://schemas.openxmlformats.org/drawingml/2006/main">
               <a:ext uri="{FF2B5EF4-FFF2-40B4-BE49-F238E27FC236}">
-                <a16:creationId xmlns:a16="http://schemas.microsoft.com/office/drawing/2014/main" id="{547A90C8-C700-4229-BAA8-63A7A94E09B8}"/>
+                <a16:creationId xmlns:a16="http://schemas.microsoft.com/office/drawing/2014/main" id="{304F2E35-53BC-4318-9D74-1AD068E037E3}"/>
               </a:ext>
             </a:extLst>
           </p:cNvPr>
@@ -23712,7 +24052,7 @@
           <p:nvPr/>
         </p:nvPicPr>
         <p:blipFill>
-          <a:blip xmlns:r="http://schemas.openxmlformats.org/officeDocument/2006/relationships" xmlns:a="http://schemas.openxmlformats.org/drawingml/2006/main" r:embed="Re8bb15efd4a84fac"/>
+          <a:blip xmlns:r="http://schemas.openxmlformats.org/officeDocument/2006/relationships" xmlns:a="http://schemas.openxmlformats.org/drawingml/2006/main" r:embed="R50068eed61c14a4b"/>
           <a:stretch xmlns:a="http://schemas.openxmlformats.org/drawingml/2006/main"/>
         </p:blipFill>
         <p:spPr>
@@ -23730,7 +24070,7 @@
           <p:cNvPr id="11" name="">
             <a:extLst xmlns:a="http://schemas.openxmlformats.org/drawingml/2006/main">
               <a:ext uri="{FF2B5EF4-FFF2-40B4-BE49-F238E27FC236}">
-                <a16:creationId xmlns:a16="http://schemas.microsoft.com/office/drawing/2014/main" id="{89CEA9AD-4D9B-4CEB-B749-0A84AFD85813}"/>
+                <a16:creationId xmlns:a16="http://schemas.microsoft.com/office/drawing/2014/main" id="{EE991F8C-E002-45D0-AA8B-0E8F34BFC9E8}"/>
               </a:ext>
             </a:extLst>
           </p:cNvPr>
@@ -23798,7 +24138,7 @@
           <p:cNvPr id="12" name="">
             <a:extLst xmlns:a="http://schemas.openxmlformats.org/drawingml/2006/main">
               <a:ext uri="{FF2B5EF4-FFF2-40B4-BE49-F238E27FC236}">
-                <a16:creationId xmlns:a16="http://schemas.microsoft.com/office/drawing/2014/main" id="{DDCD19E2-7222-4D33-9681-C8C0215FBA34}"/>
+                <a16:creationId xmlns:a16="http://schemas.microsoft.com/office/drawing/2014/main" id="{D7BEDC5D-07EC-47F7-A692-D77C334C67E1}"/>
               </a:ext>
             </a:extLst>
           </p:cNvPr>
@@ -23866,7 +24206,7 @@
           <p:cNvPr id="13" name="">
             <a:extLst xmlns:a="http://schemas.openxmlformats.org/drawingml/2006/main">
               <a:ext uri="{FF2B5EF4-FFF2-40B4-BE49-F238E27FC236}">
-                <a16:creationId xmlns:a16="http://schemas.microsoft.com/office/drawing/2014/main" id="{D1087D4C-2F7A-49A6-B30B-9EC8F2D810A9}"/>
+                <a16:creationId xmlns:a16="http://schemas.microsoft.com/office/drawing/2014/main" id="{6BADFB2D-851B-4904-9637-BA47E03119CD}"/>
               </a:ext>
             </a:extLst>
           </p:cNvPr>
@@ -23876,7 +24216,7 @@
           <p:nvPr/>
         </p:nvPicPr>
         <p:blipFill>
-          <a:blip xmlns:r="http://schemas.openxmlformats.org/officeDocument/2006/relationships" xmlns:a="http://schemas.openxmlformats.org/drawingml/2006/main" r:embed="R0d229df73e644e04"/>
+          <a:blip xmlns:r="http://schemas.openxmlformats.org/officeDocument/2006/relationships" xmlns:a="http://schemas.openxmlformats.org/drawingml/2006/main" r:embed="R6b935bf193d54af9"/>
           <a:stretch xmlns:a="http://schemas.openxmlformats.org/drawingml/2006/main"/>
         </p:blipFill>
         <p:spPr>
@@ -23894,7 +24234,7 @@
           <p:cNvPr id="14" name="">
             <a:extLst xmlns:a="http://schemas.openxmlformats.org/drawingml/2006/main">
               <a:ext uri="{FF2B5EF4-FFF2-40B4-BE49-F238E27FC236}">
-                <a16:creationId xmlns:a16="http://schemas.microsoft.com/office/drawing/2014/main" id="{A5FB1F4A-C2FB-4631-8095-E81C73C92788}"/>
+                <a16:creationId xmlns:a16="http://schemas.microsoft.com/office/drawing/2014/main" id="{4381D838-B90A-46A2-A453-527AA715ACFB}"/>
               </a:ext>
             </a:extLst>
           </p:cNvPr>
@@ -23962,7 +24302,7 @@
           <p:cNvPr id="15" name="">
             <a:extLst xmlns:a="http://schemas.openxmlformats.org/drawingml/2006/main">
               <a:ext uri="{FF2B5EF4-FFF2-40B4-BE49-F238E27FC236}">
-                <a16:creationId xmlns:a16="http://schemas.microsoft.com/office/drawing/2014/main" id="{FE0005E6-276B-494C-841C-67C4DAC13984}"/>
+                <a16:creationId xmlns:a16="http://schemas.microsoft.com/office/drawing/2014/main" id="{FDFAB8F2-576C-4ABF-900F-C0EB292D3ABA}"/>
               </a:ext>
             </a:extLst>
           </p:cNvPr>
@@ -24030,7 +24370,7 @@
           <p:cNvPr id="16" name="">
             <a:extLst xmlns:a="http://schemas.openxmlformats.org/drawingml/2006/main">
               <a:ext uri="{FF2B5EF4-FFF2-40B4-BE49-F238E27FC236}">
-                <a16:creationId xmlns:a16="http://schemas.microsoft.com/office/drawing/2014/main" id="{EE72B085-EA79-4F63-9243-C153849F9EF4}"/>
+                <a16:creationId xmlns:a16="http://schemas.microsoft.com/office/drawing/2014/main" id="{20C83D73-8EC1-48D7-ABCF-5CF38ACE9FB4}"/>
               </a:ext>
             </a:extLst>
           </p:cNvPr>
@@ -24096,7 +24436,7 @@
     </p:spTree>
     <p:extLst>
       <p:ext uri="{BB962C8B-B14F-4D97-AF65-F5344CB8AC3E}">
-        <p14:creationId xmlns:p14="http://schemas.microsoft.com/office/powerpoint/2010/main" val="1749550159"/>
+        <p14:creationId xmlns:p14="http://schemas.microsoft.com/office/powerpoint/2010/main" val="452969241"/>
       </p:ext>
     </p:extLst>
   </p:cSld>
@@ -24127,7 +24467,7 @@
           <p:cNvPr id="14" name="">
             <a:extLst xmlns:a="http://schemas.openxmlformats.org/drawingml/2006/main">
               <a:ext uri="{FF2B5EF4-FFF2-40B4-BE49-F238E27FC236}">
-                <a16:creationId xmlns:a16="http://schemas.microsoft.com/office/drawing/2014/main" id="{28BF6A88-DE2D-41BC-A0D1-8AF522229660}"/>
+                <a16:creationId xmlns:a16="http://schemas.microsoft.com/office/drawing/2014/main" id="{23BB739F-1C09-4B3D-AD24-E364E4B452FA}"/>
               </a:ext>
             </a:extLst>
           </p:cNvPr>
@@ -24195,7 +24535,7 @@
           <p:cNvPr id="2" name="">
             <a:extLst xmlns:a="http://schemas.openxmlformats.org/drawingml/2006/main">
               <a:ext uri="{FF2B5EF4-FFF2-40B4-BE49-F238E27FC236}">
-                <a16:creationId xmlns:a16="http://schemas.microsoft.com/office/drawing/2014/main" id="{FAE7EBFD-4FAB-487E-88EB-61464D599915}"/>
+                <a16:creationId xmlns:a16="http://schemas.microsoft.com/office/drawing/2014/main" id="{A5AD0B70-A143-4800-AF8E-F11AE5BA174C}"/>
               </a:ext>
             </a:extLst>
           </p:cNvPr>
@@ -24263,7 +24603,7 @@
           <p:cNvPr id="3" name="">
             <a:extLst xmlns:a="http://schemas.openxmlformats.org/drawingml/2006/main">
               <a:ext uri="{FF2B5EF4-FFF2-40B4-BE49-F238E27FC236}">
-                <a16:creationId xmlns:a16="http://schemas.microsoft.com/office/drawing/2014/main" id="{8BE2AFF3-942F-46F2-90CD-E4088C3E1AEB}"/>
+                <a16:creationId xmlns:a16="http://schemas.microsoft.com/office/drawing/2014/main" id="{1E191810-4A67-4568-B7C9-1295D2AD665B}"/>
               </a:ext>
             </a:extLst>
           </p:cNvPr>
@@ -24331,7 +24671,7 @@
           <p:cNvPr id="4" name="">
             <a:extLst xmlns:a="http://schemas.openxmlformats.org/drawingml/2006/main">
               <a:ext uri="{FF2B5EF4-FFF2-40B4-BE49-F238E27FC236}">
-                <a16:creationId xmlns:a16="http://schemas.microsoft.com/office/drawing/2014/main" id="{E376CAC8-F713-46E7-8589-2F409A121FE9}"/>
+                <a16:creationId xmlns:a16="http://schemas.microsoft.com/office/drawing/2014/main" id="{538CC834-4165-40EB-93D9-FB8F17ECB766}"/>
               </a:ext>
             </a:extLst>
           </p:cNvPr>
@@ -24341,7 +24681,7 @@
           <p:nvPr/>
         </p:nvPicPr>
         <p:blipFill>
-          <a:blip xmlns:r="http://schemas.openxmlformats.org/officeDocument/2006/relationships" xmlns:a="http://schemas.openxmlformats.org/drawingml/2006/main" r:embed="Rb22166ed60e34262"/>
+          <a:blip xmlns:r="http://schemas.openxmlformats.org/officeDocument/2006/relationships" xmlns:a="http://schemas.openxmlformats.org/drawingml/2006/main" r:embed="R34e8a1e032fe4663"/>
           <a:stretch xmlns:a="http://schemas.openxmlformats.org/drawingml/2006/main"/>
         </p:blipFill>
         <p:spPr>
@@ -24359,7 +24699,7 @@
           <p:cNvPr id="5" name="">
             <a:extLst xmlns:a="http://schemas.openxmlformats.org/drawingml/2006/main">
               <a:ext uri="{FF2B5EF4-FFF2-40B4-BE49-F238E27FC236}">
-                <a16:creationId xmlns:a16="http://schemas.microsoft.com/office/drawing/2014/main" id="{C562235A-E69C-460B-8440-A0757AF00268}"/>
+                <a16:creationId xmlns:a16="http://schemas.microsoft.com/office/drawing/2014/main" id="{C3DD3F6C-2F23-4B6F-927E-95EA97E421EA}"/>
               </a:ext>
             </a:extLst>
           </p:cNvPr>
@@ -24427,7 +24767,7 @@
           <p:cNvPr id="6" name="">
             <a:extLst xmlns:a="http://schemas.openxmlformats.org/drawingml/2006/main">
               <a:ext uri="{FF2B5EF4-FFF2-40B4-BE49-F238E27FC236}">
-                <a16:creationId xmlns:a16="http://schemas.microsoft.com/office/drawing/2014/main" id="{CFC0E01C-CFAA-427C-AB48-18AC8272E5DF}"/>
+                <a16:creationId xmlns:a16="http://schemas.microsoft.com/office/drawing/2014/main" id="{BF14F468-AF6B-4D1F-BBBE-24FB2C55165A}"/>
               </a:ext>
             </a:extLst>
           </p:cNvPr>
@@ -24495,7 +24835,7 @@
           <p:cNvPr id="7" name="">
             <a:extLst xmlns:a="http://schemas.openxmlformats.org/drawingml/2006/main">
               <a:ext uri="{FF2B5EF4-FFF2-40B4-BE49-F238E27FC236}">
-                <a16:creationId xmlns:a16="http://schemas.microsoft.com/office/drawing/2014/main" id="{6D8FC3A0-223E-4FD4-8390-B4472F2BB91E}"/>
+                <a16:creationId xmlns:a16="http://schemas.microsoft.com/office/drawing/2014/main" id="{92B2E137-2F5E-4B7A-8F9C-544D080C615E}"/>
               </a:ext>
             </a:extLst>
           </p:cNvPr>
@@ -24505,7 +24845,7 @@
           <p:nvPr/>
         </p:nvPicPr>
         <p:blipFill>
-          <a:blip xmlns:r="http://schemas.openxmlformats.org/officeDocument/2006/relationships" xmlns:a="http://schemas.openxmlformats.org/drawingml/2006/main" r:embed="R88e7a117ad564664"/>
+          <a:blip xmlns:r="http://schemas.openxmlformats.org/officeDocument/2006/relationships" xmlns:a="http://schemas.openxmlformats.org/drawingml/2006/main" r:embed="R6edc8366f0b746bb"/>
           <a:stretch xmlns:a="http://schemas.openxmlformats.org/drawingml/2006/main"/>
         </p:blipFill>
         <p:spPr>
@@ -24523,7 +24863,7 @@
           <p:cNvPr id="8" name="">
             <a:extLst xmlns:a="http://schemas.openxmlformats.org/drawingml/2006/main">
               <a:ext uri="{FF2B5EF4-FFF2-40B4-BE49-F238E27FC236}">
-                <a16:creationId xmlns:a16="http://schemas.microsoft.com/office/drawing/2014/main" id="{F0A7B879-2DEC-44BD-91B5-1385571350F6}"/>
+                <a16:creationId xmlns:a16="http://schemas.microsoft.com/office/drawing/2014/main" id="{A291E009-BFAB-4BC9-9AB1-21247FA8DCD2}"/>
               </a:ext>
             </a:extLst>
           </p:cNvPr>
@@ -24591,7 +24931,7 @@
           <p:cNvPr id="9" name="">
             <a:extLst xmlns:a="http://schemas.openxmlformats.org/drawingml/2006/main">
               <a:ext uri="{FF2B5EF4-FFF2-40B4-BE49-F238E27FC236}">
-                <a16:creationId xmlns:a16="http://schemas.microsoft.com/office/drawing/2014/main" id="{0980A3C8-BFA2-4311-831F-7E5A45343D99}"/>
+                <a16:creationId xmlns:a16="http://schemas.microsoft.com/office/drawing/2014/main" id="{B8D58446-EC82-4E45-AFC7-3DD29D46E671}"/>
               </a:ext>
             </a:extLst>
           </p:cNvPr>
@@ -24659,7 +24999,7 @@
           <p:cNvPr id="10" name="">
             <a:extLst xmlns:a="http://schemas.openxmlformats.org/drawingml/2006/main">
               <a:ext uri="{FF2B5EF4-FFF2-40B4-BE49-F238E27FC236}">
-                <a16:creationId xmlns:a16="http://schemas.microsoft.com/office/drawing/2014/main" id="{0700CCB3-E4DE-41E8-9136-32302C4EFA31}"/>
+                <a16:creationId xmlns:a16="http://schemas.microsoft.com/office/drawing/2014/main" id="{6AEA2CF7-9E59-4A3D-A3E5-C7E37B05DA8B}"/>
               </a:ext>
             </a:extLst>
           </p:cNvPr>
@@ -24669,7 +25009,7 @@
           <p:nvPr/>
         </p:nvPicPr>
         <p:blipFill>
-          <a:blip xmlns:r="http://schemas.openxmlformats.org/officeDocument/2006/relationships" xmlns:a="http://schemas.openxmlformats.org/drawingml/2006/main" r:embed="R916e26acc47e4900"/>
+          <a:blip xmlns:r="http://schemas.openxmlformats.org/officeDocument/2006/relationships" xmlns:a="http://schemas.openxmlformats.org/drawingml/2006/main" r:embed="R7302377ec0944d88"/>
           <a:stretch xmlns:a="http://schemas.openxmlformats.org/drawingml/2006/main"/>
         </p:blipFill>
         <p:spPr>
@@ -24687,7 +25027,7 @@
           <p:cNvPr id="11" name="">
             <a:extLst xmlns:a="http://schemas.openxmlformats.org/drawingml/2006/main">
               <a:ext uri="{FF2B5EF4-FFF2-40B4-BE49-F238E27FC236}">
-                <a16:creationId xmlns:a16="http://schemas.microsoft.com/office/drawing/2014/main" id="{978ADB64-2BD6-45BE-9987-E596E989E4EC}"/>
+                <a16:creationId xmlns:a16="http://schemas.microsoft.com/office/drawing/2014/main" id="{D931F2E0-838E-4593-BE80-058E366DA848}"/>
               </a:ext>
             </a:extLst>
           </p:cNvPr>
@@ -24755,7 +25095,7 @@
           <p:cNvPr id="12" name="">
             <a:extLst xmlns:a="http://schemas.openxmlformats.org/drawingml/2006/main">
               <a:ext uri="{FF2B5EF4-FFF2-40B4-BE49-F238E27FC236}">
-                <a16:creationId xmlns:a16="http://schemas.microsoft.com/office/drawing/2014/main" id="{2FF59D58-F02B-4FAE-B8A6-CF3A3FA84B32}"/>
+                <a16:creationId xmlns:a16="http://schemas.microsoft.com/office/drawing/2014/main" id="{9C2FA7B5-2620-4849-A9A7-CFD8EBA2B587}"/>
               </a:ext>
             </a:extLst>
           </p:cNvPr>
@@ -24823,7 +25163,7 @@
           <p:cNvPr id="13" name="">
             <a:extLst xmlns:a="http://schemas.openxmlformats.org/drawingml/2006/main">
               <a:ext uri="{FF2B5EF4-FFF2-40B4-BE49-F238E27FC236}">
-                <a16:creationId xmlns:a16="http://schemas.microsoft.com/office/drawing/2014/main" id="{F38984B8-0472-4F3F-822C-CAE1D15CBC7A}"/>
+                <a16:creationId xmlns:a16="http://schemas.microsoft.com/office/drawing/2014/main" id="{89303321-09C0-4895-BE3A-EA826588FBCA}"/>
               </a:ext>
             </a:extLst>
           </p:cNvPr>
@@ -24889,7 +25229,7 @@
     </p:spTree>
     <p:extLst>
       <p:ext uri="{BB962C8B-B14F-4D97-AF65-F5344CB8AC3E}">
-        <p14:creationId xmlns:p14="http://schemas.microsoft.com/office/powerpoint/2010/main" val="1261334541"/>
+        <p14:creationId xmlns:p14="http://schemas.microsoft.com/office/powerpoint/2010/main" val="1330678869"/>
       </p:ext>
     </p:extLst>
   </p:cSld>
@@ -24920,7 +25260,7 @@
           <p:cNvPr id="15" name="">
             <a:extLst xmlns:a="http://schemas.openxmlformats.org/drawingml/2006/main">
               <a:ext uri="{FF2B5EF4-FFF2-40B4-BE49-F238E27FC236}">
-                <a16:creationId xmlns:a16="http://schemas.microsoft.com/office/drawing/2014/main" id="{07D0798E-8063-406C-91CC-3389EA95362D}"/>
+                <a16:creationId xmlns:a16="http://schemas.microsoft.com/office/drawing/2014/main" id="{47D7B00E-0869-4E7E-A62A-7CBC83580DE0}"/>
               </a:ext>
             </a:extLst>
           </p:cNvPr>
@@ -24930,7 +25270,7 @@
           <p:nvPr/>
         </p:nvPicPr>
         <p:blipFill>
-          <a:blip xmlns:r="http://schemas.openxmlformats.org/officeDocument/2006/relationships" xmlns:a="http://schemas.openxmlformats.org/drawingml/2006/main" r:embed="Rf33122aae7414c68"/>
+          <a:blip xmlns:r="http://schemas.openxmlformats.org/officeDocument/2006/relationships" xmlns:a="http://schemas.openxmlformats.org/drawingml/2006/main" r:embed="R8fabb2c1e035478d"/>
           <a:srcRect xmlns:a="http://schemas.openxmlformats.org/drawingml/2006/main" l="0" t="0" r="0" b="0"/>
           <a:stretch xmlns:a="http://schemas.openxmlformats.org/drawingml/2006/main">
             <a:fillRect l="0" t="0" r="0" b="0"/>
@@ -24951,7 +25291,7 @@
           <p:cNvPr id="2" name="">
             <a:extLst xmlns:a="http://schemas.openxmlformats.org/drawingml/2006/main">
               <a:ext uri="{FF2B5EF4-FFF2-40B4-BE49-F238E27FC236}">
-                <a16:creationId xmlns:a16="http://schemas.microsoft.com/office/drawing/2014/main" id="{AB71BFAA-BA0A-45EE-9C11-0CC9563AF851}"/>
+                <a16:creationId xmlns:a16="http://schemas.microsoft.com/office/drawing/2014/main" id="{7023A1A4-9AD2-40A7-B560-A8D00FA1AC45}"/>
               </a:ext>
             </a:extLst>
           </p:cNvPr>
@@ -25019,7 +25359,7 @@
           <p:cNvPr id="3" name="">
             <a:extLst xmlns:a="http://schemas.openxmlformats.org/drawingml/2006/main">
               <a:ext uri="{FF2B5EF4-FFF2-40B4-BE49-F238E27FC236}">
-                <a16:creationId xmlns:a16="http://schemas.microsoft.com/office/drawing/2014/main" id="{8778FDBF-F0A8-4AD3-8FFF-2ED46E322281}"/>
+                <a16:creationId xmlns:a16="http://schemas.microsoft.com/office/drawing/2014/main" id="{C8CDFC08-A79A-4606-AF73-0FF5B96ADEB6}"/>
               </a:ext>
             </a:extLst>
           </p:cNvPr>
@@ -25087,7 +25427,7 @@
           <p:cNvPr id="4" name="">
             <a:extLst xmlns:a="http://schemas.openxmlformats.org/drawingml/2006/main">
               <a:ext uri="{FF2B5EF4-FFF2-40B4-BE49-F238E27FC236}">
-                <a16:creationId xmlns:a16="http://schemas.microsoft.com/office/drawing/2014/main" id="{73224F06-CD3C-4850-B1C0-121019F33323}"/>
+                <a16:creationId xmlns:a16="http://schemas.microsoft.com/office/drawing/2014/main" id="{24AE2FF8-B024-495A-989A-06E2C7F9B40C}"/>
               </a:ext>
             </a:extLst>
           </p:cNvPr>
@@ -25155,7 +25495,7 @@
           <p:cNvPr id="5" name="">
             <a:extLst xmlns:a="http://schemas.openxmlformats.org/drawingml/2006/main">
               <a:ext uri="{FF2B5EF4-FFF2-40B4-BE49-F238E27FC236}">
-                <a16:creationId xmlns:a16="http://schemas.microsoft.com/office/drawing/2014/main" id="{97985AA8-887B-4C0B-A775-7329C33D1545}"/>
+                <a16:creationId xmlns:a16="http://schemas.microsoft.com/office/drawing/2014/main" id="{CEDA1560-C6BB-4863-B2E6-1F7786806394}"/>
               </a:ext>
             </a:extLst>
           </p:cNvPr>
@@ -25223,7 +25563,7 @@
           <p:cNvPr id="6" name="">
             <a:extLst xmlns:a="http://schemas.openxmlformats.org/drawingml/2006/main">
               <a:ext uri="{FF2B5EF4-FFF2-40B4-BE49-F238E27FC236}">
-                <a16:creationId xmlns:a16="http://schemas.microsoft.com/office/drawing/2014/main" id="{1FDB4F29-E44A-4960-A43F-2630BC495C02}"/>
+                <a16:creationId xmlns:a16="http://schemas.microsoft.com/office/drawing/2014/main" id="{F833ACE7-2F5D-4F4D-9594-064FDB95305F}"/>
               </a:ext>
             </a:extLst>
           </p:cNvPr>
@@ -25314,7 +25654,7 @@
           <p:cNvPr id="7" name="">
             <a:extLst xmlns:a="http://schemas.openxmlformats.org/drawingml/2006/main">
               <a:ext uri="{FF2B5EF4-FFF2-40B4-BE49-F238E27FC236}">
-                <a16:creationId xmlns:a16="http://schemas.microsoft.com/office/drawing/2014/main" id="{1F70CBBE-F8C6-4675-B292-8DFBF2980C8F}"/>
+                <a16:creationId xmlns:a16="http://schemas.microsoft.com/office/drawing/2014/main" id="{BCEAEC33-8FDD-45D7-962F-EAB9C5145B99}"/>
               </a:ext>
             </a:extLst>
           </p:cNvPr>
@@ -25382,7 +25722,7 @@
           <p:cNvPr id="8" name="">
             <a:extLst xmlns:a="http://schemas.openxmlformats.org/drawingml/2006/main">
               <a:ext uri="{FF2B5EF4-FFF2-40B4-BE49-F238E27FC236}">
-                <a16:creationId xmlns:a16="http://schemas.microsoft.com/office/drawing/2014/main" id="{F51A91E5-B830-4ADB-B4EA-9A5F3DF919D4}"/>
+                <a16:creationId xmlns:a16="http://schemas.microsoft.com/office/drawing/2014/main" id="{52BCD391-5174-49BC-9511-789CD22263DC}"/>
               </a:ext>
             </a:extLst>
           </p:cNvPr>
@@ -25450,7 +25790,7 @@
           <p:cNvPr id="9" name="">
             <a:extLst xmlns:a="http://schemas.openxmlformats.org/drawingml/2006/main">
               <a:ext uri="{FF2B5EF4-FFF2-40B4-BE49-F238E27FC236}">
-                <a16:creationId xmlns:a16="http://schemas.microsoft.com/office/drawing/2014/main" id="{85D45CD4-682F-4CDB-9FED-31E7C1C904CD}"/>
+                <a16:creationId xmlns:a16="http://schemas.microsoft.com/office/drawing/2014/main" id="{D5FF5B9B-2BED-45B0-9BA8-73EDD936BEC0}"/>
               </a:ext>
             </a:extLst>
           </p:cNvPr>
@@ -25518,7 +25858,7 @@
           <p:cNvPr id="10" name="">
             <a:extLst xmlns:a="http://schemas.openxmlformats.org/drawingml/2006/main">
               <a:ext uri="{FF2B5EF4-FFF2-40B4-BE49-F238E27FC236}">
-                <a16:creationId xmlns:a16="http://schemas.microsoft.com/office/drawing/2014/main" id="{48D29382-7F6D-486E-8D6C-0FCC67E13FCA}"/>
+                <a16:creationId xmlns:a16="http://schemas.microsoft.com/office/drawing/2014/main" id="{B861DA2E-3D8F-448A-83E4-E405345ADE48}"/>
               </a:ext>
             </a:extLst>
           </p:cNvPr>
@@ -25586,7 +25926,7 @@
           <p:cNvPr id="11" name="">
             <a:extLst xmlns:a="http://schemas.openxmlformats.org/drawingml/2006/main">
               <a:ext uri="{FF2B5EF4-FFF2-40B4-BE49-F238E27FC236}">
-                <a16:creationId xmlns:a16="http://schemas.microsoft.com/office/drawing/2014/main" id="{2A394EB6-891A-4C9D-811F-79DE44BB940A}"/>
+                <a16:creationId xmlns:a16="http://schemas.microsoft.com/office/drawing/2014/main" id="{AF49C9AF-54ED-4EBB-8D3C-11834EBFFBD1}"/>
               </a:ext>
             </a:extLst>
           </p:cNvPr>
@@ -25654,7 +25994,7 @@
           <p:cNvPr id="12" name="">
             <a:extLst xmlns:a="http://schemas.openxmlformats.org/drawingml/2006/main">
               <a:ext uri="{FF2B5EF4-FFF2-40B4-BE49-F238E27FC236}">
-                <a16:creationId xmlns:a16="http://schemas.microsoft.com/office/drawing/2014/main" id="{348440FB-8ED7-443B-B051-0E617CEB2960}"/>
+                <a16:creationId xmlns:a16="http://schemas.microsoft.com/office/drawing/2014/main" id="{F77DB482-4C8A-40D1-BEE5-C675B761B648}"/>
               </a:ext>
             </a:extLst>
           </p:cNvPr>
@@ -25722,7 +26062,7 @@
           <p:cNvPr id="13" name="">
             <a:extLst xmlns:a="http://schemas.openxmlformats.org/drawingml/2006/main">
               <a:ext uri="{FF2B5EF4-FFF2-40B4-BE49-F238E27FC236}">
-                <a16:creationId xmlns:a16="http://schemas.microsoft.com/office/drawing/2014/main" id="{D3334E6E-18B6-4E1A-9D7C-55CD80CC2F83}"/>
+                <a16:creationId xmlns:a16="http://schemas.microsoft.com/office/drawing/2014/main" id="{1F98A8B9-AD84-46F4-8CFF-BCCDAD113A9C}"/>
               </a:ext>
             </a:extLst>
           </p:cNvPr>
@@ -25790,7 +26130,7 @@
           <p:cNvPr id="14" name="">
             <a:extLst xmlns:a="http://schemas.openxmlformats.org/drawingml/2006/main">
               <a:ext uri="{FF2B5EF4-FFF2-40B4-BE49-F238E27FC236}">
-                <a16:creationId xmlns:a16="http://schemas.microsoft.com/office/drawing/2014/main" id="{7524755D-2028-4E61-B807-CCA4A622296E}"/>
+                <a16:creationId xmlns:a16="http://schemas.microsoft.com/office/drawing/2014/main" id="{680E70E7-2AF5-4DDD-955C-3847F79DE97F}"/>
               </a:ext>
             </a:extLst>
           </p:cNvPr>
@@ -25856,7 +26196,7 @@
     </p:spTree>
     <p:extLst>
       <p:ext uri="{BB962C8B-B14F-4D97-AF65-F5344CB8AC3E}">
-        <p14:creationId xmlns:p14="http://schemas.microsoft.com/office/powerpoint/2010/main" val="1295376348"/>
+        <p14:creationId xmlns:p14="http://schemas.microsoft.com/office/powerpoint/2010/main" val="933172931"/>
       </p:ext>
     </p:extLst>
   </p:cSld>
@@ -25887,7 +26227,7 @@
           <p:cNvPr id="29" name="">
             <a:extLst xmlns:a="http://schemas.openxmlformats.org/drawingml/2006/main">
               <a:ext uri="{FF2B5EF4-FFF2-40B4-BE49-F238E27FC236}">
-                <a16:creationId xmlns:a16="http://schemas.microsoft.com/office/drawing/2014/main" id="{EFBB3F23-F183-4668-BD27-79211C829233}"/>
+                <a16:creationId xmlns:a16="http://schemas.microsoft.com/office/drawing/2014/main" id="{2F04A4C7-F2D4-4348-955D-3894B40B80C7}"/>
               </a:ext>
             </a:extLst>
           </p:cNvPr>
@@ -25955,7 +26295,7 @@
           <p:cNvPr id="2" name="">
             <a:extLst xmlns:a="http://schemas.openxmlformats.org/drawingml/2006/main">
               <a:ext uri="{FF2B5EF4-FFF2-40B4-BE49-F238E27FC236}">
-                <a16:creationId xmlns:a16="http://schemas.microsoft.com/office/drawing/2014/main" id="{7BD68548-74C6-4163-B3AC-DDC334C12EE8}"/>
+                <a16:creationId xmlns:a16="http://schemas.microsoft.com/office/drawing/2014/main" id="{14151C45-1157-4D3E-91E1-456F981D09FF}"/>
               </a:ext>
             </a:extLst>
           </p:cNvPr>
@@ -26023,7 +26363,7 @@
           <p:cNvPr id="3" name="">
             <a:extLst xmlns:a="http://schemas.openxmlformats.org/drawingml/2006/main">
               <a:ext uri="{FF2B5EF4-FFF2-40B4-BE49-F238E27FC236}">
-                <a16:creationId xmlns:a16="http://schemas.microsoft.com/office/drawing/2014/main" id="{7057CB21-BA81-4EB2-88F1-59DBC03E925A}"/>
+                <a16:creationId xmlns:a16="http://schemas.microsoft.com/office/drawing/2014/main" id="{4BF81F6A-22F5-438B-B070-A14805AFCAC0}"/>
               </a:ext>
             </a:extLst>
           </p:cNvPr>
@@ -26091,7 +26431,7 @@
           <p:cNvPr id="4" name="">
             <a:extLst xmlns:a="http://schemas.openxmlformats.org/drawingml/2006/main">
               <a:ext uri="{FF2B5EF4-FFF2-40B4-BE49-F238E27FC236}">
-                <a16:creationId xmlns:a16="http://schemas.microsoft.com/office/drawing/2014/main" id="{9C16BB99-3D9E-42A1-9BE4-CA07A8CCF12A}"/>
+                <a16:creationId xmlns:a16="http://schemas.microsoft.com/office/drawing/2014/main" id="{35D742B6-0C19-4764-9F54-03F215D3B861}"/>
               </a:ext>
             </a:extLst>
           </p:cNvPr>
@@ -26123,7 +26463,7 @@
           <p:cNvPr id="5" name="">
             <a:extLst xmlns:a="http://schemas.openxmlformats.org/drawingml/2006/main">
               <a:ext uri="{FF2B5EF4-FFF2-40B4-BE49-F238E27FC236}">
-                <a16:creationId xmlns:a16="http://schemas.microsoft.com/office/drawing/2014/main" id="{BDD5D3DA-A86D-456C-81F6-1BD07CE05475}"/>
+                <a16:creationId xmlns:a16="http://schemas.microsoft.com/office/drawing/2014/main" id="{4AD9A41B-1EA8-4229-A149-F1C833264314}"/>
               </a:ext>
             </a:extLst>
           </p:cNvPr>
@@ -26191,7 +26531,7 @@
           <p:cNvPr id="6" name="">
             <a:extLst xmlns:a="http://schemas.openxmlformats.org/drawingml/2006/main">
               <a:ext uri="{FF2B5EF4-FFF2-40B4-BE49-F238E27FC236}">
-                <a16:creationId xmlns:a16="http://schemas.microsoft.com/office/drawing/2014/main" id="{D082BD1A-9E0D-40D8-9165-501B854682F8}"/>
+                <a16:creationId xmlns:a16="http://schemas.microsoft.com/office/drawing/2014/main" id="{23ABCD74-34BF-448B-A74F-26FC395EB069}"/>
               </a:ext>
             </a:extLst>
           </p:cNvPr>
@@ -26259,7 +26599,7 @@
           <p:cNvPr id="7" name="">
             <a:extLst xmlns:a="http://schemas.openxmlformats.org/drawingml/2006/main">
               <a:ext uri="{FF2B5EF4-FFF2-40B4-BE49-F238E27FC236}">
-                <a16:creationId xmlns:a16="http://schemas.microsoft.com/office/drawing/2014/main" id="{D5AEB1B1-2B6D-4BCE-BBF8-E13763E5C575}"/>
+                <a16:creationId xmlns:a16="http://schemas.microsoft.com/office/drawing/2014/main" id="{7B13E3C6-B185-4AAB-A627-03EC925DD61D}"/>
               </a:ext>
             </a:extLst>
           </p:cNvPr>
@@ -26327,7 +26667,7 @@
           <p:cNvPr id="8" name="">
             <a:extLst xmlns:a="http://schemas.openxmlformats.org/drawingml/2006/main">
               <a:ext uri="{FF2B5EF4-FFF2-40B4-BE49-F238E27FC236}">
-                <a16:creationId xmlns:a16="http://schemas.microsoft.com/office/drawing/2014/main" id="{BA48CA48-D090-487C-A2B0-A034965A0078}"/>
+                <a16:creationId xmlns:a16="http://schemas.microsoft.com/office/drawing/2014/main" id="{1CFD8C6B-B5F7-47C2-B519-5048593E870A}"/>
               </a:ext>
             </a:extLst>
           </p:cNvPr>
@@ -26357,7 +26697,7 @@
           <p:cNvPr id="9" name="">
             <a:extLst xmlns:a="http://schemas.openxmlformats.org/drawingml/2006/main">
               <a:ext uri="{FF2B5EF4-FFF2-40B4-BE49-F238E27FC236}">
-                <a16:creationId xmlns:a16="http://schemas.microsoft.com/office/drawing/2014/main" id="{FFC3019D-0EF6-405B-8FC3-9B4D7AF7B517}"/>
+                <a16:creationId xmlns:a16="http://schemas.microsoft.com/office/drawing/2014/main" id="{7F356AE5-51E6-4EA8-A61A-5746B9721254}"/>
               </a:ext>
             </a:extLst>
           </p:cNvPr>
@@ -26389,7 +26729,7 @@
           <p:cNvPr id="10" name="">
             <a:extLst xmlns:a="http://schemas.openxmlformats.org/drawingml/2006/main">
               <a:ext uri="{FF2B5EF4-FFF2-40B4-BE49-F238E27FC236}">
-                <a16:creationId xmlns:a16="http://schemas.microsoft.com/office/drawing/2014/main" id="{DD64CD9E-5D37-44C7-849E-F61E42C2481A}"/>
+                <a16:creationId xmlns:a16="http://schemas.microsoft.com/office/drawing/2014/main" id="{1E669638-D63B-4758-943C-90F2FAFAB74F}"/>
               </a:ext>
             </a:extLst>
           </p:cNvPr>
@@ -26457,7 +26797,7 @@
           <p:cNvPr id="11" name="">
             <a:extLst xmlns:a="http://schemas.openxmlformats.org/drawingml/2006/main">
               <a:ext uri="{FF2B5EF4-FFF2-40B4-BE49-F238E27FC236}">
-                <a16:creationId xmlns:a16="http://schemas.microsoft.com/office/drawing/2014/main" id="{E448A365-2DF8-46F4-AB90-BD650D263D3C}"/>
+                <a16:creationId xmlns:a16="http://schemas.microsoft.com/office/drawing/2014/main" id="{783BABF3-9E22-42B6-86EB-7D8651AA962D}"/>
               </a:ext>
             </a:extLst>
           </p:cNvPr>
@@ -26525,7 +26865,7 @@
           <p:cNvPr id="12" name="">
             <a:extLst xmlns:a="http://schemas.openxmlformats.org/drawingml/2006/main">
               <a:ext uri="{FF2B5EF4-FFF2-40B4-BE49-F238E27FC236}">
-                <a16:creationId xmlns:a16="http://schemas.microsoft.com/office/drawing/2014/main" id="{19053871-1DC0-408D-832A-1E9C2CEB5D79}"/>
+                <a16:creationId xmlns:a16="http://schemas.microsoft.com/office/drawing/2014/main" id="{587FD247-F12B-4026-BE91-42042C162FC8}"/>
               </a:ext>
             </a:extLst>
           </p:cNvPr>
@@ -26593,7 +26933,7 @@
           <p:cNvPr id="13" name="">
             <a:extLst xmlns:a="http://schemas.openxmlformats.org/drawingml/2006/main">
               <a:ext uri="{FF2B5EF4-FFF2-40B4-BE49-F238E27FC236}">
-                <a16:creationId xmlns:a16="http://schemas.microsoft.com/office/drawing/2014/main" id="{12F341E8-43CE-4317-9828-012FCC43BEA3}"/>
+                <a16:creationId xmlns:a16="http://schemas.microsoft.com/office/drawing/2014/main" id="{153B8774-BD09-4625-B71D-9768CC4AF60C}"/>
               </a:ext>
             </a:extLst>
           </p:cNvPr>
@@ -26623,7 +26963,7 @@
           <p:cNvPr id="14" name="">
             <a:extLst xmlns:a="http://schemas.openxmlformats.org/drawingml/2006/main">
               <a:ext uri="{FF2B5EF4-FFF2-40B4-BE49-F238E27FC236}">
-                <a16:creationId xmlns:a16="http://schemas.microsoft.com/office/drawing/2014/main" id="{720DBF63-2519-4CC8-B2E6-5C2D1A6286ED}"/>
+                <a16:creationId xmlns:a16="http://schemas.microsoft.com/office/drawing/2014/main" id="{C5B28165-18D6-4DDE-B490-A7E1E098A6CC}"/>
               </a:ext>
             </a:extLst>
           </p:cNvPr>
@@ -26655,7 +26995,7 @@
           <p:cNvPr id="15" name="">
             <a:extLst xmlns:a="http://schemas.openxmlformats.org/drawingml/2006/main">
               <a:ext uri="{FF2B5EF4-FFF2-40B4-BE49-F238E27FC236}">
-                <a16:creationId xmlns:a16="http://schemas.microsoft.com/office/drawing/2014/main" id="{DF12796A-4F3C-41D7-B82A-A56E4FC9B3B2}"/>
+                <a16:creationId xmlns:a16="http://schemas.microsoft.com/office/drawing/2014/main" id="{BED11358-085A-45D9-A575-E42FF595C843}"/>
               </a:ext>
             </a:extLst>
           </p:cNvPr>
@@ -26723,7 +27063,7 @@
           <p:cNvPr id="16" name="">
             <a:extLst xmlns:a="http://schemas.openxmlformats.org/drawingml/2006/main">
               <a:ext uri="{FF2B5EF4-FFF2-40B4-BE49-F238E27FC236}">
-                <a16:creationId xmlns:a16="http://schemas.microsoft.com/office/drawing/2014/main" id="{64DA134D-F067-45E7-9094-3925A3975345}"/>
+                <a16:creationId xmlns:a16="http://schemas.microsoft.com/office/drawing/2014/main" id="{F5EA82EF-41BD-4F26-B9A8-F28BCAE9E4A8}"/>
               </a:ext>
             </a:extLst>
           </p:cNvPr>
@@ -26791,7 +27131,7 @@
           <p:cNvPr id="17" name="">
             <a:extLst xmlns:a="http://schemas.openxmlformats.org/drawingml/2006/main">
               <a:ext uri="{FF2B5EF4-FFF2-40B4-BE49-F238E27FC236}">
-                <a16:creationId xmlns:a16="http://schemas.microsoft.com/office/drawing/2014/main" id="{1686D8B1-3E88-457F-9855-ABCC00E6006A}"/>
+                <a16:creationId xmlns:a16="http://schemas.microsoft.com/office/drawing/2014/main" id="{5C25958E-DDF1-4325-8B88-69D7879CFBA9}"/>
               </a:ext>
             </a:extLst>
           </p:cNvPr>
@@ -26859,7 +27199,7 @@
           <p:cNvPr id="18" name="">
             <a:extLst xmlns:a="http://schemas.openxmlformats.org/drawingml/2006/main">
               <a:ext uri="{FF2B5EF4-FFF2-40B4-BE49-F238E27FC236}">
-                <a16:creationId xmlns:a16="http://schemas.microsoft.com/office/drawing/2014/main" id="{83B856F3-BD83-43A0-BD8D-F1B63A3259CD}"/>
+                <a16:creationId xmlns:a16="http://schemas.microsoft.com/office/drawing/2014/main" id="{0A27DAC5-812D-4E33-98D1-050A1B3DFF23}"/>
               </a:ext>
             </a:extLst>
           </p:cNvPr>
@@ -26889,7 +27229,7 @@
           <p:cNvPr id="19" name="">
             <a:extLst xmlns:a="http://schemas.openxmlformats.org/drawingml/2006/main">
               <a:ext uri="{FF2B5EF4-FFF2-40B4-BE49-F238E27FC236}">
-                <a16:creationId xmlns:a16="http://schemas.microsoft.com/office/drawing/2014/main" id="{321779C3-3C17-4AF1-8815-4C6CAC5A4EA3}"/>
+                <a16:creationId xmlns:a16="http://schemas.microsoft.com/office/drawing/2014/main" id="{361304BC-F30A-48B9-BF74-CB89ED491B1B}"/>
               </a:ext>
             </a:extLst>
           </p:cNvPr>
@@ -26921,7 +27261,7 @@
           <p:cNvPr id="20" name="">
             <a:extLst xmlns:a="http://schemas.openxmlformats.org/drawingml/2006/main">
               <a:ext uri="{FF2B5EF4-FFF2-40B4-BE49-F238E27FC236}">
-                <a16:creationId xmlns:a16="http://schemas.microsoft.com/office/drawing/2014/main" id="{D7D1C67D-2719-436A-9048-FABF27194B95}"/>
+                <a16:creationId xmlns:a16="http://schemas.microsoft.com/office/drawing/2014/main" id="{7DB1BCDB-D63A-4704-B45A-3F849099E970}"/>
               </a:ext>
             </a:extLst>
           </p:cNvPr>
@@ -26989,7 +27329,7 @@
           <p:cNvPr id="21" name="">
             <a:extLst xmlns:a="http://schemas.openxmlformats.org/drawingml/2006/main">
               <a:ext uri="{FF2B5EF4-FFF2-40B4-BE49-F238E27FC236}">
-                <a16:creationId xmlns:a16="http://schemas.microsoft.com/office/drawing/2014/main" id="{115674B8-1D7B-4F93-9121-81C8809893CE}"/>
+                <a16:creationId xmlns:a16="http://schemas.microsoft.com/office/drawing/2014/main" id="{179DC6F1-FFB8-47DD-878F-0FDB0B80926B}"/>
               </a:ext>
             </a:extLst>
           </p:cNvPr>
@@ -27057,7 +27397,7 @@
           <p:cNvPr id="22" name="">
             <a:extLst xmlns:a="http://schemas.openxmlformats.org/drawingml/2006/main">
               <a:ext uri="{FF2B5EF4-FFF2-40B4-BE49-F238E27FC236}">
-                <a16:creationId xmlns:a16="http://schemas.microsoft.com/office/drawing/2014/main" id="{5AD8ACCD-E9F8-455D-9B0B-57F229FB64EF}"/>
+                <a16:creationId xmlns:a16="http://schemas.microsoft.com/office/drawing/2014/main" id="{B7C2F5EA-FDA2-4087-A50A-F2984171DFDC}"/>
               </a:ext>
             </a:extLst>
           </p:cNvPr>
@@ -27125,7 +27465,7 @@
           <p:cNvPr id="23" name="">
             <a:extLst xmlns:a="http://schemas.openxmlformats.org/drawingml/2006/main">
               <a:ext uri="{FF2B5EF4-FFF2-40B4-BE49-F238E27FC236}">
-                <a16:creationId xmlns:a16="http://schemas.microsoft.com/office/drawing/2014/main" id="{FBD2113B-D6E2-4C9E-8A3D-8C1CCCEC90C6}"/>
+                <a16:creationId xmlns:a16="http://schemas.microsoft.com/office/drawing/2014/main" id="{3C874855-22E4-40E0-8AC7-1CA56D75B9B6}"/>
               </a:ext>
             </a:extLst>
           </p:cNvPr>
@@ -27155,7 +27495,7 @@
           <p:cNvPr id="24" name="">
             <a:extLst xmlns:a="http://schemas.openxmlformats.org/drawingml/2006/main">
               <a:ext uri="{FF2B5EF4-FFF2-40B4-BE49-F238E27FC236}">
-                <a16:creationId xmlns:a16="http://schemas.microsoft.com/office/drawing/2014/main" id="{BA969DDC-2BC1-40E7-8635-D5BD44BE0FD7}"/>
+                <a16:creationId xmlns:a16="http://schemas.microsoft.com/office/drawing/2014/main" id="{4CE12814-C0B1-4E66-9E22-6435694FB992}"/>
               </a:ext>
             </a:extLst>
           </p:cNvPr>
@@ -27187,7 +27527,7 @@
           <p:cNvPr id="25" name="">
             <a:extLst xmlns:a="http://schemas.openxmlformats.org/drawingml/2006/main">
               <a:ext uri="{FF2B5EF4-FFF2-40B4-BE49-F238E27FC236}">
-                <a16:creationId xmlns:a16="http://schemas.microsoft.com/office/drawing/2014/main" id="{216E31FE-057A-4EE8-95EF-D5C099E63FE5}"/>
+                <a16:creationId xmlns:a16="http://schemas.microsoft.com/office/drawing/2014/main" id="{9600D40E-4E0C-4125-8096-BB03439F2B58}"/>
               </a:ext>
             </a:extLst>
           </p:cNvPr>
@@ -27255,7 +27595,7 @@
           <p:cNvPr id="26" name="">
             <a:extLst xmlns:a="http://schemas.openxmlformats.org/drawingml/2006/main">
               <a:ext uri="{FF2B5EF4-FFF2-40B4-BE49-F238E27FC236}">
-                <a16:creationId xmlns:a16="http://schemas.microsoft.com/office/drawing/2014/main" id="{74187858-26E6-42E8-8187-E4DC8BC9C5BD}"/>
+                <a16:creationId xmlns:a16="http://schemas.microsoft.com/office/drawing/2014/main" id="{B694D228-B9F9-4797-935D-E96280B999A9}"/>
               </a:ext>
             </a:extLst>
           </p:cNvPr>
@@ -27323,7 +27663,7 @@
           <p:cNvPr id="27" name="">
             <a:extLst xmlns:a="http://schemas.openxmlformats.org/drawingml/2006/main">
               <a:ext uri="{FF2B5EF4-FFF2-40B4-BE49-F238E27FC236}">
-                <a16:creationId xmlns:a16="http://schemas.microsoft.com/office/drawing/2014/main" id="{48A21637-466A-47B1-AAD6-EB1ABE1C3F59}"/>
+                <a16:creationId xmlns:a16="http://schemas.microsoft.com/office/drawing/2014/main" id="{373369EA-B2A8-40D1-87FB-1DE9D95FBDDB}"/>
               </a:ext>
             </a:extLst>
           </p:cNvPr>
@@ -27391,7 +27731,7 @@
           <p:cNvPr id="28" name="">
             <a:extLst xmlns:a="http://schemas.openxmlformats.org/drawingml/2006/main">
               <a:ext uri="{FF2B5EF4-FFF2-40B4-BE49-F238E27FC236}">
-                <a16:creationId xmlns:a16="http://schemas.microsoft.com/office/drawing/2014/main" id="{433C783B-16EE-4D6A-A19C-54D796B822D9}"/>
+                <a16:creationId xmlns:a16="http://schemas.microsoft.com/office/drawing/2014/main" id="{D5B8B3B8-5D87-4F0D-B2D6-58273D13D284}"/>
               </a:ext>
             </a:extLst>
           </p:cNvPr>
@@ -27457,7 +27797,7 @@
     </p:spTree>
     <p:extLst>
       <p:ext uri="{BB962C8B-B14F-4D97-AF65-F5344CB8AC3E}">
-        <p14:creationId xmlns:p14="http://schemas.microsoft.com/office/powerpoint/2010/main" val="1592230833"/>
+        <p14:creationId xmlns:p14="http://schemas.microsoft.com/office/powerpoint/2010/main" val="1737940029"/>
       </p:ext>
     </p:extLst>
   </p:cSld>
@@ -27488,7 +27828,7 @@
           <p:cNvPr id="21" name="">
             <a:extLst xmlns:a="http://schemas.openxmlformats.org/drawingml/2006/main">
               <a:ext uri="{FF2B5EF4-FFF2-40B4-BE49-F238E27FC236}">
-                <a16:creationId xmlns:a16="http://schemas.microsoft.com/office/drawing/2014/main" id="{6459B5A1-5DD2-4E9B-B791-E2A2ABD35BF5}"/>
+                <a16:creationId xmlns:a16="http://schemas.microsoft.com/office/drawing/2014/main" id="{C8DDB032-3E43-42A2-8A78-F4D981710F90}"/>
               </a:ext>
             </a:extLst>
           </p:cNvPr>
@@ -27556,7 +27896,7 @@
           <p:cNvPr id="2" name="">
             <a:extLst xmlns:a="http://schemas.openxmlformats.org/drawingml/2006/main">
               <a:ext uri="{FF2B5EF4-FFF2-40B4-BE49-F238E27FC236}">
-                <a16:creationId xmlns:a16="http://schemas.microsoft.com/office/drawing/2014/main" id="{CD7C68EB-4D20-415E-B3C4-58DE09B3C63D}"/>
+                <a16:creationId xmlns:a16="http://schemas.microsoft.com/office/drawing/2014/main" id="{E0C210E1-738B-427F-9806-2F56B9360EDE}"/>
               </a:ext>
             </a:extLst>
           </p:cNvPr>
@@ -27624,7 +27964,7 @@
           <p:cNvPr id="3" name="">
             <a:extLst xmlns:a="http://schemas.openxmlformats.org/drawingml/2006/main">
               <a:ext uri="{FF2B5EF4-FFF2-40B4-BE49-F238E27FC236}">
-                <a16:creationId xmlns:a16="http://schemas.microsoft.com/office/drawing/2014/main" id="{E9AA4CF5-A44B-4418-BADD-7F48BAED8483}"/>
+                <a16:creationId xmlns:a16="http://schemas.microsoft.com/office/drawing/2014/main" id="{FB9D66C7-71B4-470B-AF5A-1FA1886E33FB}"/>
               </a:ext>
             </a:extLst>
           </p:cNvPr>
@@ -27692,7 +28032,7 @@
           <p:cNvPr id="4" name="">
             <a:extLst xmlns:a="http://schemas.openxmlformats.org/drawingml/2006/main">
               <a:ext uri="{FF2B5EF4-FFF2-40B4-BE49-F238E27FC236}">
-                <a16:creationId xmlns:a16="http://schemas.microsoft.com/office/drawing/2014/main" id="{6BEEE5FE-528F-4246-86F8-4949188994A8}"/>
+                <a16:creationId xmlns:a16="http://schemas.microsoft.com/office/drawing/2014/main" id="{3D1139B8-F5C4-401F-BF55-EFCE66621154}"/>
               </a:ext>
             </a:extLst>
           </p:cNvPr>
@@ -27760,7 +28100,7 @@
           <p:cNvPr id="5" name="">
             <a:extLst xmlns:a="http://schemas.openxmlformats.org/drawingml/2006/main">
               <a:ext uri="{FF2B5EF4-FFF2-40B4-BE49-F238E27FC236}">
-                <a16:creationId xmlns:a16="http://schemas.microsoft.com/office/drawing/2014/main" id="{680C653A-6C3F-4BB1-A8D2-D5406CD21391}"/>
+                <a16:creationId xmlns:a16="http://schemas.microsoft.com/office/drawing/2014/main" id="{1209187D-B1BE-4731-A260-7711225B045E}"/>
               </a:ext>
             </a:extLst>
           </p:cNvPr>
@@ -27828,7 +28168,7 @@
           <p:cNvPr id="6" name="">
             <a:extLst xmlns:a="http://schemas.openxmlformats.org/drawingml/2006/main">
               <a:ext uri="{FF2B5EF4-FFF2-40B4-BE49-F238E27FC236}">
-                <a16:creationId xmlns:a16="http://schemas.microsoft.com/office/drawing/2014/main" id="{5A31B3E4-E161-40E9-ACE6-1E8C4F3A5E7B}"/>
+                <a16:creationId xmlns:a16="http://schemas.microsoft.com/office/drawing/2014/main" id="{1301C628-24E1-4064-9386-C288C6439793}"/>
               </a:ext>
             </a:extLst>
           </p:cNvPr>
@@ -27896,7 +28236,7 @@
           <p:cNvPr id="7" name="">
             <a:extLst xmlns:a="http://schemas.openxmlformats.org/drawingml/2006/main">
               <a:ext uri="{FF2B5EF4-FFF2-40B4-BE49-F238E27FC236}">
-                <a16:creationId xmlns:a16="http://schemas.microsoft.com/office/drawing/2014/main" id="{DA8BE42A-4E4E-4E0E-BCDF-06F62AD0E0C0}"/>
+                <a16:creationId xmlns:a16="http://schemas.microsoft.com/office/drawing/2014/main" id="{6B77AABC-0C81-463D-9758-5C5EE28C5865}"/>
               </a:ext>
             </a:extLst>
           </p:cNvPr>
@@ -27964,7 +28304,7 @@
           <p:cNvPr id="8" name="">
             <a:extLst xmlns:a="http://schemas.openxmlformats.org/drawingml/2006/main">
               <a:ext uri="{FF2B5EF4-FFF2-40B4-BE49-F238E27FC236}">
-                <a16:creationId xmlns:a16="http://schemas.microsoft.com/office/drawing/2014/main" id="{2F534C9A-079A-4A17-8B50-60BB149E220E}"/>
+                <a16:creationId xmlns:a16="http://schemas.microsoft.com/office/drawing/2014/main" id="{2D754E0C-4F56-4F7D-AAF1-426468E91296}"/>
               </a:ext>
             </a:extLst>
           </p:cNvPr>
@@ -28032,7 +28372,7 @@
           <p:cNvPr id="9" name="">
             <a:extLst xmlns:a="http://schemas.openxmlformats.org/drawingml/2006/main">
               <a:ext uri="{FF2B5EF4-FFF2-40B4-BE49-F238E27FC236}">
-                <a16:creationId xmlns:a16="http://schemas.microsoft.com/office/drawing/2014/main" id="{75906C49-3749-4CDE-8C3E-E89A62F286A6}"/>
+                <a16:creationId xmlns:a16="http://schemas.microsoft.com/office/drawing/2014/main" id="{4DAA48DB-13F0-42ED-A370-0115BDE1BBD9}"/>
               </a:ext>
             </a:extLst>
           </p:cNvPr>
@@ -28100,7 +28440,7 @@
           <p:cNvPr id="10" name="">
             <a:extLst xmlns:a="http://schemas.openxmlformats.org/drawingml/2006/main">
               <a:ext uri="{FF2B5EF4-FFF2-40B4-BE49-F238E27FC236}">
-                <a16:creationId xmlns:a16="http://schemas.microsoft.com/office/drawing/2014/main" id="{9C5E2E13-C219-469D-BBE4-08A56BE7D6F9}"/>
+                <a16:creationId xmlns:a16="http://schemas.microsoft.com/office/drawing/2014/main" id="{B3EC01CF-2333-4A6A-88E0-B18D7AC1491E}"/>
               </a:ext>
             </a:extLst>
           </p:cNvPr>
@@ -28168,7 +28508,7 @@
           <p:cNvPr id="11" name="">
             <a:extLst xmlns:a="http://schemas.openxmlformats.org/drawingml/2006/main">
               <a:ext uri="{FF2B5EF4-FFF2-40B4-BE49-F238E27FC236}">
-                <a16:creationId xmlns:a16="http://schemas.microsoft.com/office/drawing/2014/main" id="{FF13B843-195D-4874-8B4B-2876E6D33A90}"/>
+                <a16:creationId xmlns:a16="http://schemas.microsoft.com/office/drawing/2014/main" id="{5E4CAD7E-C534-4559-BA80-8B5A87BE8693}"/>
               </a:ext>
             </a:extLst>
           </p:cNvPr>
@@ -28236,7 +28576,7 @@
           <p:cNvPr id="12" name="">
             <a:extLst xmlns:a="http://schemas.openxmlformats.org/drawingml/2006/main">
               <a:ext uri="{FF2B5EF4-FFF2-40B4-BE49-F238E27FC236}">
-                <a16:creationId xmlns:a16="http://schemas.microsoft.com/office/drawing/2014/main" id="{F0717D9E-8151-4E7F-8AFD-48D989FD1178}"/>
+                <a16:creationId xmlns:a16="http://schemas.microsoft.com/office/drawing/2014/main" id="{3C858523-E257-4B3E-BB5B-5097611882B1}"/>
               </a:ext>
             </a:extLst>
           </p:cNvPr>
@@ -28304,7 +28644,7 @@
           <p:cNvPr id="13" name="">
             <a:extLst xmlns:a="http://schemas.openxmlformats.org/drawingml/2006/main">
               <a:ext uri="{FF2B5EF4-FFF2-40B4-BE49-F238E27FC236}">
-                <a16:creationId xmlns:a16="http://schemas.microsoft.com/office/drawing/2014/main" id="{78D42D5F-EA28-4F3F-90D3-8A2D268E43B5}"/>
+                <a16:creationId xmlns:a16="http://schemas.microsoft.com/office/drawing/2014/main" id="{DFAE94B9-90D0-4B3B-92CE-338FB2CAFFA1}"/>
               </a:ext>
             </a:extLst>
           </p:cNvPr>
@@ -28372,7 +28712,7 @@
           <p:cNvPr id="14" name="">
             <a:extLst xmlns:a="http://schemas.openxmlformats.org/drawingml/2006/main">
               <a:ext uri="{FF2B5EF4-FFF2-40B4-BE49-F238E27FC236}">
-                <a16:creationId xmlns:a16="http://schemas.microsoft.com/office/drawing/2014/main" id="{FB4F0DCD-A122-4825-8A09-2C02A45ED271}"/>
+                <a16:creationId xmlns:a16="http://schemas.microsoft.com/office/drawing/2014/main" id="{D4A03035-97C9-412F-B447-C845FA25B1DF}"/>
               </a:ext>
             </a:extLst>
           </p:cNvPr>
@@ -28440,7 +28780,7 @@
           <p:cNvPr id="15" name="">
             <a:extLst xmlns:a="http://schemas.openxmlformats.org/drawingml/2006/main">
               <a:ext uri="{FF2B5EF4-FFF2-40B4-BE49-F238E27FC236}">
-                <a16:creationId xmlns:a16="http://schemas.microsoft.com/office/drawing/2014/main" id="{EEBC0D09-BFC5-4C51-B0AA-7CC920C43547}"/>
+                <a16:creationId xmlns:a16="http://schemas.microsoft.com/office/drawing/2014/main" id="{36692BEF-EE42-4156-AD15-5695B81BFC0B}"/>
               </a:ext>
             </a:extLst>
           </p:cNvPr>
@@ -28508,7 +28848,7 @@
           <p:cNvPr id="16" name="">
             <a:extLst xmlns:a="http://schemas.openxmlformats.org/drawingml/2006/main">
               <a:ext uri="{FF2B5EF4-FFF2-40B4-BE49-F238E27FC236}">
-                <a16:creationId xmlns:a16="http://schemas.microsoft.com/office/drawing/2014/main" id="{B16AF516-38C0-4B04-A1B6-8D3432571CAC}"/>
+                <a16:creationId xmlns:a16="http://schemas.microsoft.com/office/drawing/2014/main" id="{798DE998-2E54-429C-8AE9-EBEB516E2F45}"/>
               </a:ext>
             </a:extLst>
           </p:cNvPr>
@@ -28576,7 +28916,7 @@
           <p:cNvPr id="17" name="">
             <a:extLst xmlns:a="http://schemas.openxmlformats.org/drawingml/2006/main">
               <a:ext uri="{FF2B5EF4-FFF2-40B4-BE49-F238E27FC236}">
-                <a16:creationId xmlns:a16="http://schemas.microsoft.com/office/drawing/2014/main" id="{D9D9C2DB-1929-433F-8B85-A2C39686C7C4}"/>
+                <a16:creationId xmlns:a16="http://schemas.microsoft.com/office/drawing/2014/main" id="{2DD29685-4184-433D-81B9-7FA905D8F1BE}"/>
               </a:ext>
             </a:extLst>
           </p:cNvPr>
@@ -28644,7 +28984,7 @@
           <p:cNvPr id="18" name="">
             <a:extLst xmlns:a="http://schemas.openxmlformats.org/drawingml/2006/main">
               <a:ext uri="{FF2B5EF4-FFF2-40B4-BE49-F238E27FC236}">
-                <a16:creationId xmlns:a16="http://schemas.microsoft.com/office/drawing/2014/main" id="{E8E03C4B-C1AC-424D-9A20-917B1DFE061D}"/>
+                <a16:creationId xmlns:a16="http://schemas.microsoft.com/office/drawing/2014/main" id="{2FD76572-2B11-4A79-A69E-CBA65112BC78}"/>
               </a:ext>
             </a:extLst>
           </p:cNvPr>
@@ -28712,7 +29052,7 @@
           <p:cNvPr id="19" name="">
             <a:extLst xmlns:a="http://schemas.openxmlformats.org/drawingml/2006/main">
               <a:ext uri="{FF2B5EF4-FFF2-40B4-BE49-F238E27FC236}">
-                <a16:creationId xmlns:a16="http://schemas.microsoft.com/office/drawing/2014/main" id="{A462CEC8-F4FE-4909-B8B8-3D2C2A783A82}"/>
+                <a16:creationId xmlns:a16="http://schemas.microsoft.com/office/drawing/2014/main" id="{7B9A583B-6FFF-4C41-842D-0C9511790038}"/>
               </a:ext>
             </a:extLst>
           </p:cNvPr>
@@ -28780,7 +29120,7 @@
           <p:cNvPr id="20" name="">
             <a:extLst xmlns:a="http://schemas.openxmlformats.org/drawingml/2006/main">
               <a:ext uri="{FF2B5EF4-FFF2-40B4-BE49-F238E27FC236}">
-                <a16:creationId xmlns:a16="http://schemas.microsoft.com/office/drawing/2014/main" id="{78E517EB-C3CE-4B4E-AF0F-0E235A5E6A6F}"/>
+                <a16:creationId xmlns:a16="http://schemas.microsoft.com/office/drawing/2014/main" id="{C4371AE2-8AA2-46BF-90F3-88F2B9BF7A79}"/>
               </a:ext>
             </a:extLst>
           </p:cNvPr>
@@ -28846,7 +29186,7 @@
     </p:spTree>
     <p:extLst>
       <p:ext uri="{BB962C8B-B14F-4D97-AF65-F5344CB8AC3E}">
-        <p14:creationId xmlns:p14="http://schemas.microsoft.com/office/powerpoint/2010/main" val="938783815"/>
+        <p14:creationId xmlns:p14="http://schemas.microsoft.com/office/powerpoint/2010/main" val="1570973978"/>
       </p:ext>
     </p:extLst>
   </p:cSld>

</xml_diff>